<commit_message>
design: unify QA talk cover and sharing artwork
</commit_message>
<xml_diff>
--- a/resources/talks/beyond-the-qa-bottleneck.pptx
+++ b/resources/talks/beyond-the-qa-bottleneck.pptx
@@ -2,44 +2,44 @@
 <file path=ppt/presentation.xml><?xml version="1.0" encoding="utf-8"?>
 <p:presentation xmlns:p="http://schemas.openxmlformats.org/presentationml/2006/main">
   <p:sldMasterIdLst>
-    <p:sldMasterId xmlns:r="http://schemas.openxmlformats.org/officeDocument/2006/relationships" id="2147483648" r:id="R48239de05a4d4524"/>
+    <p:sldMasterId xmlns:r="http://schemas.openxmlformats.org/officeDocument/2006/relationships" id="2147483648" r:id="R800f2c3ea0b5492b"/>
   </p:sldMasterIdLst>
   <p:notesMasterIdLst>
-    <p:notesMasterId xmlns:r="http://schemas.openxmlformats.org/officeDocument/2006/relationships" r:id="Rf2c8eb5f523b480b"/>
+    <p:notesMasterId xmlns:r="http://schemas.openxmlformats.org/officeDocument/2006/relationships" r:id="R1954fb5872214bfe"/>
   </p:notesMasterIdLst>
   <p:sldIdLst>
-    <p:sldId xmlns:r="http://schemas.openxmlformats.org/officeDocument/2006/relationships" id="256" r:id="Rc520a373bf4646bb"/>
-    <p:sldId xmlns:r="http://schemas.openxmlformats.org/officeDocument/2006/relationships" id="257" r:id="Raec67808dd564488"/>
-    <p:sldId xmlns:r="http://schemas.openxmlformats.org/officeDocument/2006/relationships" id="258" r:id="Raea8525a61844bcb"/>
-    <p:sldId xmlns:r="http://schemas.openxmlformats.org/officeDocument/2006/relationships" id="259" r:id="Re70a120ed79d4ba4"/>
-    <p:sldId xmlns:r="http://schemas.openxmlformats.org/officeDocument/2006/relationships" id="260" r:id="Re6827ad3cc4041b3"/>
-    <p:sldId xmlns:r="http://schemas.openxmlformats.org/officeDocument/2006/relationships" id="261" r:id="R5bba421b65dd40e2"/>
-    <p:sldId xmlns:r="http://schemas.openxmlformats.org/officeDocument/2006/relationships" id="262" r:id="Rf924e6a3bbd54b2a"/>
-    <p:sldId xmlns:r="http://schemas.openxmlformats.org/officeDocument/2006/relationships" id="263" r:id="R20468bcedf8d46e4"/>
-    <p:sldId xmlns:r="http://schemas.openxmlformats.org/officeDocument/2006/relationships" id="264" r:id="R5c186081e4c042bf"/>
-    <p:sldId xmlns:r="http://schemas.openxmlformats.org/officeDocument/2006/relationships" id="265" r:id="Rb067efd82fde4f9f"/>
-    <p:sldId xmlns:r="http://schemas.openxmlformats.org/officeDocument/2006/relationships" id="266" r:id="Rc6191650bac14e6b"/>
-    <p:sldId xmlns:r="http://schemas.openxmlformats.org/officeDocument/2006/relationships" id="267" r:id="Rcff242507e3943ba"/>
-    <p:sldId xmlns:r="http://schemas.openxmlformats.org/officeDocument/2006/relationships" id="268" r:id="R6f48c4cf355e4d69"/>
-    <p:sldId xmlns:r="http://schemas.openxmlformats.org/officeDocument/2006/relationships" id="269" r:id="R0f1ebd4e19754b48"/>
-    <p:sldId xmlns:r="http://schemas.openxmlformats.org/officeDocument/2006/relationships" id="270" r:id="R2a968eeecbe14f86"/>
-    <p:sldId xmlns:r="http://schemas.openxmlformats.org/officeDocument/2006/relationships" id="271" r:id="R509d92d34d6a4ac9"/>
-    <p:sldId xmlns:r="http://schemas.openxmlformats.org/officeDocument/2006/relationships" id="272" r:id="R53d737665a824fb3"/>
-    <p:sldId xmlns:r="http://schemas.openxmlformats.org/officeDocument/2006/relationships" id="273" r:id="Rc8caa64f8a174535"/>
-    <p:sldId xmlns:r="http://schemas.openxmlformats.org/officeDocument/2006/relationships" id="274" r:id="Ra4f9484cb9814bff"/>
-    <p:sldId xmlns:r="http://schemas.openxmlformats.org/officeDocument/2006/relationships" id="275" r:id="Rbf4eac4f68b84a1f"/>
-    <p:sldId xmlns:r="http://schemas.openxmlformats.org/officeDocument/2006/relationships" id="276" r:id="R2c9d636f95b646f7"/>
-    <p:sldId xmlns:r="http://schemas.openxmlformats.org/officeDocument/2006/relationships" id="277" r:id="Ra6412c8027e848a2"/>
-    <p:sldId xmlns:r="http://schemas.openxmlformats.org/officeDocument/2006/relationships" id="278" r:id="R8131c229cb5f40a0"/>
-    <p:sldId xmlns:r="http://schemas.openxmlformats.org/officeDocument/2006/relationships" id="279" r:id="R9493df760f9c4256"/>
-    <p:sldId xmlns:r="http://schemas.openxmlformats.org/officeDocument/2006/relationships" id="280" r:id="Re069c11563664323"/>
-    <p:sldId xmlns:r="http://schemas.openxmlformats.org/officeDocument/2006/relationships" id="281" r:id="R5d91e2d0f5c34d6e"/>
-    <p:sldId xmlns:r="http://schemas.openxmlformats.org/officeDocument/2006/relationships" id="282" r:id="R47d5fb423a344077"/>
-    <p:sldId xmlns:r="http://schemas.openxmlformats.org/officeDocument/2006/relationships" id="283" r:id="R5373e16a445148b1"/>
-    <p:sldId xmlns:r="http://schemas.openxmlformats.org/officeDocument/2006/relationships" id="284" r:id="R2fa5aaa5e22d4aa1"/>
-    <p:sldId xmlns:r="http://schemas.openxmlformats.org/officeDocument/2006/relationships" id="285" r:id="Rec83db51859e4ea5"/>
-    <p:sldId xmlns:r="http://schemas.openxmlformats.org/officeDocument/2006/relationships" id="286" r:id="Rd5aec7baae6448ea"/>
-    <p:sldId xmlns:r="http://schemas.openxmlformats.org/officeDocument/2006/relationships" id="287" r:id="Re2d31457605f4f96"/>
+    <p:sldId xmlns:r="http://schemas.openxmlformats.org/officeDocument/2006/relationships" id="256" r:id="R41f0373294cf4ade"/>
+    <p:sldId xmlns:r="http://schemas.openxmlformats.org/officeDocument/2006/relationships" id="257" r:id="Ra5b2712d80c6491e"/>
+    <p:sldId xmlns:r="http://schemas.openxmlformats.org/officeDocument/2006/relationships" id="258" r:id="R36c4c98571e04cd7"/>
+    <p:sldId xmlns:r="http://schemas.openxmlformats.org/officeDocument/2006/relationships" id="259" r:id="Reaec46b5921449ea"/>
+    <p:sldId xmlns:r="http://schemas.openxmlformats.org/officeDocument/2006/relationships" id="260" r:id="Rbc4350d6eb1c4b32"/>
+    <p:sldId xmlns:r="http://schemas.openxmlformats.org/officeDocument/2006/relationships" id="261" r:id="Recb251864e9d4aaa"/>
+    <p:sldId xmlns:r="http://schemas.openxmlformats.org/officeDocument/2006/relationships" id="262" r:id="Rd5034da4e0994a4b"/>
+    <p:sldId xmlns:r="http://schemas.openxmlformats.org/officeDocument/2006/relationships" id="263" r:id="Rc0a3316c864545ff"/>
+    <p:sldId xmlns:r="http://schemas.openxmlformats.org/officeDocument/2006/relationships" id="264" r:id="Rc2375fe5720c45c4"/>
+    <p:sldId xmlns:r="http://schemas.openxmlformats.org/officeDocument/2006/relationships" id="265" r:id="Rabc4bc1c03e846a9"/>
+    <p:sldId xmlns:r="http://schemas.openxmlformats.org/officeDocument/2006/relationships" id="266" r:id="R3dd5aed433704f43"/>
+    <p:sldId xmlns:r="http://schemas.openxmlformats.org/officeDocument/2006/relationships" id="267" r:id="Rb60d7a6df93d40f2"/>
+    <p:sldId xmlns:r="http://schemas.openxmlformats.org/officeDocument/2006/relationships" id="268" r:id="Rac16c8789e954675"/>
+    <p:sldId xmlns:r="http://schemas.openxmlformats.org/officeDocument/2006/relationships" id="269" r:id="R909d858dcb6c4f1d"/>
+    <p:sldId xmlns:r="http://schemas.openxmlformats.org/officeDocument/2006/relationships" id="270" r:id="Rf56c66650622469f"/>
+    <p:sldId xmlns:r="http://schemas.openxmlformats.org/officeDocument/2006/relationships" id="271" r:id="Rbb7edbcaa6a647c1"/>
+    <p:sldId xmlns:r="http://schemas.openxmlformats.org/officeDocument/2006/relationships" id="272" r:id="Rfd37461469aa407b"/>
+    <p:sldId xmlns:r="http://schemas.openxmlformats.org/officeDocument/2006/relationships" id="273" r:id="Rab3a195ca96f4f6a"/>
+    <p:sldId xmlns:r="http://schemas.openxmlformats.org/officeDocument/2006/relationships" id="274" r:id="R099c5863ce454c23"/>
+    <p:sldId xmlns:r="http://schemas.openxmlformats.org/officeDocument/2006/relationships" id="275" r:id="R53b5fefa3eff4a77"/>
+    <p:sldId xmlns:r="http://schemas.openxmlformats.org/officeDocument/2006/relationships" id="276" r:id="R7d194c7c8a8c4e89"/>
+    <p:sldId xmlns:r="http://schemas.openxmlformats.org/officeDocument/2006/relationships" id="277" r:id="Ra318dcea340745d7"/>
+    <p:sldId xmlns:r="http://schemas.openxmlformats.org/officeDocument/2006/relationships" id="278" r:id="R9b84a6ae69e44248"/>
+    <p:sldId xmlns:r="http://schemas.openxmlformats.org/officeDocument/2006/relationships" id="279" r:id="R2fcbda823fdb4187"/>
+    <p:sldId xmlns:r="http://schemas.openxmlformats.org/officeDocument/2006/relationships" id="280" r:id="R7dd300406f714998"/>
+    <p:sldId xmlns:r="http://schemas.openxmlformats.org/officeDocument/2006/relationships" id="281" r:id="R5c92a39a7cb64508"/>
+    <p:sldId xmlns:r="http://schemas.openxmlformats.org/officeDocument/2006/relationships" id="282" r:id="R9dead64dde824385"/>
+    <p:sldId xmlns:r="http://schemas.openxmlformats.org/officeDocument/2006/relationships" id="283" r:id="R3380dd6f34264d6c"/>
+    <p:sldId xmlns:r="http://schemas.openxmlformats.org/officeDocument/2006/relationships" id="284" r:id="R18b9e9dee9e14e58"/>
+    <p:sldId xmlns:r="http://schemas.openxmlformats.org/officeDocument/2006/relationships" id="285" r:id="Rd85a9131e53944a4"/>
+    <p:sldId xmlns:r="http://schemas.openxmlformats.org/officeDocument/2006/relationships" id="286" r:id="R1b884058918b4aa6"/>
+    <p:sldId xmlns:r="http://schemas.openxmlformats.org/officeDocument/2006/relationships" id="287" r:id="R7274328a018842a3"/>
   </p:sldIdLst>
   <p:sldSz cx="12192000" cy="6858000"/>
   <p:notesSz cx="6858000" cy="9144000"/>
@@ -3281,7 +3281,7 @@
   </p:cSld>
   <p:clrMap bg1="lt1" tx1="dk1" bg2="lt2" tx2="dk2" accent1="accent1" accent2="accent2" accent3="accent3" accent4="accent4" accent5="accent5" accent6="accent6" hlink="hlink" folHlink="folHlink"/>
   <p:sldLayoutIdLst>
-    <p:sldLayoutId xmlns:r="http://schemas.openxmlformats.org/officeDocument/2006/relationships" id="2147483649" r:id="Rc46186b56deb49aa"/>
+    <p:sldLayoutId xmlns:r="http://schemas.openxmlformats.org/officeDocument/2006/relationships" id="2147483649" r:id="Rd0c38637d6964c6e"/>
   </p:sldLayoutIdLst>
   <p:txStyles>
     <p:titleStyle>
@@ -5445,41 +5445,63 @@
       <p:grpSpPr>
         <a:xfrm xmlns:a="http://schemas.openxmlformats.org/drawingml/2006/main"/>
       </p:grpSpPr>
-      <p:sp>
-        <p:nvSpPr>
-          <p:cNvPr id="6" name="Deck title">
-            <a:extLst xmlns:a="http://schemas.openxmlformats.org/drawingml/2006/main">
-              <a:ext uri="{FF2B5EF4-FFF2-40B4-BE49-F238E27FC236}">
-                <a16:creationId xmlns:a16="http://schemas.microsoft.com/office/drawing/2014/main" id="{5BF1E53E-20EB-45EE-80E4-B84558B0C764}"/>
-              </a:ext>
-            </a:extLst>
-          </p:cNvPr>
-          <p:cNvSpPr>
-            <a:spLocks xmlns:a="http://schemas.openxmlformats.org/drawingml/2006/main" noGrp="1"/>
-          </p:cNvSpPr>
-          <p:nvPr/>
-        </p:nvSpPr>
-        <p:spPr>
-          <a:xfrm xmlns:a="http://schemas.openxmlformats.org/drawingml/2006/main">
-            <a:off x="762000" y="952500"/>
-            <a:ext cx="10668000" cy="2809875"/>
-          </a:xfrm>
-          <a:prstGeom xmlns:a="http://schemas.openxmlformats.org/drawingml/2006/main" prst="rect">
-            <a:avLst/>
-          </a:prstGeom>
-          <a:noFill xmlns:a="http://schemas.openxmlformats.org/drawingml/2006/main"/>
-          <a:ln xmlns:a="http://schemas.openxmlformats.org/drawingml/2006/main" w="0">
-            <a:noFill/>
-          </a:ln>
-        </p:spPr>
-        <p:txBody>
-          <a:bodyPr xmlns:a="http://schemas.openxmlformats.org/drawingml/2006/main" lIns="0" tIns="0" rIns="0" bIns="0">
-            <a:noAutofit/>
-          </a:bodyPr>
-          <a:lstStyle xmlns:a="http://schemas.openxmlformats.org/drawingml/2006/main"/>
-          <a:p xmlns:a="http://schemas.openxmlformats.org/drawingml/2006/main">
-            <a:pPr algn="l">
-              <a:defRPr sz="8475" b="0">
+      <p:pic>
+        <p:nvPicPr>
+          <p:cNvPr id="8" name=""/>
+          <p:cNvPicPr>
+            <a:picLocks xmlns:a="http://schemas.openxmlformats.org/drawingml/2006/main" noChangeAspect="1"/>
+          </p:cNvPicPr>
+          <p:nvPr/>
+        </p:nvPicPr>
+        <p:blipFill>
+          <a:blip xmlns:r="http://schemas.openxmlformats.org/officeDocument/2006/relationships" xmlns:a="http://schemas.openxmlformats.org/drawingml/2006/main" r:embed="R11fbb65654a64376"/>
+          <a:stretch xmlns:a="http://schemas.openxmlformats.org/drawingml/2006/main"/>
+        </p:blipFill>
+        <p:spPr>
+          <a:xfrm xmlns:a="http://schemas.openxmlformats.org/drawingml/2006/main">
+            <a:off x="0" y="0"/>
+            <a:ext cx="12192000" cy="6858000"/>
+          </a:xfrm>
+          <a:prstGeom xmlns:a="http://schemas.openxmlformats.org/drawingml/2006/main" prst="rect">
+            <a:avLst/>
+          </a:prstGeom>
+        </p:spPr>
+      </p:pic>
+      <p:sp>
+        <p:nvSpPr>
+          <p:cNvPr id="2" name="Deck title">
+            <a:extLst xmlns:a="http://schemas.openxmlformats.org/drawingml/2006/main">
+              <a:ext uri="{FF2B5EF4-FFF2-40B4-BE49-F238E27FC236}">
+                <a16:creationId xmlns:a16="http://schemas.microsoft.com/office/drawing/2014/main" id="{8E6C1C23-D214-40E4-A62F-BAC0B2A7416F}"/>
+              </a:ext>
+            </a:extLst>
+          </p:cNvPr>
+          <p:cNvSpPr>
+            <a:spLocks xmlns:a="http://schemas.openxmlformats.org/drawingml/2006/main" noGrp="1"/>
+          </p:cNvSpPr>
+          <p:nvPr/>
+        </p:nvSpPr>
+        <p:spPr>
+          <a:xfrm xmlns:a="http://schemas.openxmlformats.org/drawingml/2006/main">
+            <a:off x="762000" y="857250"/>
+            <a:ext cx="10668000" cy="2476500"/>
+          </a:xfrm>
+          <a:prstGeom xmlns:a="http://schemas.openxmlformats.org/drawingml/2006/main" prst="rect">
+            <a:avLst/>
+          </a:prstGeom>
+          <a:noFill xmlns:a="http://schemas.openxmlformats.org/drawingml/2006/main"/>
+          <a:ln xmlns:a="http://schemas.openxmlformats.org/drawingml/2006/main" w="0">
+            <a:noFill/>
+          </a:ln>
+        </p:spPr>
+        <p:txBody>
+          <a:bodyPr xmlns:a="http://schemas.openxmlformats.org/drawingml/2006/main" lIns="0" tIns="0" rIns="0" bIns="0">
+            <a:noAutofit/>
+          </a:bodyPr>
+          <a:lstStyle xmlns:a="http://schemas.openxmlformats.org/drawingml/2006/main"/>
+          <a:p xmlns:a="http://schemas.openxmlformats.org/drawingml/2006/main">
+            <a:pPr algn="l">
+              <a:defRPr sz="8100" b="0">
                 <a:solidFill>
                   <a:srgbClr val="F6F4EE"/>
                 </a:solidFill>
@@ -5489,7 +5511,7 @@
               </a:defRPr>
             </a:pPr>
             <a:r>
-              <a:rPr sz="8475" b="0">
+              <a:rPr sz="8100" b="0">
                 <a:solidFill>
                   <a:srgbClr val="F6F4EE"/>
                 </a:solidFill>
@@ -5502,7 +5524,7 @@
           </a:p>
           <a:p xmlns:a="http://schemas.openxmlformats.org/drawingml/2006/main">
             <a:pPr algn="l">
-              <a:defRPr sz="8475" b="0">
+              <a:defRPr sz="8100" b="0">
                 <a:solidFill>
                   <a:srgbClr val="F6F4EE"/>
                 </a:solidFill>
@@ -5512,7 +5534,7 @@
               </a:defRPr>
             </a:pPr>
             <a:r>
-              <a:rPr sz="8475" b="0">
+              <a:rPr sz="8100" b="0">
                 <a:solidFill>
                   <a:srgbClr val="F6F4EE"/>
                 </a:solidFill>
@@ -5527,22 +5549,22 @@
       </p:sp>
       <p:sp>
         <p:nvSpPr>
-          <p:cNvPr id="2" name="text">
-            <a:extLst xmlns:a="http://schemas.openxmlformats.org/drawingml/2006/main">
-              <a:ext uri="{FF2B5EF4-FFF2-40B4-BE49-F238E27FC236}">
-                <a16:creationId xmlns:a16="http://schemas.microsoft.com/office/drawing/2014/main" id="{1943AA71-DBFB-49B9-ACF7-D7E75EA8E2F5}"/>
-              </a:ext>
-            </a:extLst>
-          </p:cNvPr>
-          <p:cNvSpPr>
-            <a:spLocks xmlns:a="http://schemas.openxmlformats.org/drawingml/2006/main" noGrp="1"/>
-          </p:cNvSpPr>
-          <p:nvPr/>
-        </p:nvSpPr>
-        <p:spPr>
-          <a:xfrm xmlns:a="http://schemas.openxmlformats.org/drawingml/2006/main">
-            <a:off x="809625" y="3857625"/>
-            <a:ext cx="9810750" cy="571500"/>
+          <p:cNvPr id="3" name="text">
+            <a:extLst xmlns:a="http://schemas.openxmlformats.org/drawingml/2006/main">
+              <a:ext uri="{FF2B5EF4-FFF2-40B4-BE49-F238E27FC236}">
+                <a16:creationId xmlns:a16="http://schemas.microsoft.com/office/drawing/2014/main" id="{F7183065-8348-4C3A-A5BE-E83CD988081C}"/>
+              </a:ext>
+            </a:extLst>
+          </p:cNvPr>
+          <p:cNvSpPr>
+            <a:spLocks xmlns:a="http://schemas.openxmlformats.org/drawingml/2006/main" noGrp="1"/>
+          </p:cNvSpPr>
+          <p:nvPr/>
+        </p:nvSpPr>
+        <p:spPr>
+          <a:xfrm xmlns:a="http://schemas.openxmlformats.org/drawingml/2006/main">
+            <a:off x="809625" y="3429000"/>
+            <a:ext cx="10477500" cy="571500"/>
           </a:xfrm>
           <a:prstGeom xmlns:a="http://schemas.openxmlformats.org/drawingml/2006/main" prst="rect">
             <a:avLst/>
@@ -5582,41 +5604,66 @@
           </a:p>
         </p:txBody>
       </p:sp>
-      <p:sp>
-        <p:nvSpPr>
-          <p:cNvPr id="3" name="Speaker">
-            <a:extLst xmlns:a="http://schemas.openxmlformats.org/drawingml/2006/main">
-              <a:ext uri="{FF2B5EF4-FFF2-40B4-BE49-F238E27FC236}">
-                <a16:creationId xmlns:a16="http://schemas.microsoft.com/office/drawing/2014/main" id="{6D4F4B95-88F5-4571-828F-632DC90E8CFA}"/>
-              </a:ext>
-            </a:extLst>
-          </p:cNvPr>
-          <p:cNvSpPr>
-            <a:spLocks xmlns:a="http://schemas.openxmlformats.org/drawingml/2006/main" noGrp="1"/>
-          </p:cNvSpPr>
-          <p:nvPr/>
-        </p:nvSpPr>
-        <p:spPr>
-          <a:xfrm xmlns:a="http://schemas.openxmlformats.org/drawingml/2006/main">
-            <a:off x="809625" y="4657725"/>
-            <a:ext cx="9810750" cy="438150"/>
-          </a:xfrm>
-          <a:prstGeom xmlns:a="http://schemas.openxmlformats.org/drawingml/2006/main" prst="rect">
-            <a:avLst/>
-          </a:prstGeom>
-          <a:noFill xmlns:a="http://schemas.openxmlformats.org/drawingml/2006/main"/>
-          <a:ln xmlns:a="http://schemas.openxmlformats.org/drawingml/2006/main" w="0">
-            <a:noFill/>
-          </a:ln>
-        </p:spPr>
-        <p:txBody>
-          <a:bodyPr xmlns:a="http://schemas.openxmlformats.org/drawingml/2006/main" lIns="0" tIns="0" rIns="0" bIns="0">
-            <a:noAutofit/>
-          </a:bodyPr>
-          <a:lstStyle xmlns:a="http://schemas.openxmlformats.org/drawingml/2006/main"/>
-          <a:p xmlns:a="http://schemas.openxmlformats.org/drawingml/2006/main">
-            <a:pPr algn="l">
-              <a:defRPr sz="2550" b="1">
+      <p:pic>
+        <p:nvPicPr>
+          <p:cNvPr id="11" name=""/>
+          <p:cNvPicPr>
+            <a:picLocks xmlns:a="http://schemas.openxmlformats.org/drawingml/2006/main" noChangeAspect="1"/>
+          </p:cNvPicPr>
+          <p:nvPr/>
+        </p:nvPicPr>
+        <p:blipFill>
+          <a:blip xmlns:r="http://schemas.openxmlformats.org/officeDocument/2006/relationships" xmlns:a="http://schemas.openxmlformats.org/drawingml/2006/main" r:embed="R4eff632efcd04c3f"/>
+          <a:srcRect xmlns:a="http://schemas.openxmlformats.org/drawingml/2006/main" l="0" t="0" r="0" b="0"/>
+          <a:stretch xmlns:a="http://schemas.openxmlformats.org/drawingml/2006/main">
+            <a:fillRect l="0" t="0" r="0" b="0"/>
+          </a:stretch>
+        </p:blipFill>
+        <p:spPr>
+          <a:xfrm xmlns:a="http://schemas.openxmlformats.org/drawingml/2006/main">
+            <a:off x="809625" y="5143500"/>
+            <a:ext cx="685800" cy="685800"/>
+          </a:xfrm>
+          <a:prstGeom xmlns:a="http://schemas.openxmlformats.org/drawingml/2006/main" prst="ellipse">
+            <a:avLst/>
+          </a:prstGeom>
+        </p:spPr>
+      </p:pic>
+      <p:sp>
+        <p:nvSpPr>
+          <p:cNvPr id="5" name="Speaker">
+            <a:extLst xmlns:a="http://schemas.openxmlformats.org/drawingml/2006/main">
+              <a:ext uri="{FF2B5EF4-FFF2-40B4-BE49-F238E27FC236}">
+                <a16:creationId xmlns:a16="http://schemas.microsoft.com/office/drawing/2014/main" id="{35F2EA53-08BD-4177-ACFB-76DB6862AF9C}"/>
+              </a:ext>
+            </a:extLst>
+          </p:cNvPr>
+          <p:cNvSpPr>
+            <a:spLocks xmlns:a="http://schemas.openxmlformats.org/drawingml/2006/main" noGrp="1"/>
+          </p:cNvSpPr>
+          <p:nvPr/>
+        </p:nvSpPr>
+        <p:spPr>
+          <a:xfrm xmlns:a="http://schemas.openxmlformats.org/drawingml/2006/main">
+            <a:off x="1714500" y="5143500"/>
+            <a:ext cx="9525000" cy="409575"/>
+          </a:xfrm>
+          <a:prstGeom xmlns:a="http://schemas.openxmlformats.org/drawingml/2006/main" prst="rect">
+            <a:avLst/>
+          </a:prstGeom>
+          <a:noFill xmlns:a="http://schemas.openxmlformats.org/drawingml/2006/main"/>
+          <a:ln xmlns:a="http://schemas.openxmlformats.org/drawingml/2006/main" w="0">
+            <a:noFill/>
+          </a:ln>
+        </p:spPr>
+        <p:txBody>
+          <a:bodyPr xmlns:a="http://schemas.openxmlformats.org/drawingml/2006/main" lIns="0" tIns="0" rIns="0" bIns="0">
+            <a:noAutofit/>
+          </a:bodyPr>
+          <a:lstStyle xmlns:a="http://schemas.openxmlformats.org/drawingml/2006/main"/>
+          <a:p xmlns:a="http://schemas.openxmlformats.org/drawingml/2006/main">
+            <a:pPr algn="l">
+              <a:defRPr sz="2400" b="1">
                 <a:solidFill>
                   <a:srgbClr val="F6F4EE"/>
                 </a:solidFill>
@@ -5626,7 +5673,7 @@
               </a:defRPr>
             </a:pPr>
             <a:r>
-              <a:rPr sz="2550" b="1">
+              <a:rPr sz="2400" b="1">
                 <a:solidFill>
                   <a:srgbClr val="F6F4EE"/>
                 </a:solidFill>
@@ -5641,21 +5688,78 @@
       </p:sp>
       <p:sp>
         <p:nvSpPr>
-          <p:cNvPr id="4" name="text">
-            <a:extLst xmlns:a="http://schemas.openxmlformats.org/drawingml/2006/main">
-              <a:ext uri="{FF2B5EF4-FFF2-40B4-BE49-F238E27FC236}">
-                <a16:creationId xmlns:a16="http://schemas.microsoft.com/office/drawing/2014/main" id="{6087CD4C-3168-42AD-87B4-3776EB3E3B81}"/>
-              </a:ext>
-            </a:extLst>
-          </p:cNvPr>
-          <p:cNvSpPr>
-            <a:spLocks xmlns:a="http://schemas.openxmlformats.org/drawingml/2006/main" noGrp="1"/>
-          </p:cNvSpPr>
-          <p:nvPr/>
-        </p:nvSpPr>
-        <p:spPr>
-          <a:xfrm xmlns:a="http://schemas.openxmlformats.org/drawingml/2006/main">
-            <a:off x="809625" y="5095875"/>
+          <p:cNvPr id="6" name="text">
+            <a:extLst xmlns:a="http://schemas.openxmlformats.org/drawingml/2006/main">
+              <a:ext uri="{FF2B5EF4-FFF2-40B4-BE49-F238E27FC236}">
+                <a16:creationId xmlns:a16="http://schemas.microsoft.com/office/drawing/2014/main" id="{9EB70777-7D0B-46FA-B7B4-E8CC1DB9CEE8}"/>
+              </a:ext>
+            </a:extLst>
+          </p:cNvPr>
+          <p:cNvSpPr>
+            <a:spLocks xmlns:a="http://schemas.openxmlformats.org/drawingml/2006/main" noGrp="1"/>
+          </p:cNvSpPr>
+          <p:nvPr/>
+        </p:nvSpPr>
+        <p:spPr>
+          <a:xfrm xmlns:a="http://schemas.openxmlformats.org/drawingml/2006/main">
+            <a:off x="1714500" y="5562600"/>
+            <a:ext cx="9525000" cy="342900"/>
+          </a:xfrm>
+          <a:prstGeom xmlns:a="http://schemas.openxmlformats.org/drawingml/2006/main" prst="rect">
+            <a:avLst/>
+          </a:prstGeom>
+          <a:noFill xmlns:a="http://schemas.openxmlformats.org/drawingml/2006/main"/>
+          <a:ln xmlns:a="http://schemas.openxmlformats.org/drawingml/2006/main" w="0">
+            <a:noFill/>
+          </a:ln>
+        </p:spPr>
+        <p:txBody>
+          <a:bodyPr xmlns:a="http://schemas.openxmlformats.org/drawingml/2006/main" lIns="0" tIns="0" rIns="0" bIns="0">
+            <a:noAutofit/>
+          </a:bodyPr>
+          <a:lstStyle xmlns:a="http://schemas.openxmlformats.org/drawingml/2006/main"/>
+          <a:p xmlns:a="http://schemas.openxmlformats.org/drawingml/2006/main">
+            <a:pPr algn="l">
+              <a:defRPr sz="1950" b="0">
+                <a:solidFill>
+                  <a:srgbClr val="B7BCC1"/>
+                </a:solidFill>
+                <a:latin typeface="Satoshi Variable"/>
+                <a:ea typeface="Satoshi Variable"/>
+                <a:cs typeface="Satoshi Variable"/>
+              </a:defRPr>
+            </a:pPr>
+            <a:r>
+              <a:rPr sz="1950" b="0">
+                <a:solidFill>
+                  <a:srgbClr val="B7BCC1"/>
+                </a:solidFill>
+                <a:latin typeface="Satoshi Variable"/>
+                <a:ea typeface="Satoshi Variable"/>
+                <a:cs typeface="Satoshi Variable"/>
+              </a:rPr>
+              <a:t>Engineering Manager at Zapp</a:t>
+            </a:r>
+          </a:p>
+        </p:txBody>
+      </p:sp>
+      <p:sp>
+        <p:nvSpPr>
+          <p:cNvPr id="7" name="text">
+            <a:extLst xmlns:a="http://schemas.openxmlformats.org/drawingml/2006/main">
+              <a:ext uri="{FF2B5EF4-FFF2-40B4-BE49-F238E27FC236}">
+                <a16:creationId xmlns:a16="http://schemas.microsoft.com/office/drawing/2014/main" id="{5C690C43-1CB0-4384-9C18-E1730635E2C0}"/>
+              </a:ext>
+            </a:extLst>
+          </p:cNvPr>
+          <p:cNvSpPr>
+            <a:spLocks xmlns:a="http://schemas.openxmlformats.org/drawingml/2006/main" noGrp="1"/>
+          </p:cNvSpPr>
+          <p:nvPr/>
+        </p:nvSpPr>
+        <p:spPr>
+          <a:xfrm xmlns:a="http://schemas.openxmlformats.org/drawingml/2006/main">
+            <a:off x="809625" y="6181725"/>
             <a:ext cx="9810750" cy="342900"/>
           </a:xfrm>
           <a:prstGeom xmlns:a="http://schemas.openxmlformats.org/drawingml/2006/main" prst="rect">
@@ -5673,7 +5777,7 @@
           <a:lstStyle xmlns:a="http://schemas.openxmlformats.org/drawingml/2006/main"/>
           <a:p xmlns:a="http://schemas.openxmlformats.org/drawingml/2006/main">
             <a:pPr algn="l">
-              <a:defRPr sz="2025" b="0">
+              <a:defRPr sz="1725" b="0">
                 <a:solidFill>
                   <a:srgbClr val="B7BCC1"/>
                 </a:solidFill>
@@ -5683,66 +5787,9 @@
               </a:defRPr>
             </a:pPr>
             <a:r>
-              <a:rPr sz="2025" b="0">
+              <a:rPr sz="1725" b="0">
                 <a:solidFill>
                   <a:srgbClr val="B7BCC1"/>
-                </a:solidFill>
-                <a:latin typeface="Satoshi Variable"/>
-                <a:ea typeface="Satoshi Variable"/>
-                <a:cs typeface="Satoshi Variable"/>
-              </a:rPr>
-              <a:t>Engineering Manager at Zapp</a:t>
-            </a:r>
-          </a:p>
-        </p:txBody>
-      </p:sp>
-      <p:sp>
-        <p:nvSpPr>
-          <p:cNvPr id="5" name="text">
-            <a:extLst xmlns:a="http://schemas.openxmlformats.org/drawingml/2006/main">
-              <a:ext uri="{FF2B5EF4-FFF2-40B4-BE49-F238E27FC236}">
-                <a16:creationId xmlns:a16="http://schemas.microsoft.com/office/drawing/2014/main" id="{14D01B4F-616B-42CB-8117-3A4C2ED6D7A0}"/>
-              </a:ext>
-            </a:extLst>
-          </p:cNvPr>
-          <p:cNvSpPr>
-            <a:spLocks xmlns:a="http://schemas.openxmlformats.org/drawingml/2006/main" noGrp="1"/>
-          </p:cNvSpPr>
-          <p:nvPr/>
-        </p:nvSpPr>
-        <p:spPr>
-          <a:xfrm xmlns:a="http://schemas.openxmlformats.org/drawingml/2006/main">
-            <a:off x="809625" y="5695950"/>
-            <a:ext cx="9810750" cy="381000"/>
-          </a:xfrm>
-          <a:prstGeom xmlns:a="http://schemas.openxmlformats.org/drawingml/2006/main" prst="rect">
-            <a:avLst/>
-          </a:prstGeom>
-          <a:noFill xmlns:a="http://schemas.openxmlformats.org/drawingml/2006/main"/>
-          <a:ln xmlns:a="http://schemas.openxmlformats.org/drawingml/2006/main" w="0">
-            <a:noFill/>
-          </a:ln>
-        </p:spPr>
-        <p:txBody>
-          <a:bodyPr xmlns:a="http://schemas.openxmlformats.org/drawingml/2006/main" lIns="0" tIns="0" rIns="0" bIns="0">
-            <a:noAutofit/>
-          </a:bodyPr>
-          <a:lstStyle xmlns:a="http://schemas.openxmlformats.org/drawingml/2006/main"/>
-          <a:p xmlns:a="http://schemas.openxmlformats.org/drawingml/2006/main">
-            <a:pPr algn="l">
-              <a:defRPr sz="1950" b="0">
-                <a:solidFill>
-                  <a:srgbClr val="00D5BE"/>
-                </a:solidFill>
-                <a:latin typeface="Satoshi Variable"/>
-                <a:ea typeface="Satoshi Variable"/>
-                <a:cs typeface="Satoshi Variable"/>
-              </a:defRPr>
-            </a:pPr>
-            <a:r>
-              <a:rPr sz="1950" b="0">
-                <a:solidFill>
-                  <a:srgbClr val="00D5BE"/>
                 </a:solidFill>
                 <a:latin typeface="Satoshi Variable"/>
                 <a:ea typeface="Satoshi Variable"/>
@@ -5756,7 +5803,7 @@
     </p:spTree>
     <p:extLst>
       <p:ext uri="{BB962C8B-B14F-4D97-AF65-F5344CB8AC3E}">
-        <p14:creationId xmlns:p14="http://schemas.microsoft.com/office/powerpoint/2010/main" val="2047333458"/>
+        <p14:creationId xmlns:p14="http://schemas.microsoft.com/office/powerpoint/2010/main" val="1272636290"/>
       </p:ext>
     </p:extLst>
   </p:cSld>
@@ -5787,7 +5834,7 @@
           <p:cNvPr id="10" name="Title">
             <a:extLst xmlns:a="http://schemas.openxmlformats.org/drawingml/2006/main">
               <a:ext uri="{FF2B5EF4-FFF2-40B4-BE49-F238E27FC236}">
-                <a16:creationId xmlns:a16="http://schemas.microsoft.com/office/drawing/2014/main" id="{AF2B373C-F8C0-4629-A756-05E2B21BE7DB}"/>
+                <a16:creationId xmlns:a16="http://schemas.microsoft.com/office/drawing/2014/main" id="{D3D7AE67-D883-418C-AB6E-CF36EA95CDEB}"/>
               </a:ext>
             </a:extLst>
           </p:cNvPr>
@@ -5844,7 +5891,7 @@
           <p:cNvPr id="2" name="text">
             <a:extLst xmlns:a="http://schemas.openxmlformats.org/drawingml/2006/main">
               <a:ext uri="{FF2B5EF4-FFF2-40B4-BE49-F238E27FC236}">
-                <a16:creationId xmlns:a16="http://schemas.microsoft.com/office/drawing/2014/main" id="{7329BE6E-5332-4C8C-AD8B-7BB201060AE7}"/>
+                <a16:creationId xmlns:a16="http://schemas.microsoft.com/office/drawing/2014/main" id="{53FF7C33-BD42-4BC5-A757-A57299E92EC0}"/>
               </a:ext>
             </a:extLst>
           </p:cNvPr>
@@ -5901,7 +5948,7 @@
           <p:cNvPr id="3" name="text">
             <a:extLst xmlns:a="http://schemas.openxmlformats.org/drawingml/2006/main">
               <a:ext uri="{FF2B5EF4-FFF2-40B4-BE49-F238E27FC236}">
-                <a16:creationId xmlns:a16="http://schemas.microsoft.com/office/drawing/2014/main" id="{A1929CA5-B2C4-43AE-B422-06036F5A0D16}"/>
+                <a16:creationId xmlns:a16="http://schemas.microsoft.com/office/drawing/2014/main" id="{59F96083-B115-47B4-AA1D-F310886FBA70}"/>
               </a:ext>
             </a:extLst>
           </p:cNvPr>
@@ -5958,7 +6005,7 @@
           <p:cNvPr id="4" name="text">
             <a:extLst xmlns:a="http://schemas.openxmlformats.org/drawingml/2006/main">
               <a:ext uri="{FF2B5EF4-FFF2-40B4-BE49-F238E27FC236}">
-                <a16:creationId xmlns:a16="http://schemas.microsoft.com/office/drawing/2014/main" id="{2006DBA1-3810-44D4-B90D-362B646B86C4}"/>
+                <a16:creationId xmlns:a16="http://schemas.microsoft.com/office/drawing/2014/main" id="{3B524F4C-3D3E-472F-9C9A-52F33B613CF6}"/>
               </a:ext>
             </a:extLst>
           </p:cNvPr>
@@ -6015,7 +6062,7 @@
           <p:cNvPr id="5" name="text">
             <a:extLst xmlns:a="http://schemas.openxmlformats.org/drawingml/2006/main">
               <a:ext uri="{FF2B5EF4-FFF2-40B4-BE49-F238E27FC236}">
-                <a16:creationId xmlns:a16="http://schemas.microsoft.com/office/drawing/2014/main" id="{0A6B18EF-7683-4D13-9336-8BEABED3EFD7}"/>
+                <a16:creationId xmlns:a16="http://schemas.microsoft.com/office/drawing/2014/main" id="{5ACDD8A2-09AD-462C-BB97-131253FF123C}"/>
               </a:ext>
             </a:extLst>
           </p:cNvPr>
@@ -6072,7 +6119,7 @@
           <p:cNvPr id="6" name="text">
             <a:extLst xmlns:a="http://schemas.openxmlformats.org/drawingml/2006/main">
               <a:ext uri="{FF2B5EF4-FFF2-40B4-BE49-F238E27FC236}">
-                <a16:creationId xmlns:a16="http://schemas.microsoft.com/office/drawing/2014/main" id="{AE2D3589-E240-40D1-98B7-E7B5B082C254}"/>
+                <a16:creationId xmlns:a16="http://schemas.microsoft.com/office/drawing/2014/main" id="{4C0D42FD-812D-4CCF-A61E-AD6F6CD4808D}"/>
               </a:ext>
             </a:extLst>
           </p:cNvPr>
@@ -6129,7 +6176,7 @@
           <p:cNvPr id="7" name="text">
             <a:extLst xmlns:a="http://schemas.openxmlformats.org/drawingml/2006/main">
               <a:ext uri="{FF2B5EF4-FFF2-40B4-BE49-F238E27FC236}">
-                <a16:creationId xmlns:a16="http://schemas.microsoft.com/office/drawing/2014/main" id="{0606CB3C-0969-41F6-A6A1-13F5E1855486}"/>
+                <a16:creationId xmlns:a16="http://schemas.microsoft.com/office/drawing/2014/main" id="{183CDEBF-5551-4D52-B17A-90E32F2148D6}"/>
               </a:ext>
             </a:extLst>
           </p:cNvPr>
@@ -6186,7 +6233,7 @@
           <p:cNvPr id="8" name="text">
             <a:extLst xmlns:a="http://schemas.openxmlformats.org/drawingml/2006/main">
               <a:ext uri="{FF2B5EF4-FFF2-40B4-BE49-F238E27FC236}">
-                <a16:creationId xmlns:a16="http://schemas.microsoft.com/office/drawing/2014/main" id="{7F28BC71-30FB-4CB6-A7AA-3DA1122A359C}"/>
+                <a16:creationId xmlns:a16="http://schemas.microsoft.com/office/drawing/2014/main" id="{5BD05F03-F01A-41E7-B987-7377E85C0D2B}"/>
               </a:ext>
             </a:extLst>
           </p:cNvPr>
@@ -6243,7 +6290,7 @@
           <p:cNvPr id="9" name="Slide number">
             <a:extLst xmlns:a="http://schemas.openxmlformats.org/drawingml/2006/main">
               <a:ext uri="{FF2B5EF4-FFF2-40B4-BE49-F238E27FC236}">
-                <a16:creationId xmlns:a16="http://schemas.microsoft.com/office/drawing/2014/main" id="{D3CBA716-E567-48C0-A592-A22E332D2468}"/>
+                <a16:creationId xmlns:a16="http://schemas.microsoft.com/office/drawing/2014/main" id="{43E61DDD-BEA0-4CED-BCBE-B6B50B96E9F0}"/>
               </a:ext>
             </a:extLst>
           </p:cNvPr>
@@ -6298,7 +6345,7 @@
     </p:spTree>
     <p:extLst>
       <p:ext uri="{BB962C8B-B14F-4D97-AF65-F5344CB8AC3E}">
-        <p14:creationId xmlns:p14="http://schemas.microsoft.com/office/powerpoint/2010/main" val="380737084"/>
+        <p14:creationId xmlns:p14="http://schemas.microsoft.com/office/powerpoint/2010/main" val="1031525693"/>
       </p:ext>
     </p:extLst>
   </p:cSld>
@@ -6329,7 +6376,7 @@
           <p:cNvPr id="11" name="Completed section 0">
             <a:extLst xmlns:a="http://schemas.openxmlformats.org/drawingml/2006/main">
               <a:ext uri="{FF2B5EF4-FFF2-40B4-BE49-F238E27FC236}">
-                <a16:creationId xmlns:a16="http://schemas.microsoft.com/office/drawing/2014/main" id="{238E5B66-693F-42BB-9FAB-15387FE37A4E}"/>
+                <a16:creationId xmlns:a16="http://schemas.microsoft.com/office/drawing/2014/main" id="{ACDDB11C-1C7D-4D5B-8944-1DE9F5B1D709}"/>
               </a:ext>
             </a:extLst>
           </p:cNvPr>
@@ -6386,7 +6433,7 @@
           <p:cNvPr id="2" name="Section description 0">
             <a:extLst xmlns:a="http://schemas.openxmlformats.org/drawingml/2006/main">
               <a:ext uri="{FF2B5EF4-FFF2-40B4-BE49-F238E27FC236}">
-                <a16:creationId xmlns:a16="http://schemas.microsoft.com/office/drawing/2014/main" id="{ABAD8437-94A0-4B05-832F-9D5D079417D1}"/>
+                <a16:creationId xmlns:a16="http://schemas.microsoft.com/office/drawing/2014/main" id="{A74E248D-4F9C-4450-98FF-05D9D662F0B4}"/>
               </a:ext>
             </a:extLst>
           </p:cNvPr>
@@ -6443,7 +6490,7 @@
           <p:cNvPr id="3" name="Title">
             <a:extLst xmlns:a="http://schemas.openxmlformats.org/drawingml/2006/main">
               <a:ext uri="{FF2B5EF4-FFF2-40B4-BE49-F238E27FC236}">
-                <a16:creationId xmlns:a16="http://schemas.microsoft.com/office/drawing/2014/main" id="{5D6E388F-78B7-4E21-88A8-062ABFE0C216}"/>
+                <a16:creationId xmlns:a16="http://schemas.microsoft.com/office/drawing/2014/main" id="{4D7333DC-6AEF-4EE1-8A60-934A4C00F357}"/>
               </a:ext>
             </a:extLst>
           </p:cNvPr>
@@ -6500,7 +6547,7 @@
           <p:cNvPr id="4" name="Section description 1">
             <a:extLst xmlns:a="http://schemas.openxmlformats.org/drawingml/2006/main">
               <a:ext uri="{FF2B5EF4-FFF2-40B4-BE49-F238E27FC236}">
-                <a16:creationId xmlns:a16="http://schemas.microsoft.com/office/drawing/2014/main" id="{08797590-87C3-4CA7-A4A2-9810B87F0D20}"/>
+                <a16:creationId xmlns:a16="http://schemas.microsoft.com/office/drawing/2014/main" id="{B19FC184-FDAA-461D-AD7B-8250E81FD51F}"/>
               </a:ext>
             </a:extLst>
           </p:cNvPr>
@@ -6561,7 +6608,7 @@
           <p:nvPr/>
         </p:nvPicPr>
         <p:blipFill>
-          <a:blip xmlns:r="http://schemas.openxmlformats.org/officeDocument/2006/relationships" xmlns:a="http://schemas.openxmlformats.org/drawingml/2006/main" r:embed="R242badab85a8430f"/>
+          <a:blip xmlns:r="http://schemas.openxmlformats.org/officeDocument/2006/relationships" xmlns:a="http://schemas.openxmlformats.org/drawingml/2006/main" r:embed="R564ee36cee62472c"/>
           <a:stretch xmlns:a="http://schemas.openxmlformats.org/drawingml/2006/main"/>
         </p:blipFill>
         <p:spPr>
@@ -6583,7 +6630,7 @@
           <p:nvPr/>
         </p:nvPicPr>
         <p:blipFill>
-          <a:blip xmlns:r="http://schemas.openxmlformats.org/officeDocument/2006/relationships" xmlns:a="http://schemas.openxmlformats.org/drawingml/2006/main" r:embed="R9e6fda7d56424630"/>
+          <a:blip xmlns:r="http://schemas.openxmlformats.org/officeDocument/2006/relationships" xmlns:a="http://schemas.openxmlformats.org/drawingml/2006/main" r:embed="Rb9d150959bbc46f6"/>
           <a:stretch xmlns:a="http://schemas.openxmlformats.org/drawingml/2006/main"/>
         </p:blipFill>
         <p:spPr>
@@ -6605,7 +6652,7 @@
           <p:nvPr/>
         </p:nvPicPr>
         <p:blipFill>
-          <a:blip xmlns:r="http://schemas.openxmlformats.org/officeDocument/2006/relationships" xmlns:a="http://schemas.openxmlformats.org/drawingml/2006/main" r:embed="Rd86193b25e7f46a1"/>
+          <a:blip xmlns:r="http://schemas.openxmlformats.org/officeDocument/2006/relationships" xmlns:a="http://schemas.openxmlformats.org/drawingml/2006/main" r:embed="Ra4b0f415c36d42e5"/>
           <a:stretch xmlns:a="http://schemas.openxmlformats.org/drawingml/2006/main"/>
         </p:blipFill>
         <p:spPr>
@@ -6627,7 +6674,7 @@
           <p:nvPr/>
         </p:nvPicPr>
         <p:blipFill>
-          <a:blip xmlns:r="http://schemas.openxmlformats.org/officeDocument/2006/relationships" xmlns:a="http://schemas.openxmlformats.org/drawingml/2006/main" r:embed="Re6d58281b99848d4"/>
+          <a:blip xmlns:r="http://schemas.openxmlformats.org/officeDocument/2006/relationships" xmlns:a="http://schemas.openxmlformats.org/drawingml/2006/main" r:embed="R64df57f567b34082"/>
           <a:stretch xmlns:a="http://schemas.openxmlformats.org/drawingml/2006/main"/>
         </p:blipFill>
         <p:spPr>
@@ -6649,7 +6696,7 @@
           <p:nvPr/>
         </p:nvPicPr>
         <p:blipFill>
-          <a:blip xmlns:r="http://schemas.openxmlformats.org/officeDocument/2006/relationships" xmlns:a="http://schemas.openxmlformats.org/drawingml/2006/main" r:embed="R586e2d43d8524628"/>
+          <a:blip xmlns:r="http://schemas.openxmlformats.org/officeDocument/2006/relationships" xmlns:a="http://schemas.openxmlformats.org/drawingml/2006/main" r:embed="R6a9fa6996bdd46bb"/>
           <a:stretch xmlns:a="http://schemas.openxmlformats.org/drawingml/2006/main"/>
         </p:blipFill>
         <p:spPr>
@@ -6667,7 +6714,7 @@
           <p:cNvPr id="10" name="Slide number">
             <a:extLst xmlns:a="http://schemas.openxmlformats.org/drawingml/2006/main">
               <a:ext uri="{FF2B5EF4-FFF2-40B4-BE49-F238E27FC236}">
-                <a16:creationId xmlns:a16="http://schemas.microsoft.com/office/drawing/2014/main" id="{3030B0A6-4E40-4356-94EC-FE281E8FE9A9}"/>
+                <a16:creationId xmlns:a16="http://schemas.microsoft.com/office/drawing/2014/main" id="{464B2E36-E060-4759-8B5A-94F48F4A0FEA}"/>
               </a:ext>
             </a:extLst>
           </p:cNvPr>
@@ -6722,7 +6769,7 @@
     </p:spTree>
     <p:extLst>
       <p:ext uri="{BB962C8B-B14F-4D97-AF65-F5344CB8AC3E}">
-        <p14:creationId xmlns:p14="http://schemas.microsoft.com/office/powerpoint/2010/main" val="2124456534"/>
+        <p14:creationId xmlns:p14="http://schemas.microsoft.com/office/powerpoint/2010/main" val="978183156"/>
       </p:ext>
     </p:extLst>
   </p:cSld>
@@ -6753,7 +6800,7 @@
           <p:cNvPr id="12" name="Title">
             <a:extLst xmlns:a="http://schemas.openxmlformats.org/drawingml/2006/main">
               <a:ext uri="{FF2B5EF4-FFF2-40B4-BE49-F238E27FC236}">
-                <a16:creationId xmlns:a16="http://schemas.microsoft.com/office/drawing/2014/main" id="{5D64C06F-4ABF-4241-87EA-156905029A44}"/>
+                <a16:creationId xmlns:a16="http://schemas.microsoft.com/office/drawing/2014/main" id="{93C2A37B-6123-4DFE-A6F4-93D0BA53FDCD}"/>
               </a:ext>
             </a:extLst>
           </p:cNvPr>
@@ -6810,7 +6857,7 @@
           <p:cNvPr id="2" name="text">
             <a:extLst xmlns:a="http://schemas.openxmlformats.org/drawingml/2006/main">
               <a:ext uri="{FF2B5EF4-FFF2-40B4-BE49-F238E27FC236}">
-                <a16:creationId xmlns:a16="http://schemas.microsoft.com/office/drawing/2014/main" id="{F895DCD0-E85C-4E52-A4E5-CCC70DF91399}"/>
+                <a16:creationId xmlns:a16="http://schemas.microsoft.com/office/drawing/2014/main" id="{95C50288-F2B4-44EE-AB8A-22509616B414}"/>
               </a:ext>
             </a:extLst>
           </p:cNvPr>
@@ -6867,7 +6914,7 @@
           <p:cNvPr id="3" name="text">
             <a:extLst xmlns:a="http://schemas.openxmlformats.org/drawingml/2006/main">
               <a:ext uri="{FF2B5EF4-FFF2-40B4-BE49-F238E27FC236}">
-                <a16:creationId xmlns:a16="http://schemas.microsoft.com/office/drawing/2014/main" id="{DCDA642F-D8CF-4D13-A368-3B4469B9C01A}"/>
+                <a16:creationId xmlns:a16="http://schemas.microsoft.com/office/drawing/2014/main" id="{1922F3D0-42E3-4807-8C80-F9652C3ACBE1}"/>
               </a:ext>
             </a:extLst>
           </p:cNvPr>
@@ -6924,7 +6971,7 @@
           <p:cNvPr id="4" name="text">
             <a:extLst xmlns:a="http://schemas.openxmlformats.org/drawingml/2006/main">
               <a:ext uri="{FF2B5EF4-FFF2-40B4-BE49-F238E27FC236}">
-                <a16:creationId xmlns:a16="http://schemas.microsoft.com/office/drawing/2014/main" id="{BCD98403-0F0D-4835-9069-ACF01010EA3A}"/>
+                <a16:creationId xmlns:a16="http://schemas.microsoft.com/office/drawing/2014/main" id="{FC2ECD5E-8EB4-4C3B-8EDD-A80E7B729F75}"/>
               </a:ext>
             </a:extLst>
           </p:cNvPr>
@@ -6981,7 +7028,7 @@
           <p:cNvPr id="5" name="text">
             <a:extLst xmlns:a="http://schemas.openxmlformats.org/drawingml/2006/main">
               <a:ext uri="{FF2B5EF4-FFF2-40B4-BE49-F238E27FC236}">
-                <a16:creationId xmlns:a16="http://schemas.microsoft.com/office/drawing/2014/main" id="{DBDA1E82-E50C-4BE1-954F-512CDC83CD55}"/>
+                <a16:creationId xmlns:a16="http://schemas.microsoft.com/office/drawing/2014/main" id="{565A2F73-61DD-40C9-944E-6705256AE072}"/>
               </a:ext>
             </a:extLst>
           </p:cNvPr>
@@ -7038,7 +7085,7 @@
           <p:cNvPr id="6" name="text">
             <a:extLst xmlns:a="http://schemas.openxmlformats.org/drawingml/2006/main">
               <a:ext uri="{FF2B5EF4-FFF2-40B4-BE49-F238E27FC236}">
-                <a16:creationId xmlns:a16="http://schemas.microsoft.com/office/drawing/2014/main" id="{8CD16C40-529A-4B5D-BE01-ACF1477C245C}"/>
+                <a16:creationId xmlns:a16="http://schemas.microsoft.com/office/drawing/2014/main" id="{0538101A-12E6-49FD-990D-5754A3F52AEE}"/>
               </a:ext>
             </a:extLst>
           </p:cNvPr>
@@ -7095,7 +7142,7 @@
           <p:cNvPr id="7" name="text">
             <a:extLst xmlns:a="http://schemas.openxmlformats.org/drawingml/2006/main">
               <a:ext uri="{FF2B5EF4-FFF2-40B4-BE49-F238E27FC236}">
-                <a16:creationId xmlns:a16="http://schemas.microsoft.com/office/drawing/2014/main" id="{B8E30D94-0801-4574-AFC5-598FBE3A1A1D}"/>
+                <a16:creationId xmlns:a16="http://schemas.microsoft.com/office/drawing/2014/main" id="{6E380CC0-12A7-4428-969D-D925CD6E8168}"/>
               </a:ext>
             </a:extLst>
           </p:cNvPr>
@@ -7152,7 +7199,7 @@
           <p:cNvPr id="8" name="text">
             <a:extLst xmlns:a="http://schemas.openxmlformats.org/drawingml/2006/main">
               <a:ext uri="{FF2B5EF4-FFF2-40B4-BE49-F238E27FC236}">
-                <a16:creationId xmlns:a16="http://schemas.microsoft.com/office/drawing/2014/main" id="{8ADB833B-3C4B-4857-87B1-2512A0892760}"/>
+                <a16:creationId xmlns:a16="http://schemas.microsoft.com/office/drawing/2014/main" id="{2541E784-2F17-4B0D-810F-819A6E41EC3E}"/>
               </a:ext>
             </a:extLst>
           </p:cNvPr>
@@ -7209,7 +7256,7 @@
           <p:cNvPr id="9" name="text">
             <a:extLst xmlns:a="http://schemas.openxmlformats.org/drawingml/2006/main">
               <a:ext uri="{FF2B5EF4-FFF2-40B4-BE49-F238E27FC236}">
-                <a16:creationId xmlns:a16="http://schemas.microsoft.com/office/drawing/2014/main" id="{640FFA4A-E8AC-4EED-97CC-74BB607421EA}"/>
+                <a16:creationId xmlns:a16="http://schemas.microsoft.com/office/drawing/2014/main" id="{82E16921-FECC-4A04-9279-CC4C5C548E0B}"/>
               </a:ext>
             </a:extLst>
           </p:cNvPr>
@@ -7266,7 +7313,7 @@
           <p:cNvPr id="10" name="text">
             <a:extLst xmlns:a="http://schemas.openxmlformats.org/drawingml/2006/main">
               <a:ext uri="{FF2B5EF4-FFF2-40B4-BE49-F238E27FC236}">
-                <a16:creationId xmlns:a16="http://schemas.microsoft.com/office/drawing/2014/main" id="{AA1257D6-2C8A-41BA-AFE7-3C4A9A33769C}"/>
+                <a16:creationId xmlns:a16="http://schemas.microsoft.com/office/drawing/2014/main" id="{7701C3C3-FB6E-4756-AE67-D12D5998DD1C}"/>
               </a:ext>
             </a:extLst>
           </p:cNvPr>
@@ -7323,7 +7370,7 @@
           <p:cNvPr id="11" name="Slide number">
             <a:extLst xmlns:a="http://schemas.openxmlformats.org/drawingml/2006/main">
               <a:ext uri="{FF2B5EF4-FFF2-40B4-BE49-F238E27FC236}">
-                <a16:creationId xmlns:a16="http://schemas.microsoft.com/office/drawing/2014/main" id="{3A4E7BBB-7109-49B4-A9FA-9018C6C1868D}"/>
+                <a16:creationId xmlns:a16="http://schemas.microsoft.com/office/drawing/2014/main" id="{C6F07778-E143-4332-9316-A13F0993FF99}"/>
               </a:ext>
             </a:extLst>
           </p:cNvPr>
@@ -7378,7 +7425,7 @@
     </p:spTree>
     <p:extLst>
       <p:ext uri="{BB962C8B-B14F-4D97-AF65-F5344CB8AC3E}">
-        <p14:creationId xmlns:p14="http://schemas.microsoft.com/office/powerpoint/2010/main" val="720973701"/>
+        <p14:creationId xmlns:p14="http://schemas.microsoft.com/office/powerpoint/2010/main" val="1381614762"/>
       </p:ext>
     </p:extLst>
   </p:cSld>
@@ -7409,7 +7456,7 @@
           <p:cNvPr id="7" name="Title">
             <a:extLst xmlns:a="http://schemas.openxmlformats.org/drawingml/2006/main">
               <a:ext uri="{FF2B5EF4-FFF2-40B4-BE49-F238E27FC236}">
-                <a16:creationId xmlns:a16="http://schemas.microsoft.com/office/drawing/2014/main" id="{2EB19C7C-A3F6-444F-B59C-0B2F5C03A7FE}"/>
+                <a16:creationId xmlns:a16="http://schemas.microsoft.com/office/drawing/2014/main" id="{6252A9E6-BD23-4527-BEB0-D935CC1CB387}"/>
               </a:ext>
             </a:extLst>
           </p:cNvPr>
@@ -7473,7 +7520,7 @@
         </p:xfrm>
         <a:graphic xmlns:a="http://schemas.openxmlformats.org/drawingml/2006/main">
           <a:graphicData uri="http://schemas.openxmlformats.org/drawingml/2006/chart">
-            <c:chart xmlns:r="http://schemas.openxmlformats.org/officeDocument/2006/relationships" xmlns:c="http://schemas.openxmlformats.org/drawingml/2006/chart" r:id="Ra13ed82f826d4449"/>
+            <c:chart xmlns:r="http://schemas.openxmlformats.org/officeDocument/2006/relationships" xmlns:c="http://schemas.openxmlformats.org/drawingml/2006/chart" r:id="R90e66843db9e43b4"/>
           </a:graphicData>
         </a:graphic>
       </p:graphicFrame>
@@ -7482,7 +7529,7 @@
           <p:cNvPr id="3" name="April month marker">
             <a:extLst xmlns:a="http://schemas.openxmlformats.org/drawingml/2006/main">
               <a:ext uri="{FF2B5EF4-FFF2-40B4-BE49-F238E27FC236}">
-                <a16:creationId xmlns:a16="http://schemas.microsoft.com/office/drawing/2014/main" id="{A54AE35F-D837-4B85-92AF-2F31DF505291}"/>
+                <a16:creationId xmlns:a16="http://schemas.microsoft.com/office/drawing/2014/main" id="{550D2CA3-E16D-498D-A583-8820A9340ED4}"/>
               </a:ext>
             </a:extLst>
           </p:cNvPr>
@@ -7513,7 +7560,7 @@
           <p:cNvPr id="4" name="April joining context">
             <a:extLst xmlns:a="http://schemas.openxmlformats.org/drawingml/2006/main">
               <a:ext uri="{FF2B5EF4-FFF2-40B4-BE49-F238E27FC236}">
-                <a16:creationId xmlns:a16="http://schemas.microsoft.com/office/drawing/2014/main" id="{00FC1A92-A02F-47C1-8EED-E2BAFFED653E}"/>
+                <a16:creationId xmlns:a16="http://schemas.microsoft.com/office/drawing/2014/main" id="{C797346A-0E26-457F-8983-78DB2217E41C}"/>
               </a:ext>
             </a:extLst>
           </p:cNvPr>
@@ -7570,7 +7617,7 @@
           <p:cNvPr id="5" name="Methodology">
             <a:extLst xmlns:a="http://schemas.openxmlformats.org/drawingml/2006/main">
               <a:ext uri="{FF2B5EF4-FFF2-40B4-BE49-F238E27FC236}">
-                <a16:creationId xmlns:a16="http://schemas.microsoft.com/office/drawing/2014/main" id="{65D1CDB4-55CC-4BB7-9CFB-925845523734}"/>
+                <a16:creationId xmlns:a16="http://schemas.microsoft.com/office/drawing/2014/main" id="{D867AD4F-EEA6-40C5-B641-37BE95D14830}"/>
               </a:ext>
             </a:extLst>
           </p:cNvPr>
@@ -7627,7 +7674,7 @@
           <p:cNvPr id="6" name="Slide number">
             <a:extLst xmlns:a="http://schemas.openxmlformats.org/drawingml/2006/main">
               <a:ext uri="{FF2B5EF4-FFF2-40B4-BE49-F238E27FC236}">
-                <a16:creationId xmlns:a16="http://schemas.microsoft.com/office/drawing/2014/main" id="{57DC0788-5A7D-49AD-85D1-C6F003825728}"/>
+                <a16:creationId xmlns:a16="http://schemas.microsoft.com/office/drawing/2014/main" id="{72E0DA62-B7EE-4C7F-94FD-C6F9EFE242D8}"/>
               </a:ext>
             </a:extLst>
           </p:cNvPr>
@@ -7682,7 +7729,7 @@
     </p:spTree>
     <p:extLst>
       <p:ext uri="{BB962C8B-B14F-4D97-AF65-F5344CB8AC3E}">
-        <p14:creationId xmlns:p14="http://schemas.microsoft.com/office/powerpoint/2010/main" val="227247027"/>
+        <p14:creationId xmlns:p14="http://schemas.microsoft.com/office/powerpoint/2010/main" val="443209956"/>
       </p:ext>
     </p:extLst>
   </p:cSld>
@@ -7713,7 +7760,7 @@
           <p:cNvPr id="12" name="Completed section 0">
             <a:extLst xmlns:a="http://schemas.openxmlformats.org/drawingml/2006/main">
               <a:ext uri="{FF2B5EF4-FFF2-40B4-BE49-F238E27FC236}">
-                <a16:creationId xmlns:a16="http://schemas.microsoft.com/office/drawing/2014/main" id="{EE9B6DCF-FFE2-4364-B595-DDE34B642344}"/>
+                <a16:creationId xmlns:a16="http://schemas.microsoft.com/office/drawing/2014/main" id="{CC7D9535-4CCB-4242-9E94-A8CC64E5FFDF}"/>
               </a:ext>
             </a:extLst>
           </p:cNvPr>
@@ -7770,7 +7817,7 @@
           <p:cNvPr id="2" name="Section description 0">
             <a:extLst xmlns:a="http://schemas.openxmlformats.org/drawingml/2006/main">
               <a:ext uri="{FF2B5EF4-FFF2-40B4-BE49-F238E27FC236}">
-                <a16:creationId xmlns:a16="http://schemas.microsoft.com/office/drawing/2014/main" id="{D6024FC3-49F3-432E-B329-B1147B4E24C4}"/>
+                <a16:creationId xmlns:a16="http://schemas.microsoft.com/office/drawing/2014/main" id="{D002FFC4-CF7C-423F-85EB-5BFE61FD87C4}"/>
               </a:ext>
             </a:extLst>
           </p:cNvPr>
@@ -7827,7 +7874,7 @@
           <p:cNvPr id="3" name="Completed section 1">
             <a:extLst xmlns:a="http://schemas.openxmlformats.org/drawingml/2006/main">
               <a:ext uri="{FF2B5EF4-FFF2-40B4-BE49-F238E27FC236}">
-                <a16:creationId xmlns:a16="http://schemas.microsoft.com/office/drawing/2014/main" id="{63DCD139-F8BE-4CE0-A6E4-AD24C457FE56}"/>
+                <a16:creationId xmlns:a16="http://schemas.microsoft.com/office/drawing/2014/main" id="{D38F0230-A282-43D8-A5A3-5860D8328674}"/>
               </a:ext>
             </a:extLst>
           </p:cNvPr>
@@ -7884,7 +7931,7 @@
           <p:cNvPr id="4" name="Section description 1">
             <a:extLst xmlns:a="http://schemas.openxmlformats.org/drawingml/2006/main">
               <a:ext uri="{FF2B5EF4-FFF2-40B4-BE49-F238E27FC236}">
-                <a16:creationId xmlns:a16="http://schemas.microsoft.com/office/drawing/2014/main" id="{C5828090-0FDD-48E1-B110-4F66B7AEF1C9}"/>
+                <a16:creationId xmlns:a16="http://schemas.microsoft.com/office/drawing/2014/main" id="{DA451308-AB2E-41BA-A186-36D9075D60A6}"/>
               </a:ext>
             </a:extLst>
           </p:cNvPr>
@@ -7941,7 +7988,7 @@
           <p:cNvPr id="5" name="Title">
             <a:extLst xmlns:a="http://schemas.openxmlformats.org/drawingml/2006/main">
               <a:ext uri="{FF2B5EF4-FFF2-40B4-BE49-F238E27FC236}">
-                <a16:creationId xmlns:a16="http://schemas.microsoft.com/office/drawing/2014/main" id="{33D73F21-33B4-435E-87FA-7DBD9D546010}"/>
+                <a16:creationId xmlns:a16="http://schemas.microsoft.com/office/drawing/2014/main" id="{030786C6-8316-4A1A-B805-EBB435377E13}"/>
               </a:ext>
             </a:extLst>
           </p:cNvPr>
@@ -7998,7 +8045,7 @@
           <p:cNvPr id="6" name="Section description 2">
             <a:extLst xmlns:a="http://schemas.openxmlformats.org/drawingml/2006/main">
               <a:ext uri="{FF2B5EF4-FFF2-40B4-BE49-F238E27FC236}">
-                <a16:creationId xmlns:a16="http://schemas.microsoft.com/office/drawing/2014/main" id="{62632D5E-C527-431B-BE40-03BF020C4585}"/>
+                <a16:creationId xmlns:a16="http://schemas.microsoft.com/office/drawing/2014/main" id="{013820CF-36D4-431F-A992-9FDE6DB58DDC}"/>
               </a:ext>
             </a:extLst>
           </p:cNvPr>
@@ -8059,7 +8106,7 @@
           <p:nvPr/>
         </p:nvPicPr>
         <p:blipFill>
-          <a:blip xmlns:r="http://schemas.openxmlformats.org/officeDocument/2006/relationships" xmlns:a="http://schemas.openxmlformats.org/drawingml/2006/main" r:embed="R1c1c128224c8434f"/>
+          <a:blip xmlns:r="http://schemas.openxmlformats.org/officeDocument/2006/relationships" xmlns:a="http://schemas.openxmlformats.org/drawingml/2006/main" r:embed="R92c8ce00253044a0"/>
           <a:stretch xmlns:a="http://schemas.openxmlformats.org/drawingml/2006/main"/>
         </p:blipFill>
         <p:spPr>
@@ -8081,7 +8128,7 @@
           <p:nvPr/>
         </p:nvPicPr>
         <p:blipFill>
-          <a:blip xmlns:r="http://schemas.openxmlformats.org/officeDocument/2006/relationships" xmlns:a="http://schemas.openxmlformats.org/drawingml/2006/main" r:embed="Raae02882cfcd4888"/>
+          <a:blip xmlns:r="http://schemas.openxmlformats.org/officeDocument/2006/relationships" xmlns:a="http://schemas.openxmlformats.org/drawingml/2006/main" r:embed="R43d4c8dd01994996"/>
           <a:stretch xmlns:a="http://schemas.openxmlformats.org/drawingml/2006/main"/>
         </p:blipFill>
         <p:spPr>
@@ -8103,7 +8150,7 @@
           <p:nvPr/>
         </p:nvPicPr>
         <p:blipFill>
-          <a:blip xmlns:r="http://schemas.openxmlformats.org/officeDocument/2006/relationships" xmlns:a="http://schemas.openxmlformats.org/drawingml/2006/main" r:embed="R642d0382c50a4e50"/>
+          <a:blip xmlns:r="http://schemas.openxmlformats.org/officeDocument/2006/relationships" xmlns:a="http://schemas.openxmlformats.org/drawingml/2006/main" r:embed="Ra4c6cb94ec6e4392"/>
           <a:stretch xmlns:a="http://schemas.openxmlformats.org/drawingml/2006/main"/>
         </p:blipFill>
         <p:spPr>
@@ -8125,7 +8172,7 @@
           <p:nvPr/>
         </p:nvPicPr>
         <p:blipFill>
-          <a:blip xmlns:r="http://schemas.openxmlformats.org/officeDocument/2006/relationships" xmlns:a="http://schemas.openxmlformats.org/drawingml/2006/main" r:embed="R7611b23f8a7e44b5"/>
+          <a:blip xmlns:r="http://schemas.openxmlformats.org/officeDocument/2006/relationships" xmlns:a="http://schemas.openxmlformats.org/drawingml/2006/main" r:embed="Recd67ba14a504214"/>
           <a:stretch xmlns:a="http://schemas.openxmlformats.org/drawingml/2006/main"/>
         </p:blipFill>
         <p:spPr>
@@ -8143,7 +8190,7 @@
           <p:cNvPr id="11" name="Slide number">
             <a:extLst xmlns:a="http://schemas.openxmlformats.org/drawingml/2006/main">
               <a:ext uri="{FF2B5EF4-FFF2-40B4-BE49-F238E27FC236}">
-                <a16:creationId xmlns:a16="http://schemas.microsoft.com/office/drawing/2014/main" id="{0A2849D5-995D-4405-8EFA-8C81BDE1FC1A}"/>
+                <a16:creationId xmlns:a16="http://schemas.microsoft.com/office/drawing/2014/main" id="{0785596F-1B47-44C8-96B8-97B9A9591E5D}"/>
               </a:ext>
             </a:extLst>
           </p:cNvPr>
@@ -8198,7 +8245,7 @@
     </p:spTree>
     <p:extLst>
       <p:ext uri="{BB962C8B-B14F-4D97-AF65-F5344CB8AC3E}">
-        <p14:creationId xmlns:p14="http://schemas.microsoft.com/office/powerpoint/2010/main" val="209495894"/>
+        <p14:creationId xmlns:p14="http://schemas.microsoft.com/office/powerpoint/2010/main" val="1655369044"/>
       </p:ext>
     </p:extLst>
   </p:cSld>
@@ -8229,7 +8276,7 @@
           <p:cNvPr id="11" name="Title">
             <a:extLst xmlns:a="http://schemas.openxmlformats.org/drawingml/2006/main">
               <a:ext uri="{FF2B5EF4-FFF2-40B4-BE49-F238E27FC236}">
-                <a16:creationId xmlns:a16="http://schemas.microsoft.com/office/drawing/2014/main" id="{0684B23E-6D3C-4176-8B99-98D3291ADB14}"/>
+                <a16:creationId xmlns:a16="http://schemas.microsoft.com/office/drawing/2014/main" id="{5DAA1398-2698-457B-9A8A-483BECF128B1}"/>
               </a:ext>
             </a:extLst>
           </p:cNvPr>
@@ -8286,7 +8333,7 @@
           <p:cNvPr id="2" name="text">
             <a:extLst xmlns:a="http://schemas.openxmlformats.org/drawingml/2006/main">
               <a:ext uri="{FF2B5EF4-FFF2-40B4-BE49-F238E27FC236}">
-                <a16:creationId xmlns:a16="http://schemas.microsoft.com/office/drawing/2014/main" id="{3F17F846-A850-46E1-9B2F-533F12144687}"/>
+                <a16:creationId xmlns:a16="http://schemas.microsoft.com/office/drawing/2014/main" id="{30A94E23-7455-4BE3-995D-60B1F775BAB2}"/>
               </a:ext>
             </a:extLst>
           </p:cNvPr>
@@ -8343,7 +8390,7 @@
           <p:cNvPr id="3" name="text">
             <a:extLst xmlns:a="http://schemas.openxmlformats.org/drawingml/2006/main">
               <a:ext uri="{FF2B5EF4-FFF2-40B4-BE49-F238E27FC236}">
-                <a16:creationId xmlns:a16="http://schemas.microsoft.com/office/drawing/2014/main" id="{115D2231-DF71-4D8E-A2E9-CD6E25425B44}"/>
+                <a16:creationId xmlns:a16="http://schemas.microsoft.com/office/drawing/2014/main" id="{A5EBF88B-3B14-4AA5-88E0-4FC38036433E}"/>
               </a:ext>
             </a:extLst>
           </p:cNvPr>
@@ -8400,7 +8447,7 @@
           <p:cNvPr id="4" name="text">
             <a:extLst xmlns:a="http://schemas.openxmlformats.org/drawingml/2006/main">
               <a:ext uri="{FF2B5EF4-FFF2-40B4-BE49-F238E27FC236}">
-                <a16:creationId xmlns:a16="http://schemas.microsoft.com/office/drawing/2014/main" id="{1DAC0E14-F593-4FB0-9D03-2B302C58483F}"/>
+                <a16:creationId xmlns:a16="http://schemas.microsoft.com/office/drawing/2014/main" id="{0F29B60F-6991-4BB4-9B55-097F5E7BFEA2}"/>
               </a:ext>
             </a:extLst>
           </p:cNvPr>
@@ -8457,7 +8504,7 @@
           <p:cNvPr id="5" name="text">
             <a:extLst xmlns:a="http://schemas.openxmlformats.org/drawingml/2006/main">
               <a:ext uri="{FF2B5EF4-FFF2-40B4-BE49-F238E27FC236}">
-                <a16:creationId xmlns:a16="http://schemas.microsoft.com/office/drawing/2014/main" id="{F541F3C0-1F66-438F-B933-FBE204BAAB66}"/>
+                <a16:creationId xmlns:a16="http://schemas.microsoft.com/office/drawing/2014/main" id="{5CA651BB-E787-46A8-92B4-202DFFD4BBA5}"/>
               </a:ext>
             </a:extLst>
           </p:cNvPr>
@@ -8514,7 +8561,7 @@
           <p:cNvPr id="6" name="text">
             <a:extLst xmlns:a="http://schemas.openxmlformats.org/drawingml/2006/main">
               <a:ext uri="{FF2B5EF4-FFF2-40B4-BE49-F238E27FC236}">
-                <a16:creationId xmlns:a16="http://schemas.microsoft.com/office/drawing/2014/main" id="{0774BB55-40F8-45F4-94B6-F794A831EEB4}"/>
+                <a16:creationId xmlns:a16="http://schemas.microsoft.com/office/drawing/2014/main" id="{B998258E-7424-4E71-84DA-C08CAF07D40F}"/>
               </a:ext>
             </a:extLst>
           </p:cNvPr>
@@ -8571,7 +8618,7 @@
           <p:cNvPr id="7" name="text">
             <a:extLst xmlns:a="http://schemas.openxmlformats.org/drawingml/2006/main">
               <a:ext uri="{FF2B5EF4-FFF2-40B4-BE49-F238E27FC236}">
-                <a16:creationId xmlns:a16="http://schemas.microsoft.com/office/drawing/2014/main" id="{B2FDD650-B3E8-4321-AAA5-76340581EDF8}"/>
+                <a16:creationId xmlns:a16="http://schemas.microsoft.com/office/drawing/2014/main" id="{AEB5ACA6-B474-462A-A18B-7BF4AE92914C}"/>
               </a:ext>
             </a:extLst>
           </p:cNvPr>
@@ -8628,7 +8675,7 @@
           <p:cNvPr id="8" name="text">
             <a:extLst xmlns:a="http://schemas.openxmlformats.org/drawingml/2006/main">
               <a:ext uri="{FF2B5EF4-FFF2-40B4-BE49-F238E27FC236}">
-                <a16:creationId xmlns:a16="http://schemas.microsoft.com/office/drawing/2014/main" id="{0A2D36F2-E2A6-4F34-BAD1-07847B089903}"/>
+                <a16:creationId xmlns:a16="http://schemas.microsoft.com/office/drawing/2014/main" id="{A1563359-A226-48D3-B461-2FD99E5FDE86}"/>
               </a:ext>
             </a:extLst>
           </p:cNvPr>
@@ -8685,7 +8732,7 @@
           <p:cNvPr id="9" name="text">
             <a:extLst xmlns:a="http://schemas.openxmlformats.org/drawingml/2006/main">
               <a:ext uri="{FF2B5EF4-FFF2-40B4-BE49-F238E27FC236}">
-                <a16:creationId xmlns:a16="http://schemas.microsoft.com/office/drawing/2014/main" id="{31DA34E2-3897-4BCD-A487-A24F781A4915}"/>
+                <a16:creationId xmlns:a16="http://schemas.microsoft.com/office/drawing/2014/main" id="{9FCF66E4-77AE-4152-89CB-556F498EDF54}"/>
               </a:ext>
             </a:extLst>
           </p:cNvPr>
@@ -8742,7 +8789,7 @@
           <p:cNvPr id="10" name="Slide number">
             <a:extLst xmlns:a="http://schemas.openxmlformats.org/drawingml/2006/main">
               <a:ext uri="{FF2B5EF4-FFF2-40B4-BE49-F238E27FC236}">
-                <a16:creationId xmlns:a16="http://schemas.microsoft.com/office/drawing/2014/main" id="{27B73733-4656-4330-9732-22C73D1458E2}"/>
+                <a16:creationId xmlns:a16="http://schemas.microsoft.com/office/drawing/2014/main" id="{F5D11C03-F974-41E9-A89B-D47572C03EA2}"/>
               </a:ext>
             </a:extLst>
           </p:cNvPr>
@@ -8797,7 +8844,7 @@
     </p:spTree>
     <p:extLst>
       <p:ext uri="{BB962C8B-B14F-4D97-AF65-F5344CB8AC3E}">
-        <p14:creationId xmlns:p14="http://schemas.microsoft.com/office/powerpoint/2010/main" val="309496614"/>
+        <p14:creationId xmlns:p14="http://schemas.microsoft.com/office/powerpoint/2010/main" val="891508891"/>
       </p:ext>
     </p:extLst>
   </p:cSld>
@@ -8828,7 +8875,7 @@
           <p:cNvPr id="5" name="Title">
             <a:extLst xmlns:a="http://schemas.openxmlformats.org/drawingml/2006/main">
               <a:ext uri="{FF2B5EF4-FFF2-40B4-BE49-F238E27FC236}">
-                <a16:creationId xmlns:a16="http://schemas.microsoft.com/office/drawing/2014/main" id="{8A391874-9CA9-4916-9CC1-3CF507761C73}"/>
+                <a16:creationId xmlns:a16="http://schemas.microsoft.com/office/drawing/2014/main" id="{80B9FB35-E991-4E7C-8F09-4A58CCE2813B}"/>
               </a:ext>
             </a:extLst>
           </p:cNvPr>
@@ -8885,7 +8932,7 @@
           <p:cNvPr id="2" name="Metric value">
             <a:extLst xmlns:a="http://schemas.openxmlformats.org/drawingml/2006/main">
               <a:ext uri="{FF2B5EF4-FFF2-40B4-BE49-F238E27FC236}">
-                <a16:creationId xmlns:a16="http://schemas.microsoft.com/office/drawing/2014/main" id="{C8B8DB95-4916-42BC-BC0E-3C253ABD1B76}"/>
+                <a16:creationId xmlns:a16="http://schemas.microsoft.com/office/drawing/2014/main" id="{70D68C48-77F9-44F8-B46A-156C307649B0}"/>
               </a:ext>
             </a:extLst>
           </p:cNvPr>
@@ -8942,7 +8989,7 @@
           <p:cNvPr id="3" name="text">
             <a:extLst xmlns:a="http://schemas.openxmlformats.org/drawingml/2006/main">
               <a:ext uri="{FF2B5EF4-FFF2-40B4-BE49-F238E27FC236}">
-                <a16:creationId xmlns:a16="http://schemas.microsoft.com/office/drawing/2014/main" id="{E3CFE3BE-E09E-44E6-8BE2-E78A525276C0}"/>
+                <a16:creationId xmlns:a16="http://schemas.microsoft.com/office/drawing/2014/main" id="{D3492B33-9A74-4BB2-9F45-866CD312D133}"/>
               </a:ext>
             </a:extLst>
           </p:cNvPr>
@@ -8999,7 +9046,7 @@
           <p:cNvPr id="4" name="Slide number">
             <a:extLst xmlns:a="http://schemas.openxmlformats.org/drawingml/2006/main">
               <a:ext uri="{FF2B5EF4-FFF2-40B4-BE49-F238E27FC236}">
-                <a16:creationId xmlns:a16="http://schemas.microsoft.com/office/drawing/2014/main" id="{66EF9902-D141-4B8D-BEEF-1BB6DF952B9E}"/>
+                <a16:creationId xmlns:a16="http://schemas.microsoft.com/office/drawing/2014/main" id="{38665F53-0F5D-4673-9D61-F5DDAD6F9121}"/>
               </a:ext>
             </a:extLst>
           </p:cNvPr>
@@ -9054,7 +9101,7 @@
     </p:spTree>
     <p:extLst>
       <p:ext uri="{BB962C8B-B14F-4D97-AF65-F5344CB8AC3E}">
-        <p14:creationId xmlns:p14="http://schemas.microsoft.com/office/powerpoint/2010/main" val="1287209004"/>
+        <p14:creationId xmlns:p14="http://schemas.microsoft.com/office/powerpoint/2010/main" val="1361532060"/>
       </p:ext>
     </p:extLst>
   </p:cSld>
@@ -9085,7 +9132,7 @@
           <p:cNvPr id="13" name="Completed section 0">
             <a:extLst xmlns:a="http://schemas.openxmlformats.org/drawingml/2006/main">
               <a:ext uri="{FF2B5EF4-FFF2-40B4-BE49-F238E27FC236}">
-                <a16:creationId xmlns:a16="http://schemas.microsoft.com/office/drawing/2014/main" id="{A3D53630-AA22-4631-BA14-720D57CA3C8E}"/>
+                <a16:creationId xmlns:a16="http://schemas.microsoft.com/office/drawing/2014/main" id="{67017849-36D3-464C-A7EB-7CFA476B14D0}"/>
               </a:ext>
             </a:extLst>
           </p:cNvPr>
@@ -9142,7 +9189,7 @@
           <p:cNvPr id="2" name="Section description 0">
             <a:extLst xmlns:a="http://schemas.openxmlformats.org/drawingml/2006/main">
               <a:ext uri="{FF2B5EF4-FFF2-40B4-BE49-F238E27FC236}">
-                <a16:creationId xmlns:a16="http://schemas.microsoft.com/office/drawing/2014/main" id="{8E2FBAA4-D073-4E45-BF11-49828476E423}"/>
+                <a16:creationId xmlns:a16="http://schemas.microsoft.com/office/drawing/2014/main" id="{85553CB1-507A-499D-A101-03F704B19A7E}"/>
               </a:ext>
             </a:extLst>
           </p:cNvPr>
@@ -9199,7 +9246,7 @@
           <p:cNvPr id="3" name="Completed section 1">
             <a:extLst xmlns:a="http://schemas.openxmlformats.org/drawingml/2006/main">
               <a:ext uri="{FF2B5EF4-FFF2-40B4-BE49-F238E27FC236}">
-                <a16:creationId xmlns:a16="http://schemas.microsoft.com/office/drawing/2014/main" id="{642ED221-668D-4E7A-8A49-05F723CE69A1}"/>
+                <a16:creationId xmlns:a16="http://schemas.microsoft.com/office/drawing/2014/main" id="{9242B5A9-15B8-4F80-8555-A7C7F3D89EBB}"/>
               </a:ext>
             </a:extLst>
           </p:cNvPr>
@@ -9256,7 +9303,7 @@
           <p:cNvPr id="4" name="Section description 1">
             <a:extLst xmlns:a="http://schemas.openxmlformats.org/drawingml/2006/main">
               <a:ext uri="{FF2B5EF4-FFF2-40B4-BE49-F238E27FC236}">
-                <a16:creationId xmlns:a16="http://schemas.microsoft.com/office/drawing/2014/main" id="{3E4C2C8A-F22B-4216-9E32-6C11C0BFDA64}"/>
+                <a16:creationId xmlns:a16="http://schemas.microsoft.com/office/drawing/2014/main" id="{9DDD57BE-B264-4EA0-ABD2-E21AE71ECDE9}"/>
               </a:ext>
             </a:extLst>
           </p:cNvPr>
@@ -9313,7 +9360,7 @@
           <p:cNvPr id="5" name="Completed section 2">
             <a:extLst xmlns:a="http://schemas.openxmlformats.org/drawingml/2006/main">
               <a:ext uri="{FF2B5EF4-FFF2-40B4-BE49-F238E27FC236}">
-                <a16:creationId xmlns:a16="http://schemas.microsoft.com/office/drawing/2014/main" id="{54969F4B-960D-4247-8C39-55C146994D9C}"/>
+                <a16:creationId xmlns:a16="http://schemas.microsoft.com/office/drawing/2014/main" id="{B02FA1C0-CC25-474C-9E7E-C138BDA047CA}"/>
               </a:ext>
             </a:extLst>
           </p:cNvPr>
@@ -9370,7 +9417,7 @@
           <p:cNvPr id="6" name="Section description 2">
             <a:extLst xmlns:a="http://schemas.openxmlformats.org/drawingml/2006/main">
               <a:ext uri="{FF2B5EF4-FFF2-40B4-BE49-F238E27FC236}">
-                <a16:creationId xmlns:a16="http://schemas.microsoft.com/office/drawing/2014/main" id="{259F437E-4E32-423B-832B-4BF0F666AEAA}"/>
+                <a16:creationId xmlns:a16="http://schemas.microsoft.com/office/drawing/2014/main" id="{84CA0994-97F1-40E5-8766-68DD3F259C49}"/>
               </a:ext>
             </a:extLst>
           </p:cNvPr>
@@ -9427,7 +9474,7 @@
           <p:cNvPr id="7" name="Title">
             <a:extLst xmlns:a="http://schemas.openxmlformats.org/drawingml/2006/main">
               <a:ext uri="{FF2B5EF4-FFF2-40B4-BE49-F238E27FC236}">
-                <a16:creationId xmlns:a16="http://schemas.microsoft.com/office/drawing/2014/main" id="{A8CC0B06-356C-489C-8189-E7C1D3FC2D73}"/>
+                <a16:creationId xmlns:a16="http://schemas.microsoft.com/office/drawing/2014/main" id="{AD1DA170-D4E5-4FB8-99E1-EE57BCC67AC9}"/>
               </a:ext>
             </a:extLst>
           </p:cNvPr>
@@ -9484,7 +9531,7 @@
           <p:cNvPr id="8" name="Section description 3">
             <a:extLst xmlns:a="http://schemas.openxmlformats.org/drawingml/2006/main">
               <a:ext uri="{FF2B5EF4-FFF2-40B4-BE49-F238E27FC236}">
-                <a16:creationId xmlns:a16="http://schemas.microsoft.com/office/drawing/2014/main" id="{9E9504B7-224B-45AD-B596-918FA86B75E4}"/>
+                <a16:creationId xmlns:a16="http://schemas.microsoft.com/office/drawing/2014/main" id="{B6135A08-EDD7-4B16-A24F-24B34F33DB60}"/>
               </a:ext>
             </a:extLst>
           </p:cNvPr>
@@ -9545,7 +9592,7 @@
           <p:nvPr/>
         </p:nvPicPr>
         <p:blipFill>
-          <a:blip xmlns:r="http://schemas.openxmlformats.org/officeDocument/2006/relationships" xmlns:a="http://schemas.openxmlformats.org/drawingml/2006/main" r:embed="R2f5d1cae7180410e"/>
+          <a:blip xmlns:r="http://schemas.openxmlformats.org/officeDocument/2006/relationships" xmlns:a="http://schemas.openxmlformats.org/drawingml/2006/main" r:embed="R73d39291516449d9"/>
           <a:stretch xmlns:a="http://schemas.openxmlformats.org/drawingml/2006/main"/>
         </p:blipFill>
         <p:spPr>
@@ -9567,7 +9614,7 @@
           <p:nvPr/>
         </p:nvPicPr>
         <p:blipFill>
-          <a:blip xmlns:r="http://schemas.openxmlformats.org/officeDocument/2006/relationships" xmlns:a="http://schemas.openxmlformats.org/drawingml/2006/main" r:embed="R18ee8b3d17a94ba6"/>
+          <a:blip xmlns:r="http://schemas.openxmlformats.org/officeDocument/2006/relationships" xmlns:a="http://schemas.openxmlformats.org/drawingml/2006/main" r:embed="Rb7c7c8b92cf3467a"/>
           <a:stretch xmlns:a="http://schemas.openxmlformats.org/drawingml/2006/main"/>
         </p:blipFill>
         <p:spPr>
@@ -9589,7 +9636,7 @@
           <p:nvPr/>
         </p:nvPicPr>
         <p:blipFill>
-          <a:blip xmlns:r="http://schemas.openxmlformats.org/officeDocument/2006/relationships" xmlns:a="http://schemas.openxmlformats.org/drawingml/2006/main" r:embed="R87af09e6a8e446dd"/>
+          <a:blip xmlns:r="http://schemas.openxmlformats.org/officeDocument/2006/relationships" xmlns:a="http://schemas.openxmlformats.org/drawingml/2006/main" r:embed="Rc5911d3e9fbf41b0"/>
           <a:stretch xmlns:a="http://schemas.openxmlformats.org/drawingml/2006/main"/>
         </p:blipFill>
         <p:spPr>
@@ -9607,7 +9654,7 @@
           <p:cNvPr id="12" name="Slide number">
             <a:extLst xmlns:a="http://schemas.openxmlformats.org/drawingml/2006/main">
               <a:ext uri="{FF2B5EF4-FFF2-40B4-BE49-F238E27FC236}">
-                <a16:creationId xmlns:a16="http://schemas.microsoft.com/office/drawing/2014/main" id="{55FA45C0-E9A3-479A-AA35-06C882AB7972}"/>
+                <a16:creationId xmlns:a16="http://schemas.microsoft.com/office/drawing/2014/main" id="{06A2A80E-9D24-423F-ADBA-DA3A939D1820}"/>
               </a:ext>
             </a:extLst>
           </p:cNvPr>
@@ -9662,7 +9709,7 @@
     </p:spTree>
     <p:extLst>
       <p:ext uri="{BB962C8B-B14F-4D97-AF65-F5344CB8AC3E}">
-        <p14:creationId xmlns:p14="http://schemas.microsoft.com/office/powerpoint/2010/main" val="1044250635"/>
+        <p14:creationId xmlns:p14="http://schemas.microsoft.com/office/powerpoint/2010/main" val="1163208728"/>
       </p:ext>
     </p:extLst>
   </p:cSld>
@@ -9693,7 +9740,7 @@
           <p:cNvPr id="11" name="Title">
             <a:extLst xmlns:a="http://schemas.openxmlformats.org/drawingml/2006/main">
               <a:ext uri="{FF2B5EF4-FFF2-40B4-BE49-F238E27FC236}">
-                <a16:creationId xmlns:a16="http://schemas.microsoft.com/office/drawing/2014/main" id="{155FDCA4-4C5A-4657-B5A1-F5724CB11178}"/>
+                <a16:creationId xmlns:a16="http://schemas.microsoft.com/office/drawing/2014/main" id="{6C2A2B30-43FB-409E-89B1-39995838CC5E}"/>
               </a:ext>
             </a:extLst>
           </p:cNvPr>
@@ -9750,7 +9797,7 @@
           <p:cNvPr id="2" name="text">
             <a:extLst xmlns:a="http://schemas.openxmlformats.org/drawingml/2006/main">
               <a:ext uri="{FF2B5EF4-FFF2-40B4-BE49-F238E27FC236}">
-                <a16:creationId xmlns:a16="http://schemas.microsoft.com/office/drawing/2014/main" id="{2F9816C9-E27C-4897-8760-0148C3EA2BD1}"/>
+                <a16:creationId xmlns:a16="http://schemas.microsoft.com/office/drawing/2014/main" id="{D86917A1-B020-4463-BCAC-EC41B3883873}"/>
               </a:ext>
             </a:extLst>
           </p:cNvPr>
@@ -9807,7 +9854,7 @@
           <p:cNvPr id="3" name="text">
             <a:extLst xmlns:a="http://schemas.openxmlformats.org/drawingml/2006/main">
               <a:ext uri="{FF2B5EF4-FFF2-40B4-BE49-F238E27FC236}">
-                <a16:creationId xmlns:a16="http://schemas.microsoft.com/office/drawing/2014/main" id="{E1B717F0-BCDD-46C4-B500-DE96772023BE}"/>
+                <a16:creationId xmlns:a16="http://schemas.microsoft.com/office/drawing/2014/main" id="{06F56D53-1853-4113-800F-0C01B6A5D591}"/>
               </a:ext>
             </a:extLst>
           </p:cNvPr>
@@ -9864,7 +9911,7 @@
           <p:cNvPr id="4" name="text">
             <a:extLst xmlns:a="http://schemas.openxmlformats.org/drawingml/2006/main">
               <a:ext uri="{FF2B5EF4-FFF2-40B4-BE49-F238E27FC236}">
-                <a16:creationId xmlns:a16="http://schemas.microsoft.com/office/drawing/2014/main" id="{E5DC8E5E-5D7B-4807-AD2C-2A0D55AE7D42}"/>
+                <a16:creationId xmlns:a16="http://schemas.microsoft.com/office/drawing/2014/main" id="{6A65289C-1E80-4FD4-9A1F-0969A4140710}"/>
               </a:ext>
             </a:extLst>
           </p:cNvPr>
@@ -9921,7 +9968,7 @@
           <p:cNvPr id="5" name="text">
             <a:extLst xmlns:a="http://schemas.openxmlformats.org/drawingml/2006/main">
               <a:ext uri="{FF2B5EF4-FFF2-40B4-BE49-F238E27FC236}">
-                <a16:creationId xmlns:a16="http://schemas.microsoft.com/office/drawing/2014/main" id="{C3333E7D-89E7-4498-908F-E8E7D2BD6DEA}"/>
+                <a16:creationId xmlns:a16="http://schemas.microsoft.com/office/drawing/2014/main" id="{51C8289C-5C41-42C5-84F3-58C380514DA6}"/>
               </a:ext>
             </a:extLst>
           </p:cNvPr>
@@ -9978,7 +10025,7 @@
           <p:cNvPr id="6" name="text">
             <a:extLst xmlns:a="http://schemas.openxmlformats.org/drawingml/2006/main">
               <a:ext uri="{FF2B5EF4-FFF2-40B4-BE49-F238E27FC236}">
-                <a16:creationId xmlns:a16="http://schemas.microsoft.com/office/drawing/2014/main" id="{6A4ACDD0-B4C4-475D-BEBB-2739BFF071F5}"/>
+                <a16:creationId xmlns:a16="http://schemas.microsoft.com/office/drawing/2014/main" id="{D8E639C1-31CC-439E-916E-017784F02DC9}"/>
               </a:ext>
             </a:extLst>
           </p:cNvPr>
@@ -10035,7 +10082,7 @@
           <p:cNvPr id="7" name="text">
             <a:extLst xmlns:a="http://schemas.openxmlformats.org/drawingml/2006/main">
               <a:ext uri="{FF2B5EF4-FFF2-40B4-BE49-F238E27FC236}">
-                <a16:creationId xmlns:a16="http://schemas.microsoft.com/office/drawing/2014/main" id="{EB718605-D2C7-4AE6-99E7-22A498E918FD}"/>
+                <a16:creationId xmlns:a16="http://schemas.microsoft.com/office/drawing/2014/main" id="{E0490DD6-403D-41BB-8265-F14959344567}"/>
               </a:ext>
             </a:extLst>
           </p:cNvPr>
@@ -10092,7 +10139,7 @@
           <p:cNvPr id="8" name="text">
             <a:extLst xmlns:a="http://schemas.openxmlformats.org/drawingml/2006/main">
               <a:ext uri="{FF2B5EF4-FFF2-40B4-BE49-F238E27FC236}">
-                <a16:creationId xmlns:a16="http://schemas.microsoft.com/office/drawing/2014/main" id="{BD74766D-4894-47AD-A879-14A50DE5220F}"/>
+                <a16:creationId xmlns:a16="http://schemas.microsoft.com/office/drawing/2014/main" id="{6B2D1144-DE3A-4111-B761-EC0124280CFD}"/>
               </a:ext>
             </a:extLst>
           </p:cNvPr>
@@ -10149,7 +10196,7 @@
           <p:cNvPr id="9" name="text">
             <a:extLst xmlns:a="http://schemas.openxmlformats.org/drawingml/2006/main">
               <a:ext uri="{FF2B5EF4-FFF2-40B4-BE49-F238E27FC236}">
-                <a16:creationId xmlns:a16="http://schemas.microsoft.com/office/drawing/2014/main" id="{0C1BA91F-C38B-47BD-817A-31B0DB287CEF}"/>
+                <a16:creationId xmlns:a16="http://schemas.microsoft.com/office/drawing/2014/main" id="{F3817302-9348-4A18-8DD5-6EB08E5DA725}"/>
               </a:ext>
             </a:extLst>
           </p:cNvPr>
@@ -10206,7 +10253,7 @@
           <p:cNvPr id="10" name="Slide number">
             <a:extLst xmlns:a="http://schemas.openxmlformats.org/drawingml/2006/main">
               <a:ext uri="{FF2B5EF4-FFF2-40B4-BE49-F238E27FC236}">
-                <a16:creationId xmlns:a16="http://schemas.microsoft.com/office/drawing/2014/main" id="{D744E8FC-CB82-4143-9294-73AD117DA3FE}"/>
+                <a16:creationId xmlns:a16="http://schemas.microsoft.com/office/drawing/2014/main" id="{F39A546D-C887-474C-B08C-026566123142}"/>
               </a:ext>
             </a:extLst>
           </p:cNvPr>
@@ -10261,7 +10308,7 @@
     </p:spTree>
     <p:extLst>
       <p:ext uri="{BB962C8B-B14F-4D97-AF65-F5344CB8AC3E}">
-        <p14:creationId xmlns:p14="http://schemas.microsoft.com/office/powerpoint/2010/main" val="59833826"/>
+        <p14:creationId xmlns:p14="http://schemas.microsoft.com/office/powerpoint/2010/main" val="1243855548"/>
       </p:ext>
     </p:extLst>
   </p:cSld>
@@ -10292,7 +10339,7 @@
           <p:cNvPr id="7" name="Title">
             <a:extLst xmlns:a="http://schemas.openxmlformats.org/drawingml/2006/main">
               <a:ext uri="{FF2B5EF4-FFF2-40B4-BE49-F238E27FC236}">
-                <a16:creationId xmlns:a16="http://schemas.microsoft.com/office/drawing/2014/main" id="{1B83F761-0CD9-4FB4-B9A1-9A1120D21089}"/>
+                <a16:creationId xmlns:a16="http://schemas.microsoft.com/office/drawing/2014/main" id="{30E401D1-6EEE-4869-8ACA-05E8E2FEFC3D}"/>
               </a:ext>
             </a:extLst>
           </p:cNvPr>
@@ -10356,7 +10403,7 @@
         </p:xfrm>
         <a:graphic xmlns:a="http://schemas.openxmlformats.org/drawingml/2006/main">
           <a:graphicData uri="http://schemas.openxmlformats.org/drawingml/2006/chart">
-            <c:chart xmlns:r="http://schemas.openxmlformats.org/officeDocument/2006/relationships" xmlns:c="http://schemas.openxmlformats.org/drawingml/2006/chart" r:id="R1a1943d269204166"/>
+            <c:chart xmlns:r="http://schemas.openxmlformats.org/officeDocument/2006/relationships" xmlns:c="http://schemas.openxmlformats.org/drawingml/2006/chart" r:id="R5cdc627162974a47"/>
           </a:graphicData>
         </a:graphic>
       </p:graphicFrame>
@@ -10365,7 +10412,7 @@
           <p:cNvPr id="3" name="April month marker">
             <a:extLst xmlns:a="http://schemas.openxmlformats.org/drawingml/2006/main">
               <a:ext uri="{FF2B5EF4-FFF2-40B4-BE49-F238E27FC236}">
-                <a16:creationId xmlns:a16="http://schemas.microsoft.com/office/drawing/2014/main" id="{6F0968EC-7CAE-46B1-AEB0-73535EE618F6}"/>
+                <a16:creationId xmlns:a16="http://schemas.microsoft.com/office/drawing/2014/main" id="{D0B5B0BE-8829-4A9D-9D24-7FBC6EFA4D92}"/>
               </a:ext>
             </a:extLst>
           </p:cNvPr>
@@ -10396,7 +10443,7 @@
           <p:cNvPr id="4" name="April joining context">
             <a:extLst xmlns:a="http://schemas.openxmlformats.org/drawingml/2006/main">
               <a:ext uri="{FF2B5EF4-FFF2-40B4-BE49-F238E27FC236}">
-                <a16:creationId xmlns:a16="http://schemas.microsoft.com/office/drawing/2014/main" id="{2D08E68D-6224-4A03-AEB5-AA3B456BA0D4}"/>
+                <a16:creationId xmlns:a16="http://schemas.microsoft.com/office/drawing/2014/main" id="{7B43F7F8-4521-4614-9B21-E03FEE56583D}"/>
               </a:ext>
             </a:extLst>
           </p:cNvPr>
@@ -10453,7 +10500,7 @@
           <p:cNvPr id="5" name="Methodology">
             <a:extLst xmlns:a="http://schemas.openxmlformats.org/drawingml/2006/main">
               <a:ext uri="{FF2B5EF4-FFF2-40B4-BE49-F238E27FC236}">
-                <a16:creationId xmlns:a16="http://schemas.microsoft.com/office/drawing/2014/main" id="{ACFF48CC-F62B-405A-819A-D39BCDA540C5}"/>
+                <a16:creationId xmlns:a16="http://schemas.microsoft.com/office/drawing/2014/main" id="{7A13090D-BAFA-45F9-A3F2-CD7B9DEC1B98}"/>
               </a:ext>
             </a:extLst>
           </p:cNvPr>
@@ -10510,7 +10557,7 @@
           <p:cNvPr id="6" name="Slide number">
             <a:extLst xmlns:a="http://schemas.openxmlformats.org/drawingml/2006/main">
               <a:ext uri="{FF2B5EF4-FFF2-40B4-BE49-F238E27FC236}">
-                <a16:creationId xmlns:a16="http://schemas.microsoft.com/office/drawing/2014/main" id="{61E2A626-26F8-42B2-B437-AD0503A810D1}"/>
+                <a16:creationId xmlns:a16="http://schemas.microsoft.com/office/drawing/2014/main" id="{F3F80FCB-8245-4A92-9497-903611044B5F}"/>
               </a:ext>
             </a:extLst>
           </p:cNvPr>
@@ -10565,7 +10612,7 @@
     </p:spTree>
     <p:extLst>
       <p:ext uri="{BB962C8B-B14F-4D97-AF65-F5344CB8AC3E}">
-        <p14:creationId xmlns:p14="http://schemas.microsoft.com/office/powerpoint/2010/main" val="480758593"/>
+        <p14:creationId xmlns:p14="http://schemas.microsoft.com/office/powerpoint/2010/main" val="2138104287"/>
       </p:ext>
     </p:extLst>
   </p:cSld>
@@ -10596,7 +10643,7 @@
           <p:cNvPr id="4" name="Title">
             <a:extLst xmlns:a="http://schemas.openxmlformats.org/drawingml/2006/main">
               <a:ext uri="{FF2B5EF4-FFF2-40B4-BE49-F238E27FC236}">
-                <a16:creationId xmlns:a16="http://schemas.microsoft.com/office/drawing/2014/main" id="{AF0924B5-8511-483A-9665-AF8219866635}"/>
+                <a16:creationId xmlns:a16="http://schemas.microsoft.com/office/drawing/2014/main" id="{88F7347F-2EBA-4ECA-9DF1-0DE97334CB10}"/>
               </a:ext>
             </a:extLst>
           </p:cNvPr>
@@ -10676,7 +10723,7 @@
           <p:cNvPr id="2" name="text">
             <a:extLst xmlns:a="http://schemas.openxmlformats.org/drawingml/2006/main">
               <a:ext uri="{FF2B5EF4-FFF2-40B4-BE49-F238E27FC236}">
-                <a16:creationId xmlns:a16="http://schemas.microsoft.com/office/drawing/2014/main" id="{41B93DDB-AE04-4BC2-8DA5-4773F7D61FC7}"/>
+                <a16:creationId xmlns:a16="http://schemas.microsoft.com/office/drawing/2014/main" id="{15130628-78C1-4CF3-BF88-5E38CF09D2DD}"/>
               </a:ext>
             </a:extLst>
           </p:cNvPr>
@@ -10733,7 +10780,7 @@
           <p:cNvPr id="3" name="Slide number">
             <a:extLst xmlns:a="http://schemas.openxmlformats.org/drawingml/2006/main">
               <a:ext uri="{FF2B5EF4-FFF2-40B4-BE49-F238E27FC236}">
-                <a16:creationId xmlns:a16="http://schemas.microsoft.com/office/drawing/2014/main" id="{73C1467C-75F0-43CD-AC4B-AA75B2160475}"/>
+                <a16:creationId xmlns:a16="http://schemas.microsoft.com/office/drawing/2014/main" id="{7E084FD0-45C3-490D-98E0-5025ABF44CEA}"/>
               </a:ext>
             </a:extLst>
           </p:cNvPr>
@@ -10788,7 +10835,7 @@
     </p:spTree>
     <p:extLst>
       <p:ext uri="{BB962C8B-B14F-4D97-AF65-F5344CB8AC3E}">
-        <p14:creationId xmlns:p14="http://schemas.microsoft.com/office/powerpoint/2010/main" val="221559347"/>
+        <p14:creationId xmlns:p14="http://schemas.microsoft.com/office/powerpoint/2010/main" val="1463111188"/>
       </p:ext>
     </p:extLst>
   </p:cSld>
@@ -10819,7 +10866,7 @@
           <p:cNvPr id="14" name="Completed section 0">
             <a:extLst xmlns:a="http://schemas.openxmlformats.org/drawingml/2006/main">
               <a:ext uri="{FF2B5EF4-FFF2-40B4-BE49-F238E27FC236}">
-                <a16:creationId xmlns:a16="http://schemas.microsoft.com/office/drawing/2014/main" id="{92D94D02-E7FC-410C-865E-F21618D8F47F}"/>
+                <a16:creationId xmlns:a16="http://schemas.microsoft.com/office/drawing/2014/main" id="{9785EBEA-8021-4E96-8AFD-AF5A85D8B244}"/>
               </a:ext>
             </a:extLst>
           </p:cNvPr>
@@ -10876,7 +10923,7 @@
           <p:cNvPr id="2" name="Section description 0">
             <a:extLst xmlns:a="http://schemas.openxmlformats.org/drawingml/2006/main">
               <a:ext uri="{FF2B5EF4-FFF2-40B4-BE49-F238E27FC236}">
-                <a16:creationId xmlns:a16="http://schemas.microsoft.com/office/drawing/2014/main" id="{D9553BC7-2FA4-41CC-8AC7-9C0581249ABD}"/>
+                <a16:creationId xmlns:a16="http://schemas.microsoft.com/office/drawing/2014/main" id="{11193B5B-CEAD-44A8-81AF-70CB3DEF9D08}"/>
               </a:ext>
             </a:extLst>
           </p:cNvPr>
@@ -10933,7 +10980,7 @@
           <p:cNvPr id="3" name="Completed section 1">
             <a:extLst xmlns:a="http://schemas.openxmlformats.org/drawingml/2006/main">
               <a:ext uri="{FF2B5EF4-FFF2-40B4-BE49-F238E27FC236}">
-                <a16:creationId xmlns:a16="http://schemas.microsoft.com/office/drawing/2014/main" id="{8F8D67DC-7B9D-487A-B792-DB74EF3513E3}"/>
+                <a16:creationId xmlns:a16="http://schemas.microsoft.com/office/drawing/2014/main" id="{091EAE3C-170E-4FAB-8B4A-81F47D3661E3}"/>
               </a:ext>
             </a:extLst>
           </p:cNvPr>
@@ -10990,7 +11037,7 @@
           <p:cNvPr id="4" name="Section description 1">
             <a:extLst xmlns:a="http://schemas.openxmlformats.org/drawingml/2006/main">
               <a:ext uri="{FF2B5EF4-FFF2-40B4-BE49-F238E27FC236}">
-                <a16:creationId xmlns:a16="http://schemas.microsoft.com/office/drawing/2014/main" id="{0893C860-54D7-420E-B945-4115C79A0000}"/>
+                <a16:creationId xmlns:a16="http://schemas.microsoft.com/office/drawing/2014/main" id="{B609FEBB-B075-49CD-A901-0B5169957EBF}"/>
               </a:ext>
             </a:extLst>
           </p:cNvPr>
@@ -11047,7 +11094,7 @@
           <p:cNvPr id="5" name="Completed section 2">
             <a:extLst xmlns:a="http://schemas.openxmlformats.org/drawingml/2006/main">
               <a:ext uri="{FF2B5EF4-FFF2-40B4-BE49-F238E27FC236}">
-                <a16:creationId xmlns:a16="http://schemas.microsoft.com/office/drawing/2014/main" id="{7362C6A5-393C-48C3-BB4A-D9D126044EB4}"/>
+                <a16:creationId xmlns:a16="http://schemas.microsoft.com/office/drawing/2014/main" id="{49B1341A-AADB-4842-9666-C2518F85DCB0}"/>
               </a:ext>
             </a:extLst>
           </p:cNvPr>
@@ -11104,7 +11151,7 @@
           <p:cNvPr id="6" name="Section description 2">
             <a:extLst xmlns:a="http://schemas.openxmlformats.org/drawingml/2006/main">
               <a:ext uri="{FF2B5EF4-FFF2-40B4-BE49-F238E27FC236}">
-                <a16:creationId xmlns:a16="http://schemas.microsoft.com/office/drawing/2014/main" id="{FAE6E8DA-9DE9-4859-A7EE-7A8C95C2AB39}"/>
+                <a16:creationId xmlns:a16="http://schemas.microsoft.com/office/drawing/2014/main" id="{C222798C-0D66-46E5-B144-F24F2F053352}"/>
               </a:ext>
             </a:extLst>
           </p:cNvPr>
@@ -11161,7 +11208,7 @@
           <p:cNvPr id="7" name="Completed section 3">
             <a:extLst xmlns:a="http://schemas.openxmlformats.org/drawingml/2006/main">
               <a:ext uri="{FF2B5EF4-FFF2-40B4-BE49-F238E27FC236}">
-                <a16:creationId xmlns:a16="http://schemas.microsoft.com/office/drawing/2014/main" id="{11332654-A028-4946-ABEA-39B9E6834073}"/>
+                <a16:creationId xmlns:a16="http://schemas.microsoft.com/office/drawing/2014/main" id="{51CC05A4-042E-4A7A-BF48-9032D15FD3E3}"/>
               </a:ext>
             </a:extLst>
           </p:cNvPr>
@@ -11218,7 +11265,7 @@
           <p:cNvPr id="8" name="Section description 3">
             <a:extLst xmlns:a="http://schemas.openxmlformats.org/drawingml/2006/main">
               <a:ext uri="{FF2B5EF4-FFF2-40B4-BE49-F238E27FC236}">
-                <a16:creationId xmlns:a16="http://schemas.microsoft.com/office/drawing/2014/main" id="{C9E4E28B-D81A-4087-B7C8-AA3F9E046AFF}"/>
+                <a16:creationId xmlns:a16="http://schemas.microsoft.com/office/drawing/2014/main" id="{F863FD43-4FAE-4610-860E-F2FEB2AD63C4}"/>
               </a:ext>
             </a:extLst>
           </p:cNvPr>
@@ -11275,7 +11322,7 @@
           <p:cNvPr id="9" name="Title">
             <a:extLst xmlns:a="http://schemas.openxmlformats.org/drawingml/2006/main">
               <a:ext uri="{FF2B5EF4-FFF2-40B4-BE49-F238E27FC236}">
-                <a16:creationId xmlns:a16="http://schemas.microsoft.com/office/drawing/2014/main" id="{097AEE85-E9DD-4BA9-B244-A0B41EB62989}"/>
+                <a16:creationId xmlns:a16="http://schemas.microsoft.com/office/drawing/2014/main" id="{F6344781-06CC-4E42-810D-D46BCF9C8C09}"/>
               </a:ext>
             </a:extLst>
           </p:cNvPr>
@@ -11332,7 +11379,7 @@
           <p:cNvPr id="10" name="Section description 4">
             <a:extLst xmlns:a="http://schemas.openxmlformats.org/drawingml/2006/main">
               <a:ext uri="{FF2B5EF4-FFF2-40B4-BE49-F238E27FC236}">
-                <a16:creationId xmlns:a16="http://schemas.microsoft.com/office/drawing/2014/main" id="{C7124E91-3587-4A69-B8EB-CD877DC8D10F}"/>
+                <a16:creationId xmlns:a16="http://schemas.microsoft.com/office/drawing/2014/main" id="{8E708DEE-5555-457F-B65D-A44064203CC6}"/>
               </a:ext>
             </a:extLst>
           </p:cNvPr>
@@ -11393,7 +11440,7 @@
           <p:nvPr/>
         </p:nvPicPr>
         <p:blipFill>
-          <a:blip xmlns:r="http://schemas.openxmlformats.org/officeDocument/2006/relationships" xmlns:a="http://schemas.openxmlformats.org/drawingml/2006/main" r:embed="Rb5eb08eb54ca46cf"/>
+          <a:blip xmlns:r="http://schemas.openxmlformats.org/officeDocument/2006/relationships" xmlns:a="http://schemas.openxmlformats.org/drawingml/2006/main" r:embed="Rec29b75b2d974eef"/>
           <a:stretch xmlns:a="http://schemas.openxmlformats.org/drawingml/2006/main"/>
         </p:blipFill>
         <p:spPr>
@@ -11415,7 +11462,7 @@
           <p:nvPr/>
         </p:nvPicPr>
         <p:blipFill>
-          <a:blip xmlns:r="http://schemas.openxmlformats.org/officeDocument/2006/relationships" xmlns:a="http://schemas.openxmlformats.org/drawingml/2006/main" r:embed="Ra56056f43a7245c1"/>
+          <a:blip xmlns:r="http://schemas.openxmlformats.org/officeDocument/2006/relationships" xmlns:a="http://schemas.openxmlformats.org/drawingml/2006/main" r:embed="R8e6610ddb0774a33"/>
           <a:stretch xmlns:a="http://schemas.openxmlformats.org/drawingml/2006/main"/>
         </p:blipFill>
         <p:spPr>
@@ -11433,7 +11480,7 @@
           <p:cNvPr id="13" name="Slide number">
             <a:extLst xmlns:a="http://schemas.openxmlformats.org/drawingml/2006/main">
               <a:ext uri="{FF2B5EF4-FFF2-40B4-BE49-F238E27FC236}">
-                <a16:creationId xmlns:a16="http://schemas.microsoft.com/office/drawing/2014/main" id="{7ACF2DEA-39C3-40E9-BE39-F7768FD3E4F8}"/>
+                <a16:creationId xmlns:a16="http://schemas.microsoft.com/office/drawing/2014/main" id="{EC00A7AD-F6C5-4F5D-A83B-45B448B91EC8}"/>
               </a:ext>
             </a:extLst>
           </p:cNvPr>
@@ -11488,7 +11535,7 @@
     </p:spTree>
     <p:extLst>
       <p:ext uri="{BB962C8B-B14F-4D97-AF65-F5344CB8AC3E}">
-        <p14:creationId xmlns:p14="http://schemas.microsoft.com/office/powerpoint/2010/main" val="1591182211"/>
+        <p14:creationId xmlns:p14="http://schemas.microsoft.com/office/powerpoint/2010/main" val="2062655390"/>
       </p:ext>
     </p:extLst>
   </p:cSld>
@@ -11519,7 +11566,7 @@
           <p:cNvPr id="10" name="Title">
             <a:extLst xmlns:a="http://schemas.openxmlformats.org/drawingml/2006/main">
               <a:ext uri="{FF2B5EF4-FFF2-40B4-BE49-F238E27FC236}">
-                <a16:creationId xmlns:a16="http://schemas.microsoft.com/office/drawing/2014/main" id="{0A7EE101-4C9F-4795-8C24-E9E3F23DE08D}"/>
+                <a16:creationId xmlns:a16="http://schemas.microsoft.com/office/drawing/2014/main" id="{6844E19E-4116-4A19-9492-4616012FA4A8}"/>
               </a:ext>
             </a:extLst>
           </p:cNvPr>
@@ -11576,7 +11623,7 @@
           <p:cNvPr id="2" name="text">
             <a:extLst xmlns:a="http://schemas.openxmlformats.org/drawingml/2006/main">
               <a:ext uri="{FF2B5EF4-FFF2-40B4-BE49-F238E27FC236}">
-                <a16:creationId xmlns:a16="http://schemas.microsoft.com/office/drawing/2014/main" id="{CE465DFE-591B-43E1-955B-8B85171AC55C}"/>
+                <a16:creationId xmlns:a16="http://schemas.microsoft.com/office/drawing/2014/main" id="{C017E8E7-5E8F-4192-A1C1-2A7AD4401428}"/>
               </a:ext>
             </a:extLst>
           </p:cNvPr>
@@ -11633,7 +11680,7 @@
           <p:cNvPr id="3" name="text">
             <a:extLst xmlns:a="http://schemas.openxmlformats.org/drawingml/2006/main">
               <a:ext uri="{FF2B5EF4-FFF2-40B4-BE49-F238E27FC236}">
-                <a16:creationId xmlns:a16="http://schemas.microsoft.com/office/drawing/2014/main" id="{019118EB-50E4-4F71-8266-95A86F9FC088}"/>
+                <a16:creationId xmlns:a16="http://schemas.microsoft.com/office/drawing/2014/main" id="{D71CFBB7-D9B5-4CA6-A6AF-33F9355D97CE}"/>
               </a:ext>
             </a:extLst>
           </p:cNvPr>
@@ -11690,7 +11737,7 @@
           <p:cNvPr id="4" name="text">
             <a:extLst xmlns:a="http://schemas.openxmlformats.org/drawingml/2006/main">
               <a:ext uri="{FF2B5EF4-FFF2-40B4-BE49-F238E27FC236}">
-                <a16:creationId xmlns:a16="http://schemas.microsoft.com/office/drawing/2014/main" id="{F63352D9-2767-465D-B719-71AB6CF06133}"/>
+                <a16:creationId xmlns:a16="http://schemas.microsoft.com/office/drawing/2014/main" id="{037EB504-3DF5-4B59-BE7D-ACADC55D4344}"/>
               </a:ext>
             </a:extLst>
           </p:cNvPr>
@@ -11747,7 +11794,7 @@
           <p:cNvPr id="5" name="text">
             <a:extLst xmlns:a="http://schemas.openxmlformats.org/drawingml/2006/main">
               <a:ext uri="{FF2B5EF4-FFF2-40B4-BE49-F238E27FC236}">
-                <a16:creationId xmlns:a16="http://schemas.microsoft.com/office/drawing/2014/main" id="{ABFBAC59-26D1-4D3E-A7CC-91E358776F1D}"/>
+                <a16:creationId xmlns:a16="http://schemas.microsoft.com/office/drawing/2014/main" id="{2DAB457E-1FD0-46C9-86E4-555903DA7935}"/>
               </a:ext>
             </a:extLst>
           </p:cNvPr>
@@ -11804,7 +11851,7 @@
           <p:cNvPr id="6" name="text">
             <a:extLst xmlns:a="http://schemas.openxmlformats.org/drawingml/2006/main">
               <a:ext uri="{FF2B5EF4-FFF2-40B4-BE49-F238E27FC236}">
-                <a16:creationId xmlns:a16="http://schemas.microsoft.com/office/drawing/2014/main" id="{0C84E6FB-25C1-4D18-AF36-AE96C35F6317}"/>
+                <a16:creationId xmlns:a16="http://schemas.microsoft.com/office/drawing/2014/main" id="{DB88C600-7186-4E3A-9CEA-E8980C564B63}"/>
               </a:ext>
             </a:extLst>
           </p:cNvPr>
@@ -11861,7 +11908,7 @@
           <p:cNvPr id="7" name="text">
             <a:extLst xmlns:a="http://schemas.openxmlformats.org/drawingml/2006/main">
               <a:ext uri="{FF2B5EF4-FFF2-40B4-BE49-F238E27FC236}">
-                <a16:creationId xmlns:a16="http://schemas.microsoft.com/office/drawing/2014/main" id="{BF6C4F01-ADB9-4C90-8343-D720A56FDAA0}"/>
+                <a16:creationId xmlns:a16="http://schemas.microsoft.com/office/drawing/2014/main" id="{E35D87D6-7D5B-443B-AB2A-FCFC4C61A6C0}"/>
               </a:ext>
             </a:extLst>
           </p:cNvPr>
@@ -11918,7 +11965,7 @@
           <p:cNvPr id="8" name="text">
             <a:extLst xmlns:a="http://schemas.openxmlformats.org/drawingml/2006/main">
               <a:ext uri="{FF2B5EF4-FFF2-40B4-BE49-F238E27FC236}">
-                <a16:creationId xmlns:a16="http://schemas.microsoft.com/office/drawing/2014/main" id="{07B07DFD-3164-43BC-968C-5A57E88F703D}"/>
+                <a16:creationId xmlns:a16="http://schemas.microsoft.com/office/drawing/2014/main" id="{A61966DB-93A8-47A9-A5E3-9BF0746AE98C}"/>
               </a:ext>
             </a:extLst>
           </p:cNvPr>
@@ -11975,7 +12022,7 @@
           <p:cNvPr id="9" name="Slide number">
             <a:extLst xmlns:a="http://schemas.openxmlformats.org/drawingml/2006/main">
               <a:ext uri="{FF2B5EF4-FFF2-40B4-BE49-F238E27FC236}">
-                <a16:creationId xmlns:a16="http://schemas.microsoft.com/office/drawing/2014/main" id="{DDE40C4B-069C-4945-B431-02DB0A2E8D06}"/>
+                <a16:creationId xmlns:a16="http://schemas.microsoft.com/office/drawing/2014/main" id="{28BD9855-9C25-4139-93B9-DD107FD311AF}"/>
               </a:ext>
             </a:extLst>
           </p:cNvPr>
@@ -12030,7 +12077,7 @@
     </p:spTree>
     <p:extLst>
       <p:ext uri="{BB962C8B-B14F-4D97-AF65-F5344CB8AC3E}">
-        <p14:creationId xmlns:p14="http://schemas.microsoft.com/office/powerpoint/2010/main" val="628396237"/>
+        <p14:creationId xmlns:p14="http://schemas.microsoft.com/office/powerpoint/2010/main" val="1233841559"/>
       </p:ext>
     </p:extLst>
   </p:cSld>
@@ -12061,7 +12108,7 @@
           <p:cNvPr id="10" name="Title">
             <a:extLst xmlns:a="http://schemas.openxmlformats.org/drawingml/2006/main">
               <a:ext uri="{FF2B5EF4-FFF2-40B4-BE49-F238E27FC236}">
-                <a16:creationId xmlns:a16="http://schemas.microsoft.com/office/drawing/2014/main" id="{48F70E94-39B8-48E0-AB54-120D0C16D992}"/>
+                <a16:creationId xmlns:a16="http://schemas.microsoft.com/office/drawing/2014/main" id="{9D660A9A-57C9-421C-9E81-E3F87E9BA26A}"/>
               </a:ext>
             </a:extLst>
           </p:cNvPr>
@@ -12118,7 +12165,7 @@
           <p:cNvPr id="2" name="text">
             <a:extLst xmlns:a="http://schemas.openxmlformats.org/drawingml/2006/main">
               <a:ext uri="{FF2B5EF4-FFF2-40B4-BE49-F238E27FC236}">
-                <a16:creationId xmlns:a16="http://schemas.microsoft.com/office/drawing/2014/main" id="{11D7C23F-695C-4192-BF2D-D6D62C74EF0C}"/>
+                <a16:creationId xmlns:a16="http://schemas.microsoft.com/office/drawing/2014/main" id="{E43E33E0-D6A3-43FB-A324-D68B281296F8}"/>
               </a:ext>
             </a:extLst>
           </p:cNvPr>
@@ -12175,7 +12222,7 @@
           <p:cNvPr id="3" name="text">
             <a:extLst xmlns:a="http://schemas.openxmlformats.org/drawingml/2006/main">
               <a:ext uri="{FF2B5EF4-FFF2-40B4-BE49-F238E27FC236}">
-                <a16:creationId xmlns:a16="http://schemas.microsoft.com/office/drawing/2014/main" id="{79D15681-D72F-47B3-9455-6C17CDD633D5}"/>
+                <a16:creationId xmlns:a16="http://schemas.microsoft.com/office/drawing/2014/main" id="{569549E0-E45B-452E-A711-F299762571F9}"/>
               </a:ext>
             </a:extLst>
           </p:cNvPr>
@@ -12232,7 +12279,7 @@
           <p:cNvPr id="4" name="text">
             <a:extLst xmlns:a="http://schemas.openxmlformats.org/drawingml/2006/main">
               <a:ext uri="{FF2B5EF4-FFF2-40B4-BE49-F238E27FC236}">
-                <a16:creationId xmlns:a16="http://schemas.microsoft.com/office/drawing/2014/main" id="{BF56510D-2366-4BCB-AC58-8C5E0FEEF56D}"/>
+                <a16:creationId xmlns:a16="http://schemas.microsoft.com/office/drawing/2014/main" id="{ED2E8868-5372-4197-B5B8-44355D7BBD9D}"/>
               </a:ext>
             </a:extLst>
           </p:cNvPr>
@@ -12289,7 +12336,7 @@
           <p:cNvPr id="5" name="text">
             <a:extLst xmlns:a="http://schemas.openxmlformats.org/drawingml/2006/main">
               <a:ext uri="{FF2B5EF4-FFF2-40B4-BE49-F238E27FC236}">
-                <a16:creationId xmlns:a16="http://schemas.microsoft.com/office/drawing/2014/main" id="{069FC0C3-FC4A-49BA-8654-A5E14A56B697}"/>
+                <a16:creationId xmlns:a16="http://schemas.microsoft.com/office/drawing/2014/main" id="{D7DB71B2-670B-45B2-9355-D804CDB3FF37}"/>
               </a:ext>
             </a:extLst>
           </p:cNvPr>
@@ -12346,7 +12393,7 @@
           <p:cNvPr id="6" name="text">
             <a:extLst xmlns:a="http://schemas.openxmlformats.org/drawingml/2006/main">
               <a:ext uri="{FF2B5EF4-FFF2-40B4-BE49-F238E27FC236}">
-                <a16:creationId xmlns:a16="http://schemas.microsoft.com/office/drawing/2014/main" id="{EBC27C82-B09D-4EDC-AB30-97DC4573A597}"/>
+                <a16:creationId xmlns:a16="http://schemas.microsoft.com/office/drawing/2014/main" id="{C97EEAD8-119F-4A22-88F1-2877D2870BB5}"/>
               </a:ext>
             </a:extLst>
           </p:cNvPr>
@@ -12403,7 +12450,7 @@
           <p:cNvPr id="7" name="text">
             <a:extLst xmlns:a="http://schemas.openxmlformats.org/drawingml/2006/main">
               <a:ext uri="{FF2B5EF4-FFF2-40B4-BE49-F238E27FC236}">
-                <a16:creationId xmlns:a16="http://schemas.microsoft.com/office/drawing/2014/main" id="{5F773D4D-1FE8-4461-B5FB-E968D746B2B1}"/>
+                <a16:creationId xmlns:a16="http://schemas.microsoft.com/office/drawing/2014/main" id="{4785CEDA-8220-4672-BBFC-0566B8490D88}"/>
               </a:ext>
             </a:extLst>
           </p:cNvPr>
@@ -12460,7 +12507,7 @@
           <p:cNvPr id="8" name="text">
             <a:extLst xmlns:a="http://schemas.openxmlformats.org/drawingml/2006/main">
               <a:ext uri="{FF2B5EF4-FFF2-40B4-BE49-F238E27FC236}">
-                <a16:creationId xmlns:a16="http://schemas.microsoft.com/office/drawing/2014/main" id="{5C0C9D4A-DCF0-4A3A-B12C-FD674210D84B}"/>
+                <a16:creationId xmlns:a16="http://schemas.microsoft.com/office/drawing/2014/main" id="{BB590B5B-7149-4F56-A4B8-A11772BF29DC}"/>
               </a:ext>
             </a:extLst>
           </p:cNvPr>
@@ -12517,7 +12564,7 @@
           <p:cNvPr id="9" name="Slide number">
             <a:extLst xmlns:a="http://schemas.openxmlformats.org/drawingml/2006/main">
               <a:ext uri="{FF2B5EF4-FFF2-40B4-BE49-F238E27FC236}">
-                <a16:creationId xmlns:a16="http://schemas.microsoft.com/office/drawing/2014/main" id="{4664BB56-BAA8-45ED-9D0F-80477C84A6B3}"/>
+                <a16:creationId xmlns:a16="http://schemas.microsoft.com/office/drawing/2014/main" id="{D8C87F73-1978-4DD0-BC26-87D3D7DC17B1}"/>
               </a:ext>
             </a:extLst>
           </p:cNvPr>
@@ -12572,7 +12619,7 @@
     </p:spTree>
     <p:extLst>
       <p:ext uri="{BB962C8B-B14F-4D97-AF65-F5344CB8AC3E}">
-        <p14:creationId xmlns:p14="http://schemas.microsoft.com/office/powerpoint/2010/main" val="1377221202"/>
+        <p14:creationId xmlns:p14="http://schemas.microsoft.com/office/powerpoint/2010/main" val="140768118"/>
       </p:ext>
     </p:extLst>
   </p:cSld>
@@ -12603,7 +12650,7 @@
           <p:cNvPr id="15" name="Completed section 0">
             <a:extLst xmlns:a="http://schemas.openxmlformats.org/drawingml/2006/main">
               <a:ext uri="{FF2B5EF4-FFF2-40B4-BE49-F238E27FC236}">
-                <a16:creationId xmlns:a16="http://schemas.microsoft.com/office/drawing/2014/main" id="{D9CB9B4A-7E58-428C-B35B-33A705D85384}"/>
+                <a16:creationId xmlns:a16="http://schemas.microsoft.com/office/drawing/2014/main" id="{96CAC356-B74A-4CB7-B78E-4E505481C89B}"/>
               </a:ext>
             </a:extLst>
           </p:cNvPr>
@@ -12660,7 +12707,7 @@
           <p:cNvPr id="2" name="Section description 0">
             <a:extLst xmlns:a="http://schemas.openxmlformats.org/drawingml/2006/main">
               <a:ext uri="{FF2B5EF4-FFF2-40B4-BE49-F238E27FC236}">
-                <a16:creationId xmlns:a16="http://schemas.microsoft.com/office/drawing/2014/main" id="{22CA7A14-D753-4E6B-A0A5-B924196C8EC9}"/>
+                <a16:creationId xmlns:a16="http://schemas.microsoft.com/office/drawing/2014/main" id="{E15A6D3C-770A-42F0-961B-1D8D686A66A5}"/>
               </a:ext>
             </a:extLst>
           </p:cNvPr>
@@ -12717,7 +12764,7 @@
           <p:cNvPr id="3" name="Completed section 1">
             <a:extLst xmlns:a="http://schemas.openxmlformats.org/drawingml/2006/main">
               <a:ext uri="{FF2B5EF4-FFF2-40B4-BE49-F238E27FC236}">
-                <a16:creationId xmlns:a16="http://schemas.microsoft.com/office/drawing/2014/main" id="{2B7D5FA3-BD78-4384-8874-9324264923C6}"/>
+                <a16:creationId xmlns:a16="http://schemas.microsoft.com/office/drawing/2014/main" id="{7E0DE1CD-4F09-4E41-A613-44294EF996D3}"/>
               </a:ext>
             </a:extLst>
           </p:cNvPr>
@@ -12774,7 +12821,7 @@
           <p:cNvPr id="4" name="Section description 1">
             <a:extLst xmlns:a="http://schemas.openxmlformats.org/drawingml/2006/main">
               <a:ext uri="{FF2B5EF4-FFF2-40B4-BE49-F238E27FC236}">
-                <a16:creationId xmlns:a16="http://schemas.microsoft.com/office/drawing/2014/main" id="{EB72FACC-F8AD-43FB-B872-A8F87673A1D0}"/>
+                <a16:creationId xmlns:a16="http://schemas.microsoft.com/office/drawing/2014/main" id="{50C50ACF-3CCA-4361-B40B-09655977272D}"/>
               </a:ext>
             </a:extLst>
           </p:cNvPr>
@@ -12831,7 +12878,7 @@
           <p:cNvPr id="5" name="Completed section 2">
             <a:extLst xmlns:a="http://schemas.openxmlformats.org/drawingml/2006/main">
               <a:ext uri="{FF2B5EF4-FFF2-40B4-BE49-F238E27FC236}">
-                <a16:creationId xmlns:a16="http://schemas.microsoft.com/office/drawing/2014/main" id="{E7E7AC81-DE07-4846-99F7-ED94128C994C}"/>
+                <a16:creationId xmlns:a16="http://schemas.microsoft.com/office/drawing/2014/main" id="{979C00C0-0D5A-4F33-B638-7A2BC02D7D66}"/>
               </a:ext>
             </a:extLst>
           </p:cNvPr>
@@ -12888,7 +12935,7 @@
           <p:cNvPr id="6" name="Section description 2">
             <a:extLst xmlns:a="http://schemas.openxmlformats.org/drawingml/2006/main">
               <a:ext uri="{FF2B5EF4-FFF2-40B4-BE49-F238E27FC236}">
-                <a16:creationId xmlns:a16="http://schemas.microsoft.com/office/drawing/2014/main" id="{6BC369A6-FF89-4A46-A7F5-D86212E7AFC5}"/>
+                <a16:creationId xmlns:a16="http://schemas.microsoft.com/office/drawing/2014/main" id="{DF8C1EA8-C820-4F54-B4ED-746F752ABE2D}"/>
               </a:ext>
             </a:extLst>
           </p:cNvPr>
@@ -12945,7 +12992,7 @@
           <p:cNvPr id="7" name="Completed section 3">
             <a:extLst xmlns:a="http://schemas.openxmlformats.org/drawingml/2006/main">
               <a:ext uri="{FF2B5EF4-FFF2-40B4-BE49-F238E27FC236}">
-                <a16:creationId xmlns:a16="http://schemas.microsoft.com/office/drawing/2014/main" id="{87AA2B8D-053A-435B-AC25-A2F050BBCC6C}"/>
+                <a16:creationId xmlns:a16="http://schemas.microsoft.com/office/drawing/2014/main" id="{67557EAE-F8F3-4BD0-903F-34F600C61D48}"/>
               </a:ext>
             </a:extLst>
           </p:cNvPr>
@@ -13002,7 +13049,7 @@
           <p:cNvPr id="8" name="Section description 3">
             <a:extLst xmlns:a="http://schemas.openxmlformats.org/drawingml/2006/main">
               <a:ext uri="{FF2B5EF4-FFF2-40B4-BE49-F238E27FC236}">
-                <a16:creationId xmlns:a16="http://schemas.microsoft.com/office/drawing/2014/main" id="{61A4E7B9-78CB-4702-981B-5116CAC0BAAE}"/>
+                <a16:creationId xmlns:a16="http://schemas.microsoft.com/office/drawing/2014/main" id="{34E48395-ADAE-4922-BDD5-9690765D502B}"/>
               </a:ext>
             </a:extLst>
           </p:cNvPr>
@@ -13059,7 +13106,7 @@
           <p:cNvPr id="9" name="Completed section 4">
             <a:extLst xmlns:a="http://schemas.openxmlformats.org/drawingml/2006/main">
               <a:ext uri="{FF2B5EF4-FFF2-40B4-BE49-F238E27FC236}">
-                <a16:creationId xmlns:a16="http://schemas.microsoft.com/office/drawing/2014/main" id="{74E481D1-C901-4363-A538-F82F73129DF7}"/>
+                <a16:creationId xmlns:a16="http://schemas.microsoft.com/office/drawing/2014/main" id="{1234EF02-4B0C-4AEE-B169-0C8D6FFDE71B}"/>
               </a:ext>
             </a:extLst>
           </p:cNvPr>
@@ -13116,7 +13163,7 @@
           <p:cNvPr id="10" name="Section description 4">
             <a:extLst xmlns:a="http://schemas.openxmlformats.org/drawingml/2006/main">
               <a:ext uri="{FF2B5EF4-FFF2-40B4-BE49-F238E27FC236}">
-                <a16:creationId xmlns:a16="http://schemas.microsoft.com/office/drawing/2014/main" id="{9C4248F3-2204-497A-8DFA-6CEFFB9CB04B}"/>
+                <a16:creationId xmlns:a16="http://schemas.microsoft.com/office/drawing/2014/main" id="{9AC411AA-1108-4E86-A8F4-B26CC2F065AB}"/>
               </a:ext>
             </a:extLst>
           </p:cNvPr>
@@ -13173,7 +13220,7 @@
           <p:cNvPr id="11" name="Title">
             <a:extLst xmlns:a="http://schemas.openxmlformats.org/drawingml/2006/main">
               <a:ext uri="{FF2B5EF4-FFF2-40B4-BE49-F238E27FC236}">
-                <a16:creationId xmlns:a16="http://schemas.microsoft.com/office/drawing/2014/main" id="{ACB3BA86-F290-440B-8098-0307D1AB5719}"/>
+                <a16:creationId xmlns:a16="http://schemas.microsoft.com/office/drawing/2014/main" id="{5D23B9FF-62CB-4512-8CD7-5D01E6020ADF}"/>
               </a:ext>
             </a:extLst>
           </p:cNvPr>
@@ -13230,7 +13277,7 @@
           <p:cNvPr id="12" name="Section description 5">
             <a:extLst xmlns:a="http://schemas.openxmlformats.org/drawingml/2006/main">
               <a:ext uri="{FF2B5EF4-FFF2-40B4-BE49-F238E27FC236}">
-                <a16:creationId xmlns:a16="http://schemas.microsoft.com/office/drawing/2014/main" id="{C9D9F7C4-5C01-41CA-B6C9-5A9D3C643C68}"/>
+                <a16:creationId xmlns:a16="http://schemas.microsoft.com/office/drawing/2014/main" id="{6474714B-21CE-4FE8-BBEF-3A406A2C3493}"/>
               </a:ext>
             </a:extLst>
           </p:cNvPr>
@@ -13291,7 +13338,7 @@
           <p:nvPr/>
         </p:nvPicPr>
         <p:blipFill>
-          <a:blip xmlns:r="http://schemas.openxmlformats.org/officeDocument/2006/relationships" xmlns:a="http://schemas.openxmlformats.org/drawingml/2006/main" r:embed="Ra8323269de254441"/>
+          <a:blip xmlns:r="http://schemas.openxmlformats.org/officeDocument/2006/relationships" xmlns:a="http://schemas.openxmlformats.org/drawingml/2006/main" r:embed="Rdecf9eb2b8d6498e"/>
           <a:stretch xmlns:a="http://schemas.openxmlformats.org/drawingml/2006/main"/>
         </p:blipFill>
         <p:spPr>
@@ -13309,7 +13356,7 @@
           <p:cNvPr id="14" name="Slide number">
             <a:extLst xmlns:a="http://schemas.openxmlformats.org/drawingml/2006/main">
               <a:ext uri="{FF2B5EF4-FFF2-40B4-BE49-F238E27FC236}">
-                <a16:creationId xmlns:a16="http://schemas.microsoft.com/office/drawing/2014/main" id="{8CE0CA5B-8751-4205-9AA1-814C354BAAF7}"/>
+                <a16:creationId xmlns:a16="http://schemas.microsoft.com/office/drawing/2014/main" id="{F492130C-241F-49FC-B133-2898B0DCF16B}"/>
               </a:ext>
             </a:extLst>
           </p:cNvPr>
@@ -13364,7 +13411,7 @@
     </p:spTree>
     <p:extLst>
       <p:ext uri="{BB962C8B-B14F-4D97-AF65-F5344CB8AC3E}">
-        <p14:creationId xmlns:p14="http://schemas.microsoft.com/office/powerpoint/2010/main" val="549938607"/>
+        <p14:creationId xmlns:p14="http://schemas.microsoft.com/office/powerpoint/2010/main" val="487780281"/>
       </p:ext>
     </p:extLst>
   </p:cSld>
@@ -13395,7 +13442,7 @@
           <p:cNvPr id="14" name="Title">
             <a:extLst xmlns:a="http://schemas.openxmlformats.org/drawingml/2006/main">
               <a:ext uri="{FF2B5EF4-FFF2-40B4-BE49-F238E27FC236}">
-                <a16:creationId xmlns:a16="http://schemas.microsoft.com/office/drawing/2014/main" id="{3E7231CA-D219-473C-8EB5-3DC335322345}"/>
+                <a16:creationId xmlns:a16="http://schemas.microsoft.com/office/drawing/2014/main" id="{F15B326C-CF7B-47E5-8B9A-4FFA32A09EC8}"/>
               </a:ext>
             </a:extLst>
           </p:cNvPr>
@@ -13452,7 +13499,7 @@
           <p:cNvPr id="2" name="text">
             <a:extLst xmlns:a="http://schemas.openxmlformats.org/drawingml/2006/main">
               <a:ext uri="{FF2B5EF4-FFF2-40B4-BE49-F238E27FC236}">
-                <a16:creationId xmlns:a16="http://schemas.microsoft.com/office/drawing/2014/main" id="{3DF4BE2C-01DE-4E0E-9098-7058B9855270}"/>
+                <a16:creationId xmlns:a16="http://schemas.microsoft.com/office/drawing/2014/main" id="{B78EC291-B42E-474B-A104-2F4CA45A99EC}"/>
               </a:ext>
             </a:extLst>
           </p:cNvPr>
@@ -13509,7 +13556,7 @@
           <p:cNvPr id="3" name="text">
             <a:extLst xmlns:a="http://schemas.openxmlformats.org/drawingml/2006/main">
               <a:ext uri="{FF2B5EF4-FFF2-40B4-BE49-F238E27FC236}">
-                <a16:creationId xmlns:a16="http://schemas.microsoft.com/office/drawing/2014/main" id="{ACB6C70A-95B6-4CC0-8431-4DDC0966795C}"/>
+                <a16:creationId xmlns:a16="http://schemas.microsoft.com/office/drawing/2014/main" id="{E78A62A0-E13B-4CDF-96E7-7307DB7CCD86}"/>
               </a:ext>
             </a:extLst>
           </p:cNvPr>
@@ -13566,7 +13613,7 @@
           <p:cNvPr id="4" name="text">
             <a:extLst xmlns:a="http://schemas.openxmlformats.org/drawingml/2006/main">
               <a:ext uri="{FF2B5EF4-FFF2-40B4-BE49-F238E27FC236}">
-                <a16:creationId xmlns:a16="http://schemas.microsoft.com/office/drawing/2014/main" id="{C12F5A72-5F98-4B1A-995B-4618C9708CC5}"/>
+                <a16:creationId xmlns:a16="http://schemas.microsoft.com/office/drawing/2014/main" id="{E824BB14-94D1-408A-8AB6-1471DD1ADF72}"/>
               </a:ext>
             </a:extLst>
           </p:cNvPr>
@@ -13623,7 +13670,7 @@
           <p:cNvPr id="5" name="text">
             <a:extLst xmlns:a="http://schemas.openxmlformats.org/drawingml/2006/main">
               <a:ext uri="{FF2B5EF4-FFF2-40B4-BE49-F238E27FC236}">
-                <a16:creationId xmlns:a16="http://schemas.microsoft.com/office/drawing/2014/main" id="{ADE8CF45-B6AB-40C4-9425-36156018B278}"/>
+                <a16:creationId xmlns:a16="http://schemas.microsoft.com/office/drawing/2014/main" id="{46D15619-9156-45DD-8817-15D91848FD93}"/>
               </a:ext>
             </a:extLst>
           </p:cNvPr>
@@ -13680,7 +13727,7 @@
           <p:cNvPr id="6" name="text">
             <a:extLst xmlns:a="http://schemas.openxmlformats.org/drawingml/2006/main">
               <a:ext uri="{FF2B5EF4-FFF2-40B4-BE49-F238E27FC236}">
-                <a16:creationId xmlns:a16="http://schemas.microsoft.com/office/drawing/2014/main" id="{D8DEF9B9-AEF1-4EEC-914B-3D1E3A66C30C}"/>
+                <a16:creationId xmlns:a16="http://schemas.microsoft.com/office/drawing/2014/main" id="{165E161B-D501-41EC-9EFC-7AFBAE253944}"/>
               </a:ext>
             </a:extLst>
           </p:cNvPr>
@@ -13737,7 +13784,7 @@
           <p:cNvPr id="7" name="text">
             <a:extLst xmlns:a="http://schemas.openxmlformats.org/drawingml/2006/main">
               <a:ext uri="{FF2B5EF4-FFF2-40B4-BE49-F238E27FC236}">
-                <a16:creationId xmlns:a16="http://schemas.microsoft.com/office/drawing/2014/main" id="{395D03D8-C51C-47D1-9D48-0512308E8DBB}"/>
+                <a16:creationId xmlns:a16="http://schemas.microsoft.com/office/drawing/2014/main" id="{976E1674-ED3C-4E37-B654-D85BBEE32E8F}"/>
               </a:ext>
             </a:extLst>
           </p:cNvPr>
@@ -13794,7 +13841,7 @@
           <p:cNvPr id="8" name="text">
             <a:extLst xmlns:a="http://schemas.openxmlformats.org/drawingml/2006/main">
               <a:ext uri="{FF2B5EF4-FFF2-40B4-BE49-F238E27FC236}">
-                <a16:creationId xmlns:a16="http://schemas.microsoft.com/office/drawing/2014/main" id="{092FC040-A08C-4D9A-B81C-73DAA2F48B59}"/>
+                <a16:creationId xmlns:a16="http://schemas.microsoft.com/office/drawing/2014/main" id="{31F0FB7E-3C3E-4604-ADA2-061E38A8B63F}"/>
               </a:ext>
             </a:extLst>
           </p:cNvPr>
@@ -13851,7 +13898,7 @@
           <p:cNvPr id="9" name="text">
             <a:extLst xmlns:a="http://schemas.openxmlformats.org/drawingml/2006/main">
               <a:ext uri="{FF2B5EF4-FFF2-40B4-BE49-F238E27FC236}">
-                <a16:creationId xmlns:a16="http://schemas.microsoft.com/office/drawing/2014/main" id="{0E5BF635-D1F0-447C-91BD-33BF1576C76A}"/>
+                <a16:creationId xmlns:a16="http://schemas.microsoft.com/office/drawing/2014/main" id="{FEE2F09B-80B5-47E0-815B-CAA4F584D9FB}"/>
               </a:ext>
             </a:extLst>
           </p:cNvPr>
@@ -13908,7 +13955,7 @@
           <p:cNvPr id="10" name="text">
             <a:extLst xmlns:a="http://schemas.openxmlformats.org/drawingml/2006/main">
               <a:ext uri="{FF2B5EF4-FFF2-40B4-BE49-F238E27FC236}">
-                <a16:creationId xmlns:a16="http://schemas.microsoft.com/office/drawing/2014/main" id="{C7D23202-EDD8-4CE1-9FB5-1F57F4229473}"/>
+                <a16:creationId xmlns:a16="http://schemas.microsoft.com/office/drawing/2014/main" id="{EC8E4434-281E-42A3-9AE9-213D32DA21AE}"/>
               </a:ext>
             </a:extLst>
           </p:cNvPr>
@@ -13965,7 +14012,7 @@
           <p:cNvPr id="11" name="text">
             <a:extLst xmlns:a="http://schemas.openxmlformats.org/drawingml/2006/main">
               <a:ext uri="{FF2B5EF4-FFF2-40B4-BE49-F238E27FC236}">
-                <a16:creationId xmlns:a16="http://schemas.microsoft.com/office/drawing/2014/main" id="{F7850662-365F-40D7-A74A-33E839576DD4}"/>
+                <a16:creationId xmlns:a16="http://schemas.microsoft.com/office/drawing/2014/main" id="{EF4CEA9B-C778-493D-ABDD-3CB399838469}"/>
               </a:ext>
             </a:extLst>
           </p:cNvPr>
@@ -14022,7 +14069,7 @@
           <p:cNvPr id="12" name="text">
             <a:extLst xmlns:a="http://schemas.openxmlformats.org/drawingml/2006/main">
               <a:ext uri="{FF2B5EF4-FFF2-40B4-BE49-F238E27FC236}">
-                <a16:creationId xmlns:a16="http://schemas.microsoft.com/office/drawing/2014/main" id="{E414C0A5-B92A-442B-9DEC-2BC479E6075E}"/>
+                <a16:creationId xmlns:a16="http://schemas.microsoft.com/office/drawing/2014/main" id="{F8E5B6B7-8696-44CC-8C6D-088F841E7E3F}"/>
               </a:ext>
             </a:extLst>
           </p:cNvPr>
@@ -14079,7 +14126,7 @@
           <p:cNvPr id="13" name="Slide number">
             <a:extLst xmlns:a="http://schemas.openxmlformats.org/drawingml/2006/main">
               <a:ext uri="{FF2B5EF4-FFF2-40B4-BE49-F238E27FC236}">
-                <a16:creationId xmlns:a16="http://schemas.microsoft.com/office/drawing/2014/main" id="{406CEC3A-D044-4457-88EC-AA47877B776F}"/>
+                <a16:creationId xmlns:a16="http://schemas.microsoft.com/office/drawing/2014/main" id="{4C239D67-C5EF-420C-9F6C-00D121F31ACA}"/>
               </a:ext>
             </a:extLst>
           </p:cNvPr>
@@ -14134,7 +14181,7 @@
     </p:spTree>
     <p:extLst>
       <p:ext uri="{BB962C8B-B14F-4D97-AF65-F5344CB8AC3E}">
-        <p14:creationId xmlns:p14="http://schemas.microsoft.com/office/powerpoint/2010/main" val="1389915455"/>
+        <p14:creationId xmlns:p14="http://schemas.microsoft.com/office/powerpoint/2010/main" val="1748606713"/>
       </p:ext>
     </p:extLst>
   </p:cSld>
@@ -14165,7 +14212,7 @@
           <p:cNvPr id="9" name="Title">
             <a:extLst xmlns:a="http://schemas.openxmlformats.org/drawingml/2006/main">
               <a:ext uri="{FF2B5EF4-FFF2-40B4-BE49-F238E27FC236}">
-                <a16:creationId xmlns:a16="http://schemas.microsoft.com/office/drawing/2014/main" id="{F1C0F829-47B1-43BF-9DEC-40BAB8F8F39F}"/>
+                <a16:creationId xmlns:a16="http://schemas.microsoft.com/office/drawing/2014/main" id="{668CB5BA-281A-4A22-8BD0-1A604F905140}"/>
               </a:ext>
             </a:extLst>
           </p:cNvPr>
@@ -14229,7 +14276,7 @@
         </p:xfrm>
         <a:graphic xmlns:a="http://schemas.openxmlformats.org/drawingml/2006/main">
           <a:graphicData uri="http://schemas.openxmlformats.org/drawingml/2006/chart">
-            <c:chart xmlns:r="http://schemas.openxmlformats.org/officeDocument/2006/relationships" xmlns:c="http://schemas.openxmlformats.org/drawingml/2006/chart" r:id="R1cc0fa79a3f9497a"/>
+            <c:chart xmlns:r="http://schemas.openxmlformats.org/officeDocument/2006/relationships" xmlns:c="http://schemas.openxmlformats.org/drawingml/2006/chart" r:id="Ra2567e7617c84cb3"/>
           </a:graphicData>
         </a:graphic>
       </p:graphicFrame>
@@ -14238,7 +14285,7 @@
           <p:cNvPr id="3" name="Date label">
             <a:extLst xmlns:a="http://schemas.openxmlformats.org/drawingml/2006/main">
               <a:ext uri="{FF2B5EF4-FFF2-40B4-BE49-F238E27FC236}">
-                <a16:creationId xmlns:a16="http://schemas.microsoft.com/office/drawing/2014/main" id="{CC1418D9-61B9-4331-97D9-0DE48A39AD94}"/>
+                <a16:creationId xmlns:a16="http://schemas.microsoft.com/office/drawing/2014/main" id="{90A7FA67-00FC-4A54-8D3F-0A6B9F4151E7}"/>
               </a:ext>
             </a:extLst>
           </p:cNvPr>
@@ -14295,7 +14342,7 @@
           <p:cNvPr id="4" name="Date label">
             <a:extLst xmlns:a="http://schemas.openxmlformats.org/drawingml/2006/main">
               <a:ext uri="{FF2B5EF4-FFF2-40B4-BE49-F238E27FC236}">
-                <a16:creationId xmlns:a16="http://schemas.microsoft.com/office/drawing/2014/main" id="{13B8E838-09A9-40EE-90C6-AAC02B7929BF}"/>
+                <a16:creationId xmlns:a16="http://schemas.microsoft.com/office/drawing/2014/main" id="{B3D947C1-9015-4C77-A29E-2E0A5425D03C}"/>
               </a:ext>
             </a:extLst>
           </p:cNvPr>
@@ -14352,7 +14399,7 @@
           <p:cNvPr id="5" name="Date label">
             <a:extLst xmlns:a="http://schemas.openxmlformats.org/drawingml/2006/main">
               <a:ext uri="{FF2B5EF4-FFF2-40B4-BE49-F238E27FC236}">
-                <a16:creationId xmlns:a16="http://schemas.microsoft.com/office/drawing/2014/main" id="{DDF329CD-9C88-4F04-8EA6-33B7D3C66889}"/>
+                <a16:creationId xmlns:a16="http://schemas.microsoft.com/office/drawing/2014/main" id="{D5B5250F-6BB2-4BCA-A04A-121604572D45}"/>
               </a:ext>
             </a:extLst>
           </p:cNvPr>
@@ -14409,7 +14456,7 @@
           <p:cNvPr id="6" name="Date label">
             <a:extLst xmlns:a="http://schemas.openxmlformats.org/drawingml/2006/main">
               <a:ext uri="{FF2B5EF4-FFF2-40B4-BE49-F238E27FC236}">
-                <a16:creationId xmlns:a16="http://schemas.microsoft.com/office/drawing/2014/main" id="{8EBFE820-D8C8-4B9F-9E60-7592D844C8C1}"/>
+                <a16:creationId xmlns:a16="http://schemas.microsoft.com/office/drawing/2014/main" id="{99E91714-8F8A-4F7F-A1B5-F27CD3C722EF}"/>
               </a:ext>
             </a:extLst>
           </p:cNvPr>
@@ -14466,7 +14513,7 @@
           <p:cNvPr id="7" name="Methodology">
             <a:extLst xmlns:a="http://schemas.openxmlformats.org/drawingml/2006/main">
               <a:ext uri="{FF2B5EF4-FFF2-40B4-BE49-F238E27FC236}">
-                <a16:creationId xmlns:a16="http://schemas.microsoft.com/office/drawing/2014/main" id="{5354FCB1-2504-4BF6-805B-59724D66FC59}"/>
+                <a16:creationId xmlns:a16="http://schemas.microsoft.com/office/drawing/2014/main" id="{2BA68363-ECF6-4D12-88FF-9BF6FB0D8AD1}"/>
               </a:ext>
             </a:extLst>
           </p:cNvPr>
@@ -14546,7 +14593,7 @@
           <p:cNvPr id="8" name="Slide number">
             <a:extLst xmlns:a="http://schemas.openxmlformats.org/drawingml/2006/main">
               <a:ext uri="{FF2B5EF4-FFF2-40B4-BE49-F238E27FC236}">
-                <a16:creationId xmlns:a16="http://schemas.microsoft.com/office/drawing/2014/main" id="{74B6D8D4-8531-4F41-B041-04B27B30C610}"/>
+                <a16:creationId xmlns:a16="http://schemas.microsoft.com/office/drawing/2014/main" id="{B82978AA-7808-4F74-BB58-FF0CCA01EEFB}"/>
               </a:ext>
             </a:extLst>
           </p:cNvPr>
@@ -14601,7 +14648,7 @@
     </p:spTree>
     <p:extLst>
       <p:ext uri="{BB962C8B-B14F-4D97-AF65-F5344CB8AC3E}">
-        <p14:creationId xmlns:p14="http://schemas.microsoft.com/office/powerpoint/2010/main" val="2003623433"/>
+        <p14:creationId xmlns:p14="http://schemas.microsoft.com/office/powerpoint/2010/main" val="1889899018"/>
       </p:ext>
     </p:extLst>
   </p:cSld>
@@ -14632,7 +14679,7 @@
           <p:cNvPr id="16" name="Completed section 0">
             <a:extLst xmlns:a="http://schemas.openxmlformats.org/drawingml/2006/main">
               <a:ext uri="{FF2B5EF4-FFF2-40B4-BE49-F238E27FC236}">
-                <a16:creationId xmlns:a16="http://schemas.microsoft.com/office/drawing/2014/main" id="{412EE8AA-55A4-4FBE-A30C-54195CBF256B}"/>
+                <a16:creationId xmlns:a16="http://schemas.microsoft.com/office/drawing/2014/main" id="{BEC7408C-162B-4032-8548-3C39DAE6FF82}"/>
               </a:ext>
             </a:extLst>
           </p:cNvPr>
@@ -14689,7 +14736,7 @@
           <p:cNvPr id="2" name="Section description 0">
             <a:extLst xmlns:a="http://schemas.openxmlformats.org/drawingml/2006/main">
               <a:ext uri="{FF2B5EF4-FFF2-40B4-BE49-F238E27FC236}">
-                <a16:creationId xmlns:a16="http://schemas.microsoft.com/office/drawing/2014/main" id="{C15951CE-3309-4A42-B287-75110CD1A7CF}"/>
+                <a16:creationId xmlns:a16="http://schemas.microsoft.com/office/drawing/2014/main" id="{6E7603B9-625F-4D69-8A02-A83E8A849CBA}"/>
               </a:ext>
             </a:extLst>
           </p:cNvPr>
@@ -14746,7 +14793,7 @@
           <p:cNvPr id="3" name="Completed section 1">
             <a:extLst xmlns:a="http://schemas.openxmlformats.org/drawingml/2006/main">
               <a:ext uri="{FF2B5EF4-FFF2-40B4-BE49-F238E27FC236}">
-                <a16:creationId xmlns:a16="http://schemas.microsoft.com/office/drawing/2014/main" id="{AE0DD652-FCBA-471A-9294-2527E04F81EA}"/>
+                <a16:creationId xmlns:a16="http://schemas.microsoft.com/office/drawing/2014/main" id="{C3ACF4E2-0F92-4BE2-BDD3-7879BFE1E85B}"/>
               </a:ext>
             </a:extLst>
           </p:cNvPr>
@@ -14803,7 +14850,7 @@
           <p:cNvPr id="4" name="Section description 1">
             <a:extLst xmlns:a="http://schemas.openxmlformats.org/drawingml/2006/main">
               <a:ext uri="{FF2B5EF4-FFF2-40B4-BE49-F238E27FC236}">
-                <a16:creationId xmlns:a16="http://schemas.microsoft.com/office/drawing/2014/main" id="{BA2840E4-735E-4E43-B414-B3C19469794B}"/>
+                <a16:creationId xmlns:a16="http://schemas.microsoft.com/office/drawing/2014/main" id="{260551A5-25AB-4189-B05E-4425C9274AF2}"/>
               </a:ext>
             </a:extLst>
           </p:cNvPr>
@@ -14860,7 +14907,7 @@
           <p:cNvPr id="5" name="Completed section 2">
             <a:extLst xmlns:a="http://schemas.openxmlformats.org/drawingml/2006/main">
               <a:ext uri="{FF2B5EF4-FFF2-40B4-BE49-F238E27FC236}">
-                <a16:creationId xmlns:a16="http://schemas.microsoft.com/office/drawing/2014/main" id="{40458CB7-5CE5-4A3E-9F5B-8AA5B6C6C7EA}"/>
+                <a16:creationId xmlns:a16="http://schemas.microsoft.com/office/drawing/2014/main" id="{795CD32F-692C-4787-ADB8-C881262BC851}"/>
               </a:ext>
             </a:extLst>
           </p:cNvPr>
@@ -14917,7 +14964,7 @@
           <p:cNvPr id="6" name="Section description 2">
             <a:extLst xmlns:a="http://schemas.openxmlformats.org/drawingml/2006/main">
               <a:ext uri="{FF2B5EF4-FFF2-40B4-BE49-F238E27FC236}">
-                <a16:creationId xmlns:a16="http://schemas.microsoft.com/office/drawing/2014/main" id="{F68C64D3-D620-4C6E-B59B-1730B9CD8179}"/>
+                <a16:creationId xmlns:a16="http://schemas.microsoft.com/office/drawing/2014/main" id="{78056AC6-FA9B-4E82-BF77-2C774DE58CBF}"/>
               </a:ext>
             </a:extLst>
           </p:cNvPr>
@@ -14974,7 +15021,7 @@
           <p:cNvPr id="7" name="Completed section 3">
             <a:extLst xmlns:a="http://schemas.openxmlformats.org/drawingml/2006/main">
               <a:ext uri="{FF2B5EF4-FFF2-40B4-BE49-F238E27FC236}">
-                <a16:creationId xmlns:a16="http://schemas.microsoft.com/office/drawing/2014/main" id="{2F46954C-98A2-4807-910B-CE2BDF491A3B}"/>
+                <a16:creationId xmlns:a16="http://schemas.microsoft.com/office/drawing/2014/main" id="{8A324B42-AF18-444C-AE7E-D4EEE72477A0}"/>
               </a:ext>
             </a:extLst>
           </p:cNvPr>
@@ -15031,7 +15078,7 @@
           <p:cNvPr id="8" name="Section description 3">
             <a:extLst xmlns:a="http://schemas.openxmlformats.org/drawingml/2006/main">
               <a:ext uri="{FF2B5EF4-FFF2-40B4-BE49-F238E27FC236}">
-                <a16:creationId xmlns:a16="http://schemas.microsoft.com/office/drawing/2014/main" id="{2C5C51FF-58BE-4F7A-A1CB-922ABDC3CBF8}"/>
+                <a16:creationId xmlns:a16="http://schemas.microsoft.com/office/drawing/2014/main" id="{77046E73-D9B7-42AC-8C6E-27C52265F946}"/>
               </a:ext>
             </a:extLst>
           </p:cNvPr>
@@ -15088,7 +15135,7 @@
           <p:cNvPr id="9" name="Completed section 4">
             <a:extLst xmlns:a="http://schemas.openxmlformats.org/drawingml/2006/main">
               <a:ext uri="{FF2B5EF4-FFF2-40B4-BE49-F238E27FC236}">
-                <a16:creationId xmlns:a16="http://schemas.microsoft.com/office/drawing/2014/main" id="{CB3E9634-C3F9-4CD7-9702-867D9A6B7CE4}"/>
+                <a16:creationId xmlns:a16="http://schemas.microsoft.com/office/drawing/2014/main" id="{FA5C51DF-2A93-45E8-8F78-1FB3C87258A5}"/>
               </a:ext>
             </a:extLst>
           </p:cNvPr>
@@ -15145,7 +15192,7 @@
           <p:cNvPr id="10" name="Section description 4">
             <a:extLst xmlns:a="http://schemas.openxmlformats.org/drawingml/2006/main">
               <a:ext uri="{FF2B5EF4-FFF2-40B4-BE49-F238E27FC236}">
-                <a16:creationId xmlns:a16="http://schemas.microsoft.com/office/drawing/2014/main" id="{61390E88-DF67-4338-B436-D5C2436B51BA}"/>
+                <a16:creationId xmlns:a16="http://schemas.microsoft.com/office/drawing/2014/main" id="{E8675550-51AB-4712-BDE5-D13B3E1A905D}"/>
               </a:ext>
             </a:extLst>
           </p:cNvPr>
@@ -15202,7 +15249,7 @@
           <p:cNvPr id="11" name="Completed section 5">
             <a:extLst xmlns:a="http://schemas.openxmlformats.org/drawingml/2006/main">
               <a:ext uri="{FF2B5EF4-FFF2-40B4-BE49-F238E27FC236}">
-                <a16:creationId xmlns:a16="http://schemas.microsoft.com/office/drawing/2014/main" id="{93132C8F-2594-41CD-8ED2-FA15F06A739F}"/>
+                <a16:creationId xmlns:a16="http://schemas.microsoft.com/office/drawing/2014/main" id="{78854BF8-9CA5-4B41-A619-E3AA073CE94C}"/>
               </a:ext>
             </a:extLst>
           </p:cNvPr>
@@ -15259,7 +15306,7 @@
           <p:cNvPr id="12" name="Section description 5">
             <a:extLst xmlns:a="http://schemas.openxmlformats.org/drawingml/2006/main">
               <a:ext uri="{FF2B5EF4-FFF2-40B4-BE49-F238E27FC236}">
-                <a16:creationId xmlns:a16="http://schemas.microsoft.com/office/drawing/2014/main" id="{37ABCAE6-57B6-423D-8884-2987DC2686F0}"/>
+                <a16:creationId xmlns:a16="http://schemas.microsoft.com/office/drawing/2014/main" id="{F4A61600-FFB2-418B-81EB-BA73E664D5AD}"/>
               </a:ext>
             </a:extLst>
           </p:cNvPr>
@@ -15316,7 +15363,7 @@
           <p:cNvPr id="13" name="Title">
             <a:extLst xmlns:a="http://schemas.openxmlformats.org/drawingml/2006/main">
               <a:ext uri="{FF2B5EF4-FFF2-40B4-BE49-F238E27FC236}">
-                <a16:creationId xmlns:a16="http://schemas.microsoft.com/office/drawing/2014/main" id="{7D3373CE-731A-4FD3-B24F-FAD9F338621F}"/>
+                <a16:creationId xmlns:a16="http://schemas.microsoft.com/office/drawing/2014/main" id="{B11E7D66-9479-42A1-A9C9-95C190EC344F}"/>
               </a:ext>
             </a:extLst>
           </p:cNvPr>
@@ -15373,7 +15420,7 @@
           <p:cNvPr id="14" name="Section description 6">
             <a:extLst xmlns:a="http://schemas.openxmlformats.org/drawingml/2006/main">
               <a:ext uri="{FF2B5EF4-FFF2-40B4-BE49-F238E27FC236}">
-                <a16:creationId xmlns:a16="http://schemas.microsoft.com/office/drawing/2014/main" id="{4FFAB23A-956C-4BED-B414-A3FD11558C08}"/>
+                <a16:creationId xmlns:a16="http://schemas.microsoft.com/office/drawing/2014/main" id="{C0E0C4DF-4DA5-408C-A6CC-34DBCEC1EBE3}"/>
               </a:ext>
             </a:extLst>
           </p:cNvPr>
@@ -15430,7 +15477,7 @@
           <p:cNvPr id="15" name="Slide number">
             <a:extLst xmlns:a="http://schemas.openxmlformats.org/drawingml/2006/main">
               <a:ext uri="{FF2B5EF4-FFF2-40B4-BE49-F238E27FC236}">
-                <a16:creationId xmlns:a16="http://schemas.microsoft.com/office/drawing/2014/main" id="{F6E3E225-5E73-4585-92D7-7134AC5CCC37}"/>
+                <a16:creationId xmlns:a16="http://schemas.microsoft.com/office/drawing/2014/main" id="{B3186662-16F9-4570-847F-7504094DED0E}"/>
               </a:ext>
             </a:extLst>
           </p:cNvPr>
@@ -15485,7 +15532,7 @@
     </p:spTree>
     <p:extLst>
       <p:ext uri="{BB962C8B-B14F-4D97-AF65-F5344CB8AC3E}">
-        <p14:creationId xmlns:p14="http://schemas.microsoft.com/office/powerpoint/2010/main" val="1030896945"/>
+        <p14:creationId xmlns:p14="http://schemas.microsoft.com/office/powerpoint/2010/main" val="1005169478"/>
       </p:ext>
     </p:extLst>
   </p:cSld>
@@ -15516,7 +15563,7 @@
           <p:cNvPr id="12" name="Title">
             <a:extLst xmlns:a="http://schemas.openxmlformats.org/drawingml/2006/main">
               <a:ext uri="{FF2B5EF4-FFF2-40B4-BE49-F238E27FC236}">
-                <a16:creationId xmlns:a16="http://schemas.microsoft.com/office/drawing/2014/main" id="{A12F779E-9B15-4761-80AE-247C60C88168}"/>
+                <a16:creationId xmlns:a16="http://schemas.microsoft.com/office/drawing/2014/main" id="{72A6ED65-8CDC-4AEE-B668-F621B2A05B9E}"/>
               </a:ext>
             </a:extLst>
           </p:cNvPr>
@@ -15573,7 +15620,7 @@
           <p:cNvPr id="2" name="text">
             <a:extLst xmlns:a="http://schemas.openxmlformats.org/drawingml/2006/main">
               <a:ext uri="{FF2B5EF4-FFF2-40B4-BE49-F238E27FC236}">
-                <a16:creationId xmlns:a16="http://schemas.microsoft.com/office/drawing/2014/main" id="{AF81E3EB-F203-4AA3-82A9-43579ECACF40}"/>
+                <a16:creationId xmlns:a16="http://schemas.microsoft.com/office/drawing/2014/main" id="{6019C45D-214C-4B14-A3E8-57F328A4440A}"/>
               </a:ext>
             </a:extLst>
           </p:cNvPr>
@@ -15630,7 +15677,7 @@
           <p:cNvPr id="3" name="text">
             <a:extLst xmlns:a="http://schemas.openxmlformats.org/drawingml/2006/main">
               <a:ext uri="{FF2B5EF4-FFF2-40B4-BE49-F238E27FC236}">
-                <a16:creationId xmlns:a16="http://schemas.microsoft.com/office/drawing/2014/main" id="{B382F0A8-0770-455D-8DC1-5EE0CFE8E124}"/>
+                <a16:creationId xmlns:a16="http://schemas.microsoft.com/office/drawing/2014/main" id="{42B37AD4-05B9-4A4B-97B2-2A9AC33A357C}"/>
               </a:ext>
             </a:extLst>
           </p:cNvPr>
@@ -15687,7 +15734,7 @@
           <p:cNvPr id="4" name="text">
             <a:extLst xmlns:a="http://schemas.openxmlformats.org/drawingml/2006/main">
               <a:ext uri="{FF2B5EF4-FFF2-40B4-BE49-F238E27FC236}">
-                <a16:creationId xmlns:a16="http://schemas.microsoft.com/office/drawing/2014/main" id="{CBBDD2D6-231E-4040-9BBA-1AAAE1B64222}"/>
+                <a16:creationId xmlns:a16="http://schemas.microsoft.com/office/drawing/2014/main" id="{1E795AC6-EAE3-42D7-A3CA-AEDB694ACBF8}"/>
               </a:ext>
             </a:extLst>
           </p:cNvPr>
@@ -15744,7 +15791,7 @@
           <p:cNvPr id="5" name="text">
             <a:extLst xmlns:a="http://schemas.openxmlformats.org/drawingml/2006/main">
               <a:ext uri="{FF2B5EF4-FFF2-40B4-BE49-F238E27FC236}">
-                <a16:creationId xmlns:a16="http://schemas.microsoft.com/office/drawing/2014/main" id="{77E95DFD-CF41-4542-A2C5-60D3E3D592AD}"/>
+                <a16:creationId xmlns:a16="http://schemas.microsoft.com/office/drawing/2014/main" id="{597D0EB4-72ED-40F0-850F-308C56FD30A1}"/>
               </a:ext>
             </a:extLst>
           </p:cNvPr>
@@ -15801,7 +15848,7 @@
           <p:cNvPr id="6" name="text">
             <a:extLst xmlns:a="http://schemas.openxmlformats.org/drawingml/2006/main">
               <a:ext uri="{FF2B5EF4-FFF2-40B4-BE49-F238E27FC236}">
-                <a16:creationId xmlns:a16="http://schemas.microsoft.com/office/drawing/2014/main" id="{5CCBB040-D5E0-4E9A-BD9F-C21328B1D068}"/>
+                <a16:creationId xmlns:a16="http://schemas.microsoft.com/office/drawing/2014/main" id="{409FC3FF-599C-4F71-B747-6E4EFE37C832}"/>
               </a:ext>
             </a:extLst>
           </p:cNvPr>
@@ -15858,7 +15905,7 @@
           <p:cNvPr id="7" name="text">
             <a:extLst xmlns:a="http://schemas.openxmlformats.org/drawingml/2006/main">
               <a:ext uri="{FF2B5EF4-FFF2-40B4-BE49-F238E27FC236}">
-                <a16:creationId xmlns:a16="http://schemas.microsoft.com/office/drawing/2014/main" id="{6C5CF31C-69E7-4E77-A5D5-4370260DF04B}"/>
+                <a16:creationId xmlns:a16="http://schemas.microsoft.com/office/drawing/2014/main" id="{0CFB49A0-3E6D-4B7A-95E8-41E51D2D82F0}"/>
               </a:ext>
             </a:extLst>
           </p:cNvPr>
@@ -15915,7 +15962,7 @@
           <p:cNvPr id="8" name="text">
             <a:extLst xmlns:a="http://schemas.openxmlformats.org/drawingml/2006/main">
               <a:ext uri="{FF2B5EF4-FFF2-40B4-BE49-F238E27FC236}">
-                <a16:creationId xmlns:a16="http://schemas.microsoft.com/office/drawing/2014/main" id="{E9F4684A-C8B2-4C69-A4AA-84EA1FCC116A}"/>
+                <a16:creationId xmlns:a16="http://schemas.microsoft.com/office/drawing/2014/main" id="{7C3AE15C-39E8-4DDD-8FA1-27BDAB11EFDE}"/>
               </a:ext>
             </a:extLst>
           </p:cNvPr>
@@ -15972,7 +16019,7 @@
           <p:cNvPr id="9" name="text">
             <a:extLst xmlns:a="http://schemas.openxmlformats.org/drawingml/2006/main">
               <a:ext uri="{FF2B5EF4-FFF2-40B4-BE49-F238E27FC236}">
-                <a16:creationId xmlns:a16="http://schemas.microsoft.com/office/drawing/2014/main" id="{8F199C6A-230B-4702-812C-A1124C3EEEA4}"/>
+                <a16:creationId xmlns:a16="http://schemas.microsoft.com/office/drawing/2014/main" id="{00785CAC-C902-4B82-8161-C27CCF1EB870}"/>
               </a:ext>
             </a:extLst>
           </p:cNvPr>
@@ -16029,7 +16076,7 @@
           <p:cNvPr id="10" name="text">
             <a:extLst xmlns:a="http://schemas.openxmlformats.org/drawingml/2006/main">
               <a:ext uri="{FF2B5EF4-FFF2-40B4-BE49-F238E27FC236}">
-                <a16:creationId xmlns:a16="http://schemas.microsoft.com/office/drawing/2014/main" id="{08605815-BDB1-4353-8324-2FB8BE6309BC}"/>
+                <a16:creationId xmlns:a16="http://schemas.microsoft.com/office/drawing/2014/main" id="{8B0FFF2F-F86C-47E6-AE96-0165FB8E6E04}"/>
               </a:ext>
             </a:extLst>
           </p:cNvPr>
@@ -16086,7 +16133,7 @@
           <p:cNvPr id="11" name="Slide number">
             <a:extLst xmlns:a="http://schemas.openxmlformats.org/drawingml/2006/main">
               <a:ext uri="{FF2B5EF4-FFF2-40B4-BE49-F238E27FC236}">
-                <a16:creationId xmlns:a16="http://schemas.microsoft.com/office/drawing/2014/main" id="{94C42454-1017-4A2F-9234-E3A9D0CA0461}"/>
+                <a16:creationId xmlns:a16="http://schemas.microsoft.com/office/drawing/2014/main" id="{631DE450-A017-4C00-AF90-459B1FB6A817}"/>
               </a:ext>
             </a:extLst>
           </p:cNvPr>
@@ -16141,7 +16188,7 @@
     </p:spTree>
     <p:extLst>
       <p:ext uri="{BB962C8B-B14F-4D97-AF65-F5344CB8AC3E}">
-        <p14:creationId xmlns:p14="http://schemas.microsoft.com/office/powerpoint/2010/main" val="1328765961"/>
+        <p14:creationId xmlns:p14="http://schemas.microsoft.com/office/powerpoint/2010/main" val="1018389231"/>
       </p:ext>
     </p:extLst>
   </p:cSld>
@@ -16172,7 +16219,7 @@
           <p:cNvPr id="10" name="Title">
             <a:extLst xmlns:a="http://schemas.openxmlformats.org/drawingml/2006/main">
               <a:ext uri="{FF2B5EF4-FFF2-40B4-BE49-F238E27FC236}">
-                <a16:creationId xmlns:a16="http://schemas.microsoft.com/office/drawing/2014/main" id="{0A1CEAFF-6531-4940-A8DD-4CD95F6330F1}"/>
+                <a16:creationId xmlns:a16="http://schemas.microsoft.com/office/drawing/2014/main" id="{8B1CB38E-1586-4020-ACAA-D277E7154504}"/>
               </a:ext>
             </a:extLst>
           </p:cNvPr>
@@ -16229,7 +16276,7 @@
           <p:cNvPr id="2" name="text">
             <a:extLst xmlns:a="http://schemas.openxmlformats.org/drawingml/2006/main">
               <a:ext uri="{FF2B5EF4-FFF2-40B4-BE49-F238E27FC236}">
-                <a16:creationId xmlns:a16="http://schemas.microsoft.com/office/drawing/2014/main" id="{984781EC-5954-48C1-8FA0-C96B5618CE52}"/>
+                <a16:creationId xmlns:a16="http://schemas.microsoft.com/office/drawing/2014/main" id="{6600903E-8CDE-4B09-94F5-8D656B400DD9}"/>
               </a:ext>
             </a:extLst>
           </p:cNvPr>
@@ -16286,7 +16333,7 @@
           <p:cNvPr id="3" name="text">
             <a:extLst xmlns:a="http://schemas.openxmlformats.org/drawingml/2006/main">
               <a:ext uri="{FF2B5EF4-FFF2-40B4-BE49-F238E27FC236}">
-                <a16:creationId xmlns:a16="http://schemas.microsoft.com/office/drawing/2014/main" id="{54406093-9BF1-49C5-AB36-A33598CAEF2A}"/>
+                <a16:creationId xmlns:a16="http://schemas.microsoft.com/office/drawing/2014/main" id="{1D2A7302-1822-448B-9899-1391BF0BF017}"/>
               </a:ext>
             </a:extLst>
           </p:cNvPr>
@@ -16343,7 +16390,7 @@
           <p:cNvPr id="4" name="text">
             <a:extLst xmlns:a="http://schemas.openxmlformats.org/drawingml/2006/main">
               <a:ext uri="{FF2B5EF4-FFF2-40B4-BE49-F238E27FC236}">
-                <a16:creationId xmlns:a16="http://schemas.microsoft.com/office/drawing/2014/main" id="{6891BF32-9847-4BA8-9F7E-28E62381F31A}"/>
+                <a16:creationId xmlns:a16="http://schemas.microsoft.com/office/drawing/2014/main" id="{1AB5E5B9-B6A0-4F04-AE9D-AA9CFDE41F8A}"/>
               </a:ext>
             </a:extLst>
           </p:cNvPr>
@@ -16400,7 +16447,7 @@
           <p:cNvPr id="5" name="text">
             <a:extLst xmlns:a="http://schemas.openxmlformats.org/drawingml/2006/main">
               <a:ext uri="{FF2B5EF4-FFF2-40B4-BE49-F238E27FC236}">
-                <a16:creationId xmlns:a16="http://schemas.microsoft.com/office/drawing/2014/main" id="{A90B87A8-24F3-47DA-8A4E-43FD2329AAB3}"/>
+                <a16:creationId xmlns:a16="http://schemas.microsoft.com/office/drawing/2014/main" id="{8A59A8D5-A028-4245-817E-ED7CD2295054}"/>
               </a:ext>
             </a:extLst>
           </p:cNvPr>
@@ -16457,7 +16504,7 @@
           <p:cNvPr id="6" name="text">
             <a:extLst xmlns:a="http://schemas.openxmlformats.org/drawingml/2006/main">
               <a:ext uri="{FF2B5EF4-FFF2-40B4-BE49-F238E27FC236}">
-                <a16:creationId xmlns:a16="http://schemas.microsoft.com/office/drawing/2014/main" id="{B39C61F0-8CA7-4A27-BB13-A55C8C35CF6E}"/>
+                <a16:creationId xmlns:a16="http://schemas.microsoft.com/office/drawing/2014/main" id="{C95FCDD7-73A0-4F6E-93E3-3AA10A927B17}"/>
               </a:ext>
             </a:extLst>
           </p:cNvPr>
@@ -16514,7 +16561,7 @@
           <p:cNvPr id="7" name="text">
             <a:extLst xmlns:a="http://schemas.openxmlformats.org/drawingml/2006/main">
               <a:ext uri="{FF2B5EF4-FFF2-40B4-BE49-F238E27FC236}">
-                <a16:creationId xmlns:a16="http://schemas.microsoft.com/office/drawing/2014/main" id="{866251E0-2CB5-4B5F-B481-482631CF46F6}"/>
+                <a16:creationId xmlns:a16="http://schemas.microsoft.com/office/drawing/2014/main" id="{B6607407-BBD4-4450-97AA-8773BA118A1D}"/>
               </a:ext>
             </a:extLst>
           </p:cNvPr>
@@ -16571,7 +16618,7 @@
           <p:cNvPr id="8" name="text">
             <a:extLst xmlns:a="http://schemas.openxmlformats.org/drawingml/2006/main">
               <a:ext uri="{FF2B5EF4-FFF2-40B4-BE49-F238E27FC236}">
-                <a16:creationId xmlns:a16="http://schemas.microsoft.com/office/drawing/2014/main" id="{187C1A94-F7B1-4CC8-B70E-64733CE5A6CD}"/>
+                <a16:creationId xmlns:a16="http://schemas.microsoft.com/office/drawing/2014/main" id="{B5135DB4-5FB7-4B84-AA3C-FBDEE4F2A3B3}"/>
               </a:ext>
             </a:extLst>
           </p:cNvPr>
@@ -16628,7 +16675,7 @@
           <p:cNvPr id="9" name="Slide number">
             <a:extLst xmlns:a="http://schemas.openxmlformats.org/drawingml/2006/main">
               <a:ext uri="{FF2B5EF4-FFF2-40B4-BE49-F238E27FC236}">
-                <a16:creationId xmlns:a16="http://schemas.microsoft.com/office/drawing/2014/main" id="{51031795-FEA1-48C1-AAF3-EF5F073CF953}"/>
+                <a16:creationId xmlns:a16="http://schemas.microsoft.com/office/drawing/2014/main" id="{7B1AE42C-43B8-49F3-A223-1A0A5F6A53BE}"/>
               </a:ext>
             </a:extLst>
           </p:cNvPr>
@@ -16683,7 +16730,7 @@
     </p:spTree>
     <p:extLst>
       <p:ext uri="{BB962C8B-B14F-4D97-AF65-F5344CB8AC3E}">
-        <p14:creationId xmlns:p14="http://schemas.microsoft.com/office/powerpoint/2010/main" val="1721399080"/>
+        <p14:creationId xmlns:p14="http://schemas.microsoft.com/office/powerpoint/2010/main" val="811381101"/>
       </p:ext>
     </p:extLst>
   </p:cSld>
@@ -16714,7 +16761,7 @@
           <p:cNvPr id="7" name="Title">
             <a:extLst xmlns:a="http://schemas.openxmlformats.org/drawingml/2006/main">
               <a:ext uri="{FF2B5EF4-FFF2-40B4-BE49-F238E27FC236}">
-                <a16:creationId xmlns:a16="http://schemas.microsoft.com/office/drawing/2014/main" id="{C093152A-7387-4E17-AA79-808A2DCA55F1}"/>
+                <a16:creationId xmlns:a16="http://schemas.microsoft.com/office/drawing/2014/main" id="{8860B78B-ACDC-4D91-8F59-A6AEC61B9F46}"/>
               </a:ext>
             </a:extLst>
           </p:cNvPr>
@@ -16778,7 +16825,7 @@
         </p:xfrm>
         <a:graphic xmlns:a="http://schemas.openxmlformats.org/drawingml/2006/main">
           <a:graphicData uri="http://schemas.openxmlformats.org/drawingml/2006/chart">
-            <c:chart xmlns:r="http://schemas.openxmlformats.org/officeDocument/2006/relationships" xmlns:c="http://schemas.openxmlformats.org/drawingml/2006/chart" r:id="R411f71c78bc64716"/>
+            <c:chart xmlns:r="http://schemas.openxmlformats.org/officeDocument/2006/relationships" xmlns:c="http://schemas.openxmlformats.org/drawingml/2006/chart" r:id="R4234f1675b444451"/>
           </a:graphicData>
         </a:graphic>
       </p:graphicFrame>
@@ -16787,7 +16834,7 @@
           <p:cNvPr id="3" name="April month marker">
             <a:extLst xmlns:a="http://schemas.openxmlformats.org/drawingml/2006/main">
               <a:ext uri="{FF2B5EF4-FFF2-40B4-BE49-F238E27FC236}">
-                <a16:creationId xmlns:a16="http://schemas.microsoft.com/office/drawing/2014/main" id="{F8EE451D-7BCE-4A2B-AC88-F256BC4D0794}"/>
+                <a16:creationId xmlns:a16="http://schemas.microsoft.com/office/drawing/2014/main" id="{25CA7CDB-6268-4DDA-8480-91A17E29D4D7}"/>
               </a:ext>
             </a:extLst>
           </p:cNvPr>
@@ -16818,7 +16865,7 @@
           <p:cNvPr id="4" name="April joining context">
             <a:extLst xmlns:a="http://schemas.openxmlformats.org/drawingml/2006/main">
               <a:ext uri="{FF2B5EF4-FFF2-40B4-BE49-F238E27FC236}">
-                <a16:creationId xmlns:a16="http://schemas.microsoft.com/office/drawing/2014/main" id="{27F20E5D-224A-4245-9733-57F1BC163704}"/>
+                <a16:creationId xmlns:a16="http://schemas.microsoft.com/office/drawing/2014/main" id="{9D383EF5-99AE-48FD-B9B0-7946DCB07DF0}"/>
               </a:ext>
             </a:extLst>
           </p:cNvPr>
@@ -16875,7 +16922,7 @@
           <p:cNvPr id="5" name="Methodology">
             <a:extLst xmlns:a="http://schemas.openxmlformats.org/drawingml/2006/main">
               <a:ext uri="{FF2B5EF4-FFF2-40B4-BE49-F238E27FC236}">
-                <a16:creationId xmlns:a16="http://schemas.microsoft.com/office/drawing/2014/main" id="{79CCFD08-36ED-486A-B1E8-9D0D87EB6F67}"/>
+                <a16:creationId xmlns:a16="http://schemas.microsoft.com/office/drawing/2014/main" id="{0D2B0809-1540-4554-9CFD-B05B125762F1}"/>
               </a:ext>
             </a:extLst>
           </p:cNvPr>
@@ -16932,7 +16979,7 @@
           <p:cNvPr id="6" name="Slide number">
             <a:extLst xmlns:a="http://schemas.openxmlformats.org/drawingml/2006/main">
               <a:ext uri="{FF2B5EF4-FFF2-40B4-BE49-F238E27FC236}">
-                <a16:creationId xmlns:a16="http://schemas.microsoft.com/office/drawing/2014/main" id="{665596F5-38FD-4F56-8C12-3DA74AD8B09B}"/>
+                <a16:creationId xmlns:a16="http://schemas.microsoft.com/office/drawing/2014/main" id="{60975BFC-07F3-4FBA-ADFD-70A8DEB249AB}"/>
               </a:ext>
             </a:extLst>
           </p:cNvPr>
@@ -16987,7 +17034,7 @@
     </p:spTree>
     <p:extLst>
       <p:ext uri="{BB962C8B-B14F-4D97-AF65-F5344CB8AC3E}">
-        <p14:creationId xmlns:p14="http://schemas.microsoft.com/office/powerpoint/2010/main" val="2128560045"/>
+        <p14:creationId xmlns:p14="http://schemas.microsoft.com/office/powerpoint/2010/main" val="287692859"/>
       </p:ext>
     </p:extLst>
   </p:cSld>
@@ -17018,7 +17065,7 @@
           <p:cNvPr id="4" name="Title">
             <a:extLst xmlns:a="http://schemas.openxmlformats.org/drawingml/2006/main">
               <a:ext uri="{FF2B5EF4-FFF2-40B4-BE49-F238E27FC236}">
-                <a16:creationId xmlns:a16="http://schemas.microsoft.com/office/drawing/2014/main" id="{A3E737FF-D39C-4275-B58F-B7C94C59A7E0}"/>
+                <a16:creationId xmlns:a16="http://schemas.microsoft.com/office/drawing/2014/main" id="{37A3EBD6-2CDB-4B6E-BAE8-9E7D3A1E4AA7}"/>
               </a:ext>
             </a:extLst>
           </p:cNvPr>
@@ -17098,7 +17145,7 @@
           <p:cNvPr id="2" name="text">
             <a:extLst xmlns:a="http://schemas.openxmlformats.org/drawingml/2006/main">
               <a:ext uri="{FF2B5EF4-FFF2-40B4-BE49-F238E27FC236}">
-                <a16:creationId xmlns:a16="http://schemas.microsoft.com/office/drawing/2014/main" id="{FA67A654-DF8E-435D-875D-FFCB374EFB85}"/>
+                <a16:creationId xmlns:a16="http://schemas.microsoft.com/office/drawing/2014/main" id="{1874DCAB-2FE8-4F80-8DBD-99A550C12CBE}"/>
               </a:ext>
             </a:extLst>
           </p:cNvPr>
@@ -17155,7 +17202,7 @@
           <p:cNvPr id="3" name="Slide number">
             <a:extLst xmlns:a="http://schemas.openxmlformats.org/drawingml/2006/main">
               <a:ext uri="{FF2B5EF4-FFF2-40B4-BE49-F238E27FC236}">
-                <a16:creationId xmlns:a16="http://schemas.microsoft.com/office/drawing/2014/main" id="{2E017BFF-3102-4FA7-9FF8-312550D6F811}"/>
+                <a16:creationId xmlns:a16="http://schemas.microsoft.com/office/drawing/2014/main" id="{FFDC9D87-3417-4590-882A-2BD4BC765B13}"/>
               </a:ext>
             </a:extLst>
           </p:cNvPr>
@@ -17210,7 +17257,7 @@
     </p:spTree>
     <p:extLst>
       <p:ext uri="{BB962C8B-B14F-4D97-AF65-F5344CB8AC3E}">
-        <p14:creationId xmlns:p14="http://schemas.microsoft.com/office/powerpoint/2010/main" val="1165813092"/>
+        <p14:creationId xmlns:p14="http://schemas.microsoft.com/office/powerpoint/2010/main" val="773529445"/>
       </p:ext>
     </p:extLst>
   </p:cSld>
@@ -17241,7 +17288,7 @@
           <p:cNvPr id="10" name="Title">
             <a:extLst xmlns:a="http://schemas.openxmlformats.org/drawingml/2006/main">
               <a:ext uri="{FF2B5EF4-FFF2-40B4-BE49-F238E27FC236}">
-                <a16:creationId xmlns:a16="http://schemas.microsoft.com/office/drawing/2014/main" id="{8B19E80D-6F6E-43D3-8E00-90AD491273A9}"/>
+                <a16:creationId xmlns:a16="http://schemas.microsoft.com/office/drawing/2014/main" id="{5D7360A5-21B1-48DB-B3A0-97008AEEBFE8}"/>
               </a:ext>
             </a:extLst>
           </p:cNvPr>
@@ -17298,7 +17345,7 @@
           <p:cNvPr id="2" name="text">
             <a:extLst xmlns:a="http://schemas.openxmlformats.org/drawingml/2006/main">
               <a:ext uri="{FF2B5EF4-FFF2-40B4-BE49-F238E27FC236}">
-                <a16:creationId xmlns:a16="http://schemas.microsoft.com/office/drawing/2014/main" id="{0FC3CF7C-B2A8-42E6-9B30-24C9700E027E}"/>
+                <a16:creationId xmlns:a16="http://schemas.microsoft.com/office/drawing/2014/main" id="{F442DE67-679A-41DE-88FD-0FA9560B36A9}"/>
               </a:ext>
             </a:extLst>
           </p:cNvPr>
@@ -17355,7 +17402,7 @@
           <p:cNvPr id="3" name="text">
             <a:extLst xmlns:a="http://schemas.openxmlformats.org/drawingml/2006/main">
               <a:ext uri="{FF2B5EF4-FFF2-40B4-BE49-F238E27FC236}">
-                <a16:creationId xmlns:a16="http://schemas.microsoft.com/office/drawing/2014/main" id="{82FED95E-6B7B-4F1A-9302-C94B2D395B33}"/>
+                <a16:creationId xmlns:a16="http://schemas.microsoft.com/office/drawing/2014/main" id="{650D5F58-04B7-4D3C-AF42-7E9DB6C2F4C4}"/>
               </a:ext>
             </a:extLst>
           </p:cNvPr>
@@ -17412,7 +17459,7 @@
           <p:cNvPr id="4" name="text">
             <a:extLst xmlns:a="http://schemas.openxmlformats.org/drawingml/2006/main">
               <a:ext uri="{FF2B5EF4-FFF2-40B4-BE49-F238E27FC236}">
-                <a16:creationId xmlns:a16="http://schemas.microsoft.com/office/drawing/2014/main" id="{5986E479-0FC8-4C2F-887A-6763FBC7B432}"/>
+                <a16:creationId xmlns:a16="http://schemas.microsoft.com/office/drawing/2014/main" id="{66D5EED1-CAAD-4954-BEB9-3F2E893423A9}"/>
               </a:ext>
             </a:extLst>
           </p:cNvPr>
@@ -17469,7 +17516,7 @@
           <p:cNvPr id="5" name="text">
             <a:extLst xmlns:a="http://schemas.openxmlformats.org/drawingml/2006/main">
               <a:ext uri="{FF2B5EF4-FFF2-40B4-BE49-F238E27FC236}">
-                <a16:creationId xmlns:a16="http://schemas.microsoft.com/office/drawing/2014/main" id="{A7AEBC85-0C2D-46DC-B944-B72ABAB73DBA}"/>
+                <a16:creationId xmlns:a16="http://schemas.microsoft.com/office/drawing/2014/main" id="{87313970-F288-4C7F-BCCD-33DF6635A83B}"/>
               </a:ext>
             </a:extLst>
           </p:cNvPr>
@@ -17526,7 +17573,7 @@
           <p:cNvPr id="6" name="text">
             <a:extLst xmlns:a="http://schemas.openxmlformats.org/drawingml/2006/main">
               <a:ext uri="{FF2B5EF4-FFF2-40B4-BE49-F238E27FC236}">
-                <a16:creationId xmlns:a16="http://schemas.microsoft.com/office/drawing/2014/main" id="{A33F8377-CF08-40CF-946D-2EB554D54761}"/>
+                <a16:creationId xmlns:a16="http://schemas.microsoft.com/office/drawing/2014/main" id="{AFF863E2-21CC-4C22-85C9-D8BEF510D76D}"/>
               </a:ext>
             </a:extLst>
           </p:cNvPr>
@@ -17583,7 +17630,7 @@
           <p:cNvPr id="7" name="text">
             <a:extLst xmlns:a="http://schemas.openxmlformats.org/drawingml/2006/main">
               <a:ext uri="{FF2B5EF4-FFF2-40B4-BE49-F238E27FC236}">
-                <a16:creationId xmlns:a16="http://schemas.microsoft.com/office/drawing/2014/main" id="{6F1F1A55-FF5B-4F9E-A509-CD983EF8F56C}"/>
+                <a16:creationId xmlns:a16="http://schemas.microsoft.com/office/drawing/2014/main" id="{2B2AC683-31E7-47E9-AE11-67D075C56FCC}"/>
               </a:ext>
             </a:extLst>
           </p:cNvPr>
@@ -17640,7 +17687,7 @@
           <p:cNvPr id="8" name="text">
             <a:extLst xmlns:a="http://schemas.openxmlformats.org/drawingml/2006/main">
               <a:ext uri="{FF2B5EF4-FFF2-40B4-BE49-F238E27FC236}">
-                <a16:creationId xmlns:a16="http://schemas.microsoft.com/office/drawing/2014/main" id="{1B4E5FE2-40DC-4932-804E-FFA6B517E7B9}"/>
+                <a16:creationId xmlns:a16="http://schemas.microsoft.com/office/drawing/2014/main" id="{4A21D41D-3259-496B-89A9-BDC3733E0176}"/>
               </a:ext>
             </a:extLst>
           </p:cNvPr>
@@ -17697,7 +17744,7 @@
           <p:cNvPr id="9" name="Slide number">
             <a:extLst xmlns:a="http://schemas.openxmlformats.org/drawingml/2006/main">
               <a:ext uri="{FF2B5EF4-FFF2-40B4-BE49-F238E27FC236}">
-                <a16:creationId xmlns:a16="http://schemas.microsoft.com/office/drawing/2014/main" id="{80BEF0F0-BE70-4481-92BE-58AF155D56B2}"/>
+                <a16:creationId xmlns:a16="http://schemas.microsoft.com/office/drawing/2014/main" id="{3012F3F6-E6AB-4790-8B5C-0FA413D6D4AE}"/>
               </a:ext>
             </a:extLst>
           </p:cNvPr>
@@ -17752,7 +17799,7 @@
     </p:spTree>
     <p:extLst>
       <p:ext uri="{BB962C8B-B14F-4D97-AF65-F5344CB8AC3E}">
-        <p14:creationId xmlns:p14="http://schemas.microsoft.com/office/powerpoint/2010/main" val="1189716668"/>
+        <p14:creationId xmlns:p14="http://schemas.microsoft.com/office/powerpoint/2010/main" val="733908757"/>
       </p:ext>
     </p:extLst>
   </p:cSld>
@@ -17783,7 +17830,7 @@
           <p:cNvPr id="12" name="Title">
             <a:extLst xmlns:a="http://schemas.openxmlformats.org/drawingml/2006/main">
               <a:ext uri="{FF2B5EF4-FFF2-40B4-BE49-F238E27FC236}">
-                <a16:creationId xmlns:a16="http://schemas.microsoft.com/office/drawing/2014/main" id="{BC0A6DAD-B17F-4BFE-9AAF-0E86949B571B}"/>
+                <a16:creationId xmlns:a16="http://schemas.microsoft.com/office/drawing/2014/main" id="{9A3406B3-AD1A-4289-AFE7-FE2C2679045B}"/>
               </a:ext>
             </a:extLst>
           </p:cNvPr>
@@ -17840,7 +17887,7 @@
           <p:cNvPr id="2" name="text">
             <a:extLst xmlns:a="http://schemas.openxmlformats.org/drawingml/2006/main">
               <a:ext uri="{FF2B5EF4-FFF2-40B4-BE49-F238E27FC236}">
-                <a16:creationId xmlns:a16="http://schemas.microsoft.com/office/drawing/2014/main" id="{DF9B3694-C59F-42DF-BA4E-0D3F1D228E55}"/>
+                <a16:creationId xmlns:a16="http://schemas.microsoft.com/office/drawing/2014/main" id="{94174E89-BDB1-407B-868D-B76C72C67A81}"/>
               </a:ext>
             </a:extLst>
           </p:cNvPr>
@@ -17897,7 +17944,7 @@
           <p:cNvPr id="3" name="text">
             <a:extLst xmlns:a="http://schemas.openxmlformats.org/drawingml/2006/main">
               <a:ext uri="{FF2B5EF4-FFF2-40B4-BE49-F238E27FC236}">
-                <a16:creationId xmlns:a16="http://schemas.microsoft.com/office/drawing/2014/main" id="{48B05D9E-F2F9-4C72-A4F2-B1C289F68B2D}"/>
+                <a16:creationId xmlns:a16="http://schemas.microsoft.com/office/drawing/2014/main" id="{118EE328-B280-4F12-8F26-836A9683FE63}"/>
               </a:ext>
             </a:extLst>
           </p:cNvPr>
@@ -17954,7 +18001,7 @@
           <p:cNvPr id="4" name="text">
             <a:extLst xmlns:a="http://schemas.openxmlformats.org/drawingml/2006/main">
               <a:ext uri="{FF2B5EF4-FFF2-40B4-BE49-F238E27FC236}">
-                <a16:creationId xmlns:a16="http://schemas.microsoft.com/office/drawing/2014/main" id="{546DBA9C-FB56-4C84-BDD2-9D765EE94C2A}"/>
+                <a16:creationId xmlns:a16="http://schemas.microsoft.com/office/drawing/2014/main" id="{E7F685AF-0167-47A6-9FE1-24C6C1F6285D}"/>
               </a:ext>
             </a:extLst>
           </p:cNvPr>
@@ -18011,7 +18058,7 @@
           <p:cNvPr id="5" name="text">
             <a:extLst xmlns:a="http://schemas.openxmlformats.org/drawingml/2006/main">
               <a:ext uri="{FF2B5EF4-FFF2-40B4-BE49-F238E27FC236}">
-                <a16:creationId xmlns:a16="http://schemas.microsoft.com/office/drawing/2014/main" id="{63DAC5D2-70B5-4E9D-B96B-291F128FCF28}"/>
+                <a16:creationId xmlns:a16="http://schemas.microsoft.com/office/drawing/2014/main" id="{B805E832-2EAC-446A-9041-A5598E0B6D40}"/>
               </a:ext>
             </a:extLst>
           </p:cNvPr>
@@ -18068,7 +18115,7 @@
           <p:cNvPr id="6" name="text">
             <a:extLst xmlns:a="http://schemas.openxmlformats.org/drawingml/2006/main">
               <a:ext uri="{FF2B5EF4-FFF2-40B4-BE49-F238E27FC236}">
-                <a16:creationId xmlns:a16="http://schemas.microsoft.com/office/drawing/2014/main" id="{477B57DD-2A57-4E45-88F2-EA97235CCB5C}"/>
+                <a16:creationId xmlns:a16="http://schemas.microsoft.com/office/drawing/2014/main" id="{F0BB1937-1332-4723-8CBA-D11ECCAC82F6}"/>
               </a:ext>
             </a:extLst>
           </p:cNvPr>
@@ -18125,7 +18172,7 @@
           <p:cNvPr id="7" name="text">
             <a:extLst xmlns:a="http://schemas.openxmlformats.org/drawingml/2006/main">
               <a:ext uri="{FF2B5EF4-FFF2-40B4-BE49-F238E27FC236}">
-                <a16:creationId xmlns:a16="http://schemas.microsoft.com/office/drawing/2014/main" id="{CE7613E9-97DD-4280-9765-0C6E8AAA6EC0}"/>
+                <a16:creationId xmlns:a16="http://schemas.microsoft.com/office/drawing/2014/main" id="{AA20175A-2148-45A7-82B4-0D82F5C415BA}"/>
               </a:ext>
             </a:extLst>
           </p:cNvPr>
@@ -18182,7 +18229,7 @@
           <p:cNvPr id="8" name="text">
             <a:extLst xmlns:a="http://schemas.openxmlformats.org/drawingml/2006/main">
               <a:ext uri="{FF2B5EF4-FFF2-40B4-BE49-F238E27FC236}">
-                <a16:creationId xmlns:a16="http://schemas.microsoft.com/office/drawing/2014/main" id="{B2CD3D6A-32C4-4EFA-AE92-9DA586AB3A0A}"/>
+                <a16:creationId xmlns:a16="http://schemas.microsoft.com/office/drawing/2014/main" id="{D03EBD0F-AFDD-4E8A-8B3A-1AA0DB6333D2}"/>
               </a:ext>
             </a:extLst>
           </p:cNvPr>
@@ -18239,7 +18286,7 @@
           <p:cNvPr id="9" name="text">
             <a:extLst xmlns:a="http://schemas.openxmlformats.org/drawingml/2006/main">
               <a:ext uri="{FF2B5EF4-FFF2-40B4-BE49-F238E27FC236}">
-                <a16:creationId xmlns:a16="http://schemas.microsoft.com/office/drawing/2014/main" id="{097BE20E-3F83-45B0-BDB9-FF464C0F2119}"/>
+                <a16:creationId xmlns:a16="http://schemas.microsoft.com/office/drawing/2014/main" id="{4654BBCB-3D55-4BDC-9772-BE7238B81F20}"/>
               </a:ext>
             </a:extLst>
           </p:cNvPr>
@@ -18296,7 +18343,7 @@
           <p:cNvPr id="10" name="text">
             <a:extLst xmlns:a="http://schemas.openxmlformats.org/drawingml/2006/main">
               <a:ext uri="{FF2B5EF4-FFF2-40B4-BE49-F238E27FC236}">
-                <a16:creationId xmlns:a16="http://schemas.microsoft.com/office/drawing/2014/main" id="{A239A43E-AFFA-4670-98B3-22697BBCBD7B}"/>
+                <a16:creationId xmlns:a16="http://schemas.microsoft.com/office/drawing/2014/main" id="{C91A9679-6D58-4E6A-ADA8-464070A46F2F}"/>
               </a:ext>
             </a:extLst>
           </p:cNvPr>
@@ -18353,7 +18400,7 @@
           <p:cNvPr id="11" name="Slide number">
             <a:extLst xmlns:a="http://schemas.openxmlformats.org/drawingml/2006/main">
               <a:ext uri="{FF2B5EF4-FFF2-40B4-BE49-F238E27FC236}">
-                <a16:creationId xmlns:a16="http://schemas.microsoft.com/office/drawing/2014/main" id="{1357B00C-6AEB-48CF-9547-F55E9AF67141}"/>
+                <a16:creationId xmlns:a16="http://schemas.microsoft.com/office/drawing/2014/main" id="{A67DC86E-DEB4-4114-A72B-73D5311AD041}"/>
               </a:ext>
             </a:extLst>
           </p:cNvPr>
@@ -18408,7 +18455,7 @@
     </p:spTree>
     <p:extLst>
       <p:ext uri="{BB962C8B-B14F-4D97-AF65-F5344CB8AC3E}">
-        <p14:creationId xmlns:p14="http://schemas.microsoft.com/office/powerpoint/2010/main" val="355898713"/>
+        <p14:creationId xmlns:p14="http://schemas.microsoft.com/office/powerpoint/2010/main" val="1241225958"/>
       </p:ext>
     </p:extLst>
   </p:cSld>
@@ -18439,7 +18486,7 @@
           <p:cNvPr id="19" name="Title">
             <a:extLst xmlns:a="http://schemas.openxmlformats.org/drawingml/2006/main">
               <a:ext uri="{FF2B5EF4-FFF2-40B4-BE49-F238E27FC236}">
-                <a16:creationId xmlns:a16="http://schemas.microsoft.com/office/drawing/2014/main" id="{0A65E929-19E8-473B-8008-EF160BAE3988}"/>
+                <a16:creationId xmlns:a16="http://schemas.microsoft.com/office/drawing/2014/main" id="{FC5120DF-6BC1-401E-983E-967DA5120AB0}"/>
               </a:ext>
             </a:extLst>
           </p:cNvPr>
@@ -18496,7 +18543,7 @@
           <p:cNvPr id="2" name="text">
             <a:extLst xmlns:a="http://schemas.openxmlformats.org/drawingml/2006/main">
               <a:ext uri="{FF2B5EF4-FFF2-40B4-BE49-F238E27FC236}">
-                <a16:creationId xmlns:a16="http://schemas.microsoft.com/office/drawing/2014/main" id="{DC221CAA-A243-497E-953D-03E1C94AA877}"/>
+                <a16:creationId xmlns:a16="http://schemas.microsoft.com/office/drawing/2014/main" id="{4E54C2FB-85F5-4D5F-85B2-965A026BDA55}"/>
               </a:ext>
             </a:extLst>
           </p:cNvPr>
@@ -18553,7 +18600,7 @@
           <p:cNvPr id="3" name="text">
             <a:extLst xmlns:a="http://schemas.openxmlformats.org/drawingml/2006/main">
               <a:ext uri="{FF2B5EF4-FFF2-40B4-BE49-F238E27FC236}">
-                <a16:creationId xmlns:a16="http://schemas.microsoft.com/office/drawing/2014/main" id="{F60D4B31-5BD1-4C16-880F-4057EB5A1442}"/>
+                <a16:creationId xmlns:a16="http://schemas.microsoft.com/office/drawing/2014/main" id="{1AE7410D-8C66-4B03-A150-E5E598890EE0}"/>
               </a:ext>
             </a:extLst>
           </p:cNvPr>
@@ -18610,7 +18657,7 @@
           <p:cNvPr id="4" name="text">
             <a:extLst xmlns:a="http://schemas.openxmlformats.org/drawingml/2006/main">
               <a:ext uri="{FF2B5EF4-FFF2-40B4-BE49-F238E27FC236}">
-                <a16:creationId xmlns:a16="http://schemas.microsoft.com/office/drawing/2014/main" id="{492F520C-EFEB-4902-94C1-1828656FFE65}"/>
+                <a16:creationId xmlns:a16="http://schemas.microsoft.com/office/drawing/2014/main" id="{2B1C6811-DB8F-4789-9E5D-5BA5C84C5B9E}"/>
               </a:ext>
             </a:extLst>
           </p:cNvPr>
@@ -18667,7 +18714,7 @@
           <p:cNvPr id="5" name="text">
             <a:extLst xmlns:a="http://schemas.openxmlformats.org/drawingml/2006/main">
               <a:ext uri="{FF2B5EF4-FFF2-40B4-BE49-F238E27FC236}">
-                <a16:creationId xmlns:a16="http://schemas.microsoft.com/office/drawing/2014/main" id="{04091570-E08B-4AFF-85EB-57568E300860}"/>
+                <a16:creationId xmlns:a16="http://schemas.microsoft.com/office/drawing/2014/main" id="{EFB76CC2-EF60-4FB0-8C79-1F263A53B306}"/>
               </a:ext>
             </a:extLst>
           </p:cNvPr>
@@ -18724,7 +18771,7 @@
           <p:cNvPr id="6" name="text">
             <a:extLst xmlns:a="http://schemas.openxmlformats.org/drawingml/2006/main">
               <a:ext uri="{FF2B5EF4-FFF2-40B4-BE49-F238E27FC236}">
-                <a16:creationId xmlns:a16="http://schemas.microsoft.com/office/drawing/2014/main" id="{101B837C-B6DA-4848-8FD0-7BDEFCDBF161}"/>
+                <a16:creationId xmlns:a16="http://schemas.microsoft.com/office/drawing/2014/main" id="{A526BA95-6364-4AB2-B745-93111EC95112}"/>
               </a:ext>
             </a:extLst>
           </p:cNvPr>
@@ -18781,7 +18828,7 @@
           <p:cNvPr id="7" name="text">
             <a:extLst xmlns:a="http://schemas.openxmlformats.org/drawingml/2006/main">
               <a:ext uri="{FF2B5EF4-FFF2-40B4-BE49-F238E27FC236}">
-                <a16:creationId xmlns:a16="http://schemas.microsoft.com/office/drawing/2014/main" id="{466D2190-E987-4DD8-992B-A8A58E70ED60}"/>
+                <a16:creationId xmlns:a16="http://schemas.microsoft.com/office/drawing/2014/main" id="{FB5410D9-0230-4611-BFAB-E3760D7F02C7}"/>
               </a:ext>
             </a:extLst>
           </p:cNvPr>
@@ -18838,7 +18885,7 @@
           <p:cNvPr id="8" name="text">
             <a:extLst xmlns:a="http://schemas.openxmlformats.org/drawingml/2006/main">
               <a:ext uri="{FF2B5EF4-FFF2-40B4-BE49-F238E27FC236}">
-                <a16:creationId xmlns:a16="http://schemas.microsoft.com/office/drawing/2014/main" id="{7D7EC166-F2C9-45A5-8445-96197E7BC9D8}"/>
+                <a16:creationId xmlns:a16="http://schemas.microsoft.com/office/drawing/2014/main" id="{C2B7C7AC-4F04-4043-8A4A-8D863EEC8A09}"/>
               </a:ext>
             </a:extLst>
           </p:cNvPr>
@@ -18895,7 +18942,7 @@
           <p:cNvPr id="9" name="text">
             <a:extLst xmlns:a="http://schemas.openxmlformats.org/drawingml/2006/main">
               <a:ext uri="{FF2B5EF4-FFF2-40B4-BE49-F238E27FC236}">
-                <a16:creationId xmlns:a16="http://schemas.microsoft.com/office/drawing/2014/main" id="{584B06ED-9AFF-49B3-A92D-BAE6E9D20755}"/>
+                <a16:creationId xmlns:a16="http://schemas.microsoft.com/office/drawing/2014/main" id="{C2CB19C6-D0DC-411E-8280-CC48D67D7B8D}"/>
               </a:ext>
             </a:extLst>
           </p:cNvPr>
@@ -18952,7 +18999,7 @@
           <p:cNvPr id="10" name="text">
             <a:extLst xmlns:a="http://schemas.openxmlformats.org/drawingml/2006/main">
               <a:ext uri="{FF2B5EF4-FFF2-40B4-BE49-F238E27FC236}">
-                <a16:creationId xmlns:a16="http://schemas.microsoft.com/office/drawing/2014/main" id="{91928ABC-93EB-4F1F-9176-224DF0BF3D36}"/>
+                <a16:creationId xmlns:a16="http://schemas.microsoft.com/office/drawing/2014/main" id="{BDB9F568-F94B-462A-BCC7-C93DB0B97D61}"/>
               </a:ext>
             </a:extLst>
           </p:cNvPr>
@@ -19009,7 +19056,7 @@
           <p:cNvPr id="11" name="text">
             <a:extLst xmlns:a="http://schemas.openxmlformats.org/drawingml/2006/main">
               <a:ext uri="{FF2B5EF4-FFF2-40B4-BE49-F238E27FC236}">
-                <a16:creationId xmlns:a16="http://schemas.microsoft.com/office/drawing/2014/main" id="{BE5C8790-7915-4D19-BF91-DF2CBAED7E29}"/>
+                <a16:creationId xmlns:a16="http://schemas.microsoft.com/office/drawing/2014/main" id="{0DE59E44-EAEA-4EFF-8371-0FEF491CE706}"/>
               </a:ext>
             </a:extLst>
           </p:cNvPr>
@@ -19066,7 +19113,7 @@
           <p:cNvPr id="12" name="text">
             <a:extLst xmlns:a="http://schemas.openxmlformats.org/drawingml/2006/main">
               <a:ext uri="{FF2B5EF4-FFF2-40B4-BE49-F238E27FC236}">
-                <a16:creationId xmlns:a16="http://schemas.microsoft.com/office/drawing/2014/main" id="{12B5B76C-7614-42DE-A81D-9D65A3D0F0D3}"/>
+                <a16:creationId xmlns:a16="http://schemas.microsoft.com/office/drawing/2014/main" id="{FD89793C-A376-4E7E-8F62-712703235459}"/>
               </a:ext>
             </a:extLst>
           </p:cNvPr>
@@ -19123,7 +19170,7 @@
           <p:cNvPr id="13" name="text">
             <a:extLst xmlns:a="http://schemas.openxmlformats.org/drawingml/2006/main">
               <a:ext uri="{FF2B5EF4-FFF2-40B4-BE49-F238E27FC236}">
-                <a16:creationId xmlns:a16="http://schemas.microsoft.com/office/drawing/2014/main" id="{0CD14DB3-E897-4586-9636-F1BFEBD2653A}"/>
+                <a16:creationId xmlns:a16="http://schemas.microsoft.com/office/drawing/2014/main" id="{A0108D4C-22FB-4BC6-BAB9-5047023C8DB0}"/>
               </a:ext>
             </a:extLst>
           </p:cNvPr>
@@ -19180,7 +19227,7 @@
           <p:cNvPr id="14" name="text">
             <a:extLst xmlns:a="http://schemas.openxmlformats.org/drawingml/2006/main">
               <a:ext uri="{FF2B5EF4-FFF2-40B4-BE49-F238E27FC236}">
-                <a16:creationId xmlns:a16="http://schemas.microsoft.com/office/drawing/2014/main" id="{7C660DAE-90DE-4735-B495-6EBBC21F0C17}"/>
+                <a16:creationId xmlns:a16="http://schemas.microsoft.com/office/drawing/2014/main" id="{2E529090-5D97-49B0-ACB6-32668E5D7297}"/>
               </a:ext>
             </a:extLst>
           </p:cNvPr>
@@ -19237,7 +19284,7 @@
           <p:cNvPr id="15" name="text">
             <a:extLst xmlns:a="http://schemas.openxmlformats.org/drawingml/2006/main">
               <a:ext uri="{FF2B5EF4-FFF2-40B4-BE49-F238E27FC236}">
-                <a16:creationId xmlns:a16="http://schemas.microsoft.com/office/drawing/2014/main" id="{67CB557D-7D42-4B7C-A5F7-AC37582B6334}"/>
+                <a16:creationId xmlns:a16="http://schemas.microsoft.com/office/drawing/2014/main" id="{925986DB-7259-4366-9F6B-3D515D564E62}"/>
               </a:ext>
             </a:extLst>
           </p:cNvPr>
@@ -19294,7 +19341,7 @@
           <p:cNvPr id="16" name="text">
             <a:extLst xmlns:a="http://schemas.openxmlformats.org/drawingml/2006/main">
               <a:ext uri="{FF2B5EF4-FFF2-40B4-BE49-F238E27FC236}">
-                <a16:creationId xmlns:a16="http://schemas.microsoft.com/office/drawing/2014/main" id="{9724A3B1-EBE8-443A-9C49-B74C59151B6F}"/>
+                <a16:creationId xmlns:a16="http://schemas.microsoft.com/office/drawing/2014/main" id="{CABACC58-D843-433E-814E-FAECBFB523AD}"/>
               </a:ext>
             </a:extLst>
           </p:cNvPr>
@@ -19351,7 +19398,7 @@
           <p:cNvPr id="17" name="text">
             <a:extLst xmlns:a="http://schemas.openxmlformats.org/drawingml/2006/main">
               <a:ext uri="{FF2B5EF4-FFF2-40B4-BE49-F238E27FC236}">
-                <a16:creationId xmlns:a16="http://schemas.microsoft.com/office/drawing/2014/main" id="{E8C80CF1-5C3C-42AF-B5A5-0457692C5CED}"/>
+                <a16:creationId xmlns:a16="http://schemas.microsoft.com/office/drawing/2014/main" id="{9DE62BE7-B25F-49AD-B35C-3514BF98AEBB}"/>
               </a:ext>
             </a:extLst>
           </p:cNvPr>
@@ -19431,7 +19478,7 @@
           <p:cNvPr id="18" name="Slide number">
             <a:extLst xmlns:a="http://schemas.openxmlformats.org/drawingml/2006/main">
               <a:ext uri="{FF2B5EF4-FFF2-40B4-BE49-F238E27FC236}">
-                <a16:creationId xmlns:a16="http://schemas.microsoft.com/office/drawing/2014/main" id="{6A09BCF9-F9F4-4B21-8B37-C9DB623F2FF3}"/>
+                <a16:creationId xmlns:a16="http://schemas.microsoft.com/office/drawing/2014/main" id="{A344E1AD-82E5-4370-8666-CD842936F56E}"/>
               </a:ext>
             </a:extLst>
           </p:cNvPr>
@@ -19486,7 +19533,7 @@
     </p:spTree>
     <p:extLst>
       <p:ext uri="{BB962C8B-B14F-4D97-AF65-F5344CB8AC3E}">
-        <p14:creationId xmlns:p14="http://schemas.microsoft.com/office/powerpoint/2010/main" val="301391236"/>
+        <p14:creationId xmlns:p14="http://schemas.microsoft.com/office/powerpoint/2010/main" val="1645740287"/>
       </p:ext>
     </p:extLst>
   </p:cSld>
@@ -19517,7 +19564,7 @@
           <p:cNvPr id="4" name="Title">
             <a:extLst xmlns:a="http://schemas.openxmlformats.org/drawingml/2006/main">
               <a:ext uri="{FF2B5EF4-FFF2-40B4-BE49-F238E27FC236}">
-                <a16:creationId xmlns:a16="http://schemas.microsoft.com/office/drawing/2014/main" id="{EF6DD78C-D289-4208-91C8-A0107F54A2A0}"/>
+                <a16:creationId xmlns:a16="http://schemas.microsoft.com/office/drawing/2014/main" id="{79B1B30B-7CCA-4382-901F-EA8130E3E11B}"/>
               </a:ext>
             </a:extLst>
           </p:cNvPr>
@@ -19597,7 +19644,7 @@
           <p:cNvPr id="2" name="text">
             <a:extLst xmlns:a="http://schemas.openxmlformats.org/drawingml/2006/main">
               <a:ext uri="{FF2B5EF4-FFF2-40B4-BE49-F238E27FC236}">
-                <a16:creationId xmlns:a16="http://schemas.microsoft.com/office/drawing/2014/main" id="{50792166-A3F7-4043-A4AF-8065CC40DA2A}"/>
+                <a16:creationId xmlns:a16="http://schemas.microsoft.com/office/drawing/2014/main" id="{EECF0200-ED33-4C75-AB87-AC7AFF9CCE70}"/>
               </a:ext>
             </a:extLst>
           </p:cNvPr>
@@ -19677,7 +19724,7 @@
           <p:cNvPr id="3" name="Slide number">
             <a:extLst xmlns:a="http://schemas.openxmlformats.org/drawingml/2006/main">
               <a:ext uri="{FF2B5EF4-FFF2-40B4-BE49-F238E27FC236}">
-                <a16:creationId xmlns:a16="http://schemas.microsoft.com/office/drawing/2014/main" id="{363F7F71-82CE-48E7-A497-B6E2D843C9C1}"/>
+                <a16:creationId xmlns:a16="http://schemas.microsoft.com/office/drawing/2014/main" id="{34799F64-4739-4809-980A-B1DFC3662113}"/>
               </a:ext>
             </a:extLst>
           </p:cNvPr>
@@ -19732,7 +19779,7 @@
     </p:spTree>
     <p:extLst>
       <p:ext uri="{BB962C8B-B14F-4D97-AF65-F5344CB8AC3E}">
-        <p14:creationId xmlns:p14="http://schemas.microsoft.com/office/powerpoint/2010/main" val="2038103393"/>
+        <p14:creationId xmlns:p14="http://schemas.microsoft.com/office/powerpoint/2010/main" val="641453245"/>
       </p:ext>
     </p:extLst>
   </p:cSld>
@@ -19763,7 +19810,7 @@
           <p:cNvPr id="4" name="Title">
             <a:extLst xmlns:a="http://schemas.openxmlformats.org/drawingml/2006/main">
               <a:ext uri="{FF2B5EF4-FFF2-40B4-BE49-F238E27FC236}">
-                <a16:creationId xmlns:a16="http://schemas.microsoft.com/office/drawing/2014/main" id="{D90346CE-F91C-4FD6-AC85-2156F4CD63BB}"/>
+                <a16:creationId xmlns:a16="http://schemas.microsoft.com/office/drawing/2014/main" id="{7881AD34-EBAF-4F7C-A9B2-3B2C395C0022}"/>
               </a:ext>
             </a:extLst>
           </p:cNvPr>
@@ -19843,7 +19890,7 @@
           <p:cNvPr id="2" name="text">
             <a:extLst xmlns:a="http://schemas.openxmlformats.org/drawingml/2006/main">
               <a:ext uri="{FF2B5EF4-FFF2-40B4-BE49-F238E27FC236}">
-                <a16:creationId xmlns:a16="http://schemas.microsoft.com/office/drawing/2014/main" id="{62B27858-1BC0-4820-AB12-C2682D4C3CF4}"/>
+                <a16:creationId xmlns:a16="http://schemas.microsoft.com/office/drawing/2014/main" id="{EE1E06AF-D30B-46D8-A6D2-325DB2718F48}"/>
               </a:ext>
             </a:extLst>
           </p:cNvPr>
@@ -19900,7 +19947,7 @@
           <p:cNvPr id="3" name="Slide number">
             <a:extLst xmlns:a="http://schemas.openxmlformats.org/drawingml/2006/main">
               <a:ext uri="{FF2B5EF4-FFF2-40B4-BE49-F238E27FC236}">
-                <a16:creationId xmlns:a16="http://schemas.microsoft.com/office/drawing/2014/main" id="{7D760A4B-FCEA-4352-AC81-6FACCFDB1F73}"/>
+                <a16:creationId xmlns:a16="http://schemas.microsoft.com/office/drawing/2014/main" id="{1837BC1C-56CE-4D4E-A3A2-7835BD892C0D}"/>
               </a:ext>
             </a:extLst>
           </p:cNvPr>
@@ -19955,7 +20002,7 @@
     </p:spTree>
     <p:extLst>
       <p:ext uri="{BB962C8B-B14F-4D97-AF65-F5344CB8AC3E}">
-        <p14:creationId xmlns:p14="http://schemas.microsoft.com/office/powerpoint/2010/main" val="1548503487"/>
+        <p14:creationId xmlns:p14="http://schemas.microsoft.com/office/powerpoint/2010/main" val="118407966"/>
       </p:ext>
     </p:extLst>
   </p:cSld>
@@ -19986,7 +20033,7 @@
           <p:cNvPr id="4" name="Title">
             <a:extLst xmlns:a="http://schemas.openxmlformats.org/drawingml/2006/main">
               <a:ext uri="{FF2B5EF4-FFF2-40B4-BE49-F238E27FC236}">
-                <a16:creationId xmlns:a16="http://schemas.microsoft.com/office/drawing/2014/main" id="{ED70B743-3298-4F1F-B874-DBC43D4BA7D2}"/>
+                <a16:creationId xmlns:a16="http://schemas.microsoft.com/office/drawing/2014/main" id="{F0EF91FA-0984-46C6-A9A3-5236D7DBC48C}"/>
               </a:ext>
             </a:extLst>
           </p:cNvPr>
@@ -20066,7 +20113,7 @@
           <p:cNvPr id="2" name="text">
             <a:extLst xmlns:a="http://schemas.openxmlformats.org/drawingml/2006/main">
               <a:ext uri="{FF2B5EF4-FFF2-40B4-BE49-F238E27FC236}">
-                <a16:creationId xmlns:a16="http://schemas.microsoft.com/office/drawing/2014/main" id="{BF785D3B-18E4-46C1-8EE6-11F20870FB3B}"/>
+                <a16:creationId xmlns:a16="http://schemas.microsoft.com/office/drawing/2014/main" id="{54AEDEB5-43D2-472E-A94E-3C43014FFC15}"/>
               </a:ext>
             </a:extLst>
           </p:cNvPr>
@@ -20123,7 +20170,7 @@
           <p:cNvPr id="3" name="Slide number">
             <a:extLst xmlns:a="http://schemas.openxmlformats.org/drawingml/2006/main">
               <a:ext uri="{FF2B5EF4-FFF2-40B4-BE49-F238E27FC236}">
-                <a16:creationId xmlns:a16="http://schemas.microsoft.com/office/drawing/2014/main" id="{6C47BD3C-2F15-40A7-B423-7E512443E358}"/>
+                <a16:creationId xmlns:a16="http://schemas.microsoft.com/office/drawing/2014/main" id="{D09C8F64-A73B-4150-99E4-E216A2BF214E}"/>
               </a:ext>
             </a:extLst>
           </p:cNvPr>
@@ -20178,7 +20225,7 @@
     </p:spTree>
     <p:extLst>
       <p:ext uri="{BB962C8B-B14F-4D97-AF65-F5344CB8AC3E}">
-        <p14:creationId xmlns:p14="http://schemas.microsoft.com/office/powerpoint/2010/main" val="366890337"/>
+        <p14:creationId xmlns:p14="http://schemas.microsoft.com/office/powerpoint/2010/main" val="768007193"/>
       </p:ext>
     </p:extLst>
   </p:cSld>
@@ -20213,7 +20260,7 @@
           <p:nvPr/>
         </p:nvPicPr>
         <p:blipFill>
-          <a:blip xmlns:r="http://schemas.openxmlformats.org/officeDocument/2006/relationships" xmlns:a="http://schemas.openxmlformats.org/drawingml/2006/main" r:embed="R24a9221abee34600"/>
+          <a:blip xmlns:r="http://schemas.openxmlformats.org/officeDocument/2006/relationships" xmlns:a="http://schemas.openxmlformats.org/drawingml/2006/main" r:embed="R586e434493a54a14"/>
           <a:srcRect xmlns:a="http://schemas.openxmlformats.org/drawingml/2006/main" l="0" t="0" r="0" b="0"/>
           <a:stretch xmlns:a="http://schemas.openxmlformats.org/drawingml/2006/main">
             <a:fillRect l="0" t="0" r="0" b="0"/>
@@ -20234,7 +20281,7 @@
           <p:cNvPr id="2" name="Title">
             <a:extLst xmlns:a="http://schemas.openxmlformats.org/drawingml/2006/main">
               <a:ext uri="{FF2B5EF4-FFF2-40B4-BE49-F238E27FC236}">
-                <a16:creationId xmlns:a16="http://schemas.microsoft.com/office/drawing/2014/main" id="{C8580D4A-671F-44C7-AA9D-40568DB1C1AB}"/>
+                <a16:creationId xmlns:a16="http://schemas.microsoft.com/office/drawing/2014/main" id="{2FD13C49-3D25-420B-9F07-19CC8C47ADDA}"/>
               </a:ext>
             </a:extLst>
           </p:cNvPr>
@@ -20291,7 +20338,7 @@
           <p:cNvPr id="3" name="Title">
             <a:extLst xmlns:a="http://schemas.openxmlformats.org/drawingml/2006/main">
               <a:ext uri="{FF2B5EF4-FFF2-40B4-BE49-F238E27FC236}">
-                <a16:creationId xmlns:a16="http://schemas.microsoft.com/office/drawing/2014/main" id="{043D4EDA-8A7F-4F93-943A-47EAC234E5F3}"/>
+                <a16:creationId xmlns:a16="http://schemas.microsoft.com/office/drawing/2014/main" id="{2E82110B-32E9-40B6-83C3-28BDD3C379D5}"/>
               </a:ext>
             </a:extLst>
           </p:cNvPr>
@@ -20348,7 +20395,7 @@
           <p:cNvPr id="4" name="Credentials">
             <a:extLst xmlns:a="http://schemas.openxmlformats.org/drawingml/2006/main">
               <a:ext uri="{FF2B5EF4-FFF2-40B4-BE49-F238E27FC236}">
-                <a16:creationId xmlns:a16="http://schemas.microsoft.com/office/drawing/2014/main" id="{781688B3-5CC5-47B3-AF18-B256B6D3BA22}"/>
+                <a16:creationId xmlns:a16="http://schemas.microsoft.com/office/drawing/2014/main" id="{78B64D60-0D7B-4587-8C47-FCC5E1AF27CD}"/>
               </a:ext>
             </a:extLst>
           </p:cNvPr>
@@ -20405,7 +20452,7 @@
           <p:cNvPr id="5" name="Experience">
             <a:extLst xmlns:a="http://schemas.openxmlformats.org/drawingml/2006/main">
               <a:ext uri="{FF2B5EF4-FFF2-40B4-BE49-F238E27FC236}">
-                <a16:creationId xmlns:a16="http://schemas.microsoft.com/office/drawing/2014/main" id="{89AEA86C-4BBB-4E70-8ABF-A6911C3CA1C8}"/>
+                <a16:creationId xmlns:a16="http://schemas.microsoft.com/office/drawing/2014/main" id="{B100D47E-30A2-4B93-9048-C09A077E179E}"/>
               </a:ext>
             </a:extLst>
           </p:cNvPr>
@@ -20462,7 +20509,7 @@
           <p:cNvPr id="6" name="Website">
             <a:extLst xmlns:a="http://schemas.openxmlformats.org/drawingml/2006/main">
               <a:ext uri="{FF2B5EF4-FFF2-40B4-BE49-F238E27FC236}">
-                <a16:creationId xmlns:a16="http://schemas.microsoft.com/office/drawing/2014/main" id="{D1274EF2-18CA-4264-8D5F-802C920CE256}"/>
+                <a16:creationId xmlns:a16="http://schemas.microsoft.com/office/drawing/2014/main" id="{0A795F41-F790-4968-BAB6-B5CFA32095D7}"/>
               </a:ext>
             </a:extLst>
           </p:cNvPr>
@@ -20519,7 +20566,7 @@
           <p:cNvPr id="7" name="Slide number">
             <a:extLst xmlns:a="http://schemas.openxmlformats.org/drawingml/2006/main">
               <a:ext uri="{FF2B5EF4-FFF2-40B4-BE49-F238E27FC236}">
-                <a16:creationId xmlns:a16="http://schemas.microsoft.com/office/drawing/2014/main" id="{F1A30403-2C02-4EFE-9C46-0194DA96BDFB}"/>
+                <a16:creationId xmlns:a16="http://schemas.microsoft.com/office/drawing/2014/main" id="{423F2320-46FF-454C-AAA7-29BAEC06C48D}"/>
               </a:ext>
             </a:extLst>
           </p:cNvPr>
@@ -20574,7 +20621,7 @@
     </p:spTree>
     <p:extLst>
       <p:ext uri="{BB962C8B-B14F-4D97-AF65-F5344CB8AC3E}">
-        <p14:creationId xmlns:p14="http://schemas.microsoft.com/office/powerpoint/2010/main" val="1198151197"/>
+        <p14:creationId xmlns:p14="http://schemas.microsoft.com/office/powerpoint/2010/main" val="965188646"/>
       </p:ext>
     </p:extLst>
   </p:cSld>
@@ -20605,7 +20652,7 @@
           <p:cNvPr id="10" name="Title">
             <a:extLst xmlns:a="http://schemas.openxmlformats.org/drawingml/2006/main">
               <a:ext uri="{FF2B5EF4-FFF2-40B4-BE49-F238E27FC236}">
-                <a16:creationId xmlns:a16="http://schemas.microsoft.com/office/drawing/2014/main" id="{57DCEE60-3BEE-4CA3-8051-1146475584C3}"/>
+                <a16:creationId xmlns:a16="http://schemas.microsoft.com/office/drawing/2014/main" id="{34574421-8327-4D03-9ED3-2982045E87C6}"/>
               </a:ext>
             </a:extLst>
           </p:cNvPr>
@@ -20662,7 +20709,7 @@
           <p:cNvPr id="2" name="Section description 0">
             <a:extLst xmlns:a="http://schemas.openxmlformats.org/drawingml/2006/main">
               <a:ext uri="{FF2B5EF4-FFF2-40B4-BE49-F238E27FC236}">
-                <a16:creationId xmlns:a16="http://schemas.microsoft.com/office/drawing/2014/main" id="{A18FF01E-E4FD-489F-B6A9-34773C086A2D}"/>
+                <a16:creationId xmlns:a16="http://schemas.microsoft.com/office/drawing/2014/main" id="{1EFA5945-B639-4FB8-B560-302724BD359B}"/>
               </a:ext>
             </a:extLst>
           </p:cNvPr>
@@ -20723,7 +20770,7 @@
           <p:nvPr/>
         </p:nvPicPr>
         <p:blipFill>
-          <a:blip xmlns:r="http://schemas.openxmlformats.org/officeDocument/2006/relationships" xmlns:a="http://schemas.openxmlformats.org/drawingml/2006/main" r:embed="Rd6cc8b9dc0064170"/>
+          <a:blip xmlns:r="http://schemas.openxmlformats.org/officeDocument/2006/relationships" xmlns:a="http://schemas.openxmlformats.org/drawingml/2006/main" r:embed="R60d5379dfb594bdc"/>
           <a:stretch xmlns:a="http://schemas.openxmlformats.org/drawingml/2006/main"/>
         </p:blipFill>
         <p:spPr>
@@ -20745,7 +20792,7 @@
           <p:nvPr/>
         </p:nvPicPr>
         <p:blipFill>
-          <a:blip xmlns:r="http://schemas.openxmlformats.org/officeDocument/2006/relationships" xmlns:a="http://schemas.openxmlformats.org/drawingml/2006/main" r:embed="Rd58c47805fc4414a"/>
+          <a:blip xmlns:r="http://schemas.openxmlformats.org/officeDocument/2006/relationships" xmlns:a="http://schemas.openxmlformats.org/drawingml/2006/main" r:embed="Rbaa3cfd0c8c9424c"/>
           <a:stretch xmlns:a="http://schemas.openxmlformats.org/drawingml/2006/main"/>
         </p:blipFill>
         <p:spPr>
@@ -20767,7 +20814,7 @@
           <p:nvPr/>
         </p:nvPicPr>
         <p:blipFill>
-          <a:blip xmlns:r="http://schemas.openxmlformats.org/officeDocument/2006/relationships" xmlns:a="http://schemas.openxmlformats.org/drawingml/2006/main" r:embed="R325e58fcb46c4a63"/>
+          <a:blip xmlns:r="http://schemas.openxmlformats.org/officeDocument/2006/relationships" xmlns:a="http://schemas.openxmlformats.org/drawingml/2006/main" r:embed="Rd1449189056d4c33"/>
           <a:stretch xmlns:a="http://schemas.openxmlformats.org/drawingml/2006/main"/>
         </p:blipFill>
         <p:spPr>
@@ -20789,7 +20836,7 @@
           <p:nvPr/>
         </p:nvPicPr>
         <p:blipFill>
-          <a:blip xmlns:r="http://schemas.openxmlformats.org/officeDocument/2006/relationships" xmlns:a="http://schemas.openxmlformats.org/drawingml/2006/main" r:embed="Rbf560fb80852494b"/>
+          <a:blip xmlns:r="http://schemas.openxmlformats.org/officeDocument/2006/relationships" xmlns:a="http://schemas.openxmlformats.org/drawingml/2006/main" r:embed="R616a3f12fcd94f4c"/>
           <a:stretch xmlns:a="http://schemas.openxmlformats.org/drawingml/2006/main"/>
         </p:blipFill>
         <p:spPr>
@@ -20811,7 +20858,7 @@
           <p:nvPr/>
         </p:nvPicPr>
         <p:blipFill>
-          <a:blip xmlns:r="http://schemas.openxmlformats.org/officeDocument/2006/relationships" xmlns:a="http://schemas.openxmlformats.org/drawingml/2006/main" r:embed="R3186a3db6e604ae4"/>
+          <a:blip xmlns:r="http://schemas.openxmlformats.org/officeDocument/2006/relationships" xmlns:a="http://schemas.openxmlformats.org/drawingml/2006/main" r:embed="Ra2efd9d936b84c31"/>
           <a:stretch xmlns:a="http://schemas.openxmlformats.org/drawingml/2006/main"/>
         </p:blipFill>
         <p:spPr>
@@ -20833,7 +20880,7 @@
           <p:nvPr/>
         </p:nvPicPr>
         <p:blipFill>
-          <a:blip xmlns:r="http://schemas.openxmlformats.org/officeDocument/2006/relationships" xmlns:a="http://schemas.openxmlformats.org/drawingml/2006/main" r:embed="R63d4bba53cf6456d"/>
+          <a:blip xmlns:r="http://schemas.openxmlformats.org/officeDocument/2006/relationships" xmlns:a="http://schemas.openxmlformats.org/drawingml/2006/main" r:embed="R41d994cf918b45dd"/>
           <a:stretch xmlns:a="http://schemas.openxmlformats.org/drawingml/2006/main"/>
         </p:blipFill>
         <p:spPr>
@@ -20851,7 +20898,7 @@
           <p:cNvPr id="9" name="Slide number">
             <a:extLst xmlns:a="http://schemas.openxmlformats.org/drawingml/2006/main">
               <a:ext uri="{FF2B5EF4-FFF2-40B4-BE49-F238E27FC236}">
-                <a16:creationId xmlns:a16="http://schemas.microsoft.com/office/drawing/2014/main" id="{DED9BCAB-E313-4BDC-BF3E-F0D0A372CF77}"/>
+                <a16:creationId xmlns:a16="http://schemas.microsoft.com/office/drawing/2014/main" id="{B675EA72-8DB0-4D12-9F71-CF27336D855B}"/>
               </a:ext>
             </a:extLst>
           </p:cNvPr>
@@ -20906,7 +20953,7 @@
     </p:spTree>
     <p:extLst>
       <p:ext uri="{BB962C8B-B14F-4D97-AF65-F5344CB8AC3E}">
-        <p14:creationId xmlns:p14="http://schemas.microsoft.com/office/powerpoint/2010/main" val="1259718706"/>
+        <p14:creationId xmlns:p14="http://schemas.microsoft.com/office/powerpoint/2010/main" val="1597524118"/>
       </p:ext>
     </p:extLst>
   </p:cSld>
@@ -20937,7 +20984,7 @@
           <p:cNvPr id="20" name="Title">
             <a:extLst xmlns:a="http://schemas.openxmlformats.org/drawingml/2006/main">
               <a:ext uri="{FF2B5EF4-FFF2-40B4-BE49-F238E27FC236}">
-                <a16:creationId xmlns:a16="http://schemas.microsoft.com/office/drawing/2014/main" id="{45CF65B4-4318-45F3-AB47-091A6FB75C7D}"/>
+                <a16:creationId xmlns:a16="http://schemas.microsoft.com/office/drawing/2014/main" id="{2C6A9527-FCF4-4387-9BA7-59CE7463FA7A}"/>
               </a:ext>
             </a:extLst>
           </p:cNvPr>
@@ -20994,7 +21041,7 @@
           <p:cNvPr id="2" name="text">
             <a:extLst xmlns:a="http://schemas.openxmlformats.org/drawingml/2006/main">
               <a:ext uri="{FF2B5EF4-FFF2-40B4-BE49-F238E27FC236}">
-                <a16:creationId xmlns:a16="http://schemas.microsoft.com/office/drawing/2014/main" id="{6B87C44F-F972-40AF-ACB5-9E8D119434F5}"/>
+                <a16:creationId xmlns:a16="http://schemas.microsoft.com/office/drawing/2014/main" id="{A83D6ADF-ADCD-4AB1-8BE5-CB9D28A385E0}"/>
               </a:ext>
             </a:extLst>
           </p:cNvPr>
@@ -21051,7 +21098,7 @@
           <p:cNvPr id="3" name="text">
             <a:extLst xmlns:a="http://schemas.openxmlformats.org/drawingml/2006/main">
               <a:ext uri="{FF2B5EF4-FFF2-40B4-BE49-F238E27FC236}">
-                <a16:creationId xmlns:a16="http://schemas.microsoft.com/office/drawing/2014/main" id="{F917D12C-4FBE-4A72-BAF2-3ED32129D061}"/>
+                <a16:creationId xmlns:a16="http://schemas.microsoft.com/office/drawing/2014/main" id="{4ABF9F20-657B-4430-B9DC-9D5435AC95DE}"/>
               </a:ext>
             </a:extLst>
           </p:cNvPr>
@@ -21108,7 +21155,7 @@
           <p:cNvPr id="4" name="text">
             <a:extLst xmlns:a="http://schemas.openxmlformats.org/drawingml/2006/main">
               <a:ext uri="{FF2B5EF4-FFF2-40B4-BE49-F238E27FC236}">
-                <a16:creationId xmlns:a16="http://schemas.microsoft.com/office/drawing/2014/main" id="{1A4B6C67-450C-4ED2-84F9-60AC15E63D24}"/>
+                <a16:creationId xmlns:a16="http://schemas.microsoft.com/office/drawing/2014/main" id="{12788574-B8A0-429C-B1F1-FF1DC1DC8F19}"/>
               </a:ext>
             </a:extLst>
           </p:cNvPr>
@@ -21165,7 +21212,7 @@
           <p:cNvPr id="5" name="text">
             <a:extLst xmlns:a="http://schemas.openxmlformats.org/drawingml/2006/main">
               <a:ext uri="{FF2B5EF4-FFF2-40B4-BE49-F238E27FC236}">
-                <a16:creationId xmlns:a16="http://schemas.microsoft.com/office/drawing/2014/main" id="{8A1BF6F0-A1EB-4D74-A633-231AFCF8CF82}"/>
+                <a16:creationId xmlns:a16="http://schemas.microsoft.com/office/drawing/2014/main" id="{AC977ACE-98E7-46D1-949B-A38F78BA8BB8}"/>
               </a:ext>
             </a:extLst>
           </p:cNvPr>
@@ -21222,7 +21269,7 @@
           <p:cNvPr id="6" name="text">
             <a:extLst xmlns:a="http://schemas.openxmlformats.org/drawingml/2006/main">
               <a:ext uri="{FF2B5EF4-FFF2-40B4-BE49-F238E27FC236}">
-                <a16:creationId xmlns:a16="http://schemas.microsoft.com/office/drawing/2014/main" id="{E4EBCD23-74B8-45F5-AAD1-1C0880082779}"/>
+                <a16:creationId xmlns:a16="http://schemas.microsoft.com/office/drawing/2014/main" id="{550EE34D-E3E4-42CA-BA35-41930EC81312}"/>
               </a:ext>
             </a:extLst>
           </p:cNvPr>
@@ -21279,7 +21326,7 @@
           <p:cNvPr id="7" name="text">
             <a:extLst xmlns:a="http://schemas.openxmlformats.org/drawingml/2006/main">
               <a:ext uri="{FF2B5EF4-FFF2-40B4-BE49-F238E27FC236}">
-                <a16:creationId xmlns:a16="http://schemas.microsoft.com/office/drawing/2014/main" id="{3D58FDC8-BB17-4C80-ACE4-D77008D2D64B}"/>
+                <a16:creationId xmlns:a16="http://schemas.microsoft.com/office/drawing/2014/main" id="{6673C8CB-FE0D-4BD0-B7E2-653807BF9685}"/>
               </a:ext>
             </a:extLst>
           </p:cNvPr>
@@ -21336,7 +21383,7 @@
           <p:cNvPr id="8" name="text">
             <a:extLst xmlns:a="http://schemas.openxmlformats.org/drawingml/2006/main">
               <a:ext uri="{FF2B5EF4-FFF2-40B4-BE49-F238E27FC236}">
-                <a16:creationId xmlns:a16="http://schemas.microsoft.com/office/drawing/2014/main" id="{01D79CCA-8A11-48C0-AD25-0388D7D552BC}"/>
+                <a16:creationId xmlns:a16="http://schemas.microsoft.com/office/drawing/2014/main" id="{2B872F40-4AB8-470A-8A8C-55D0B2C73907}"/>
               </a:ext>
             </a:extLst>
           </p:cNvPr>
@@ -21393,7 +21440,7 @@
           <p:cNvPr id="9" name="text">
             <a:extLst xmlns:a="http://schemas.openxmlformats.org/drawingml/2006/main">
               <a:ext uri="{FF2B5EF4-FFF2-40B4-BE49-F238E27FC236}">
-                <a16:creationId xmlns:a16="http://schemas.microsoft.com/office/drawing/2014/main" id="{2BA0EA72-7784-4E03-A3E3-E732AABC4A51}"/>
+                <a16:creationId xmlns:a16="http://schemas.microsoft.com/office/drawing/2014/main" id="{4CF3889F-58DF-4496-A921-150215D5BD01}"/>
               </a:ext>
             </a:extLst>
           </p:cNvPr>
@@ -21450,7 +21497,7 @@
           <p:cNvPr id="10" name="text">
             <a:extLst xmlns:a="http://schemas.openxmlformats.org/drawingml/2006/main">
               <a:ext uri="{FF2B5EF4-FFF2-40B4-BE49-F238E27FC236}">
-                <a16:creationId xmlns:a16="http://schemas.microsoft.com/office/drawing/2014/main" id="{32F77AA7-8DF2-450D-AFEC-6E39808D1EFC}"/>
+                <a16:creationId xmlns:a16="http://schemas.microsoft.com/office/drawing/2014/main" id="{D7F86EB8-6B38-4BD7-AAEE-FB277A7E3DA1}"/>
               </a:ext>
             </a:extLst>
           </p:cNvPr>
@@ -21507,7 +21554,7 @@
           <p:cNvPr id="11" name="text">
             <a:extLst xmlns:a="http://schemas.openxmlformats.org/drawingml/2006/main">
               <a:ext uri="{FF2B5EF4-FFF2-40B4-BE49-F238E27FC236}">
-                <a16:creationId xmlns:a16="http://schemas.microsoft.com/office/drawing/2014/main" id="{7C2199DD-F972-4A19-B492-6FD4F327BBAE}"/>
+                <a16:creationId xmlns:a16="http://schemas.microsoft.com/office/drawing/2014/main" id="{18E4B122-082F-4576-B5DA-92B0B916D6FE}"/>
               </a:ext>
             </a:extLst>
           </p:cNvPr>
@@ -21564,7 +21611,7 @@
           <p:cNvPr id="12" name="text">
             <a:extLst xmlns:a="http://schemas.openxmlformats.org/drawingml/2006/main">
               <a:ext uri="{FF2B5EF4-FFF2-40B4-BE49-F238E27FC236}">
-                <a16:creationId xmlns:a16="http://schemas.microsoft.com/office/drawing/2014/main" id="{4A1D9730-7D13-4331-8D7E-00DB0C224FD7}"/>
+                <a16:creationId xmlns:a16="http://schemas.microsoft.com/office/drawing/2014/main" id="{2B167CDD-97F8-4D40-8209-60DC3BBE2ABE}"/>
               </a:ext>
             </a:extLst>
           </p:cNvPr>
@@ -21621,7 +21668,7 @@
           <p:cNvPr id="13" name="text">
             <a:extLst xmlns:a="http://schemas.openxmlformats.org/drawingml/2006/main">
               <a:ext uri="{FF2B5EF4-FFF2-40B4-BE49-F238E27FC236}">
-                <a16:creationId xmlns:a16="http://schemas.microsoft.com/office/drawing/2014/main" id="{77B08489-D672-4419-89F0-C47C3C4DFFD6}"/>
+                <a16:creationId xmlns:a16="http://schemas.microsoft.com/office/drawing/2014/main" id="{5F63B313-5A37-427A-B41B-CFA1254E7C1A}"/>
               </a:ext>
             </a:extLst>
           </p:cNvPr>
@@ -21678,7 +21725,7 @@
           <p:cNvPr id="14" name="text">
             <a:extLst xmlns:a="http://schemas.openxmlformats.org/drawingml/2006/main">
               <a:ext uri="{FF2B5EF4-FFF2-40B4-BE49-F238E27FC236}">
-                <a16:creationId xmlns:a16="http://schemas.microsoft.com/office/drawing/2014/main" id="{D87373DE-0FFD-43BF-AA96-5DC00FA291CB}"/>
+                <a16:creationId xmlns:a16="http://schemas.microsoft.com/office/drawing/2014/main" id="{2AA5752B-D82D-40F8-9BC0-F50E59499C1A}"/>
               </a:ext>
             </a:extLst>
           </p:cNvPr>
@@ -21735,7 +21782,7 @@
           <p:cNvPr id="15" name="text">
             <a:extLst xmlns:a="http://schemas.openxmlformats.org/drawingml/2006/main">
               <a:ext uri="{FF2B5EF4-FFF2-40B4-BE49-F238E27FC236}">
-                <a16:creationId xmlns:a16="http://schemas.microsoft.com/office/drawing/2014/main" id="{DB7C8C21-10D5-4623-A57C-D1A7C0510943}"/>
+                <a16:creationId xmlns:a16="http://schemas.microsoft.com/office/drawing/2014/main" id="{1E9CB0F5-21D6-437A-B28C-B6214FE272A9}"/>
               </a:ext>
             </a:extLst>
           </p:cNvPr>
@@ -21792,7 +21839,7 @@
           <p:cNvPr id="16" name="text">
             <a:extLst xmlns:a="http://schemas.openxmlformats.org/drawingml/2006/main">
               <a:ext uri="{FF2B5EF4-FFF2-40B4-BE49-F238E27FC236}">
-                <a16:creationId xmlns:a16="http://schemas.microsoft.com/office/drawing/2014/main" id="{D78B72B2-6389-4254-944E-3B815BB1F4DB}"/>
+                <a16:creationId xmlns:a16="http://schemas.microsoft.com/office/drawing/2014/main" id="{E98E29B3-B694-4BE5-9655-4C9AF5E4411F}"/>
               </a:ext>
             </a:extLst>
           </p:cNvPr>
@@ -21849,7 +21896,7 @@
           <p:cNvPr id="17" name="text">
             <a:extLst xmlns:a="http://schemas.openxmlformats.org/drawingml/2006/main">
               <a:ext uri="{FF2B5EF4-FFF2-40B4-BE49-F238E27FC236}">
-                <a16:creationId xmlns:a16="http://schemas.microsoft.com/office/drawing/2014/main" id="{12E91AB2-A4FE-4E24-ADA5-A3C1C5111C0A}"/>
+                <a16:creationId xmlns:a16="http://schemas.microsoft.com/office/drawing/2014/main" id="{7FA1420A-EF62-46E5-AFD2-9720533979DE}"/>
               </a:ext>
             </a:extLst>
           </p:cNvPr>
@@ -21906,7 +21953,7 @@
           <p:cNvPr id="18" name="text">
             <a:extLst xmlns:a="http://schemas.openxmlformats.org/drawingml/2006/main">
               <a:ext uri="{FF2B5EF4-FFF2-40B4-BE49-F238E27FC236}">
-                <a16:creationId xmlns:a16="http://schemas.microsoft.com/office/drawing/2014/main" id="{61D1E9FB-C372-40AE-A0C3-E8700D4FD391}"/>
+                <a16:creationId xmlns:a16="http://schemas.microsoft.com/office/drawing/2014/main" id="{606B7A48-3B96-44D4-9A91-798678039B17}"/>
               </a:ext>
             </a:extLst>
           </p:cNvPr>
@@ -21963,7 +22010,7 @@
           <p:cNvPr id="19" name="Slide number">
             <a:extLst xmlns:a="http://schemas.openxmlformats.org/drawingml/2006/main">
               <a:ext uri="{FF2B5EF4-FFF2-40B4-BE49-F238E27FC236}">
-                <a16:creationId xmlns:a16="http://schemas.microsoft.com/office/drawing/2014/main" id="{7CF347DA-E021-4819-87F2-E730A97DD0DC}"/>
+                <a16:creationId xmlns:a16="http://schemas.microsoft.com/office/drawing/2014/main" id="{DB7D3251-4A9C-49EB-A3B0-0C31BE543997}"/>
               </a:ext>
             </a:extLst>
           </p:cNvPr>
@@ -22018,7 +22065,7 @@
     </p:spTree>
     <p:extLst>
       <p:ext uri="{BB962C8B-B14F-4D97-AF65-F5344CB8AC3E}">
-        <p14:creationId xmlns:p14="http://schemas.microsoft.com/office/powerpoint/2010/main" val="1138904478"/>
+        <p14:creationId xmlns:p14="http://schemas.microsoft.com/office/powerpoint/2010/main" val="2104452150"/>
       </p:ext>
     </p:extLst>
   </p:cSld>

</xml_diff>

<commit_message>
fix: lighten PDF chart labels and add final-slide contact QR
</commit_message>
<xml_diff>
--- a/resources/talks/beyond-the-qa-bottleneck.pptx
+++ b/resources/talks/beyond-the-qa-bottleneck.pptx
@@ -2,44 +2,44 @@
 <file path=ppt/presentation.xml><?xml version="1.0" encoding="utf-8"?>
 <p:presentation xmlns:p="http://schemas.openxmlformats.org/presentationml/2006/main">
   <p:sldMasterIdLst>
-    <p:sldMasterId xmlns:r="http://schemas.openxmlformats.org/officeDocument/2006/relationships" id="2147483648" r:id="R34b9207cbafa4854"/>
+    <p:sldMasterId xmlns:r="http://schemas.openxmlformats.org/officeDocument/2006/relationships" id="2147483648" r:id="R724fad4136eb49b9"/>
   </p:sldMasterIdLst>
   <p:notesMasterIdLst>
-    <p:notesMasterId xmlns:r="http://schemas.openxmlformats.org/officeDocument/2006/relationships" r:id="R7957f317abdc4581"/>
+    <p:notesMasterId xmlns:r="http://schemas.openxmlformats.org/officeDocument/2006/relationships" r:id="Rf6cbdd3258ae450e"/>
   </p:notesMasterIdLst>
   <p:sldIdLst>
-    <p:sldId xmlns:r="http://schemas.openxmlformats.org/officeDocument/2006/relationships" id="256" r:id="R1994c819973849f2"/>
-    <p:sldId xmlns:r="http://schemas.openxmlformats.org/officeDocument/2006/relationships" id="257" r:id="Rd00ce983781c4061"/>
-    <p:sldId xmlns:r="http://schemas.openxmlformats.org/officeDocument/2006/relationships" id="258" r:id="R1b02719c9da64065"/>
-    <p:sldId xmlns:r="http://schemas.openxmlformats.org/officeDocument/2006/relationships" id="259" r:id="R36f92ef057a541d0"/>
-    <p:sldId xmlns:r="http://schemas.openxmlformats.org/officeDocument/2006/relationships" id="260" r:id="Rc6145fbbda4a4b8c"/>
-    <p:sldId xmlns:r="http://schemas.openxmlformats.org/officeDocument/2006/relationships" id="261" r:id="Rffa4540e43474127"/>
-    <p:sldId xmlns:r="http://schemas.openxmlformats.org/officeDocument/2006/relationships" id="262" r:id="Ra9921c2af0d64ed9"/>
-    <p:sldId xmlns:r="http://schemas.openxmlformats.org/officeDocument/2006/relationships" id="263" r:id="R406b0995d983479a"/>
-    <p:sldId xmlns:r="http://schemas.openxmlformats.org/officeDocument/2006/relationships" id="264" r:id="R682aae402602403b"/>
-    <p:sldId xmlns:r="http://schemas.openxmlformats.org/officeDocument/2006/relationships" id="265" r:id="R5248af4aaf5e45df"/>
-    <p:sldId xmlns:r="http://schemas.openxmlformats.org/officeDocument/2006/relationships" id="266" r:id="R3adabc427f7e4d4a"/>
-    <p:sldId xmlns:r="http://schemas.openxmlformats.org/officeDocument/2006/relationships" id="267" r:id="R151cf0aa7e424ea3"/>
-    <p:sldId xmlns:r="http://schemas.openxmlformats.org/officeDocument/2006/relationships" id="268" r:id="R1208bb77afe348f2"/>
-    <p:sldId xmlns:r="http://schemas.openxmlformats.org/officeDocument/2006/relationships" id="269" r:id="R2236a163c18d4593"/>
-    <p:sldId xmlns:r="http://schemas.openxmlformats.org/officeDocument/2006/relationships" id="270" r:id="R4ae1dcaa3ade4a4e"/>
-    <p:sldId xmlns:r="http://schemas.openxmlformats.org/officeDocument/2006/relationships" id="271" r:id="R40cc0b6989b340a0"/>
-    <p:sldId xmlns:r="http://schemas.openxmlformats.org/officeDocument/2006/relationships" id="272" r:id="R9cb1bdaeba054fa6"/>
-    <p:sldId xmlns:r="http://schemas.openxmlformats.org/officeDocument/2006/relationships" id="273" r:id="R83f3e8683cdf4b6e"/>
-    <p:sldId xmlns:r="http://schemas.openxmlformats.org/officeDocument/2006/relationships" id="274" r:id="Rc8e3cef4ea474e1c"/>
-    <p:sldId xmlns:r="http://schemas.openxmlformats.org/officeDocument/2006/relationships" id="275" r:id="Re44298092a8142ce"/>
-    <p:sldId xmlns:r="http://schemas.openxmlformats.org/officeDocument/2006/relationships" id="276" r:id="R13920298ec3e4761"/>
-    <p:sldId xmlns:r="http://schemas.openxmlformats.org/officeDocument/2006/relationships" id="277" r:id="R459a63fe225f47ed"/>
-    <p:sldId xmlns:r="http://schemas.openxmlformats.org/officeDocument/2006/relationships" id="278" r:id="R75568fb0593a4ebe"/>
-    <p:sldId xmlns:r="http://schemas.openxmlformats.org/officeDocument/2006/relationships" id="279" r:id="R09fd8b6812a84ac8"/>
-    <p:sldId xmlns:r="http://schemas.openxmlformats.org/officeDocument/2006/relationships" id="280" r:id="R73f8fb79ad394650"/>
-    <p:sldId xmlns:r="http://schemas.openxmlformats.org/officeDocument/2006/relationships" id="281" r:id="R85285ee7d2614d51"/>
-    <p:sldId xmlns:r="http://schemas.openxmlformats.org/officeDocument/2006/relationships" id="282" r:id="R8786eea9661645b8"/>
-    <p:sldId xmlns:r="http://schemas.openxmlformats.org/officeDocument/2006/relationships" id="283" r:id="R5dc553d066364a0d"/>
-    <p:sldId xmlns:r="http://schemas.openxmlformats.org/officeDocument/2006/relationships" id="284" r:id="Rd81eb36d58c247e9"/>
-    <p:sldId xmlns:r="http://schemas.openxmlformats.org/officeDocument/2006/relationships" id="285" r:id="R0ad615dc10dc4fa2"/>
-    <p:sldId xmlns:r="http://schemas.openxmlformats.org/officeDocument/2006/relationships" id="286" r:id="R9f12fef01ead4464"/>
-    <p:sldId xmlns:r="http://schemas.openxmlformats.org/officeDocument/2006/relationships" id="287" r:id="R2e5c92ce8f00403a"/>
+    <p:sldId xmlns:r="http://schemas.openxmlformats.org/officeDocument/2006/relationships" id="256" r:id="R258ca32e915e4eb4"/>
+    <p:sldId xmlns:r="http://schemas.openxmlformats.org/officeDocument/2006/relationships" id="257" r:id="R397d907a106c4405"/>
+    <p:sldId xmlns:r="http://schemas.openxmlformats.org/officeDocument/2006/relationships" id="258" r:id="Ra621ff7fbdfe4ed6"/>
+    <p:sldId xmlns:r="http://schemas.openxmlformats.org/officeDocument/2006/relationships" id="259" r:id="Rc096beb805194c4e"/>
+    <p:sldId xmlns:r="http://schemas.openxmlformats.org/officeDocument/2006/relationships" id="260" r:id="Ra592c6cf1521470d"/>
+    <p:sldId xmlns:r="http://schemas.openxmlformats.org/officeDocument/2006/relationships" id="261" r:id="Ra6efb85d75ff4ac2"/>
+    <p:sldId xmlns:r="http://schemas.openxmlformats.org/officeDocument/2006/relationships" id="262" r:id="Rd8d388fc87c1472b"/>
+    <p:sldId xmlns:r="http://schemas.openxmlformats.org/officeDocument/2006/relationships" id="263" r:id="R4cb7afad5127477e"/>
+    <p:sldId xmlns:r="http://schemas.openxmlformats.org/officeDocument/2006/relationships" id="264" r:id="R983ef58bfd484c56"/>
+    <p:sldId xmlns:r="http://schemas.openxmlformats.org/officeDocument/2006/relationships" id="265" r:id="R40f62009a9f0414b"/>
+    <p:sldId xmlns:r="http://schemas.openxmlformats.org/officeDocument/2006/relationships" id="266" r:id="R1916cd2aed594e3c"/>
+    <p:sldId xmlns:r="http://schemas.openxmlformats.org/officeDocument/2006/relationships" id="267" r:id="Re1e176cf45a748b6"/>
+    <p:sldId xmlns:r="http://schemas.openxmlformats.org/officeDocument/2006/relationships" id="268" r:id="Rfe371b7b7a134a93"/>
+    <p:sldId xmlns:r="http://schemas.openxmlformats.org/officeDocument/2006/relationships" id="269" r:id="R4d5b43d1b2bb4722"/>
+    <p:sldId xmlns:r="http://schemas.openxmlformats.org/officeDocument/2006/relationships" id="270" r:id="Raa9f1cc7b6874f56"/>
+    <p:sldId xmlns:r="http://schemas.openxmlformats.org/officeDocument/2006/relationships" id="271" r:id="Ref618978a2ad459f"/>
+    <p:sldId xmlns:r="http://schemas.openxmlformats.org/officeDocument/2006/relationships" id="272" r:id="R49e420575356445a"/>
+    <p:sldId xmlns:r="http://schemas.openxmlformats.org/officeDocument/2006/relationships" id="273" r:id="R6c39d34a01834aa8"/>
+    <p:sldId xmlns:r="http://schemas.openxmlformats.org/officeDocument/2006/relationships" id="274" r:id="Re734c665095a4464"/>
+    <p:sldId xmlns:r="http://schemas.openxmlformats.org/officeDocument/2006/relationships" id="275" r:id="R6c9350e64dc34e24"/>
+    <p:sldId xmlns:r="http://schemas.openxmlformats.org/officeDocument/2006/relationships" id="276" r:id="R1085c8e73ace4825"/>
+    <p:sldId xmlns:r="http://schemas.openxmlformats.org/officeDocument/2006/relationships" id="277" r:id="R66641f7e7a3d4849"/>
+    <p:sldId xmlns:r="http://schemas.openxmlformats.org/officeDocument/2006/relationships" id="278" r:id="R35abdc4a6e154efb"/>
+    <p:sldId xmlns:r="http://schemas.openxmlformats.org/officeDocument/2006/relationships" id="279" r:id="R1b93426069f04ebb"/>
+    <p:sldId xmlns:r="http://schemas.openxmlformats.org/officeDocument/2006/relationships" id="280" r:id="R6c0db11951df4833"/>
+    <p:sldId xmlns:r="http://schemas.openxmlformats.org/officeDocument/2006/relationships" id="281" r:id="R86734a5ad46e427a"/>
+    <p:sldId xmlns:r="http://schemas.openxmlformats.org/officeDocument/2006/relationships" id="282" r:id="Rdc7104b1429f4df7"/>
+    <p:sldId xmlns:r="http://schemas.openxmlformats.org/officeDocument/2006/relationships" id="283" r:id="R73755d312f3b452b"/>
+    <p:sldId xmlns:r="http://schemas.openxmlformats.org/officeDocument/2006/relationships" id="284" r:id="R92f0fab575014af5"/>
+    <p:sldId xmlns:r="http://schemas.openxmlformats.org/officeDocument/2006/relationships" id="285" r:id="Rb7e24c2bda4b4c54"/>
+    <p:sldId xmlns:r="http://schemas.openxmlformats.org/officeDocument/2006/relationships" id="286" r:id="Re20233323cf54d35"/>
+    <p:sldId xmlns:r="http://schemas.openxmlformats.org/officeDocument/2006/relationships" id="287" r:id="Rb8a4d23628614597"/>
   </p:sldIdLst>
   <p:sldSz cx="12192000" cy="6858000"/>
   <p:notesSz cx="6858000" cy="9144000"/>
@@ -2701,6 +2701,11 @@
               <a:t>• Evidence has limits. Human judgement still matters.</a:t>
             </a:r>
           </a:p>
+          <a:p xmlns:a="http://schemas.openxmlformats.org/drawingml/2006/main">
+            <a:r>
+              <a:t>• QR: social profiles, talks and contact details</a:t>
+            </a:r>
+          </a:p>
         </p:txBody>
       </p:sp>
       <p:sp>
@@ -3286,7 +3291,7 @@
   </p:cSld>
   <p:clrMap bg1="lt1" tx1="dk1" bg2="lt2" tx2="dk2" accent1="accent1" accent2="accent2" accent3="accent3" accent4="accent4" accent5="accent5" accent6="accent6" hlink="hlink" folHlink="folHlink"/>
   <p:sldLayoutIdLst>
-    <p:sldLayoutId xmlns:r="http://schemas.openxmlformats.org/officeDocument/2006/relationships" id="2147483649" r:id="R7428a31d830c48d9"/>
+    <p:sldLayoutId xmlns:r="http://schemas.openxmlformats.org/officeDocument/2006/relationships" id="2147483649" r:id="R834091f62b414adf"/>
   </p:sldLayoutIdLst>
   <p:txStyles>
     <p:titleStyle>
@@ -5459,7 +5464,7 @@
           <p:nvPr/>
         </p:nvPicPr>
         <p:blipFill>
-          <a:blip xmlns:r="http://schemas.openxmlformats.org/officeDocument/2006/relationships" xmlns:a="http://schemas.openxmlformats.org/drawingml/2006/main" r:embed="R17cc45a231dc454f"/>
+          <a:blip xmlns:r="http://schemas.openxmlformats.org/officeDocument/2006/relationships" xmlns:a="http://schemas.openxmlformats.org/drawingml/2006/main" r:embed="Reb8bcd32546f4831"/>
           <a:stretch xmlns:a="http://schemas.openxmlformats.org/drawingml/2006/main"/>
         </p:blipFill>
         <p:spPr>
@@ -5477,7 +5482,7 @@
           <p:cNvPr id="2" name="Deck title">
             <a:extLst xmlns:a="http://schemas.openxmlformats.org/drawingml/2006/main">
               <a:ext uri="{FF2B5EF4-FFF2-40B4-BE49-F238E27FC236}">
-                <a16:creationId xmlns:a16="http://schemas.microsoft.com/office/drawing/2014/main" id="{0BAB2ED4-B3EE-4D0D-BF3A-23AB1289B2A3}"/>
+                <a16:creationId xmlns:a16="http://schemas.microsoft.com/office/drawing/2014/main" id="{8BF84378-BFAE-4A52-BACF-782A78058363}"/>
               </a:ext>
             </a:extLst>
           </p:cNvPr>
@@ -5557,7 +5562,7 @@
           <p:cNvPr id="3" name="text">
             <a:extLst xmlns:a="http://schemas.openxmlformats.org/drawingml/2006/main">
               <a:ext uri="{FF2B5EF4-FFF2-40B4-BE49-F238E27FC236}">
-                <a16:creationId xmlns:a16="http://schemas.microsoft.com/office/drawing/2014/main" id="{2A5E310A-1D1A-4F88-A561-C4A8A76590D0}"/>
+                <a16:creationId xmlns:a16="http://schemas.microsoft.com/office/drawing/2014/main" id="{028F46F9-2339-44D8-A620-A654A01CFC76}"/>
               </a:ext>
             </a:extLst>
           </p:cNvPr>
@@ -5618,7 +5623,7 @@
           <p:nvPr/>
         </p:nvPicPr>
         <p:blipFill>
-          <a:blip xmlns:r="http://schemas.openxmlformats.org/officeDocument/2006/relationships" xmlns:a="http://schemas.openxmlformats.org/drawingml/2006/main" r:embed="R8ba68d6199f8429a"/>
+          <a:blip xmlns:r="http://schemas.openxmlformats.org/officeDocument/2006/relationships" xmlns:a="http://schemas.openxmlformats.org/drawingml/2006/main" r:embed="R2a6ebbf0f606427c"/>
           <a:srcRect xmlns:a="http://schemas.openxmlformats.org/drawingml/2006/main" l="0" t="0" r="0" b="0"/>
           <a:stretch xmlns:a="http://schemas.openxmlformats.org/drawingml/2006/main">
             <a:fillRect l="0" t="0" r="0" b="0"/>
@@ -5639,7 +5644,7 @@
           <p:cNvPr id="5" name="Speaker">
             <a:extLst xmlns:a="http://schemas.openxmlformats.org/drawingml/2006/main">
               <a:ext uri="{FF2B5EF4-FFF2-40B4-BE49-F238E27FC236}">
-                <a16:creationId xmlns:a16="http://schemas.microsoft.com/office/drawing/2014/main" id="{5C8D213C-7827-4B54-BF70-1514550925E6}"/>
+                <a16:creationId xmlns:a16="http://schemas.microsoft.com/office/drawing/2014/main" id="{D2396FD6-FACB-47D6-B7DC-3B71B962008E}"/>
               </a:ext>
             </a:extLst>
           </p:cNvPr>
@@ -5696,7 +5701,7 @@
           <p:cNvPr id="6" name="text">
             <a:extLst xmlns:a="http://schemas.openxmlformats.org/drawingml/2006/main">
               <a:ext uri="{FF2B5EF4-FFF2-40B4-BE49-F238E27FC236}">
-                <a16:creationId xmlns:a16="http://schemas.microsoft.com/office/drawing/2014/main" id="{3210962B-65E1-4C7A-964A-FFB72BDED07D}"/>
+                <a16:creationId xmlns:a16="http://schemas.microsoft.com/office/drawing/2014/main" id="{7924DC62-DF76-494B-89D4-68CE3C64FA2B}"/>
               </a:ext>
             </a:extLst>
           </p:cNvPr>
@@ -5753,7 +5758,7 @@
           <p:cNvPr id="7" name="text">
             <a:extLst xmlns:a="http://schemas.openxmlformats.org/drawingml/2006/main">
               <a:ext uri="{FF2B5EF4-FFF2-40B4-BE49-F238E27FC236}">
-                <a16:creationId xmlns:a16="http://schemas.microsoft.com/office/drawing/2014/main" id="{E45D4DA8-04C2-4521-86CF-73122D882A76}"/>
+                <a16:creationId xmlns:a16="http://schemas.microsoft.com/office/drawing/2014/main" id="{DB2FFA60-2949-425F-A1CC-2092B66DC5AF}"/>
               </a:ext>
             </a:extLst>
           </p:cNvPr>
@@ -5808,7 +5813,7 @@
     </p:spTree>
     <p:extLst>
       <p:ext uri="{BB962C8B-B14F-4D97-AF65-F5344CB8AC3E}">
-        <p14:creationId xmlns:p14="http://schemas.microsoft.com/office/powerpoint/2010/main" val="1033236038"/>
+        <p14:creationId xmlns:p14="http://schemas.microsoft.com/office/powerpoint/2010/main" val="1882413052"/>
       </p:ext>
     </p:extLst>
   </p:cSld>
@@ -5839,7 +5844,7 @@
           <p:cNvPr id="10" name="Title">
             <a:extLst xmlns:a="http://schemas.openxmlformats.org/drawingml/2006/main">
               <a:ext uri="{FF2B5EF4-FFF2-40B4-BE49-F238E27FC236}">
-                <a16:creationId xmlns:a16="http://schemas.microsoft.com/office/drawing/2014/main" id="{BC8CFC50-76D1-456D-8F89-73E55A7F7AD3}"/>
+                <a16:creationId xmlns:a16="http://schemas.microsoft.com/office/drawing/2014/main" id="{2EC7A33B-B62E-4DE2-9BF3-1E9418A7426D}"/>
               </a:ext>
             </a:extLst>
           </p:cNvPr>
@@ -5896,7 +5901,7 @@
           <p:cNvPr id="2" name="text">
             <a:extLst xmlns:a="http://schemas.openxmlformats.org/drawingml/2006/main">
               <a:ext uri="{FF2B5EF4-FFF2-40B4-BE49-F238E27FC236}">
-                <a16:creationId xmlns:a16="http://schemas.microsoft.com/office/drawing/2014/main" id="{969E2D70-30AE-4B09-A415-C520E940A8A8}"/>
+                <a16:creationId xmlns:a16="http://schemas.microsoft.com/office/drawing/2014/main" id="{240DA354-D08D-4EF2-AFFE-A63B92723102}"/>
               </a:ext>
             </a:extLst>
           </p:cNvPr>
@@ -5953,7 +5958,7 @@
           <p:cNvPr id="3" name="text">
             <a:extLst xmlns:a="http://schemas.openxmlformats.org/drawingml/2006/main">
               <a:ext uri="{FF2B5EF4-FFF2-40B4-BE49-F238E27FC236}">
-                <a16:creationId xmlns:a16="http://schemas.microsoft.com/office/drawing/2014/main" id="{67BA27A6-B504-4509-B46E-C0A6A8A956EA}"/>
+                <a16:creationId xmlns:a16="http://schemas.microsoft.com/office/drawing/2014/main" id="{E8415725-98C3-4184-A6C2-A256C6716464}"/>
               </a:ext>
             </a:extLst>
           </p:cNvPr>
@@ -6010,7 +6015,7 @@
           <p:cNvPr id="4" name="text">
             <a:extLst xmlns:a="http://schemas.openxmlformats.org/drawingml/2006/main">
               <a:ext uri="{FF2B5EF4-FFF2-40B4-BE49-F238E27FC236}">
-                <a16:creationId xmlns:a16="http://schemas.microsoft.com/office/drawing/2014/main" id="{5F9DD524-378E-4E0B-BAFF-D4166FD43073}"/>
+                <a16:creationId xmlns:a16="http://schemas.microsoft.com/office/drawing/2014/main" id="{AB8A174F-FC57-429C-BA40-8F6314B26A8C}"/>
               </a:ext>
             </a:extLst>
           </p:cNvPr>
@@ -6067,7 +6072,7 @@
           <p:cNvPr id="5" name="text">
             <a:extLst xmlns:a="http://schemas.openxmlformats.org/drawingml/2006/main">
               <a:ext uri="{FF2B5EF4-FFF2-40B4-BE49-F238E27FC236}">
-                <a16:creationId xmlns:a16="http://schemas.microsoft.com/office/drawing/2014/main" id="{7BB08FBE-566D-4538-B461-0AD25294C8FC}"/>
+                <a16:creationId xmlns:a16="http://schemas.microsoft.com/office/drawing/2014/main" id="{5295A0C6-A055-4006-84C4-02A10E90B3DE}"/>
               </a:ext>
             </a:extLst>
           </p:cNvPr>
@@ -6124,7 +6129,7 @@
           <p:cNvPr id="6" name="text">
             <a:extLst xmlns:a="http://schemas.openxmlformats.org/drawingml/2006/main">
               <a:ext uri="{FF2B5EF4-FFF2-40B4-BE49-F238E27FC236}">
-                <a16:creationId xmlns:a16="http://schemas.microsoft.com/office/drawing/2014/main" id="{348B74E4-233C-4F6E-81FC-F6A84C6B6300}"/>
+                <a16:creationId xmlns:a16="http://schemas.microsoft.com/office/drawing/2014/main" id="{5A636143-3673-44F6-8D6E-B37950734851}"/>
               </a:ext>
             </a:extLst>
           </p:cNvPr>
@@ -6181,7 +6186,7 @@
           <p:cNvPr id="7" name="text">
             <a:extLst xmlns:a="http://schemas.openxmlformats.org/drawingml/2006/main">
               <a:ext uri="{FF2B5EF4-FFF2-40B4-BE49-F238E27FC236}">
-                <a16:creationId xmlns:a16="http://schemas.microsoft.com/office/drawing/2014/main" id="{5CA5FFA8-C62D-4448-904F-789BE4BADDAC}"/>
+                <a16:creationId xmlns:a16="http://schemas.microsoft.com/office/drawing/2014/main" id="{7B5A87E6-2454-4F12-8969-3DF2E82F3037}"/>
               </a:ext>
             </a:extLst>
           </p:cNvPr>
@@ -6238,7 +6243,7 @@
           <p:cNvPr id="8" name="text">
             <a:extLst xmlns:a="http://schemas.openxmlformats.org/drawingml/2006/main">
               <a:ext uri="{FF2B5EF4-FFF2-40B4-BE49-F238E27FC236}">
-                <a16:creationId xmlns:a16="http://schemas.microsoft.com/office/drawing/2014/main" id="{12EB3EAF-3B84-4D36-BE82-5CE73FF3B548}"/>
+                <a16:creationId xmlns:a16="http://schemas.microsoft.com/office/drawing/2014/main" id="{C4F94EA5-232E-4C77-B18F-F956D4EB53D5}"/>
               </a:ext>
             </a:extLst>
           </p:cNvPr>
@@ -6295,7 +6300,7 @@
           <p:cNvPr id="9" name="Slide number">
             <a:extLst xmlns:a="http://schemas.openxmlformats.org/drawingml/2006/main">
               <a:ext uri="{FF2B5EF4-FFF2-40B4-BE49-F238E27FC236}">
-                <a16:creationId xmlns:a16="http://schemas.microsoft.com/office/drawing/2014/main" id="{F3A3702C-29E3-490E-8887-76A1EFAC0A4B}"/>
+                <a16:creationId xmlns:a16="http://schemas.microsoft.com/office/drawing/2014/main" id="{B83A0B54-B163-4095-A2C4-96371CB4B53B}"/>
               </a:ext>
             </a:extLst>
           </p:cNvPr>
@@ -6350,7 +6355,7 @@
     </p:spTree>
     <p:extLst>
       <p:ext uri="{BB962C8B-B14F-4D97-AF65-F5344CB8AC3E}">
-        <p14:creationId xmlns:p14="http://schemas.microsoft.com/office/powerpoint/2010/main" val="2078032149"/>
+        <p14:creationId xmlns:p14="http://schemas.microsoft.com/office/powerpoint/2010/main" val="92756918"/>
       </p:ext>
     </p:extLst>
   </p:cSld>
@@ -6381,7 +6386,7 @@
           <p:cNvPr id="11" name="Completed section 0">
             <a:extLst xmlns:a="http://schemas.openxmlformats.org/drawingml/2006/main">
               <a:ext uri="{FF2B5EF4-FFF2-40B4-BE49-F238E27FC236}">
-                <a16:creationId xmlns:a16="http://schemas.microsoft.com/office/drawing/2014/main" id="{E7494205-5BD3-4DCA-9E04-47F26C3BCA80}"/>
+                <a16:creationId xmlns:a16="http://schemas.microsoft.com/office/drawing/2014/main" id="{1C16225C-E27A-44BB-AD09-80B950A94B73}"/>
               </a:ext>
             </a:extLst>
           </p:cNvPr>
@@ -6438,7 +6443,7 @@
           <p:cNvPr id="2" name="Section description 0">
             <a:extLst xmlns:a="http://schemas.openxmlformats.org/drawingml/2006/main">
               <a:ext uri="{FF2B5EF4-FFF2-40B4-BE49-F238E27FC236}">
-                <a16:creationId xmlns:a16="http://schemas.microsoft.com/office/drawing/2014/main" id="{9679AC10-39BC-42FA-90BA-8277C152A9CA}"/>
+                <a16:creationId xmlns:a16="http://schemas.microsoft.com/office/drawing/2014/main" id="{1C5DCCF8-7850-4684-91F2-E5EA37BEC40F}"/>
               </a:ext>
             </a:extLst>
           </p:cNvPr>
@@ -6495,7 +6500,7 @@
           <p:cNvPr id="3" name="Active section">
             <a:extLst xmlns:a="http://schemas.openxmlformats.org/drawingml/2006/main">
               <a:ext uri="{FF2B5EF4-FFF2-40B4-BE49-F238E27FC236}">
-                <a16:creationId xmlns:a16="http://schemas.microsoft.com/office/drawing/2014/main" id="{37E41B39-3E01-4355-9F3D-5EB41A3F34EE}"/>
+                <a16:creationId xmlns:a16="http://schemas.microsoft.com/office/drawing/2014/main" id="{78E51BF0-3E4D-4D3B-B9BC-A98108F7C54E}"/>
               </a:ext>
             </a:extLst>
           </p:cNvPr>
@@ -6552,7 +6557,7 @@
           <p:cNvPr id="4" name="Section description 1">
             <a:extLst xmlns:a="http://schemas.openxmlformats.org/drawingml/2006/main">
               <a:ext uri="{FF2B5EF4-FFF2-40B4-BE49-F238E27FC236}">
-                <a16:creationId xmlns:a16="http://schemas.microsoft.com/office/drawing/2014/main" id="{0E6475CC-0857-43C7-9D5C-C571264ADEAA}"/>
+                <a16:creationId xmlns:a16="http://schemas.microsoft.com/office/drawing/2014/main" id="{B0359905-C049-4B8F-9D20-43EB745C0CDC}"/>
               </a:ext>
             </a:extLst>
           </p:cNvPr>
@@ -6613,7 +6618,7 @@
           <p:nvPr/>
         </p:nvPicPr>
         <p:blipFill>
-          <a:blip xmlns:r="http://schemas.openxmlformats.org/officeDocument/2006/relationships" xmlns:a="http://schemas.openxmlformats.org/drawingml/2006/main" r:embed="R228805522a2a4de8"/>
+          <a:blip xmlns:r="http://schemas.openxmlformats.org/officeDocument/2006/relationships" xmlns:a="http://schemas.openxmlformats.org/drawingml/2006/main" r:embed="Ra203104bb57442b0"/>
           <a:stretch xmlns:a="http://schemas.openxmlformats.org/drawingml/2006/main"/>
         </p:blipFill>
         <p:spPr>
@@ -6635,7 +6640,7 @@
           <p:nvPr/>
         </p:nvPicPr>
         <p:blipFill>
-          <a:blip xmlns:r="http://schemas.openxmlformats.org/officeDocument/2006/relationships" xmlns:a="http://schemas.openxmlformats.org/drawingml/2006/main" r:embed="Rcd8cd68219e94929"/>
+          <a:blip xmlns:r="http://schemas.openxmlformats.org/officeDocument/2006/relationships" xmlns:a="http://schemas.openxmlformats.org/drawingml/2006/main" r:embed="R36e3c397d1ff4453"/>
           <a:stretch xmlns:a="http://schemas.openxmlformats.org/drawingml/2006/main"/>
         </p:blipFill>
         <p:spPr>
@@ -6657,7 +6662,7 @@
           <p:nvPr/>
         </p:nvPicPr>
         <p:blipFill>
-          <a:blip xmlns:r="http://schemas.openxmlformats.org/officeDocument/2006/relationships" xmlns:a="http://schemas.openxmlformats.org/drawingml/2006/main" r:embed="Rfa463f1f87d849e6"/>
+          <a:blip xmlns:r="http://schemas.openxmlformats.org/officeDocument/2006/relationships" xmlns:a="http://schemas.openxmlformats.org/drawingml/2006/main" r:embed="R650ab03a67144073"/>
           <a:stretch xmlns:a="http://schemas.openxmlformats.org/drawingml/2006/main"/>
         </p:blipFill>
         <p:spPr>
@@ -6679,7 +6684,7 @@
           <p:nvPr/>
         </p:nvPicPr>
         <p:blipFill>
-          <a:blip xmlns:r="http://schemas.openxmlformats.org/officeDocument/2006/relationships" xmlns:a="http://schemas.openxmlformats.org/drawingml/2006/main" r:embed="R8ee2465c12194a10"/>
+          <a:blip xmlns:r="http://schemas.openxmlformats.org/officeDocument/2006/relationships" xmlns:a="http://schemas.openxmlformats.org/drawingml/2006/main" r:embed="R4130afa5b2d5428f"/>
           <a:stretch xmlns:a="http://schemas.openxmlformats.org/drawingml/2006/main"/>
         </p:blipFill>
         <p:spPr>
@@ -6701,7 +6706,7 @@
           <p:nvPr/>
         </p:nvPicPr>
         <p:blipFill>
-          <a:blip xmlns:r="http://schemas.openxmlformats.org/officeDocument/2006/relationships" xmlns:a="http://schemas.openxmlformats.org/drawingml/2006/main" r:embed="R0bb1e0448a0142cd"/>
+          <a:blip xmlns:r="http://schemas.openxmlformats.org/officeDocument/2006/relationships" xmlns:a="http://schemas.openxmlformats.org/drawingml/2006/main" r:embed="R1f1dc894a036432e"/>
           <a:stretch xmlns:a="http://schemas.openxmlformats.org/drawingml/2006/main"/>
         </p:blipFill>
         <p:spPr>
@@ -6719,7 +6724,7 @@
           <p:cNvPr id="10" name="Slide number">
             <a:extLst xmlns:a="http://schemas.openxmlformats.org/drawingml/2006/main">
               <a:ext uri="{FF2B5EF4-FFF2-40B4-BE49-F238E27FC236}">
-                <a16:creationId xmlns:a16="http://schemas.microsoft.com/office/drawing/2014/main" id="{745EB61A-C0ED-4BAE-959A-729ECF69F6E5}"/>
+                <a16:creationId xmlns:a16="http://schemas.microsoft.com/office/drawing/2014/main" id="{F2EFB321-EFB2-47AC-BD7D-E7DA94DAAAA5}"/>
               </a:ext>
             </a:extLst>
           </p:cNvPr>
@@ -6774,7 +6779,7 @@
     </p:spTree>
     <p:extLst>
       <p:ext uri="{BB962C8B-B14F-4D97-AF65-F5344CB8AC3E}">
-        <p14:creationId xmlns:p14="http://schemas.microsoft.com/office/powerpoint/2010/main" val="1960630104"/>
+        <p14:creationId xmlns:p14="http://schemas.microsoft.com/office/powerpoint/2010/main" val="1344742438"/>
       </p:ext>
     </p:extLst>
   </p:cSld>
@@ -6805,7 +6810,7 @@
           <p:cNvPr id="12" name="Title">
             <a:extLst xmlns:a="http://schemas.openxmlformats.org/drawingml/2006/main">
               <a:ext uri="{FF2B5EF4-FFF2-40B4-BE49-F238E27FC236}">
-                <a16:creationId xmlns:a16="http://schemas.microsoft.com/office/drawing/2014/main" id="{C69FE19A-D576-49F0-B313-A82A5A1E8539}"/>
+                <a16:creationId xmlns:a16="http://schemas.microsoft.com/office/drawing/2014/main" id="{A1761A1B-5574-4831-80C3-4601DCF9C21F}"/>
               </a:ext>
             </a:extLst>
           </p:cNvPr>
@@ -6862,7 +6867,7 @@
           <p:cNvPr id="2" name="text">
             <a:extLst xmlns:a="http://schemas.openxmlformats.org/drawingml/2006/main">
               <a:ext uri="{FF2B5EF4-FFF2-40B4-BE49-F238E27FC236}">
-                <a16:creationId xmlns:a16="http://schemas.microsoft.com/office/drawing/2014/main" id="{2314F845-28E7-4F47-9291-A3A024F7E3A4}"/>
+                <a16:creationId xmlns:a16="http://schemas.microsoft.com/office/drawing/2014/main" id="{025D1FFD-7EAD-455B-BE3F-5E0922428655}"/>
               </a:ext>
             </a:extLst>
           </p:cNvPr>
@@ -6919,7 +6924,7 @@
           <p:cNvPr id="3" name="text">
             <a:extLst xmlns:a="http://schemas.openxmlformats.org/drawingml/2006/main">
               <a:ext uri="{FF2B5EF4-FFF2-40B4-BE49-F238E27FC236}">
-                <a16:creationId xmlns:a16="http://schemas.microsoft.com/office/drawing/2014/main" id="{B255FCE8-9176-46AB-8D34-F3A80C9BFF13}"/>
+                <a16:creationId xmlns:a16="http://schemas.microsoft.com/office/drawing/2014/main" id="{08FED0EC-B59B-4BDE-90BD-5E887002693C}"/>
               </a:ext>
             </a:extLst>
           </p:cNvPr>
@@ -6976,7 +6981,7 @@
           <p:cNvPr id="4" name="text">
             <a:extLst xmlns:a="http://schemas.openxmlformats.org/drawingml/2006/main">
               <a:ext uri="{FF2B5EF4-FFF2-40B4-BE49-F238E27FC236}">
-                <a16:creationId xmlns:a16="http://schemas.microsoft.com/office/drawing/2014/main" id="{90E85F62-551E-453F-AFA3-B4E72C24DF7F}"/>
+                <a16:creationId xmlns:a16="http://schemas.microsoft.com/office/drawing/2014/main" id="{C46D4565-692F-45F6-AA41-901E7A3B34ED}"/>
               </a:ext>
             </a:extLst>
           </p:cNvPr>
@@ -7033,7 +7038,7 @@
           <p:cNvPr id="5" name="text">
             <a:extLst xmlns:a="http://schemas.openxmlformats.org/drawingml/2006/main">
               <a:ext uri="{FF2B5EF4-FFF2-40B4-BE49-F238E27FC236}">
-                <a16:creationId xmlns:a16="http://schemas.microsoft.com/office/drawing/2014/main" id="{28E8DD26-9DB4-4EB8-9424-C38D70F0BCBF}"/>
+                <a16:creationId xmlns:a16="http://schemas.microsoft.com/office/drawing/2014/main" id="{AD9F0479-12A7-4528-BEE3-62315E9BAF87}"/>
               </a:ext>
             </a:extLst>
           </p:cNvPr>
@@ -7090,7 +7095,7 @@
           <p:cNvPr id="6" name="text">
             <a:extLst xmlns:a="http://schemas.openxmlformats.org/drawingml/2006/main">
               <a:ext uri="{FF2B5EF4-FFF2-40B4-BE49-F238E27FC236}">
-                <a16:creationId xmlns:a16="http://schemas.microsoft.com/office/drawing/2014/main" id="{34C4448A-2F55-4104-B7A2-C96EB4034D48}"/>
+                <a16:creationId xmlns:a16="http://schemas.microsoft.com/office/drawing/2014/main" id="{328EB135-57CD-4919-922E-67981DEAA0C5}"/>
               </a:ext>
             </a:extLst>
           </p:cNvPr>
@@ -7147,7 +7152,7 @@
           <p:cNvPr id="7" name="text">
             <a:extLst xmlns:a="http://schemas.openxmlformats.org/drawingml/2006/main">
               <a:ext uri="{FF2B5EF4-FFF2-40B4-BE49-F238E27FC236}">
-                <a16:creationId xmlns:a16="http://schemas.microsoft.com/office/drawing/2014/main" id="{CA981DDB-0C5D-4FDC-B97F-AF23AD79D01E}"/>
+                <a16:creationId xmlns:a16="http://schemas.microsoft.com/office/drawing/2014/main" id="{9C4EAEA0-67B6-47ED-A5A4-4EE6A85BCC3C}"/>
               </a:ext>
             </a:extLst>
           </p:cNvPr>
@@ -7204,7 +7209,7 @@
           <p:cNvPr id="8" name="text">
             <a:extLst xmlns:a="http://schemas.openxmlformats.org/drawingml/2006/main">
               <a:ext uri="{FF2B5EF4-FFF2-40B4-BE49-F238E27FC236}">
-                <a16:creationId xmlns:a16="http://schemas.microsoft.com/office/drawing/2014/main" id="{E9D2ECCB-5DBA-4C7E-ADF7-7B5FB077EA31}"/>
+                <a16:creationId xmlns:a16="http://schemas.microsoft.com/office/drawing/2014/main" id="{A7F07C09-56B6-44D9-AF00-DF74F5165487}"/>
               </a:ext>
             </a:extLst>
           </p:cNvPr>
@@ -7261,7 +7266,7 @@
           <p:cNvPr id="9" name="text">
             <a:extLst xmlns:a="http://schemas.openxmlformats.org/drawingml/2006/main">
               <a:ext uri="{FF2B5EF4-FFF2-40B4-BE49-F238E27FC236}">
-                <a16:creationId xmlns:a16="http://schemas.microsoft.com/office/drawing/2014/main" id="{22E600CE-6FDA-451C-826C-3E3D94EBEB17}"/>
+                <a16:creationId xmlns:a16="http://schemas.microsoft.com/office/drawing/2014/main" id="{DF98B727-3E2D-4AD0-87B2-02A257FE3CA1}"/>
               </a:ext>
             </a:extLst>
           </p:cNvPr>
@@ -7318,7 +7323,7 @@
           <p:cNvPr id="10" name="text">
             <a:extLst xmlns:a="http://schemas.openxmlformats.org/drawingml/2006/main">
               <a:ext uri="{FF2B5EF4-FFF2-40B4-BE49-F238E27FC236}">
-                <a16:creationId xmlns:a16="http://schemas.microsoft.com/office/drawing/2014/main" id="{B5765058-6CCA-4AEB-B9E8-5B488A3127F8}"/>
+                <a16:creationId xmlns:a16="http://schemas.microsoft.com/office/drawing/2014/main" id="{DE8B1B16-433F-48B5-8301-C0F6D6AC2F14}"/>
               </a:ext>
             </a:extLst>
           </p:cNvPr>
@@ -7375,7 +7380,7 @@
           <p:cNvPr id="11" name="Slide number">
             <a:extLst xmlns:a="http://schemas.openxmlformats.org/drawingml/2006/main">
               <a:ext uri="{FF2B5EF4-FFF2-40B4-BE49-F238E27FC236}">
-                <a16:creationId xmlns:a16="http://schemas.microsoft.com/office/drawing/2014/main" id="{DE8D2C78-0EC6-400C-A169-A83FCCD19C86}"/>
+                <a16:creationId xmlns:a16="http://schemas.microsoft.com/office/drawing/2014/main" id="{72221EA2-B898-490C-A503-8AD3CFB700BF}"/>
               </a:ext>
             </a:extLst>
           </p:cNvPr>
@@ -7430,7 +7435,7 @@
     </p:spTree>
     <p:extLst>
       <p:ext uri="{BB962C8B-B14F-4D97-AF65-F5344CB8AC3E}">
-        <p14:creationId xmlns:p14="http://schemas.microsoft.com/office/powerpoint/2010/main" val="1049498722"/>
+        <p14:creationId xmlns:p14="http://schemas.microsoft.com/office/powerpoint/2010/main" val="664879587"/>
       </p:ext>
     </p:extLst>
   </p:cSld>
@@ -7461,7 +7466,7 @@
           <p:cNvPr id="7" name="Title">
             <a:extLst xmlns:a="http://schemas.openxmlformats.org/drawingml/2006/main">
               <a:ext uri="{FF2B5EF4-FFF2-40B4-BE49-F238E27FC236}">
-                <a16:creationId xmlns:a16="http://schemas.microsoft.com/office/drawing/2014/main" id="{4C9AC240-ED19-4A75-8B1B-1DD15A27E2CE}"/>
+                <a16:creationId xmlns:a16="http://schemas.microsoft.com/office/drawing/2014/main" id="{78D0C284-6007-458B-8EAF-8021A975C9A1}"/>
               </a:ext>
             </a:extLst>
           </p:cNvPr>
@@ -7525,7 +7530,7 @@
         </p:xfrm>
         <a:graphic xmlns:a="http://schemas.openxmlformats.org/drawingml/2006/main">
           <a:graphicData uri="http://schemas.openxmlformats.org/drawingml/2006/chart">
-            <c:chart xmlns:r="http://schemas.openxmlformats.org/officeDocument/2006/relationships" xmlns:c="http://schemas.openxmlformats.org/drawingml/2006/chart" r:id="Rf451083efdce4234"/>
+            <c:chart xmlns:r="http://schemas.openxmlformats.org/officeDocument/2006/relationships" xmlns:c="http://schemas.openxmlformats.org/drawingml/2006/chart" r:id="R40f12f99bf2b4184"/>
           </a:graphicData>
         </a:graphic>
       </p:graphicFrame>
@@ -7534,7 +7539,7 @@
           <p:cNvPr id="3" name="April month marker">
             <a:extLst xmlns:a="http://schemas.openxmlformats.org/drawingml/2006/main">
               <a:ext uri="{FF2B5EF4-FFF2-40B4-BE49-F238E27FC236}">
-                <a16:creationId xmlns:a16="http://schemas.microsoft.com/office/drawing/2014/main" id="{C8428A43-5648-475C-BB10-DF4EF31A4E09}"/>
+                <a16:creationId xmlns:a16="http://schemas.microsoft.com/office/drawing/2014/main" id="{66FE8300-2ECF-4EA5-8C4C-B56D3B9F637D}"/>
               </a:ext>
             </a:extLst>
           </p:cNvPr>
@@ -7565,7 +7570,7 @@
           <p:cNvPr id="4" name="April joining context">
             <a:extLst xmlns:a="http://schemas.openxmlformats.org/drawingml/2006/main">
               <a:ext uri="{FF2B5EF4-FFF2-40B4-BE49-F238E27FC236}">
-                <a16:creationId xmlns:a16="http://schemas.microsoft.com/office/drawing/2014/main" id="{8D2974E1-C439-45EE-BF60-CDE2421F744F}"/>
+                <a16:creationId xmlns:a16="http://schemas.microsoft.com/office/drawing/2014/main" id="{55390C04-1D39-4AD4-8066-D823A985D035}"/>
               </a:ext>
             </a:extLst>
           </p:cNvPr>
@@ -7622,7 +7627,7 @@
           <p:cNvPr id="5" name="Methodology">
             <a:extLst xmlns:a="http://schemas.openxmlformats.org/drawingml/2006/main">
               <a:ext uri="{FF2B5EF4-FFF2-40B4-BE49-F238E27FC236}">
-                <a16:creationId xmlns:a16="http://schemas.microsoft.com/office/drawing/2014/main" id="{BADF56BC-0725-434B-886A-609AC4ED2CCD}"/>
+                <a16:creationId xmlns:a16="http://schemas.microsoft.com/office/drawing/2014/main" id="{1F2B6659-8B9E-43E2-A86B-CBDCE363D5D1}"/>
               </a:ext>
             </a:extLst>
           </p:cNvPr>
@@ -7679,7 +7684,7 @@
           <p:cNvPr id="6" name="Slide number">
             <a:extLst xmlns:a="http://schemas.openxmlformats.org/drawingml/2006/main">
               <a:ext uri="{FF2B5EF4-FFF2-40B4-BE49-F238E27FC236}">
-                <a16:creationId xmlns:a16="http://schemas.microsoft.com/office/drawing/2014/main" id="{A71786E4-A0E8-4460-B69C-92780FE5EE2F}"/>
+                <a16:creationId xmlns:a16="http://schemas.microsoft.com/office/drawing/2014/main" id="{BD4251FE-779D-4665-8F0D-457C382AB3AA}"/>
               </a:ext>
             </a:extLst>
           </p:cNvPr>
@@ -7734,7 +7739,7 @@
     </p:spTree>
     <p:extLst>
       <p:ext uri="{BB962C8B-B14F-4D97-AF65-F5344CB8AC3E}">
-        <p14:creationId xmlns:p14="http://schemas.microsoft.com/office/powerpoint/2010/main" val="572917968"/>
+        <p14:creationId xmlns:p14="http://schemas.microsoft.com/office/powerpoint/2010/main" val="45583594"/>
       </p:ext>
     </p:extLst>
   </p:cSld>
@@ -7765,7 +7770,7 @@
           <p:cNvPr id="12" name="Completed section 0">
             <a:extLst xmlns:a="http://schemas.openxmlformats.org/drawingml/2006/main">
               <a:ext uri="{FF2B5EF4-FFF2-40B4-BE49-F238E27FC236}">
-                <a16:creationId xmlns:a16="http://schemas.microsoft.com/office/drawing/2014/main" id="{64BB44C4-0480-426A-92F2-9A661DE91980}"/>
+                <a16:creationId xmlns:a16="http://schemas.microsoft.com/office/drawing/2014/main" id="{28D1C248-EF55-4380-A468-5A39E1CB52A5}"/>
               </a:ext>
             </a:extLst>
           </p:cNvPr>
@@ -7822,7 +7827,7 @@
           <p:cNvPr id="2" name="Section description 0">
             <a:extLst xmlns:a="http://schemas.openxmlformats.org/drawingml/2006/main">
               <a:ext uri="{FF2B5EF4-FFF2-40B4-BE49-F238E27FC236}">
-                <a16:creationId xmlns:a16="http://schemas.microsoft.com/office/drawing/2014/main" id="{A31C566F-0BA4-4D5F-BCFA-D3D77199A75C}"/>
+                <a16:creationId xmlns:a16="http://schemas.microsoft.com/office/drawing/2014/main" id="{F97F3961-560F-4969-A27F-AE32DFAE360E}"/>
               </a:ext>
             </a:extLst>
           </p:cNvPr>
@@ -7879,7 +7884,7 @@
           <p:cNvPr id="3" name="Completed section 1">
             <a:extLst xmlns:a="http://schemas.openxmlformats.org/drawingml/2006/main">
               <a:ext uri="{FF2B5EF4-FFF2-40B4-BE49-F238E27FC236}">
-                <a16:creationId xmlns:a16="http://schemas.microsoft.com/office/drawing/2014/main" id="{7AA55F7F-5E5F-4CE8-91CA-B15332A99457}"/>
+                <a16:creationId xmlns:a16="http://schemas.microsoft.com/office/drawing/2014/main" id="{B1E110D4-6B70-4F5D-9E0E-A5349EC5371E}"/>
               </a:ext>
             </a:extLst>
           </p:cNvPr>
@@ -7936,7 +7941,7 @@
           <p:cNvPr id="4" name="Section description 1">
             <a:extLst xmlns:a="http://schemas.openxmlformats.org/drawingml/2006/main">
               <a:ext uri="{FF2B5EF4-FFF2-40B4-BE49-F238E27FC236}">
-                <a16:creationId xmlns:a16="http://schemas.microsoft.com/office/drawing/2014/main" id="{80DBCA3C-1169-49FA-8092-E77BBC27E971}"/>
+                <a16:creationId xmlns:a16="http://schemas.microsoft.com/office/drawing/2014/main" id="{7A5B873E-7E0A-45BB-997E-41C437298AD6}"/>
               </a:ext>
             </a:extLst>
           </p:cNvPr>
@@ -7993,7 +7998,7 @@
           <p:cNvPr id="5" name="Active section">
             <a:extLst xmlns:a="http://schemas.openxmlformats.org/drawingml/2006/main">
               <a:ext uri="{FF2B5EF4-FFF2-40B4-BE49-F238E27FC236}">
-                <a16:creationId xmlns:a16="http://schemas.microsoft.com/office/drawing/2014/main" id="{ACA76752-A005-4061-9F22-1E85E7A1D56C}"/>
+                <a16:creationId xmlns:a16="http://schemas.microsoft.com/office/drawing/2014/main" id="{1180AF2C-6F59-48EA-B9BE-EC256751B56C}"/>
               </a:ext>
             </a:extLst>
           </p:cNvPr>
@@ -8050,7 +8055,7 @@
           <p:cNvPr id="6" name="Section description 2">
             <a:extLst xmlns:a="http://schemas.openxmlformats.org/drawingml/2006/main">
               <a:ext uri="{FF2B5EF4-FFF2-40B4-BE49-F238E27FC236}">
-                <a16:creationId xmlns:a16="http://schemas.microsoft.com/office/drawing/2014/main" id="{0D32226D-A671-404A-AB23-F17A434F60AF}"/>
+                <a16:creationId xmlns:a16="http://schemas.microsoft.com/office/drawing/2014/main" id="{23A5C84D-574F-4802-87CD-1922BF21D0D9}"/>
               </a:ext>
             </a:extLst>
           </p:cNvPr>
@@ -8111,7 +8116,7 @@
           <p:nvPr/>
         </p:nvPicPr>
         <p:blipFill>
-          <a:blip xmlns:r="http://schemas.openxmlformats.org/officeDocument/2006/relationships" xmlns:a="http://schemas.openxmlformats.org/drawingml/2006/main" r:embed="R1b8d6741ba7b4708"/>
+          <a:blip xmlns:r="http://schemas.openxmlformats.org/officeDocument/2006/relationships" xmlns:a="http://schemas.openxmlformats.org/drawingml/2006/main" r:embed="Racdd9329fde04bea"/>
           <a:stretch xmlns:a="http://schemas.openxmlformats.org/drawingml/2006/main"/>
         </p:blipFill>
         <p:spPr>
@@ -8133,7 +8138,7 @@
           <p:nvPr/>
         </p:nvPicPr>
         <p:blipFill>
-          <a:blip xmlns:r="http://schemas.openxmlformats.org/officeDocument/2006/relationships" xmlns:a="http://schemas.openxmlformats.org/drawingml/2006/main" r:embed="R2c17a689959b495b"/>
+          <a:blip xmlns:r="http://schemas.openxmlformats.org/officeDocument/2006/relationships" xmlns:a="http://schemas.openxmlformats.org/drawingml/2006/main" r:embed="R5b0e457787fb4307"/>
           <a:stretch xmlns:a="http://schemas.openxmlformats.org/drawingml/2006/main"/>
         </p:blipFill>
         <p:spPr>
@@ -8155,7 +8160,7 @@
           <p:nvPr/>
         </p:nvPicPr>
         <p:blipFill>
-          <a:blip xmlns:r="http://schemas.openxmlformats.org/officeDocument/2006/relationships" xmlns:a="http://schemas.openxmlformats.org/drawingml/2006/main" r:embed="R38ae09c694a04f65"/>
+          <a:blip xmlns:r="http://schemas.openxmlformats.org/officeDocument/2006/relationships" xmlns:a="http://schemas.openxmlformats.org/drawingml/2006/main" r:embed="R55c907c80f244279"/>
           <a:stretch xmlns:a="http://schemas.openxmlformats.org/drawingml/2006/main"/>
         </p:blipFill>
         <p:spPr>
@@ -8177,7 +8182,7 @@
           <p:nvPr/>
         </p:nvPicPr>
         <p:blipFill>
-          <a:blip xmlns:r="http://schemas.openxmlformats.org/officeDocument/2006/relationships" xmlns:a="http://schemas.openxmlformats.org/drawingml/2006/main" r:embed="R67971cbd10e24ec9"/>
+          <a:blip xmlns:r="http://schemas.openxmlformats.org/officeDocument/2006/relationships" xmlns:a="http://schemas.openxmlformats.org/drawingml/2006/main" r:embed="R915b7829ce654bfb"/>
           <a:stretch xmlns:a="http://schemas.openxmlformats.org/drawingml/2006/main"/>
         </p:blipFill>
         <p:spPr>
@@ -8195,7 +8200,7 @@
           <p:cNvPr id="11" name="Slide number">
             <a:extLst xmlns:a="http://schemas.openxmlformats.org/drawingml/2006/main">
               <a:ext uri="{FF2B5EF4-FFF2-40B4-BE49-F238E27FC236}">
-                <a16:creationId xmlns:a16="http://schemas.microsoft.com/office/drawing/2014/main" id="{66D1CB86-8FA2-4D9F-A648-2EA0DAB09969}"/>
+                <a16:creationId xmlns:a16="http://schemas.microsoft.com/office/drawing/2014/main" id="{7722DEFB-ADCD-437A-BAF3-9D14804FB862}"/>
               </a:ext>
             </a:extLst>
           </p:cNvPr>
@@ -8250,7 +8255,7 @@
     </p:spTree>
     <p:extLst>
       <p:ext uri="{BB962C8B-B14F-4D97-AF65-F5344CB8AC3E}">
-        <p14:creationId xmlns:p14="http://schemas.microsoft.com/office/powerpoint/2010/main" val="910902101"/>
+        <p14:creationId xmlns:p14="http://schemas.microsoft.com/office/powerpoint/2010/main" val="878774562"/>
       </p:ext>
     </p:extLst>
   </p:cSld>
@@ -8281,7 +8286,7 @@
           <p:cNvPr id="11" name="Title">
             <a:extLst xmlns:a="http://schemas.openxmlformats.org/drawingml/2006/main">
               <a:ext uri="{FF2B5EF4-FFF2-40B4-BE49-F238E27FC236}">
-                <a16:creationId xmlns:a16="http://schemas.microsoft.com/office/drawing/2014/main" id="{21F42C89-8702-46A4-92FE-35D03D55E04D}"/>
+                <a16:creationId xmlns:a16="http://schemas.microsoft.com/office/drawing/2014/main" id="{CB23D8C6-C61E-4AF4-8B84-EAF89B587521}"/>
               </a:ext>
             </a:extLst>
           </p:cNvPr>
@@ -8338,7 +8343,7 @@
           <p:cNvPr id="2" name="text">
             <a:extLst xmlns:a="http://schemas.openxmlformats.org/drawingml/2006/main">
               <a:ext uri="{FF2B5EF4-FFF2-40B4-BE49-F238E27FC236}">
-                <a16:creationId xmlns:a16="http://schemas.microsoft.com/office/drawing/2014/main" id="{4B4F26B4-FB01-4B2E-938C-B661720F65E6}"/>
+                <a16:creationId xmlns:a16="http://schemas.microsoft.com/office/drawing/2014/main" id="{A4988C07-34D3-45F4-B633-7CED00436D61}"/>
               </a:ext>
             </a:extLst>
           </p:cNvPr>
@@ -8395,7 +8400,7 @@
           <p:cNvPr id="3" name="text">
             <a:extLst xmlns:a="http://schemas.openxmlformats.org/drawingml/2006/main">
               <a:ext uri="{FF2B5EF4-FFF2-40B4-BE49-F238E27FC236}">
-                <a16:creationId xmlns:a16="http://schemas.microsoft.com/office/drawing/2014/main" id="{D8E9ACEE-51DE-4A98-B27C-3F37CFFA723D}"/>
+                <a16:creationId xmlns:a16="http://schemas.microsoft.com/office/drawing/2014/main" id="{65DAEF8A-DADF-443A-8E93-1028EECF0583}"/>
               </a:ext>
             </a:extLst>
           </p:cNvPr>
@@ -8452,7 +8457,7 @@
           <p:cNvPr id="4" name="text">
             <a:extLst xmlns:a="http://schemas.openxmlformats.org/drawingml/2006/main">
               <a:ext uri="{FF2B5EF4-FFF2-40B4-BE49-F238E27FC236}">
-                <a16:creationId xmlns:a16="http://schemas.microsoft.com/office/drawing/2014/main" id="{D452BD97-DF1B-42A9-9DCE-71088D29C2CA}"/>
+                <a16:creationId xmlns:a16="http://schemas.microsoft.com/office/drawing/2014/main" id="{2B06F654-C823-4977-84C0-8ED88E5A4C92}"/>
               </a:ext>
             </a:extLst>
           </p:cNvPr>
@@ -8509,7 +8514,7 @@
           <p:cNvPr id="5" name="text">
             <a:extLst xmlns:a="http://schemas.openxmlformats.org/drawingml/2006/main">
               <a:ext uri="{FF2B5EF4-FFF2-40B4-BE49-F238E27FC236}">
-                <a16:creationId xmlns:a16="http://schemas.microsoft.com/office/drawing/2014/main" id="{921B7348-1EDE-49EA-8C2B-0B7D03FF678F}"/>
+                <a16:creationId xmlns:a16="http://schemas.microsoft.com/office/drawing/2014/main" id="{5378DF3B-B6E8-429C-A414-3D9DC8209DEE}"/>
               </a:ext>
             </a:extLst>
           </p:cNvPr>
@@ -8566,7 +8571,7 @@
           <p:cNvPr id="6" name="text">
             <a:extLst xmlns:a="http://schemas.openxmlformats.org/drawingml/2006/main">
               <a:ext uri="{FF2B5EF4-FFF2-40B4-BE49-F238E27FC236}">
-                <a16:creationId xmlns:a16="http://schemas.microsoft.com/office/drawing/2014/main" id="{BD7CE005-DF41-4AAB-B64D-C9BCD8CF9905}"/>
+                <a16:creationId xmlns:a16="http://schemas.microsoft.com/office/drawing/2014/main" id="{945221A1-99A1-4A20-940F-CB5EFF07084E}"/>
               </a:ext>
             </a:extLst>
           </p:cNvPr>
@@ -8623,7 +8628,7 @@
           <p:cNvPr id="7" name="text">
             <a:extLst xmlns:a="http://schemas.openxmlformats.org/drawingml/2006/main">
               <a:ext uri="{FF2B5EF4-FFF2-40B4-BE49-F238E27FC236}">
-                <a16:creationId xmlns:a16="http://schemas.microsoft.com/office/drawing/2014/main" id="{94341048-6EA6-4852-A295-3B5A6996AC2F}"/>
+                <a16:creationId xmlns:a16="http://schemas.microsoft.com/office/drawing/2014/main" id="{A8EE8EC3-D4E9-4A82-9350-37029093FDFE}"/>
               </a:ext>
             </a:extLst>
           </p:cNvPr>
@@ -8680,7 +8685,7 @@
           <p:cNvPr id="8" name="text">
             <a:extLst xmlns:a="http://schemas.openxmlformats.org/drawingml/2006/main">
               <a:ext uri="{FF2B5EF4-FFF2-40B4-BE49-F238E27FC236}">
-                <a16:creationId xmlns:a16="http://schemas.microsoft.com/office/drawing/2014/main" id="{EBCAAE61-29CC-4C9D-97E2-971237D6F2DC}"/>
+                <a16:creationId xmlns:a16="http://schemas.microsoft.com/office/drawing/2014/main" id="{83E44EC7-74CD-44CC-82A9-01082265DCA0}"/>
               </a:ext>
             </a:extLst>
           </p:cNvPr>
@@ -8737,7 +8742,7 @@
           <p:cNvPr id="9" name="text">
             <a:extLst xmlns:a="http://schemas.openxmlformats.org/drawingml/2006/main">
               <a:ext uri="{FF2B5EF4-FFF2-40B4-BE49-F238E27FC236}">
-                <a16:creationId xmlns:a16="http://schemas.microsoft.com/office/drawing/2014/main" id="{30DB35DE-7EF7-4490-93D5-A7CE23A70046}"/>
+                <a16:creationId xmlns:a16="http://schemas.microsoft.com/office/drawing/2014/main" id="{F66A290C-7995-4FD7-B6A0-438F2C7A71C6}"/>
               </a:ext>
             </a:extLst>
           </p:cNvPr>
@@ -8794,7 +8799,7 @@
           <p:cNvPr id="10" name="Slide number">
             <a:extLst xmlns:a="http://schemas.openxmlformats.org/drawingml/2006/main">
               <a:ext uri="{FF2B5EF4-FFF2-40B4-BE49-F238E27FC236}">
-                <a16:creationId xmlns:a16="http://schemas.microsoft.com/office/drawing/2014/main" id="{01F6F4E9-D326-403F-A3F0-DF08845FDF90}"/>
+                <a16:creationId xmlns:a16="http://schemas.microsoft.com/office/drawing/2014/main" id="{35D17DC2-AC2E-4D99-AAD6-547DF13E29C6}"/>
               </a:ext>
             </a:extLst>
           </p:cNvPr>
@@ -8849,7 +8854,7 @@
     </p:spTree>
     <p:extLst>
       <p:ext uri="{BB962C8B-B14F-4D97-AF65-F5344CB8AC3E}">
-        <p14:creationId xmlns:p14="http://schemas.microsoft.com/office/powerpoint/2010/main" val="114817317"/>
+        <p14:creationId xmlns:p14="http://schemas.microsoft.com/office/powerpoint/2010/main" val="181194872"/>
       </p:ext>
     </p:extLst>
   </p:cSld>
@@ -8880,7 +8885,7 @@
           <p:cNvPr id="5" name="Title">
             <a:extLst xmlns:a="http://schemas.openxmlformats.org/drawingml/2006/main">
               <a:ext uri="{FF2B5EF4-FFF2-40B4-BE49-F238E27FC236}">
-                <a16:creationId xmlns:a16="http://schemas.microsoft.com/office/drawing/2014/main" id="{FA651FE0-02D8-45FD-995C-C7E19B585A41}"/>
+                <a16:creationId xmlns:a16="http://schemas.microsoft.com/office/drawing/2014/main" id="{D54E44C1-EB51-4555-95DE-FEDE236159FF}"/>
               </a:ext>
             </a:extLst>
           </p:cNvPr>
@@ -8937,7 +8942,7 @@
           <p:cNvPr id="2" name="Metric value">
             <a:extLst xmlns:a="http://schemas.openxmlformats.org/drawingml/2006/main">
               <a:ext uri="{FF2B5EF4-FFF2-40B4-BE49-F238E27FC236}">
-                <a16:creationId xmlns:a16="http://schemas.microsoft.com/office/drawing/2014/main" id="{978F308C-28E3-448E-9058-4D67640050DC}"/>
+                <a16:creationId xmlns:a16="http://schemas.microsoft.com/office/drawing/2014/main" id="{28E9960B-B681-4BC8-92C7-02927321BF26}"/>
               </a:ext>
             </a:extLst>
           </p:cNvPr>
@@ -8994,7 +8999,7 @@
           <p:cNvPr id="3" name="text">
             <a:extLst xmlns:a="http://schemas.openxmlformats.org/drawingml/2006/main">
               <a:ext uri="{FF2B5EF4-FFF2-40B4-BE49-F238E27FC236}">
-                <a16:creationId xmlns:a16="http://schemas.microsoft.com/office/drawing/2014/main" id="{27D80EC3-DCDF-4980-8E8D-960350BAABF7}"/>
+                <a16:creationId xmlns:a16="http://schemas.microsoft.com/office/drawing/2014/main" id="{61FD9CF3-47A9-412D-B374-2CC9687742AD}"/>
               </a:ext>
             </a:extLst>
           </p:cNvPr>
@@ -9051,7 +9056,7 @@
           <p:cNvPr id="4" name="Slide number">
             <a:extLst xmlns:a="http://schemas.openxmlformats.org/drawingml/2006/main">
               <a:ext uri="{FF2B5EF4-FFF2-40B4-BE49-F238E27FC236}">
-                <a16:creationId xmlns:a16="http://schemas.microsoft.com/office/drawing/2014/main" id="{42D5D558-4D1A-47DC-9289-03A6BA7A944A}"/>
+                <a16:creationId xmlns:a16="http://schemas.microsoft.com/office/drawing/2014/main" id="{2BDB626C-60C9-4A78-A1CD-3229945A417D}"/>
               </a:ext>
             </a:extLst>
           </p:cNvPr>
@@ -9106,7 +9111,7 @@
     </p:spTree>
     <p:extLst>
       <p:ext uri="{BB962C8B-B14F-4D97-AF65-F5344CB8AC3E}">
-        <p14:creationId xmlns:p14="http://schemas.microsoft.com/office/powerpoint/2010/main" val="288206362"/>
+        <p14:creationId xmlns:p14="http://schemas.microsoft.com/office/powerpoint/2010/main" val="1814794178"/>
       </p:ext>
     </p:extLst>
   </p:cSld>
@@ -9137,7 +9142,7 @@
           <p:cNvPr id="13" name="Completed section 0">
             <a:extLst xmlns:a="http://schemas.openxmlformats.org/drawingml/2006/main">
               <a:ext uri="{FF2B5EF4-FFF2-40B4-BE49-F238E27FC236}">
-                <a16:creationId xmlns:a16="http://schemas.microsoft.com/office/drawing/2014/main" id="{F263F267-1757-4058-9D14-CE17B3CD3E85}"/>
+                <a16:creationId xmlns:a16="http://schemas.microsoft.com/office/drawing/2014/main" id="{9BAEE95B-C4EE-4692-BEE9-C90223EB5831}"/>
               </a:ext>
             </a:extLst>
           </p:cNvPr>
@@ -9194,7 +9199,7 @@
           <p:cNvPr id="2" name="Section description 0">
             <a:extLst xmlns:a="http://schemas.openxmlformats.org/drawingml/2006/main">
               <a:ext uri="{FF2B5EF4-FFF2-40B4-BE49-F238E27FC236}">
-                <a16:creationId xmlns:a16="http://schemas.microsoft.com/office/drawing/2014/main" id="{4F6F8B8B-CB59-43BA-BDF3-A41E00C3527D}"/>
+                <a16:creationId xmlns:a16="http://schemas.microsoft.com/office/drawing/2014/main" id="{DCD2D9C4-9410-48F8-846A-28530636E75C}"/>
               </a:ext>
             </a:extLst>
           </p:cNvPr>
@@ -9251,7 +9256,7 @@
           <p:cNvPr id="3" name="Completed section 1">
             <a:extLst xmlns:a="http://schemas.openxmlformats.org/drawingml/2006/main">
               <a:ext uri="{FF2B5EF4-FFF2-40B4-BE49-F238E27FC236}">
-                <a16:creationId xmlns:a16="http://schemas.microsoft.com/office/drawing/2014/main" id="{9D1B131E-987F-4E6F-B82E-39A5BAD7147E}"/>
+                <a16:creationId xmlns:a16="http://schemas.microsoft.com/office/drawing/2014/main" id="{AACB47CB-FF0A-4E5B-8DB0-E7053F3FDCA4}"/>
               </a:ext>
             </a:extLst>
           </p:cNvPr>
@@ -9308,7 +9313,7 @@
           <p:cNvPr id="4" name="Section description 1">
             <a:extLst xmlns:a="http://schemas.openxmlformats.org/drawingml/2006/main">
               <a:ext uri="{FF2B5EF4-FFF2-40B4-BE49-F238E27FC236}">
-                <a16:creationId xmlns:a16="http://schemas.microsoft.com/office/drawing/2014/main" id="{9E5F4306-8CD6-44F8-84BE-65405B2C2BB6}"/>
+                <a16:creationId xmlns:a16="http://schemas.microsoft.com/office/drawing/2014/main" id="{EF4FBBAA-E628-406C-963C-13A31770476B}"/>
               </a:ext>
             </a:extLst>
           </p:cNvPr>
@@ -9365,7 +9370,7 @@
           <p:cNvPr id="5" name="Completed section 2">
             <a:extLst xmlns:a="http://schemas.openxmlformats.org/drawingml/2006/main">
               <a:ext uri="{FF2B5EF4-FFF2-40B4-BE49-F238E27FC236}">
-                <a16:creationId xmlns:a16="http://schemas.microsoft.com/office/drawing/2014/main" id="{AB537A24-1CD5-4435-A804-E1DA48FBE40F}"/>
+                <a16:creationId xmlns:a16="http://schemas.microsoft.com/office/drawing/2014/main" id="{16F95636-598D-45E5-A824-B70FCBCFA830}"/>
               </a:ext>
             </a:extLst>
           </p:cNvPr>
@@ -9422,7 +9427,7 @@
           <p:cNvPr id="6" name="Section description 2">
             <a:extLst xmlns:a="http://schemas.openxmlformats.org/drawingml/2006/main">
               <a:ext uri="{FF2B5EF4-FFF2-40B4-BE49-F238E27FC236}">
-                <a16:creationId xmlns:a16="http://schemas.microsoft.com/office/drawing/2014/main" id="{F9603A7E-D7C9-4397-A1AD-2B509F7DF1E7}"/>
+                <a16:creationId xmlns:a16="http://schemas.microsoft.com/office/drawing/2014/main" id="{A8A11852-24EC-4F73-886C-58DE3752EE42}"/>
               </a:ext>
             </a:extLst>
           </p:cNvPr>
@@ -9479,7 +9484,7 @@
           <p:cNvPr id="7" name="Active section">
             <a:extLst xmlns:a="http://schemas.openxmlformats.org/drawingml/2006/main">
               <a:ext uri="{FF2B5EF4-FFF2-40B4-BE49-F238E27FC236}">
-                <a16:creationId xmlns:a16="http://schemas.microsoft.com/office/drawing/2014/main" id="{81E72057-FA15-42E5-9A06-1B5B348C6C62}"/>
+                <a16:creationId xmlns:a16="http://schemas.microsoft.com/office/drawing/2014/main" id="{173F8003-42F6-4E6F-BB34-AC644947B8CA}"/>
               </a:ext>
             </a:extLst>
           </p:cNvPr>
@@ -9536,7 +9541,7 @@
           <p:cNvPr id="8" name="Section description 3">
             <a:extLst xmlns:a="http://schemas.openxmlformats.org/drawingml/2006/main">
               <a:ext uri="{FF2B5EF4-FFF2-40B4-BE49-F238E27FC236}">
-                <a16:creationId xmlns:a16="http://schemas.microsoft.com/office/drawing/2014/main" id="{3D7DC405-1685-40C7-BD0F-B719328EEBF3}"/>
+                <a16:creationId xmlns:a16="http://schemas.microsoft.com/office/drawing/2014/main" id="{02D56BCD-E0F7-49CB-B3B2-34C31A8D5F92}"/>
               </a:ext>
             </a:extLst>
           </p:cNvPr>
@@ -9597,7 +9602,7 @@
           <p:nvPr/>
         </p:nvPicPr>
         <p:blipFill>
-          <a:blip xmlns:r="http://schemas.openxmlformats.org/officeDocument/2006/relationships" xmlns:a="http://schemas.openxmlformats.org/drawingml/2006/main" r:embed="Ra0e5aac92eea4ac6"/>
+          <a:blip xmlns:r="http://schemas.openxmlformats.org/officeDocument/2006/relationships" xmlns:a="http://schemas.openxmlformats.org/drawingml/2006/main" r:embed="R6410cfc258e44b4c"/>
           <a:stretch xmlns:a="http://schemas.openxmlformats.org/drawingml/2006/main"/>
         </p:blipFill>
         <p:spPr>
@@ -9619,7 +9624,7 @@
           <p:nvPr/>
         </p:nvPicPr>
         <p:blipFill>
-          <a:blip xmlns:r="http://schemas.openxmlformats.org/officeDocument/2006/relationships" xmlns:a="http://schemas.openxmlformats.org/drawingml/2006/main" r:embed="Ra5bd702f09934e43"/>
+          <a:blip xmlns:r="http://schemas.openxmlformats.org/officeDocument/2006/relationships" xmlns:a="http://schemas.openxmlformats.org/drawingml/2006/main" r:embed="Ra31a95853da4424b"/>
           <a:stretch xmlns:a="http://schemas.openxmlformats.org/drawingml/2006/main"/>
         </p:blipFill>
         <p:spPr>
@@ -9641,7 +9646,7 @@
           <p:nvPr/>
         </p:nvPicPr>
         <p:blipFill>
-          <a:blip xmlns:r="http://schemas.openxmlformats.org/officeDocument/2006/relationships" xmlns:a="http://schemas.openxmlformats.org/drawingml/2006/main" r:embed="Rf5b6cc00cbda4c04"/>
+          <a:blip xmlns:r="http://schemas.openxmlformats.org/officeDocument/2006/relationships" xmlns:a="http://schemas.openxmlformats.org/drawingml/2006/main" r:embed="R86181dcf4617446a"/>
           <a:stretch xmlns:a="http://schemas.openxmlformats.org/drawingml/2006/main"/>
         </p:blipFill>
         <p:spPr>
@@ -9659,7 +9664,7 @@
           <p:cNvPr id="12" name="Slide number">
             <a:extLst xmlns:a="http://schemas.openxmlformats.org/drawingml/2006/main">
               <a:ext uri="{FF2B5EF4-FFF2-40B4-BE49-F238E27FC236}">
-                <a16:creationId xmlns:a16="http://schemas.microsoft.com/office/drawing/2014/main" id="{02668A6B-EB18-4B9B-ADAC-C0A7D2D02BC6}"/>
+                <a16:creationId xmlns:a16="http://schemas.microsoft.com/office/drawing/2014/main" id="{279665A2-DCD5-44B4-B56F-27B88C7C4162}"/>
               </a:ext>
             </a:extLst>
           </p:cNvPr>
@@ -9714,7 +9719,7 @@
     </p:spTree>
     <p:extLst>
       <p:ext uri="{BB962C8B-B14F-4D97-AF65-F5344CB8AC3E}">
-        <p14:creationId xmlns:p14="http://schemas.microsoft.com/office/powerpoint/2010/main" val="1218848347"/>
+        <p14:creationId xmlns:p14="http://schemas.microsoft.com/office/powerpoint/2010/main" val="1106189989"/>
       </p:ext>
     </p:extLst>
   </p:cSld>
@@ -9745,7 +9750,7 @@
           <p:cNvPr id="11" name="Title">
             <a:extLst xmlns:a="http://schemas.openxmlformats.org/drawingml/2006/main">
               <a:ext uri="{FF2B5EF4-FFF2-40B4-BE49-F238E27FC236}">
-                <a16:creationId xmlns:a16="http://schemas.microsoft.com/office/drawing/2014/main" id="{257CF241-3415-4FCC-8F41-560220FC0369}"/>
+                <a16:creationId xmlns:a16="http://schemas.microsoft.com/office/drawing/2014/main" id="{EF54057B-4424-4E3E-A60E-767540344D33}"/>
               </a:ext>
             </a:extLst>
           </p:cNvPr>
@@ -9802,7 +9807,7 @@
           <p:cNvPr id="2" name="text">
             <a:extLst xmlns:a="http://schemas.openxmlformats.org/drawingml/2006/main">
               <a:ext uri="{FF2B5EF4-FFF2-40B4-BE49-F238E27FC236}">
-                <a16:creationId xmlns:a16="http://schemas.microsoft.com/office/drawing/2014/main" id="{C67B83A7-C88D-4E7C-AC02-B8FFC8DCC95D}"/>
+                <a16:creationId xmlns:a16="http://schemas.microsoft.com/office/drawing/2014/main" id="{E72B6F37-D8BD-4DB8-8439-EAFC61756E94}"/>
               </a:ext>
             </a:extLst>
           </p:cNvPr>
@@ -9859,7 +9864,7 @@
           <p:cNvPr id="3" name="text">
             <a:extLst xmlns:a="http://schemas.openxmlformats.org/drawingml/2006/main">
               <a:ext uri="{FF2B5EF4-FFF2-40B4-BE49-F238E27FC236}">
-                <a16:creationId xmlns:a16="http://schemas.microsoft.com/office/drawing/2014/main" id="{4007FD5A-9BDF-4B1A-B99A-C0A2E5E40A19}"/>
+                <a16:creationId xmlns:a16="http://schemas.microsoft.com/office/drawing/2014/main" id="{0C498E09-6CFC-4B43-9C83-06C25836C10E}"/>
               </a:ext>
             </a:extLst>
           </p:cNvPr>
@@ -9916,7 +9921,7 @@
           <p:cNvPr id="4" name="text">
             <a:extLst xmlns:a="http://schemas.openxmlformats.org/drawingml/2006/main">
               <a:ext uri="{FF2B5EF4-FFF2-40B4-BE49-F238E27FC236}">
-                <a16:creationId xmlns:a16="http://schemas.microsoft.com/office/drawing/2014/main" id="{7DBEAAB1-5060-40D0-A669-46E2757B9E3D}"/>
+                <a16:creationId xmlns:a16="http://schemas.microsoft.com/office/drawing/2014/main" id="{5A50192D-FA1F-42B1-B06E-3BDD6306B06A}"/>
               </a:ext>
             </a:extLst>
           </p:cNvPr>
@@ -9973,7 +9978,7 @@
           <p:cNvPr id="5" name="text">
             <a:extLst xmlns:a="http://schemas.openxmlformats.org/drawingml/2006/main">
               <a:ext uri="{FF2B5EF4-FFF2-40B4-BE49-F238E27FC236}">
-                <a16:creationId xmlns:a16="http://schemas.microsoft.com/office/drawing/2014/main" id="{5FB0DC28-B29E-4956-A3AB-74F4E8541B8A}"/>
+                <a16:creationId xmlns:a16="http://schemas.microsoft.com/office/drawing/2014/main" id="{938DB2F4-9476-4A96-8CCA-B7FCA2A629DC}"/>
               </a:ext>
             </a:extLst>
           </p:cNvPr>
@@ -10030,7 +10035,7 @@
           <p:cNvPr id="6" name="text">
             <a:extLst xmlns:a="http://schemas.openxmlformats.org/drawingml/2006/main">
               <a:ext uri="{FF2B5EF4-FFF2-40B4-BE49-F238E27FC236}">
-                <a16:creationId xmlns:a16="http://schemas.microsoft.com/office/drawing/2014/main" id="{3578DEDA-12C4-4497-B585-E6AD2EB24F3C}"/>
+                <a16:creationId xmlns:a16="http://schemas.microsoft.com/office/drawing/2014/main" id="{E5DE212D-C503-4F87-B738-44276D6F93DB}"/>
               </a:ext>
             </a:extLst>
           </p:cNvPr>
@@ -10087,7 +10092,7 @@
           <p:cNvPr id="7" name="text">
             <a:extLst xmlns:a="http://schemas.openxmlformats.org/drawingml/2006/main">
               <a:ext uri="{FF2B5EF4-FFF2-40B4-BE49-F238E27FC236}">
-                <a16:creationId xmlns:a16="http://schemas.microsoft.com/office/drawing/2014/main" id="{B741A2F6-C39E-47DF-8C52-5E93FAE8B241}"/>
+                <a16:creationId xmlns:a16="http://schemas.microsoft.com/office/drawing/2014/main" id="{5AACE2E8-90B1-4F21-B3B0-FDA15505A81A}"/>
               </a:ext>
             </a:extLst>
           </p:cNvPr>
@@ -10144,7 +10149,7 @@
           <p:cNvPr id="8" name="text">
             <a:extLst xmlns:a="http://schemas.openxmlformats.org/drawingml/2006/main">
               <a:ext uri="{FF2B5EF4-FFF2-40B4-BE49-F238E27FC236}">
-                <a16:creationId xmlns:a16="http://schemas.microsoft.com/office/drawing/2014/main" id="{D4F4DF50-F64A-4747-B145-75B0DB870DAA}"/>
+                <a16:creationId xmlns:a16="http://schemas.microsoft.com/office/drawing/2014/main" id="{EC776F72-B310-4760-8870-D58BA54B27FD}"/>
               </a:ext>
             </a:extLst>
           </p:cNvPr>
@@ -10201,7 +10206,7 @@
           <p:cNvPr id="9" name="text">
             <a:extLst xmlns:a="http://schemas.openxmlformats.org/drawingml/2006/main">
               <a:ext uri="{FF2B5EF4-FFF2-40B4-BE49-F238E27FC236}">
-                <a16:creationId xmlns:a16="http://schemas.microsoft.com/office/drawing/2014/main" id="{EE26F92B-99B6-4E2A-8ECA-FCA3D89441D4}"/>
+                <a16:creationId xmlns:a16="http://schemas.microsoft.com/office/drawing/2014/main" id="{93C959D6-B1CA-4829-BA63-F9BCFAECDF4C}"/>
               </a:ext>
             </a:extLst>
           </p:cNvPr>
@@ -10258,7 +10263,7 @@
           <p:cNvPr id="10" name="Slide number">
             <a:extLst xmlns:a="http://schemas.openxmlformats.org/drawingml/2006/main">
               <a:ext uri="{FF2B5EF4-FFF2-40B4-BE49-F238E27FC236}">
-                <a16:creationId xmlns:a16="http://schemas.microsoft.com/office/drawing/2014/main" id="{6DEE70DA-AB40-469C-8AF1-7CB77AA37746}"/>
+                <a16:creationId xmlns:a16="http://schemas.microsoft.com/office/drawing/2014/main" id="{BED41FD9-09F3-4E2E-B7B1-AC50F76BF326}"/>
               </a:ext>
             </a:extLst>
           </p:cNvPr>
@@ -10313,7 +10318,7 @@
     </p:spTree>
     <p:extLst>
       <p:ext uri="{BB962C8B-B14F-4D97-AF65-F5344CB8AC3E}">
-        <p14:creationId xmlns:p14="http://schemas.microsoft.com/office/powerpoint/2010/main" val="489380489"/>
+        <p14:creationId xmlns:p14="http://schemas.microsoft.com/office/powerpoint/2010/main" val="774204167"/>
       </p:ext>
     </p:extLst>
   </p:cSld>
@@ -10344,7 +10349,7 @@
           <p:cNvPr id="7" name="Title">
             <a:extLst xmlns:a="http://schemas.openxmlformats.org/drawingml/2006/main">
               <a:ext uri="{FF2B5EF4-FFF2-40B4-BE49-F238E27FC236}">
-                <a16:creationId xmlns:a16="http://schemas.microsoft.com/office/drawing/2014/main" id="{1413FD42-4D8E-4FB4-9463-738C541554C3}"/>
+                <a16:creationId xmlns:a16="http://schemas.microsoft.com/office/drawing/2014/main" id="{3322D41B-A043-41C3-8B50-F6BEDDBB3F9A}"/>
               </a:ext>
             </a:extLst>
           </p:cNvPr>
@@ -10408,7 +10413,7 @@
         </p:xfrm>
         <a:graphic xmlns:a="http://schemas.openxmlformats.org/drawingml/2006/main">
           <a:graphicData uri="http://schemas.openxmlformats.org/drawingml/2006/chart">
-            <c:chart xmlns:r="http://schemas.openxmlformats.org/officeDocument/2006/relationships" xmlns:c="http://schemas.openxmlformats.org/drawingml/2006/chart" r:id="Rca861328ea974996"/>
+            <c:chart xmlns:r="http://schemas.openxmlformats.org/officeDocument/2006/relationships" xmlns:c="http://schemas.openxmlformats.org/drawingml/2006/chart" r:id="Rbb53618df6af4a4e"/>
           </a:graphicData>
         </a:graphic>
       </p:graphicFrame>
@@ -10417,7 +10422,7 @@
           <p:cNvPr id="3" name="April month marker">
             <a:extLst xmlns:a="http://schemas.openxmlformats.org/drawingml/2006/main">
               <a:ext uri="{FF2B5EF4-FFF2-40B4-BE49-F238E27FC236}">
-                <a16:creationId xmlns:a16="http://schemas.microsoft.com/office/drawing/2014/main" id="{13D95845-79B9-4726-A656-0AAB771CEFD0}"/>
+                <a16:creationId xmlns:a16="http://schemas.microsoft.com/office/drawing/2014/main" id="{1EBED6CE-F90F-4992-BBE9-955AF28689FB}"/>
               </a:ext>
             </a:extLst>
           </p:cNvPr>
@@ -10448,7 +10453,7 @@
           <p:cNvPr id="4" name="April joining context">
             <a:extLst xmlns:a="http://schemas.openxmlformats.org/drawingml/2006/main">
               <a:ext uri="{FF2B5EF4-FFF2-40B4-BE49-F238E27FC236}">
-                <a16:creationId xmlns:a16="http://schemas.microsoft.com/office/drawing/2014/main" id="{F05D9A48-F17C-4197-9C1F-BCBE91C5350E}"/>
+                <a16:creationId xmlns:a16="http://schemas.microsoft.com/office/drawing/2014/main" id="{9D25A462-7015-4E9F-8E38-DD6C2E0063F9}"/>
               </a:ext>
             </a:extLst>
           </p:cNvPr>
@@ -10505,7 +10510,7 @@
           <p:cNvPr id="5" name="Methodology">
             <a:extLst xmlns:a="http://schemas.openxmlformats.org/drawingml/2006/main">
               <a:ext uri="{FF2B5EF4-FFF2-40B4-BE49-F238E27FC236}">
-                <a16:creationId xmlns:a16="http://schemas.microsoft.com/office/drawing/2014/main" id="{F1E05F11-AA9A-4D02-9CB4-8DFB2361B6D1}"/>
+                <a16:creationId xmlns:a16="http://schemas.microsoft.com/office/drawing/2014/main" id="{B4F2C1C9-0E7F-468C-8C55-4237BCA9D200}"/>
               </a:ext>
             </a:extLst>
           </p:cNvPr>
@@ -10562,7 +10567,7 @@
           <p:cNvPr id="6" name="Slide number">
             <a:extLst xmlns:a="http://schemas.openxmlformats.org/drawingml/2006/main">
               <a:ext uri="{FF2B5EF4-FFF2-40B4-BE49-F238E27FC236}">
-                <a16:creationId xmlns:a16="http://schemas.microsoft.com/office/drawing/2014/main" id="{7DB2F84C-C627-464E-970A-ED07DD38876F}"/>
+                <a16:creationId xmlns:a16="http://schemas.microsoft.com/office/drawing/2014/main" id="{FD537F8B-7F7F-4B92-A4FC-9BF700AE4689}"/>
               </a:ext>
             </a:extLst>
           </p:cNvPr>
@@ -10617,7 +10622,7 @@
     </p:spTree>
     <p:extLst>
       <p:ext uri="{BB962C8B-B14F-4D97-AF65-F5344CB8AC3E}">
-        <p14:creationId xmlns:p14="http://schemas.microsoft.com/office/powerpoint/2010/main" val="2141875795"/>
+        <p14:creationId xmlns:p14="http://schemas.microsoft.com/office/powerpoint/2010/main" val="1355284349"/>
       </p:ext>
     </p:extLst>
   </p:cSld>
@@ -10648,7 +10653,7 @@
           <p:cNvPr id="4" name="Title">
             <a:extLst xmlns:a="http://schemas.openxmlformats.org/drawingml/2006/main">
               <a:ext uri="{FF2B5EF4-FFF2-40B4-BE49-F238E27FC236}">
-                <a16:creationId xmlns:a16="http://schemas.microsoft.com/office/drawing/2014/main" id="{82B7B660-260D-4944-813A-84790F37C143}"/>
+                <a16:creationId xmlns:a16="http://schemas.microsoft.com/office/drawing/2014/main" id="{B54F3460-1AD0-4965-A0AC-874959E9EEE0}"/>
               </a:ext>
             </a:extLst>
           </p:cNvPr>
@@ -10728,7 +10733,7 @@
           <p:cNvPr id="2" name="text">
             <a:extLst xmlns:a="http://schemas.openxmlformats.org/drawingml/2006/main">
               <a:ext uri="{FF2B5EF4-FFF2-40B4-BE49-F238E27FC236}">
-                <a16:creationId xmlns:a16="http://schemas.microsoft.com/office/drawing/2014/main" id="{475D2947-CF67-4D8D-AED4-43462FFDB98B}"/>
+                <a16:creationId xmlns:a16="http://schemas.microsoft.com/office/drawing/2014/main" id="{8FD32802-B54A-45AF-8A03-BEA29BF0116F}"/>
               </a:ext>
             </a:extLst>
           </p:cNvPr>
@@ -10785,7 +10790,7 @@
           <p:cNvPr id="3" name="Slide number">
             <a:extLst xmlns:a="http://schemas.openxmlformats.org/drawingml/2006/main">
               <a:ext uri="{FF2B5EF4-FFF2-40B4-BE49-F238E27FC236}">
-                <a16:creationId xmlns:a16="http://schemas.microsoft.com/office/drawing/2014/main" id="{E8DFB136-3F79-4571-95C1-CA63E344441D}"/>
+                <a16:creationId xmlns:a16="http://schemas.microsoft.com/office/drawing/2014/main" id="{B4D91593-A065-4659-9373-549E4E4E4299}"/>
               </a:ext>
             </a:extLst>
           </p:cNvPr>
@@ -10840,7 +10845,7 @@
     </p:spTree>
     <p:extLst>
       <p:ext uri="{BB962C8B-B14F-4D97-AF65-F5344CB8AC3E}">
-        <p14:creationId xmlns:p14="http://schemas.microsoft.com/office/powerpoint/2010/main" val="1759978478"/>
+        <p14:creationId xmlns:p14="http://schemas.microsoft.com/office/powerpoint/2010/main" val="507578909"/>
       </p:ext>
     </p:extLst>
   </p:cSld>
@@ -10871,7 +10876,7 @@
           <p:cNvPr id="14" name="Completed section 0">
             <a:extLst xmlns:a="http://schemas.openxmlformats.org/drawingml/2006/main">
               <a:ext uri="{FF2B5EF4-FFF2-40B4-BE49-F238E27FC236}">
-                <a16:creationId xmlns:a16="http://schemas.microsoft.com/office/drawing/2014/main" id="{F4454660-3E90-4334-890B-23B3D3CFD448}"/>
+                <a16:creationId xmlns:a16="http://schemas.microsoft.com/office/drawing/2014/main" id="{94B786FE-4280-43B8-95CE-5FBF32CE26D2}"/>
               </a:ext>
             </a:extLst>
           </p:cNvPr>
@@ -10928,7 +10933,7 @@
           <p:cNvPr id="2" name="Section description 0">
             <a:extLst xmlns:a="http://schemas.openxmlformats.org/drawingml/2006/main">
               <a:ext uri="{FF2B5EF4-FFF2-40B4-BE49-F238E27FC236}">
-                <a16:creationId xmlns:a16="http://schemas.microsoft.com/office/drawing/2014/main" id="{DF8B7338-E3C8-4991-B097-6577CB242FC4}"/>
+                <a16:creationId xmlns:a16="http://schemas.microsoft.com/office/drawing/2014/main" id="{BC202744-067C-4122-A706-3C6D9238AF5F}"/>
               </a:ext>
             </a:extLst>
           </p:cNvPr>
@@ -10985,7 +10990,7 @@
           <p:cNvPr id="3" name="Completed section 1">
             <a:extLst xmlns:a="http://schemas.openxmlformats.org/drawingml/2006/main">
               <a:ext uri="{FF2B5EF4-FFF2-40B4-BE49-F238E27FC236}">
-                <a16:creationId xmlns:a16="http://schemas.microsoft.com/office/drawing/2014/main" id="{6B3EFE04-7AB8-4703-B4C2-5EBF0EC9EA62}"/>
+                <a16:creationId xmlns:a16="http://schemas.microsoft.com/office/drawing/2014/main" id="{E45D3290-9712-435F-8A89-90DE13715404}"/>
               </a:ext>
             </a:extLst>
           </p:cNvPr>
@@ -11042,7 +11047,7 @@
           <p:cNvPr id="4" name="Section description 1">
             <a:extLst xmlns:a="http://schemas.openxmlformats.org/drawingml/2006/main">
               <a:ext uri="{FF2B5EF4-FFF2-40B4-BE49-F238E27FC236}">
-                <a16:creationId xmlns:a16="http://schemas.microsoft.com/office/drawing/2014/main" id="{BEE16F68-A9D3-4B72-B614-DE75E0636433}"/>
+                <a16:creationId xmlns:a16="http://schemas.microsoft.com/office/drawing/2014/main" id="{7387A07E-6B74-4A89-A956-BDAC083B89ED}"/>
               </a:ext>
             </a:extLst>
           </p:cNvPr>
@@ -11099,7 +11104,7 @@
           <p:cNvPr id="5" name="Completed section 2">
             <a:extLst xmlns:a="http://schemas.openxmlformats.org/drawingml/2006/main">
               <a:ext uri="{FF2B5EF4-FFF2-40B4-BE49-F238E27FC236}">
-                <a16:creationId xmlns:a16="http://schemas.microsoft.com/office/drawing/2014/main" id="{4CCED7EA-E36F-47D8-A80E-E779D30D8627}"/>
+                <a16:creationId xmlns:a16="http://schemas.microsoft.com/office/drawing/2014/main" id="{9FD68C36-BC01-443E-B0E3-5AE781BEE28E}"/>
               </a:ext>
             </a:extLst>
           </p:cNvPr>
@@ -11156,7 +11161,7 @@
           <p:cNvPr id="6" name="Section description 2">
             <a:extLst xmlns:a="http://schemas.openxmlformats.org/drawingml/2006/main">
               <a:ext uri="{FF2B5EF4-FFF2-40B4-BE49-F238E27FC236}">
-                <a16:creationId xmlns:a16="http://schemas.microsoft.com/office/drawing/2014/main" id="{6BC4728B-9955-4F06-B57A-AA3842D7976F}"/>
+                <a16:creationId xmlns:a16="http://schemas.microsoft.com/office/drawing/2014/main" id="{CA5F5C2E-E789-47FE-AB31-E14672A85029}"/>
               </a:ext>
             </a:extLst>
           </p:cNvPr>
@@ -11213,7 +11218,7 @@
           <p:cNvPr id="7" name="Completed section 3">
             <a:extLst xmlns:a="http://schemas.openxmlformats.org/drawingml/2006/main">
               <a:ext uri="{FF2B5EF4-FFF2-40B4-BE49-F238E27FC236}">
-                <a16:creationId xmlns:a16="http://schemas.microsoft.com/office/drawing/2014/main" id="{4D7C1A4B-77ED-4EC9-9CFE-89BACBAFF2E1}"/>
+                <a16:creationId xmlns:a16="http://schemas.microsoft.com/office/drawing/2014/main" id="{1322148B-22B8-4BC5-93F0-2221E237E87F}"/>
               </a:ext>
             </a:extLst>
           </p:cNvPr>
@@ -11270,7 +11275,7 @@
           <p:cNvPr id="8" name="Section description 3">
             <a:extLst xmlns:a="http://schemas.openxmlformats.org/drawingml/2006/main">
               <a:ext uri="{FF2B5EF4-FFF2-40B4-BE49-F238E27FC236}">
-                <a16:creationId xmlns:a16="http://schemas.microsoft.com/office/drawing/2014/main" id="{CDEB4541-2693-4429-BD09-B057F7ECDF7E}"/>
+                <a16:creationId xmlns:a16="http://schemas.microsoft.com/office/drawing/2014/main" id="{9106252A-99DC-4E28-9AEB-927359F4720E}"/>
               </a:ext>
             </a:extLst>
           </p:cNvPr>
@@ -11327,7 +11332,7 @@
           <p:cNvPr id="9" name="Active section">
             <a:extLst xmlns:a="http://schemas.openxmlformats.org/drawingml/2006/main">
               <a:ext uri="{FF2B5EF4-FFF2-40B4-BE49-F238E27FC236}">
-                <a16:creationId xmlns:a16="http://schemas.microsoft.com/office/drawing/2014/main" id="{97B60D11-4DDB-44A0-865D-32F994717721}"/>
+                <a16:creationId xmlns:a16="http://schemas.microsoft.com/office/drawing/2014/main" id="{E9B2A970-8F71-41FF-B292-787FA8193583}"/>
               </a:ext>
             </a:extLst>
           </p:cNvPr>
@@ -11384,7 +11389,7 @@
           <p:cNvPr id="10" name="Section description 4">
             <a:extLst xmlns:a="http://schemas.openxmlformats.org/drawingml/2006/main">
               <a:ext uri="{FF2B5EF4-FFF2-40B4-BE49-F238E27FC236}">
-                <a16:creationId xmlns:a16="http://schemas.microsoft.com/office/drawing/2014/main" id="{6F7DD744-338E-4A2C-907E-0A4D5CAEDAFC}"/>
+                <a16:creationId xmlns:a16="http://schemas.microsoft.com/office/drawing/2014/main" id="{D284C5F2-6178-4471-B510-24B9F524CBAB}"/>
               </a:ext>
             </a:extLst>
           </p:cNvPr>
@@ -11445,7 +11450,7 @@
           <p:nvPr/>
         </p:nvPicPr>
         <p:blipFill>
-          <a:blip xmlns:r="http://schemas.openxmlformats.org/officeDocument/2006/relationships" xmlns:a="http://schemas.openxmlformats.org/drawingml/2006/main" r:embed="R6672311b84424179"/>
+          <a:blip xmlns:r="http://schemas.openxmlformats.org/officeDocument/2006/relationships" xmlns:a="http://schemas.openxmlformats.org/drawingml/2006/main" r:embed="R50001818c26b4014"/>
           <a:stretch xmlns:a="http://schemas.openxmlformats.org/drawingml/2006/main"/>
         </p:blipFill>
         <p:spPr>
@@ -11467,7 +11472,7 @@
           <p:nvPr/>
         </p:nvPicPr>
         <p:blipFill>
-          <a:blip xmlns:r="http://schemas.openxmlformats.org/officeDocument/2006/relationships" xmlns:a="http://schemas.openxmlformats.org/drawingml/2006/main" r:embed="Ra58ec0f66aa6437e"/>
+          <a:blip xmlns:r="http://schemas.openxmlformats.org/officeDocument/2006/relationships" xmlns:a="http://schemas.openxmlformats.org/drawingml/2006/main" r:embed="R8de1240965e84a6b"/>
           <a:stretch xmlns:a="http://schemas.openxmlformats.org/drawingml/2006/main"/>
         </p:blipFill>
         <p:spPr>
@@ -11485,7 +11490,7 @@
           <p:cNvPr id="13" name="Slide number">
             <a:extLst xmlns:a="http://schemas.openxmlformats.org/drawingml/2006/main">
               <a:ext uri="{FF2B5EF4-FFF2-40B4-BE49-F238E27FC236}">
-                <a16:creationId xmlns:a16="http://schemas.microsoft.com/office/drawing/2014/main" id="{59B7471D-D8BB-4BAC-8AD2-ABB546AA6DE6}"/>
+                <a16:creationId xmlns:a16="http://schemas.microsoft.com/office/drawing/2014/main" id="{86C1C890-544C-4DED-8EBE-1F3B809A440A}"/>
               </a:ext>
             </a:extLst>
           </p:cNvPr>
@@ -11540,7 +11545,7 @@
     </p:spTree>
     <p:extLst>
       <p:ext uri="{BB962C8B-B14F-4D97-AF65-F5344CB8AC3E}">
-        <p14:creationId xmlns:p14="http://schemas.microsoft.com/office/powerpoint/2010/main" val="641035913"/>
+        <p14:creationId xmlns:p14="http://schemas.microsoft.com/office/powerpoint/2010/main" val="1075929725"/>
       </p:ext>
     </p:extLst>
   </p:cSld>
@@ -11571,7 +11576,7 @@
           <p:cNvPr id="10" name="Title">
             <a:extLst xmlns:a="http://schemas.openxmlformats.org/drawingml/2006/main">
               <a:ext uri="{FF2B5EF4-FFF2-40B4-BE49-F238E27FC236}">
-                <a16:creationId xmlns:a16="http://schemas.microsoft.com/office/drawing/2014/main" id="{F3AC8928-AB73-4C85-9803-C0F372475B1E}"/>
+                <a16:creationId xmlns:a16="http://schemas.microsoft.com/office/drawing/2014/main" id="{ECE2B09F-5D53-4CA4-A382-3846113B0EFD}"/>
               </a:ext>
             </a:extLst>
           </p:cNvPr>
@@ -11628,7 +11633,7 @@
           <p:cNvPr id="2" name="text">
             <a:extLst xmlns:a="http://schemas.openxmlformats.org/drawingml/2006/main">
               <a:ext uri="{FF2B5EF4-FFF2-40B4-BE49-F238E27FC236}">
-                <a16:creationId xmlns:a16="http://schemas.microsoft.com/office/drawing/2014/main" id="{8DBE3591-5568-40B2-B9F1-092DFB2C9889}"/>
+                <a16:creationId xmlns:a16="http://schemas.microsoft.com/office/drawing/2014/main" id="{D11D099F-17FB-4112-BE77-B9668CC439DA}"/>
               </a:ext>
             </a:extLst>
           </p:cNvPr>
@@ -11685,7 +11690,7 @@
           <p:cNvPr id="3" name="text">
             <a:extLst xmlns:a="http://schemas.openxmlformats.org/drawingml/2006/main">
               <a:ext uri="{FF2B5EF4-FFF2-40B4-BE49-F238E27FC236}">
-                <a16:creationId xmlns:a16="http://schemas.microsoft.com/office/drawing/2014/main" id="{C14DACEE-C77E-443F-97FF-C8FD99CB4D36}"/>
+                <a16:creationId xmlns:a16="http://schemas.microsoft.com/office/drawing/2014/main" id="{2B2A1956-0AFE-4554-81B3-C451847AD21E}"/>
               </a:ext>
             </a:extLst>
           </p:cNvPr>
@@ -11742,7 +11747,7 @@
           <p:cNvPr id="4" name="text">
             <a:extLst xmlns:a="http://schemas.openxmlformats.org/drawingml/2006/main">
               <a:ext uri="{FF2B5EF4-FFF2-40B4-BE49-F238E27FC236}">
-                <a16:creationId xmlns:a16="http://schemas.microsoft.com/office/drawing/2014/main" id="{FACF5B3B-3C7C-43A2-94BE-0760EA394AD7}"/>
+                <a16:creationId xmlns:a16="http://schemas.microsoft.com/office/drawing/2014/main" id="{E8D8F046-0D4D-433B-B61C-D7E5F458B148}"/>
               </a:ext>
             </a:extLst>
           </p:cNvPr>
@@ -11799,7 +11804,7 @@
           <p:cNvPr id="5" name="text">
             <a:extLst xmlns:a="http://schemas.openxmlformats.org/drawingml/2006/main">
               <a:ext uri="{FF2B5EF4-FFF2-40B4-BE49-F238E27FC236}">
-                <a16:creationId xmlns:a16="http://schemas.microsoft.com/office/drawing/2014/main" id="{6A324861-5309-404D-9A72-EFD1DFC731A1}"/>
+                <a16:creationId xmlns:a16="http://schemas.microsoft.com/office/drawing/2014/main" id="{BA0B7A0F-8E18-4C11-B5EC-9CB5A5BC9A0F}"/>
               </a:ext>
             </a:extLst>
           </p:cNvPr>
@@ -11856,7 +11861,7 @@
           <p:cNvPr id="6" name="text">
             <a:extLst xmlns:a="http://schemas.openxmlformats.org/drawingml/2006/main">
               <a:ext uri="{FF2B5EF4-FFF2-40B4-BE49-F238E27FC236}">
-                <a16:creationId xmlns:a16="http://schemas.microsoft.com/office/drawing/2014/main" id="{FF669FF2-048F-4AF5-BAD0-3AB8D1DF6E9A}"/>
+                <a16:creationId xmlns:a16="http://schemas.microsoft.com/office/drawing/2014/main" id="{87588227-B5E4-4731-8B9D-2CD4774639B3}"/>
               </a:ext>
             </a:extLst>
           </p:cNvPr>
@@ -11913,7 +11918,7 @@
           <p:cNvPr id="7" name="text">
             <a:extLst xmlns:a="http://schemas.openxmlformats.org/drawingml/2006/main">
               <a:ext uri="{FF2B5EF4-FFF2-40B4-BE49-F238E27FC236}">
-                <a16:creationId xmlns:a16="http://schemas.microsoft.com/office/drawing/2014/main" id="{4E198EDF-0D53-4BB0-9C36-A7D37F16D7A8}"/>
+                <a16:creationId xmlns:a16="http://schemas.microsoft.com/office/drawing/2014/main" id="{67E15C09-13C4-4FCF-8625-22C35B355CF8}"/>
               </a:ext>
             </a:extLst>
           </p:cNvPr>
@@ -11970,7 +11975,7 @@
           <p:cNvPr id="8" name="text">
             <a:extLst xmlns:a="http://schemas.openxmlformats.org/drawingml/2006/main">
               <a:ext uri="{FF2B5EF4-FFF2-40B4-BE49-F238E27FC236}">
-                <a16:creationId xmlns:a16="http://schemas.microsoft.com/office/drawing/2014/main" id="{A1EED131-02AF-4209-8D4D-8F8F1E277734}"/>
+                <a16:creationId xmlns:a16="http://schemas.microsoft.com/office/drawing/2014/main" id="{FFA16564-1EE0-4C08-B320-C777E9ADB67E}"/>
               </a:ext>
             </a:extLst>
           </p:cNvPr>
@@ -12027,7 +12032,7 @@
           <p:cNvPr id="9" name="Slide number">
             <a:extLst xmlns:a="http://schemas.openxmlformats.org/drawingml/2006/main">
               <a:ext uri="{FF2B5EF4-FFF2-40B4-BE49-F238E27FC236}">
-                <a16:creationId xmlns:a16="http://schemas.microsoft.com/office/drawing/2014/main" id="{A2B4A6AB-F6E4-4586-AC5D-797980A97F5B}"/>
+                <a16:creationId xmlns:a16="http://schemas.microsoft.com/office/drawing/2014/main" id="{4F3736C7-ACB9-4DD6-A6C2-91671AC5DC51}"/>
               </a:ext>
             </a:extLst>
           </p:cNvPr>
@@ -12082,7 +12087,7 @@
     </p:spTree>
     <p:extLst>
       <p:ext uri="{BB962C8B-B14F-4D97-AF65-F5344CB8AC3E}">
-        <p14:creationId xmlns:p14="http://schemas.microsoft.com/office/powerpoint/2010/main" val="2127959117"/>
+        <p14:creationId xmlns:p14="http://schemas.microsoft.com/office/powerpoint/2010/main" val="883914056"/>
       </p:ext>
     </p:extLst>
   </p:cSld>
@@ -12113,7 +12118,7 @@
           <p:cNvPr id="10" name="Title">
             <a:extLst xmlns:a="http://schemas.openxmlformats.org/drawingml/2006/main">
               <a:ext uri="{FF2B5EF4-FFF2-40B4-BE49-F238E27FC236}">
-                <a16:creationId xmlns:a16="http://schemas.microsoft.com/office/drawing/2014/main" id="{09C15638-5561-43FD-A0DF-3CE3D9A95A65}"/>
+                <a16:creationId xmlns:a16="http://schemas.microsoft.com/office/drawing/2014/main" id="{F6ACFA04-DB10-4A69-AF2F-1033535BAFF6}"/>
               </a:ext>
             </a:extLst>
           </p:cNvPr>
@@ -12170,7 +12175,7 @@
           <p:cNvPr id="2" name="text">
             <a:extLst xmlns:a="http://schemas.openxmlformats.org/drawingml/2006/main">
               <a:ext uri="{FF2B5EF4-FFF2-40B4-BE49-F238E27FC236}">
-                <a16:creationId xmlns:a16="http://schemas.microsoft.com/office/drawing/2014/main" id="{1F1EA01D-7C37-4FE4-8341-4F7F47C1C3D7}"/>
+                <a16:creationId xmlns:a16="http://schemas.microsoft.com/office/drawing/2014/main" id="{4202EFDC-8E1C-4FCA-9689-C1DB654361DC}"/>
               </a:ext>
             </a:extLst>
           </p:cNvPr>
@@ -12227,7 +12232,7 @@
           <p:cNvPr id="3" name="text">
             <a:extLst xmlns:a="http://schemas.openxmlformats.org/drawingml/2006/main">
               <a:ext uri="{FF2B5EF4-FFF2-40B4-BE49-F238E27FC236}">
-                <a16:creationId xmlns:a16="http://schemas.microsoft.com/office/drawing/2014/main" id="{999E60EC-4B8C-4E9F-BDA5-74D667942C73}"/>
+                <a16:creationId xmlns:a16="http://schemas.microsoft.com/office/drawing/2014/main" id="{EDAB1031-E019-45D5-BA9D-112BC06A9F38}"/>
               </a:ext>
             </a:extLst>
           </p:cNvPr>
@@ -12284,7 +12289,7 @@
           <p:cNvPr id="4" name="text">
             <a:extLst xmlns:a="http://schemas.openxmlformats.org/drawingml/2006/main">
               <a:ext uri="{FF2B5EF4-FFF2-40B4-BE49-F238E27FC236}">
-                <a16:creationId xmlns:a16="http://schemas.microsoft.com/office/drawing/2014/main" id="{A9899CA7-D8DD-4FF9-8E30-1BBDC70EE172}"/>
+                <a16:creationId xmlns:a16="http://schemas.microsoft.com/office/drawing/2014/main" id="{DE9FA2D5-31A9-42A6-A7E5-3EE1D101CC76}"/>
               </a:ext>
             </a:extLst>
           </p:cNvPr>
@@ -12341,7 +12346,7 @@
           <p:cNvPr id="5" name="text">
             <a:extLst xmlns:a="http://schemas.openxmlformats.org/drawingml/2006/main">
               <a:ext uri="{FF2B5EF4-FFF2-40B4-BE49-F238E27FC236}">
-                <a16:creationId xmlns:a16="http://schemas.microsoft.com/office/drawing/2014/main" id="{77D93B11-0524-4E02-97F9-3E8DFCC8F410}"/>
+                <a16:creationId xmlns:a16="http://schemas.microsoft.com/office/drawing/2014/main" id="{1F29721D-E6F5-4ED9-A7D9-1A4BFF2F0437}"/>
               </a:ext>
             </a:extLst>
           </p:cNvPr>
@@ -12398,7 +12403,7 @@
           <p:cNvPr id="6" name="text">
             <a:extLst xmlns:a="http://schemas.openxmlformats.org/drawingml/2006/main">
               <a:ext uri="{FF2B5EF4-FFF2-40B4-BE49-F238E27FC236}">
-                <a16:creationId xmlns:a16="http://schemas.microsoft.com/office/drawing/2014/main" id="{B6CDF7EB-5C78-4FD2-8BFD-AFF8BCE5B4C5}"/>
+                <a16:creationId xmlns:a16="http://schemas.microsoft.com/office/drawing/2014/main" id="{74A4F7C9-CE16-4C0F-841B-E53E9F05E6CF}"/>
               </a:ext>
             </a:extLst>
           </p:cNvPr>
@@ -12455,7 +12460,7 @@
           <p:cNvPr id="7" name="text">
             <a:extLst xmlns:a="http://schemas.openxmlformats.org/drawingml/2006/main">
               <a:ext uri="{FF2B5EF4-FFF2-40B4-BE49-F238E27FC236}">
-                <a16:creationId xmlns:a16="http://schemas.microsoft.com/office/drawing/2014/main" id="{A4CF8802-BCF6-4E3D-969D-46326783C07B}"/>
+                <a16:creationId xmlns:a16="http://schemas.microsoft.com/office/drawing/2014/main" id="{48A96BAA-D1F4-4D0C-BF44-A291787EE15F}"/>
               </a:ext>
             </a:extLst>
           </p:cNvPr>
@@ -12512,7 +12517,7 @@
           <p:cNvPr id="8" name="text">
             <a:extLst xmlns:a="http://schemas.openxmlformats.org/drawingml/2006/main">
               <a:ext uri="{FF2B5EF4-FFF2-40B4-BE49-F238E27FC236}">
-                <a16:creationId xmlns:a16="http://schemas.microsoft.com/office/drawing/2014/main" id="{484151F3-B71A-462E-B8C1-03304751E388}"/>
+                <a16:creationId xmlns:a16="http://schemas.microsoft.com/office/drawing/2014/main" id="{9B9E1B97-44E2-4CD9-8315-DBA5611AEDD9}"/>
               </a:ext>
             </a:extLst>
           </p:cNvPr>
@@ -12569,7 +12574,7 @@
           <p:cNvPr id="9" name="Slide number">
             <a:extLst xmlns:a="http://schemas.openxmlformats.org/drawingml/2006/main">
               <a:ext uri="{FF2B5EF4-FFF2-40B4-BE49-F238E27FC236}">
-                <a16:creationId xmlns:a16="http://schemas.microsoft.com/office/drawing/2014/main" id="{CD840393-71F8-4FE7-87FD-67EA7734878F}"/>
+                <a16:creationId xmlns:a16="http://schemas.microsoft.com/office/drawing/2014/main" id="{6A2B5F3A-E39D-470C-907C-3D19CB70EC99}"/>
               </a:ext>
             </a:extLst>
           </p:cNvPr>
@@ -12624,7 +12629,7 @@
     </p:spTree>
     <p:extLst>
       <p:ext uri="{BB962C8B-B14F-4D97-AF65-F5344CB8AC3E}">
-        <p14:creationId xmlns:p14="http://schemas.microsoft.com/office/powerpoint/2010/main" val="1529277702"/>
+        <p14:creationId xmlns:p14="http://schemas.microsoft.com/office/powerpoint/2010/main" val="1578030420"/>
       </p:ext>
     </p:extLst>
   </p:cSld>
@@ -12655,7 +12660,7 @@
           <p:cNvPr id="15" name="Completed section 0">
             <a:extLst xmlns:a="http://schemas.openxmlformats.org/drawingml/2006/main">
               <a:ext uri="{FF2B5EF4-FFF2-40B4-BE49-F238E27FC236}">
-                <a16:creationId xmlns:a16="http://schemas.microsoft.com/office/drawing/2014/main" id="{5F90FE8F-7B3B-4C34-8C4E-66810113043A}"/>
+                <a16:creationId xmlns:a16="http://schemas.microsoft.com/office/drawing/2014/main" id="{2EDAE210-7C39-4AF6-AB96-C5F69DD675EC}"/>
               </a:ext>
             </a:extLst>
           </p:cNvPr>
@@ -12712,7 +12717,7 @@
           <p:cNvPr id="2" name="Section description 0">
             <a:extLst xmlns:a="http://schemas.openxmlformats.org/drawingml/2006/main">
               <a:ext uri="{FF2B5EF4-FFF2-40B4-BE49-F238E27FC236}">
-                <a16:creationId xmlns:a16="http://schemas.microsoft.com/office/drawing/2014/main" id="{161E7900-B1CC-4C38-8599-2871F647C92D}"/>
+                <a16:creationId xmlns:a16="http://schemas.microsoft.com/office/drawing/2014/main" id="{E884C0E5-DBBC-4265-9ACF-D53BE47DB95A}"/>
               </a:ext>
             </a:extLst>
           </p:cNvPr>
@@ -12769,7 +12774,7 @@
           <p:cNvPr id="3" name="Completed section 1">
             <a:extLst xmlns:a="http://schemas.openxmlformats.org/drawingml/2006/main">
               <a:ext uri="{FF2B5EF4-FFF2-40B4-BE49-F238E27FC236}">
-                <a16:creationId xmlns:a16="http://schemas.microsoft.com/office/drawing/2014/main" id="{6740CFD4-E1F6-4FB1-BE0A-75D45390D65D}"/>
+                <a16:creationId xmlns:a16="http://schemas.microsoft.com/office/drawing/2014/main" id="{731D8800-0260-4364-8C5A-D0D26458034B}"/>
               </a:ext>
             </a:extLst>
           </p:cNvPr>
@@ -12826,7 +12831,7 @@
           <p:cNvPr id="4" name="Section description 1">
             <a:extLst xmlns:a="http://schemas.openxmlformats.org/drawingml/2006/main">
               <a:ext uri="{FF2B5EF4-FFF2-40B4-BE49-F238E27FC236}">
-                <a16:creationId xmlns:a16="http://schemas.microsoft.com/office/drawing/2014/main" id="{7B7EF12D-1BA9-47F2-A2B4-5FC6D0830FAC}"/>
+                <a16:creationId xmlns:a16="http://schemas.microsoft.com/office/drawing/2014/main" id="{015E0F2B-0759-467C-B41C-8461B42AE142}"/>
               </a:ext>
             </a:extLst>
           </p:cNvPr>
@@ -12883,7 +12888,7 @@
           <p:cNvPr id="5" name="Completed section 2">
             <a:extLst xmlns:a="http://schemas.openxmlformats.org/drawingml/2006/main">
               <a:ext uri="{FF2B5EF4-FFF2-40B4-BE49-F238E27FC236}">
-                <a16:creationId xmlns:a16="http://schemas.microsoft.com/office/drawing/2014/main" id="{B8433B0C-0AA9-4A14-B632-A7ECCFA9CD32}"/>
+                <a16:creationId xmlns:a16="http://schemas.microsoft.com/office/drawing/2014/main" id="{E2A34BD0-A58A-400F-B6AF-A7D5F51D73E5}"/>
               </a:ext>
             </a:extLst>
           </p:cNvPr>
@@ -12940,7 +12945,7 @@
           <p:cNvPr id="6" name="Section description 2">
             <a:extLst xmlns:a="http://schemas.openxmlformats.org/drawingml/2006/main">
               <a:ext uri="{FF2B5EF4-FFF2-40B4-BE49-F238E27FC236}">
-                <a16:creationId xmlns:a16="http://schemas.microsoft.com/office/drawing/2014/main" id="{3BD0E429-C084-4722-BFE1-164F928034B8}"/>
+                <a16:creationId xmlns:a16="http://schemas.microsoft.com/office/drawing/2014/main" id="{6D72708E-30ED-4CC4-B9E3-367B449D7738}"/>
               </a:ext>
             </a:extLst>
           </p:cNvPr>
@@ -12997,7 +13002,7 @@
           <p:cNvPr id="7" name="Completed section 3">
             <a:extLst xmlns:a="http://schemas.openxmlformats.org/drawingml/2006/main">
               <a:ext uri="{FF2B5EF4-FFF2-40B4-BE49-F238E27FC236}">
-                <a16:creationId xmlns:a16="http://schemas.microsoft.com/office/drawing/2014/main" id="{74EAE6CF-655C-4950-A15E-D707AC700612}"/>
+                <a16:creationId xmlns:a16="http://schemas.microsoft.com/office/drawing/2014/main" id="{A2E76956-F687-4DC5-B49E-DF769F2ACAE3}"/>
               </a:ext>
             </a:extLst>
           </p:cNvPr>
@@ -13054,7 +13059,7 @@
           <p:cNvPr id="8" name="Section description 3">
             <a:extLst xmlns:a="http://schemas.openxmlformats.org/drawingml/2006/main">
               <a:ext uri="{FF2B5EF4-FFF2-40B4-BE49-F238E27FC236}">
-                <a16:creationId xmlns:a16="http://schemas.microsoft.com/office/drawing/2014/main" id="{FEB766B2-0332-4100-8D7F-6B5F9C4F330F}"/>
+                <a16:creationId xmlns:a16="http://schemas.microsoft.com/office/drawing/2014/main" id="{E037437C-2F5A-4B22-91E2-8CC705DC50AA}"/>
               </a:ext>
             </a:extLst>
           </p:cNvPr>
@@ -13111,7 +13116,7 @@
           <p:cNvPr id="9" name="Completed section 4">
             <a:extLst xmlns:a="http://schemas.openxmlformats.org/drawingml/2006/main">
               <a:ext uri="{FF2B5EF4-FFF2-40B4-BE49-F238E27FC236}">
-                <a16:creationId xmlns:a16="http://schemas.microsoft.com/office/drawing/2014/main" id="{88EC29A8-BC17-4D99-AF71-14854A12572E}"/>
+                <a16:creationId xmlns:a16="http://schemas.microsoft.com/office/drawing/2014/main" id="{4B896032-36B8-4422-B778-70ECAC58C3F0}"/>
               </a:ext>
             </a:extLst>
           </p:cNvPr>
@@ -13168,7 +13173,7 @@
           <p:cNvPr id="10" name="Section description 4">
             <a:extLst xmlns:a="http://schemas.openxmlformats.org/drawingml/2006/main">
               <a:ext uri="{FF2B5EF4-FFF2-40B4-BE49-F238E27FC236}">
-                <a16:creationId xmlns:a16="http://schemas.microsoft.com/office/drawing/2014/main" id="{E0B51085-7EEE-4CEA-9DA4-5630B4891A5E}"/>
+                <a16:creationId xmlns:a16="http://schemas.microsoft.com/office/drawing/2014/main" id="{08DAE03A-4941-41AA-B0C3-4213FA307BF2}"/>
               </a:ext>
             </a:extLst>
           </p:cNvPr>
@@ -13225,7 +13230,7 @@
           <p:cNvPr id="11" name="Active section">
             <a:extLst xmlns:a="http://schemas.openxmlformats.org/drawingml/2006/main">
               <a:ext uri="{FF2B5EF4-FFF2-40B4-BE49-F238E27FC236}">
-                <a16:creationId xmlns:a16="http://schemas.microsoft.com/office/drawing/2014/main" id="{6DAF54AF-B98B-4F4F-B8A8-995ECB1D9382}"/>
+                <a16:creationId xmlns:a16="http://schemas.microsoft.com/office/drawing/2014/main" id="{10EDF5AD-BCDE-4D3C-9DD6-34AB488D7524}"/>
               </a:ext>
             </a:extLst>
           </p:cNvPr>
@@ -13282,7 +13287,7 @@
           <p:cNvPr id="12" name="Section description 5">
             <a:extLst xmlns:a="http://schemas.openxmlformats.org/drawingml/2006/main">
               <a:ext uri="{FF2B5EF4-FFF2-40B4-BE49-F238E27FC236}">
-                <a16:creationId xmlns:a16="http://schemas.microsoft.com/office/drawing/2014/main" id="{6C84DE18-F12B-484B-8228-ABCE9E6C825D}"/>
+                <a16:creationId xmlns:a16="http://schemas.microsoft.com/office/drawing/2014/main" id="{A9CF712D-FC6C-4184-93E0-DC1F6A9A0BF9}"/>
               </a:ext>
             </a:extLst>
           </p:cNvPr>
@@ -13343,7 +13348,7 @@
           <p:nvPr/>
         </p:nvPicPr>
         <p:blipFill>
-          <a:blip xmlns:r="http://schemas.openxmlformats.org/officeDocument/2006/relationships" xmlns:a="http://schemas.openxmlformats.org/drawingml/2006/main" r:embed="R6bb33c0c03544315"/>
+          <a:blip xmlns:r="http://schemas.openxmlformats.org/officeDocument/2006/relationships" xmlns:a="http://schemas.openxmlformats.org/drawingml/2006/main" r:embed="Rfa0bdecf16ae49e8"/>
           <a:stretch xmlns:a="http://schemas.openxmlformats.org/drawingml/2006/main"/>
         </p:blipFill>
         <p:spPr>
@@ -13361,7 +13366,7 @@
           <p:cNvPr id="14" name="Slide number">
             <a:extLst xmlns:a="http://schemas.openxmlformats.org/drawingml/2006/main">
               <a:ext uri="{FF2B5EF4-FFF2-40B4-BE49-F238E27FC236}">
-                <a16:creationId xmlns:a16="http://schemas.microsoft.com/office/drawing/2014/main" id="{2B66ACE0-9F5C-45D6-B1AC-E6A99A2E916E}"/>
+                <a16:creationId xmlns:a16="http://schemas.microsoft.com/office/drawing/2014/main" id="{5677392C-03C9-4BAD-B189-1C0379C5C60D}"/>
               </a:ext>
             </a:extLst>
           </p:cNvPr>
@@ -13416,7 +13421,7 @@
     </p:spTree>
     <p:extLst>
       <p:ext uri="{BB962C8B-B14F-4D97-AF65-F5344CB8AC3E}">
-        <p14:creationId xmlns:p14="http://schemas.microsoft.com/office/powerpoint/2010/main" val="790060053"/>
+        <p14:creationId xmlns:p14="http://schemas.microsoft.com/office/powerpoint/2010/main" val="1221296452"/>
       </p:ext>
     </p:extLst>
   </p:cSld>
@@ -13447,7 +13452,7 @@
           <p:cNvPr id="14" name="Title">
             <a:extLst xmlns:a="http://schemas.openxmlformats.org/drawingml/2006/main">
               <a:ext uri="{FF2B5EF4-FFF2-40B4-BE49-F238E27FC236}">
-                <a16:creationId xmlns:a16="http://schemas.microsoft.com/office/drawing/2014/main" id="{AE4D9B05-2A5C-4623-A9E5-DFFA35683A6F}"/>
+                <a16:creationId xmlns:a16="http://schemas.microsoft.com/office/drawing/2014/main" id="{1AF6DBF1-88C0-4C0A-8FA0-81F742815D1C}"/>
               </a:ext>
             </a:extLst>
           </p:cNvPr>
@@ -13504,7 +13509,7 @@
           <p:cNvPr id="2" name="text">
             <a:extLst xmlns:a="http://schemas.openxmlformats.org/drawingml/2006/main">
               <a:ext uri="{FF2B5EF4-FFF2-40B4-BE49-F238E27FC236}">
-                <a16:creationId xmlns:a16="http://schemas.microsoft.com/office/drawing/2014/main" id="{602EF712-5C59-4AB6-92F1-76C257049C01}"/>
+                <a16:creationId xmlns:a16="http://schemas.microsoft.com/office/drawing/2014/main" id="{C9BA4B5D-B092-4518-9333-81EC90A4B77F}"/>
               </a:ext>
             </a:extLst>
           </p:cNvPr>
@@ -13561,7 +13566,7 @@
           <p:cNvPr id="3" name="text">
             <a:extLst xmlns:a="http://schemas.openxmlformats.org/drawingml/2006/main">
               <a:ext uri="{FF2B5EF4-FFF2-40B4-BE49-F238E27FC236}">
-                <a16:creationId xmlns:a16="http://schemas.microsoft.com/office/drawing/2014/main" id="{D4400E39-31B1-4E96-9B0D-ABD94FEFE293}"/>
+                <a16:creationId xmlns:a16="http://schemas.microsoft.com/office/drawing/2014/main" id="{F4A6D235-ABC8-458A-9189-69D5D773C64B}"/>
               </a:ext>
             </a:extLst>
           </p:cNvPr>
@@ -13618,7 +13623,7 @@
           <p:cNvPr id="4" name="text">
             <a:extLst xmlns:a="http://schemas.openxmlformats.org/drawingml/2006/main">
               <a:ext uri="{FF2B5EF4-FFF2-40B4-BE49-F238E27FC236}">
-                <a16:creationId xmlns:a16="http://schemas.microsoft.com/office/drawing/2014/main" id="{5AC3ED76-AAF8-4D4B-861E-8B72B73FA0BC}"/>
+                <a16:creationId xmlns:a16="http://schemas.microsoft.com/office/drawing/2014/main" id="{B4C4914D-A5FD-4F9A-9ADE-A345918511B9}"/>
               </a:ext>
             </a:extLst>
           </p:cNvPr>
@@ -13675,7 +13680,7 @@
           <p:cNvPr id="5" name="text">
             <a:extLst xmlns:a="http://schemas.openxmlformats.org/drawingml/2006/main">
               <a:ext uri="{FF2B5EF4-FFF2-40B4-BE49-F238E27FC236}">
-                <a16:creationId xmlns:a16="http://schemas.microsoft.com/office/drawing/2014/main" id="{45296F50-FD25-49DC-9C3A-4443F464CFF9}"/>
+                <a16:creationId xmlns:a16="http://schemas.microsoft.com/office/drawing/2014/main" id="{C6A1C7DE-8240-40E5-812E-B274F3C392AD}"/>
               </a:ext>
             </a:extLst>
           </p:cNvPr>
@@ -13732,7 +13737,7 @@
           <p:cNvPr id="6" name="text">
             <a:extLst xmlns:a="http://schemas.openxmlformats.org/drawingml/2006/main">
               <a:ext uri="{FF2B5EF4-FFF2-40B4-BE49-F238E27FC236}">
-                <a16:creationId xmlns:a16="http://schemas.microsoft.com/office/drawing/2014/main" id="{628FB49C-F732-457D-94B9-E88F142B90D0}"/>
+                <a16:creationId xmlns:a16="http://schemas.microsoft.com/office/drawing/2014/main" id="{EF709B09-DDDE-4766-9E40-B1BA1031CC4E}"/>
               </a:ext>
             </a:extLst>
           </p:cNvPr>
@@ -13789,7 +13794,7 @@
           <p:cNvPr id="7" name="text">
             <a:extLst xmlns:a="http://schemas.openxmlformats.org/drawingml/2006/main">
               <a:ext uri="{FF2B5EF4-FFF2-40B4-BE49-F238E27FC236}">
-                <a16:creationId xmlns:a16="http://schemas.microsoft.com/office/drawing/2014/main" id="{3503A2B7-EC04-4C11-8FCA-EA821A8F2595}"/>
+                <a16:creationId xmlns:a16="http://schemas.microsoft.com/office/drawing/2014/main" id="{0E201D42-5A77-4E5F-8094-05B1D89B952C}"/>
               </a:ext>
             </a:extLst>
           </p:cNvPr>
@@ -13846,7 +13851,7 @@
           <p:cNvPr id="8" name="text">
             <a:extLst xmlns:a="http://schemas.openxmlformats.org/drawingml/2006/main">
               <a:ext uri="{FF2B5EF4-FFF2-40B4-BE49-F238E27FC236}">
-                <a16:creationId xmlns:a16="http://schemas.microsoft.com/office/drawing/2014/main" id="{0330BE7D-833B-45F9-9B22-C1D254FD6175}"/>
+                <a16:creationId xmlns:a16="http://schemas.microsoft.com/office/drawing/2014/main" id="{A5E0F26C-0988-43B0-AC9A-48D62E9EF549}"/>
               </a:ext>
             </a:extLst>
           </p:cNvPr>
@@ -13903,7 +13908,7 @@
           <p:cNvPr id="9" name="text">
             <a:extLst xmlns:a="http://schemas.openxmlformats.org/drawingml/2006/main">
               <a:ext uri="{FF2B5EF4-FFF2-40B4-BE49-F238E27FC236}">
-                <a16:creationId xmlns:a16="http://schemas.microsoft.com/office/drawing/2014/main" id="{BC3BD6C1-4DBF-4DB6-992F-6547A8BE19E6}"/>
+                <a16:creationId xmlns:a16="http://schemas.microsoft.com/office/drawing/2014/main" id="{4E7C2EEF-4ECB-451A-9B87-28B8A6A6C3D1}"/>
               </a:ext>
             </a:extLst>
           </p:cNvPr>
@@ -13960,7 +13965,7 @@
           <p:cNvPr id="10" name="text">
             <a:extLst xmlns:a="http://schemas.openxmlformats.org/drawingml/2006/main">
               <a:ext uri="{FF2B5EF4-FFF2-40B4-BE49-F238E27FC236}">
-                <a16:creationId xmlns:a16="http://schemas.microsoft.com/office/drawing/2014/main" id="{367366EC-64FB-4280-9998-AE77F54A21B4}"/>
+                <a16:creationId xmlns:a16="http://schemas.microsoft.com/office/drawing/2014/main" id="{E01D2AED-CEDD-4F88-A3ED-1B61C06D46C0}"/>
               </a:ext>
             </a:extLst>
           </p:cNvPr>
@@ -14017,7 +14022,7 @@
           <p:cNvPr id="11" name="text">
             <a:extLst xmlns:a="http://schemas.openxmlformats.org/drawingml/2006/main">
               <a:ext uri="{FF2B5EF4-FFF2-40B4-BE49-F238E27FC236}">
-                <a16:creationId xmlns:a16="http://schemas.microsoft.com/office/drawing/2014/main" id="{FEB67F59-1680-4C39-8A4F-439F12757F46}"/>
+                <a16:creationId xmlns:a16="http://schemas.microsoft.com/office/drawing/2014/main" id="{0EBBADCF-328C-4414-B802-0E6EDC92AED1}"/>
               </a:ext>
             </a:extLst>
           </p:cNvPr>
@@ -14074,7 +14079,7 @@
           <p:cNvPr id="12" name="text">
             <a:extLst xmlns:a="http://schemas.openxmlformats.org/drawingml/2006/main">
               <a:ext uri="{FF2B5EF4-FFF2-40B4-BE49-F238E27FC236}">
-                <a16:creationId xmlns:a16="http://schemas.microsoft.com/office/drawing/2014/main" id="{C75A6EF1-9281-4A35-96CB-4F9BB3E61BCF}"/>
+                <a16:creationId xmlns:a16="http://schemas.microsoft.com/office/drawing/2014/main" id="{66CDFA8D-1554-410C-BCC1-BDB5594DEB1F}"/>
               </a:ext>
             </a:extLst>
           </p:cNvPr>
@@ -14131,7 +14136,7 @@
           <p:cNvPr id="13" name="Slide number">
             <a:extLst xmlns:a="http://schemas.openxmlformats.org/drawingml/2006/main">
               <a:ext uri="{FF2B5EF4-FFF2-40B4-BE49-F238E27FC236}">
-                <a16:creationId xmlns:a16="http://schemas.microsoft.com/office/drawing/2014/main" id="{CE036FAE-8CFB-495E-9633-3E3686066400}"/>
+                <a16:creationId xmlns:a16="http://schemas.microsoft.com/office/drawing/2014/main" id="{9611F3A9-409B-46C4-97E8-9068909AC1AD}"/>
               </a:ext>
             </a:extLst>
           </p:cNvPr>
@@ -14186,7 +14191,7 @@
     </p:spTree>
     <p:extLst>
       <p:ext uri="{BB962C8B-B14F-4D97-AF65-F5344CB8AC3E}">
-        <p14:creationId xmlns:p14="http://schemas.microsoft.com/office/powerpoint/2010/main" val="323235022"/>
+        <p14:creationId xmlns:p14="http://schemas.microsoft.com/office/powerpoint/2010/main" val="19839791"/>
       </p:ext>
     </p:extLst>
   </p:cSld>
@@ -14217,7 +14222,7 @@
           <p:cNvPr id="9" name="Title">
             <a:extLst xmlns:a="http://schemas.openxmlformats.org/drawingml/2006/main">
               <a:ext uri="{FF2B5EF4-FFF2-40B4-BE49-F238E27FC236}">
-                <a16:creationId xmlns:a16="http://schemas.microsoft.com/office/drawing/2014/main" id="{5008DA1C-A2DA-470F-BDF5-3A1B273DD54A}"/>
+                <a16:creationId xmlns:a16="http://schemas.microsoft.com/office/drawing/2014/main" id="{45157D8D-D6F6-4528-9EBD-30551F797CAC}"/>
               </a:ext>
             </a:extLst>
           </p:cNvPr>
@@ -14281,7 +14286,7 @@
         </p:xfrm>
         <a:graphic xmlns:a="http://schemas.openxmlformats.org/drawingml/2006/main">
           <a:graphicData uri="http://schemas.openxmlformats.org/drawingml/2006/chart">
-            <c:chart xmlns:r="http://schemas.openxmlformats.org/officeDocument/2006/relationships" xmlns:c="http://schemas.openxmlformats.org/drawingml/2006/chart" r:id="R50f8a824fb4a489e"/>
+            <c:chart xmlns:r="http://schemas.openxmlformats.org/officeDocument/2006/relationships" xmlns:c="http://schemas.openxmlformats.org/drawingml/2006/chart" r:id="Rfb0cb4ca1ebf4843"/>
           </a:graphicData>
         </a:graphic>
       </p:graphicFrame>
@@ -14290,7 +14295,7 @@
           <p:cNvPr id="3" name="Date label">
             <a:extLst xmlns:a="http://schemas.openxmlformats.org/drawingml/2006/main">
               <a:ext uri="{FF2B5EF4-FFF2-40B4-BE49-F238E27FC236}">
-                <a16:creationId xmlns:a16="http://schemas.microsoft.com/office/drawing/2014/main" id="{62E3AE39-0E6C-4DE9-A861-B6B03B956BAB}"/>
+                <a16:creationId xmlns:a16="http://schemas.microsoft.com/office/drawing/2014/main" id="{4D94CFA1-ACE0-41FD-A9B1-FDA327B2643E}"/>
               </a:ext>
             </a:extLst>
           </p:cNvPr>
@@ -14347,7 +14352,7 @@
           <p:cNvPr id="4" name="Date label">
             <a:extLst xmlns:a="http://schemas.openxmlformats.org/drawingml/2006/main">
               <a:ext uri="{FF2B5EF4-FFF2-40B4-BE49-F238E27FC236}">
-                <a16:creationId xmlns:a16="http://schemas.microsoft.com/office/drawing/2014/main" id="{3701E9B8-04BC-4102-80CC-98B77DD082B3}"/>
+                <a16:creationId xmlns:a16="http://schemas.microsoft.com/office/drawing/2014/main" id="{DB28A6E3-C469-4490-B863-A7382EB6DD44}"/>
               </a:ext>
             </a:extLst>
           </p:cNvPr>
@@ -14404,7 +14409,7 @@
           <p:cNvPr id="5" name="Date label">
             <a:extLst xmlns:a="http://schemas.openxmlformats.org/drawingml/2006/main">
               <a:ext uri="{FF2B5EF4-FFF2-40B4-BE49-F238E27FC236}">
-                <a16:creationId xmlns:a16="http://schemas.microsoft.com/office/drawing/2014/main" id="{A64F35CD-E536-4E8B-8E5F-01E5403D863C}"/>
+                <a16:creationId xmlns:a16="http://schemas.microsoft.com/office/drawing/2014/main" id="{A9888C04-A8FA-4171-A270-804B58A6E3AA}"/>
               </a:ext>
             </a:extLst>
           </p:cNvPr>
@@ -14461,7 +14466,7 @@
           <p:cNvPr id="6" name="Date label">
             <a:extLst xmlns:a="http://schemas.openxmlformats.org/drawingml/2006/main">
               <a:ext uri="{FF2B5EF4-FFF2-40B4-BE49-F238E27FC236}">
-                <a16:creationId xmlns:a16="http://schemas.microsoft.com/office/drawing/2014/main" id="{30A999D4-A532-4472-AABD-D5B87CAC6241}"/>
+                <a16:creationId xmlns:a16="http://schemas.microsoft.com/office/drawing/2014/main" id="{04B11676-61E6-45EC-909C-4950D4466B67}"/>
               </a:ext>
             </a:extLst>
           </p:cNvPr>
@@ -14518,7 +14523,7 @@
           <p:cNvPr id="7" name="Methodology">
             <a:extLst xmlns:a="http://schemas.openxmlformats.org/drawingml/2006/main">
               <a:ext uri="{FF2B5EF4-FFF2-40B4-BE49-F238E27FC236}">
-                <a16:creationId xmlns:a16="http://schemas.microsoft.com/office/drawing/2014/main" id="{EDB43C70-1888-4878-AF5A-894FEFC66C3D}"/>
+                <a16:creationId xmlns:a16="http://schemas.microsoft.com/office/drawing/2014/main" id="{42EC145A-CE76-4211-ABDA-5B58747E1698}"/>
               </a:ext>
             </a:extLst>
           </p:cNvPr>
@@ -14598,7 +14603,7 @@
           <p:cNvPr id="8" name="Slide number">
             <a:extLst xmlns:a="http://schemas.openxmlformats.org/drawingml/2006/main">
               <a:ext uri="{FF2B5EF4-FFF2-40B4-BE49-F238E27FC236}">
-                <a16:creationId xmlns:a16="http://schemas.microsoft.com/office/drawing/2014/main" id="{B0367C67-0575-49F6-8AF1-63FFE37F8A38}"/>
+                <a16:creationId xmlns:a16="http://schemas.microsoft.com/office/drawing/2014/main" id="{4A3BC585-FC2F-48D4-BBDE-240EA5C8AE2E}"/>
               </a:ext>
             </a:extLst>
           </p:cNvPr>
@@ -14653,7 +14658,7 @@
     </p:spTree>
     <p:extLst>
       <p:ext uri="{BB962C8B-B14F-4D97-AF65-F5344CB8AC3E}">
-        <p14:creationId xmlns:p14="http://schemas.microsoft.com/office/powerpoint/2010/main" val="2100586113"/>
+        <p14:creationId xmlns:p14="http://schemas.microsoft.com/office/powerpoint/2010/main" val="659791837"/>
       </p:ext>
     </p:extLst>
   </p:cSld>
@@ -14684,7 +14689,7 @@
           <p:cNvPr id="16" name="Completed section 0">
             <a:extLst xmlns:a="http://schemas.openxmlformats.org/drawingml/2006/main">
               <a:ext uri="{FF2B5EF4-FFF2-40B4-BE49-F238E27FC236}">
-                <a16:creationId xmlns:a16="http://schemas.microsoft.com/office/drawing/2014/main" id="{80A9A7C3-C73E-409C-A715-F8CEC33EC6CD}"/>
+                <a16:creationId xmlns:a16="http://schemas.microsoft.com/office/drawing/2014/main" id="{8DBE2E48-E4D6-4746-8932-5737ACD95A85}"/>
               </a:ext>
             </a:extLst>
           </p:cNvPr>
@@ -14741,7 +14746,7 @@
           <p:cNvPr id="2" name="Section description 0">
             <a:extLst xmlns:a="http://schemas.openxmlformats.org/drawingml/2006/main">
               <a:ext uri="{FF2B5EF4-FFF2-40B4-BE49-F238E27FC236}">
-                <a16:creationId xmlns:a16="http://schemas.microsoft.com/office/drawing/2014/main" id="{E3AFC1B9-EFAC-4176-945E-C08F9BD2E3CA}"/>
+                <a16:creationId xmlns:a16="http://schemas.microsoft.com/office/drawing/2014/main" id="{20ABC02C-6451-47D7-9FCE-0880AB60BDD4}"/>
               </a:ext>
             </a:extLst>
           </p:cNvPr>
@@ -14798,7 +14803,7 @@
           <p:cNvPr id="3" name="Completed section 1">
             <a:extLst xmlns:a="http://schemas.openxmlformats.org/drawingml/2006/main">
               <a:ext uri="{FF2B5EF4-FFF2-40B4-BE49-F238E27FC236}">
-                <a16:creationId xmlns:a16="http://schemas.microsoft.com/office/drawing/2014/main" id="{D1CEA0BE-78E9-4144-8555-C5B87B9578D9}"/>
+                <a16:creationId xmlns:a16="http://schemas.microsoft.com/office/drawing/2014/main" id="{23DE937B-A4A1-4567-8CE7-854939C60358}"/>
               </a:ext>
             </a:extLst>
           </p:cNvPr>
@@ -14855,7 +14860,7 @@
           <p:cNvPr id="4" name="Section description 1">
             <a:extLst xmlns:a="http://schemas.openxmlformats.org/drawingml/2006/main">
               <a:ext uri="{FF2B5EF4-FFF2-40B4-BE49-F238E27FC236}">
-                <a16:creationId xmlns:a16="http://schemas.microsoft.com/office/drawing/2014/main" id="{D400C854-254B-4A50-A820-72A3DCC12CD5}"/>
+                <a16:creationId xmlns:a16="http://schemas.microsoft.com/office/drawing/2014/main" id="{BB542C8E-2AB3-4F3D-AA58-F9B6FFB04BE4}"/>
               </a:ext>
             </a:extLst>
           </p:cNvPr>
@@ -14912,7 +14917,7 @@
           <p:cNvPr id="5" name="Completed section 2">
             <a:extLst xmlns:a="http://schemas.openxmlformats.org/drawingml/2006/main">
               <a:ext uri="{FF2B5EF4-FFF2-40B4-BE49-F238E27FC236}">
-                <a16:creationId xmlns:a16="http://schemas.microsoft.com/office/drawing/2014/main" id="{4E54D0DE-FDA4-4901-A4E6-F3637D47F694}"/>
+                <a16:creationId xmlns:a16="http://schemas.microsoft.com/office/drawing/2014/main" id="{491B462A-25B8-419C-909C-EB4463271457}"/>
               </a:ext>
             </a:extLst>
           </p:cNvPr>
@@ -14969,7 +14974,7 @@
           <p:cNvPr id="6" name="Section description 2">
             <a:extLst xmlns:a="http://schemas.openxmlformats.org/drawingml/2006/main">
               <a:ext uri="{FF2B5EF4-FFF2-40B4-BE49-F238E27FC236}">
-                <a16:creationId xmlns:a16="http://schemas.microsoft.com/office/drawing/2014/main" id="{D79F68B5-DE95-42B2-8D6B-F165CECA70D0}"/>
+                <a16:creationId xmlns:a16="http://schemas.microsoft.com/office/drawing/2014/main" id="{21DCD568-1F14-4020-8450-5833B9C8C50B}"/>
               </a:ext>
             </a:extLst>
           </p:cNvPr>
@@ -15026,7 +15031,7 @@
           <p:cNvPr id="7" name="Completed section 3">
             <a:extLst xmlns:a="http://schemas.openxmlformats.org/drawingml/2006/main">
               <a:ext uri="{FF2B5EF4-FFF2-40B4-BE49-F238E27FC236}">
-                <a16:creationId xmlns:a16="http://schemas.microsoft.com/office/drawing/2014/main" id="{FFE4913C-83D5-4E85-BBE7-DFF04B3A329D}"/>
+                <a16:creationId xmlns:a16="http://schemas.microsoft.com/office/drawing/2014/main" id="{BBD32A9E-AFCC-437F-99CE-8919421FAAB6}"/>
               </a:ext>
             </a:extLst>
           </p:cNvPr>
@@ -15083,7 +15088,7 @@
           <p:cNvPr id="8" name="Section description 3">
             <a:extLst xmlns:a="http://schemas.openxmlformats.org/drawingml/2006/main">
               <a:ext uri="{FF2B5EF4-FFF2-40B4-BE49-F238E27FC236}">
-                <a16:creationId xmlns:a16="http://schemas.microsoft.com/office/drawing/2014/main" id="{60DFE702-870B-4BAF-9817-5086ED4AE91B}"/>
+                <a16:creationId xmlns:a16="http://schemas.microsoft.com/office/drawing/2014/main" id="{9C81D5BE-56D5-482A-AFBE-64344AD75E19}"/>
               </a:ext>
             </a:extLst>
           </p:cNvPr>
@@ -15140,7 +15145,7 @@
           <p:cNvPr id="9" name="Completed section 4">
             <a:extLst xmlns:a="http://schemas.openxmlformats.org/drawingml/2006/main">
               <a:ext uri="{FF2B5EF4-FFF2-40B4-BE49-F238E27FC236}">
-                <a16:creationId xmlns:a16="http://schemas.microsoft.com/office/drawing/2014/main" id="{077C84DB-9456-41F9-A270-A14280ABFCCF}"/>
+                <a16:creationId xmlns:a16="http://schemas.microsoft.com/office/drawing/2014/main" id="{868F81CA-F535-4CCA-A11B-C71856154F91}"/>
               </a:ext>
             </a:extLst>
           </p:cNvPr>
@@ -15197,7 +15202,7 @@
           <p:cNvPr id="10" name="Section description 4">
             <a:extLst xmlns:a="http://schemas.openxmlformats.org/drawingml/2006/main">
               <a:ext uri="{FF2B5EF4-FFF2-40B4-BE49-F238E27FC236}">
-                <a16:creationId xmlns:a16="http://schemas.microsoft.com/office/drawing/2014/main" id="{5127C9CA-6E80-4FAF-B0EC-572566864013}"/>
+                <a16:creationId xmlns:a16="http://schemas.microsoft.com/office/drawing/2014/main" id="{ED2C9B76-2617-4C76-A369-626195CEE680}"/>
               </a:ext>
             </a:extLst>
           </p:cNvPr>
@@ -15254,7 +15259,7 @@
           <p:cNvPr id="11" name="Completed section 5">
             <a:extLst xmlns:a="http://schemas.openxmlformats.org/drawingml/2006/main">
               <a:ext uri="{FF2B5EF4-FFF2-40B4-BE49-F238E27FC236}">
-                <a16:creationId xmlns:a16="http://schemas.microsoft.com/office/drawing/2014/main" id="{FB8814B9-3C79-4694-938E-37F1114C628E}"/>
+                <a16:creationId xmlns:a16="http://schemas.microsoft.com/office/drawing/2014/main" id="{67F4A18F-E115-4779-B772-2A053D92FEF1}"/>
               </a:ext>
             </a:extLst>
           </p:cNvPr>
@@ -15311,7 +15316,7 @@
           <p:cNvPr id="12" name="Section description 5">
             <a:extLst xmlns:a="http://schemas.openxmlformats.org/drawingml/2006/main">
               <a:ext uri="{FF2B5EF4-FFF2-40B4-BE49-F238E27FC236}">
-                <a16:creationId xmlns:a16="http://schemas.microsoft.com/office/drawing/2014/main" id="{4B1C40E1-53F5-4819-961F-F11D49B0ACE7}"/>
+                <a16:creationId xmlns:a16="http://schemas.microsoft.com/office/drawing/2014/main" id="{57A9997D-B759-4AD4-A730-426DB68D3810}"/>
               </a:ext>
             </a:extLst>
           </p:cNvPr>
@@ -15368,7 +15373,7 @@
           <p:cNvPr id="13" name="Active section">
             <a:extLst xmlns:a="http://schemas.openxmlformats.org/drawingml/2006/main">
               <a:ext uri="{FF2B5EF4-FFF2-40B4-BE49-F238E27FC236}">
-                <a16:creationId xmlns:a16="http://schemas.microsoft.com/office/drawing/2014/main" id="{ABB16E36-2EE4-48F0-B971-810672A80E66}"/>
+                <a16:creationId xmlns:a16="http://schemas.microsoft.com/office/drawing/2014/main" id="{3C069916-59D2-4530-B06C-DF3C4F705427}"/>
               </a:ext>
             </a:extLst>
           </p:cNvPr>
@@ -15425,7 +15430,7 @@
           <p:cNvPr id="14" name="Section description 6">
             <a:extLst xmlns:a="http://schemas.openxmlformats.org/drawingml/2006/main">
               <a:ext uri="{FF2B5EF4-FFF2-40B4-BE49-F238E27FC236}">
-                <a16:creationId xmlns:a16="http://schemas.microsoft.com/office/drawing/2014/main" id="{51B5DF06-CA37-4252-9A68-2308FCB64FA5}"/>
+                <a16:creationId xmlns:a16="http://schemas.microsoft.com/office/drawing/2014/main" id="{DF4505B2-0B7C-48E6-AF52-82D0A2033001}"/>
               </a:ext>
             </a:extLst>
           </p:cNvPr>
@@ -15482,7 +15487,7 @@
           <p:cNvPr id="15" name="Slide number">
             <a:extLst xmlns:a="http://schemas.openxmlformats.org/drawingml/2006/main">
               <a:ext uri="{FF2B5EF4-FFF2-40B4-BE49-F238E27FC236}">
-                <a16:creationId xmlns:a16="http://schemas.microsoft.com/office/drawing/2014/main" id="{648C866B-8862-464E-8960-236DF4F2DCF8}"/>
+                <a16:creationId xmlns:a16="http://schemas.microsoft.com/office/drawing/2014/main" id="{4C398D40-2CB2-4730-A79E-2386A17CB592}"/>
               </a:ext>
             </a:extLst>
           </p:cNvPr>
@@ -15537,7 +15542,7 @@
     </p:spTree>
     <p:extLst>
       <p:ext uri="{BB962C8B-B14F-4D97-AF65-F5344CB8AC3E}">
-        <p14:creationId xmlns:p14="http://schemas.microsoft.com/office/powerpoint/2010/main" val="79176917"/>
+        <p14:creationId xmlns:p14="http://schemas.microsoft.com/office/powerpoint/2010/main" val="49434697"/>
       </p:ext>
     </p:extLst>
   </p:cSld>
@@ -15568,7 +15573,7 @@
           <p:cNvPr id="12" name="Title">
             <a:extLst xmlns:a="http://schemas.openxmlformats.org/drawingml/2006/main">
               <a:ext uri="{FF2B5EF4-FFF2-40B4-BE49-F238E27FC236}">
-                <a16:creationId xmlns:a16="http://schemas.microsoft.com/office/drawing/2014/main" id="{A1A90384-BD75-4366-B727-62D69FF55CF4}"/>
+                <a16:creationId xmlns:a16="http://schemas.microsoft.com/office/drawing/2014/main" id="{2B27D7BB-36BD-4438-BF51-8031BB4F0BCB}"/>
               </a:ext>
             </a:extLst>
           </p:cNvPr>
@@ -15625,7 +15630,7 @@
           <p:cNvPr id="2" name="text">
             <a:extLst xmlns:a="http://schemas.openxmlformats.org/drawingml/2006/main">
               <a:ext uri="{FF2B5EF4-FFF2-40B4-BE49-F238E27FC236}">
-                <a16:creationId xmlns:a16="http://schemas.microsoft.com/office/drawing/2014/main" id="{D74069A7-E5CB-4D24-A22F-F3AA3663EE5C}"/>
+                <a16:creationId xmlns:a16="http://schemas.microsoft.com/office/drawing/2014/main" id="{9382F438-4CF1-4E11-975F-0C4D086FCCED}"/>
               </a:ext>
             </a:extLst>
           </p:cNvPr>
@@ -15682,7 +15687,7 @@
           <p:cNvPr id="3" name="text">
             <a:extLst xmlns:a="http://schemas.openxmlformats.org/drawingml/2006/main">
               <a:ext uri="{FF2B5EF4-FFF2-40B4-BE49-F238E27FC236}">
-                <a16:creationId xmlns:a16="http://schemas.microsoft.com/office/drawing/2014/main" id="{AC77D9F4-2F68-490A-9EBF-E78BFF2B65ED}"/>
+                <a16:creationId xmlns:a16="http://schemas.microsoft.com/office/drawing/2014/main" id="{6CD22075-36EF-4A13-8CBA-20375B23F966}"/>
               </a:ext>
             </a:extLst>
           </p:cNvPr>
@@ -15739,7 +15744,7 @@
           <p:cNvPr id="4" name="text">
             <a:extLst xmlns:a="http://schemas.openxmlformats.org/drawingml/2006/main">
               <a:ext uri="{FF2B5EF4-FFF2-40B4-BE49-F238E27FC236}">
-                <a16:creationId xmlns:a16="http://schemas.microsoft.com/office/drawing/2014/main" id="{AB7582BD-450C-45FD-B1C4-AB47227124AF}"/>
+                <a16:creationId xmlns:a16="http://schemas.microsoft.com/office/drawing/2014/main" id="{D77F08F0-0F84-4FFA-AB90-9450C5D0BC51}"/>
               </a:ext>
             </a:extLst>
           </p:cNvPr>
@@ -15796,7 +15801,7 @@
           <p:cNvPr id="5" name="text">
             <a:extLst xmlns:a="http://schemas.openxmlformats.org/drawingml/2006/main">
               <a:ext uri="{FF2B5EF4-FFF2-40B4-BE49-F238E27FC236}">
-                <a16:creationId xmlns:a16="http://schemas.microsoft.com/office/drawing/2014/main" id="{85B4AA40-2117-44AE-B73F-06DF1CA0BE31}"/>
+                <a16:creationId xmlns:a16="http://schemas.microsoft.com/office/drawing/2014/main" id="{4CAE414C-E959-419D-AD48-8EA1CC8FC821}"/>
               </a:ext>
             </a:extLst>
           </p:cNvPr>
@@ -15853,7 +15858,7 @@
           <p:cNvPr id="6" name="text">
             <a:extLst xmlns:a="http://schemas.openxmlformats.org/drawingml/2006/main">
               <a:ext uri="{FF2B5EF4-FFF2-40B4-BE49-F238E27FC236}">
-                <a16:creationId xmlns:a16="http://schemas.microsoft.com/office/drawing/2014/main" id="{76067234-B2EF-4DAA-AC01-DA130DED55ED}"/>
+                <a16:creationId xmlns:a16="http://schemas.microsoft.com/office/drawing/2014/main" id="{26C6FCE2-2F02-413C-B7E3-222BEE208E18}"/>
               </a:ext>
             </a:extLst>
           </p:cNvPr>
@@ -15910,7 +15915,7 @@
           <p:cNvPr id="7" name="text">
             <a:extLst xmlns:a="http://schemas.openxmlformats.org/drawingml/2006/main">
               <a:ext uri="{FF2B5EF4-FFF2-40B4-BE49-F238E27FC236}">
-                <a16:creationId xmlns:a16="http://schemas.microsoft.com/office/drawing/2014/main" id="{A2FDA493-AFC2-4302-A272-E455BC3A1AAE}"/>
+                <a16:creationId xmlns:a16="http://schemas.microsoft.com/office/drawing/2014/main" id="{CA5647D2-4E83-446F-B3C4-06010A411E45}"/>
               </a:ext>
             </a:extLst>
           </p:cNvPr>
@@ -15967,7 +15972,7 @@
           <p:cNvPr id="8" name="text">
             <a:extLst xmlns:a="http://schemas.openxmlformats.org/drawingml/2006/main">
               <a:ext uri="{FF2B5EF4-FFF2-40B4-BE49-F238E27FC236}">
-                <a16:creationId xmlns:a16="http://schemas.microsoft.com/office/drawing/2014/main" id="{08A3EC5B-F833-457B-B01E-04D8AF17DFBC}"/>
+                <a16:creationId xmlns:a16="http://schemas.microsoft.com/office/drawing/2014/main" id="{5841546A-515E-4CF2-A310-C9867CFD81E5}"/>
               </a:ext>
             </a:extLst>
           </p:cNvPr>
@@ -16024,7 +16029,7 @@
           <p:cNvPr id="9" name="text">
             <a:extLst xmlns:a="http://schemas.openxmlformats.org/drawingml/2006/main">
               <a:ext uri="{FF2B5EF4-FFF2-40B4-BE49-F238E27FC236}">
-                <a16:creationId xmlns:a16="http://schemas.microsoft.com/office/drawing/2014/main" id="{34360EF6-B7CD-4FD0-B58A-BD0F13723DC1}"/>
+                <a16:creationId xmlns:a16="http://schemas.microsoft.com/office/drawing/2014/main" id="{FC8C36EB-75C6-4DA6-AC06-9DEA83C3469B}"/>
               </a:ext>
             </a:extLst>
           </p:cNvPr>
@@ -16081,7 +16086,7 @@
           <p:cNvPr id="10" name="text">
             <a:extLst xmlns:a="http://schemas.openxmlformats.org/drawingml/2006/main">
               <a:ext uri="{FF2B5EF4-FFF2-40B4-BE49-F238E27FC236}">
-                <a16:creationId xmlns:a16="http://schemas.microsoft.com/office/drawing/2014/main" id="{32AD5942-60D7-4094-9025-BD6BE1BF2985}"/>
+                <a16:creationId xmlns:a16="http://schemas.microsoft.com/office/drawing/2014/main" id="{84BA36EA-F957-4C87-9508-82C4EE39706A}"/>
               </a:ext>
             </a:extLst>
           </p:cNvPr>
@@ -16138,7 +16143,7 @@
           <p:cNvPr id="11" name="Slide number">
             <a:extLst xmlns:a="http://schemas.openxmlformats.org/drawingml/2006/main">
               <a:ext uri="{FF2B5EF4-FFF2-40B4-BE49-F238E27FC236}">
-                <a16:creationId xmlns:a16="http://schemas.microsoft.com/office/drawing/2014/main" id="{0D9AB200-F241-433B-979D-FA8416136904}"/>
+                <a16:creationId xmlns:a16="http://schemas.microsoft.com/office/drawing/2014/main" id="{6116B759-2753-405F-86E8-1AF1E7C0BB9B}"/>
               </a:ext>
             </a:extLst>
           </p:cNvPr>
@@ -16193,7 +16198,7 @@
     </p:spTree>
     <p:extLst>
       <p:ext uri="{BB962C8B-B14F-4D97-AF65-F5344CB8AC3E}">
-        <p14:creationId xmlns:p14="http://schemas.microsoft.com/office/powerpoint/2010/main" val="271306707"/>
+        <p14:creationId xmlns:p14="http://schemas.microsoft.com/office/powerpoint/2010/main" val="1665081484"/>
       </p:ext>
     </p:extLst>
   </p:cSld>
@@ -16224,7 +16229,7 @@
           <p:cNvPr id="10" name="Title">
             <a:extLst xmlns:a="http://schemas.openxmlformats.org/drawingml/2006/main">
               <a:ext uri="{FF2B5EF4-FFF2-40B4-BE49-F238E27FC236}">
-                <a16:creationId xmlns:a16="http://schemas.microsoft.com/office/drawing/2014/main" id="{C7EA056B-0C64-4723-AC9B-9BFA8A8EB6F6}"/>
+                <a16:creationId xmlns:a16="http://schemas.microsoft.com/office/drawing/2014/main" id="{4362546F-1ED1-418D-83C0-BFC1A048A680}"/>
               </a:ext>
             </a:extLst>
           </p:cNvPr>
@@ -16281,7 +16286,7 @@
           <p:cNvPr id="2" name="text">
             <a:extLst xmlns:a="http://schemas.openxmlformats.org/drawingml/2006/main">
               <a:ext uri="{FF2B5EF4-FFF2-40B4-BE49-F238E27FC236}">
-                <a16:creationId xmlns:a16="http://schemas.microsoft.com/office/drawing/2014/main" id="{C040A7B0-FB97-44DA-9069-B3CC959C9626}"/>
+                <a16:creationId xmlns:a16="http://schemas.microsoft.com/office/drawing/2014/main" id="{A56D12EF-BCED-4F48-ADBD-D1DC7389097A}"/>
               </a:ext>
             </a:extLst>
           </p:cNvPr>
@@ -16338,7 +16343,7 @@
           <p:cNvPr id="3" name="text">
             <a:extLst xmlns:a="http://schemas.openxmlformats.org/drawingml/2006/main">
               <a:ext uri="{FF2B5EF4-FFF2-40B4-BE49-F238E27FC236}">
-                <a16:creationId xmlns:a16="http://schemas.microsoft.com/office/drawing/2014/main" id="{17065BFC-EE66-456E-A92A-FD2CBB172DCA}"/>
+                <a16:creationId xmlns:a16="http://schemas.microsoft.com/office/drawing/2014/main" id="{BC56DF17-B651-4FE8-AC48-E44B673F463D}"/>
               </a:ext>
             </a:extLst>
           </p:cNvPr>
@@ -16395,7 +16400,7 @@
           <p:cNvPr id="4" name="text">
             <a:extLst xmlns:a="http://schemas.openxmlformats.org/drawingml/2006/main">
               <a:ext uri="{FF2B5EF4-FFF2-40B4-BE49-F238E27FC236}">
-                <a16:creationId xmlns:a16="http://schemas.microsoft.com/office/drawing/2014/main" id="{2418602B-51C9-4868-8205-D9728BA59099}"/>
+                <a16:creationId xmlns:a16="http://schemas.microsoft.com/office/drawing/2014/main" id="{2140DF3E-13A8-4476-8426-AEB313E0685E}"/>
               </a:ext>
             </a:extLst>
           </p:cNvPr>
@@ -16452,7 +16457,7 @@
           <p:cNvPr id="5" name="text">
             <a:extLst xmlns:a="http://schemas.openxmlformats.org/drawingml/2006/main">
               <a:ext uri="{FF2B5EF4-FFF2-40B4-BE49-F238E27FC236}">
-                <a16:creationId xmlns:a16="http://schemas.microsoft.com/office/drawing/2014/main" id="{28306EE5-F796-4187-B1FD-F7D577A70C4F}"/>
+                <a16:creationId xmlns:a16="http://schemas.microsoft.com/office/drawing/2014/main" id="{DDE799D3-239F-4FF8-9C97-F0CD77AC45B1}"/>
               </a:ext>
             </a:extLst>
           </p:cNvPr>
@@ -16509,7 +16514,7 @@
           <p:cNvPr id="6" name="text">
             <a:extLst xmlns:a="http://schemas.openxmlformats.org/drawingml/2006/main">
               <a:ext uri="{FF2B5EF4-FFF2-40B4-BE49-F238E27FC236}">
-                <a16:creationId xmlns:a16="http://schemas.microsoft.com/office/drawing/2014/main" id="{ED578408-87D9-4CCB-89AC-7E7A375B431B}"/>
+                <a16:creationId xmlns:a16="http://schemas.microsoft.com/office/drawing/2014/main" id="{D5FAF12B-7A15-46A3-A1A3-D795A9119566}"/>
               </a:ext>
             </a:extLst>
           </p:cNvPr>
@@ -16566,7 +16571,7 @@
           <p:cNvPr id="7" name="text">
             <a:extLst xmlns:a="http://schemas.openxmlformats.org/drawingml/2006/main">
               <a:ext uri="{FF2B5EF4-FFF2-40B4-BE49-F238E27FC236}">
-                <a16:creationId xmlns:a16="http://schemas.microsoft.com/office/drawing/2014/main" id="{266698F2-718D-419C-8275-31E439AD3A6B}"/>
+                <a16:creationId xmlns:a16="http://schemas.microsoft.com/office/drawing/2014/main" id="{0C1BA506-5CEE-4DD8-8434-A1415F4B0C57}"/>
               </a:ext>
             </a:extLst>
           </p:cNvPr>
@@ -16623,7 +16628,7 @@
           <p:cNvPr id="8" name="text">
             <a:extLst xmlns:a="http://schemas.openxmlformats.org/drawingml/2006/main">
               <a:ext uri="{FF2B5EF4-FFF2-40B4-BE49-F238E27FC236}">
-                <a16:creationId xmlns:a16="http://schemas.microsoft.com/office/drawing/2014/main" id="{45353F6D-E08D-4AFA-8AFA-D8FA5EF57DD6}"/>
+                <a16:creationId xmlns:a16="http://schemas.microsoft.com/office/drawing/2014/main" id="{564DDA7B-8B3F-49DB-9302-B57FEB6FC1C7}"/>
               </a:ext>
             </a:extLst>
           </p:cNvPr>
@@ -16680,7 +16685,7 @@
           <p:cNvPr id="9" name="Slide number">
             <a:extLst xmlns:a="http://schemas.openxmlformats.org/drawingml/2006/main">
               <a:ext uri="{FF2B5EF4-FFF2-40B4-BE49-F238E27FC236}">
-                <a16:creationId xmlns:a16="http://schemas.microsoft.com/office/drawing/2014/main" id="{531C0B23-C236-4C82-882E-A3F17915A671}"/>
+                <a16:creationId xmlns:a16="http://schemas.microsoft.com/office/drawing/2014/main" id="{92326648-6B1C-46A0-8ADA-079641690E4C}"/>
               </a:ext>
             </a:extLst>
           </p:cNvPr>
@@ -16735,7 +16740,7 @@
     </p:spTree>
     <p:extLst>
       <p:ext uri="{BB962C8B-B14F-4D97-AF65-F5344CB8AC3E}">
-        <p14:creationId xmlns:p14="http://schemas.microsoft.com/office/powerpoint/2010/main" val="1449542277"/>
+        <p14:creationId xmlns:p14="http://schemas.microsoft.com/office/powerpoint/2010/main" val="526340348"/>
       </p:ext>
     </p:extLst>
   </p:cSld>
@@ -16766,7 +16771,7 @@
           <p:cNvPr id="7" name="Title">
             <a:extLst xmlns:a="http://schemas.openxmlformats.org/drawingml/2006/main">
               <a:ext uri="{FF2B5EF4-FFF2-40B4-BE49-F238E27FC236}">
-                <a16:creationId xmlns:a16="http://schemas.microsoft.com/office/drawing/2014/main" id="{1066D99B-7016-46C4-8810-D7E9E96C52CE}"/>
+                <a16:creationId xmlns:a16="http://schemas.microsoft.com/office/drawing/2014/main" id="{92EA5EBA-25FD-4530-B16F-541EED1142F6}"/>
               </a:ext>
             </a:extLst>
           </p:cNvPr>
@@ -16830,7 +16835,7 @@
         </p:xfrm>
         <a:graphic xmlns:a="http://schemas.openxmlformats.org/drawingml/2006/main">
           <a:graphicData uri="http://schemas.openxmlformats.org/drawingml/2006/chart">
-            <c:chart xmlns:r="http://schemas.openxmlformats.org/officeDocument/2006/relationships" xmlns:c="http://schemas.openxmlformats.org/drawingml/2006/chart" r:id="R119af2cd99954836"/>
+            <c:chart xmlns:r="http://schemas.openxmlformats.org/officeDocument/2006/relationships" xmlns:c="http://schemas.openxmlformats.org/drawingml/2006/chart" r:id="R2050fb85d3c5441b"/>
           </a:graphicData>
         </a:graphic>
       </p:graphicFrame>
@@ -16839,7 +16844,7 @@
           <p:cNvPr id="3" name="April month marker">
             <a:extLst xmlns:a="http://schemas.openxmlformats.org/drawingml/2006/main">
               <a:ext uri="{FF2B5EF4-FFF2-40B4-BE49-F238E27FC236}">
-                <a16:creationId xmlns:a16="http://schemas.microsoft.com/office/drawing/2014/main" id="{7A8CB0E3-071A-4235-B122-4B8589D72CF2}"/>
+                <a16:creationId xmlns:a16="http://schemas.microsoft.com/office/drawing/2014/main" id="{01CAE974-608A-4591-A20B-5F925CA76607}"/>
               </a:ext>
             </a:extLst>
           </p:cNvPr>
@@ -16870,7 +16875,7 @@
           <p:cNvPr id="4" name="April joining context">
             <a:extLst xmlns:a="http://schemas.openxmlformats.org/drawingml/2006/main">
               <a:ext uri="{FF2B5EF4-FFF2-40B4-BE49-F238E27FC236}">
-                <a16:creationId xmlns:a16="http://schemas.microsoft.com/office/drawing/2014/main" id="{1220C954-6E16-4C79-8E24-C8E169B0B2C4}"/>
+                <a16:creationId xmlns:a16="http://schemas.microsoft.com/office/drawing/2014/main" id="{BE940CE2-0DE2-4DC1-8D56-41E11F186592}"/>
               </a:ext>
             </a:extLst>
           </p:cNvPr>
@@ -16927,7 +16932,7 @@
           <p:cNvPr id="5" name="Methodology">
             <a:extLst xmlns:a="http://schemas.openxmlformats.org/drawingml/2006/main">
               <a:ext uri="{FF2B5EF4-FFF2-40B4-BE49-F238E27FC236}">
-                <a16:creationId xmlns:a16="http://schemas.microsoft.com/office/drawing/2014/main" id="{7CD241B9-29B0-4677-A317-7F1581DF0798}"/>
+                <a16:creationId xmlns:a16="http://schemas.microsoft.com/office/drawing/2014/main" id="{06D2F084-3399-41F9-8D40-B0BC1F746829}"/>
               </a:ext>
             </a:extLst>
           </p:cNvPr>
@@ -16984,7 +16989,7 @@
           <p:cNvPr id="6" name="Slide number">
             <a:extLst xmlns:a="http://schemas.openxmlformats.org/drawingml/2006/main">
               <a:ext uri="{FF2B5EF4-FFF2-40B4-BE49-F238E27FC236}">
-                <a16:creationId xmlns:a16="http://schemas.microsoft.com/office/drawing/2014/main" id="{04BDD38A-7828-445B-BB0E-D564C8EDAB35}"/>
+                <a16:creationId xmlns:a16="http://schemas.microsoft.com/office/drawing/2014/main" id="{DA22CD1D-410C-40A8-A512-4C7824F35FF6}"/>
               </a:ext>
             </a:extLst>
           </p:cNvPr>
@@ -17039,7 +17044,7 @@
     </p:spTree>
     <p:extLst>
       <p:ext uri="{BB962C8B-B14F-4D97-AF65-F5344CB8AC3E}">
-        <p14:creationId xmlns:p14="http://schemas.microsoft.com/office/powerpoint/2010/main" val="659656129"/>
+        <p14:creationId xmlns:p14="http://schemas.microsoft.com/office/powerpoint/2010/main" val="710498476"/>
       </p:ext>
     </p:extLst>
   </p:cSld>
@@ -17070,7 +17075,7 @@
           <p:cNvPr id="4" name="Title">
             <a:extLst xmlns:a="http://schemas.openxmlformats.org/drawingml/2006/main">
               <a:ext uri="{FF2B5EF4-FFF2-40B4-BE49-F238E27FC236}">
-                <a16:creationId xmlns:a16="http://schemas.microsoft.com/office/drawing/2014/main" id="{7ABCB487-D6F2-4C4B-B1C6-45DD157C3BB8}"/>
+                <a16:creationId xmlns:a16="http://schemas.microsoft.com/office/drawing/2014/main" id="{896AF29D-23F0-4805-B872-A42EC67BFA1F}"/>
               </a:ext>
             </a:extLst>
           </p:cNvPr>
@@ -17150,7 +17155,7 @@
           <p:cNvPr id="2" name="text">
             <a:extLst xmlns:a="http://schemas.openxmlformats.org/drawingml/2006/main">
               <a:ext uri="{FF2B5EF4-FFF2-40B4-BE49-F238E27FC236}">
-                <a16:creationId xmlns:a16="http://schemas.microsoft.com/office/drawing/2014/main" id="{C38DC8CD-6799-4EA2-B5FB-449946563528}"/>
+                <a16:creationId xmlns:a16="http://schemas.microsoft.com/office/drawing/2014/main" id="{D210EB56-5548-4896-8417-EF2F63319E1F}"/>
               </a:ext>
             </a:extLst>
           </p:cNvPr>
@@ -17207,7 +17212,7 @@
           <p:cNvPr id="3" name="Slide number">
             <a:extLst xmlns:a="http://schemas.openxmlformats.org/drawingml/2006/main">
               <a:ext uri="{FF2B5EF4-FFF2-40B4-BE49-F238E27FC236}">
-                <a16:creationId xmlns:a16="http://schemas.microsoft.com/office/drawing/2014/main" id="{CA3D0AF6-575C-4A2B-ABDE-5FF7804A2D6D}"/>
+                <a16:creationId xmlns:a16="http://schemas.microsoft.com/office/drawing/2014/main" id="{0595DC53-257E-4FC1-900B-E7128E9F3771}"/>
               </a:ext>
             </a:extLst>
           </p:cNvPr>
@@ -17262,7 +17267,7 @@
     </p:spTree>
     <p:extLst>
       <p:ext uri="{BB962C8B-B14F-4D97-AF65-F5344CB8AC3E}">
-        <p14:creationId xmlns:p14="http://schemas.microsoft.com/office/powerpoint/2010/main" val="1136942892"/>
+        <p14:creationId xmlns:p14="http://schemas.microsoft.com/office/powerpoint/2010/main" val="1529289577"/>
       </p:ext>
     </p:extLst>
   </p:cSld>
@@ -17290,10 +17295,10 @@
       </p:grpSpPr>
       <p:sp>
         <p:nvSpPr>
-          <p:cNvPr id="14" name="Title">
-            <a:extLst xmlns:a="http://schemas.openxmlformats.org/drawingml/2006/main">
-              <a:ext uri="{FF2B5EF4-FFF2-40B4-BE49-F238E27FC236}">
-                <a16:creationId xmlns:a16="http://schemas.microsoft.com/office/drawing/2014/main" id="{37975EC4-7E4E-46DA-A751-F9FA3793B2CC}"/>
+          <p:cNvPr id="16" name="Title">
+            <a:extLst xmlns:a="http://schemas.openxmlformats.org/drawingml/2006/main">
+              <a:ext uri="{FF2B5EF4-FFF2-40B4-BE49-F238E27FC236}">
+                <a16:creationId xmlns:a16="http://schemas.microsoft.com/office/drawing/2014/main" id="{FB789147-4D02-4566-BA23-E890B929CE03}"/>
               </a:ext>
             </a:extLst>
           </p:cNvPr>
@@ -17350,7 +17355,7 @@
           <p:cNvPr id="2" name="text">
             <a:extLst xmlns:a="http://schemas.openxmlformats.org/drawingml/2006/main">
               <a:ext uri="{FF2B5EF4-FFF2-40B4-BE49-F238E27FC236}">
-                <a16:creationId xmlns:a16="http://schemas.microsoft.com/office/drawing/2014/main" id="{81FE1295-5008-4B22-9C7A-B199FF366CD6}"/>
+                <a16:creationId xmlns:a16="http://schemas.microsoft.com/office/drawing/2014/main" id="{E2D0DB57-64F9-4E4C-9E3E-D6B48E2BC17C}"/>
               </a:ext>
             </a:extLst>
           </p:cNvPr>
@@ -17407,7 +17412,7 @@
           <p:cNvPr id="3" name="text">
             <a:extLst xmlns:a="http://schemas.openxmlformats.org/drawingml/2006/main">
               <a:ext uri="{FF2B5EF4-FFF2-40B4-BE49-F238E27FC236}">
-                <a16:creationId xmlns:a16="http://schemas.microsoft.com/office/drawing/2014/main" id="{1342B955-9139-4E96-AFF8-0BE21E2504D0}"/>
+                <a16:creationId xmlns:a16="http://schemas.microsoft.com/office/drawing/2014/main" id="{49FF55BE-1553-4B75-B99D-04ED34C6BE57}"/>
               </a:ext>
             </a:extLst>
           </p:cNvPr>
@@ -17419,7 +17424,7 @@
         <p:spPr>
           <a:xfrm xmlns:a="http://schemas.openxmlformats.org/drawingml/2006/main">
             <a:off x="781050" y="2414588"/>
-            <a:ext cx="3200400" cy="666750"/>
+            <a:ext cx="3200400" cy="552450"/>
           </a:xfrm>
           <a:prstGeom xmlns:a="http://schemas.openxmlformats.org/drawingml/2006/main" prst="rect">
             <a:avLst/>
@@ -17464,7 +17469,7 @@
           <p:cNvPr id="4" name="text">
             <a:extLst xmlns:a="http://schemas.openxmlformats.org/drawingml/2006/main">
               <a:ext uri="{FF2B5EF4-FFF2-40B4-BE49-F238E27FC236}">
-                <a16:creationId xmlns:a16="http://schemas.microsoft.com/office/drawing/2014/main" id="{27B7030C-5D36-4FDB-A8B2-844016F49C31}"/>
+                <a16:creationId xmlns:a16="http://schemas.microsoft.com/office/drawing/2014/main" id="{8F3481FD-D6A4-485F-B464-BD2748724B6C}"/>
               </a:ext>
             </a:extLst>
           </p:cNvPr>
@@ -17476,7 +17481,7 @@
         <p:spPr>
           <a:xfrm xmlns:a="http://schemas.openxmlformats.org/drawingml/2006/main">
             <a:off x="4286250" y="2414588"/>
-            <a:ext cx="7048500" cy="666750"/>
+            <a:ext cx="7048500" cy="552450"/>
           </a:xfrm>
           <a:prstGeom xmlns:a="http://schemas.openxmlformats.org/drawingml/2006/main" prst="rect">
             <a:avLst/>
@@ -17521,19 +17526,19 @@
           <p:cNvPr id="5" name="text">
             <a:extLst xmlns:a="http://schemas.openxmlformats.org/drawingml/2006/main">
               <a:ext uri="{FF2B5EF4-FFF2-40B4-BE49-F238E27FC236}">
-                <a16:creationId xmlns:a16="http://schemas.microsoft.com/office/drawing/2014/main" id="{B3858F9B-56C9-48AD-A3E2-46F5A9B2984B}"/>
-              </a:ext>
-            </a:extLst>
-          </p:cNvPr>
-          <p:cNvSpPr>
-            <a:spLocks xmlns:a="http://schemas.openxmlformats.org/drawingml/2006/main" noGrp="1"/>
-          </p:cNvSpPr>
-          <p:nvPr/>
-        </p:nvSpPr>
-        <p:spPr>
-          <a:xfrm xmlns:a="http://schemas.openxmlformats.org/drawingml/2006/main">
-            <a:off x="781050" y="3195638"/>
-            <a:ext cx="3200400" cy="666750"/>
+                <a16:creationId xmlns:a16="http://schemas.microsoft.com/office/drawing/2014/main" id="{58E17C3F-A5F1-4DF1-BDF1-D1E041615A38}"/>
+              </a:ext>
+            </a:extLst>
+          </p:cNvPr>
+          <p:cNvSpPr>
+            <a:spLocks xmlns:a="http://schemas.openxmlformats.org/drawingml/2006/main" noGrp="1"/>
+          </p:cNvSpPr>
+          <p:nvPr/>
+        </p:nvSpPr>
+        <p:spPr>
+          <a:xfrm xmlns:a="http://schemas.openxmlformats.org/drawingml/2006/main">
+            <a:off x="781050" y="3062288"/>
+            <a:ext cx="3200400" cy="552450"/>
           </a:xfrm>
           <a:prstGeom xmlns:a="http://schemas.openxmlformats.org/drawingml/2006/main" prst="rect">
             <a:avLst/>
@@ -17568,7 +17573,7 @@
                 <a:ea typeface="Satoshi Variable"/>
                 <a:cs typeface="Satoshi Variable"/>
               </a:rPr>
-              <a:t>Monorepo and ways of working</a:t>
+              <a:t>Monorepo</a:t>
             </a:r>
           </a:p>
         </p:txBody>
@@ -17578,19 +17583,19 @@
           <p:cNvPr id="6" name="text">
             <a:extLst xmlns:a="http://schemas.openxmlformats.org/drawingml/2006/main">
               <a:ext uri="{FF2B5EF4-FFF2-40B4-BE49-F238E27FC236}">
-                <a16:creationId xmlns:a16="http://schemas.microsoft.com/office/drawing/2014/main" id="{8145B3EB-C74F-4AE8-8429-42CA2E156223}"/>
-              </a:ext>
-            </a:extLst>
-          </p:cNvPr>
-          <p:cNvSpPr>
-            <a:spLocks xmlns:a="http://schemas.openxmlformats.org/drawingml/2006/main" noGrp="1"/>
-          </p:cNvSpPr>
-          <p:nvPr/>
-        </p:nvSpPr>
-        <p:spPr>
-          <a:xfrm xmlns:a="http://schemas.openxmlformats.org/drawingml/2006/main">
-            <a:off x="4286250" y="3195638"/>
-            <a:ext cx="7048500" cy="666750"/>
+                <a16:creationId xmlns:a16="http://schemas.microsoft.com/office/drawing/2014/main" id="{B7E14999-895A-4CE1-A9B1-3EB320C471E0}"/>
+              </a:ext>
+            </a:extLst>
+          </p:cNvPr>
+          <p:cNvSpPr>
+            <a:spLocks xmlns:a="http://schemas.openxmlformats.org/drawingml/2006/main" noGrp="1"/>
+          </p:cNvSpPr>
+          <p:nvPr/>
+        </p:nvSpPr>
+        <p:spPr>
+          <a:xfrm xmlns:a="http://schemas.openxmlformats.org/drawingml/2006/main">
+            <a:off x="4286250" y="3062288"/>
+            <a:ext cx="7048500" cy="552450"/>
           </a:xfrm>
           <a:prstGeom xmlns:a="http://schemas.openxmlformats.org/drawingml/2006/main" prst="rect">
             <a:avLst/>
@@ -17625,7 +17630,7 @@
                 <a:ea typeface="Satoshi Variable"/>
                 <a:cs typeface="Satoshi Variable"/>
               </a:rPr>
-              <a:t>Shared code, coordinated changes and clearer ownership.</a:t>
+              <a:t>Shared code and coordinated changes.</a:t>
             </a:r>
           </a:p>
         </p:txBody>
@@ -17635,19 +17640,19 @@
           <p:cNvPr id="7" name="text">
             <a:extLst xmlns:a="http://schemas.openxmlformats.org/drawingml/2006/main">
               <a:ext uri="{FF2B5EF4-FFF2-40B4-BE49-F238E27FC236}">
-                <a16:creationId xmlns:a16="http://schemas.microsoft.com/office/drawing/2014/main" id="{9A227AA3-10EC-4477-AF1E-8FAF315EFC6E}"/>
-              </a:ext>
-            </a:extLst>
-          </p:cNvPr>
-          <p:cNvSpPr>
-            <a:spLocks xmlns:a="http://schemas.openxmlformats.org/drawingml/2006/main" noGrp="1"/>
-          </p:cNvSpPr>
-          <p:nvPr/>
-        </p:nvSpPr>
-        <p:spPr>
-          <a:xfrm xmlns:a="http://schemas.openxmlformats.org/drawingml/2006/main">
-            <a:off x="781050" y="3976688"/>
-            <a:ext cx="3200400" cy="666750"/>
+                <a16:creationId xmlns:a16="http://schemas.microsoft.com/office/drawing/2014/main" id="{D8286A08-31C6-49DC-BB33-3ECF4450256F}"/>
+              </a:ext>
+            </a:extLst>
+          </p:cNvPr>
+          <p:cNvSpPr>
+            <a:spLocks xmlns:a="http://schemas.openxmlformats.org/drawingml/2006/main" noGrp="1"/>
+          </p:cNvSpPr>
+          <p:nvPr/>
+        </p:nvSpPr>
+        <p:spPr>
+          <a:xfrm xmlns:a="http://schemas.openxmlformats.org/drawingml/2006/main">
+            <a:off x="781050" y="3709988"/>
+            <a:ext cx="3200400" cy="552450"/>
           </a:xfrm>
           <a:prstGeom xmlns:a="http://schemas.openxmlformats.org/drawingml/2006/main" prst="rect">
             <a:avLst/>
@@ -17682,6 +17687,120 @@
                 <a:ea typeface="Satoshi Variable"/>
                 <a:cs typeface="Satoshi Variable"/>
               </a:rPr>
+              <a:t>Ways of working</a:t>
+            </a:r>
+          </a:p>
+        </p:txBody>
+      </p:sp>
+      <p:sp>
+        <p:nvSpPr>
+          <p:cNvPr id="8" name="text">
+            <a:extLst xmlns:a="http://schemas.openxmlformats.org/drawingml/2006/main">
+              <a:ext uri="{FF2B5EF4-FFF2-40B4-BE49-F238E27FC236}">
+                <a16:creationId xmlns:a16="http://schemas.microsoft.com/office/drawing/2014/main" id="{A2B373C1-7EBC-4D59-AD20-4980E4C52F00}"/>
+              </a:ext>
+            </a:extLst>
+          </p:cNvPr>
+          <p:cNvSpPr>
+            <a:spLocks xmlns:a="http://schemas.openxmlformats.org/drawingml/2006/main" noGrp="1"/>
+          </p:cNvSpPr>
+          <p:nvPr/>
+        </p:nvSpPr>
+        <p:spPr>
+          <a:xfrm xmlns:a="http://schemas.openxmlformats.org/drawingml/2006/main">
+            <a:off x="4286250" y="3709988"/>
+            <a:ext cx="7048500" cy="552450"/>
+          </a:xfrm>
+          <a:prstGeom xmlns:a="http://schemas.openxmlformats.org/drawingml/2006/main" prst="rect">
+            <a:avLst/>
+          </a:prstGeom>
+          <a:noFill xmlns:a="http://schemas.openxmlformats.org/drawingml/2006/main"/>
+          <a:ln xmlns:a="http://schemas.openxmlformats.org/drawingml/2006/main" w="0">
+            <a:noFill/>
+          </a:ln>
+        </p:spPr>
+        <p:txBody>
+          <a:bodyPr xmlns:a="http://schemas.openxmlformats.org/drawingml/2006/main" lIns="0" tIns="0" rIns="0" bIns="0">
+            <a:noAutofit/>
+          </a:bodyPr>
+          <a:lstStyle xmlns:a="http://schemas.openxmlformats.org/drawingml/2006/main"/>
+          <a:p xmlns:a="http://schemas.openxmlformats.org/drawingml/2006/main">
+            <a:pPr algn="l">
+              <a:defRPr sz="2100" b="0">
+                <a:solidFill>
+                  <a:srgbClr val="17243B"/>
+                </a:solidFill>
+                <a:latin typeface="Satoshi Variable"/>
+                <a:ea typeface="Satoshi Variable"/>
+                <a:cs typeface="Satoshi Variable"/>
+              </a:defRPr>
+            </a:pPr>
+            <a:r>
+              <a:rPr sz="2100" b="0">
+                <a:solidFill>
+                  <a:srgbClr val="17243B"/>
+                </a:solidFill>
+                <a:latin typeface="Satoshi Variable"/>
+                <a:ea typeface="Satoshi Variable"/>
+                <a:cs typeface="Satoshi Variable"/>
+              </a:rPr>
+              <a:t>Clearer ownership and everyday engineering habits.</a:t>
+            </a:r>
+          </a:p>
+        </p:txBody>
+      </p:sp>
+      <p:sp>
+        <p:nvSpPr>
+          <p:cNvPr id="9" name="text">
+            <a:extLst xmlns:a="http://schemas.openxmlformats.org/drawingml/2006/main">
+              <a:ext uri="{FF2B5EF4-FFF2-40B4-BE49-F238E27FC236}">
+                <a16:creationId xmlns:a16="http://schemas.microsoft.com/office/drawing/2014/main" id="{325B73B3-94DB-4F21-980E-31151A716A3F}"/>
+              </a:ext>
+            </a:extLst>
+          </p:cNvPr>
+          <p:cNvSpPr>
+            <a:spLocks xmlns:a="http://schemas.openxmlformats.org/drawingml/2006/main" noGrp="1"/>
+          </p:cNvSpPr>
+          <p:nvPr/>
+        </p:nvSpPr>
+        <p:spPr>
+          <a:xfrm xmlns:a="http://schemas.openxmlformats.org/drawingml/2006/main">
+            <a:off x="781050" y="4357688"/>
+            <a:ext cx="3200400" cy="552450"/>
+          </a:xfrm>
+          <a:prstGeom xmlns:a="http://schemas.openxmlformats.org/drawingml/2006/main" prst="rect">
+            <a:avLst/>
+          </a:prstGeom>
+          <a:noFill xmlns:a="http://schemas.openxmlformats.org/drawingml/2006/main"/>
+          <a:ln xmlns:a="http://schemas.openxmlformats.org/drawingml/2006/main" w="0">
+            <a:noFill/>
+          </a:ln>
+        </p:spPr>
+        <p:txBody>
+          <a:bodyPr xmlns:a="http://schemas.openxmlformats.org/drawingml/2006/main" lIns="0" tIns="0" rIns="0" bIns="0">
+            <a:noAutofit/>
+          </a:bodyPr>
+          <a:lstStyle xmlns:a="http://schemas.openxmlformats.org/drawingml/2006/main"/>
+          <a:p xmlns:a="http://schemas.openxmlformats.org/drawingml/2006/main">
+            <a:pPr algn="l">
+              <a:defRPr sz="2100" b="1">
+                <a:solidFill>
+                  <a:srgbClr val="385782"/>
+                </a:solidFill>
+                <a:latin typeface="Satoshi Variable"/>
+                <a:ea typeface="Satoshi Variable"/>
+                <a:cs typeface="Satoshi Variable"/>
+              </a:defRPr>
+            </a:pPr>
+            <a:r>
+              <a:rPr sz="2100" b="1">
+                <a:solidFill>
+                  <a:srgbClr val="385782"/>
+                </a:solidFill>
+                <a:latin typeface="Satoshi Variable"/>
+                <a:ea typeface="Satoshi Variable"/>
+                <a:cs typeface="Satoshi Variable"/>
+              </a:rPr>
               <a:t>Product engineering</a:t>
             </a:r>
           </a:p>
@@ -17689,22 +17808,22 @@
       </p:sp>
       <p:sp>
         <p:nvSpPr>
-          <p:cNvPr id="8" name="text">
-            <a:extLst xmlns:a="http://schemas.openxmlformats.org/drawingml/2006/main">
-              <a:ext uri="{FF2B5EF4-FFF2-40B4-BE49-F238E27FC236}">
-                <a16:creationId xmlns:a16="http://schemas.microsoft.com/office/drawing/2014/main" id="{5CBD1D57-A667-46FC-8541-340C86E751E9}"/>
-              </a:ext>
-            </a:extLst>
-          </p:cNvPr>
-          <p:cNvSpPr>
-            <a:spLocks xmlns:a="http://schemas.openxmlformats.org/drawingml/2006/main" noGrp="1"/>
-          </p:cNvSpPr>
-          <p:nvPr/>
-        </p:nvSpPr>
-        <p:spPr>
-          <a:xfrm xmlns:a="http://schemas.openxmlformats.org/drawingml/2006/main">
-            <a:off x="4286250" y="3976688"/>
-            <a:ext cx="7048500" cy="666750"/>
+          <p:cNvPr id="10" name="text">
+            <a:extLst xmlns:a="http://schemas.openxmlformats.org/drawingml/2006/main">
+              <a:ext uri="{FF2B5EF4-FFF2-40B4-BE49-F238E27FC236}">
+                <a16:creationId xmlns:a16="http://schemas.microsoft.com/office/drawing/2014/main" id="{067441B4-8574-4B76-9936-232B4331E8F7}"/>
+              </a:ext>
+            </a:extLst>
+          </p:cNvPr>
+          <p:cNvSpPr>
+            <a:spLocks xmlns:a="http://schemas.openxmlformats.org/drawingml/2006/main" noGrp="1"/>
+          </p:cNvSpPr>
+          <p:nvPr/>
+        </p:nvSpPr>
+        <p:spPr>
+          <a:xfrm xmlns:a="http://schemas.openxmlformats.org/drawingml/2006/main">
+            <a:off x="4286250" y="4357688"/>
+            <a:ext cx="7048500" cy="552450"/>
           </a:xfrm>
           <a:prstGeom xmlns:a="http://schemas.openxmlformats.org/drawingml/2006/main" prst="rect">
             <a:avLst/>
@@ -17746,22 +17865,22 @@
       </p:sp>
       <p:sp>
         <p:nvSpPr>
-          <p:cNvPr id="9" name="text">
-            <a:extLst xmlns:a="http://schemas.openxmlformats.org/drawingml/2006/main">
-              <a:ext uri="{FF2B5EF4-FFF2-40B4-BE49-F238E27FC236}">
-                <a16:creationId xmlns:a16="http://schemas.microsoft.com/office/drawing/2014/main" id="{5FF736DF-09EB-45F1-81EE-988A51BC6CA1}"/>
-              </a:ext>
-            </a:extLst>
-          </p:cNvPr>
-          <p:cNvSpPr>
-            <a:spLocks xmlns:a="http://schemas.openxmlformats.org/drawingml/2006/main" noGrp="1"/>
-          </p:cNvSpPr>
-          <p:nvPr/>
-        </p:nvSpPr>
-        <p:spPr>
-          <a:xfrm xmlns:a="http://schemas.openxmlformats.org/drawingml/2006/main">
-            <a:off x="781050" y="4757738"/>
-            <a:ext cx="3200400" cy="666750"/>
+          <p:cNvPr id="11" name="text">
+            <a:extLst xmlns:a="http://schemas.openxmlformats.org/drawingml/2006/main">
+              <a:ext uri="{FF2B5EF4-FFF2-40B4-BE49-F238E27FC236}">
+                <a16:creationId xmlns:a16="http://schemas.microsoft.com/office/drawing/2014/main" id="{82949252-8B8D-4E8B-AFBA-90DCCCE7FB57}"/>
+              </a:ext>
+            </a:extLst>
+          </p:cNvPr>
+          <p:cNvSpPr>
+            <a:spLocks xmlns:a="http://schemas.openxmlformats.org/drawingml/2006/main" noGrp="1"/>
+          </p:cNvSpPr>
+          <p:nvPr/>
+        </p:nvSpPr>
+        <p:spPr>
+          <a:xfrm xmlns:a="http://schemas.openxmlformats.org/drawingml/2006/main">
+            <a:off x="781050" y="5005388"/>
+            <a:ext cx="3200400" cy="552450"/>
           </a:xfrm>
           <a:prstGeom xmlns:a="http://schemas.openxmlformats.org/drawingml/2006/main" prst="rect">
             <a:avLst/>
@@ -17803,22 +17922,22 @@
       </p:sp>
       <p:sp>
         <p:nvSpPr>
-          <p:cNvPr id="10" name="text">
-            <a:extLst xmlns:a="http://schemas.openxmlformats.org/drawingml/2006/main">
-              <a:ext uri="{FF2B5EF4-FFF2-40B4-BE49-F238E27FC236}">
-                <a16:creationId xmlns:a16="http://schemas.microsoft.com/office/drawing/2014/main" id="{56C5136B-1E24-4B88-ADDD-01EE25B5314A}"/>
-              </a:ext>
-            </a:extLst>
-          </p:cNvPr>
-          <p:cNvSpPr>
-            <a:spLocks xmlns:a="http://schemas.openxmlformats.org/drawingml/2006/main" noGrp="1"/>
-          </p:cNvSpPr>
-          <p:nvPr/>
-        </p:nvSpPr>
-        <p:spPr>
-          <a:xfrm xmlns:a="http://schemas.openxmlformats.org/drawingml/2006/main">
-            <a:off x="4286250" y="4757738"/>
-            <a:ext cx="7048500" cy="666750"/>
+          <p:cNvPr id="12" name="text">
+            <a:extLst xmlns:a="http://schemas.openxmlformats.org/drawingml/2006/main">
+              <a:ext uri="{FF2B5EF4-FFF2-40B4-BE49-F238E27FC236}">
+                <a16:creationId xmlns:a16="http://schemas.microsoft.com/office/drawing/2014/main" id="{C09F2B95-C8D8-4B49-A49C-2E6CA5CDA7E1}"/>
+              </a:ext>
+            </a:extLst>
+          </p:cNvPr>
+          <p:cNvSpPr>
+            <a:spLocks xmlns:a="http://schemas.openxmlformats.org/drawingml/2006/main" noGrp="1"/>
+          </p:cNvSpPr>
+          <p:nvPr/>
+        </p:nvSpPr>
+        <p:spPr>
+          <a:xfrm xmlns:a="http://schemas.openxmlformats.org/drawingml/2006/main">
+            <a:off x="4286250" y="5005388"/>
+            <a:ext cx="7048500" cy="552450"/>
           </a:xfrm>
           <a:prstGeom xmlns:a="http://schemas.openxmlformats.org/drawingml/2006/main" prst="rect">
             <a:avLst/>
@@ -17860,22 +17979,22 @@
       </p:sp>
       <p:sp>
         <p:nvSpPr>
-          <p:cNvPr id="11" name="text">
-            <a:extLst xmlns:a="http://schemas.openxmlformats.org/drawingml/2006/main">
-              <a:ext uri="{FF2B5EF4-FFF2-40B4-BE49-F238E27FC236}">
-                <a16:creationId xmlns:a16="http://schemas.microsoft.com/office/drawing/2014/main" id="{0CB81B2A-3539-41FF-B3FF-7149B2646924}"/>
-              </a:ext>
-            </a:extLst>
-          </p:cNvPr>
-          <p:cNvSpPr>
-            <a:spLocks xmlns:a="http://schemas.openxmlformats.org/drawingml/2006/main" noGrp="1"/>
-          </p:cNvSpPr>
-          <p:nvPr/>
-        </p:nvSpPr>
-        <p:spPr>
-          <a:xfrm xmlns:a="http://schemas.openxmlformats.org/drawingml/2006/main">
-            <a:off x="781050" y="5538788"/>
-            <a:ext cx="3200400" cy="666750"/>
+          <p:cNvPr id="13" name="text">
+            <a:extLst xmlns:a="http://schemas.openxmlformats.org/drawingml/2006/main">
+              <a:ext uri="{FF2B5EF4-FFF2-40B4-BE49-F238E27FC236}">
+                <a16:creationId xmlns:a16="http://schemas.microsoft.com/office/drawing/2014/main" id="{9BAF6DE4-F31F-4ED9-9D19-F7DFA0DA9F93}"/>
+              </a:ext>
+            </a:extLst>
+          </p:cNvPr>
+          <p:cNvSpPr>
+            <a:spLocks xmlns:a="http://schemas.openxmlformats.org/drawingml/2006/main" noGrp="1"/>
+          </p:cNvSpPr>
+          <p:nvPr/>
+        </p:nvSpPr>
+        <p:spPr>
+          <a:xfrm xmlns:a="http://schemas.openxmlformats.org/drawingml/2006/main">
+            <a:off x="781050" y="5653088"/>
+            <a:ext cx="3200400" cy="552450"/>
           </a:xfrm>
           <a:prstGeom xmlns:a="http://schemas.openxmlformats.org/drawingml/2006/main" prst="rect">
             <a:avLst/>
@@ -17917,22 +18036,22 @@
       </p:sp>
       <p:sp>
         <p:nvSpPr>
-          <p:cNvPr id="12" name="text">
-            <a:extLst xmlns:a="http://schemas.openxmlformats.org/drawingml/2006/main">
-              <a:ext uri="{FF2B5EF4-FFF2-40B4-BE49-F238E27FC236}">
-                <a16:creationId xmlns:a16="http://schemas.microsoft.com/office/drawing/2014/main" id="{03A34651-64B0-4C7B-A1FC-3B94DEF9CFB1}"/>
-              </a:ext>
-            </a:extLst>
-          </p:cNvPr>
-          <p:cNvSpPr>
-            <a:spLocks xmlns:a="http://schemas.openxmlformats.org/drawingml/2006/main" noGrp="1"/>
-          </p:cNvSpPr>
-          <p:nvPr/>
-        </p:nvSpPr>
-        <p:spPr>
-          <a:xfrm xmlns:a="http://schemas.openxmlformats.org/drawingml/2006/main">
-            <a:off x="4286250" y="5538788"/>
-            <a:ext cx="7048500" cy="666750"/>
+          <p:cNvPr id="14" name="text">
+            <a:extLst xmlns:a="http://schemas.openxmlformats.org/drawingml/2006/main">
+              <a:ext uri="{FF2B5EF4-FFF2-40B4-BE49-F238E27FC236}">
+                <a16:creationId xmlns:a16="http://schemas.microsoft.com/office/drawing/2014/main" id="{1986B903-56D0-4D48-8236-0A6263075F56}"/>
+              </a:ext>
+            </a:extLst>
+          </p:cNvPr>
+          <p:cNvSpPr>
+            <a:spLocks xmlns:a="http://schemas.openxmlformats.org/drawingml/2006/main" noGrp="1"/>
+          </p:cNvSpPr>
+          <p:nvPr/>
+        </p:nvSpPr>
+        <p:spPr>
+          <a:xfrm xmlns:a="http://schemas.openxmlformats.org/drawingml/2006/main">
+            <a:off x="4286250" y="5653088"/>
+            <a:ext cx="7048500" cy="552450"/>
           </a:xfrm>
           <a:prstGeom xmlns:a="http://schemas.openxmlformats.org/drawingml/2006/main" prst="rect">
             <a:avLst/>
@@ -17974,10 +18093,10 @@
       </p:sp>
       <p:sp>
         <p:nvSpPr>
-          <p:cNvPr id="13" name="Slide number">
-            <a:extLst xmlns:a="http://schemas.openxmlformats.org/drawingml/2006/main">
-              <a:ext uri="{FF2B5EF4-FFF2-40B4-BE49-F238E27FC236}">
-                <a16:creationId xmlns:a16="http://schemas.microsoft.com/office/drawing/2014/main" id="{9D4890EB-EF51-4B46-BD96-52959785ECA4}"/>
+          <p:cNvPr id="15" name="Slide number">
+            <a:extLst xmlns:a="http://schemas.openxmlformats.org/drawingml/2006/main">
+              <a:ext uri="{FF2B5EF4-FFF2-40B4-BE49-F238E27FC236}">
+                <a16:creationId xmlns:a16="http://schemas.microsoft.com/office/drawing/2014/main" id="{7192178C-9B1D-4298-83DF-1811999B0533}"/>
               </a:ext>
             </a:extLst>
           </p:cNvPr>
@@ -18032,7 +18151,7 @@
     </p:spTree>
     <p:extLst>
       <p:ext uri="{BB962C8B-B14F-4D97-AF65-F5344CB8AC3E}">
-        <p14:creationId xmlns:p14="http://schemas.microsoft.com/office/powerpoint/2010/main" val="1291129722"/>
+        <p14:creationId xmlns:p14="http://schemas.microsoft.com/office/powerpoint/2010/main" val="1559923155"/>
       </p:ext>
     </p:extLst>
   </p:cSld>
@@ -18063,7 +18182,7 @@
           <p:cNvPr id="12" name="Title">
             <a:extLst xmlns:a="http://schemas.openxmlformats.org/drawingml/2006/main">
               <a:ext uri="{FF2B5EF4-FFF2-40B4-BE49-F238E27FC236}">
-                <a16:creationId xmlns:a16="http://schemas.microsoft.com/office/drawing/2014/main" id="{8B74B684-93C3-4DD8-98DD-22FF02812CC3}"/>
+                <a16:creationId xmlns:a16="http://schemas.microsoft.com/office/drawing/2014/main" id="{1B7EEC79-1B04-44B5-B3B4-F7970C757065}"/>
               </a:ext>
             </a:extLst>
           </p:cNvPr>
@@ -18120,7 +18239,7 @@
           <p:cNvPr id="2" name="text">
             <a:extLst xmlns:a="http://schemas.openxmlformats.org/drawingml/2006/main">
               <a:ext uri="{FF2B5EF4-FFF2-40B4-BE49-F238E27FC236}">
-                <a16:creationId xmlns:a16="http://schemas.microsoft.com/office/drawing/2014/main" id="{1A1971EC-3F62-469A-97DC-74589515D1F0}"/>
+                <a16:creationId xmlns:a16="http://schemas.microsoft.com/office/drawing/2014/main" id="{3CB9A3B4-FC34-4BF8-86A6-C8AC6B4266AD}"/>
               </a:ext>
             </a:extLst>
           </p:cNvPr>
@@ -18177,7 +18296,7 @@
           <p:cNvPr id="3" name="text">
             <a:extLst xmlns:a="http://schemas.openxmlformats.org/drawingml/2006/main">
               <a:ext uri="{FF2B5EF4-FFF2-40B4-BE49-F238E27FC236}">
-                <a16:creationId xmlns:a16="http://schemas.microsoft.com/office/drawing/2014/main" id="{7FC2E16C-D1CB-48BA-89C2-D3DFBB11AEC0}"/>
+                <a16:creationId xmlns:a16="http://schemas.microsoft.com/office/drawing/2014/main" id="{E1D47B81-B831-423C-AC31-ABD47443A7B9}"/>
               </a:ext>
             </a:extLst>
           </p:cNvPr>
@@ -18234,7 +18353,7 @@
           <p:cNvPr id="4" name="text">
             <a:extLst xmlns:a="http://schemas.openxmlformats.org/drawingml/2006/main">
               <a:ext uri="{FF2B5EF4-FFF2-40B4-BE49-F238E27FC236}">
-                <a16:creationId xmlns:a16="http://schemas.microsoft.com/office/drawing/2014/main" id="{67747A2A-C1D8-4A0A-B481-3D8CEC067528}"/>
+                <a16:creationId xmlns:a16="http://schemas.microsoft.com/office/drawing/2014/main" id="{16919918-C2BF-4E59-BDFA-C9AC2091EFF1}"/>
               </a:ext>
             </a:extLst>
           </p:cNvPr>
@@ -18291,7 +18410,7 @@
           <p:cNvPr id="5" name="text">
             <a:extLst xmlns:a="http://schemas.openxmlformats.org/drawingml/2006/main">
               <a:ext uri="{FF2B5EF4-FFF2-40B4-BE49-F238E27FC236}">
-                <a16:creationId xmlns:a16="http://schemas.microsoft.com/office/drawing/2014/main" id="{4216D60C-038C-4F74-BD3F-1E90F21485E7}"/>
+                <a16:creationId xmlns:a16="http://schemas.microsoft.com/office/drawing/2014/main" id="{0CD6E3EF-BB09-4F59-8E10-2F297BA036BB}"/>
               </a:ext>
             </a:extLst>
           </p:cNvPr>
@@ -18348,7 +18467,7 @@
           <p:cNvPr id="6" name="text">
             <a:extLst xmlns:a="http://schemas.openxmlformats.org/drawingml/2006/main">
               <a:ext uri="{FF2B5EF4-FFF2-40B4-BE49-F238E27FC236}">
-                <a16:creationId xmlns:a16="http://schemas.microsoft.com/office/drawing/2014/main" id="{765C1557-0167-4400-9E5B-A0AF3E633AD6}"/>
+                <a16:creationId xmlns:a16="http://schemas.microsoft.com/office/drawing/2014/main" id="{1AAEA730-AE4F-426E-96DA-AEB3DE96B39B}"/>
               </a:ext>
             </a:extLst>
           </p:cNvPr>
@@ -18405,7 +18524,7 @@
           <p:cNvPr id="7" name="text">
             <a:extLst xmlns:a="http://schemas.openxmlformats.org/drawingml/2006/main">
               <a:ext uri="{FF2B5EF4-FFF2-40B4-BE49-F238E27FC236}">
-                <a16:creationId xmlns:a16="http://schemas.microsoft.com/office/drawing/2014/main" id="{8DFD0105-F2F7-47FA-96AF-8A574EE14B66}"/>
+                <a16:creationId xmlns:a16="http://schemas.microsoft.com/office/drawing/2014/main" id="{76470C99-07C5-4F24-B279-9CD9D11936E9}"/>
               </a:ext>
             </a:extLst>
           </p:cNvPr>
@@ -18462,7 +18581,7 @@
           <p:cNvPr id="8" name="text">
             <a:extLst xmlns:a="http://schemas.openxmlformats.org/drawingml/2006/main">
               <a:ext uri="{FF2B5EF4-FFF2-40B4-BE49-F238E27FC236}">
-                <a16:creationId xmlns:a16="http://schemas.microsoft.com/office/drawing/2014/main" id="{80A6ACB6-CDBE-454E-9BB4-57F0CBF46133}"/>
+                <a16:creationId xmlns:a16="http://schemas.microsoft.com/office/drawing/2014/main" id="{D6EAEB86-123C-4175-84ED-9A1B93264F8B}"/>
               </a:ext>
             </a:extLst>
           </p:cNvPr>
@@ -18519,7 +18638,7 @@
           <p:cNvPr id="9" name="text">
             <a:extLst xmlns:a="http://schemas.openxmlformats.org/drawingml/2006/main">
               <a:ext uri="{FF2B5EF4-FFF2-40B4-BE49-F238E27FC236}">
-                <a16:creationId xmlns:a16="http://schemas.microsoft.com/office/drawing/2014/main" id="{8827526D-3DC1-443E-B78D-DCD874FC3383}"/>
+                <a16:creationId xmlns:a16="http://schemas.microsoft.com/office/drawing/2014/main" id="{541AE98A-1765-43DF-8CF8-A52BF1207C8A}"/>
               </a:ext>
             </a:extLst>
           </p:cNvPr>
@@ -18576,7 +18695,7 @@
           <p:cNvPr id="10" name="text">
             <a:extLst xmlns:a="http://schemas.openxmlformats.org/drawingml/2006/main">
               <a:ext uri="{FF2B5EF4-FFF2-40B4-BE49-F238E27FC236}">
-                <a16:creationId xmlns:a16="http://schemas.microsoft.com/office/drawing/2014/main" id="{9B8CFBBF-4EE8-4FD7-8E76-3C129E31A3AC}"/>
+                <a16:creationId xmlns:a16="http://schemas.microsoft.com/office/drawing/2014/main" id="{DBAEFD38-8A44-4CAF-A08B-5FC3E9ADAAF2}"/>
               </a:ext>
             </a:extLst>
           </p:cNvPr>
@@ -18633,7 +18752,7 @@
           <p:cNvPr id="11" name="Slide number">
             <a:extLst xmlns:a="http://schemas.openxmlformats.org/drawingml/2006/main">
               <a:ext uri="{FF2B5EF4-FFF2-40B4-BE49-F238E27FC236}">
-                <a16:creationId xmlns:a16="http://schemas.microsoft.com/office/drawing/2014/main" id="{FB072C43-D0C7-4163-99CB-219312E41D58}"/>
+                <a16:creationId xmlns:a16="http://schemas.microsoft.com/office/drawing/2014/main" id="{53D8A744-3A04-4A88-A05E-140EAD41CAD1}"/>
               </a:ext>
             </a:extLst>
           </p:cNvPr>
@@ -18688,7 +18807,7 @@
     </p:spTree>
     <p:extLst>
       <p:ext uri="{BB962C8B-B14F-4D97-AF65-F5344CB8AC3E}">
-        <p14:creationId xmlns:p14="http://schemas.microsoft.com/office/powerpoint/2010/main" val="2114801706"/>
+        <p14:creationId xmlns:p14="http://schemas.microsoft.com/office/powerpoint/2010/main" val="796727475"/>
       </p:ext>
     </p:extLst>
   </p:cSld>
@@ -18716,10 +18835,10 @@
       </p:grpSpPr>
       <p:sp>
         <p:nvSpPr>
-          <p:cNvPr id="19" name="Title">
-            <a:extLst xmlns:a="http://schemas.openxmlformats.org/drawingml/2006/main">
-              <a:ext uri="{FF2B5EF4-FFF2-40B4-BE49-F238E27FC236}">
-                <a16:creationId xmlns:a16="http://schemas.microsoft.com/office/drawing/2014/main" id="{478E8F0E-C76B-4B15-A890-79EBFF609DBF}"/>
+          <p:cNvPr id="21" name="Title">
+            <a:extLst xmlns:a="http://schemas.openxmlformats.org/drawingml/2006/main">
+              <a:ext uri="{FF2B5EF4-FFF2-40B4-BE49-F238E27FC236}">
+                <a16:creationId xmlns:a16="http://schemas.microsoft.com/office/drawing/2014/main" id="{4779100D-2685-4726-8C7D-6DA2DE1560F5}"/>
               </a:ext>
             </a:extLst>
           </p:cNvPr>
@@ -18776,7 +18895,7 @@
           <p:cNvPr id="2" name="text">
             <a:extLst xmlns:a="http://schemas.openxmlformats.org/drawingml/2006/main">
               <a:ext uri="{FF2B5EF4-FFF2-40B4-BE49-F238E27FC236}">
-                <a16:creationId xmlns:a16="http://schemas.microsoft.com/office/drawing/2014/main" id="{6E6403A9-C8BE-4A0D-B5F9-153AD3360AAD}"/>
+                <a16:creationId xmlns:a16="http://schemas.microsoft.com/office/drawing/2014/main" id="{39912999-3F04-4A23-896A-5A31211DC755}"/>
               </a:ext>
             </a:extLst>
           </p:cNvPr>
@@ -18833,7 +18952,7 @@
           <p:cNvPr id="3" name="text">
             <a:extLst xmlns:a="http://schemas.openxmlformats.org/drawingml/2006/main">
               <a:ext uri="{FF2B5EF4-FFF2-40B4-BE49-F238E27FC236}">
-                <a16:creationId xmlns:a16="http://schemas.microsoft.com/office/drawing/2014/main" id="{A77A1AD9-CBCC-44F2-A7B1-F795F728CFDC}"/>
+                <a16:creationId xmlns:a16="http://schemas.microsoft.com/office/drawing/2014/main" id="{79B34954-1E6B-4FE9-9930-A3F6CDF52AA5}"/>
               </a:ext>
             </a:extLst>
           </p:cNvPr>
@@ -18845,24 +18964,24 @@
         <p:spPr>
           <a:xfrm xmlns:a="http://schemas.openxmlformats.org/drawingml/2006/main">
             <a:off x="781050" y="2486025"/>
-            <a:ext cx="3238500" cy="400050"/>
-          </a:xfrm>
-          <a:prstGeom xmlns:a="http://schemas.openxmlformats.org/drawingml/2006/main" prst="rect">
-            <a:avLst/>
-          </a:prstGeom>
-          <a:noFill xmlns:a="http://schemas.openxmlformats.org/drawingml/2006/main"/>
-          <a:ln xmlns:a="http://schemas.openxmlformats.org/drawingml/2006/main" w="0">
-            <a:noFill/>
-          </a:ln>
-        </p:spPr>
-        <p:txBody>
-          <a:bodyPr xmlns:a="http://schemas.openxmlformats.org/drawingml/2006/main" lIns="0" tIns="0" rIns="0" bIns="0">
-            <a:noAutofit/>
-          </a:bodyPr>
-          <a:lstStyle xmlns:a="http://schemas.openxmlformats.org/drawingml/2006/main"/>
-          <a:p xmlns:a="http://schemas.openxmlformats.org/drawingml/2006/main">
-            <a:pPr algn="l">
-              <a:defRPr sz="2025" b="1">
+            <a:ext cx="2343150" cy="400050"/>
+          </a:xfrm>
+          <a:prstGeom xmlns:a="http://schemas.openxmlformats.org/drawingml/2006/main" prst="rect">
+            <a:avLst/>
+          </a:prstGeom>
+          <a:noFill xmlns:a="http://schemas.openxmlformats.org/drawingml/2006/main"/>
+          <a:ln xmlns:a="http://schemas.openxmlformats.org/drawingml/2006/main" w="0">
+            <a:noFill/>
+          </a:ln>
+        </p:spPr>
+        <p:txBody>
+          <a:bodyPr xmlns:a="http://schemas.openxmlformats.org/drawingml/2006/main" lIns="0" tIns="0" rIns="0" bIns="0">
+            <a:noAutofit/>
+          </a:bodyPr>
+          <a:lstStyle xmlns:a="http://schemas.openxmlformats.org/drawingml/2006/main"/>
+          <a:p xmlns:a="http://schemas.openxmlformats.org/drawingml/2006/main">
+            <a:pPr algn="l">
+              <a:defRPr sz="1800" b="1">
                 <a:solidFill>
                   <a:srgbClr val="00786F"/>
                 </a:solidFill>
@@ -18872,7 +18991,7 @@
               </a:defRPr>
             </a:pPr>
             <a:r>
-              <a:rPr sz="2025" b="1">
+              <a:rPr sz="1800" b="1">
                 <a:solidFill>
                   <a:srgbClr val="00786F"/>
                 </a:solidFill>
@@ -18890,36 +19009,36 @@
           <p:cNvPr id="4" name="text">
             <a:extLst xmlns:a="http://schemas.openxmlformats.org/drawingml/2006/main">
               <a:ext uri="{FF2B5EF4-FFF2-40B4-BE49-F238E27FC236}">
-                <a16:creationId xmlns:a16="http://schemas.microsoft.com/office/drawing/2014/main" id="{811E6B45-AD4B-4EF3-801A-FF5905EED2FB}"/>
-              </a:ext>
-            </a:extLst>
-          </p:cNvPr>
-          <p:cNvSpPr>
-            <a:spLocks xmlns:a="http://schemas.openxmlformats.org/drawingml/2006/main" noGrp="1"/>
-          </p:cNvSpPr>
-          <p:nvPr/>
-        </p:nvSpPr>
-        <p:spPr>
-          <a:xfrm xmlns:a="http://schemas.openxmlformats.org/drawingml/2006/main">
-            <a:off x="4286250" y="2486025"/>
-            <a:ext cx="7143750" cy="400050"/>
-          </a:xfrm>
-          <a:prstGeom xmlns:a="http://schemas.openxmlformats.org/drawingml/2006/main" prst="rect">
-            <a:avLst/>
-          </a:prstGeom>
-          <a:noFill xmlns:a="http://schemas.openxmlformats.org/drawingml/2006/main"/>
-          <a:ln xmlns:a="http://schemas.openxmlformats.org/drawingml/2006/main" w="0">
-            <a:noFill/>
-          </a:ln>
-        </p:spPr>
-        <p:txBody>
-          <a:bodyPr xmlns:a="http://schemas.openxmlformats.org/drawingml/2006/main" lIns="0" tIns="0" rIns="0" bIns="0">
-            <a:noAutofit/>
-          </a:bodyPr>
-          <a:lstStyle xmlns:a="http://schemas.openxmlformats.org/drawingml/2006/main"/>
-          <a:p xmlns:a="http://schemas.openxmlformats.org/drawingml/2006/main">
-            <a:pPr algn="l">
-              <a:defRPr sz="2025" b="0">
+                <a16:creationId xmlns:a16="http://schemas.microsoft.com/office/drawing/2014/main" id="{45E3FFA6-4867-4BC9-B59E-29CAEAF5B4FE}"/>
+              </a:ext>
+            </a:extLst>
+          </p:cNvPr>
+          <p:cNvSpPr>
+            <a:spLocks xmlns:a="http://schemas.openxmlformats.org/drawingml/2006/main" noGrp="1"/>
+          </p:cNvSpPr>
+          <p:nvPr/>
+        </p:nvSpPr>
+        <p:spPr>
+          <a:xfrm xmlns:a="http://schemas.openxmlformats.org/drawingml/2006/main">
+            <a:off x="3143250" y="2486025"/>
+            <a:ext cx="6191250" cy="400050"/>
+          </a:xfrm>
+          <a:prstGeom xmlns:a="http://schemas.openxmlformats.org/drawingml/2006/main" prst="rect">
+            <a:avLst/>
+          </a:prstGeom>
+          <a:noFill xmlns:a="http://schemas.openxmlformats.org/drawingml/2006/main"/>
+          <a:ln xmlns:a="http://schemas.openxmlformats.org/drawingml/2006/main" w="0">
+            <a:noFill/>
+          </a:ln>
+        </p:spPr>
+        <p:txBody>
+          <a:bodyPr xmlns:a="http://schemas.openxmlformats.org/drawingml/2006/main" lIns="0" tIns="0" rIns="0" bIns="0">
+            <a:noAutofit/>
+          </a:bodyPr>
+          <a:lstStyle xmlns:a="http://schemas.openxmlformats.org/drawingml/2006/main"/>
+          <a:p xmlns:a="http://schemas.openxmlformats.org/drawingml/2006/main">
+            <a:pPr algn="l">
+              <a:defRPr sz="1800" b="0">
                 <a:solidFill>
                   <a:srgbClr val="15181B"/>
                 </a:solidFill>
@@ -18929,7 +19048,7 @@
               </a:defRPr>
             </a:pPr>
             <a:r>
-              <a:rPr sz="2025" b="0">
+              <a:rPr sz="1800" b="0">
                 <a:solidFill>
                   <a:srgbClr val="15181B"/>
                 </a:solidFill>
@@ -18937,7 +19056,7 @@
                 <a:ea typeface="Satoshi Variable"/>
                 <a:cs typeface="Satoshi Variable"/>
               </a:rPr>
-              <a:t>Repeat good habits and engineering standards.</a:t>
+              <a:t>Repeat good engineering habits.</a:t>
             </a:r>
           </a:p>
         </p:txBody>
@@ -18947,7 +19066,7 @@
           <p:cNvPr id="5" name="text">
             <a:extLst xmlns:a="http://schemas.openxmlformats.org/drawingml/2006/main">
               <a:ext uri="{FF2B5EF4-FFF2-40B4-BE49-F238E27FC236}">
-                <a16:creationId xmlns:a16="http://schemas.microsoft.com/office/drawing/2014/main" id="{D21AB3AF-FA00-442B-88DA-B4D98347C154}"/>
+                <a16:creationId xmlns:a16="http://schemas.microsoft.com/office/drawing/2014/main" id="{293E3A4A-C006-434C-A49A-D95E3709F031}"/>
               </a:ext>
             </a:extLst>
           </p:cNvPr>
@@ -18959,24 +19078,24 @@
         <p:spPr>
           <a:xfrm xmlns:a="http://schemas.openxmlformats.org/drawingml/2006/main">
             <a:off x="781050" y="2962275"/>
-            <a:ext cx="3238500" cy="400050"/>
-          </a:xfrm>
-          <a:prstGeom xmlns:a="http://schemas.openxmlformats.org/drawingml/2006/main" prst="rect">
-            <a:avLst/>
-          </a:prstGeom>
-          <a:noFill xmlns:a="http://schemas.openxmlformats.org/drawingml/2006/main"/>
-          <a:ln xmlns:a="http://schemas.openxmlformats.org/drawingml/2006/main" w="0">
-            <a:noFill/>
-          </a:ln>
-        </p:spPr>
-        <p:txBody>
-          <a:bodyPr xmlns:a="http://schemas.openxmlformats.org/drawingml/2006/main" lIns="0" tIns="0" rIns="0" bIns="0">
-            <a:noAutofit/>
-          </a:bodyPr>
-          <a:lstStyle xmlns:a="http://schemas.openxmlformats.org/drawingml/2006/main"/>
-          <a:p xmlns:a="http://schemas.openxmlformats.org/drawingml/2006/main">
-            <a:pPr algn="l">
-              <a:defRPr sz="2025" b="1">
+            <a:ext cx="2343150" cy="400050"/>
+          </a:xfrm>
+          <a:prstGeom xmlns:a="http://schemas.openxmlformats.org/drawingml/2006/main" prst="rect">
+            <a:avLst/>
+          </a:prstGeom>
+          <a:noFill xmlns:a="http://schemas.openxmlformats.org/drawingml/2006/main"/>
+          <a:ln xmlns:a="http://schemas.openxmlformats.org/drawingml/2006/main" w="0">
+            <a:noFill/>
+          </a:ln>
+        </p:spPr>
+        <p:txBody>
+          <a:bodyPr xmlns:a="http://schemas.openxmlformats.org/drawingml/2006/main" lIns="0" tIns="0" rIns="0" bIns="0">
+            <a:noAutofit/>
+          </a:bodyPr>
+          <a:lstStyle xmlns:a="http://schemas.openxmlformats.org/drawingml/2006/main"/>
+          <a:p xmlns:a="http://schemas.openxmlformats.org/drawingml/2006/main">
+            <a:pPr algn="l">
+              <a:defRPr sz="1800" b="1">
                 <a:solidFill>
                   <a:srgbClr val="00786F"/>
                 </a:solidFill>
@@ -18986,7 +19105,7 @@
               </a:defRPr>
             </a:pPr>
             <a:r>
-              <a:rPr sz="2025" b="1">
+              <a:rPr sz="1800" b="1">
                 <a:solidFill>
                   <a:srgbClr val="00786F"/>
                 </a:solidFill>
@@ -19004,36 +19123,36 @@
           <p:cNvPr id="6" name="text">
             <a:extLst xmlns:a="http://schemas.openxmlformats.org/drawingml/2006/main">
               <a:ext uri="{FF2B5EF4-FFF2-40B4-BE49-F238E27FC236}">
-                <a16:creationId xmlns:a16="http://schemas.microsoft.com/office/drawing/2014/main" id="{224AD563-FDB9-471C-BE09-2F3048F367E8}"/>
-              </a:ext>
-            </a:extLst>
-          </p:cNvPr>
-          <p:cNvSpPr>
-            <a:spLocks xmlns:a="http://schemas.openxmlformats.org/drawingml/2006/main" noGrp="1"/>
-          </p:cNvSpPr>
-          <p:nvPr/>
-        </p:nvSpPr>
-        <p:spPr>
-          <a:xfrm xmlns:a="http://schemas.openxmlformats.org/drawingml/2006/main">
-            <a:off x="4286250" y="2962275"/>
-            <a:ext cx="7143750" cy="400050"/>
-          </a:xfrm>
-          <a:prstGeom xmlns:a="http://schemas.openxmlformats.org/drawingml/2006/main" prst="rect">
-            <a:avLst/>
-          </a:prstGeom>
-          <a:noFill xmlns:a="http://schemas.openxmlformats.org/drawingml/2006/main"/>
-          <a:ln xmlns:a="http://schemas.openxmlformats.org/drawingml/2006/main" w="0">
-            <a:noFill/>
-          </a:ln>
-        </p:spPr>
-        <p:txBody>
-          <a:bodyPr xmlns:a="http://schemas.openxmlformats.org/drawingml/2006/main" lIns="0" tIns="0" rIns="0" bIns="0">
-            <a:noAutofit/>
-          </a:bodyPr>
-          <a:lstStyle xmlns:a="http://schemas.openxmlformats.org/drawingml/2006/main"/>
-          <a:p xmlns:a="http://schemas.openxmlformats.org/drawingml/2006/main">
-            <a:pPr algn="l">
-              <a:defRPr sz="2025" b="0">
+                <a16:creationId xmlns:a16="http://schemas.microsoft.com/office/drawing/2014/main" id="{C018DB14-DA92-458C-ACBA-0C04DC73CE04}"/>
+              </a:ext>
+            </a:extLst>
+          </p:cNvPr>
+          <p:cNvSpPr>
+            <a:spLocks xmlns:a="http://schemas.openxmlformats.org/drawingml/2006/main" noGrp="1"/>
+          </p:cNvSpPr>
+          <p:nvPr/>
+        </p:nvSpPr>
+        <p:spPr>
+          <a:xfrm xmlns:a="http://schemas.openxmlformats.org/drawingml/2006/main">
+            <a:off x="3143250" y="2962275"/>
+            <a:ext cx="6191250" cy="400050"/>
+          </a:xfrm>
+          <a:prstGeom xmlns:a="http://schemas.openxmlformats.org/drawingml/2006/main" prst="rect">
+            <a:avLst/>
+          </a:prstGeom>
+          <a:noFill xmlns:a="http://schemas.openxmlformats.org/drawingml/2006/main"/>
+          <a:ln xmlns:a="http://schemas.openxmlformats.org/drawingml/2006/main" w="0">
+            <a:noFill/>
+          </a:ln>
+        </p:spPr>
+        <p:txBody>
+          <a:bodyPr xmlns:a="http://schemas.openxmlformats.org/drawingml/2006/main" lIns="0" tIns="0" rIns="0" bIns="0">
+            <a:noAutofit/>
+          </a:bodyPr>
+          <a:lstStyle xmlns:a="http://schemas.openxmlformats.org/drawingml/2006/main"/>
+          <a:p xmlns:a="http://schemas.openxmlformats.org/drawingml/2006/main">
+            <a:pPr algn="l">
+              <a:defRPr sz="1800" b="0">
                 <a:solidFill>
                   <a:srgbClr val="15181B"/>
                 </a:solidFill>
@@ -19043,7 +19162,7 @@
               </a:defRPr>
             </a:pPr>
             <a:r>
-              <a:rPr sz="2025" b="0">
+              <a:rPr sz="1800" b="0">
                 <a:solidFill>
                   <a:srgbClr val="15181B"/>
                 </a:solidFill>
@@ -19051,7 +19170,7 @@
                 <a:ea typeface="Satoshi Variable"/>
                 <a:cs typeface="Satoshi Variable"/>
               </a:rPr>
-              <a:t>Protect behaviour with meaningful regression checks.</a:t>
+              <a:t>Protect behaviour with regression checks.</a:t>
             </a:r>
           </a:p>
         </p:txBody>
@@ -19061,7 +19180,7 @@
           <p:cNvPr id="7" name="text">
             <a:extLst xmlns:a="http://schemas.openxmlformats.org/drawingml/2006/main">
               <a:ext uri="{FF2B5EF4-FFF2-40B4-BE49-F238E27FC236}">
-                <a16:creationId xmlns:a16="http://schemas.microsoft.com/office/drawing/2014/main" id="{35F4E6DA-A5BA-4670-8D0F-27F30458592A}"/>
+                <a16:creationId xmlns:a16="http://schemas.microsoft.com/office/drawing/2014/main" id="{611296C2-7852-4DBC-BE58-9970E9F6C936}"/>
               </a:ext>
             </a:extLst>
           </p:cNvPr>
@@ -19073,24 +19192,24 @@
         <p:spPr>
           <a:xfrm xmlns:a="http://schemas.openxmlformats.org/drawingml/2006/main">
             <a:off x="781050" y="3438525"/>
-            <a:ext cx="3238500" cy="400050"/>
-          </a:xfrm>
-          <a:prstGeom xmlns:a="http://schemas.openxmlformats.org/drawingml/2006/main" prst="rect">
-            <a:avLst/>
-          </a:prstGeom>
-          <a:noFill xmlns:a="http://schemas.openxmlformats.org/drawingml/2006/main"/>
-          <a:ln xmlns:a="http://schemas.openxmlformats.org/drawingml/2006/main" w="0">
-            <a:noFill/>
-          </a:ln>
-        </p:spPr>
-        <p:txBody>
-          <a:bodyPr xmlns:a="http://schemas.openxmlformats.org/drawingml/2006/main" lIns="0" tIns="0" rIns="0" bIns="0">
-            <a:noAutofit/>
-          </a:bodyPr>
-          <a:lstStyle xmlns:a="http://schemas.openxmlformats.org/drawingml/2006/main"/>
-          <a:p xmlns:a="http://schemas.openxmlformats.org/drawingml/2006/main">
-            <a:pPr algn="l">
-              <a:defRPr sz="2025" b="1">
+            <a:ext cx="2343150" cy="400050"/>
+          </a:xfrm>
+          <a:prstGeom xmlns:a="http://schemas.openxmlformats.org/drawingml/2006/main" prst="rect">
+            <a:avLst/>
+          </a:prstGeom>
+          <a:noFill xmlns:a="http://schemas.openxmlformats.org/drawingml/2006/main"/>
+          <a:ln xmlns:a="http://schemas.openxmlformats.org/drawingml/2006/main" w="0">
+            <a:noFill/>
+          </a:ln>
+        </p:spPr>
+        <p:txBody>
+          <a:bodyPr xmlns:a="http://schemas.openxmlformats.org/drawingml/2006/main" lIns="0" tIns="0" rIns="0" bIns="0">
+            <a:noAutofit/>
+          </a:bodyPr>
+          <a:lstStyle xmlns:a="http://schemas.openxmlformats.org/drawingml/2006/main"/>
+          <a:p xmlns:a="http://schemas.openxmlformats.org/drawingml/2006/main">
+            <a:pPr algn="l">
+              <a:defRPr sz="1800" b="1">
                 <a:solidFill>
                   <a:srgbClr val="00786F"/>
                 </a:solidFill>
@@ -19100,7 +19219,7 @@
               </a:defRPr>
             </a:pPr>
             <a:r>
-              <a:rPr sz="2025" b="1">
+              <a:rPr sz="1800" b="1">
                 <a:solidFill>
                   <a:srgbClr val="00786F"/>
                 </a:solidFill>
@@ -19118,36 +19237,36 @@
           <p:cNvPr id="8" name="text">
             <a:extLst xmlns:a="http://schemas.openxmlformats.org/drawingml/2006/main">
               <a:ext uri="{FF2B5EF4-FFF2-40B4-BE49-F238E27FC236}">
-                <a16:creationId xmlns:a16="http://schemas.microsoft.com/office/drawing/2014/main" id="{4C47F9CB-77C2-4B46-9CBC-A62F4D7C8130}"/>
-              </a:ext>
-            </a:extLst>
-          </p:cNvPr>
-          <p:cNvSpPr>
-            <a:spLocks xmlns:a="http://schemas.openxmlformats.org/drawingml/2006/main" noGrp="1"/>
-          </p:cNvSpPr>
-          <p:nvPr/>
-        </p:nvSpPr>
-        <p:spPr>
-          <a:xfrm xmlns:a="http://schemas.openxmlformats.org/drawingml/2006/main">
-            <a:off x="4286250" y="3438525"/>
-            <a:ext cx="7143750" cy="400050"/>
-          </a:xfrm>
-          <a:prstGeom xmlns:a="http://schemas.openxmlformats.org/drawingml/2006/main" prst="rect">
-            <a:avLst/>
-          </a:prstGeom>
-          <a:noFill xmlns:a="http://schemas.openxmlformats.org/drawingml/2006/main"/>
-          <a:ln xmlns:a="http://schemas.openxmlformats.org/drawingml/2006/main" w="0">
-            <a:noFill/>
-          </a:ln>
-        </p:spPr>
-        <p:txBody>
-          <a:bodyPr xmlns:a="http://schemas.openxmlformats.org/drawingml/2006/main" lIns="0" tIns="0" rIns="0" bIns="0">
-            <a:noAutofit/>
-          </a:bodyPr>
-          <a:lstStyle xmlns:a="http://schemas.openxmlformats.org/drawingml/2006/main"/>
-          <a:p xmlns:a="http://schemas.openxmlformats.org/drawingml/2006/main">
-            <a:pPr algn="l">
-              <a:defRPr sz="2025" b="0">
+                <a16:creationId xmlns:a16="http://schemas.microsoft.com/office/drawing/2014/main" id="{1011631E-7A18-4E73-AAA4-FCD754466085}"/>
+              </a:ext>
+            </a:extLst>
+          </p:cNvPr>
+          <p:cNvSpPr>
+            <a:spLocks xmlns:a="http://schemas.openxmlformats.org/drawingml/2006/main" noGrp="1"/>
+          </p:cNvSpPr>
+          <p:nvPr/>
+        </p:nvSpPr>
+        <p:spPr>
+          <a:xfrm xmlns:a="http://schemas.openxmlformats.org/drawingml/2006/main">
+            <a:off x="3143250" y="3438525"/>
+            <a:ext cx="6191250" cy="400050"/>
+          </a:xfrm>
+          <a:prstGeom xmlns:a="http://schemas.openxmlformats.org/drawingml/2006/main" prst="rect">
+            <a:avLst/>
+          </a:prstGeom>
+          <a:noFill xmlns:a="http://schemas.openxmlformats.org/drawingml/2006/main"/>
+          <a:ln xmlns:a="http://schemas.openxmlformats.org/drawingml/2006/main" w="0">
+            <a:noFill/>
+          </a:ln>
+        </p:spPr>
+        <p:txBody>
+          <a:bodyPr xmlns:a="http://schemas.openxmlformats.org/drawingml/2006/main" lIns="0" tIns="0" rIns="0" bIns="0">
+            <a:noAutofit/>
+          </a:bodyPr>
+          <a:lstStyle xmlns:a="http://schemas.openxmlformats.org/drawingml/2006/main"/>
+          <a:p xmlns:a="http://schemas.openxmlformats.org/drawingml/2006/main">
+            <a:pPr algn="l">
+              <a:defRPr sz="1800" b="0">
                 <a:solidFill>
                   <a:srgbClr val="15181B"/>
                 </a:solidFill>
@@ -19157,7 +19276,7 @@
               </a:defRPr>
             </a:pPr>
             <a:r>
-              <a:rPr sz="2025" b="0">
+              <a:rPr sz="1800" b="0">
                 <a:solidFill>
                   <a:srgbClr val="15181B"/>
                 </a:solidFill>
@@ -19175,7 +19294,7 @@
           <p:cNvPr id="9" name="text">
             <a:extLst xmlns:a="http://schemas.openxmlformats.org/drawingml/2006/main">
               <a:ext uri="{FF2B5EF4-FFF2-40B4-BE49-F238E27FC236}">
-                <a16:creationId xmlns:a16="http://schemas.microsoft.com/office/drawing/2014/main" id="{E8B306C2-1548-47F9-B616-E6322DD4E24F}"/>
+                <a16:creationId xmlns:a16="http://schemas.microsoft.com/office/drawing/2014/main" id="{2EAD6CE7-C350-4C07-9830-4C1448116549}"/>
               </a:ext>
             </a:extLst>
           </p:cNvPr>
@@ -19187,24 +19306,24 @@
         <p:spPr>
           <a:xfrm xmlns:a="http://schemas.openxmlformats.org/drawingml/2006/main">
             <a:off x="781050" y="3914775"/>
-            <a:ext cx="3238500" cy="400050"/>
-          </a:xfrm>
-          <a:prstGeom xmlns:a="http://schemas.openxmlformats.org/drawingml/2006/main" prst="rect">
-            <a:avLst/>
-          </a:prstGeom>
-          <a:noFill xmlns:a="http://schemas.openxmlformats.org/drawingml/2006/main"/>
-          <a:ln xmlns:a="http://schemas.openxmlformats.org/drawingml/2006/main" w="0">
-            <a:noFill/>
-          </a:ln>
-        </p:spPr>
-        <p:txBody>
-          <a:bodyPr xmlns:a="http://schemas.openxmlformats.org/drawingml/2006/main" lIns="0" tIns="0" rIns="0" bIns="0">
-            <a:noAutofit/>
-          </a:bodyPr>
-          <a:lstStyle xmlns:a="http://schemas.openxmlformats.org/drawingml/2006/main"/>
-          <a:p xmlns:a="http://schemas.openxmlformats.org/drawingml/2006/main">
-            <a:pPr algn="l">
-              <a:defRPr sz="2025" b="1">
+            <a:ext cx="2343150" cy="400050"/>
+          </a:xfrm>
+          <a:prstGeom xmlns:a="http://schemas.openxmlformats.org/drawingml/2006/main" prst="rect">
+            <a:avLst/>
+          </a:prstGeom>
+          <a:noFill xmlns:a="http://schemas.openxmlformats.org/drawingml/2006/main"/>
+          <a:ln xmlns:a="http://schemas.openxmlformats.org/drawingml/2006/main" w="0">
+            <a:noFill/>
+          </a:ln>
+        </p:spPr>
+        <p:txBody>
+          <a:bodyPr xmlns:a="http://schemas.openxmlformats.org/drawingml/2006/main" lIns="0" tIns="0" rIns="0" bIns="0">
+            <a:noAutofit/>
+          </a:bodyPr>
+          <a:lstStyle xmlns:a="http://schemas.openxmlformats.org/drawingml/2006/main"/>
+          <a:p xmlns:a="http://schemas.openxmlformats.org/drawingml/2006/main">
+            <a:pPr algn="l">
+              <a:defRPr sz="1800" b="1">
                 <a:solidFill>
                   <a:srgbClr val="00786F"/>
                 </a:solidFill>
@@ -19214,7 +19333,7 @@
               </a:defRPr>
             </a:pPr>
             <a:r>
-              <a:rPr sz="2025" b="1">
+              <a:rPr sz="1800" b="1">
                 <a:solidFill>
                   <a:srgbClr val="00786F"/>
                 </a:solidFill>
@@ -19232,36 +19351,36 @@
           <p:cNvPr id="10" name="text">
             <a:extLst xmlns:a="http://schemas.openxmlformats.org/drawingml/2006/main">
               <a:ext uri="{FF2B5EF4-FFF2-40B4-BE49-F238E27FC236}">
-                <a16:creationId xmlns:a16="http://schemas.microsoft.com/office/drawing/2014/main" id="{638FA6EC-2F7A-4AF3-8551-BDA50441712C}"/>
-              </a:ext>
-            </a:extLst>
-          </p:cNvPr>
-          <p:cNvSpPr>
-            <a:spLocks xmlns:a="http://schemas.openxmlformats.org/drawingml/2006/main" noGrp="1"/>
-          </p:cNvSpPr>
-          <p:nvPr/>
-        </p:nvSpPr>
-        <p:spPr>
-          <a:xfrm xmlns:a="http://schemas.openxmlformats.org/drawingml/2006/main">
-            <a:off x="4286250" y="3914775"/>
-            <a:ext cx="7143750" cy="400050"/>
-          </a:xfrm>
-          <a:prstGeom xmlns:a="http://schemas.openxmlformats.org/drawingml/2006/main" prst="rect">
-            <a:avLst/>
-          </a:prstGeom>
-          <a:noFill xmlns:a="http://schemas.openxmlformats.org/drawingml/2006/main"/>
-          <a:ln xmlns:a="http://schemas.openxmlformats.org/drawingml/2006/main" w="0">
-            <a:noFill/>
-          </a:ln>
-        </p:spPr>
-        <p:txBody>
-          <a:bodyPr xmlns:a="http://schemas.openxmlformats.org/drawingml/2006/main" lIns="0" tIns="0" rIns="0" bIns="0">
-            <a:noAutofit/>
-          </a:bodyPr>
-          <a:lstStyle xmlns:a="http://schemas.openxmlformats.org/drawingml/2006/main"/>
-          <a:p xmlns:a="http://schemas.openxmlformats.org/drawingml/2006/main">
-            <a:pPr algn="l">
-              <a:defRPr sz="2025" b="0">
+                <a16:creationId xmlns:a16="http://schemas.microsoft.com/office/drawing/2014/main" id="{3C8D82D0-C27C-42BD-9545-A34CB46B6B22}"/>
+              </a:ext>
+            </a:extLst>
+          </p:cNvPr>
+          <p:cNvSpPr>
+            <a:spLocks xmlns:a="http://schemas.openxmlformats.org/drawingml/2006/main" noGrp="1"/>
+          </p:cNvSpPr>
+          <p:nvPr/>
+        </p:nvSpPr>
+        <p:spPr>
+          <a:xfrm xmlns:a="http://schemas.openxmlformats.org/drawingml/2006/main">
+            <a:off x="3143250" y="3914775"/>
+            <a:ext cx="6191250" cy="400050"/>
+          </a:xfrm>
+          <a:prstGeom xmlns:a="http://schemas.openxmlformats.org/drawingml/2006/main" prst="rect">
+            <a:avLst/>
+          </a:prstGeom>
+          <a:noFill xmlns:a="http://schemas.openxmlformats.org/drawingml/2006/main"/>
+          <a:ln xmlns:a="http://schemas.openxmlformats.org/drawingml/2006/main" w="0">
+            <a:noFill/>
+          </a:ln>
+        </p:spPr>
+        <p:txBody>
+          <a:bodyPr xmlns:a="http://schemas.openxmlformats.org/drawingml/2006/main" lIns="0" tIns="0" rIns="0" bIns="0">
+            <a:noAutofit/>
+          </a:bodyPr>
+          <a:lstStyle xmlns:a="http://schemas.openxmlformats.org/drawingml/2006/main"/>
+          <a:p xmlns:a="http://schemas.openxmlformats.org/drawingml/2006/main">
+            <a:pPr algn="l">
+              <a:defRPr sz="1800" b="0">
                 <a:solidFill>
                   <a:srgbClr val="15181B"/>
                 </a:solidFill>
@@ -19271,7 +19390,7 @@
               </a:defRPr>
             </a:pPr>
             <a:r>
-              <a:rPr sz="2025" b="0">
+              <a:rPr sz="1800" b="0">
                 <a:solidFill>
                   <a:srgbClr val="15181B"/>
                 </a:solidFill>
@@ -19279,7 +19398,7 @@
                 <a:ea typeface="Satoshi Variable"/>
                 <a:cs typeface="Satoshi Variable"/>
               </a:rPr>
-              <a:t>Maestro smoke and nightly checks. Videos and logs.</a:t>
+              <a:t>Maestro smoke and nightly checks. Video evidence.</a:t>
             </a:r>
           </a:p>
         </p:txBody>
@@ -19289,7 +19408,7 @@
           <p:cNvPr id="11" name="text">
             <a:extLst xmlns:a="http://schemas.openxmlformats.org/drawingml/2006/main">
               <a:ext uri="{FF2B5EF4-FFF2-40B4-BE49-F238E27FC236}">
-                <a16:creationId xmlns:a16="http://schemas.microsoft.com/office/drawing/2014/main" id="{88F69DFF-2668-4622-90B2-88F86AEF262B}"/>
+                <a16:creationId xmlns:a16="http://schemas.microsoft.com/office/drawing/2014/main" id="{6EF5F8DD-F0A0-4F5F-ADDC-12553CEFA27B}"/>
               </a:ext>
             </a:extLst>
           </p:cNvPr>
@@ -19301,24 +19420,24 @@
         <p:spPr>
           <a:xfrm xmlns:a="http://schemas.openxmlformats.org/drawingml/2006/main">
             <a:off x="781050" y="4391025"/>
-            <a:ext cx="3238500" cy="400050"/>
-          </a:xfrm>
-          <a:prstGeom xmlns:a="http://schemas.openxmlformats.org/drawingml/2006/main" prst="rect">
-            <a:avLst/>
-          </a:prstGeom>
-          <a:noFill xmlns:a="http://schemas.openxmlformats.org/drawingml/2006/main"/>
-          <a:ln xmlns:a="http://schemas.openxmlformats.org/drawingml/2006/main" w="0">
-            <a:noFill/>
-          </a:ln>
-        </p:spPr>
-        <p:txBody>
-          <a:bodyPr xmlns:a="http://schemas.openxmlformats.org/drawingml/2006/main" lIns="0" tIns="0" rIns="0" bIns="0">
-            <a:noAutofit/>
-          </a:bodyPr>
-          <a:lstStyle xmlns:a="http://schemas.openxmlformats.org/drawingml/2006/main"/>
-          <a:p xmlns:a="http://schemas.openxmlformats.org/drawingml/2006/main">
-            <a:pPr algn="l">
-              <a:defRPr sz="2025" b="1">
+            <a:ext cx="2343150" cy="400050"/>
+          </a:xfrm>
+          <a:prstGeom xmlns:a="http://schemas.openxmlformats.org/drawingml/2006/main" prst="rect">
+            <a:avLst/>
+          </a:prstGeom>
+          <a:noFill xmlns:a="http://schemas.openxmlformats.org/drawingml/2006/main"/>
+          <a:ln xmlns:a="http://schemas.openxmlformats.org/drawingml/2006/main" w="0">
+            <a:noFill/>
+          </a:ln>
+        </p:spPr>
+        <p:txBody>
+          <a:bodyPr xmlns:a="http://schemas.openxmlformats.org/drawingml/2006/main" lIns="0" tIns="0" rIns="0" bIns="0">
+            <a:noAutofit/>
+          </a:bodyPr>
+          <a:lstStyle xmlns:a="http://schemas.openxmlformats.org/drawingml/2006/main"/>
+          <a:p xmlns:a="http://schemas.openxmlformats.org/drawingml/2006/main">
+            <a:pPr algn="l">
+              <a:defRPr sz="1800" b="1">
                 <a:solidFill>
                   <a:srgbClr val="00786F"/>
                 </a:solidFill>
@@ -19328,7 +19447,7 @@
               </a:defRPr>
             </a:pPr>
             <a:r>
-              <a:rPr sz="2025" b="1">
+              <a:rPr sz="1800" b="1">
                 <a:solidFill>
                   <a:srgbClr val="00786F"/>
                 </a:solidFill>
@@ -19346,36 +19465,36 @@
           <p:cNvPr id="12" name="text">
             <a:extLst xmlns:a="http://schemas.openxmlformats.org/drawingml/2006/main">
               <a:ext uri="{FF2B5EF4-FFF2-40B4-BE49-F238E27FC236}">
-                <a16:creationId xmlns:a16="http://schemas.microsoft.com/office/drawing/2014/main" id="{E44BC78E-1119-4501-86A7-31C48C6B2DA5}"/>
-              </a:ext>
-            </a:extLst>
-          </p:cNvPr>
-          <p:cNvSpPr>
-            <a:spLocks xmlns:a="http://schemas.openxmlformats.org/drawingml/2006/main" noGrp="1"/>
-          </p:cNvSpPr>
-          <p:nvPr/>
-        </p:nvSpPr>
-        <p:spPr>
-          <a:xfrm xmlns:a="http://schemas.openxmlformats.org/drawingml/2006/main">
-            <a:off x="4286250" y="4391025"/>
-            <a:ext cx="7143750" cy="400050"/>
-          </a:xfrm>
-          <a:prstGeom xmlns:a="http://schemas.openxmlformats.org/drawingml/2006/main" prst="rect">
-            <a:avLst/>
-          </a:prstGeom>
-          <a:noFill xmlns:a="http://schemas.openxmlformats.org/drawingml/2006/main"/>
-          <a:ln xmlns:a="http://schemas.openxmlformats.org/drawingml/2006/main" w="0">
-            <a:noFill/>
-          </a:ln>
-        </p:spPr>
-        <p:txBody>
-          <a:bodyPr xmlns:a="http://schemas.openxmlformats.org/drawingml/2006/main" lIns="0" tIns="0" rIns="0" bIns="0">
-            <a:noAutofit/>
-          </a:bodyPr>
-          <a:lstStyle xmlns:a="http://schemas.openxmlformats.org/drawingml/2006/main"/>
-          <a:p xmlns:a="http://schemas.openxmlformats.org/drawingml/2006/main">
-            <a:pPr algn="l">
-              <a:defRPr sz="2025" b="0">
+                <a16:creationId xmlns:a16="http://schemas.microsoft.com/office/drawing/2014/main" id="{679C133F-5D74-4C11-B7B9-A417772DE33C}"/>
+              </a:ext>
+            </a:extLst>
+          </p:cNvPr>
+          <p:cNvSpPr>
+            <a:spLocks xmlns:a="http://schemas.openxmlformats.org/drawingml/2006/main" noGrp="1"/>
+          </p:cNvSpPr>
+          <p:nvPr/>
+        </p:nvSpPr>
+        <p:spPr>
+          <a:xfrm xmlns:a="http://schemas.openxmlformats.org/drawingml/2006/main">
+            <a:off x="3143250" y="4391025"/>
+            <a:ext cx="6191250" cy="400050"/>
+          </a:xfrm>
+          <a:prstGeom xmlns:a="http://schemas.openxmlformats.org/drawingml/2006/main" prst="rect">
+            <a:avLst/>
+          </a:prstGeom>
+          <a:noFill xmlns:a="http://schemas.openxmlformats.org/drawingml/2006/main"/>
+          <a:ln xmlns:a="http://schemas.openxmlformats.org/drawingml/2006/main" w="0">
+            <a:noFill/>
+          </a:ln>
+        </p:spPr>
+        <p:txBody>
+          <a:bodyPr xmlns:a="http://schemas.openxmlformats.org/drawingml/2006/main" lIns="0" tIns="0" rIns="0" bIns="0">
+            <a:noAutofit/>
+          </a:bodyPr>
+          <a:lstStyle xmlns:a="http://schemas.openxmlformats.org/drawingml/2006/main"/>
+          <a:p xmlns:a="http://schemas.openxmlformats.org/drawingml/2006/main">
+            <a:pPr algn="l">
+              <a:defRPr sz="1800" b="0">
                 <a:solidFill>
                   <a:srgbClr val="15181B"/>
                 </a:solidFill>
@@ -19385,7 +19504,7 @@
               </a:defRPr>
             </a:pPr>
             <a:r>
-              <a:rPr sz="2025" b="0">
+              <a:rPr sz="1800" b="0">
                 <a:solidFill>
                   <a:srgbClr val="15181B"/>
                 </a:solidFill>
@@ -19393,7 +19512,7 @@
                 <a:ea typeface="Satoshi Variable"/>
                 <a:cs typeface="Satoshi Variable"/>
               </a:rPr>
-              <a:t>Shared mobile guidelines. Feedback evaluated and fixed.</a:t>
+              <a:t>Mobile guidelines. Evaluate feedback. Fix valid issues.</a:t>
             </a:r>
           </a:p>
         </p:txBody>
@@ -19403,7 +19522,7 @@
           <p:cNvPr id="13" name="text">
             <a:extLst xmlns:a="http://schemas.openxmlformats.org/drawingml/2006/main">
               <a:ext uri="{FF2B5EF4-FFF2-40B4-BE49-F238E27FC236}">
-                <a16:creationId xmlns:a16="http://schemas.microsoft.com/office/drawing/2014/main" id="{BBB26C6F-E670-4C42-8103-456DB4ED8B53}"/>
+                <a16:creationId xmlns:a16="http://schemas.microsoft.com/office/drawing/2014/main" id="{18D5CEF8-880E-4D87-BB0A-9211C3588635}"/>
               </a:ext>
             </a:extLst>
           </p:cNvPr>
@@ -19415,24 +19534,24 @@
         <p:spPr>
           <a:xfrm xmlns:a="http://schemas.openxmlformats.org/drawingml/2006/main">
             <a:off x="781050" y="4867275"/>
-            <a:ext cx="3238500" cy="400050"/>
-          </a:xfrm>
-          <a:prstGeom xmlns:a="http://schemas.openxmlformats.org/drawingml/2006/main" prst="rect">
-            <a:avLst/>
-          </a:prstGeom>
-          <a:noFill xmlns:a="http://schemas.openxmlformats.org/drawingml/2006/main"/>
-          <a:ln xmlns:a="http://schemas.openxmlformats.org/drawingml/2006/main" w="0">
-            <a:noFill/>
-          </a:ln>
-        </p:spPr>
-        <p:txBody>
-          <a:bodyPr xmlns:a="http://schemas.openxmlformats.org/drawingml/2006/main" lIns="0" tIns="0" rIns="0" bIns="0">
-            <a:noAutofit/>
-          </a:bodyPr>
-          <a:lstStyle xmlns:a="http://schemas.openxmlformats.org/drawingml/2006/main"/>
-          <a:p xmlns:a="http://schemas.openxmlformats.org/drawingml/2006/main">
-            <a:pPr algn="l">
-              <a:defRPr sz="2025" b="1">
+            <a:ext cx="2343150" cy="400050"/>
+          </a:xfrm>
+          <a:prstGeom xmlns:a="http://schemas.openxmlformats.org/drawingml/2006/main" prst="rect">
+            <a:avLst/>
+          </a:prstGeom>
+          <a:noFill xmlns:a="http://schemas.openxmlformats.org/drawingml/2006/main"/>
+          <a:ln xmlns:a="http://schemas.openxmlformats.org/drawingml/2006/main" w="0">
+            <a:noFill/>
+          </a:ln>
+        </p:spPr>
+        <p:txBody>
+          <a:bodyPr xmlns:a="http://schemas.openxmlformats.org/drawingml/2006/main" lIns="0" tIns="0" rIns="0" bIns="0">
+            <a:noAutofit/>
+          </a:bodyPr>
+          <a:lstStyle xmlns:a="http://schemas.openxmlformats.org/drawingml/2006/main"/>
+          <a:p xmlns:a="http://schemas.openxmlformats.org/drawingml/2006/main">
+            <a:pPr algn="l">
+              <a:defRPr sz="1800" b="1">
                 <a:solidFill>
                   <a:srgbClr val="00786F"/>
                 </a:solidFill>
@@ -19442,7 +19561,7 @@
               </a:defRPr>
             </a:pPr>
             <a:r>
-              <a:rPr sz="2025" b="1">
+              <a:rPr sz="1800" b="1">
                 <a:solidFill>
                   <a:srgbClr val="00786F"/>
                 </a:solidFill>
@@ -19460,36 +19579,36 @@
           <p:cNvPr id="14" name="text">
             <a:extLst xmlns:a="http://schemas.openxmlformats.org/drawingml/2006/main">
               <a:ext uri="{FF2B5EF4-FFF2-40B4-BE49-F238E27FC236}">
-                <a16:creationId xmlns:a16="http://schemas.microsoft.com/office/drawing/2014/main" id="{319BBE4C-E910-4E1D-8D4A-0342D99A02F5}"/>
-              </a:ext>
-            </a:extLst>
-          </p:cNvPr>
-          <p:cNvSpPr>
-            <a:spLocks xmlns:a="http://schemas.openxmlformats.org/drawingml/2006/main" noGrp="1"/>
-          </p:cNvSpPr>
-          <p:nvPr/>
-        </p:nvSpPr>
-        <p:spPr>
-          <a:xfrm xmlns:a="http://schemas.openxmlformats.org/drawingml/2006/main">
-            <a:off x="4286250" y="4867275"/>
-            <a:ext cx="7143750" cy="400050"/>
-          </a:xfrm>
-          <a:prstGeom xmlns:a="http://schemas.openxmlformats.org/drawingml/2006/main" prst="rect">
-            <a:avLst/>
-          </a:prstGeom>
-          <a:noFill xmlns:a="http://schemas.openxmlformats.org/drawingml/2006/main"/>
-          <a:ln xmlns:a="http://schemas.openxmlformats.org/drawingml/2006/main" w="0">
-            <a:noFill/>
-          </a:ln>
-        </p:spPr>
-        <p:txBody>
-          <a:bodyPr xmlns:a="http://schemas.openxmlformats.org/drawingml/2006/main" lIns="0" tIns="0" rIns="0" bIns="0">
-            <a:noAutofit/>
-          </a:bodyPr>
-          <a:lstStyle xmlns:a="http://schemas.openxmlformats.org/drawingml/2006/main"/>
-          <a:p xmlns:a="http://schemas.openxmlformats.org/drawingml/2006/main">
-            <a:pPr algn="l">
-              <a:defRPr sz="2025" b="0">
+                <a16:creationId xmlns:a16="http://schemas.microsoft.com/office/drawing/2014/main" id="{54E0DBDB-7F13-4250-96D4-191510ADC662}"/>
+              </a:ext>
+            </a:extLst>
+          </p:cNvPr>
+          <p:cNvSpPr>
+            <a:spLocks xmlns:a="http://schemas.openxmlformats.org/drawingml/2006/main" noGrp="1"/>
+          </p:cNvSpPr>
+          <p:nvPr/>
+        </p:nvSpPr>
+        <p:spPr>
+          <a:xfrm xmlns:a="http://schemas.openxmlformats.org/drawingml/2006/main">
+            <a:off x="3143250" y="4867275"/>
+            <a:ext cx="6191250" cy="400050"/>
+          </a:xfrm>
+          <a:prstGeom xmlns:a="http://schemas.openxmlformats.org/drawingml/2006/main" prst="rect">
+            <a:avLst/>
+          </a:prstGeom>
+          <a:noFill xmlns:a="http://schemas.openxmlformats.org/drawingml/2006/main"/>
+          <a:ln xmlns:a="http://schemas.openxmlformats.org/drawingml/2006/main" w="0">
+            <a:noFill/>
+          </a:ln>
+        </p:spPr>
+        <p:txBody>
+          <a:bodyPr xmlns:a="http://schemas.openxmlformats.org/drawingml/2006/main" lIns="0" tIns="0" rIns="0" bIns="0">
+            <a:noAutofit/>
+          </a:bodyPr>
+          <a:lstStyle xmlns:a="http://schemas.openxmlformats.org/drawingml/2006/main"/>
+          <a:p xmlns:a="http://schemas.openxmlformats.org/drawingml/2006/main">
+            <a:pPr algn="l">
+              <a:defRPr sz="1800" b="0">
                 <a:solidFill>
                   <a:srgbClr val="15181B"/>
                 </a:solidFill>
@@ -19499,7 +19618,7 @@
               </a:defRPr>
             </a:pPr>
             <a:r>
-              <a:rPr sz="2025" b="0">
+              <a:rPr sz="1800" b="0">
                 <a:solidFill>
                   <a:srgbClr val="15181B"/>
                 </a:solidFill>
@@ -19517,7 +19636,7 @@
           <p:cNvPr id="15" name="text">
             <a:extLst xmlns:a="http://schemas.openxmlformats.org/drawingml/2006/main">
               <a:ext uri="{FF2B5EF4-FFF2-40B4-BE49-F238E27FC236}">
-                <a16:creationId xmlns:a16="http://schemas.microsoft.com/office/drawing/2014/main" id="{4598CC10-9C1E-4FFF-BBFE-DD9A2BE935CC}"/>
+                <a16:creationId xmlns:a16="http://schemas.microsoft.com/office/drawing/2014/main" id="{75979A3D-A2F6-4746-9ED8-E5120CCAAC71}"/>
               </a:ext>
             </a:extLst>
           </p:cNvPr>
@@ -19529,24 +19648,24 @@
         <p:spPr>
           <a:xfrm xmlns:a="http://schemas.openxmlformats.org/drawingml/2006/main">
             <a:off x="781050" y="5343525"/>
-            <a:ext cx="3238500" cy="400050"/>
-          </a:xfrm>
-          <a:prstGeom xmlns:a="http://schemas.openxmlformats.org/drawingml/2006/main" prst="rect">
-            <a:avLst/>
-          </a:prstGeom>
-          <a:noFill xmlns:a="http://schemas.openxmlformats.org/drawingml/2006/main"/>
-          <a:ln xmlns:a="http://schemas.openxmlformats.org/drawingml/2006/main" w="0">
-            <a:noFill/>
-          </a:ln>
-        </p:spPr>
-        <p:txBody>
-          <a:bodyPr xmlns:a="http://schemas.openxmlformats.org/drawingml/2006/main" lIns="0" tIns="0" rIns="0" bIns="0">
-            <a:noAutofit/>
-          </a:bodyPr>
-          <a:lstStyle xmlns:a="http://schemas.openxmlformats.org/drawingml/2006/main"/>
-          <a:p xmlns:a="http://schemas.openxmlformats.org/drawingml/2006/main">
-            <a:pPr algn="l">
-              <a:defRPr sz="2025" b="1">
+            <a:ext cx="2343150" cy="400050"/>
+          </a:xfrm>
+          <a:prstGeom xmlns:a="http://schemas.openxmlformats.org/drawingml/2006/main" prst="rect">
+            <a:avLst/>
+          </a:prstGeom>
+          <a:noFill xmlns:a="http://schemas.openxmlformats.org/drawingml/2006/main"/>
+          <a:ln xmlns:a="http://schemas.openxmlformats.org/drawingml/2006/main" w="0">
+            <a:noFill/>
+          </a:ln>
+        </p:spPr>
+        <p:txBody>
+          <a:bodyPr xmlns:a="http://schemas.openxmlformats.org/drawingml/2006/main" lIns="0" tIns="0" rIns="0" bIns="0">
+            <a:noAutofit/>
+          </a:bodyPr>
+          <a:lstStyle xmlns:a="http://schemas.openxmlformats.org/drawingml/2006/main"/>
+          <a:p xmlns:a="http://schemas.openxmlformats.org/drawingml/2006/main">
+            <a:pPr algn="l">
+              <a:defRPr sz="1800" b="1">
                 <a:solidFill>
                   <a:srgbClr val="00786F"/>
                 </a:solidFill>
@@ -19556,7 +19675,7 @@
               </a:defRPr>
             </a:pPr>
             <a:r>
-              <a:rPr sz="2025" b="1">
+              <a:rPr sz="1800" b="1">
                 <a:solidFill>
                   <a:srgbClr val="00786F"/>
                 </a:solidFill>
@@ -19574,36 +19693,36 @@
           <p:cNvPr id="16" name="text">
             <a:extLst xmlns:a="http://schemas.openxmlformats.org/drawingml/2006/main">
               <a:ext uri="{FF2B5EF4-FFF2-40B4-BE49-F238E27FC236}">
-                <a16:creationId xmlns:a16="http://schemas.microsoft.com/office/drawing/2014/main" id="{BCCF2D0F-37D2-4E8A-BA4D-BE2C96E4A052}"/>
-              </a:ext>
-            </a:extLst>
-          </p:cNvPr>
-          <p:cNvSpPr>
-            <a:spLocks xmlns:a="http://schemas.openxmlformats.org/drawingml/2006/main" noGrp="1"/>
-          </p:cNvSpPr>
-          <p:nvPr/>
-        </p:nvSpPr>
-        <p:spPr>
-          <a:xfrm xmlns:a="http://schemas.openxmlformats.org/drawingml/2006/main">
-            <a:off x="4286250" y="5343525"/>
-            <a:ext cx="7143750" cy="400050"/>
-          </a:xfrm>
-          <a:prstGeom xmlns:a="http://schemas.openxmlformats.org/drawingml/2006/main" prst="rect">
-            <a:avLst/>
-          </a:prstGeom>
-          <a:noFill xmlns:a="http://schemas.openxmlformats.org/drawingml/2006/main"/>
-          <a:ln xmlns:a="http://schemas.openxmlformats.org/drawingml/2006/main" w="0">
-            <a:noFill/>
-          </a:ln>
-        </p:spPr>
-        <p:txBody>
-          <a:bodyPr xmlns:a="http://schemas.openxmlformats.org/drawingml/2006/main" lIns="0" tIns="0" rIns="0" bIns="0">
-            <a:noAutofit/>
-          </a:bodyPr>
-          <a:lstStyle xmlns:a="http://schemas.openxmlformats.org/drawingml/2006/main"/>
-          <a:p xmlns:a="http://schemas.openxmlformats.org/drawingml/2006/main">
-            <a:pPr algn="l">
-              <a:defRPr sz="2025" b="0">
+                <a16:creationId xmlns:a16="http://schemas.microsoft.com/office/drawing/2014/main" id="{241F00E9-DF63-4012-B6F6-9E4DF369F30E}"/>
+              </a:ext>
+            </a:extLst>
+          </p:cNvPr>
+          <p:cNvSpPr>
+            <a:spLocks xmlns:a="http://schemas.openxmlformats.org/drawingml/2006/main" noGrp="1"/>
+          </p:cNvSpPr>
+          <p:nvPr/>
+        </p:nvSpPr>
+        <p:spPr>
+          <a:xfrm xmlns:a="http://schemas.openxmlformats.org/drawingml/2006/main">
+            <a:off x="3143250" y="5343525"/>
+            <a:ext cx="6191250" cy="400050"/>
+          </a:xfrm>
+          <a:prstGeom xmlns:a="http://schemas.openxmlformats.org/drawingml/2006/main" prst="rect">
+            <a:avLst/>
+          </a:prstGeom>
+          <a:noFill xmlns:a="http://schemas.openxmlformats.org/drawingml/2006/main"/>
+          <a:ln xmlns:a="http://schemas.openxmlformats.org/drawingml/2006/main" w="0">
+            <a:noFill/>
+          </a:ln>
+        </p:spPr>
+        <p:txBody>
+          <a:bodyPr xmlns:a="http://schemas.openxmlformats.org/drawingml/2006/main" lIns="0" tIns="0" rIns="0" bIns="0">
+            <a:noAutofit/>
+          </a:bodyPr>
+          <a:lstStyle xmlns:a="http://schemas.openxmlformats.org/drawingml/2006/main"/>
+          <a:p xmlns:a="http://schemas.openxmlformats.org/drawingml/2006/main">
+            <a:pPr algn="l">
+              <a:defRPr sz="1800" b="0">
                 <a:solidFill>
                   <a:srgbClr val="15181B"/>
                 </a:solidFill>
@@ -19613,7 +19732,7 @@
               </a:defRPr>
             </a:pPr>
             <a:r>
-              <a:rPr sz="2025" b="0">
+              <a:rPr sz="1800" b="0">
                 <a:solidFill>
                   <a:srgbClr val="15181B"/>
                 </a:solidFill>
@@ -19626,12 +19745,91 @@
           </a:p>
         </p:txBody>
       </p:sp>
-      <p:sp>
-        <p:nvSpPr>
-          <p:cNvPr id="17" name="text">
-            <a:extLst xmlns:a="http://schemas.openxmlformats.org/drawingml/2006/main">
-              <a:ext uri="{FF2B5EF4-FFF2-40B4-BE49-F238E27FC236}">
-                <a16:creationId xmlns:a16="http://schemas.microsoft.com/office/drawing/2014/main" id="{CDB2414B-B010-44EA-B15A-DC5C781CDA41}"/>
+      <p:pic>
+        <p:nvPicPr>
+          <p:cNvPr id="37" name=""/>
+          <p:cNvPicPr>
+            <a:picLocks xmlns:a="http://schemas.openxmlformats.org/drawingml/2006/main" noChangeAspect="1"/>
+          </p:cNvPicPr>
+          <p:nvPr/>
+        </p:nvPicPr>
+        <p:blipFill>
+          <a:blip xmlns:r="http://schemas.openxmlformats.org/officeDocument/2006/relationships" xmlns:a="http://schemas.openxmlformats.org/drawingml/2006/main" r:embed="R9b7b5b1bad224adb"/>
+          <a:stretch xmlns:a="http://schemas.openxmlformats.org/drawingml/2006/main"/>
+        </p:blipFill>
+        <p:spPr>
+          <a:xfrm xmlns:a="http://schemas.openxmlformats.org/drawingml/2006/main">
+            <a:off x="9525000" y="3095625"/>
+            <a:ext cx="1905000" cy="1905000"/>
+          </a:xfrm>
+          <a:prstGeom xmlns:a="http://schemas.openxmlformats.org/drawingml/2006/main" prst="rect">
+            <a:avLst/>
+          </a:prstGeom>
+        </p:spPr>
+      </p:pic>
+      <p:sp>
+        <p:nvSpPr>
+          <p:cNvPr id="18" name="Share page">
+            <a:extLst xmlns:a="http://schemas.openxmlformats.org/drawingml/2006/main">
+              <a:ext uri="{FF2B5EF4-FFF2-40B4-BE49-F238E27FC236}">
+                <a16:creationId xmlns:a16="http://schemas.microsoft.com/office/drawing/2014/main" id="{28F36433-379A-4930-B84F-0CE68B750C36}"/>
+              </a:ext>
+            </a:extLst>
+          </p:cNvPr>
+          <p:cNvSpPr>
+            <a:spLocks xmlns:a="http://schemas.openxmlformats.org/drawingml/2006/main" noGrp="1"/>
+          </p:cNvSpPr>
+          <p:nvPr/>
+        </p:nvSpPr>
+        <p:spPr>
+          <a:xfrm xmlns:a="http://schemas.openxmlformats.org/drawingml/2006/main">
+            <a:off x="9334500" y="5124450"/>
+            <a:ext cx="2286000" cy="304800"/>
+          </a:xfrm>
+          <a:prstGeom xmlns:a="http://schemas.openxmlformats.org/drawingml/2006/main" prst="rect">
+            <a:avLst/>
+          </a:prstGeom>
+          <a:noFill xmlns:a="http://schemas.openxmlformats.org/drawingml/2006/main"/>
+          <a:ln xmlns:a="http://schemas.openxmlformats.org/drawingml/2006/main" w="0">
+            <a:noFill/>
+          </a:ln>
+        </p:spPr>
+        <p:txBody>
+          <a:bodyPr xmlns:a="http://schemas.openxmlformats.org/drawingml/2006/main" lIns="0" tIns="0" rIns="0" bIns="0">
+            <a:noAutofit/>
+          </a:bodyPr>
+          <a:lstStyle xmlns:a="http://schemas.openxmlformats.org/drawingml/2006/main"/>
+          <a:p xmlns:a="http://schemas.openxmlformats.org/drawingml/2006/main">
+            <a:pPr algn="ctr">
+              <a:defRPr sz="1575" b="0">
+                <a:solidFill>
+                  <a:srgbClr val="565F65"/>
+                </a:solidFill>
+                <a:latin typeface="Satoshi Variable"/>
+                <a:ea typeface="Satoshi Variable"/>
+                <a:cs typeface="Satoshi Variable"/>
+              </a:defRPr>
+            </a:pPr>
+            <a:r>
+              <a:rPr sz="1575" b="0">
+                <a:solidFill>
+                  <a:srgbClr val="565F65"/>
+                </a:solidFill>
+                <a:latin typeface="Satoshi Variable"/>
+                <a:ea typeface="Satoshi Variable"/>
+                <a:cs typeface="Satoshi Variable"/>
+              </a:rPr>
+              <a:t>MrAdib.com/share</a:t>
+            </a:r>
+          </a:p>
+        </p:txBody>
+      </p:sp>
+      <p:sp>
+        <p:nvSpPr>
+          <p:cNvPr id="19" name="text">
+            <a:extLst xmlns:a="http://schemas.openxmlformats.org/drawingml/2006/main">
+              <a:ext uri="{FF2B5EF4-FFF2-40B4-BE49-F238E27FC236}">
+                <a16:creationId xmlns:a16="http://schemas.microsoft.com/office/drawing/2014/main" id="{E0A48791-CF80-4211-B651-2AA21D7E2670}"/>
               </a:ext>
             </a:extLst>
           </p:cNvPr>
@@ -19708,10 +19906,10 @@
       </p:sp>
       <p:sp>
         <p:nvSpPr>
-          <p:cNvPr id="18" name="Slide number">
-            <a:extLst xmlns:a="http://schemas.openxmlformats.org/drawingml/2006/main">
-              <a:ext uri="{FF2B5EF4-FFF2-40B4-BE49-F238E27FC236}">
-                <a16:creationId xmlns:a16="http://schemas.microsoft.com/office/drawing/2014/main" id="{1C634AE3-5EB6-4358-B245-D1979B03EA06}"/>
+          <p:cNvPr id="20" name="Slide number">
+            <a:extLst xmlns:a="http://schemas.openxmlformats.org/drawingml/2006/main">
+              <a:ext uri="{FF2B5EF4-FFF2-40B4-BE49-F238E27FC236}">
+                <a16:creationId xmlns:a16="http://schemas.microsoft.com/office/drawing/2014/main" id="{EF298D97-570F-42B3-BDBC-C4C9801A874B}"/>
               </a:ext>
             </a:extLst>
           </p:cNvPr>
@@ -19766,7 +19964,7 @@
     </p:spTree>
     <p:extLst>
       <p:ext uri="{BB962C8B-B14F-4D97-AF65-F5344CB8AC3E}">
-        <p14:creationId xmlns:p14="http://schemas.microsoft.com/office/powerpoint/2010/main" val="939582229"/>
+        <p14:creationId xmlns:p14="http://schemas.microsoft.com/office/powerpoint/2010/main" val="1703217195"/>
       </p:ext>
     </p:extLst>
   </p:cSld>
@@ -19797,7 +19995,7 @@
           <p:cNvPr id="4" name="Title">
             <a:extLst xmlns:a="http://schemas.openxmlformats.org/drawingml/2006/main">
               <a:ext uri="{FF2B5EF4-FFF2-40B4-BE49-F238E27FC236}">
-                <a16:creationId xmlns:a16="http://schemas.microsoft.com/office/drawing/2014/main" id="{A5D2041B-0190-4A12-BB7F-A301F69B45F6}"/>
+                <a16:creationId xmlns:a16="http://schemas.microsoft.com/office/drawing/2014/main" id="{2E00852A-E984-490B-8992-8B108FA1FB3C}"/>
               </a:ext>
             </a:extLst>
           </p:cNvPr>
@@ -19877,7 +20075,7 @@
           <p:cNvPr id="2" name="text">
             <a:extLst xmlns:a="http://schemas.openxmlformats.org/drawingml/2006/main">
               <a:ext uri="{FF2B5EF4-FFF2-40B4-BE49-F238E27FC236}">
-                <a16:creationId xmlns:a16="http://schemas.microsoft.com/office/drawing/2014/main" id="{25A3644B-90AC-4471-AAF3-38459D235458}"/>
+                <a16:creationId xmlns:a16="http://schemas.microsoft.com/office/drawing/2014/main" id="{92A81B22-5F38-44B2-BB2F-246832DA4008}"/>
               </a:ext>
             </a:extLst>
           </p:cNvPr>
@@ -19957,7 +20155,7 @@
           <p:cNvPr id="3" name="Slide number">
             <a:extLst xmlns:a="http://schemas.openxmlformats.org/drawingml/2006/main">
               <a:ext uri="{FF2B5EF4-FFF2-40B4-BE49-F238E27FC236}">
-                <a16:creationId xmlns:a16="http://schemas.microsoft.com/office/drawing/2014/main" id="{B97C6B96-0C8D-462E-9CB3-3E8CF083C9B8}"/>
+                <a16:creationId xmlns:a16="http://schemas.microsoft.com/office/drawing/2014/main" id="{5CE2C04C-BE14-459E-9707-D6596CD032B4}"/>
               </a:ext>
             </a:extLst>
           </p:cNvPr>
@@ -20012,7 +20210,7 @@
     </p:spTree>
     <p:extLst>
       <p:ext uri="{BB962C8B-B14F-4D97-AF65-F5344CB8AC3E}">
-        <p14:creationId xmlns:p14="http://schemas.microsoft.com/office/powerpoint/2010/main" val="1963305659"/>
+        <p14:creationId xmlns:p14="http://schemas.microsoft.com/office/powerpoint/2010/main" val="1777394008"/>
       </p:ext>
     </p:extLst>
   </p:cSld>
@@ -20043,7 +20241,7 @@
           <p:cNvPr id="4" name="Title">
             <a:extLst xmlns:a="http://schemas.openxmlformats.org/drawingml/2006/main">
               <a:ext uri="{FF2B5EF4-FFF2-40B4-BE49-F238E27FC236}">
-                <a16:creationId xmlns:a16="http://schemas.microsoft.com/office/drawing/2014/main" id="{34E0B17A-12AE-4381-BB3C-823ABC2D8D78}"/>
+                <a16:creationId xmlns:a16="http://schemas.microsoft.com/office/drawing/2014/main" id="{FDC07A54-3E1F-40AB-9007-69EB5B6B2BF6}"/>
               </a:ext>
             </a:extLst>
           </p:cNvPr>
@@ -20123,7 +20321,7 @@
           <p:cNvPr id="2" name="text">
             <a:extLst xmlns:a="http://schemas.openxmlformats.org/drawingml/2006/main">
               <a:ext uri="{FF2B5EF4-FFF2-40B4-BE49-F238E27FC236}">
-                <a16:creationId xmlns:a16="http://schemas.microsoft.com/office/drawing/2014/main" id="{F4449733-DD90-4678-89F9-0FF1983C8BAE}"/>
+                <a16:creationId xmlns:a16="http://schemas.microsoft.com/office/drawing/2014/main" id="{599539F0-61EF-40A0-9F1F-3078CFC38F43}"/>
               </a:ext>
             </a:extLst>
           </p:cNvPr>
@@ -20180,7 +20378,7 @@
           <p:cNvPr id="3" name="Slide number">
             <a:extLst xmlns:a="http://schemas.openxmlformats.org/drawingml/2006/main">
               <a:ext uri="{FF2B5EF4-FFF2-40B4-BE49-F238E27FC236}">
-                <a16:creationId xmlns:a16="http://schemas.microsoft.com/office/drawing/2014/main" id="{655D36BF-59B1-4A91-BDD3-1B6422B52A78}"/>
+                <a16:creationId xmlns:a16="http://schemas.microsoft.com/office/drawing/2014/main" id="{E19A6955-FC80-4CA7-BFAA-D9E0F3113710}"/>
               </a:ext>
             </a:extLst>
           </p:cNvPr>
@@ -20235,7 +20433,7 @@
     </p:spTree>
     <p:extLst>
       <p:ext uri="{BB962C8B-B14F-4D97-AF65-F5344CB8AC3E}">
-        <p14:creationId xmlns:p14="http://schemas.microsoft.com/office/powerpoint/2010/main" val="356064071"/>
+        <p14:creationId xmlns:p14="http://schemas.microsoft.com/office/powerpoint/2010/main" val="1491725523"/>
       </p:ext>
     </p:extLst>
   </p:cSld>
@@ -20266,7 +20464,7 @@
           <p:cNvPr id="4" name="Title">
             <a:extLst xmlns:a="http://schemas.openxmlformats.org/drawingml/2006/main">
               <a:ext uri="{FF2B5EF4-FFF2-40B4-BE49-F238E27FC236}">
-                <a16:creationId xmlns:a16="http://schemas.microsoft.com/office/drawing/2014/main" id="{5565B5E1-428E-409B-96EA-E75CFC8D6E31}"/>
+                <a16:creationId xmlns:a16="http://schemas.microsoft.com/office/drawing/2014/main" id="{50487B2D-2C7F-4BE8-8BE9-04665B0A9156}"/>
               </a:ext>
             </a:extLst>
           </p:cNvPr>
@@ -20346,7 +20544,7 @@
           <p:cNvPr id="2" name="text">
             <a:extLst xmlns:a="http://schemas.openxmlformats.org/drawingml/2006/main">
               <a:ext uri="{FF2B5EF4-FFF2-40B4-BE49-F238E27FC236}">
-                <a16:creationId xmlns:a16="http://schemas.microsoft.com/office/drawing/2014/main" id="{636EA02C-3661-4309-9DE8-08985C3B31D6}"/>
+                <a16:creationId xmlns:a16="http://schemas.microsoft.com/office/drawing/2014/main" id="{A9FA32C0-9A4D-451E-9FA7-D22CC978A30C}"/>
               </a:ext>
             </a:extLst>
           </p:cNvPr>
@@ -20403,7 +20601,7 @@
           <p:cNvPr id="3" name="Slide number">
             <a:extLst xmlns:a="http://schemas.openxmlformats.org/drawingml/2006/main">
               <a:ext uri="{FF2B5EF4-FFF2-40B4-BE49-F238E27FC236}">
-                <a16:creationId xmlns:a16="http://schemas.microsoft.com/office/drawing/2014/main" id="{F6746422-74A7-49A7-AA2F-D90A5361E915}"/>
+                <a16:creationId xmlns:a16="http://schemas.microsoft.com/office/drawing/2014/main" id="{A80C96B0-A105-4398-8E87-B10C22CBB237}"/>
               </a:ext>
             </a:extLst>
           </p:cNvPr>
@@ -20458,7 +20656,7 @@
     </p:spTree>
     <p:extLst>
       <p:ext uri="{BB962C8B-B14F-4D97-AF65-F5344CB8AC3E}">
-        <p14:creationId xmlns:p14="http://schemas.microsoft.com/office/powerpoint/2010/main" val="409488624"/>
+        <p14:creationId xmlns:p14="http://schemas.microsoft.com/office/powerpoint/2010/main" val="86274152"/>
       </p:ext>
     </p:extLst>
   </p:cSld>
@@ -20493,7 +20691,7 @@
           <p:nvPr/>
         </p:nvPicPr>
         <p:blipFill>
-          <a:blip xmlns:r="http://schemas.openxmlformats.org/officeDocument/2006/relationships" xmlns:a="http://schemas.openxmlformats.org/drawingml/2006/main" r:embed="Ra881f5aa917c4bae"/>
+          <a:blip xmlns:r="http://schemas.openxmlformats.org/officeDocument/2006/relationships" xmlns:a="http://schemas.openxmlformats.org/drawingml/2006/main" r:embed="R2ae33bec15eb48c1"/>
           <a:srcRect xmlns:a="http://schemas.openxmlformats.org/drawingml/2006/main" l="0" t="0" r="0" b="0"/>
           <a:stretch xmlns:a="http://schemas.openxmlformats.org/drawingml/2006/main">
             <a:fillRect l="0" t="0" r="0" b="0"/>
@@ -20514,7 +20712,7 @@
           <p:cNvPr id="2" name="Title">
             <a:extLst xmlns:a="http://schemas.openxmlformats.org/drawingml/2006/main">
               <a:ext uri="{FF2B5EF4-FFF2-40B4-BE49-F238E27FC236}">
-                <a16:creationId xmlns:a16="http://schemas.microsoft.com/office/drawing/2014/main" id="{D6DBAEC4-11D5-41D7-955B-43589919CA48}"/>
+                <a16:creationId xmlns:a16="http://schemas.microsoft.com/office/drawing/2014/main" id="{3250F189-1E2E-4FEA-B2DD-682B307E81DE}"/>
               </a:ext>
             </a:extLst>
           </p:cNvPr>
@@ -20571,7 +20769,7 @@
           <p:cNvPr id="3" name="Title">
             <a:extLst xmlns:a="http://schemas.openxmlformats.org/drawingml/2006/main">
               <a:ext uri="{FF2B5EF4-FFF2-40B4-BE49-F238E27FC236}">
-                <a16:creationId xmlns:a16="http://schemas.microsoft.com/office/drawing/2014/main" id="{69504F14-17FF-42FA-9ED9-286306385A5F}"/>
+                <a16:creationId xmlns:a16="http://schemas.microsoft.com/office/drawing/2014/main" id="{AA1C88BB-7AA0-4146-A28E-D8F548C084C6}"/>
               </a:ext>
             </a:extLst>
           </p:cNvPr>
@@ -20628,7 +20826,7 @@
           <p:cNvPr id="4" name="Credentials">
             <a:extLst xmlns:a="http://schemas.openxmlformats.org/drawingml/2006/main">
               <a:ext uri="{FF2B5EF4-FFF2-40B4-BE49-F238E27FC236}">
-                <a16:creationId xmlns:a16="http://schemas.microsoft.com/office/drawing/2014/main" id="{9C90B494-37D1-4416-BCC8-92ABADDC7E9D}"/>
+                <a16:creationId xmlns:a16="http://schemas.microsoft.com/office/drawing/2014/main" id="{41B753CE-F93D-408A-93EF-070BA12472DD}"/>
               </a:ext>
             </a:extLst>
           </p:cNvPr>
@@ -20685,7 +20883,7 @@
           <p:cNvPr id="5" name="Experience">
             <a:extLst xmlns:a="http://schemas.openxmlformats.org/drawingml/2006/main">
               <a:ext uri="{FF2B5EF4-FFF2-40B4-BE49-F238E27FC236}">
-                <a16:creationId xmlns:a16="http://schemas.microsoft.com/office/drawing/2014/main" id="{4D6EE929-468D-4EBE-9160-120CCBB84F14}"/>
+                <a16:creationId xmlns:a16="http://schemas.microsoft.com/office/drawing/2014/main" id="{33BDDF89-0CCF-405F-90CD-52A58F11888F}"/>
               </a:ext>
             </a:extLst>
           </p:cNvPr>
@@ -20742,7 +20940,7 @@
           <p:cNvPr id="6" name="Website">
             <a:extLst xmlns:a="http://schemas.openxmlformats.org/drawingml/2006/main">
               <a:ext uri="{FF2B5EF4-FFF2-40B4-BE49-F238E27FC236}">
-                <a16:creationId xmlns:a16="http://schemas.microsoft.com/office/drawing/2014/main" id="{8DE4F3CA-B112-4F39-A94F-A3894B174F00}"/>
+                <a16:creationId xmlns:a16="http://schemas.microsoft.com/office/drawing/2014/main" id="{B7F5DE0F-A0B5-43D4-9D11-7C6C025E969C}"/>
               </a:ext>
             </a:extLst>
           </p:cNvPr>
@@ -20799,7 +20997,7 @@
           <p:cNvPr id="7" name="Slide number">
             <a:extLst xmlns:a="http://schemas.openxmlformats.org/drawingml/2006/main">
               <a:ext uri="{FF2B5EF4-FFF2-40B4-BE49-F238E27FC236}">
-                <a16:creationId xmlns:a16="http://schemas.microsoft.com/office/drawing/2014/main" id="{3306D512-5E37-4A50-BE73-3CDD38B8061B}"/>
+                <a16:creationId xmlns:a16="http://schemas.microsoft.com/office/drawing/2014/main" id="{44948736-23AD-4DA8-9302-45C0996AFE52}"/>
               </a:ext>
             </a:extLst>
           </p:cNvPr>
@@ -20854,7 +21052,7 @@
     </p:spTree>
     <p:extLst>
       <p:ext uri="{BB962C8B-B14F-4D97-AF65-F5344CB8AC3E}">
-        <p14:creationId xmlns:p14="http://schemas.microsoft.com/office/powerpoint/2010/main" val="776816197"/>
+        <p14:creationId xmlns:p14="http://schemas.microsoft.com/office/powerpoint/2010/main" val="1890271321"/>
       </p:ext>
     </p:extLst>
   </p:cSld>
@@ -20885,7 +21083,7 @@
           <p:cNvPr id="10" name="Active section">
             <a:extLst xmlns:a="http://schemas.openxmlformats.org/drawingml/2006/main">
               <a:ext uri="{FF2B5EF4-FFF2-40B4-BE49-F238E27FC236}">
-                <a16:creationId xmlns:a16="http://schemas.microsoft.com/office/drawing/2014/main" id="{E8A1E629-561F-4DDB-B6F8-83851DCCB113}"/>
+                <a16:creationId xmlns:a16="http://schemas.microsoft.com/office/drawing/2014/main" id="{F9810F8A-8EE4-44E0-8DBD-0348E8AE0842}"/>
               </a:ext>
             </a:extLst>
           </p:cNvPr>
@@ -20942,7 +21140,7 @@
           <p:cNvPr id="2" name="Section description 0">
             <a:extLst xmlns:a="http://schemas.openxmlformats.org/drawingml/2006/main">
               <a:ext uri="{FF2B5EF4-FFF2-40B4-BE49-F238E27FC236}">
-                <a16:creationId xmlns:a16="http://schemas.microsoft.com/office/drawing/2014/main" id="{AB49B450-98D0-4494-A289-5B1D13509E8F}"/>
+                <a16:creationId xmlns:a16="http://schemas.microsoft.com/office/drawing/2014/main" id="{77364B72-484D-4EEE-B7AF-F94FEFA2C6BF}"/>
               </a:ext>
             </a:extLst>
           </p:cNvPr>
@@ -21003,7 +21201,7 @@
           <p:nvPr/>
         </p:nvPicPr>
         <p:blipFill>
-          <a:blip xmlns:r="http://schemas.openxmlformats.org/officeDocument/2006/relationships" xmlns:a="http://schemas.openxmlformats.org/drawingml/2006/main" r:embed="R99a0e094f2504018"/>
+          <a:blip xmlns:r="http://schemas.openxmlformats.org/officeDocument/2006/relationships" xmlns:a="http://schemas.openxmlformats.org/drawingml/2006/main" r:embed="R855bafc60bae4fd9"/>
           <a:stretch xmlns:a="http://schemas.openxmlformats.org/drawingml/2006/main"/>
         </p:blipFill>
         <p:spPr>
@@ -21025,7 +21223,7 @@
           <p:nvPr/>
         </p:nvPicPr>
         <p:blipFill>
-          <a:blip xmlns:r="http://schemas.openxmlformats.org/officeDocument/2006/relationships" xmlns:a="http://schemas.openxmlformats.org/drawingml/2006/main" r:embed="R156f818f46154a5f"/>
+          <a:blip xmlns:r="http://schemas.openxmlformats.org/officeDocument/2006/relationships" xmlns:a="http://schemas.openxmlformats.org/drawingml/2006/main" r:embed="Re3ed74c0a5624935"/>
           <a:stretch xmlns:a="http://schemas.openxmlformats.org/drawingml/2006/main"/>
         </p:blipFill>
         <p:spPr>
@@ -21047,7 +21245,7 @@
           <p:nvPr/>
         </p:nvPicPr>
         <p:blipFill>
-          <a:blip xmlns:r="http://schemas.openxmlformats.org/officeDocument/2006/relationships" xmlns:a="http://schemas.openxmlformats.org/drawingml/2006/main" r:embed="R9a231d7a2b734481"/>
+          <a:blip xmlns:r="http://schemas.openxmlformats.org/officeDocument/2006/relationships" xmlns:a="http://schemas.openxmlformats.org/drawingml/2006/main" r:embed="R937d62573b0843a3"/>
           <a:stretch xmlns:a="http://schemas.openxmlformats.org/drawingml/2006/main"/>
         </p:blipFill>
         <p:spPr>
@@ -21069,7 +21267,7 @@
           <p:nvPr/>
         </p:nvPicPr>
         <p:blipFill>
-          <a:blip xmlns:r="http://schemas.openxmlformats.org/officeDocument/2006/relationships" xmlns:a="http://schemas.openxmlformats.org/drawingml/2006/main" r:embed="Rf117a5217b9d4ffc"/>
+          <a:blip xmlns:r="http://schemas.openxmlformats.org/officeDocument/2006/relationships" xmlns:a="http://schemas.openxmlformats.org/drawingml/2006/main" r:embed="R058095599fc84fe9"/>
           <a:stretch xmlns:a="http://schemas.openxmlformats.org/drawingml/2006/main"/>
         </p:blipFill>
         <p:spPr>
@@ -21091,7 +21289,7 @@
           <p:nvPr/>
         </p:nvPicPr>
         <p:blipFill>
-          <a:blip xmlns:r="http://schemas.openxmlformats.org/officeDocument/2006/relationships" xmlns:a="http://schemas.openxmlformats.org/drawingml/2006/main" r:embed="R3438005bffb24271"/>
+          <a:blip xmlns:r="http://schemas.openxmlformats.org/officeDocument/2006/relationships" xmlns:a="http://schemas.openxmlformats.org/drawingml/2006/main" r:embed="R5bb584804b894f15"/>
           <a:stretch xmlns:a="http://schemas.openxmlformats.org/drawingml/2006/main"/>
         </p:blipFill>
         <p:spPr>
@@ -21113,7 +21311,7 @@
           <p:nvPr/>
         </p:nvPicPr>
         <p:blipFill>
-          <a:blip xmlns:r="http://schemas.openxmlformats.org/officeDocument/2006/relationships" xmlns:a="http://schemas.openxmlformats.org/drawingml/2006/main" r:embed="Re9380cab87e74f3b"/>
+          <a:blip xmlns:r="http://schemas.openxmlformats.org/officeDocument/2006/relationships" xmlns:a="http://schemas.openxmlformats.org/drawingml/2006/main" r:embed="R29be8132589a4001"/>
           <a:stretch xmlns:a="http://schemas.openxmlformats.org/drawingml/2006/main"/>
         </p:blipFill>
         <p:spPr>
@@ -21131,7 +21329,7 @@
           <p:cNvPr id="9" name="Slide number">
             <a:extLst xmlns:a="http://schemas.openxmlformats.org/drawingml/2006/main">
               <a:ext uri="{FF2B5EF4-FFF2-40B4-BE49-F238E27FC236}">
-                <a16:creationId xmlns:a16="http://schemas.microsoft.com/office/drawing/2014/main" id="{621322AB-9E44-4F31-9025-63795D8150C6}"/>
+                <a16:creationId xmlns:a16="http://schemas.microsoft.com/office/drawing/2014/main" id="{C911B0A7-B1DD-4A4D-98FD-0E6BB170426E}"/>
               </a:ext>
             </a:extLst>
           </p:cNvPr>
@@ -21186,7 +21384,7 @@
     </p:spTree>
     <p:extLst>
       <p:ext uri="{BB962C8B-B14F-4D97-AF65-F5344CB8AC3E}">
-        <p14:creationId xmlns:p14="http://schemas.microsoft.com/office/powerpoint/2010/main" val="1394673865"/>
+        <p14:creationId xmlns:p14="http://schemas.microsoft.com/office/powerpoint/2010/main" val="417239002"/>
       </p:ext>
     </p:extLst>
   </p:cSld>
@@ -21217,7 +21415,7 @@
           <p:cNvPr id="20" name="Title">
             <a:extLst xmlns:a="http://schemas.openxmlformats.org/drawingml/2006/main">
               <a:ext uri="{FF2B5EF4-FFF2-40B4-BE49-F238E27FC236}">
-                <a16:creationId xmlns:a16="http://schemas.microsoft.com/office/drawing/2014/main" id="{4A1B8803-28CA-4F6D-8DD5-1AE6668A08BF}"/>
+                <a16:creationId xmlns:a16="http://schemas.microsoft.com/office/drawing/2014/main" id="{7FEB187A-11D5-417D-A976-90853A8C0362}"/>
               </a:ext>
             </a:extLst>
           </p:cNvPr>
@@ -21274,7 +21472,7 @@
           <p:cNvPr id="2" name="text">
             <a:extLst xmlns:a="http://schemas.openxmlformats.org/drawingml/2006/main">
               <a:ext uri="{FF2B5EF4-FFF2-40B4-BE49-F238E27FC236}">
-                <a16:creationId xmlns:a16="http://schemas.microsoft.com/office/drawing/2014/main" id="{939125DC-A93E-408F-9B89-CD93C6C1B8D6}"/>
+                <a16:creationId xmlns:a16="http://schemas.microsoft.com/office/drawing/2014/main" id="{E94798F0-6227-4459-BF9E-716974A57154}"/>
               </a:ext>
             </a:extLst>
           </p:cNvPr>
@@ -21331,7 +21529,7 @@
           <p:cNvPr id="3" name="text">
             <a:extLst xmlns:a="http://schemas.openxmlformats.org/drawingml/2006/main">
               <a:ext uri="{FF2B5EF4-FFF2-40B4-BE49-F238E27FC236}">
-                <a16:creationId xmlns:a16="http://schemas.microsoft.com/office/drawing/2014/main" id="{74998D5F-D523-4AC7-92AA-18CC9E16BC93}"/>
+                <a16:creationId xmlns:a16="http://schemas.microsoft.com/office/drawing/2014/main" id="{D31049BD-1433-4DC6-8065-DD94B9B27977}"/>
               </a:ext>
             </a:extLst>
           </p:cNvPr>
@@ -21388,7 +21586,7 @@
           <p:cNvPr id="4" name="text">
             <a:extLst xmlns:a="http://schemas.openxmlformats.org/drawingml/2006/main">
               <a:ext uri="{FF2B5EF4-FFF2-40B4-BE49-F238E27FC236}">
-                <a16:creationId xmlns:a16="http://schemas.microsoft.com/office/drawing/2014/main" id="{78FB9C37-C958-4C46-BDA6-30BB77FE21B6}"/>
+                <a16:creationId xmlns:a16="http://schemas.microsoft.com/office/drawing/2014/main" id="{8323FB13-EE71-48B0-A42B-4E9C59DE9FDC}"/>
               </a:ext>
             </a:extLst>
           </p:cNvPr>
@@ -21445,7 +21643,7 @@
           <p:cNvPr id="5" name="text">
             <a:extLst xmlns:a="http://schemas.openxmlformats.org/drawingml/2006/main">
               <a:ext uri="{FF2B5EF4-FFF2-40B4-BE49-F238E27FC236}">
-                <a16:creationId xmlns:a16="http://schemas.microsoft.com/office/drawing/2014/main" id="{3C67CB18-5D29-429C-AC0B-2ABB29D58BF2}"/>
+                <a16:creationId xmlns:a16="http://schemas.microsoft.com/office/drawing/2014/main" id="{CACB3F03-341A-40DF-93A9-FFF6CCF3BA5D}"/>
               </a:ext>
             </a:extLst>
           </p:cNvPr>
@@ -21502,7 +21700,7 @@
           <p:cNvPr id="6" name="text">
             <a:extLst xmlns:a="http://schemas.openxmlformats.org/drawingml/2006/main">
               <a:ext uri="{FF2B5EF4-FFF2-40B4-BE49-F238E27FC236}">
-                <a16:creationId xmlns:a16="http://schemas.microsoft.com/office/drawing/2014/main" id="{1D712E4D-4C0E-44CD-B4AA-7A958411FDFC}"/>
+                <a16:creationId xmlns:a16="http://schemas.microsoft.com/office/drawing/2014/main" id="{67AADB3E-F273-424B-B829-002A0EADA563}"/>
               </a:ext>
             </a:extLst>
           </p:cNvPr>
@@ -21559,7 +21757,7 @@
           <p:cNvPr id="7" name="text">
             <a:extLst xmlns:a="http://schemas.openxmlformats.org/drawingml/2006/main">
               <a:ext uri="{FF2B5EF4-FFF2-40B4-BE49-F238E27FC236}">
-                <a16:creationId xmlns:a16="http://schemas.microsoft.com/office/drawing/2014/main" id="{0A96F54B-3356-4094-ADFD-6C9067777813}"/>
+                <a16:creationId xmlns:a16="http://schemas.microsoft.com/office/drawing/2014/main" id="{B7B61609-AE76-49C3-A77B-6AF4C36D5F59}"/>
               </a:ext>
             </a:extLst>
           </p:cNvPr>
@@ -21616,7 +21814,7 @@
           <p:cNvPr id="8" name="text">
             <a:extLst xmlns:a="http://schemas.openxmlformats.org/drawingml/2006/main">
               <a:ext uri="{FF2B5EF4-FFF2-40B4-BE49-F238E27FC236}">
-                <a16:creationId xmlns:a16="http://schemas.microsoft.com/office/drawing/2014/main" id="{089AAA45-FE15-4FA9-8A8E-7FBB57B204B4}"/>
+                <a16:creationId xmlns:a16="http://schemas.microsoft.com/office/drawing/2014/main" id="{87655647-ECBC-458A-AB08-AFCCB73AF147}"/>
               </a:ext>
             </a:extLst>
           </p:cNvPr>
@@ -21673,7 +21871,7 @@
           <p:cNvPr id="9" name="text">
             <a:extLst xmlns:a="http://schemas.openxmlformats.org/drawingml/2006/main">
               <a:ext uri="{FF2B5EF4-FFF2-40B4-BE49-F238E27FC236}">
-                <a16:creationId xmlns:a16="http://schemas.microsoft.com/office/drawing/2014/main" id="{6FF706F7-C958-476D-A12A-6663A220DC3A}"/>
+                <a16:creationId xmlns:a16="http://schemas.microsoft.com/office/drawing/2014/main" id="{20CAA20E-27C8-4F0A-8940-1262EB1EE628}"/>
               </a:ext>
             </a:extLst>
           </p:cNvPr>
@@ -21730,7 +21928,7 @@
           <p:cNvPr id="10" name="text">
             <a:extLst xmlns:a="http://schemas.openxmlformats.org/drawingml/2006/main">
               <a:ext uri="{FF2B5EF4-FFF2-40B4-BE49-F238E27FC236}">
-                <a16:creationId xmlns:a16="http://schemas.microsoft.com/office/drawing/2014/main" id="{B9C96AC7-4B41-497F-B20D-D7F10707F82A}"/>
+                <a16:creationId xmlns:a16="http://schemas.microsoft.com/office/drawing/2014/main" id="{4D83F05C-E49F-4CB2-8B68-05BA8E8426DE}"/>
               </a:ext>
             </a:extLst>
           </p:cNvPr>
@@ -21787,7 +21985,7 @@
           <p:cNvPr id="11" name="text">
             <a:extLst xmlns:a="http://schemas.openxmlformats.org/drawingml/2006/main">
               <a:ext uri="{FF2B5EF4-FFF2-40B4-BE49-F238E27FC236}">
-                <a16:creationId xmlns:a16="http://schemas.microsoft.com/office/drawing/2014/main" id="{CF808F7D-29EC-4E2A-8300-642F61897241}"/>
+                <a16:creationId xmlns:a16="http://schemas.microsoft.com/office/drawing/2014/main" id="{55205D37-BC6B-4A1D-8693-8F44B3C94207}"/>
               </a:ext>
             </a:extLst>
           </p:cNvPr>
@@ -21844,7 +22042,7 @@
           <p:cNvPr id="12" name="text">
             <a:extLst xmlns:a="http://schemas.openxmlformats.org/drawingml/2006/main">
               <a:ext uri="{FF2B5EF4-FFF2-40B4-BE49-F238E27FC236}">
-                <a16:creationId xmlns:a16="http://schemas.microsoft.com/office/drawing/2014/main" id="{EEA0029A-9123-4B37-8A2D-E989661842D2}"/>
+                <a16:creationId xmlns:a16="http://schemas.microsoft.com/office/drawing/2014/main" id="{231192E1-6E08-4696-BEF6-055E57AEF97C}"/>
               </a:ext>
             </a:extLst>
           </p:cNvPr>
@@ -21901,7 +22099,7 @@
           <p:cNvPr id="13" name="text">
             <a:extLst xmlns:a="http://schemas.openxmlformats.org/drawingml/2006/main">
               <a:ext uri="{FF2B5EF4-FFF2-40B4-BE49-F238E27FC236}">
-                <a16:creationId xmlns:a16="http://schemas.microsoft.com/office/drawing/2014/main" id="{6BC6D98D-66A9-418F-A868-084E6B4EEC94}"/>
+                <a16:creationId xmlns:a16="http://schemas.microsoft.com/office/drawing/2014/main" id="{54209DAE-1652-41A1-ACFD-D758F38AC1CC}"/>
               </a:ext>
             </a:extLst>
           </p:cNvPr>
@@ -21958,7 +22156,7 @@
           <p:cNvPr id="14" name="text">
             <a:extLst xmlns:a="http://schemas.openxmlformats.org/drawingml/2006/main">
               <a:ext uri="{FF2B5EF4-FFF2-40B4-BE49-F238E27FC236}">
-                <a16:creationId xmlns:a16="http://schemas.microsoft.com/office/drawing/2014/main" id="{39F9037D-D40E-4C50-8F94-F86EC9A807D4}"/>
+                <a16:creationId xmlns:a16="http://schemas.microsoft.com/office/drawing/2014/main" id="{F2ED57E9-E822-46DC-AC56-9E421ADFBA1E}"/>
               </a:ext>
             </a:extLst>
           </p:cNvPr>
@@ -22015,7 +22213,7 @@
           <p:cNvPr id="15" name="text">
             <a:extLst xmlns:a="http://schemas.openxmlformats.org/drawingml/2006/main">
               <a:ext uri="{FF2B5EF4-FFF2-40B4-BE49-F238E27FC236}">
-                <a16:creationId xmlns:a16="http://schemas.microsoft.com/office/drawing/2014/main" id="{A6572F4D-0C2F-4240-8C9B-7CB7ACDC19A7}"/>
+                <a16:creationId xmlns:a16="http://schemas.microsoft.com/office/drawing/2014/main" id="{9700C2F6-D237-4D0A-BDF7-9CD1092B03CB}"/>
               </a:ext>
             </a:extLst>
           </p:cNvPr>
@@ -22072,7 +22270,7 @@
           <p:cNvPr id="16" name="text">
             <a:extLst xmlns:a="http://schemas.openxmlformats.org/drawingml/2006/main">
               <a:ext uri="{FF2B5EF4-FFF2-40B4-BE49-F238E27FC236}">
-                <a16:creationId xmlns:a16="http://schemas.microsoft.com/office/drawing/2014/main" id="{0929C2AC-8417-4032-9650-D1EBFB1AC06F}"/>
+                <a16:creationId xmlns:a16="http://schemas.microsoft.com/office/drawing/2014/main" id="{4A4E38EE-4060-4D32-9B10-489EE7C1AEC5}"/>
               </a:ext>
             </a:extLst>
           </p:cNvPr>
@@ -22129,7 +22327,7 @@
           <p:cNvPr id="17" name="text">
             <a:extLst xmlns:a="http://schemas.openxmlformats.org/drawingml/2006/main">
               <a:ext uri="{FF2B5EF4-FFF2-40B4-BE49-F238E27FC236}">
-                <a16:creationId xmlns:a16="http://schemas.microsoft.com/office/drawing/2014/main" id="{6E36A010-2F0E-4F7F-A62D-3428DDF2BADB}"/>
+                <a16:creationId xmlns:a16="http://schemas.microsoft.com/office/drawing/2014/main" id="{1BE58C5B-4901-4A6C-AB8E-A5D4B9751AAA}"/>
               </a:ext>
             </a:extLst>
           </p:cNvPr>
@@ -22186,7 +22384,7 @@
           <p:cNvPr id="18" name="text">
             <a:extLst xmlns:a="http://schemas.openxmlformats.org/drawingml/2006/main">
               <a:ext uri="{FF2B5EF4-FFF2-40B4-BE49-F238E27FC236}">
-                <a16:creationId xmlns:a16="http://schemas.microsoft.com/office/drawing/2014/main" id="{5A297C2C-331E-43D2-858F-0701B7D2A8E4}"/>
+                <a16:creationId xmlns:a16="http://schemas.microsoft.com/office/drawing/2014/main" id="{2EE52165-94BD-4EEC-A97E-0B22CFF2B76F}"/>
               </a:ext>
             </a:extLst>
           </p:cNvPr>
@@ -22243,7 +22441,7 @@
           <p:cNvPr id="19" name="Slide number">
             <a:extLst xmlns:a="http://schemas.openxmlformats.org/drawingml/2006/main">
               <a:ext uri="{FF2B5EF4-FFF2-40B4-BE49-F238E27FC236}">
-                <a16:creationId xmlns:a16="http://schemas.microsoft.com/office/drawing/2014/main" id="{28685518-BD1D-4E7B-898B-455B4982C313}"/>
+                <a16:creationId xmlns:a16="http://schemas.microsoft.com/office/drawing/2014/main" id="{4AC19AA1-2407-4B27-8FB5-754E4CF97087}"/>
               </a:ext>
             </a:extLst>
           </p:cNvPr>
@@ -22298,7 +22496,7 @@
     </p:spTree>
     <p:extLst>
       <p:ext uri="{BB962C8B-B14F-4D97-AF65-F5344CB8AC3E}">
-        <p14:creationId xmlns:p14="http://schemas.microsoft.com/office/powerpoint/2010/main" val="596481213"/>
+        <p14:creationId xmlns:p14="http://schemas.microsoft.com/office/powerpoint/2010/main" val="1181725275"/>
       </p:ext>
     </p:extLst>
   </p:cSld>

</xml_diff>

<commit_message>
Point final talk slide QR to the short contact URL
</commit_message>
<xml_diff>
--- a/resources/talks/beyond-the-qa-bottleneck.pptx
+++ b/resources/talks/beyond-the-qa-bottleneck.pptx
@@ -2,44 +2,44 @@
 <file path=ppt/presentation.xml><?xml version="1.0" encoding="utf-8"?>
 <p:presentation xmlns:p="http://schemas.openxmlformats.org/presentationml/2006/main">
   <p:sldMasterIdLst>
-    <p:sldMasterId xmlns:r="http://schemas.openxmlformats.org/officeDocument/2006/relationships" id="2147483648" r:id="R724fad4136eb49b9"/>
+    <p:sldMasterId xmlns:r="http://schemas.openxmlformats.org/officeDocument/2006/relationships" id="2147483648" r:id="Rf3bb899abc8e4010"/>
   </p:sldMasterIdLst>
   <p:notesMasterIdLst>
-    <p:notesMasterId xmlns:r="http://schemas.openxmlformats.org/officeDocument/2006/relationships" r:id="Rf6cbdd3258ae450e"/>
+    <p:notesMasterId xmlns:r="http://schemas.openxmlformats.org/officeDocument/2006/relationships" r:id="R227f3259a8384314"/>
   </p:notesMasterIdLst>
   <p:sldIdLst>
-    <p:sldId xmlns:r="http://schemas.openxmlformats.org/officeDocument/2006/relationships" id="256" r:id="R258ca32e915e4eb4"/>
-    <p:sldId xmlns:r="http://schemas.openxmlformats.org/officeDocument/2006/relationships" id="257" r:id="R397d907a106c4405"/>
-    <p:sldId xmlns:r="http://schemas.openxmlformats.org/officeDocument/2006/relationships" id="258" r:id="Ra621ff7fbdfe4ed6"/>
-    <p:sldId xmlns:r="http://schemas.openxmlformats.org/officeDocument/2006/relationships" id="259" r:id="Rc096beb805194c4e"/>
-    <p:sldId xmlns:r="http://schemas.openxmlformats.org/officeDocument/2006/relationships" id="260" r:id="Ra592c6cf1521470d"/>
-    <p:sldId xmlns:r="http://schemas.openxmlformats.org/officeDocument/2006/relationships" id="261" r:id="Ra6efb85d75ff4ac2"/>
-    <p:sldId xmlns:r="http://schemas.openxmlformats.org/officeDocument/2006/relationships" id="262" r:id="Rd8d388fc87c1472b"/>
-    <p:sldId xmlns:r="http://schemas.openxmlformats.org/officeDocument/2006/relationships" id="263" r:id="R4cb7afad5127477e"/>
-    <p:sldId xmlns:r="http://schemas.openxmlformats.org/officeDocument/2006/relationships" id="264" r:id="R983ef58bfd484c56"/>
-    <p:sldId xmlns:r="http://schemas.openxmlformats.org/officeDocument/2006/relationships" id="265" r:id="R40f62009a9f0414b"/>
-    <p:sldId xmlns:r="http://schemas.openxmlformats.org/officeDocument/2006/relationships" id="266" r:id="R1916cd2aed594e3c"/>
-    <p:sldId xmlns:r="http://schemas.openxmlformats.org/officeDocument/2006/relationships" id="267" r:id="Re1e176cf45a748b6"/>
-    <p:sldId xmlns:r="http://schemas.openxmlformats.org/officeDocument/2006/relationships" id="268" r:id="Rfe371b7b7a134a93"/>
-    <p:sldId xmlns:r="http://schemas.openxmlformats.org/officeDocument/2006/relationships" id="269" r:id="R4d5b43d1b2bb4722"/>
-    <p:sldId xmlns:r="http://schemas.openxmlformats.org/officeDocument/2006/relationships" id="270" r:id="Raa9f1cc7b6874f56"/>
-    <p:sldId xmlns:r="http://schemas.openxmlformats.org/officeDocument/2006/relationships" id="271" r:id="Ref618978a2ad459f"/>
-    <p:sldId xmlns:r="http://schemas.openxmlformats.org/officeDocument/2006/relationships" id="272" r:id="R49e420575356445a"/>
-    <p:sldId xmlns:r="http://schemas.openxmlformats.org/officeDocument/2006/relationships" id="273" r:id="R6c39d34a01834aa8"/>
-    <p:sldId xmlns:r="http://schemas.openxmlformats.org/officeDocument/2006/relationships" id="274" r:id="Re734c665095a4464"/>
-    <p:sldId xmlns:r="http://schemas.openxmlformats.org/officeDocument/2006/relationships" id="275" r:id="R6c9350e64dc34e24"/>
-    <p:sldId xmlns:r="http://schemas.openxmlformats.org/officeDocument/2006/relationships" id="276" r:id="R1085c8e73ace4825"/>
-    <p:sldId xmlns:r="http://schemas.openxmlformats.org/officeDocument/2006/relationships" id="277" r:id="R66641f7e7a3d4849"/>
-    <p:sldId xmlns:r="http://schemas.openxmlformats.org/officeDocument/2006/relationships" id="278" r:id="R35abdc4a6e154efb"/>
-    <p:sldId xmlns:r="http://schemas.openxmlformats.org/officeDocument/2006/relationships" id="279" r:id="R1b93426069f04ebb"/>
-    <p:sldId xmlns:r="http://schemas.openxmlformats.org/officeDocument/2006/relationships" id="280" r:id="R6c0db11951df4833"/>
-    <p:sldId xmlns:r="http://schemas.openxmlformats.org/officeDocument/2006/relationships" id="281" r:id="R86734a5ad46e427a"/>
-    <p:sldId xmlns:r="http://schemas.openxmlformats.org/officeDocument/2006/relationships" id="282" r:id="Rdc7104b1429f4df7"/>
-    <p:sldId xmlns:r="http://schemas.openxmlformats.org/officeDocument/2006/relationships" id="283" r:id="R73755d312f3b452b"/>
-    <p:sldId xmlns:r="http://schemas.openxmlformats.org/officeDocument/2006/relationships" id="284" r:id="R92f0fab575014af5"/>
-    <p:sldId xmlns:r="http://schemas.openxmlformats.org/officeDocument/2006/relationships" id="285" r:id="Rb7e24c2bda4b4c54"/>
-    <p:sldId xmlns:r="http://schemas.openxmlformats.org/officeDocument/2006/relationships" id="286" r:id="Re20233323cf54d35"/>
-    <p:sldId xmlns:r="http://schemas.openxmlformats.org/officeDocument/2006/relationships" id="287" r:id="Rb8a4d23628614597"/>
+    <p:sldId xmlns:r="http://schemas.openxmlformats.org/officeDocument/2006/relationships" id="256" r:id="R816a18b2a8ef420e"/>
+    <p:sldId xmlns:r="http://schemas.openxmlformats.org/officeDocument/2006/relationships" id="257" r:id="R4627c973be3641f2"/>
+    <p:sldId xmlns:r="http://schemas.openxmlformats.org/officeDocument/2006/relationships" id="258" r:id="Re2697793b52a4f17"/>
+    <p:sldId xmlns:r="http://schemas.openxmlformats.org/officeDocument/2006/relationships" id="259" r:id="R2246054b89eb4f1f"/>
+    <p:sldId xmlns:r="http://schemas.openxmlformats.org/officeDocument/2006/relationships" id="260" r:id="R14156d25f93243dc"/>
+    <p:sldId xmlns:r="http://schemas.openxmlformats.org/officeDocument/2006/relationships" id="261" r:id="R23402588663b4da2"/>
+    <p:sldId xmlns:r="http://schemas.openxmlformats.org/officeDocument/2006/relationships" id="262" r:id="R5e4d8f9a05d54aee"/>
+    <p:sldId xmlns:r="http://schemas.openxmlformats.org/officeDocument/2006/relationships" id="263" r:id="R4b4c1cea41fb4f87"/>
+    <p:sldId xmlns:r="http://schemas.openxmlformats.org/officeDocument/2006/relationships" id="264" r:id="R610a49b97e38457e"/>
+    <p:sldId xmlns:r="http://schemas.openxmlformats.org/officeDocument/2006/relationships" id="265" r:id="R38ccbba758594066"/>
+    <p:sldId xmlns:r="http://schemas.openxmlformats.org/officeDocument/2006/relationships" id="266" r:id="R75427144e0b34f57"/>
+    <p:sldId xmlns:r="http://schemas.openxmlformats.org/officeDocument/2006/relationships" id="267" r:id="R40a72fecc3914e6d"/>
+    <p:sldId xmlns:r="http://schemas.openxmlformats.org/officeDocument/2006/relationships" id="268" r:id="R505ccdf6fc1940a9"/>
+    <p:sldId xmlns:r="http://schemas.openxmlformats.org/officeDocument/2006/relationships" id="269" r:id="R95c370205b154ced"/>
+    <p:sldId xmlns:r="http://schemas.openxmlformats.org/officeDocument/2006/relationships" id="270" r:id="Rc954d9bf3a0346f6"/>
+    <p:sldId xmlns:r="http://schemas.openxmlformats.org/officeDocument/2006/relationships" id="271" r:id="R21ecaf65f6264fb5"/>
+    <p:sldId xmlns:r="http://schemas.openxmlformats.org/officeDocument/2006/relationships" id="272" r:id="R9ed237b90da74532"/>
+    <p:sldId xmlns:r="http://schemas.openxmlformats.org/officeDocument/2006/relationships" id="273" r:id="R48aa6cad3b6e4ee3"/>
+    <p:sldId xmlns:r="http://schemas.openxmlformats.org/officeDocument/2006/relationships" id="274" r:id="Rf700d5df1c8e4152"/>
+    <p:sldId xmlns:r="http://schemas.openxmlformats.org/officeDocument/2006/relationships" id="275" r:id="Reff11af91d2d4584"/>
+    <p:sldId xmlns:r="http://schemas.openxmlformats.org/officeDocument/2006/relationships" id="276" r:id="R701466577b5c4b70"/>
+    <p:sldId xmlns:r="http://schemas.openxmlformats.org/officeDocument/2006/relationships" id="277" r:id="Ra12db1a7e5204f9f"/>
+    <p:sldId xmlns:r="http://schemas.openxmlformats.org/officeDocument/2006/relationships" id="278" r:id="Rad10435470984e11"/>
+    <p:sldId xmlns:r="http://schemas.openxmlformats.org/officeDocument/2006/relationships" id="279" r:id="Rd292dd5ea1224c8f"/>
+    <p:sldId xmlns:r="http://schemas.openxmlformats.org/officeDocument/2006/relationships" id="280" r:id="R563784c825074a78"/>
+    <p:sldId xmlns:r="http://schemas.openxmlformats.org/officeDocument/2006/relationships" id="281" r:id="R811825cc06384b77"/>
+    <p:sldId xmlns:r="http://schemas.openxmlformats.org/officeDocument/2006/relationships" id="282" r:id="R152034ed041d4651"/>
+    <p:sldId xmlns:r="http://schemas.openxmlformats.org/officeDocument/2006/relationships" id="283" r:id="Ra3b0d43e62af4d08"/>
+    <p:sldId xmlns:r="http://schemas.openxmlformats.org/officeDocument/2006/relationships" id="284" r:id="Rc99208a0598c4bc9"/>
+    <p:sldId xmlns:r="http://schemas.openxmlformats.org/officeDocument/2006/relationships" id="285" r:id="R36082f60f7e543d1"/>
+    <p:sldId xmlns:r="http://schemas.openxmlformats.org/officeDocument/2006/relationships" id="286" r:id="R2804e27998f14843"/>
+    <p:sldId xmlns:r="http://schemas.openxmlformats.org/officeDocument/2006/relationships" id="287" r:id="Rc62c30391c444cfe"/>
   </p:sldIdLst>
   <p:sldSz cx="12192000" cy="6858000"/>
   <p:notesSz cx="6858000" cy="9144000"/>
@@ -3291,7 +3291,7 @@
   </p:cSld>
   <p:clrMap bg1="lt1" tx1="dk1" bg2="lt2" tx2="dk2" accent1="accent1" accent2="accent2" accent3="accent3" accent4="accent4" accent5="accent5" accent6="accent6" hlink="hlink" folHlink="folHlink"/>
   <p:sldLayoutIdLst>
-    <p:sldLayoutId xmlns:r="http://schemas.openxmlformats.org/officeDocument/2006/relationships" id="2147483649" r:id="R834091f62b414adf"/>
+    <p:sldLayoutId xmlns:r="http://schemas.openxmlformats.org/officeDocument/2006/relationships" id="2147483649" r:id="R57f63230b41c4a34"/>
   </p:sldLayoutIdLst>
   <p:txStyles>
     <p:titleStyle>
@@ -5464,7 +5464,7 @@
           <p:nvPr/>
         </p:nvPicPr>
         <p:blipFill>
-          <a:blip xmlns:r="http://schemas.openxmlformats.org/officeDocument/2006/relationships" xmlns:a="http://schemas.openxmlformats.org/drawingml/2006/main" r:embed="Reb8bcd32546f4831"/>
+          <a:blip xmlns:r="http://schemas.openxmlformats.org/officeDocument/2006/relationships" xmlns:a="http://schemas.openxmlformats.org/drawingml/2006/main" r:embed="R23af55394d554092"/>
           <a:stretch xmlns:a="http://schemas.openxmlformats.org/drawingml/2006/main"/>
         </p:blipFill>
         <p:spPr>
@@ -5482,7 +5482,7 @@
           <p:cNvPr id="2" name="Deck title">
             <a:extLst xmlns:a="http://schemas.openxmlformats.org/drawingml/2006/main">
               <a:ext uri="{FF2B5EF4-FFF2-40B4-BE49-F238E27FC236}">
-                <a16:creationId xmlns:a16="http://schemas.microsoft.com/office/drawing/2014/main" id="{8BF84378-BFAE-4A52-BACF-782A78058363}"/>
+                <a16:creationId xmlns:a16="http://schemas.microsoft.com/office/drawing/2014/main" id="{82A3A3E2-B2A0-49BB-A851-CE2C8DAEB258}"/>
               </a:ext>
             </a:extLst>
           </p:cNvPr>
@@ -5562,7 +5562,7 @@
           <p:cNvPr id="3" name="text">
             <a:extLst xmlns:a="http://schemas.openxmlformats.org/drawingml/2006/main">
               <a:ext uri="{FF2B5EF4-FFF2-40B4-BE49-F238E27FC236}">
-                <a16:creationId xmlns:a16="http://schemas.microsoft.com/office/drawing/2014/main" id="{028F46F9-2339-44D8-A620-A654A01CFC76}"/>
+                <a16:creationId xmlns:a16="http://schemas.microsoft.com/office/drawing/2014/main" id="{A7EEA416-A42A-4017-B3F4-D435AE282B2F}"/>
               </a:ext>
             </a:extLst>
           </p:cNvPr>
@@ -5623,7 +5623,7 @@
           <p:nvPr/>
         </p:nvPicPr>
         <p:blipFill>
-          <a:blip xmlns:r="http://schemas.openxmlformats.org/officeDocument/2006/relationships" xmlns:a="http://schemas.openxmlformats.org/drawingml/2006/main" r:embed="R2a6ebbf0f606427c"/>
+          <a:blip xmlns:r="http://schemas.openxmlformats.org/officeDocument/2006/relationships" xmlns:a="http://schemas.openxmlformats.org/drawingml/2006/main" r:embed="R10b2a2c64f784bc5"/>
           <a:srcRect xmlns:a="http://schemas.openxmlformats.org/drawingml/2006/main" l="0" t="0" r="0" b="0"/>
           <a:stretch xmlns:a="http://schemas.openxmlformats.org/drawingml/2006/main">
             <a:fillRect l="0" t="0" r="0" b="0"/>
@@ -5644,7 +5644,7 @@
           <p:cNvPr id="5" name="Speaker">
             <a:extLst xmlns:a="http://schemas.openxmlformats.org/drawingml/2006/main">
               <a:ext uri="{FF2B5EF4-FFF2-40B4-BE49-F238E27FC236}">
-                <a16:creationId xmlns:a16="http://schemas.microsoft.com/office/drawing/2014/main" id="{D2396FD6-FACB-47D6-B7DC-3B71B962008E}"/>
+                <a16:creationId xmlns:a16="http://schemas.microsoft.com/office/drawing/2014/main" id="{EB4704C4-8352-4881-8651-81691A416BF5}"/>
               </a:ext>
             </a:extLst>
           </p:cNvPr>
@@ -5701,7 +5701,7 @@
           <p:cNvPr id="6" name="text">
             <a:extLst xmlns:a="http://schemas.openxmlformats.org/drawingml/2006/main">
               <a:ext uri="{FF2B5EF4-FFF2-40B4-BE49-F238E27FC236}">
-                <a16:creationId xmlns:a16="http://schemas.microsoft.com/office/drawing/2014/main" id="{7924DC62-DF76-494B-89D4-68CE3C64FA2B}"/>
+                <a16:creationId xmlns:a16="http://schemas.microsoft.com/office/drawing/2014/main" id="{B29156FE-C716-47B1-B6A5-A37252D28CF1}"/>
               </a:ext>
             </a:extLst>
           </p:cNvPr>
@@ -5758,7 +5758,7 @@
           <p:cNvPr id="7" name="text">
             <a:extLst xmlns:a="http://schemas.openxmlformats.org/drawingml/2006/main">
               <a:ext uri="{FF2B5EF4-FFF2-40B4-BE49-F238E27FC236}">
-                <a16:creationId xmlns:a16="http://schemas.microsoft.com/office/drawing/2014/main" id="{DB2FFA60-2949-425F-A1CC-2092B66DC5AF}"/>
+                <a16:creationId xmlns:a16="http://schemas.microsoft.com/office/drawing/2014/main" id="{63DAB90D-B662-47DC-A81A-1F0836025D97}"/>
               </a:ext>
             </a:extLst>
           </p:cNvPr>
@@ -5813,7 +5813,7 @@
     </p:spTree>
     <p:extLst>
       <p:ext uri="{BB962C8B-B14F-4D97-AF65-F5344CB8AC3E}">
-        <p14:creationId xmlns:p14="http://schemas.microsoft.com/office/powerpoint/2010/main" val="1882413052"/>
+        <p14:creationId xmlns:p14="http://schemas.microsoft.com/office/powerpoint/2010/main" val="1975246968"/>
       </p:ext>
     </p:extLst>
   </p:cSld>
@@ -5844,7 +5844,7 @@
           <p:cNvPr id="10" name="Title">
             <a:extLst xmlns:a="http://schemas.openxmlformats.org/drawingml/2006/main">
               <a:ext uri="{FF2B5EF4-FFF2-40B4-BE49-F238E27FC236}">
-                <a16:creationId xmlns:a16="http://schemas.microsoft.com/office/drawing/2014/main" id="{2EC7A33B-B62E-4DE2-9BF3-1E9418A7426D}"/>
+                <a16:creationId xmlns:a16="http://schemas.microsoft.com/office/drawing/2014/main" id="{8417F8DB-A507-4268-9D95-3752E57D4FAD}"/>
               </a:ext>
             </a:extLst>
           </p:cNvPr>
@@ -5901,7 +5901,7 @@
           <p:cNvPr id="2" name="text">
             <a:extLst xmlns:a="http://schemas.openxmlformats.org/drawingml/2006/main">
               <a:ext uri="{FF2B5EF4-FFF2-40B4-BE49-F238E27FC236}">
-                <a16:creationId xmlns:a16="http://schemas.microsoft.com/office/drawing/2014/main" id="{240DA354-D08D-4EF2-AFFE-A63B92723102}"/>
+                <a16:creationId xmlns:a16="http://schemas.microsoft.com/office/drawing/2014/main" id="{DF475E6C-FCD6-4FC0-8A41-AE13FB1D168F}"/>
               </a:ext>
             </a:extLst>
           </p:cNvPr>
@@ -5958,7 +5958,7 @@
           <p:cNvPr id="3" name="text">
             <a:extLst xmlns:a="http://schemas.openxmlformats.org/drawingml/2006/main">
               <a:ext uri="{FF2B5EF4-FFF2-40B4-BE49-F238E27FC236}">
-                <a16:creationId xmlns:a16="http://schemas.microsoft.com/office/drawing/2014/main" id="{E8415725-98C3-4184-A6C2-A256C6716464}"/>
+                <a16:creationId xmlns:a16="http://schemas.microsoft.com/office/drawing/2014/main" id="{46CA04FB-AB34-46ED-AC7E-0DFEFD113094}"/>
               </a:ext>
             </a:extLst>
           </p:cNvPr>
@@ -6015,7 +6015,7 @@
           <p:cNvPr id="4" name="text">
             <a:extLst xmlns:a="http://schemas.openxmlformats.org/drawingml/2006/main">
               <a:ext uri="{FF2B5EF4-FFF2-40B4-BE49-F238E27FC236}">
-                <a16:creationId xmlns:a16="http://schemas.microsoft.com/office/drawing/2014/main" id="{AB8A174F-FC57-429C-BA40-8F6314B26A8C}"/>
+                <a16:creationId xmlns:a16="http://schemas.microsoft.com/office/drawing/2014/main" id="{36A6D40C-1202-461E-90DC-CB9E29A29623}"/>
               </a:ext>
             </a:extLst>
           </p:cNvPr>
@@ -6072,7 +6072,7 @@
           <p:cNvPr id="5" name="text">
             <a:extLst xmlns:a="http://schemas.openxmlformats.org/drawingml/2006/main">
               <a:ext uri="{FF2B5EF4-FFF2-40B4-BE49-F238E27FC236}">
-                <a16:creationId xmlns:a16="http://schemas.microsoft.com/office/drawing/2014/main" id="{5295A0C6-A055-4006-84C4-02A10E90B3DE}"/>
+                <a16:creationId xmlns:a16="http://schemas.microsoft.com/office/drawing/2014/main" id="{E7A27779-A7E9-47E0-8668-4D4BE3C5670F}"/>
               </a:ext>
             </a:extLst>
           </p:cNvPr>
@@ -6129,7 +6129,7 @@
           <p:cNvPr id="6" name="text">
             <a:extLst xmlns:a="http://schemas.openxmlformats.org/drawingml/2006/main">
               <a:ext uri="{FF2B5EF4-FFF2-40B4-BE49-F238E27FC236}">
-                <a16:creationId xmlns:a16="http://schemas.microsoft.com/office/drawing/2014/main" id="{5A636143-3673-44F6-8D6E-B37950734851}"/>
+                <a16:creationId xmlns:a16="http://schemas.microsoft.com/office/drawing/2014/main" id="{6C1408D3-2531-4547-A349-AADFA7EEDBAF}"/>
               </a:ext>
             </a:extLst>
           </p:cNvPr>
@@ -6186,7 +6186,7 @@
           <p:cNvPr id="7" name="text">
             <a:extLst xmlns:a="http://schemas.openxmlformats.org/drawingml/2006/main">
               <a:ext uri="{FF2B5EF4-FFF2-40B4-BE49-F238E27FC236}">
-                <a16:creationId xmlns:a16="http://schemas.microsoft.com/office/drawing/2014/main" id="{7B5A87E6-2454-4F12-8969-3DF2E82F3037}"/>
+                <a16:creationId xmlns:a16="http://schemas.microsoft.com/office/drawing/2014/main" id="{507B4298-4C72-4C99-A3B0-A1A4FCF73856}"/>
               </a:ext>
             </a:extLst>
           </p:cNvPr>
@@ -6243,7 +6243,7 @@
           <p:cNvPr id="8" name="text">
             <a:extLst xmlns:a="http://schemas.openxmlformats.org/drawingml/2006/main">
               <a:ext uri="{FF2B5EF4-FFF2-40B4-BE49-F238E27FC236}">
-                <a16:creationId xmlns:a16="http://schemas.microsoft.com/office/drawing/2014/main" id="{C4F94EA5-232E-4C77-B18F-F956D4EB53D5}"/>
+                <a16:creationId xmlns:a16="http://schemas.microsoft.com/office/drawing/2014/main" id="{794C7883-A16F-4DF0-A809-74A4E77F0014}"/>
               </a:ext>
             </a:extLst>
           </p:cNvPr>
@@ -6300,7 +6300,7 @@
           <p:cNvPr id="9" name="Slide number">
             <a:extLst xmlns:a="http://schemas.openxmlformats.org/drawingml/2006/main">
               <a:ext uri="{FF2B5EF4-FFF2-40B4-BE49-F238E27FC236}">
-                <a16:creationId xmlns:a16="http://schemas.microsoft.com/office/drawing/2014/main" id="{B83A0B54-B163-4095-A2C4-96371CB4B53B}"/>
+                <a16:creationId xmlns:a16="http://schemas.microsoft.com/office/drawing/2014/main" id="{29B7FCAF-CF73-4F55-80B4-94E63E526A87}"/>
               </a:ext>
             </a:extLst>
           </p:cNvPr>
@@ -6355,7 +6355,7 @@
     </p:spTree>
     <p:extLst>
       <p:ext uri="{BB962C8B-B14F-4D97-AF65-F5344CB8AC3E}">
-        <p14:creationId xmlns:p14="http://schemas.microsoft.com/office/powerpoint/2010/main" val="92756918"/>
+        <p14:creationId xmlns:p14="http://schemas.microsoft.com/office/powerpoint/2010/main" val="139087634"/>
       </p:ext>
     </p:extLst>
   </p:cSld>
@@ -6386,7 +6386,7 @@
           <p:cNvPr id="11" name="Completed section 0">
             <a:extLst xmlns:a="http://schemas.openxmlformats.org/drawingml/2006/main">
               <a:ext uri="{FF2B5EF4-FFF2-40B4-BE49-F238E27FC236}">
-                <a16:creationId xmlns:a16="http://schemas.microsoft.com/office/drawing/2014/main" id="{1C16225C-E27A-44BB-AD09-80B950A94B73}"/>
+                <a16:creationId xmlns:a16="http://schemas.microsoft.com/office/drawing/2014/main" id="{414BAE52-0E22-4964-8BAF-F698480D1E8D}"/>
               </a:ext>
             </a:extLst>
           </p:cNvPr>
@@ -6443,7 +6443,7 @@
           <p:cNvPr id="2" name="Section description 0">
             <a:extLst xmlns:a="http://schemas.openxmlformats.org/drawingml/2006/main">
               <a:ext uri="{FF2B5EF4-FFF2-40B4-BE49-F238E27FC236}">
-                <a16:creationId xmlns:a16="http://schemas.microsoft.com/office/drawing/2014/main" id="{1C5DCCF8-7850-4684-91F2-E5EA37BEC40F}"/>
+                <a16:creationId xmlns:a16="http://schemas.microsoft.com/office/drawing/2014/main" id="{1E4335DA-490E-4F2E-A5DB-5ED4514B9DD5}"/>
               </a:ext>
             </a:extLst>
           </p:cNvPr>
@@ -6500,7 +6500,7 @@
           <p:cNvPr id="3" name="Active section">
             <a:extLst xmlns:a="http://schemas.openxmlformats.org/drawingml/2006/main">
               <a:ext uri="{FF2B5EF4-FFF2-40B4-BE49-F238E27FC236}">
-                <a16:creationId xmlns:a16="http://schemas.microsoft.com/office/drawing/2014/main" id="{78E51BF0-3E4D-4D3B-B9BC-A98108F7C54E}"/>
+                <a16:creationId xmlns:a16="http://schemas.microsoft.com/office/drawing/2014/main" id="{4CDB8BE5-A643-4925-B120-B154BAEF400F}"/>
               </a:ext>
             </a:extLst>
           </p:cNvPr>
@@ -6557,7 +6557,7 @@
           <p:cNvPr id="4" name="Section description 1">
             <a:extLst xmlns:a="http://schemas.openxmlformats.org/drawingml/2006/main">
               <a:ext uri="{FF2B5EF4-FFF2-40B4-BE49-F238E27FC236}">
-                <a16:creationId xmlns:a16="http://schemas.microsoft.com/office/drawing/2014/main" id="{B0359905-C049-4B8F-9D20-43EB745C0CDC}"/>
+                <a16:creationId xmlns:a16="http://schemas.microsoft.com/office/drawing/2014/main" id="{E238DD8B-9E17-477F-A970-7EA0E530F35A}"/>
               </a:ext>
             </a:extLst>
           </p:cNvPr>
@@ -6618,7 +6618,7 @@
           <p:nvPr/>
         </p:nvPicPr>
         <p:blipFill>
-          <a:blip xmlns:r="http://schemas.openxmlformats.org/officeDocument/2006/relationships" xmlns:a="http://schemas.openxmlformats.org/drawingml/2006/main" r:embed="Ra203104bb57442b0"/>
+          <a:blip xmlns:r="http://schemas.openxmlformats.org/officeDocument/2006/relationships" xmlns:a="http://schemas.openxmlformats.org/drawingml/2006/main" r:embed="R16c5c02f70cb4b7c"/>
           <a:stretch xmlns:a="http://schemas.openxmlformats.org/drawingml/2006/main"/>
         </p:blipFill>
         <p:spPr>
@@ -6640,7 +6640,7 @@
           <p:nvPr/>
         </p:nvPicPr>
         <p:blipFill>
-          <a:blip xmlns:r="http://schemas.openxmlformats.org/officeDocument/2006/relationships" xmlns:a="http://schemas.openxmlformats.org/drawingml/2006/main" r:embed="R36e3c397d1ff4453"/>
+          <a:blip xmlns:r="http://schemas.openxmlformats.org/officeDocument/2006/relationships" xmlns:a="http://schemas.openxmlformats.org/drawingml/2006/main" r:embed="Rf541919a59cd42ea"/>
           <a:stretch xmlns:a="http://schemas.openxmlformats.org/drawingml/2006/main"/>
         </p:blipFill>
         <p:spPr>
@@ -6662,7 +6662,7 @@
           <p:nvPr/>
         </p:nvPicPr>
         <p:blipFill>
-          <a:blip xmlns:r="http://schemas.openxmlformats.org/officeDocument/2006/relationships" xmlns:a="http://schemas.openxmlformats.org/drawingml/2006/main" r:embed="R650ab03a67144073"/>
+          <a:blip xmlns:r="http://schemas.openxmlformats.org/officeDocument/2006/relationships" xmlns:a="http://schemas.openxmlformats.org/drawingml/2006/main" r:embed="Rba960ad715914c71"/>
           <a:stretch xmlns:a="http://schemas.openxmlformats.org/drawingml/2006/main"/>
         </p:blipFill>
         <p:spPr>
@@ -6684,7 +6684,7 @@
           <p:nvPr/>
         </p:nvPicPr>
         <p:blipFill>
-          <a:blip xmlns:r="http://schemas.openxmlformats.org/officeDocument/2006/relationships" xmlns:a="http://schemas.openxmlformats.org/drawingml/2006/main" r:embed="R4130afa5b2d5428f"/>
+          <a:blip xmlns:r="http://schemas.openxmlformats.org/officeDocument/2006/relationships" xmlns:a="http://schemas.openxmlformats.org/drawingml/2006/main" r:embed="R84d277b8674a4410"/>
           <a:stretch xmlns:a="http://schemas.openxmlformats.org/drawingml/2006/main"/>
         </p:blipFill>
         <p:spPr>
@@ -6706,7 +6706,7 @@
           <p:nvPr/>
         </p:nvPicPr>
         <p:blipFill>
-          <a:blip xmlns:r="http://schemas.openxmlformats.org/officeDocument/2006/relationships" xmlns:a="http://schemas.openxmlformats.org/drawingml/2006/main" r:embed="R1f1dc894a036432e"/>
+          <a:blip xmlns:r="http://schemas.openxmlformats.org/officeDocument/2006/relationships" xmlns:a="http://schemas.openxmlformats.org/drawingml/2006/main" r:embed="Rdfca83019a824970"/>
           <a:stretch xmlns:a="http://schemas.openxmlformats.org/drawingml/2006/main"/>
         </p:blipFill>
         <p:spPr>
@@ -6724,7 +6724,7 @@
           <p:cNvPr id="10" name="Slide number">
             <a:extLst xmlns:a="http://schemas.openxmlformats.org/drawingml/2006/main">
               <a:ext uri="{FF2B5EF4-FFF2-40B4-BE49-F238E27FC236}">
-                <a16:creationId xmlns:a16="http://schemas.microsoft.com/office/drawing/2014/main" id="{F2EFB321-EFB2-47AC-BD7D-E7DA94DAAAA5}"/>
+                <a16:creationId xmlns:a16="http://schemas.microsoft.com/office/drawing/2014/main" id="{E782DB31-AD19-4C5C-9DD7-121EB8F5CA03}"/>
               </a:ext>
             </a:extLst>
           </p:cNvPr>
@@ -6779,7 +6779,7 @@
     </p:spTree>
     <p:extLst>
       <p:ext uri="{BB962C8B-B14F-4D97-AF65-F5344CB8AC3E}">
-        <p14:creationId xmlns:p14="http://schemas.microsoft.com/office/powerpoint/2010/main" val="1344742438"/>
+        <p14:creationId xmlns:p14="http://schemas.microsoft.com/office/powerpoint/2010/main" val="144007543"/>
       </p:ext>
     </p:extLst>
   </p:cSld>
@@ -6810,7 +6810,7 @@
           <p:cNvPr id="12" name="Title">
             <a:extLst xmlns:a="http://schemas.openxmlformats.org/drawingml/2006/main">
               <a:ext uri="{FF2B5EF4-FFF2-40B4-BE49-F238E27FC236}">
-                <a16:creationId xmlns:a16="http://schemas.microsoft.com/office/drawing/2014/main" id="{A1761A1B-5574-4831-80C3-4601DCF9C21F}"/>
+                <a16:creationId xmlns:a16="http://schemas.microsoft.com/office/drawing/2014/main" id="{D220C8C8-1236-4575-8C98-8F5972BB2726}"/>
               </a:ext>
             </a:extLst>
           </p:cNvPr>
@@ -6867,7 +6867,7 @@
           <p:cNvPr id="2" name="text">
             <a:extLst xmlns:a="http://schemas.openxmlformats.org/drawingml/2006/main">
               <a:ext uri="{FF2B5EF4-FFF2-40B4-BE49-F238E27FC236}">
-                <a16:creationId xmlns:a16="http://schemas.microsoft.com/office/drawing/2014/main" id="{025D1FFD-7EAD-455B-BE3F-5E0922428655}"/>
+                <a16:creationId xmlns:a16="http://schemas.microsoft.com/office/drawing/2014/main" id="{8D1331B1-BE70-4A49-B30F-EB146A334251}"/>
               </a:ext>
             </a:extLst>
           </p:cNvPr>
@@ -6924,7 +6924,7 @@
           <p:cNvPr id="3" name="text">
             <a:extLst xmlns:a="http://schemas.openxmlformats.org/drawingml/2006/main">
               <a:ext uri="{FF2B5EF4-FFF2-40B4-BE49-F238E27FC236}">
-                <a16:creationId xmlns:a16="http://schemas.microsoft.com/office/drawing/2014/main" id="{08FED0EC-B59B-4BDE-90BD-5E887002693C}"/>
+                <a16:creationId xmlns:a16="http://schemas.microsoft.com/office/drawing/2014/main" id="{664BA1AB-5849-4E13-A81A-42F357715AD4}"/>
               </a:ext>
             </a:extLst>
           </p:cNvPr>
@@ -6981,7 +6981,7 @@
           <p:cNvPr id="4" name="text">
             <a:extLst xmlns:a="http://schemas.openxmlformats.org/drawingml/2006/main">
               <a:ext uri="{FF2B5EF4-FFF2-40B4-BE49-F238E27FC236}">
-                <a16:creationId xmlns:a16="http://schemas.microsoft.com/office/drawing/2014/main" id="{C46D4565-692F-45F6-AA41-901E7A3B34ED}"/>
+                <a16:creationId xmlns:a16="http://schemas.microsoft.com/office/drawing/2014/main" id="{82D7BE61-122B-41ED-9D4B-0D9B469CD18D}"/>
               </a:ext>
             </a:extLst>
           </p:cNvPr>
@@ -7038,7 +7038,7 @@
           <p:cNvPr id="5" name="text">
             <a:extLst xmlns:a="http://schemas.openxmlformats.org/drawingml/2006/main">
               <a:ext uri="{FF2B5EF4-FFF2-40B4-BE49-F238E27FC236}">
-                <a16:creationId xmlns:a16="http://schemas.microsoft.com/office/drawing/2014/main" id="{AD9F0479-12A7-4528-BEE3-62315E9BAF87}"/>
+                <a16:creationId xmlns:a16="http://schemas.microsoft.com/office/drawing/2014/main" id="{AE11A309-8B47-46F3-B4DA-8B34E9A57FCD}"/>
               </a:ext>
             </a:extLst>
           </p:cNvPr>
@@ -7095,7 +7095,7 @@
           <p:cNvPr id="6" name="text">
             <a:extLst xmlns:a="http://schemas.openxmlformats.org/drawingml/2006/main">
               <a:ext uri="{FF2B5EF4-FFF2-40B4-BE49-F238E27FC236}">
-                <a16:creationId xmlns:a16="http://schemas.microsoft.com/office/drawing/2014/main" id="{328EB135-57CD-4919-922E-67981DEAA0C5}"/>
+                <a16:creationId xmlns:a16="http://schemas.microsoft.com/office/drawing/2014/main" id="{AE874895-D677-401A-A3C3-459804DDB428}"/>
               </a:ext>
             </a:extLst>
           </p:cNvPr>
@@ -7152,7 +7152,7 @@
           <p:cNvPr id="7" name="text">
             <a:extLst xmlns:a="http://schemas.openxmlformats.org/drawingml/2006/main">
               <a:ext uri="{FF2B5EF4-FFF2-40B4-BE49-F238E27FC236}">
-                <a16:creationId xmlns:a16="http://schemas.microsoft.com/office/drawing/2014/main" id="{9C4EAEA0-67B6-47ED-A5A4-4EE6A85BCC3C}"/>
+                <a16:creationId xmlns:a16="http://schemas.microsoft.com/office/drawing/2014/main" id="{773AEE9F-2BBA-4823-A261-54D47F45B6D0}"/>
               </a:ext>
             </a:extLst>
           </p:cNvPr>
@@ -7209,7 +7209,7 @@
           <p:cNvPr id="8" name="text">
             <a:extLst xmlns:a="http://schemas.openxmlformats.org/drawingml/2006/main">
               <a:ext uri="{FF2B5EF4-FFF2-40B4-BE49-F238E27FC236}">
-                <a16:creationId xmlns:a16="http://schemas.microsoft.com/office/drawing/2014/main" id="{A7F07C09-56B6-44D9-AF00-DF74F5165487}"/>
+                <a16:creationId xmlns:a16="http://schemas.microsoft.com/office/drawing/2014/main" id="{7B2803F2-1C21-4742-875C-2875ABA92585}"/>
               </a:ext>
             </a:extLst>
           </p:cNvPr>
@@ -7266,7 +7266,7 @@
           <p:cNvPr id="9" name="text">
             <a:extLst xmlns:a="http://schemas.openxmlformats.org/drawingml/2006/main">
               <a:ext uri="{FF2B5EF4-FFF2-40B4-BE49-F238E27FC236}">
-                <a16:creationId xmlns:a16="http://schemas.microsoft.com/office/drawing/2014/main" id="{DF98B727-3E2D-4AD0-87B2-02A257FE3CA1}"/>
+                <a16:creationId xmlns:a16="http://schemas.microsoft.com/office/drawing/2014/main" id="{D4CDC2C3-90AD-4367-AEF9-2E94AA07E2D8}"/>
               </a:ext>
             </a:extLst>
           </p:cNvPr>
@@ -7323,7 +7323,7 @@
           <p:cNvPr id="10" name="text">
             <a:extLst xmlns:a="http://schemas.openxmlformats.org/drawingml/2006/main">
               <a:ext uri="{FF2B5EF4-FFF2-40B4-BE49-F238E27FC236}">
-                <a16:creationId xmlns:a16="http://schemas.microsoft.com/office/drawing/2014/main" id="{DE8B1B16-433F-48B5-8301-C0F6D6AC2F14}"/>
+                <a16:creationId xmlns:a16="http://schemas.microsoft.com/office/drawing/2014/main" id="{B117D2F5-4BE0-4B1C-AE67-2EDC731DA2DE}"/>
               </a:ext>
             </a:extLst>
           </p:cNvPr>
@@ -7380,7 +7380,7 @@
           <p:cNvPr id="11" name="Slide number">
             <a:extLst xmlns:a="http://schemas.openxmlformats.org/drawingml/2006/main">
               <a:ext uri="{FF2B5EF4-FFF2-40B4-BE49-F238E27FC236}">
-                <a16:creationId xmlns:a16="http://schemas.microsoft.com/office/drawing/2014/main" id="{72221EA2-B898-490C-A503-8AD3CFB700BF}"/>
+                <a16:creationId xmlns:a16="http://schemas.microsoft.com/office/drawing/2014/main" id="{3CD05FAE-C572-4E13-80B6-4D731F61FF00}"/>
               </a:ext>
             </a:extLst>
           </p:cNvPr>
@@ -7435,7 +7435,7 @@
     </p:spTree>
     <p:extLst>
       <p:ext uri="{BB962C8B-B14F-4D97-AF65-F5344CB8AC3E}">
-        <p14:creationId xmlns:p14="http://schemas.microsoft.com/office/powerpoint/2010/main" val="664879587"/>
+        <p14:creationId xmlns:p14="http://schemas.microsoft.com/office/powerpoint/2010/main" val="1514826676"/>
       </p:ext>
     </p:extLst>
   </p:cSld>
@@ -7466,7 +7466,7 @@
           <p:cNvPr id="7" name="Title">
             <a:extLst xmlns:a="http://schemas.openxmlformats.org/drawingml/2006/main">
               <a:ext uri="{FF2B5EF4-FFF2-40B4-BE49-F238E27FC236}">
-                <a16:creationId xmlns:a16="http://schemas.microsoft.com/office/drawing/2014/main" id="{78D0C284-6007-458B-8EAF-8021A975C9A1}"/>
+                <a16:creationId xmlns:a16="http://schemas.microsoft.com/office/drawing/2014/main" id="{B8643C34-5242-43CC-9F51-265CA6CFAE40}"/>
               </a:ext>
             </a:extLst>
           </p:cNvPr>
@@ -7530,7 +7530,7 @@
         </p:xfrm>
         <a:graphic xmlns:a="http://schemas.openxmlformats.org/drawingml/2006/main">
           <a:graphicData uri="http://schemas.openxmlformats.org/drawingml/2006/chart">
-            <c:chart xmlns:r="http://schemas.openxmlformats.org/officeDocument/2006/relationships" xmlns:c="http://schemas.openxmlformats.org/drawingml/2006/chart" r:id="R40f12f99bf2b4184"/>
+            <c:chart xmlns:r="http://schemas.openxmlformats.org/officeDocument/2006/relationships" xmlns:c="http://schemas.openxmlformats.org/drawingml/2006/chart" r:id="R6665329d62554a87"/>
           </a:graphicData>
         </a:graphic>
       </p:graphicFrame>
@@ -7539,7 +7539,7 @@
           <p:cNvPr id="3" name="April month marker">
             <a:extLst xmlns:a="http://schemas.openxmlformats.org/drawingml/2006/main">
               <a:ext uri="{FF2B5EF4-FFF2-40B4-BE49-F238E27FC236}">
-                <a16:creationId xmlns:a16="http://schemas.microsoft.com/office/drawing/2014/main" id="{66FE8300-2ECF-4EA5-8C4C-B56D3B9F637D}"/>
+                <a16:creationId xmlns:a16="http://schemas.microsoft.com/office/drawing/2014/main" id="{78E1C7F9-69ED-4015-B7E9-881C3205BB46}"/>
               </a:ext>
             </a:extLst>
           </p:cNvPr>
@@ -7570,7 +7570,7 @@
           <p:cNvPr id="4" name="April joining context">
             <a:extLst xmlns:a="http://schemas.openxmlformats.org/drawingml/2006/main">
               <a:ext uri="{FF2B5EF4-FFF2-40B4-BE49-F238E27FC236}">
-                <a16:creationId xmlns:a16="http://schemas.microsoft.com/office/drawing/2014/main" id="{55390C04-1D39-4AD4-8066-D823A985D035}"/>
+                <a16:creationId xmlns:a16="http://schemas.microsoft.com/office/drawing/2014/main" id="{1A286B42-AF2A-43F9-A868-3756E99CCD92}"/>
               </a:ext>
             </a:extLst>
           </p:cNvPr>
@@ -7627,7 +7627,7 @@
           <p:cNvPr id="5" name="Methodology">
             <a:extLst xmlns:a="http://schemas.openxmlformats.org/drawingml/2006/main">
               <a:ext uri="{FF2B5EF4-FFF2-40B4-BE49-F238E27FC236}">
-                <a16:creationId xmlns:a16="http://schemas.microsoft.com/office/drawing/2014/main" id="{1F2B6659-8B9E-43E2-A86B-CBDCE363D5D1}"/>
+                <a16:creationId xmlns:a16="http://schemas.microsoft.com/office/drawing/2014/main" id="{59E98B96-DBA0-4C13-8E4D-D48990040F37}"/>
               </a:ext>
             </a:extLst>
           </p:cNvPr>
@@ -7684,7 +7684,7 @@
           <p:cNvPr id="6" name="Slide number">
             <a:extLst xmlns:a="http://schemas.openxmlformats.org/drawingml/2006/main">
               <a:ext uri="{FF2B5EF4-FFF2-40B4-BE49-F238E27FC236}">
-                <a16:creationId xmlns:a16="http://schemas.microsoft.com/office/drawing/2014/main" id="{BD4251FE-779D-4665-8F0D-457C382AB3AA}"/>
+                <a16:creationId xmlns:a16="http://schemas.microsoft.com/office/drawing/2014/main" id="{8B8F171D-04E4-4595-8EA1-FD3C1312D57E}"/>
               </a:ext>
             </a:extLst>
           </p:cNvPr>
@@ -7739,7 +7739,7 @@
     </p:spTree>
     <p:extLst>
       <p:ext uri="{BB962C8B-B14F-4D97-AF65-F5344CB8AC3E}">
-        <p14:creationId xmlns:p14="http://schemas.microsoft.com/office/powerpoint/2010/main" val="45583594"/>
+        <p14:creationId xmlns:p14="http://schemas.microsoft.com/office/powerpoint/2010/main" val="623779823"/>
       </p:ext>
     </p:extLst>
   </p:cSld>
@@ -7770,7 +7770,7 @@
           <p:cNvPr id="12" name="Completed section 0">
             <a:extLst xmlns:a="http://schemas.openxmlformats.org/drawingml/2006/main">
               <a:ext uri="{FF2B5EF4-FFF2-40B4-BE49-F238E27FC236}">
-                <a16:creationId xmlns:a16="http://schemas.microsoft.com/office/drawing/2014/main" id="{28D1C248-EF55-4380-A468-5A39E1CB52A5}"/>
+                <a16:creationId xmlns:a16="http://schemas.microsoft.com/office/drawing/2014/main" id="{E921C1F2-BE1C-474E-BE69-F9669057C0EA}"/>
               </a:ext>
             </a:extLst>
           </p:cNvPr>
@@ -7827,7 +7827,7 @@
           <p:cNvPr id="2" name="Section description 0">
             <a:extLst xmlns:a="http://schemas.openxmlformats.org/drawingml/2006/main">
               <a:ext uri="{FF2B5EF4-FFF2-40B4-BE49-F238E27FC236}">
-                <a16:creationId xmlns:a16="http://schemas.microsoft.com/office/drawing/2014/main" id="{F97F3961-560F-4969-A27F-AE32DFAE360E}"/>
+                <a16:creationId xmlns:a16="http://schemas.microsoft.com/office/drawing/2014/main" id="{77DB0398-4028-43AE-B759-06AF84DA054F}"/>
               </a:ext>
             </a:extLst>
           </p:cNvPr>
@@ -7884,7 +7884,7 @@
           <p:cNvPr id="3" name="Completed section 1">
             <a:extLst xmlns:a="http://schemas.openxmlformats.org/drawingml/2006/main">
               <a:ext uri="{FF2B5EF4-FFF2-40B4-BE49-F238E27FC236}">
-                <a16:creationId xmlns:a16="http://schemas.microsoft.com/office/drawing/2014/main" id="{B1E110D4-6B70-4F5D-9E0E-A5349EC5371E}"/>
+                <a16:creationId xmlns:a16="http://schemas.microsoft.com/office/drawing/2014/main" id="{67A03D94-4142-4E07-8AC2-261F1961D115}"/>
               </a:ext>
             </a:extLst>
           </p:cNvPr>
@@ -7941,7 +7941,7 @@
           <p:cNvPr id="4" name="Section description 1">
             <a:extLst xmlns:a="http://schemas.openxmlformats.org/drawingml/2006/main">
               <a:ext uri="{FF2B5EF4-FFF2-40B4-BE49-F238E27FC236}">
-                <a16:creationId xmlns:a16="http://schemas.microsoft.com/office/drawing/2014/main" id="{7A5B873E-7E0A-45BB-997E-41C437298AD6}"/>
+                <a16:creationId xmlns:a16="http://schemas.microsoft.com/office/drawing/2014/main" id="{81B2E4F2-16D3-4D10-B1CE-32FF1F167584}"/>
               </a:ext>
             </a:extLst>
           </p:cNvPr>
@@ -7998,7 +7998,7 @@
           <p:cNvPr id="5" name="Active section">
             <a:extLst xmlns:a="http://schemas.openxmlformats.org/drawingml/2006/main">
               <a:ext uri="{FF2B5EF4-FFF2-40B4-BE49-F238E27FC236}">
-                <a16:creationId xmlns:a16="http://schemas.microsoft.com/office/drawing/2014/main" id="{1180AF2C-6F59-48EA-B9BE-EC256751B56C}"/>
+                <a16:creationId xmlns:a16="http://schemas.microsoft.com/office/drawing/2014/main" id="{35A7CB20-67DE-42A3-81D5-CC6D3AE637B7}"/>
               </a:ext>
             </a:extLst>
           </p:cNvPr>
@@ -8055,7 +8055,7 @@
           <p:cNvPr id="6" name="Section description 2">
             <a:extLst xmlns:a="http://schemas.openxmlformats.org/drawingml/2006/main">
               <a:ext uri="{FF2B5EF4-FFF2-40B4-BE49-F238E27FC236}">
-                <a16:creationId xmlns:a16="http://schemas.microsoft.com/office/drawing/2014/main" id="{23A5C84D-574F-4802-87CD-1922BF21D0D9}"/>
+                <a16:creationId xmlns:a16="http://schemas.microsoft.com/office/drawing/2014/main" id="{A115FE66-D640-4190-819C-7DBC6C8CB5D1}"/>
               </a:ext>
             </a:extLst>
           </p:cNvPr>
@@ -8116,7 +8116,7 @@
           <p:nvPr/>
         </p:nvPicPr>
         <p:blipFill>
-          <a:blip xmlns:r="http://schemas.openxmlformats.org/officeDocument/2006/relationships" xmlns:a="http://schemas.openxmlformats.org/drawingml/2006/main" r:embed="Racdd9329fde04bea"/>
+          <a:blip xmlns:r="http://schemas.openxmlformats.org/officeDocument/2006/relationships" xmlns:a="http://schemas.openxmlformats.org/drawingml/2006/main" r:embed="R3be2f77fdce44669"/>
           <a:stretch xmlns:a="http://schemas.openxmlformats.org/drawingml/2006/main"/>
         </p:blipFill>
         <p:spPr>
@@ -8138,7 +8138,7 @@
           <p:nvPr/>
         </p:nvPicPr>
         <p:blipFill>
-          <a:blip xmlns:r="http://schemas.openxmlformats.org/officeDocument/2006/relationships" xmlns:a="http://schemas.openxmlformats.org/drawingml/2006/main" r:embed="R5b0e457787fb4307"/>
+          <a:blip xmlns:r="http://schemas.openxmlformats.org/officeDocument/2006/relationships" xmlns:a="http://schemas.openxmlformats.org/drawingml/2006/main" r:embed="R25b8a439d4d147a0"/>
           <a:stretch xmlns:a="http://schemas.openxmlformats.org/drawingml/2006/main"/>
         </p:blipFill>
         <p:spPr>
@@ -8160,7 +8160,7 @@
           <p:nvPr/>
         </p:nvPicPr>
         <p:blipFill>
-          <a:blip xmlns:r="http://schemas.openxmlformats.org/officeDocument/2006/relationships" xmlns:a="http://schemas.openxmlformats.org/drawingml/2006/main" r:embed="R55c907c80f244279"/>
+          <a:blip xmlns:r="http://schemas.openxmlformats.org/officeDocument/2006/relationships" xmlns:a="http://schemas.openxmlformats.org/drawingml/2006/main" r:embed="R1d4ec999cad74ab8"/>
           <a:stretch xmlns:a="http://schemas.openxmlformats.org/drawingml/2006/main"/>
         </p:blipFill>
         <p:spPr>
@@ -8182,7 +8182,7 @@
           <p:nvPr/>
         </p:nvPicPr>
         <p:blipFill>
-          <a:blip xmlns:r="http://schemas.openxmlformats.org/officeDocument/2006/relationships" xmlns:a="http://schemas.openxmlformats.org/drawingml/2006/main" r:embed="R915b7829ce654bfb"/>
+          <a:blip xmlns:r="http://schemas.openxmlformats.org/officeDocument/2006/relationships" xmlns:a="http://schemas.openxmlformats.org/drawingml/2006/main" r:embed="Rd08bfe3197b04950"/>
           <a:stretch xmlns:a="http://schemas.openxmlformats.org/drawingml/2006/main"/>
         </p:blipFill>
         <p:spPr>
@@ -8200,7 +8200,7 @@
           <p:cNvPr id="11" name="Slide number">
             <a:extLst xmlns:a="http://schemas.openxmlformats.org/drawingml/2006/main">
               <a:ext uri="{FF2B5EF4-FFF2-40B4-BE49-F238E27FC236}">
-                <a16:creationId xmlns:a16="http://schemas.microsoft.com/office/drawing/2014/main" id="{7722DEFB-ADCD-437A-BAF3-9D14804FB862}"/>
+                <a16:creationId xmlns:a16="http://schemas.microsoft.com/office/drawing/2014/main" id="{B1D41B0B-CC88-47A1-AC48-EFC28CCCE24B}"/>
               </a:ext>
             </a:extLst>
           </p:cNvPr>
@@ -8255,7 +8255,7 @@
     </p:spTree>
     <p:extLst>
       <p:ext uri="{BB962C8B-B14F-4D97-AF65-F5344CB8AC3E}">
-        <p14:creationId xmlns:p14="http://schemas.microsoft.com/office/powerpoint/2010/main" val="878774562"/>
+        <p14:creationId xmlns:p14="http://schemas.microsoft.com/office/powerpoint/2010/main" val="827189659"/>
       </p:ext>
     </p:extLst>
   </p:cSld>
@@ -8286,7 +8286,7 @@
           <p:cNvPr id="11" name="Title">
             <a:extLst xmlns:a="http://schemas.openxmlformats.org/drawingml/2006/main">
               <a:ext uri="{FF2B5EF4-FFF2-40B4-BE49-F238E27FC236}">
-                <a16:creationId xmlns:a16="http://schemas.microsoft.com/office/drawing/2014/main" id="{CB23D8C6-C61E-4AF4-8B84-EAF89B587521}"/>
+                <a16:creationId xmlns:a16="http://schemas.microsoft.com/office/drawing/2014/main" id="{1FE16F8B-4676-41A3-9FD7-ADC618DB63C0}"/>
               </a:ext>
             </a:extLst>
           </p:cNvPr>
@@ -8343,7 +8343,7 @@
           <p:cNvPr id="2" name="text">
             <a:extLst xmlns:a="http://schemas.openxmlformats.org/drawingml/2006/main">
               <a:ext uri="{FF2B5EF4-FFF2-40B4-BE49-F238E27FC236}">
-                <a16:creationId xmlns:a16="http://schemas.microsoft.com/office/drawing/2014/main" id="{A4988C07-34D3-45F4-B633-7CED00436D61}"/>
+                <a16:creationId xmlns:a16="http://schemas.microsoft.com/office/drawing/2014/main" id="{BAE1839C-4D2C-4C69-BDC4-B6CF169A51C4}"/>
               </a:ext>
             </a:extLst>
           </p:cNvPr>
@@ -8400,7 +8400,7 @@
           <p:cNvPr id="3" name="text">
             <a:extLst xmlns:a="http://schemas.openxmlformats.org/drawingml/2006/main">
               <a:ext uri="{FF2B5EF4-FFF2-40B4-BE49-F238E27FC236}">
-                <a16:creationId xmlns:a16="http://schemas.microsoft.com/office/drawing/2014/main" id="{65DAEF8A-DADF-443A-8E93-1028EECF0583}"/>
+                <a16:creationId xmlns:a16="http://schemas.microsoft.com/office/drawing/2014/main" id="{E0F99A68-2523-4B83-B719-931DCBEC6D0D}"/>
               </a:ext>
             </a:extLst>
           </p:cNvPr>
@@ -8457,7 +8457,7 @@
           <p:cNvPr id="4" name="text">
             <a:extLst xmlns:a="http://schemas.openxmlformats.org/drawingml/2006/main">
               <a:ext uri="{FF2B5EF4-FFF2-40B4-BE49-F238E27FC236}">
-                <a16:creationId xmlns:a16="http://schemas.microsoft.com/office/drawing/2014/main" id="{2B06F654-C823-4977-84C0-8ED88E5A4C92}"/>
+                <a16:creationId xmlns:a16="http://schemas.microsoft.com/office/drawing/2014/main" id="{4EAF5CDE-D357-4A15-AF3D-E8F63D82448E}"/>
               </a:ext>
             </a:extLst>
           </p:cNvPr>
@@ -8514,7 +8514,7 @@
           <p:cNvPr id="5" name="text">
             <a:extLst xmlns:a="http://schemas.openxmlformats.org/drawingml/2006/main">
               <a:ext uri="{FF2B5EF4-FFF2-40B4-BE49-F238E27FC236}">
-                <a16:creationId xmlns:a16="http://schemas.microsoft.com/office/drawing/2014/main" id="{5378DF3B-B6E8-429C-A414-3D9DC8209DEE}"/>
+                <a16:creationId xmlns:a16="http://schemas.microsoft.com/office/drawing/2014/main" id="{04F13449-582F-48C2-8AE2-A2F9CBF42625}"/>
               </a:ext>
             </a:extLst>
           </p:cNvPr>
@@ -8571,7 +8571,7 @@
           <p:cNvPr id="6" name="text">
             <a:extLst xmlns:a="http://schemas.openxmlformats.org/drawingml/2006/main">
               <a:ext uri="{FF2B5EF4-FFF2-40B4-BE49-F238E27FC236}">
-                <a16:creationId xmlns:a16="http://schemas.microsoft.com/office/drawing/2014/main" id="{945221A1-99A1-4A20-940F-CB5EFF07084E}"/>
+                <a16:creationId xmlns:a16="http://schemas.microsoft.com/office/drawing/2014/main" id="{009B3E09-E41F-41DD-BA2C-9E25AB415705}"/>
               </a:ext>
             </a:extLst>
           </p:cNvPr>
@@ -8628,7 +8628,7 @@
           <p:cNvPr id="7" name="text">
             <a:extLst xmlns:a="http://schemas.openxmlformats.org/drawingml/2006/main">
               <a:ext uri="{FF2B5EF4-FFF2-40B4-BE49-F238E27FC236}">
-                <a16:creationId xmlns:a16="http://schemas.microsoft.com/office/drawing/2014/main" id="{A8EE8EC3-D4E9-4A82-9350-37029093FDFE}"/>
+                <a16:creationId xmlns:a16="http://schemas.microsoft.com/office/drawing/2014/main" id="{E07199D3-6C3B-4012-9EE2-22073083AB67}"/>
               </a:ext>
             </a:extLst>
           </p:cNvPr>
@@ -8685,7 +8685,7 @@
           <p:cNvPr id="8" name="text">
             <a:extLst xmlns:a="http://schemas.openxmlformats.org/drawingml/2006/main">
               <a:ext uri="{FF2B5EF4-FFF2-40B4-BE49-F238E27FC236}">
-                <a16:creationId xmlns:a16="http://schemas.microsoft.com/office/drawing/2014/main" id="{83E44EC7-74CD-44CC-82A9-01082265DCA0}"/>
+                <a16:creationId xmlns:a16="http://schemas.microsoft.com/office/drawing/2014/main" id="{98A2F261-0F02-4103-A8D5-8FC42E3636A6}"/>
               </a:ext>
             </a:extLst>
           </p:cNvPr>
@@ -8742,7 +8742,7 @@
           <p:cNvPr id="9" name="text">
             <a:extLst xmlns:a="http://schemas.openxmlformats.org/drawingml/2006/main">
               <a:ext uri="{FF2B5EF4-FFF2-40B4-BE49-F238E27FC236}">
-                <a16:creationId xmlns:a16="http://schemas.microsoft.com/office/drawing/2014/main" id="{F66A290C-7995-4FD7-B6A0-438F2C7A71C6}"/>
+                <a16:creationId xmlns:a16="http://schemas.microsoft.com/office/drawing/2014/main" id="{4745E6D6-E72A-4678-B538-12243E135066}"/>
               </a:ext>
             </a:extLst>
           </p:cNvPr>
@@ -8799,7 +8799,7 @@
           <p:cNvPr id="10" name="Slide number">
             <a:extLst xmlns:a="http://schemas.openxmlformats.org/drawingml/2006/main">
               <a:ext uri="{FF2B5EF4-FFF2-40B4-BE49-F238E27FC236}">
-                <a16:creationId xmlns:a16="http://schemas.microsoft.com/office/drawing/2014/main" id="{35D17DC2-AC2E-4D99-AAD6-547DF13E29C6}"/>
+                <a16:creationId xmlns:a16="http://schemas.microsoft.com/office/drawing/2014/main" id="{30194299-DD15-4518-9383-570C5B14F73A}"/>
               </a:ext>
             </a:extLst>
           </p:cNvPr>
@@ -8854,7 +8854,7 @@
     </p:spTree>
     <p:extLst>
       <p:ext uri="{BB962C8B-B14F-4D97-AF65-F5344CB8AC3E}">
-        <p14:creationId xmlns:p14="http://schemas.microsoft.com/office/powerpoint/2010/main" val="181194872"/>
+        <p14:creationId xmlns:p14="http://schemas.microsoft.com/office/powerpoint/2010/main" val="2110213330"/>
       </p:ext>
     </p:extLst>
   </p:cSld>
@@ -8885,7 +8885,7 @@
           <p:cNvPr id="5" name="Title">
             <a:extLst xmlns:a="http://schemas.openxmlformats.org/drawingml/2006/main">
               <a:ext uri="{FF2B5EF4-FFF2-40B4-BE49-F238E27FC236}">
-                <a16:creationId xmlns:a16="http://schemas.microsoft.com/office/drawing/2014/main" id="{D54E44C1-EB51-4555-95DE-FEDE236159FF}"/>
+                <a16:creationId xmlns:a16="http://schemas.microsoft.com/office/drawing/2014/main" id="{2CA6CE29-108B-4151-9FA6-3B0C0F145981}"/>
               </a:ext>
             </a:extLst>
           </p:cNvPr>
@@ -8942,7 +8942,7 @@
           <p:cNvPr id="2" name="Metric value">
             <a:extLst xmlns:a="http://schemas.openxmlformats.org/drawingml/2006/main">
               <a:ext uri="{FF2B5EF4-FFF2-40B4-BE49-F238E27FC236}">
-                <a16:creationId xmlns:a16="http://schemas.microsoft.com/office/drawing/2014/main" id="{28E9960B-B681-4BC8-92C7-02927321BF26}"/>
+                <a16:creationId xmlns:a16="http://schemas.microsoft.com/office/drawing/2014/main" id="{33F0C5CB-7B63-4340-9B18-4E6456B3C298}"/>
               </a:ext>
             </a:extLst>
           </p:cNvPr>
@@ -8999,7 +8999,7 @@
           <p:cNvPr id="3" name="text">
             <a:extLst xmlns:a="http://schemas.openxmlformats.org/drawingml/2006/main">
               <a:ext uri="{FF2B5EF4-FFF2-40B4-BE49-F238E27FC236}">
-                <a16:creationId xmlns:a16="http://schemas.microsoft.com/office/drawing/2014/main" id="{61FD9CF3-47A9-412D-B374-2CC9687742AD}"/>
+                <a16:creationId xmlns:a16="http://schemas.microsoft.com/office/drawing/2014/main" id="{1E7BDB36-B3D5-44CF-9304-8604374979AF}"/>
               </a:ext>
             </a:extLst>
           </p:cNvPr>
@@ -9056,7 +9056,7 @@
           <p:cNvPr id="4" name="Slide number">
             <a:extLst xmlns:a="http://schemas.openxmlformats.org/drawingml/2006/main">
               <a:ext uri="{FF2B5EF4-FFF2-40B4-BE49-F238E27FC236}">
-                <a16:creationId xmlns:a16="http://schemas.microsoft.com/office/drawing/2014/main" id="{2BDB626C-60C9-4A78-A1CD-3229945A417D}"/>
+                <a16:creationId xmlns:a16="http://schemas.microsoft.com/office/drawing/2014/main" id="{9250B434-2C71-4BE1-A914-11BE399A8647}"/>
               </a:ext>
             </a:extLst>
           </p:cNvPr>
@@ -9111,7 +9111,7 @@
     </p:spTree>
     <p:extLst>
       <p:ext uri="{BB962C8B-B14F-4D97-AF65-F5344CB8AC3E}">
-        <p14:creationId xmlns:p14="http://schemas.microsoft.com/office/powerpoint/2010/main" val="1814794178"/>
+        <p14:creationId xmlns:p14="http://schemas.microsoft.com/office/powerpoint/2010/main" val="1999390664"/>
       </p:ext>
     </p:extLst>
   </p:cSld>
@@ -9142,7 +9142,7 @@
           <p:cNvPr id="13" name="Completed section 0">
             <a:extLst xmlns:a="http://schemas.openxmlformats.org/drawingml/2006/main">
               <a:ext uri="{FF2B5EF4-FFF2-40B4-BE49-F238E27FC236}">
-                <a16:creationId xmlns:a16="http://schemas.microsoft.com/office/drawing/2014/main" id="{9BAEE95B-C4EE-4692-BEE9-C90223EB5831}"/>
+                <a16:creationId xmlns:a16="http://schemas.microsoft.com/office/drawing/2014/main" id="{B5B03F65-CBC8-4616-9D84-D1277BA15EB8}"/>
               </a:ext>
             </a:extLst>
           </p:cNvPr>
@@ -9199,7 +9199,7 @@
           <p:cNvPr id="2" name="Section description 0">
             <a:extLst xmlns:a="http://schemas.openxmlformats.org/drawingml/2006/main">
               <a:ext uri="{FF2B5EF4-FFF2-40B4-BE49-F238E27FC236}">
-                <a16:creationId xmlns:a16="http://schemas.microsoft.com/office/drawing/2014/main" id="{DCD2D9C4-9410-48F8-846A-28530636E75C}"/>
+                <a16:creationId xmlns:a16="http://schemas.microsoft.com/office/drawing/2014/main" id="{4884559A-72E5-475A-9818-A29389897355}"/>
               </a:ext>
             </a:extLst>
           </p:cNvPr>
@@ -9256,7 +9256,7 @@
           <p:cNvPr id="3" name="Completed section 1">
             <a:extLst xmlns:a="http://schemas.openxmlformats.org/drawingml/2006/main">
               <a:ext uri="{FF2B5EF4-FFF2-40B4-BE49-F238E27FC236}">
-                <a16:creationId xmlns:a16="http://schemas.microsoft.com/office/drawing/2014/main" id="{AACB47CB-FF0A-4E5B-8DB0-E7053F3FDCA4}"/>
+                <a16:creationId xmlns:a16="http://schemas.microsoft.com/office/drawing/2014/main" id="{94BCA6E7-00E5-4DD4-84CE-0BA838BB7658}"/>
               </a:ext>
             </a:extLst>
           </p:cNvPr>
@@ -9313,7 +9313,7 @@
           <p:cNvPr id="4" name="Section description 1">
             <a:extLst xmlns:a="http://schemas.openxmlformats.org/drawingml/2006/main">
               <a:ext uri="{FF2B5EF4-FFF2-40B4-BE49-F238E27FC236}">
-                <a16:creationId xmlns:a16="http://schemas.microsoft.com/office/drawing/2014/main" id="{EF4FBBAA-E628-406C-963C-13A31770476B}"/>
+                <a16:creationId xmlns:a16="http://schemas.microsoft.com/office/drawing/2014/main" id="{D0AD2C26-0C1F-4A02-8D76-855F0A5D21C1}"/>
               </a:ext>
             </a:extLst>
           </p:cNvPr>
@@ -9370,7 +9370,7 @@
           <p:cNvPr id="5" name="Completed section 2">
             <a:extLst xmlns:a="http://schemas.openxmlformats.org/drawingml/2006/main">
               <a:ext uri="{FF2B5EF4-FFF2-40B4-BE49-F238E27FC236}">
-                <a16:creationId xmlns:a16="http://schemas.microsoft.com/office/drawing/2014/main" id="{16F95636-598D-45E5-A824-B70FCBCFA830}"/>
+                <a16:creationId xmlns:a16="http://schemas.microsoft.com/office/drawing/2014/main" id="{F2FB6489-6B98-436D-AF76-AB6B7D4DCD4B}"/>
               </a:ext>
             </a:extLst>
           </p:cNvPr>
@@ -9427,7 +9427,7 @@
           <p:cNvPr id="6" name="Section description 2">
             <a:extLst xmlns:a="http://schemas.openxmlformats.org/drawingml/2006/main">
               <a:ext uri="{FF2B5EF4-FFF2-40B4-BE49-F238E27FC236}">
-                <a16:creationId xmlns:a16="http://schemas.microsoft.com/office/drawing/2014/main" id="{A8A11852-24EC-4F73-886C-58DE3752EE42}"/>
+                <a16:creationId xmlns:a16="http://schemas.microsoft.com/office/drawing/2014/main" id="{0B7FFB4F-A917-44A2-BDDE-CB7BCBD76F2A}"/>
               </a:ext>
             </a:extLst>
           </p:cNvPr>
@@ -9484,7 +9484,7 @@
           <p:cNvPr id="7" name="Active section">
             <a:extLst xmlns:a="http://schemas.openxmlformats.org/drawingml/2006/main">
               <a:ext uri="{FF2B5EF4-FFF2-40B4-BE49-F238E27FC236}">
-                <a16:creationId xmlns:a16="http://schemas.microsoft.com/office/drawing/2014/main" id="{173F8003-42F6-4E6F-BB34-AC644947B8CA}"/>
+                <a16:creationId xmlns:a16="http://schemas.microsoft.com/office/drawing/2014/main" id="{4DE8CF8B-ED80-47FD-BDF3-150824700C41}"/>
               </a:ext>
             </a:extLst>
           </p:cNvPr>
@@ -9541,7 +9541,7 @@
           <p:cNvPr id="8" name="Section description 3">
             <a:extLst xmlns:a="http://schemas.openxmlformats.org/drawingml/2006/main">
               <a:ext uri="{FF2B5EF4-FFF2-40B4-BE49-F238E27FC236}">
-                <a16:creationId xmlns:a16="http://schemas.microsoft.com/office/drawing/2014/main" id="{02D56BCD-E0F7-49CB-B3B2-34C31A8D5F92}"/>
+                <a16:creationId xmlns:a16="http://schemas.microsoft.com/office/drawing/2014/main" id="{BB4FDBE1-12D7-4176-B933-8525425DCA24}"/>
               </a:ext>
             </a:extLst>
           </p:cNvPr>
@@ -9602,7 +9602,7 @@
           <p:nvPr/>
         </p:nvPicPr>
         <p:blipFill>
-          <a:blip xmlns:r="http://schemas.openxmlformats.org/officeDocument/2006/relationships" xmlns:a="http://schemas.openxmlformats.org/drawingml/2006/main" r:embed="R6410cfc258e44b4c"/>
+          <a:blip xmlns:r="http://schemas.openxmlformats.org/officeDocument/2006/relationships" xmlns:a="http://schemas.openxmlformats.org/drawingml/2006/main" r:embed="R1874032ccdb2457d"/>
           <a:stretch xmlns:a="http://schemas.openxmlformats.org/drawingml/2006/main"/>
         </p:blipFill>
         <p:spPr>
@@ -9624,7 +9624,7 @@
           <p:nvPr/>
         </p:nvPicPr>
         <p:blipFill>
-          <a:blip xmlns:r="http://schemas.openxmlformats.org/officeDocument/2006/relationships" xmlns:a="http://schemas.openxmlformats.org/drawingml/2006/main" r:embed="Ra31a95853da4424b"/>
+          <a:blip xmlns:r="http://schemas.openxmlformats.org/officeDocument/2006/relationships" xmlns:a="http://schemas.openxmlformats.org/drawingml/2006/main" r:embed="Rdd6cdeb6e78445b9"/>
           <a:stretch xmlns:a="http://schemas.openxmlformats.org/drawingml/2006/main"/>
         </p:blipFill>
         <p:spPr>
@@ -9646,7 +9646,7 @@
           <p:nvPr/>
         </p:nvPicPr>
         <p:blipFill>
-          <a:blip xmlns:r="http://schemas.openxmlformats.org/officeDocument/2006/relationships" xmlns:a="http://schemas.openxmlformats.org/drawingml/2006/main" r:embed="R86181dcf4617446a"/>
+          <a:blip xmlns:r="http://schemas.openxmlformats.org/officeDocument/2006/relationships" xmlns:a="http://schemas.openxmlformats.org/drawingml/2006/main" r:embed="R1573c5e5b03e4087"/>
           <a:stretch xmlns:a="http://schemas.openxmlformats.org/drawingml/2006/main"/>
         </p:blipFill>
         <p:spPr>
@@ -9664,7 +9664,7 @@
           <p:cNvPr id="12" name="Slide number">
             <a:extLst xmlns:a="http://schemas.openxmlformats.org/drawingml/2006/main">
               <a:ext uri="{FF2B5EF4-FFF2-40B4-BE49-F238E27FC236}">
-                <a16:creationId xmlns:a16="http://schemas.microsoft.com/office/drawing/2014/main" id="{279665A2-DCD5-44B4-B56F-27B88C7C4162}"/>
+                <a16:creationId xmlns:a16="http://schemas.microsoft.com/office/drawing/2014/main" id="{B8F45720-CA06-40BE-ACF2-C44B8B24BE41}"/>
               </a:ext>
             </a:extLst>
           </p:cNvPr>
@@ -9719,7 +9719,7 @@
     </p:spTree>
     <p:extLst>
       <p:ext uri="{BB962C8B-B14F-4D97-AF65-F5344CB8AC3E}">
-        <p14:creationId xmlns:p14="http://schemas.microsoft.com/office/powerpoint/2010/main" val="1106189989"/>
+        <p14:creationId xmlns:p14="http://schemas.microsoft.com/office/powerpoint/2010/main" val="742984196"/>
       </p:ext>
     </p:extLst>
   </p:cSld>
@@ -9750,7 +9750,7 @@
           <p:cNvPr id="11" name="Title">
             <a:extLst xmlns:a="http://schemas.openxmlformats.org/drawingml/2006/main">
               <a:ext uri="{FF2B5EF4-FFF2-40B4-BE49-F238E27FC236}">
-                <a16:creationId xmlns:a16="http://schemas.microsoft.com/office/drawing/2014/main" id="{EF54057B-4424-4E3E-A60E-767540344D33}"/>
+                <a16:creationId xmlns:a16="http://schemas.microsoft.com/office/drawing/2014/main" id="{C9B2501E-608F-4921-90A8-095A7DCE032F}"/>
               </a:ext>
             </a:extLst>
           </p:cNvPr>
@@ -9807,7 +9807,7 @@
           <p:cNvPr id="2" name="text">
             <a:extLst xmlns:a="http://schemas.openxmlformats.org/drawingml/2006/main">
               <a:ext uri="{FF2B5EF4-FFF2-40B4-BE49-F238E27FC236}">
-                <a16:creationId xmlns:a16="http://schemas.microsoft.com/office/drawing/2014/main" id="{E72B6F37-D8BD-4DB8-8439-EAFC61756E94}"/>
+                <a16:creationId xmlns:a16="http://schemas.microsoft.com/office/drawing/2014/main" id="{230A4A10-4A20-4F5D-AB1A-E96E9CB1C306}"/>
               </a:ext>
             </a:extLst>
           </p:cNvPr>
@@ -9864,7 +9864,7 @@
           <p:cNvPr id="3" name="text">
             <a:extLst xmlns:a="http://schemas.openxmlformats.org/drawingml/2006/main">
               <a:ext uri="{FF2B5EF4-FFF2-40B4-BE49-F238E27FC236}">
-                <a16:creationId xmlns:a16="http://schemas.microsoft.com/office/drawing/2014/main" id="{0C498E09-6CFC-4B43-9C83-06C25836C10E}"/>
+                <a16:creationId xmlns:a16="http://schemas.microsoft.com/office/drawing/2014/main" id="{EE7DC6E2-1275-443F-A90F-C6522094A9B6}"/>
               </a:ext>
             </a:extLst>
           </p:cNvPr>
@@ -9921,7 +9921,7 @@
           <p:cNvPr id="4" name="text">
             <a:extLst xmlns:a="http://schemas.openxmlformats.org/drawingml/2006/main">
               <a:ext uri="{FF2B5EF4-FFF2-40B4-BE49-F238E27FC236}">
-                <a16:creationId xmlns:a16="http://schemas.microsoft.com/office/drawing/2014/main" id="{5A50192D-FA1F-42B1-B06E-3BDD6306B06A}"/>
+                <a16:creationId xmlns:a16="http://schemas.microsoft.com/office/drawing/2014/main" id="{EE76EC5D-7B82-4F01-B341-8E72CA1290C7}"/>
               </a:ext>
             </a:extLst>
           </p:cNvPr>
@@ -9978,7 +9978,7 @@
           <p:cNvPr id="5" name="text">
             <a:extLst xmlns:a="http://schemas.openxmlformats.org/drawingml/2006/main">
               <a:ext uri="{FF2B5EF4-FFF2-40B4-BE49-F238E27FC236}">
-                <a16:creationId xmlns:a16="http://schemas.microsoft.com/office/drawing/2014/main" id="{938DB2F4-9476-4A96-8CCA-B7FCA2A629DC}"/>
+                <a16:creationId xmlns:a16="http://schemas.microsoft.com/office/drawing/2014/main" id="{423D37C1-07F5-47E9-8C37-264FA35C7B98}"/>
               </a:ext>
             </a:extLst>
           </p:cNvPr>
@@ -10035,7 +10035,7 @@
           <p:cNvPr id="6" name="text">
             <a:extLst xmlns:a="http://schemas.openxmlformats.org/drawingml/2006/main">
               <a:ext uri="{FF2B5EF4-FFF2-40B4-BE49-F238E27FC236}">
-                <a16:creationId xmlns:a16="http://schemas.microsoft.com/office/drawing/2014/main" id="{E5DE212D-C503-4F87-B738-44276D6F93DB}"/>
+                <a16:creationId xmlns:a16="http://schemas.microsoft.com/office/drawing/2014/main" id="{A2DCF61D-9E1D-4F21-A751-0CA12B20AEC1}"/>
               </a:ext>
             </a:extLst>
           </p:cNvPr>
@@ -10092,7 +10092,7 @@
           <p:cNvPr id="7" name="text">
             <a:extLst xmlns:a="http://schemas.openxmlformats.org/drawingml/2006/main">
               <a:ext uri="{FF2B5EF4-FFF2-40B4-BE49-F238E27FC236}">
-                <a16:creationId xmlns:a16="http://schemas.microsoft.com/office/drawing/2014/main" id="{5AACE2E8-90B1-4F21-B3B0-FDA15505A81A}"/>
+                <a16:creationId xmlns:a16="http://schemas.microsoft.com/office/drawing/2014/main" id="{31927B0D-558D-4E99-AB61-AC8B2F25D693}"/>
               </a:ext>
             </a:extLst>
           </p:cNvPr>
@@ -10149,7 +10149,7 @@
           <p:cNvPr id="8" name="text">
             <a:extLst xmlns:a="http://schemas.openxmlformats.org/drawingml/2006/main">
               <a:ext uri="{FF2B5EF4-FFF2-40B4-BE49-F238E27FC236}">
-                <a16:creationId xmlns:a16="http://schemas.microsoft.com/office/drawing/2014/main" id="{EC776F72-B310-4760-8870-D58BA54B27FD}"/>
+                <a16:creationId xmlns:a16="http://schemas.microsoft.com/office/drawing/2014/main" id="{9BAA642A-9223-4C45-B69D-D28427A1BC26}"/>
               </a:ext>
             </a:extLst>
           </p:cNvPr>
@@ -10206,7 +10206,7 @@
           <p:cNvPr id="9" name="text">
             <a:extLst xmlns:a="http://schemas.openxmlformats.org/drawingml/2006/main">
               <a:ext uri="{FF2B5EF4-FFF2-40B4-BE49-F238E27FC236}">
-                <a16:creationId xmlns:a16="http://schemas.microsoft.com/office/drawing/2014/main" id="{93C959D6-B1CA-4829-BA63-F9BCFAECDF4C}"/>
+                <a16:creationId xmlns:a16="http://schemas.microsoft.com/office/drawing/2014/main" id="{C3FE3A02-C0EE-4CF9-AD0F-7F1C6E40954E}"/>
               </a:ext>
             </a:extLst>
           </p:cNvPr>
@@ -10263,7 +10263,7 @@
           <p:cNvPr id="10" name="Slide number">
             <a:extLst xmlns:a="http://schemas.openxmlformats.org/drawingml/2006/main">
               <a:ext uri="{FF2B5EF4-FFF2-40B4-BE49-F238E27FC236}">
-                <a16:creationId xmlns:a16="http://schemas.microsoft.com/office/drawing/2014/main" id="{BED41FD9-09F3-4E2E-B7B1-AC50F76BF326}"/>
+                <a16:creationId xmlns:a16="http://schemas.microsoft.com/office/drawing/2014/main" id="{C5AE1854-E24E-40D1-B981-469FA4150B6A}"/>
               </a:ext>
             </a:extLst>
           </p:cNvPr>
@@ -10318,7 +10318,7 @@
     </p:spTree>
     <p:extLst>
       <p:ext uri="{BB962C8B-B14F-4D97-AF65-F5344CB8AC3E}">
-        <p14:creationId xmlns:p14="http://schemas.microsoft.com/office/powerpoint/2010/main" val="774204167"/>
+        <p14:creationId xmlns:p14="http://schemas.microsoft.com/office/powerpoint/2010/main" val="1964028764"/>
       </p:ext>
     </p:extLst>
   </p:cSld>
@@ -10349,7 +10349,7 @@
           <p:cNvPr id="7" name="Title">
             <a:extLst xmlns:a="http://schemas.openxmlformats.org/drawingml/2006/main">
               <a:ext uri="{FF2B5EF4-FFF2-40B4-BE49-F238E27FC236}">
-                <a16:creationId xmlns:a16="http://schemas.microsoft.com/office/drawing/2014/main" id="{3322D41B-A043-41C3-8B50-F6BEDDBB3F9A}"/>
+                <a16:creationId xmlns:a16="http://schemas.microsoft.com/office/drawing/2014/main" id="{BCA82044-F3D2-4A82-8ECB-A2E0DDC41C2F}"/>
               </a:ext>
             </a:extLst>
           </p:cNvPr>
@@ -10413,7 +10413,7 @@
         </p:xfrm>
         <a:graphic xmlns:a="http://schemas.openxmlformats.org/drawingml/2006/main">
           <a:graphicData uri="http://schemas.openxmlformats.org/drawingml/2006/chart">
-            <c:chart xmlns:r="http://schemas.openxmlformats.org/officeDocument/2006/relationships" xmlns:c="http://schemas.openxmlformats.org/drawingml/2006/chart" r:id="Rbb53618df6af4a4e"/>
+            <c:chart xmlns:r="http://schemas.openxmlformats.org/officeDocument/2006/relationships" xmlns:c="http://schemas.openxmlformats.org/drawingml/2006/chart" r:id="R8325e139d1ee458c"/>
           </a:graphicData>
         </a:graphic>
       </p:graphicFrame>
@@ -10422,7 +10422,7 @@
           <p:cNvPr id="3" name="April month marker">
             <a:extLst xmlns:a="http://schemas.openxmlformats.org/drawingml/2006/main">
               <a:ext uri="{FF2B5EF4-FFF2-40B4-BE49-F238E27FC236}">
-                <a16:creationId xmlns:a16="http://schemas.microsoft.com/office/drawing/2014/main" id="{1EBED6CE-F90F-4992-BBE9-955AF28689FB}"/>
+                <a16:creationId xmlns:a16="http://schemas.microsoft.com/office/drawing/2014/main" id="{E42DAEA2-5BFC-4CF6-B05B-1A75B9788112}"/>
               </a:ext>
             </a:extLst>
           </p:cNvPr>
@@ -10453,7 +10453,7 @@
           <p:cNvPr id="4" name="April joining context">
             <a:extLst xmlns:a="http://schemas.openxmlformats.org/drawingml/2006/main">
               <a:ext uri="{FF2B5EF4-FFF2-40B4-BE49-F238E27FC236}">
-                <a16:creationId xmlns:a16="http://schemas.microsoft.com/office/drawing/2014/main" id="{9D25A462-7015-4E9F-8E38-DD6C2E0063F9}"/>
+                <a16:creationId xmlns:a16="http://schemas.microsoft.com/office/drawing/2014/main" id="{1582BD08-A791-4FEB-836C-7F474C7A683B}"/>
               </a:ext>
             </a:extLst>
           </p:cNvPr>
@@ -10510,7 +10510,7 @@
           <p:cNvPr id="5" name="Methodology">
             <a:extLst xmlns:a="http://schemas.openxmlformats.org/drawingml/2006/main">
               <a:ext uri="{FF2B5EF4-FFF2-40B4-BE49-F238E27FC236}">
-                <a16:creationId xmlns:a16="http://schemas.microsoft.com/office/drawing/2014/main" id="{B4F2C1C9-0E7F-468C-8C55-4237BCA9D200}"/>
+                <a16:creationId xmlns:a16="http://schemas.microsoft.com/office/drawing/2014/main" id="{206AA904-FCB4-4F30-8DE7-E4B18950A0B8}"/>
               </a:ext>
             </a:extLst>
           </p:cNvPr>
@@ -10567,7 +10567,7 @@
           <p:cNvPr id="6" name="Slide number">
             <a:extLst xmlns:a="http://schemas.openxmlformats.org/drawingml/2006/main">
               <a:ext uri="{FF2B5EF4-FFF2-40B4-BE49-F238E27FC236}">
-                <a16:creationId xmlns:a16="http://schemas.microsoft.com/office/drawing/2014/main" id="{FD537F8B-7F7F-4B92-A4FC-9BF700AE4689}"/>
+                <a16:creationId xmlns:a16="http://schemas.microsoft.com/office/drawing/2014/main" id="{9347B2FB-9CF0-40C8-84DC-854ED907B01C}"/>
               </a:ext>
             </a:extLst>
           </p:cNvPr>
@@ -10622,7 +10622,7 @@
     </p:spTree>
     <p:extLst>
       <p:ext uri="{BB962C8B-B14F-4D97-AF65-F5344CB8AC3E}">
-        <p14:creationId xmlns:p14="http://schemas.microsoft.com/office/powerpoint/2010/main" val="1355284349"/>
+        <p14:creationId xmlns:p14="http://schemas.microsoft.com/office/powerpoint/2010/main" val="1124513076"/>
       </p:ext>
     </p:extLst>
   </p:cSld>
@@ -10653,7 +10653,7 @@
           <p:cNvPr id="4" name="Title">
             <a:extLst xmlns:a="http://schemas.openxmlformats.org/drawingml/2006/main">
               <a:ext uri="{FF2B5EF4-FFF2-40B4-BE49-F238E27FC236}">
-                <a16:creationId xmlns:a16="http://schemas.microsoft.com/office/drawing/2014/main" id="{B54F3460-1AD0-4965-A0AC-874959E9EEE0}"/>
+                <a16:creationId xmlns:a16="http://schemas.microsoft.com/office/drawing/2014/main" id="{A2DBBB71-6B34-41D8-92D0-26CE43CCE713}"/>
               </a:ext>
             </a:extLst>
           </p:cNvPr>
@@ -10733,7 +10733,7 @@
           <p:cNvPr id="2" name="text">
             <a:extLst xmlns:a="http://schemas.openxmlformats.org/drawingml/2006/main">
               <a:ext uri="{FF2B5EF4-FFF2-40B4-BE49-F238E27FC236}">
-                <a16:creationId xmlns:a16="http://schemas.microsoft.com/office/drawing/2014/main" id="{8FD32802-B54A-45AF-8A03-BEA29BF0116F}"/>
+                <a16:creationId xmlns:a16="http://schemas.microsoft.com/office/drawing/2014/main" id="{5F2CBB4C-70DB-4D12-9845-719C9F21D6D6}"/>
               </a:ext>
             </a:extLst>
           </p:cNvPr>
@@ -10790,7 +10790,7 @@
           <p:cNvPr id="3" name="Slide number">
             <a:extLst xmlns:a="http://schemas.openxmlformats.org/drawingml/2006/main">
               <a:ext uri="{FF2B5EF4-FFF2-40B4-BE49-F238E27FC236}">
-                <a16:creationId xmlns:a16="http://schemas.microsoft.com/office/drawing/2014/main" id="{B4D91593-A065-4659-9373-549E4E4E4299}"/>
+                <a16:creationId xmlns:a16="http://schemas.microsoft.com/office/drawing/2014/main" id="{6C26D012-F009-4470-BFB1-9191CF359C45}"/>
               </a:ext>
             </a:extLst>
           </p:cNvPr>
@@ -10845,7 +10845,7 @@
     </p:spTree>
     <p:extLst>
       <p:ext uri="{BB962C8B-B14F-4D97-AF65-F5344CB8AC3E}">
-        <p14:creationId xmlns:p14="http://schemas.microsoft.com/office/powerpoint/2010/main" val="507578909"/>
+        <p14:creationId xmlns:p14="http://schemas.microsoft.com/office/powerpoint/2010/main" val="1489830060"/>
       </p:ext>
     </p:extLst>
   </p:cSld>
@@ -10876,7 +10876,7 @@
           <p:cNvPr id="14" name="Completed section 0">
             <a:extLst xmlns:a="http://schemas.openxmlformats.org/drawingml/2006/main">
               <a:ext uri="{FF2B5EF4-FFF2-40B4-BE49-F238E27FC236}">
-                <a16:creationId xmlns:a16="http://schemas.microsoft.com/office/drawing/2014/main" id="{94B786FE-4280-43B8-95CE-5FBF32CE26D2}"/>
+                <a16:creationId xmlns:a16="http://schemas.microsoft.com/office/drawing/2014/main" id="{4C794464-EED6-4F98-9E08-A08F49A28C05}"/>
               </a:ext>
             </a:extLst>
           </p:cNvPr>
@@ -10933,7 +10933,7 @@
           <p:cNvPr id="2" name="Section description 0">
             <a:extLst xmlns:a="http://schemas.openxmlformats.org/drawingml/2006/main">
               <a:ext uri="{FF2B5EF4-FFF2-40B4-BE49-F238E27FC236}">
-                <a16:creationId xmlns:a16="http://schemas.microsoft.com/office/drawing/2014/main" id="{BC202744-067C-4122-A706-3C6D9238AF5F}"/>
+                <a16:creationId xmlns:a16="http://schemas.microsoft.com/office/drawing/2014/main" id="{B5F84B27-B748-4AC5-811B-130E23258B28}"/>
               </a:ext>
             </a:extLst>
           </p:cNvPr>
@@ -10990,7 +10990,7 @@
           <p:cNvPr id="3" name="Completed section 1">
             <a:extLst xmlns:a="http://schemas.openxmlformats.org/drawingml/2006/main">
               <a:ext uri="{FF2B5EF4-FFF2-40B4-BE49-F238E27FC236}">
-                <a16:creationId xmlns:a16="http://schemas.microsoft.com/office/drawing/2014/main" id="{E45D3290-9712-435F-8A89-90DE13715404}"/>
+                <a16:creationId xmlns:a16="http://schemas.microsoft.com/office/drawing/2014/main" id="{02B580A4-19F8-4E08-B8E0-401B2C9E2EBE}"/>
               </a:ext>
             </a:extLst>
           </p:cNvPr>
@@ -11047,7 +11047,7 @@
           <p:cNvPr id="4" name="Section description 1">
             <a:extLst xmlns:a="http://schemas.openxmlformats.org/drawingml/2006/main">
               <a:ext uri="{FF2B5EF4-FFF2-40B4-BE49-F238E27FC236}">
-                <a16:creationId xmlns:a16="http://schemas.microsoft.com/office/drawing/2014/main" id="{7387A07E-6B74-4A89-A956-BDAC083B89ED}"/>
+                <a16:creationId xmlns:a16="http://schemas.microsoft.com/office/drawing/2014/main" id="{D39D7607-303F-459E-8F69-1DA414E69098}"/>
               </a:ext>
             </a:extLst>
           </p:cNvPr>
@@ -11104,7 +11104,7 @@
           <p:cNvPr id="5" name="Completed section 2">
             <a:extLst xmlns:a="http://schemas.openxmlformats.org/drawingml/2006/main">
               <a:ext uri="{FF2B5EF4-FFF2-40B4-BE49-F238E27FC236}">
-                <a16:creationId xmlns:a16="http://schemas.microsoft.com/office/drawing/2014/main" id="{9FD68C36-BC01-443E-B0E3-5AE781BEE28E}"/>
+                <a16:creationId xmlns:a16="http://schemas.microsoft.com/office/drawing/2014/main" id="{E53BFC2F-837E-4F3C-ADA8-5589E9956AE3}"/>
               </a:ext>
             </a:extLst>
           </p:cNvPr>
@@ -11161,7 +11161,7 @@
           <p:cNvPr id="6" name="Section description 2">
             <a:extLst xmlns:a="http://schemas.openxmlformats.org/drawingml/2006/main">
               <a:ext uri="{FF2B5EF4-FFF2-40B4-BE49-F238E27FC236}">
-                <a16:creationId xmlns:a16="http://schemas.microsoft.com/office/drawing/2014/main" id="{CA5F5C2E-E789-47FE-AB31-E14672A85029}"/>
+                <a16:creationId xmlns:a16="http://schemas.microsoft.com/office/drawing/2014/main" id="{92A36FCC-CBEB-4C31-8F21-809EAAA31CD9}"/>
               </a:ext>
             </a:extLst>
           </p:cNvPr>
@@ -11218,7 +11218,7 @@
           <p:cNvPr id="7" name="Completed section 3">
             <a:extLst xmlns:a="http://schemas.openxmlformats.org/drawingml/2006/main">
               <a:ext uri="{FF2B5EF4-FFF2-40B4-BE49-F238E27FC236}">
-                <a16:creationId xmlns:a16="http://schemas.microsoft.com/office/drawing/2014/main" id="{1322148B-22B8-4BC5-93F0-2221E237E87F}"/>
+                <a16:creationId xmlns:a16="http://schemas.microsoft.com/office/drawing/2014/main" id="{3D4D8234-8368-4286-A38F-DB4EE76E21F4}"/>
               </a:ext>
             </a:extLst>
           </p:cNvPr>
@@ -11275,7 +11275,7 @@
           <p:cNvPr id="8" name="Section description 3">
             <a:extLst xmlns:a="http://schemas.openxmlformats.org/drawingml/2006/main">
               <a:ext uri="{FF2B5EF4-FFF2-40B4-BE49-F238E27FC236}">
-                <a16:creationId xmlns:a16="http://schemas.microsoft.com/office/drawing/2014/main" id="{9106252A-99DC-4E28-9AEB-927359F4720E}"/>
+                <a16:creationId xmlns:a16="http://schemas.microsoft.com/office/drawing/2014/main" id="{82A30ECE-EB73-417B-AB8D-68B9FBDC467B}"/>
               </a:ext>
             </a:extLst>
           </p:cNvPr>
@@ -11332,7 +11332,7 @@
           <p:cNvPr id="9" name="Active section">
             <a:extLst xmlns:a="http://schemas.openxmlformats.org/drawingml/2006/main">
               <a:ext uri="{FF2B5EF4-FFF2-40B4-BE49-F238E27FC236}">
-                <a16:creationId xmlns:a16="http://schemas.microsoft.com/office/drawing/2014/main" id="{E9B2A970-8F71-41FF-B292-787FA8193583}"/>
+                <a16:creationId xmlns:a16="http://schemas.microsoft.com/office/drawing/2014/main" id="{1B15D9E0-4EC2-412F-95E9-1EFC0CEFD7C9}"/>
               </a:ext>
             </a:extLst>
           </p:cNvPr>
@@ -11389,7 +11389,7 @@
           <p:cNvPr id="10" name="Section description 4">
             <a:extLst xmlns:a="http://schemas.openxmlformats.org/drawingml/2006/main">
               <a:ext uri="{FF2B5EF4-FFF2-40B4-BE49-F238E27FC236}">
-                <a16:creationId xmlns:a16="http://schemas.microsoft.com/office/drawing/2014/main" id="{D284C5F2-6178-4471-B510-24B9F524CBAB}"/>
+                <a16:creationId xmlns:a16="http://schemas.microsoft.com/office/drawing/2014/main" id="{7DA33A54-5695-4D84-9A7A-DE9F5406F2B0}"/>
               </a:ext>
             </a:extLst>
           </p:cNvPr>
@@ -11450,7 +11450,7 @@
           <p:nvPr/>
         </p:nvPicPr>
         <p:blipFill>
-          <a:blip xmlns:r="http://schemas.openxmlformats.org/officeDocument/2006/relationships" xmlns:a="http://schemas.openxmlformats.org/drawingml/2006/main" r:embed="R50001818c26b4014"/>
+          <a:blip xmlns:r="http://schemas.openxmlformats.org/officeDocument/2006/relationships" xmlns:a="http://schemas.openxmlformats.org/drawingml/2006/main" r:embed="Rfc2a7eb922074300"/>
           <a:stretch xmlns:a="http://schemas.openxmlformats.org/drawingml/2006/main"/>
         </p:blipFill>
         <p:spPr>
@@ -11472,7 +11472,7 @@
           <p:nvPr/>
         </p:nvPicPr>
         <p:blipFill>
-          <a:blip xmlns:r="http://schemas.openxmlformats.org/officeDocument/2006/relationships" xmlns:a="http://schemas.openxmlformats.org/drawingml/2006/main" r:embed="R8de1240965e84a6b"/>
+          <a:blip xmlns:r="http://schemas.openxmlformats.org/officeDocument/2006/relationships" xmlns:a="http://schemas.openxmlformats.org/drawingml/2006/main" r:embed="Rbd089b2c21254640"/>
           <a:stretch xmlns:a="http://schemas.openxmlformats.org/drawingml/2006/main"/>
         </p:blipFill>
         <p:spPr>
@@ -11490,7 +11490,7 @@
           <p:cNvPr id="13" name="Slide number">
             <a:extLst xmlns:a="http://schemas.openxmlformats.org/drawingml/2006/main">
               <a:ext uri="{FF2B5EF4-FFF2-40B4-BE49-F238E27FC236}">
-                <a16:creationId xmlns:a16="http://schemas.microsoft.com/office/drawing/2014/main" id="{86C1C890-544C-4DED-8EBE-1F3B809A440A}"/>
+                <a16:creationId xmlns:a16="http://schemas.microsoft.com/office/drawing/2014/main" id="{7B3F13F5-112A-4E3C-957D-01A86E1D6AAE}"/>
               </a:ext>
             </a:extLst>
           </p:cNvPr>
@@ -11545,7 +11545,7 @@
     </p:spTree>
     <p:extLst>
       <p:ext uri="{BB962C8B-B14F-4D97-AF65-F5344CB8AC3E}">
-        <p14:creationId xmlns:p14="http://schemas.microsoft.com/office/powerpoint/2010/main" val="1075929725"/>
+        <p14:creationId xmlns:p14="http://schemas.microsoft.com/office/powerpoint/2010/main" val="1429513413"/>
       </p:ext>
     </p:extLst>
   </p:cSld>
@@ -11576,7 +11576,7 @@
           <p:cNvPr id="10" name="Title">
             <a:extLst xmlns:a="http://schemas.openxmlformats.org/drawingml/2006/main">
               <a:ext uri="{FF2B5EF4-FFF2-40B4-BE49-F238E27FC236}">
-                <a16:creationId xmlns:a16="http://schemas.microsoft.com/office/drawing/2014/main" id="{ECE2B09F-5D53-4CA4-A382-3846113B0EFD}"/>
+                <a16:creationId xmlns:a16="http://schemas.microsoft.com/office/drawing/2014/main" id="{20760945-0697-40D6-8DB5-A6AA54F9742F}"/>
               </a:ext>
             </a:extLst>
           </p:cNvPr>
@@ -11633,7 +11633,7 @@
           <p:cNvPr id="2" name="text">
             <a:extLst xmlns:a="http://schemas.openxmlformats.org/drawingml/2006/main">
               <a:ext uri="{FF2B5EF4-FFF2-40B4-BE49-F238E27FC236}">
-                <a16:creationId xmlns:a16="http://schemas.microsoft.com/office/drawing/2014/main" id="{D11D099F-17FB-4112-BE77-B9668CC439DA}"/>
+                <a16:creationId xmlns:a16="http://schemas.microsoft.com/office/drawing/2014/main" id="{6679CAE1-C3B0-48D5-9B81-DB392B0EEAC1}"/>
               </a:ext>
             </a:extLst>
           </p:cNvPr>
@@ -11690,7 +11690,7 @@
           <p:cNvPr id="3" name="text">
             <a:extLst xmlns:a="http://schemas.openxmlformats.org/drawingml/2006/main">
               <a:ext uri="{FF2B5EF4-FFF2-40B4-BE49-F238E27FC236}">
-                <a16:creationId xmlns:a16="http://schemas.microsoft.com/office/drawing/2014/main" id="{2B2A1956-0AFE-4554-81B3-C451847AD21E}"/>
+                <a16:creationId xmlns:a16="http://schemas.microsoft.com/office/drawing/2014/main" id="{79389B0D-AD91-4752-8710-C97F7A8C70BD}"/>
               </a:ext>
             </a:extLst>
           </p:cNvPr>
@@ -11747,7 +11747,7 @@
           <p:cNvPr id="4" name="text">
             <a:extLst xmlns:a="http://schemas.openxmlformats.org/drawingml/2006/main">
               <a:ext uri="{FF2B5EF4-FFF2-40B4-BE49-F238E27FC236}">
-                <a16:creationId xmlns:a16="http://schemas.microsoft.com/office/drawing/2014/main" id="{E8D8F046-0D4D-433B-B61C-D7E5F458B148}"/>
+                <a16:creationId xmlns:a16="http://schemas.microsoft.com/office/drawing/2014/main" id="{AEE69E0F-FF6C-4168-977E-CD0935317BEC}"/>
               </a:ext>
             </a:extLst>
           </p:cNvPr>
@@ -11804,7 +11804,7 @@
           <p:cNvPr id="5" name="text">
             <a:extLst xmlns:a="http://schemas.openxmlformats.org/drawingml/2006/main">
               <a:ext uri="{FF2B5EF4-FFF2-40B4-BE49-F238E27FC236}">
-                <a16:creationId xmlns:a16="http://schemas.microsoft.com/office/drawing/2014/main" id="{BA0B7A0F-8E18-4C11-B5EC-9CB5A5BC9A0F}"/>
+                <a16:creationId xmlns:a16="http://schemas.microsoft.com/office/drawing/2014/main" id="{D207C237-91EF-44F0-ADBD-C724ADA18009}"/>
               </a:ext>
             </a:extLst>
           </p:cNvPr>
@@ -11861,7 +11861,7 @@
           <p:cNvPr id="6" name="text">
             <a:extLst xmlns:a="http://schemas.openxmlformats.org/drawingml/2006/main">
               <a:ext uri="{FF2B5EF4-FFF2-40B4-BE49-F238E27FC236}">
-                <a16:creationId xmlns:a16="http://schemas.microsoft.com/office/drawing/2014/main" id="{87588227-B5E4-4731-8B9D-2CD4774639B3}"/>
+                <a16:creationId xmlns:a16="http://schemas.microsoft.com/office/drawing/2014/main" id="{46C9690F-7B08-435C-B310-78464A186FDA}"/>
               </a:ext>
             </a:extLst>
           </p:cNvPr>
@@ -11918,7 +11918,7 @@
           <p:cNvPr id="7" name="text">
             <a:extLst xmlns:a="http://schemas.openxmlformats.org/drawingml/2006/main">
               <a:ext uri="{FF2B5EF4-FFF2-40B4-BE49-F238E27FC236}">
-                <a16:creationId xmlns:a16="http://schemas.microsoft.com/office/drawing/2014/main" id="{67E15C09-13C4-4FCF-8625-22C35B355CF8}"/>
+                <a16:creationId xmlns:a16="http://schemas.microsoft.com/office/drawing/2014/main" id="{2811330A-18F5-4192-9055-7946EE14370D}"/>
               </a:ext>
             </a:extLst>
           </p:cNvPr>
@@ -11975,7 +11975,7 @@
           <p:cNvPr id="8" name="text">
             <a:extLst xmlns:a="http://schemas.openxmlformats.org/drawingml/2006/main">
               <a:ext uri="{FF2B5EF4-FFF2-40B4-BE49-F238E27FC236}">
-                <a16:creationId xmlns:a16="http://schemas.microsoft.com/office/drawing/2014/main" id="{FFA16564-1EE0-4C08-B320-C777E9ADB67E}"/>
+                <a16:creationId xmlns:a16="http://schemas.microsoft.com/office/drawing/2014/main" id="{DE3055D8-E985-4CD6-B289-31AC372E9E4F}"/>
               </a:ext>
             </a:extLst>
           </p:cNvPr>
@@ -12032,7 +12032,7 @@
           <p:cNvPr id="9" name="Slide number">
             <a:extLst xmlns:a="http://schemas.openxmlformats.org/drawingml/2006/main">
               <a:ext uri="{FF2B5EF4-FFF2-40B4-BE49-F238E27FC236}">
-                <a16:creationId xmlns:a16="http://schemas.microsoft.com/office/drawing/2014/main" id="{4F3736C7-ACB9-4DD6-A6C2-91671AC5DC51}"/>
+                <a16:creationId xmlns:a16="http://schemas.microsoft.com/office/drawing/2014/main" id="{16B4C732-FACC-4495-9573-3D52BA899F00}"/>
               </a:ext>
             </a:extLst>
           </p:cNvPr>
@@ -12087,7 +12087,7 @@
     </p:spTree>
     <p:extLst>
       <p:ext uri="{BB962C8B-B14F-4D97-AF65-F5344CB8AC3E}">
-        <p14:creationId xmlns:p14="http://schemas.microsoft.com/office/powerpoint/2010/main" val="883914056"/>
+        <p14:creationId xmlns:p14="http://schemas.microsoft.com/office/powerpoint/2010/main" val="1190938785"/>
       </p:ext>
     </p:extLst>
   </p:cSld>
@@ -12118,7 +12118,7 @@
           <p:cNvPr id="10" name="Title">
             <a:extLst xmlns:a="http://schemas.openxmlformats.org/drawingml/2006/main">
               <a:ext uri="{FF2B5EF4-FFF2-40B4-BE49-F238E27FC236}">
-                <a16:creationId xmlns:a16="http://schemas.microsoft.com/office/drawing/2014/main" id="{F6ACFA04-DB10-4A69-AF2F-1033535BAFF6}"/>
+                <a16:creationId xmlns:a16="http://schemas.microsoft.com/office/drawing/2014/main" id="{509C1B13-6146-4381-BC9E-6467E461AA75}"/>
               </a:ext>
             </a:extLst>
           </p:cNvPr>
@@ -12175,7 +12175,7 @@
           <p:cNvPr id="2" name="text">
             <a:extLst xmlns:a="http://schemas.openxmlformats.org/drawingml/2006/main">
               <a:ext uri="{FF2B5EF4-FFF2-40B4-BE49-F238E27FC236}">
-                <a16:creationId xmlns:a16="http://schemas.microsoft.com/office/drawing/2014/main" id="{4202EFDC-8E1C-4FCA-9689-C1DB654361DC}"/>
+                <a16:creationId xmlns:a16="http://schemas.microsoft.com/office/drawing/2014/main" id="{1B9057C1-AC1E-4AC7-9233-896127E8CEFC}"/>
               </a:ext>
             </a:extLst>
           </p:cNvPr>
@@ -12232,7 +12232,7 @@
           <p:cNvPr id="3" name="text">
             <a:extLst xmlns:a="http://schemas.openxmlformats.org/drawingml/2006/main">
               <a:ext uri="{FF2B5EF4-FFF2-40B4-BE49-F238E27FC236}">
-                <a16:creationId xmlns:a16="http://schemas.microsoft.com/office/drawing/2014/main" id="{EDAB1031-E019-45D5-BA9D-112BC06A9F38}"/>
+                <a16:creationId xmlns:a16="http://schemas.microsoft.com/office/drawing/2014/main" id="{98E4D2FF-7635-485D-AF53-2346AB34F56C}"/>
               </a:ext>
             </a:extLst>
           </p:cNvPr>
@@ -12289,7 +12289,7 @@
           <p:cNvPr id="4" name="text">
             <a:extLst xmlns:a="http://schemas.openxmlformats.org/drawingml/2006/main">
               <a:ext uri="{FF2B5EF4-FFF2-40B4-BE49-F238E27FC236}">
-                <a16:creationId xmlns:a16="http://schemas.microsoft.com/office/drawing/2014/main" id="{DE9FA2D5-31A9-42A6-A7E5-3EE1D101CC76}"/>
+                <a16:creationId xmlns:a16="http://schemas.microsoft.com/office/drawing/2014/main" id="{851210B8-4624-42F4-9519-53037C6D460B}"/>
               </a:ext>
             </a:extLst>
           </p:cNvPr>
@@ -12346,7 +12346,7 @@
           <p:cNvPr id="5" name="text">
             <a:extLst xmlns:a="http://schemas.openxmlformats.org/drawingml/2006/main">
               <a:ext uri="{FF2B5EF4-FFF2-40B4-BE49-F238E27FC236}">
-                <a16:creationId xmlns:a16="http://schemas.microsoft.com/office/drawing/2014/main" id="{1F29721D-E6F5-4ED9-A7D9-1A4BFF2F0437}"/>
+                <a16:creationId xmlns:a16="http://schemas.microsoft.com/office/drawing/2014/main" id="{2508F265-A3D0-47A1-8611-B1FAFCEB0B2B}"/>
               </a:ext>
             </a:extLst>
           </p:cNvPr>
@@ -12403,7 +12403,7 @@
           <p:cNvPr id="6" name="text">
             <a:extLst xmlns:a="http://schemas.openxmlformats.org/drawingml/2006/main">
               <a:ext uri="{FF2B5EF4-FFF2-40B4-BE49-F238E27FC236}">
-                <a16:creationId xmlns:a16="http://schemas.microsoft.com/office/drawing/2014/main" id="{74A4F7C9-CE16-4C0F-841B-E53E9F05E6CF}"/>
+                <a16:creationId xmlns:a16="http://schemas.microsoft.com/office/drawing/2014/main" id="{77E310D3-07FA-448D-A3D3-16A42FFC1B2C}"/>
               </a:ext>
             </a:extLst>
           </p:cNvPr>
@@ -12460,7 +12460,7 @@
           <p:cNvPr id="7" name="text">
             <a:extLst xmlns:a="http://schemas.openxmlformats.org/drawingml/2006/main">
               <a:ext uri="{FF2B5EF4-FFF2-40B4-BE49-F238E27FC236}">
-                <a16:creationId xmlns:a16="http://schemas.microsoft.com/office/drawing/2014/main" id="{48A96BAA-D1F4-4D0C-BF44-A291787EE15F}"/>
+                <a16:creationId xmlns:a16="http://schemas.microsoft.com/office/drawing/2014/main" id="{1320166C-A90C-4AB3-BD12-5575C19C8ADF}"/>
               </a:ext>
             </a:extLst>
           </p:cNvPr>
@@ -12517,7 +12517,7 @@
           <p:cNvPr id="8" name="text">
             <a:extLst xmlns:a="http://schemas.openxmlformats.org/drawingml/2006/main">
               <a:ext uri="{FF2B5EF4-FFF2-40B4-BE49-F238E27FC236}">
-                <a16:creationId xmlns:a16="http://schemas.microsoft.com/office/drawing/2014/main" id="{9B9E1B97-44E2-4CD9-8315-DBA5611AEDD9}"/>
+                <a16:creationId xmlns:a16="http://schemas.microsoft.com/office/drawing/2014/main" id="{4A868DEE-2E91-40FE-AF16-3E46C149E652}"/>
               </a:ext>
             </a:extLst>
           </p:cNvPr>
@@ -12574,7 +12574,7 @@
           <p:cNvPr id="9" name="Slide number">
             <a:extLst xmlns:a="http://schemas.openxmlformats.org/drawingml/2006/main">
               <a:ext uri="{FF2B5EF4-FFF2-40B4-BE49-F238E27FC236}">
-                <a16:creationId xmlns:a16="http://schemas.microsoft.com/office/drawing/2014/main" id="{6A2B5F3A-E39D-470C-907C-3D19CB70EC99}"/>
+                <a16:creationId xmlns:a16="http://schemas.microsoft.com/office/drawing/2014/main" id="{97912DBA-7877-4B15-AA47-D39C7C3C25DB}"/>
               </a:ext>
             </a:extLst>
           </p:cNvPr>
@@ -12629,7 +12629,7 @@
     </p:spTree>
     <p:extLst>
       <p:ext uri="{BB962C8B-B14F-4D97-AF65-F5344CB8AC3E}">
-        <p14:creationId xmlns:p14="http://schemas.microsoft.com/office/powerpoint/2010/main" val="1578030420"/>
+        <p14:creationId xmlns:p14="http://schemas.microsoft.com/office/powerpoint/2010/main" val="1730577385"/>
       </p:ext>
     </p:extLst>
   </p:cSld>
@@ -12660,7 +12660,7 @@
           <p:cNvPr id="15" name="Completed section 0">
             <a:extLst xmlns:a="http://schemas.openxmlformats.org/drawingml/2006/main">
               <a:ext uri="{FF2B5EF4-FFF2-40B4-BE49-F238E27FC236}">
-                <a16:creationId xmlns:a16="http://schemas.microsoft.com/office/drawing/2014/main" id="{2EDAE210-7C39-4AF6-AB96-C5F69DD675EC}"/>
+                <a16:creationId xmlns:a16="http://schemas.microsoft.com/office/drawing/2014/main" id="{D9DEE9C0-9F69-4DC3-A44E-C36046A6D9D6}"/>
               </a:ext>
             </a:extLst>
           </p:cNvPr>
@@ -12717,7 +12717,7 @@
           <p:cNvPr id="2" name="Section description 0">
             <a:extLst xmlns:a="http://schemas.openxmlformats.org/drawingml/2006/main">
               <a:ext uri="{FF2B5EF4-FFF2-40B4-BE49-F238E27FC236}">
-                <a16:creationId xmlns:a16="http://schemas.microsoft.com/office/drawing/2014/main" id="{E884C0E5-DBBC-4265-9ACF-D53BE47DB95A}"/>
+                <a16:creationId xmlns:a16="http://schemas.microsoft.com/office/drawing/2014/main" id="{B7B9036F-8B24-4C5E-9BC0-D007BAD7F420}"/>
               </a:ext>
             </a:extLst>
           </p:cNvPr>
@@ -12774,7 +12774,7 @@
           <p:cNvPr id="3" name="Completed section 1">
             <a:extLst xmlns:a="http://schemas.openxmlformats.org/drawingml/2006/main">
               <a:ext uri="{FF2B5EF4-FFF2-40B4-BE49-F238E27FC236}">
-                <a16:creationId xmlns:a16="http://schemas.microsoft.com/office/drawing/2014/main" id="{731D8800-0260-4364-8C5A-D0D26458034B}"/>
+                <a16:creationId xmlns:a16="http://schemas.microsoft.com/office/drawing/2014/main" id="{A7BD2E91-E187-42C0-99D7-E5F726011265}"/>
               </a:ext>
             </a:extLst>
           </p:cNvPr>
@@ -12831,7 +12831,7 @@
           <p:cNvPr id="4" name="Section description 1">
             <a:extLst xmlns:a="http://schemas.openxmlformats.org/drawingml/2006/main">
               <a:ext uri="{FF2B5EF4-FFF2-40B4-BE49-F238E27FC236}">
-                <a16:creationId xmlns:a16="http://schemas.microsoft.com/office/drawing/2014/main" id="{015E0F2B-0759-467C-B41C-8461B42AE142}"/>
+                <a16:creationId xmlns:a16="http://schemas.microsoft.com/office/drawing/2014/main" id="{28D05F98-DB0A-49AF-ABF4-3EDF8CB9033E}"/>
               </a:ext>
             </a:extLst>
           </p:cNvPr>
@@ -12888,7 +12888,7 @@
           <p:cNvPr id="5" name="Completed section 2">
             <a:extLst xmlns:a="http://schemas.openxmlformats.org/drawingml/2006/main">
               <a:ext uri="{FF2B5EF4-FFF2-40B4-BE49-F238E27FC236}">
-                <a16:creationId xmlns:a16="http://schemas.microsoft.com/office/drawing/2014/main" id="{E2A34BD0-A58A-400F-B6AF-A7D5F51D73E5}"/>
+                <a16:creationId xmlns:a16="http://schemas.microsoft.com/office/drawing/2014/main" id="{B6163F1E-8121-4686-B1E7-C0416190F810}"/>
               </a:ext>
             </a:extLst>
           </p:cNvPr>
@@ -12945,7 +12945,7 @@
           <p:cNvPr id="6" name="Section description 2">
             <a:extLst xmlns:a="http://schemas.openxmlformats.org/drawingml/2006/main">
               <a:ext uri="{FF2B5EF4-FFF2-40B4-BE49-F238E27FC236}">
-                <a16:creationId xmlns:a16="http://schemas.microsoft.com/office/drawing/2014/main" id="{6D72708E-30ED-4CC4-B9E3-367B449D7738}"/>
+                <a16:creationId xmlns:a16="http://schemas.microsoft.com/office/drawing/2014/main" id="{8C14C502-40E4-434F-8849-11B8E4BAA1A6}"/>
               </a:ext>
             </a:extLst>
           </p:cNvPr>
@@ -13002,7 +13002,7 @@
           <p:cNvPr id="7" name="Completed section 3">
             <a:extLst xmlns:a="http://schemas.openxmlformats.org/drawingml/2006/main">
               <a:ext uri="{FF2B5EF4-FFF2-40B4-BE49-F238E27FC236}">
-                <a16:creationId xmlns:a16="http://schemas.microsoft.com/office/drawing/2014/main" id="{A2E76956-F687-4DC5-B49E-DF769F2ACAE3}"/>
+                <a16:creationId xmlns:a16="http://schemas.microsoft.com/office/drawing/2014/main" id="{C613CBB6-1B67-4BFA-865B-5958439151C2}"/>
               </a:ext>
             </a:extLst>
           </p:cNvPr>
@@ -13059,7 +13059,7 @@
           <p:cNvPr id="8" name="Section description 3">
             <a:extLst xmlns:a="http://schemas.openxmlformats.org/drawingml/2006/main">
               <a:ext uri="{FF2B5EF4-FFF2-40B4-BE49-F238E27FC236}">
-                <a16:creationId xmlns:a16="http://schemas.microsoft.com/office/drawing/2014/main" id="{E037437C-2F5A-4B22-91E2-8CC705DC50AA}"/>
+                <a16:creationId xmlns:a16="http://schemas.microsoft.com/office/drawing/2014/main" id="{4F1A04CF-6818-4C2A-8CC8-7B4B52E8D46D}"/>
               </a:ext>
             </a:extLst>
           </p:cNvPr>
@@ -13116,7 +13116,7 @@
           <p:cNvPr id="9" name="Completed section 4">
             <a:extLst xmlns:a="http://schemas.openxmlformats.org/drawingml/2006/main">
               <a:ext uri="{FF2B5EF4-FFF2-40B4-BE49-F238E27FC236}">
-                <a16:creationId xmlns:a16="http://schemas.microsoft.com/office/drawing/2014/main" id="{4B896032-36B8-4422-B778-70ECAC58C3F0}"/>
+                <a16:creationId xmlns:a16="http://schemas.microsoft.com/office/drawing/2014/main" id="{AF47410F-2720-4099-8FB1-9AF8D9C7E3ED}"/>
               </a:ext>
             </a:extLst>
           </p:cNvPr>
@@ -13173,7 +13173,7 @@
           <p:cNvPr id="10" name="Section description 4">
             <a:extLst xmlns:a="http://schemas.openxmlformats.org/drawingml/2006/main">
               <a:ext uri="{FF2B5EF4-FFF2-40B4-BE49-F238E27FC236}">
-                <a16:creationId xmlns:a16="http://schemas.microsoft.com/office/drawing/2014/main" id="{08DAE03A-4941-41AA-B0C3-4213FA307BF2}"/>
+                <a16:creationId xmlns:a16="http://schemas.microsoft.com/office/drawing/2014/main" id="{5F300C54-1D35-429C-B3F8-79D1310D0C36}"/>
               </a:ext>
             </a:extLst>
           </p:cNvPr>
@@ -13230,7 +13230,7 @@
           <p:cNvPr id="11" name="Active section">
             <a:extLst xmlns:a="http://schemas.openxmlformats.org/drawingml/2006/main">
               <a:ext uri="{FF2B5EF4-FFF2-40B4-BE49-F238E27FC236}">
-                <a16:creationId xmlns:a16="http://schemas.microsoft.com/office/drawing/2014/main" id="{10EDF5AD-BCDE-4D3C-9DD6-34AB488D7524}"/>
+                <a16:creationId xmlns:a16="http://schemas.microsoft.com/office/drawing/2014/main" id="{3B3CB8F7-0F04-4874-B2C0-F8A0163112D5}"/>
               </a:ext>
             </a:extLst>
           </p:cNvPr>
@@ -13287,7 +13287,7 @@
           <p:cNvPr id="12" name="Section description 5">
             <a:extLst xmlns:a="http://schemas.openxmlformats.org/drawingml/2006/main">
               <a:ext uri="{FF2B5EF4-FFF2-40B4-BE49-F238E27FC236}">
-                <a16:creationId xmlns:a16="http://schemas.microsoft.com/office/drawing/2014/main" id="{A9CF712D-FC6C-4184-93E0-DC1F6A9A0BF9}"/>
+                <a16:creationId xmlns:a16="http://schemas.microsoft.com/office/drawing/2014/main" id="{82EC4AC3-ED31-4883-8E07-11B559B08695}"/>
               </a:ext>
             </a:extLst>
           </p:cNvPr>
@@ -13348,7 +13348,7 @@
           <p:nvPr/>
         </p:nvPicPr>
         <p:blipFill>
-          <a:blip xmlns:r="http://schemas.openxmlformats.org/officeDocument/2006/relationships" xmlns:a="http://schemas.openxmlformats.org/drawingml/2006/main" r:embed="Rfa0bdecf16ae49e8"/>
+          <a:blip xmlns:r="http://schemas.openxmlformats.org/officeDocument/2006/relationships" xmlns:a="http://schemas.openxmlformats.org/drawingml/2006/main" r:embed="R0e533cd528724968"/>
           <a:stretch xmlns:a="http://schemas.openxmlformats.org/drawingml/2006/main"/>
         </p:blipFill>
         <p:spPr>
@@ -13366,7 +13366,7 @@
           <p:cNvPr id="14" name="Slide number">
             <a:extLst xmlns:a="http://schemas.openxmlformats.org/drawingml/2006/main">
               <a:ext uri="{FF2B5EF4-FFF2-40B4-BE49-F238E27FC236}">
-                <a16:creationId xmlns:a16="http://schemas.microsoft.com/office/drawing/2014/main" id="{5677392C-03C9-4BAD-B189-1C0379C5C60D}"/>
+                <a16:creationId xmlns:a16="http://schemas.microsoft.com/office/drawing/2014/main" id="{E04CDF84-E0BF-4216-807E-4F5D731F82CD}"/>
               </a:ext>
             </a:extLst>
           </p:cNvPr>
@@ -13421,7 +13421,7 @@
     </p:spTree>
     <p:extLst>
       <p:ext uri="{BB962C8B-B14F-4D97-AF65-F5344CB8AC3E}">
-        <p14:creationId xmlns:p14="http://schemas.microsoft.com/office/powerpoint/2010/main" val="1221296452"/>
+        <p14:creationId xmlns:p14="http://schemas.microsoft.com/office/powerpoint/2010/main" val="1338003675"/>
       </p:ext>
     </p:extLst>
   </p:cSld>
@@ -13452,7 +13452,7 @@
           <p:cNvPr id="14" name="Title">
             <a:extLst xmlns:a="http://schemas.openxmlformats.org/drawingml/2006/main">
               <a:ext uri="{FF2B5EF4-FFF2-40B4-BE49-F238E27FC236}">
-                <a16:creationId xmlns:a16="http://schemas.microsoft.com/office/drawing/2014/main" id="{1AF6DBF1-88C0-4C0A-8FA0-81F742815D1C}"/>
+                <a16:creationId xmlns:a16="http://schemas.microsoft.com/office/drawing/2014/main" id="{B6043D4E-264D-414E-83F7-554C71F47F4A}"/>
               </a:ext>
             </a:extLst>
           </p:cNvPr>
@@ -13509,7 +13509,7 @@
           <p:cNvPr id="2" name="text">
             <a:extLst xmlns:a="http://schemas.openxmlformats.org/drawingml/2006/main">
               <a:ext uri="{FF2B5EF4-FFF2-40B4-BE49-F238E27FC236}">
-                <a16:creationId xmlns:a16="http://schemas.microsoft.com/office/drawing/2014/main" id="{C9BA4B5D-B092-4518-9333-81EC90A4B77F}"/>
+                <a16:creationId xmlns:a16="http://schemas.microsoft.com/office/drawing/2014/main" id="{4BACF18E-81A4-4B76-8774-AA6B60C5A69F}"/>
               </a:ext>
             </a:extLst>
           </p:cNvPr>
@@ -13566,7 +13566,7 @@
           <p:cNvPr id="3" name="text">
             <a:extLst xmlns:a="http://schemas.openxmlformats.org/drawingml/2006/main">
               <a:ext uri="{FF2B5EF4-FFF2-40B4-BE49-F238E27FC236}">
-                <a16:creationId xmlns:a16="http://schemas.microsoft.com/office/drawing/2014/main" id="{F4A6D235-ABC8-458A-9189-69D5D773C64B}"/>
+                <a16:creationId xmlns:a16="http://schemas.microsoft.com/office/drawing/2014/main" id="{BF6C977D-1B37-4CBD-A194-DB5F37156548}"/>
               </a:ext>
             </a:extLst>
           </p:cNvPr>
@@ -13623,7 +13623,7 @@
           <p:cNvPr id="4" name="text">
             <a:extLst xmlns:a="http://schemas.openxmlformats.org/drawingml/2006/main">
               <a:ext uri="{FF2B5EF4-FFF2-40B4-BE49-F238E27FC236}">
-                <a16:creationId xmlns:a16="http://schemas.microsoft.com/office/drawing/2014/main" id="{B4C4914D-A5FD-4F9A-9ADE-A345918511B9}"/>
+                <a16:creationId xmlns:a16="http://schemas.microsoft.com/office/drawing/2014/main" id="{132E95C9-345B-4010-9682-BFA84DDA5845}"/>
               </a:ext>
             </a:extLst>
           </p:cNvPr>
@@ -13680,7 +13680,7 @@
           <p:cNvPr id="5" name="text">
             <a:extLst xmlns:a="http://schemas.openxmlformats.org/drawingml/2006/main">
               <a:ext uri="{FF2B5EF4-FFF2-40B4-BE49-F238E27FC236}">
-                <a16:creationId xmlns:a16="http://schemas.microsoft.com/office/drawing/2014/main" id="{C6A1C7DE-8240-40E5-812E-B274F3C392AD}"/>
+                <a16:creationId xmlns:a16="http://schemas.microsoft.com/office/drawing/2014/main" id="{A0FD5669-DDF3-438C-B925-981046442AD6}"/>
               </a:ext>
             </a:extLst>
           </p:cNvPr>
@@ -13737,7 +13737,7 @@
           <p:cNvPr id="6" name="text">
             <a:extLst xmlns:a="http://schemas.openxmlformats.org/drawingml/2006/main">
               <a:ext uri="{FF2B5EF4-FFF2-40B4-BE49-F238E27FC236}">
-                <a16:creationId xmlns:a16="http://schemas.microsoft.com/office/drawing/2014/main" id="{EF709B09-DDDE-4766-9E40-B1BA1031CC4E}"/>
+                <a16:creationId xmlns:a16="http://schemas.microsoft.com/office/drawing/2014/main" id="{A4483677-766E-4AE9-898A-953589D11FEE}"/>
               </a:ext>
             </a:extLst>
           </p:cNvPr>
@@ -13794,7 +13794,7 @@
           <p:cNvPr id="7" name="text">
             <a:extLst xmlns:a="http://schemas.openxmlformats.org/drawingml/2006/main">
               <a:ext uri="{FF2B5EF4-FFF2-40B4-BE49-F238E27FC236}">
-                <a16:creationId xmlns:a16="http://schemas.microsoft.com/office/drawing/2014/main" id="{0E201D42-5A77-4E5F-8094-05B1D89B952C}"/>
+                <a16:creationId xmlns:a16="http://schemas.microsoft.com/office/drawing/2014/main" id="{D5675EC1-8A34-4A4E-B99C-57AB06A2436A}"/>
               </a:ext>
             </a:extLst>
           </p:cNvPr>
@@ -13851,7 +13851,7 @@
           <p:cNvPr id="8" name="text">
             <a:extLst xmlns:a="http://schemas.openxmlformats.org/drawingml/2006/main">
               <a:ext uri="{FF2B5EF4-FFF2-40B4-BE49-F238E27FC236}">
-                <a16:creationId xmlns:a16="http://schemas.microsoft.com/office/drawing/2014/main" id="{A5E0F26C-0988-43B0-AC9A-48D62E9EF549}"/>
+                <a16:creationId xmlns:a16="http://schemas.microsoft.com/office/drawing/2014/main" id="{A58F4555-D14A-4016-81C6-42AA841A1675}"/>
               </a:ext>
             </a:extLst>
           </p:cNvPr>
@@ -13908,7 +13908,7 @@
           <p:cNvPr id="9" name="text">
             <a:extLst xmlns:a="http://schemas.openxmlformats.org/drawingml/2006/main">
               <a:ext uri="{FF2B5EF4-FFF2-40B4-BE49-F238E27FC236}">
-                <a16:creationId xmlns:a16="http://schemas.microsoft.com/office/drawing/2014/main" id="{4E7C2EEF-4ECB-451A-9B87-28B8A6A6C3D1}"/>
+                <a16:creationId xmlns:a16="http://schemas.microsoft.com/office/drawing/2014/main" id="{92800D96-01A6-4398-9F3E-77745D32EDC6}"/>
               </a:ext>
             </a:extLst>
           </p:cNvPr>
@@ -13965,7 +13965,7 @@
           <p:cNvPr id="10" name="text">
             <a:extLst xmlns:a="http://schemas.openxmlformats.org/drawingml/2006/main">
               <a:ext uri="{FF2B5EF4-FFF2-40B4-BE49-F238E27FC236}">
-                <a16:creationId xmlns:a16="http://schemas.microsoft.com/office/drawing/2014/main" id="{E01D2AED-CEDD-4F88-A3ED-1B61C06D46C0}"/>
+                <a16:creationId xmlns:a16="http://schemas.microsoft.com/office/drawing/2014/main" id="{2CA261FB-8648-419C-8D96-B4FEC1453982}"/>
               </a:ext>
             </a:extLst>
           </p:cNvPr>
@@ -14022,7 +14022,7 @@
           <p:cNvPr id="11" name="text">
             <a:extLst xmlns:a="http://schemas.openxmlformats.org/drawingml/2006/main">
               <a:ext uri="{FF2B5EF4-FFF2-40B4-BE49-F238E27FC236}">
-                <a16:creationId xmlns:a16="http://schemas.microsoft.com/office/drawing/2014/main" id="{0EBBADCF-328C-4414-B802-0E6EDC92AED1}"/>
+                <a16:creationId xmlns:a16="http://schemas.microsoft.com/office/drawing/2014/main" id="{449CEC6D-DCDD-4BB1-AF76-0DC35D7E27B4}"/>
               </a:ext>
             </a:extLst>
           </p:cNvPr>
@@ -14079,7 +14079,7 @@
           <p:cNvPr id="12" name="text">
             <a:extLst xmlns:a="http://schemas.openxmlformats.org/drawingml/2006/main">
               <a:ext uri="{FF2B5EF4-FFF2-40B4-BE49-F238E27FC236}">
-                <a16:creationId xmlns:a16="http://schemas.microsoft.com/office/drawing/2014/main" id="{66CDFA8D-1554-410C-BCC1-BDB5594DEB1F}"/>
+                <a16:creationId xmlns:a16="http://schemas.microsoft.com/office/drawing/2014/main" id="{C7F77088-297B-48DD-AA20-FE4DEC91BF58}"/>
               </a:ext>
             </a:extLst>
           </p:cNvPr>
@@ -14136,7 +14136,7 @@
           <p:cNvPr id="13" name="Slide number">
             <a:extLst xmlns:a="http://schemas.openxmlformats.org/drawingml/2006/main">
               <a:ext uri="{FF2B5EF4-FFF2-40B4-BE49-F238E27FC236}">
-                <a16:creationId xmlns:a16="http://schemas.microsoft.com/office/drawing/2014/main" id="{9611F3A9-409B-46C4-97E8-9068909AC1AD}"/>
+                <a16:creationId xmlns:a16="http://schemas.microsoft.com/office/drawing/2014/main" id="{ECC5B932-AB8B-4505-B135-E597ACAE8066}"/>
               </a:ext>
             </a:extLst>
           </p:cNvPr>
@@ -14191,7 +14191,7 @@
     </p:spTree>
     <p:extLst>
       <p:ext uri="{BB962C8B-B14F-4D97-AF65-F5344CB8AC3E}">
-        <p14:creationId xmlns:p14="http://schemas.microsoft.com/office/powerpoint/2010/main" val="19839791"/>
+        <p14:creationId xmlns:p14="http://schemas.microsoft.com/office/powerpoint/2010/main" val="760796427"/>
       </p:ext>
     </p:extLst>
   </p:cSld>
@@ -14222,7 +14222,7 @@
           <p:cNvPr id="9" name="Title">
             <a:extLst xmlns:a="http://schemas.openxmlformats.org/drawingml/2006/main">
               <a:ext uri="{FF2B5EF4-FFF2-40B4-BE49-F238E27FC236}">
-                <a16:creationId xmlns:a16="http://schemas.microsoft.com/office/drawing/2014/main" id="{45157D8D-D6F6-4528-9EBD-30551F797CAC}"/>
+                <a16:creationId xmlns:a16="http://schemas.microsoft.com/office/drawing/2014/main" id="{7DF88359-A1C2-41C8-A441-C8A3A2ED5DB7}"/>
               </a:ext>
             </a:extLst>
           </p:cNvPr>
@@ -14286,7 +14286,7 @@
         </p:xfrm>
         <a:graphic xmlns:a="http://schemas.openxmlformats.org/drawingml/2006/main">
           <a:graphicData uri="http://schemas.openxmlformats.org/drawingml/2006/chart">
-            <c:chart xmlns:r="http://schemas.openxmlformats.org/officeDocument/2006/relationships" xmlns:c="http://schemas.openxmlformats.org/drawingml/2006/chart" r:id="Rfb0cb4ca1ebf4843"/>
+            <c:chart xmlns:r="http://schemas.openxmlformats.org/officeDocument/2006/relationships" xmlns:c="http://schemas.openxmlformats.org/drawingml/2006/chart" r:id="R469fd70a437e45df"/>
           </a:graphicData>
         </a:graphic>
       </p:graphicFrame>
@@ -14295,7 +14295,7 @@
           <p:cNvPr id="3" name="Date label">
             <a:extLst xmlns:a="http://schemas.openxmlformats.org/drawingml/2006/main">
               <a:ext uri="{FF2B5EF4-FFF2-40B4-BE49-F238E27FC236}">
-                <a16:creationId xmlns:a16="http://schemas.microsoft.com/office/drawing/2014/main" id="{4D94CFA1-ACE0-41FD-A9B1-FDA327B2643E}"/>
+                <a16:creationId xmlns:a16="http://schemas.microsoft.com/office/drawing/2014/main" id="{5B2E91A6-D789-48D6-85FA-C98EA41412E5}"/>
               </a:ext>
             </a:extLst>
           </p:cNvPr>
@@ -14352,7 +14352,7 @@
           <p:cNvPr id="4" name="Date label">
             <a:extLst xmlns:a="http://schemas.openxmlformats.org/drawingml/2006/main">
               <a:ext uri="{FF2B5EF4-FFF2-40B4-BE49-F238E27FC236}">
-                <a16:creationId xmlns:a16="http://schemas.microsoft.com/office/drawing/2014/main" id="{DB28A6E3-C469-4490-B863-A7382EB6DD44}"/>
+                <a16:creationId xmlns:a16="http://schemas.microsoft.com/office/drawing/2014/main" id="{93582CE6-ECDD-4331-B945-FFE9B1186668}"/>
               </a:ext>
             </a:extLst>
           </p:cNvPr>
@@ -14409,7 +14409,7 @@
           <p:cNvPr id="5" name="Date label">
             <a:extLst xmlns:a="http://schemas.openxmlformats.org/drawingml/2006/main">
               <a:ext uri="{FF2B5EF4-FFF2-40B4-BE49-F238E27FC236}">
-                <a16:creationId xmlns:a16="http://schemas.microsoft.com/office/drawing/2014/main" id="{A9888C04-A8FA-4171-A270-804B58A6E3AA}"/>
+                <a16:creationId xmlns:a16="http://schemas.microsoft.com/office/drawing/2014/main" id="{D7068799-FE5B-442D-BDD5-A36D6C4A625D}"/>
               </a:ext>
             </a:extLst>
           </p:cNvPr>
@@ -14466,7 +14466,7 @@
           <p:cNvPr id="6" name="Date label">
             <a:extLst xmlns:a="http://schemas.openxmlformats.org/drawingml/2006/main">
               <a:ext uri="{FF2B5EF4-FFF2-40B4-BE49-F238E27FC236}">
-                <a16:creationId xmlns:a16="http://schemas.microsoft.com/office/drawing/2014/main" id="{04B11676-61E6-45EC-909C-4950D4466B67}"/>
+                <a16:creationId xmlns:a16="http://schemas.microsoft.com/office/drawing/2014/main" id="{44847058-4B98-4608-82E9-C138B1274AEB}"/>
               </a:ext>
             </a:extLst>
           </p:cNvPr>
@@ -14523,7 +14523,7 @@
           <p:cNvPr id="7" name="Methodology">
             <a:extLst xmlns:a="http://schemas.openxmlformats.org/drawingml/2006/main">
               <a:ext uri="{FF2B5EF4-FFF2-40B4-BE49-F238E27FC236}">
-                <a16:creationId xmlns:a16="http://schemas.microsoft.com/office/drawing/2014/main" id="{42EC145A-CE76-4211-ABDA-5B58747E1698}"/>
+                <a16:creationId xmlns:a16="http://schemas.microsoft.com/office/drawing/2014/main" id="{A4113382-BEAE-417A-8BBE-5DA0E49BEC3B}"/>
               </a:ext>
             </a:extLst>
           </p:cNvPr>
@@ -14603,7 +14603,7 @@
           <p:cNvPr id="8" name="Slide number">
             <a:extLst xmlns:a="http://schemas.openxmlformats.org/drawingml/2006/main">
               <a:ext uri="{FF2B5EF4-FFF2-40B4-BE49-F238E27FC236}">
-                <a16:creationId xmlns:a16="http://schemas.microsoft.com/office/drawing/2014/main" id="{4A3BC585-FC2F-48D4-BBDE-240EA5C8AE2E}"/>
+                <a16:creationId xmlns:a16="http://schemas.microsoft.com/office/drawing/2014/main" id="{5733A80F-1CF3-4105-AD0C-32FDDBE06779}"/>
               </a:ext>
             </a:extLst>
           </p:cNvPr>
@@ -14658,7 +14658,7 @@
     </p:spTree>
     <p:extLst>
       <p:ext uri="{BB962C8B-B14F-4D97-AF65-F5344CB8AC3E}">
-        <p14:creationId xmlns:p14="http://schemas.microsoft.com/office/powerpoint/2010/main" val="659791837"/>
+        <p14:creationId xmlns:p14="http://schemas.microsoft.com/office/powerpoint/2010/main" val="1842320157"/>
       </p:ext>
     </p:extLst>
   </p:cSld>
@@ -14689,7 +14689,7 @@
           <p:cNvPr id="16" name="Completed section 0">
             <a:extLst xmlns:a="http://schemas.openxmlformats.org/drawingml/2006/main">
               <a:ext uri="{FF2B5EF4-FFF2-40B4-BE49-F238E27FC236}">
-                <a16:creationId xmlns:a16="http://schemas.microsoft.com/office/drawing/2014/main" id="{8DBE2E48-E4D6-4746-8932-5737ACD95A85}"/>
+                <a16:creationId xmlns:a16="http://schemas.microsoft.com/office/drawing/2014/main" id="{C05BAAF9-C430-4B99-8790-EF4D9E462744}"/>
               </a:ext>
             </a:extLst>
           </p:cNvPr>
@@ -14746,7 +14746,7 @@
           <p:cNvPr id="2" name="Section description 0">
             <a:extLst xmlns:a="http://schemas.openxmlformats.org/drawingml/2006/main">
               <a:ext uri="{FF2B5EF4-FFF2-40B4-BE49-F238E27FC236}">
-                <a16:creationId xmlns:a16="http://schemas.microsoft.com/office/drawing/2014/main" id="{20ABC02C-6451-47D7-9FCE-0880AB60BDD4}"/>
+                <a16:creationId xmlns:a16="http://schemas.microsoft.com/office/drawing/2014/main" id="{BA89438F-5273-43B7-B830-A66020472744}"/>
               </a:ext>
             </a:extLst>
           </p:cNvPr>
@@ -14803,7 +14803,7 @@
           <p:cNvPr id="3" name="Completed section 1">
             <a:extLst xmlns:a="http://schemas.openxmlformats.org/drawingml/2006/main">
               <a:ext uri="{FF2B5EF4-FFF2-40B4-BE49-F238E27FC236}">
-                <a16:creationId xmlns:a16="http://schemas.microsoft.com/office/drawing/2014/main" id="{23DE937B-A4A1-4567-8CE7-854939C60358}"/>
+                <a16:creationId xmlns:a16="http://schemas.microsoft.com/office/drawing/2014/main" id="{F8B574E2-3928-4309-8EF5-B91B08FB0176}"/>
               </a:ext>
             </a:extLst>
           </p:cNvPr>
@@ -14860,7 +14860,7 @@
           <p:cNvPr id="4" name="Section description 1">
             <a:extLst xmlns:a="http://schemas.openxmlformats.org/drawingml/2006/main">
               <a:ext uri="{FF2B5EF4-FFF2-40B4-BE49-F238E27FC236}">
-                <a16:creationId xmlns:a16="http://schemas.microsoft.com/office/drawing/2014/main" id="{BB542C8E-2AB3-4F3D-AA58-F9B6FFB04BE4}"/>
+                <a16:creationId xmlns:a16="http://schemas.microsoft.com/office/drawing/2014/main" id="{80CFB9E1-11AB-43BB-802B-74C6D726BE12}"/>
               </a:ext>
             </a:extLst>
           </p:cNvPr>
@@ -14917,7 +14917,7 @@
           <p:cNvPr id="5" name="Completed section 2">
             <a:extLst xmlns:a="http://schemas.openxmlformats.org/drawingml/2006/main">
               <a:ext uri="{FF2B5EF4-FFF2-40B4-BE49-F238E27FC236}">
-                <a16:creationId xmlns:a16="http://schemas.microsoft.com/office/drawing/2014/main" id="{491B462A-25B8-419C-909C-EB4463271457}"/>
+                <a16:creationId xmlns:a16="http://schemas.microsoft.com/office/drawing/2014/main" id="{B60279A3-48FB-4DFE-BE25-2E9E5CF1ABB7}"/>
               </a:ext>
             </a:extLst>
           </p:cNvPr>
@@ -14974,7 +14974,7 @@
           <p:cNvPr id="6" name="Section description 2">
             <a:extLst xmlns:a="http://schemas.openxmlformats.org/drawingml/2006/main">
               <a:ext uri="{FF2B5EF4-FFF2-40B4-BE49-F238E27FC236}">
-                <a16:creationId xmlns:a16="http://schemas.microsoft.com/office/drawing/2014/main" id="{21DCD568-1F14-4020-8450-5833B9C8C50B}"/>
+                <a16:creationId xmlns:a16="http://schemas.microsoft.com/office/drawing/2014/main" id="{F90C1663-2325-4625-BA03-DE1073F6CD8C}"/>
               </a:ext>
             </a:extLst>
           </p:cNvPr>
@@ -15031,7 +15031,7 @@
           <p:cNvPr id="7" name="Completed section 3">
             <a:extLst xmlns:a="http://schemas.openxmlformats.org/drawingml/2006/main">
               <a:ext uri="{FF2B5EF4-FFF2-40B4-BE49-F238E27FC236}">
-                <a16:creationId xmlns:a16="http://schemas.microsoft.com/office/drawing/2014/main" id="{BBD32A9E-AFCC-437F-99CE-8919421FAAB6}"/>
+                <a16:creationId xmlns:a16="http://schemas.microsoft.com/office/drawing/2014/main" id="{1EFDB821-2C3E-4B51-AD9C-4136ACF427ED}"/>
               </a:ext>
             </a:extLst>
           </p:cNvPr>
@@ -15088,7 +15088,7 @@
           <p:cNvPr id="8" name="Section description 3">
             <a:extLst xmlns:a="http://schemas.openxmlformats.org/drawingml/2006/main">
               <a:ext uri="{FF2B5EF4-FFF2-40B4-BE49-F238E27FC236}">
-                <a16:creationId xmlns:a16="http://schemas.microsoft.com/office/drawing/2014/main" id="{9C81D5BE-56D5-482A-AFBE-64344AD75E19}"/>
+                <a16:creationId xmlns:a16="http://schemas.microsoft.com/office/drawing/2014/main" id="{BD740E3D-0099-434B-9142-3BD37880F7E8}"/>
               </a:ext>
             </a:extLst>
           </p:cNvPr>
@@ -15145,7 +15145,7 @@
           <p:cNvPr id="9" name="Completed section 4">
             <a:extLst xmlns:a="http://schemas.openxmlformats.org/drawingml/2006/main">
               <a:ext uri="{FF2B5EF4-FFF2-40B4-BE49-F238E27FC236}">
-                <a16:creationId xmlns:a16="http://schemas.microsoft.com/office/drawing/2014/main" id="{868F81CA-F535-4CCA-A11B-C71856154F91}"/>
+                <a16:creationId xmlns:a16="http://schemas.microsoft.com/office/drawing/2014/main" id="{73C550D0-6908-4E26-A2DA-2A31BAE5509C}"/>
               </a:ext>
             </a:extLst>
           </p:cNvPr>
@@ -15202,7 +15202,7 @@
           <p:cNvPr id="10" name="Section description 4">
             <a:extLst xmlns:a="http://schemas.openxmlformats.org/drawingml/2006/main">
               <a:ext uri="{FF2B5EF4-FFF2-40B4-BE49-F238E27FC236}">
-                <a16:creationId xmlns:a16="http://schemas.microsoft.com/office/drawing/2014/main" id="{ED2C9B76-2617-4C76-A369-626195CEE680}"/>
+                <a16:creationId xmlns:a16="http://schemas.microsoft.com/office/drawing/2014/main" id="{CF5735D2-06F6-4E02-A390-0156BC8E6289}"/>
               </a:ext>
             </a:extLst>
           </p:cNvPr>
@@ -15259,7 +15259,7 @@
           <p:cNvPr id="11" name="Completed section 5">
             <a:extLst xmlns:a="http://schemas.openxmlformats.org/drawingml/2006/main">
               <a:ext uri="{FF2B5EF4-FFF2-40B4-BE49-F238E27FC236}">
-                <a16:creationId xmlns:a16="http://schemas.microsoft.com/office/drawing/2014/main" id="{67F4A18F-E115-4779-B772-2A053D92FEF1}"/>
+                <a16:creationId xmlns:a16="http://schemas.microsoft.com/office/drawing/2014/main" id="{A8D7A771-7737-4E2D-8961-5BF87DA67EE2}"/>
               </a:ext>
             </a:extLst>
           </p:cNvPr>
@@ -15316,7 +15316,7 @@
           <p:cNvPr id="12" name="Section description 5">
             <a:extLst xmlns:a="http://schemas.openxmlformats.org/drawingml/2006/main">
               <a:ext uri="{FF2B5EF4-FFF2-40B4-BE49-F238E27FC236}">
-                <a16:creationId xmlns:a16="http://schemas.microsoft.com/office/drawing/2014/main" id="{57A9997D-B759-4AD4-A730-426DB68D3810}"/>
+                <a16:creationId xmlns:a16="http://schemas.microsoft.com/office/drawing/2014/main" id="{4B7C41BB-52D6-4AA2-8907-A159254D9ADC}"/>
               </a:ext>
             </a:extLst>
           </p:cNvPr>
@@ -15373,7 +15373,7 @@
           <p:cNvPr id="13" name="Active section">
             <a:extLst xmlns:a="http://schemas.openxmlformats.org/drawingml/2006/main">
               <a:ext uri="{FF2B5EF4-FFF2-40B4-BE49-F238E27FC236}">
-                <a16:creationId xmlns:a16="http://schemas.microsoft.com/office/drawing/2014/main" id="{3C069916-59D2-4530-B06C-DF3C4F705427}"/>
+                <a16:creationId xmlns:a16="http://schemas.microsoft.com/office/drawing/2014/main" id="{580604DE-B98F-456E-B46C-16C24F876153}"/>
               </a:ext>
             </a:extLst>
           </p:cNvPr>
@@ -15430,7 +15430,7 @@
           <p:cNvPr id="14" name="Section description 6">
             <a:extLst xmlns:a="http://schemas.openxmlformats.org/drawingml/2006/main">
               <a:ext uri="{FF2B5EF4-FFF2-40B4-BE49-F238E27FC236}">
-                <a16:creationId xmlns:a16="http://schemas.microsoft.com/office/drawing/2014/main" id="{DF4505B2-0B7C-48E6-AF52-82D0A2033001}"/>
+                <a16:creationId xmlns:a16="http://schemas.microsoft.com/office/drawing/2014/main" id="{32E89021-EC73-4EE8-A818-FFE6731A549B}"/>
               </a:ext>
             </a:extLst>
           </p:cNvPr>
@@ -15487,7 +15487,7 @@
           <p:cNvPr id="15" name="Slide number">
             <a:extLst xmlns:a="http://schemas.openxmlformats.org/drawingml/2006/main">
               <a:ext uri="{FF2B5EF4-FFF2-40B4-BE49-F238E27FC236}">
-                <a16:creationId xmlns:a16="http://schemas.microsoft.com/office/drawing/2014/main" id="{4C398D40-2CB2-4730-A79E-2386A17CB592}"/>
+                <a16:creationId xmlns:a16="http://schemas.microsoft.com/office/drawing/2014/main" id="{0BB63657-CE33-4A16-BCBE-7F33EDE570BC}"/>
               </a:ext>
             </a:extLst>
           </p:cNvPr>
@@ -15542,7 +15542,7 @@
     </p:spTree>
     <p:extLst>
       <p:ext uri="{BB962C8B-B14F-4D97-AF65-F5344CB8AC3E}">
-        <p14:creationId xmlns:p14="http://schemas.microsoft.com/office/powerpoint/2010/main" val="49434697"/>
+        <p14:creationId xmlns:p14="http://schemas.microsoft.com/office/powerpoint/2010/main" val="433574066"/>
       </p:ext>
     </p:extLst>
   </p:cSld>
@@ -15573,7 +15573,7 @@
           <p:cNvPr id="12" name="Title">
             <a:extLst xmlns:a="http://schemas.openxmlformats.org/drawingml/2006/main">
               <a:ext uri="{FF2B5EF4-FFF2-40B4-BE49-F238E27FC236}">
-                <a16:creationId xmlns:a16="http://schemas.microsoft.com/office/drawing/2014/main" id="{2B27D7BB-36BD-4438-BF51-8031BB4F0BCB}"/>
+                <a16:creationId xmlns:a16="http://schemas.microsoft.com/office/drawing/2014/main" id="{460380AE-2F09-4083-945F-AEED0575D956}"/>
               </a:ext>
             </a:extLst>
           </p:cNvPr>
@@ -15630,7 +15630,7 @@
           <p:cNvPr id="2" name="text">
             <a:extLst xmlns:a="http://schemas.openxmlformats.org/drawingml/2006/main">
               <a:ext uri="{FF2B5EF4-FFF2-40B4-BE49-F238E27FC236}">
-                <a16:creationId xmlns:a16="http://schemas.microsoft.com/office/drawing/2014/main" id="{9382F438-4CF1-4E11-975F-0C4D086FCCED}"/>
+                <a16:creationId xmlns:a16="http://schemas.microsoft.com/office/drawing/2014/main" id="{946E624A-9A94-4AB9-9E25-E7DB49EDC245}"/>
               </a:ext>
             </a:extLst>
           </p:cNvPr>
@@ -15687,7 +15687,7 @@
           <p:cNvPr id="3" name="text">
             <a:extLst xmlns:a="http://schemas.openxmlformats.org/drawingml/2006/main">
               <a:ext uri="{FF2B5EF4-FFF2-40B4-BE49-F238E27FC236}">
-                <a16:creationId xmlns:a16="http://schemas.microsoft.com/office/drawing/2014/main" id="{6CD22075-36EF-4A13-8CBA-20375B23F966}"/>
+                <a16:creationId xmlns:a16="http://schemas.microsoft.com/office/drawing/2014/main" id="{1FE80743-5D19-49E9-AAA3-792D06DDB898}"/>
               </a:ext>
             </a:extLst>
           </p:cNvPr>
@@ -15744,7 +15744,7 @@
           <p:cNvPr id="4" name="text">
             <a:extLst xmlns:a="http://schemas.openxmlformats.org/drawingml/2006/main">
               <a:ext uri="{FF2B5EF4-FFF2-40B4-BE49-F238E27FC236}">
-                <a16:creationId xmlns:a16="http://schemas.microsoft.com/office/drawing/2014/main" id="{D77F08F0-0F84-4FFA-AB90-9450C5D0BC51}"/>
+                <a16:creationId xmlns:a16="http://schemas.microsoft.com/office/drawing/2014/main" id="{0C3498E5-B588-4120-96E6-073AC1E76E91}"/>
               </a:ext>
             </a:extLst>
           </p:cNvPr>
@@ -15801,7 +15801,7 @@
           <p:cNvPr id="5" name="text">
             <a:extLst xmlns:a="http://schemas.openxmlformats.org/drawingml/2006/main">
               <a:ext uri="{FF2B5EF4-FFF2-40B4-BE49-F238E27FC236}">
-                <a16:creationId xmlns:a16="http://schemas.microsoft.com/office/drawing/2014/main" id="{4CAE414C-E959-419D-AD48-8EA1CC8FC821}"/>
+                <a16:creationId xmlns:a16="http://schemas.microsoft.com/office/drawing/2014/main" id="{E3B0728C-DA84-4263-8BA8-94653DD235B8}"/>
               </a:ext>
             </a:extLst>
           </p:cNvPr>
@@ -15858,7 +15858,7 @@
           <p:cNvPr id="6" name="text">
             <a:extLst xmlns:a="http://schemas.openxmlformats.org/drawingml/2006/main">
               <a:ext uri="{FF2B5EF4-FFF2-40B4-BE49-F238E27FC236}">
-                <a16:creationId xmlns:a16="http://schemas.microsoft.com/office/drawing/2014/main" id="{26C6FCE2-2F02-413C-B7E3-222BEE208E18}"/>
+                <a16:creationId xmlns:a16="http://schemas.microsoft.com/office/drawing/2014/main" id="{4F7B4BA6-3371-468C-8BB1-1626F57F1595}"/>
               </a:ext>
             </a:extLst>
           </p:cNvPr>
@@ -15915,7 +15915,7 @@
           <p:cNvPr id="7" name="text">
             <a:extLst xmlns:a="http://schemas.openxmlformats.org/drawingml/2006/main">
               <a:ext uri="{FF2B5EF4-FFF2-40B4-BE49-F238E27FC236}">
-                <a16:creationId xmlns:a16="http://schemas.microsoft.com/office/drawing/2014/main" id="{CA5647D2-4E83-446F-B3C4-06010A411E45}"/>
+                <a16:creationId xmlns:a16="http://schemas.microsoft.com/office/drawing/2014/main" id="{2DE1CCDD-8392-469A-90E0-1A7E7F2A5A9C}"/>
               </a:ext>
             </a:extLst>
           </p:cNvPr>
@@ -15972,7 +15972,7 @@
           <p:cNvPr id="8" name="text">
             <a:extLst xmlns:a="http://schemas.openxmlformats.org/drawingml/2006/main">
               <a:ext uri="{FF2B5EF4-FFF2-40B4-BE49-F238E27FC236}">
-                <a16:creationId xmlns:a16="http://schemas.microsoft.com/office/drawing/2014/main" id="{5841546A-515E-4CF2-A310-C9867CFD81E5}"/>
+                <a16:creationId xmlns:a16="http://schemas.microsoft.com/office/drawing/2014/main" id="{00373CA5-B788-425E-88CD-3C89ED768BBA}"/>
               </a:ext>
             </a:extLst>
           </p:cNvPr>
@@ -16029,7 +16029,7 @@
           <p:cNvPr id="9" name="text">
             <a:extLst xmlns:a="http://schemas.openxmlformats.org/drawingml/2006/main">
               <a:ext uri="{FF2B5EF4-FFF2-40B4-BE49-F238E27FC236}">
-                <a16:creationId xmlns:a16="http://schemas.microsoft.com/office/drawing/2014/main" id="{FC8C36EB-75C6-4DA6-AC06-9DEA83C3469B}"/>
+                <a16:creationId xmlns:a16="http://schemas.microsoft.com/office/drawing/2014/main" id="{72C242D0-84BC-49B2-8E61-71C0F6A4CFC0}"/>
               </a:ext>
             </a:extLst>
           </p:cNvPr>
@@ -16086,7 +16086,7 @@
           <p:cNvPr id="10" name="text">
             <a:extLst xmlns:a="http://schemas.openxmlformats.org/drawingml/2006/main">
               <a:ext uri="{FF2B5EF4-FFF2-40B4-BE49-F238E27FC236}">
-                <a16:creationId xmlns:a16="http://schemas.microsoft.com/office/drawing/2014/main" id="{84BA36EA-F957-4C87-9508-82C4EE39706A}"/>
+                <a16:creationId xmlns:a16="http://schemas.microsoft.com/office/drawing/2014/main" id="{C1D20C1F-29FF-49A3-B8D4-C6CD21565678}"/>
               </a:ext>
             </a:extLst>
           </p:cNvPr>
@@ -16143,7 +16143,7 @@
           <p:cNvPr id="11" name="Slide number">
             <a:extLst xmlns:a="http://schemas.openxmlformats.org/drawingml/2006/main">
               <a:ext uri="{FF2B5EF4-FFF2-40B4-BE49-F238E27FC236}">
-                <a16:creationId xmlns:a16="http://schemas.microsoft.com/office/drawing/2014/main" id="{6116B759-2753-405F-86E8-1AF1E7C0BB9B}"/>
+                <a16:creationId xmlns:a16="http://schemas.microsoft.com/office/drawing/2014/main" id="{6358824E-6FC7-4F2A-96B0-21D69AD04DC0}"/>
               </a:ext>
             </a:extLst>
           </p:cNvPr>
@@ -16198,7 +16198,7 @@
     </p:spTree>
     <p:extLst>
       <p:ext uri="{BB962C8B-B14F-4D97-AF65-F5344CB8AC3E}">
-        <p14:creationId xmlns:p14="http://schemas.microsoft.com/office/powerpoint/2010/main" val="1665081484"/>
+        <p14:creationId xmlns:p14="http://schemas.microsoft.com/office/powerpoint/2010/main" val="1551874896"/>
       </p:ext>
     </p:extLst>
   </p:cSld>
@@ -16229,7 +16229,7 @@
           <p:cNvPr id="10" name="Title">
             <a:extLst xmlns:a="http://schemas.openxmlformats.org/drawingml/2006/main">
               <a:ext uri="{FF2B5EF4-FFF2-40B4-BE49-F238E27FC236}">
-                <a16:creationId xmlns:a16="http://schemas.microsoft.com/office/drawing/2014/main" id="{4362546F-1ED1-418D-83C0-BFC1A048A680}"/>
+                <a16:creationId xmlns:a16="http://schemas.microsoft.com/office/drawing/2014/main" id="{DC872620-6A05-48D6-8252-25E4FEC43A12}"/>
               </a:ext>
             </a:extLst>
           </p:cNvPr>
@@ -16286,7 +16286,7 @@
           <p:cNvPr id="2" name="text">
             <a:extLst xmlns:a="http://schemas.openxmlformats.org/drawingml/2006/main">
               <a:ext uri="{FF2B5EF4-FFF2-40B4-BE49-F238E27FC236}">
-                <a16:creationId xmlns:a16="http://schemas.microsoft.com/office/drawing/2014/main" id="{A56D12EF-BCED-4F48-ADBD-D1DC7389097A}"/>
+                <a16:creationId xmlns:a16="http://schemas.microsoft.com/office/drawing/2014/main" id="{E6CF2C16-197C-4A75-B043-84128DD454E6}"/>
               </a:ext>
             </a:extLst>
           </p:cNvPr>
@@ -16343,7 +16343,7 @@
           <p:cNvPr id="3" name="text">
             <a:extLst xmlns:a="http://schemas.openxmlformats.org/drawingml/2006/main">
               <a:ext uri="{FF2B5EF4-FFF2-40B4-BE49-F238E27FC236}">
-                <a16:creationId xmlns:a16="http://schemas.microsoft.com/office/drawing/2014/main" id="{BC56DF17-B651-4FE8-AC48-E44B673F463D}"/>
+                <a16:creationId xmlns:a16="http://schemas.microsoft.com/office/drawing/2014/main" id="{9D3062DC-4A58-4526-A377-E73E8D4E8010}"/>
               </a:ext>
             </a:extLst>
           </p:cNvPr>
@@ -16400,7 +16400,7 @@
           <p:cNvPr id="4" name="text">
             <a:extLst xmlns:a="http://schemas.openxmlformats.org/drawingml/2006/main">
               <a:ext uri="{FF2B5EF4-FFF2-40B4-BE49-F238E27FC236}">
-                <a16:creationId xmlns:a16="http://schemas.microsoft.com/office/drawing/2014/main" id="{2140DF3E-13A8-4476-8426-AEB313E0685E}"/>
+                <a16:creationId xmlns:a16="http://schemas.microsoft.com/office/drawing/2014/main" id="{815DCC3A-1C5F-4D97-9F43-5C80918F60B8}"/>
               </a:ext>
             </a:extLst>
           </p:cNvPr>
@@ -16457,7 +16457,7 @@
           <p:cNvPr id="5" name="text">
             <a:extLst xmlns:a="http://schemas.openxmlformats.org/drawingml/2006/main">
               <a:ext uri="{FF2B5EF4-FFF2-40B4-BE49-F238E27FC236}">
-                <a16:creationId xmlns:a16="http://schemas.microsoft.com/office/drawing/2014/main" id="{DDE799D3-239F-4FF8-9C97-F0CD77AC45B1}"/>
+                <a16:creationId xmlns:a16="http://schemas.microsoft.com/office/drawing/2014/main" id="{A4F0C6AA-BBDE-4223-BE9E-68CB97DBAC6B}"/>
               </a:ext>
             </a:extLst>
           </p:cNvPr>
@@ -16514,7 +16514,7 @@
           <p:cNvPr id="6" name="text">
             <a:extLst xmlns:a="http://schemas.openxmlformats.org/drawingml/2006/main">
               <a:ext uri="{FF2B5EF4-FFF2-40B4-BE49-F238E27FC236}">
-                <a16:creationId xmlns:a16="http://schemas.microsoft.com/office/drawing/2014/main" id="{D5FAF12B-7A15-46A3-A1A3-D795A9119566}"/>
+                <a16:creationId xmlns:a16="http://schemas.microsoft.com/office/drawing/2014/main" id="{EE068F94-B801-41A0-94FB-3CE1FD4AE840}"/>
               </a:ext>
             </a:extLst>
           </p:cNvPr>
@@ -16571,7 +16571,7 @@
           <p:cNvPr id="7" name="text">
             <a:extLst xmlns:a="http://schemas.openxmlformats.org/drawingml/2006/main">
               <a:ext uri="{FF2B5EF4-FFF2-40B4-BE49-F238E27FC236}">
-                <a16:creationId xmlns:a16="http://schemas.microsoft.com/office/drawing/2014/main" id="{0C1BA506-5CEE-4DD8-8434-A1415F4B0C57}"/>
+                <a16:creationId xmlns:a16="http://schemas.microsoft.com/office/drawing/2014/main" id="{BE377CBE-84D9-4B39-A165-126DA70BDD07}"/>
               </a:ext>
             </a:extLst>
           </p:cNvPr>
@@ -16628,7 +16628,7 @@
           <p:cNvPr id="8" name="text">
             <a:extLst xmlns:a="http://schemas.openxmlformats.org/drawingml/2006/main">
               <a:ext uri="{FF2B5EF4-FFF2-40B4-BE49-F238E27FC236}">
-                <a16:creationId xmlns:a16="http://schemas.microsoft.com/office/drawing/2014/main" id="{564DDA7B-8B3F-49DB-9302-B57FEB6FC1C7}"/>
+                <a16:creationId xmlns:a16="http://schemas.microsoft.com/office/drawing/2014/main" id="{8752BC83-F261-4349-8632-3C636D1CE06E}"/>
               </a:ext>
             </a:extLst>
           </p:cNvPr>
@@ -16685,7 +16685,7 @@
           <p:cNvPr id="9" name="Slide number">
             <a:extLst xmlns:a="http://schemas.openxmlformats.org/drawingml/2006/main">
               <a:ext uri="{FF2B5EF4-FFF2-40B4-BE49-F238E27FC236}">
-                <a16:creationId xmlns:a16="http://schemas.microsoft.com/office/drawing/2014/main" id="{92326648-6B1C-46A0-8ADA-079641690E4C}"/>
+                <a16:creationId xmlns:a16="http://schemas.microsoft.com/office/drawing/2014/main" id="{08FE2BD4-862E-40F6-BDB1-7C4A88CD6727}"/>
               </a:ext>
             </a:extLst>
           </p:cNvPr>
@@ -16740,7 +16740,7 @@
     </p:spTree>
     <p:extLst>
       <p:ext uri="{BB962C8B-B14F-4D97-AF65-F5344CB8AC3E}">
-        <p14:creationId xmlns:p14="http://schemas.microsoft.com/office/powerpoint/2010/main" val="526340348"/>
+        <p14:creationId xmlns:p14="http://schemas.microsoft.com/office/powerpoint/2010/main" val="1311867414"/>
       </p:ext>
     </p:extLst>
   </p:cSld>
@@ -16771,7 +16771,7 @@
           <p:cNvPr id="7" name="Title">
             <a:extLst xmlns:a="http://schemas.openxmlformats.org/drawingml/2006/main">
               <a:ext uri="{FF2B5EF4-FFF2-40B4-BE49-F238E27FC236}">
-                <a16:creationId xmlns:a16="http://schemas.microsoft.com/office/drawing/2014/main" id="{92EA5EBA-25FD-4530-B16F-541EED1142F6}"/>
+                <a16:creationId xmlns:a16="http://schemas.microsoft.com/office/drawing/2014/main" id="{C97EC86F-9BE0-442A-8803-D1E469D71DAE}"/>
               </a:ext>
             </a:extLst>
           </p:cNvPr>
@@ -16835,7 +16835,7 @@
         </p:xfrm>
         <a:graphic xmlns:a="http://schemas.openxmlformats.org/drawingml/2006/main">
           <a:graphicData uri="http://schemas.openxmlformats.org/drawingml/2006/chart">
-            <c:chart xmlns:r="http://schemas.openxmlformats.org/officeDocument/2006/relationships" xmlns:c="http://schemas.openxmlformats.org/drawingml/2006/chart" r:id="R2050fb85d3c5441b"/>
+            <c:chart xmlns:r="http://schemas.openxmlformats.org/officeDocument/2006/relationships" xmlns:c="http://schemas.openxmlformats.org/drawingml/2006/chart" r:id="R4096c68d80c9455f"/>
           </a:graphicData>
         </a:graphic>
       </p:graphicFrame>
@@ -16844,7 +16844,7 @@
           <p:cNvPr id="3" name="April month marker">
             <a:extLst xmlns:a="http://schemas.openxmlformats.org/drawingml/2006/main">
               <a:ext uri="{FF2B5EF4-FFF2-40B4-BE49-F238E27FC236}">
-                <a16:creationId xmlns:a16="http://schemas.microsoft.com/office/drawing/2014/main" id="{01CAE974-608A-4591-A20B-5F925CA76607}"/>
+                <a16:creationId xmlns:a16="http://schemas.microsoft.com/office/drawing/2014/main" id="{030D6A09-871B-40D6-A0C8-5676B6A30C1A}"/>
               </a:ext>
             </a:extLst>
           </p:cNvPr>
@@ -16875,7 +16875,7 @@
           <p:cNvPr id="4" name="April joining context">
             <a:extLst xmlns:a="http://schemas.openxmlformats.org/drawingml/2006/main">
               <a:ext uri="{FF2B5EF4-FFF2-40B4-BE49-F238E27FC236}">
-                <a16:creationId xmlns:a16="http://schemas.microsoft.com/office/drawing/2014/main" id="{BE940CE2-0DE2-4DC1-8D56-41E11F186592}"/>
+                <a16:creationId xmlns:a16="http://schemas.microsoft.com/office/drawing/2014/main" id="{AE169E75-821C-4628-89B6-647FC15ADCA6}"/>
               </a:ext>
             </a:extLst>
           </p:cNvPr>
@@ -16932,7 +16932,7 @@
           <p:cNvPr id="5" name="Methodology">
             <a:extLst xmlns:a="http://schemas.openxmlformats.org/drawingml/2006/main">
               <a:ext uri="{FF2B5EF4-FFF2-40B4-BE49-F238E27FC236}">
-                <a16:creationId xmlns:a16="http://schemas.microsoft.com/office/drawing/2014/main" id="{06D2F084-3399-41F9-8D40-B0BC1F746829}"/>
+                <a16:creationId xmlns:a16="http://schemas.microsoft.com/office/drawing/2014/main" id="{AB62B0F0-58BE-4428-A911-125A40EDE579}"/>
               </a:ext>
             </a:extLst>
           </p:cNvPr>
@@ -16989,7 +16989,7 @@
           <p:cNvPr id="6" name="Slide number">
             <a:extLst xmlns:a="http://schemas.openxmlformats.org/drawingml/2006/main">
               <a:ext uri="{FF2B5EF4-FFF2-40B4-BE49-F238E27FC236}">
-                <a16:creationId xmlns:a16="http://schemas.microsoft.com/office/drawing/2014/main" id="{DA22CD1D-410C-40A8-A512-4C7824F35FF6}"/>
+                <a16:creationId xmlns:a16="http://schemas.microsoft.com/office/drawing/2014/main" id="{5C6F8FB6-010E-4EE5-A9D5-CF6D8F9A1570}"/>
               </a:ext>
             </a:extLst>
           </p:cNvPr>
@@ -17044,7 +17044,7 @@
     </p:spTree>
     <p:extLst>
       <p:ext uri="{BB962C8B-B14F-4D97-AF65-F5344CB8AC3E}">
-        <p14:creationId xmlns:p14="http://schemas.microsoft.com/office/powerpoint/2010/main" val="710498476"/>
+        <p14:creationId xmlns:p14="http://schemas.microsoft.com/office/powerpoint/2010/main" val="133674283"/>
       </p:ext>
     </p:extLst>
   </p:cSld>
@@ -17075,7 +17075,7 @@
           <p:cNvPr id="4" name="Title">
             <a:extLst xmlns:a="http://schemas.openxmlformats.org/drawingml/2006/main">
               <a:ext uri="{FF2B5EF4-FFF2-40B4-BE49-F238E27FC236}">
-                <a16:creationId xmlns:a16="http://schemas.microsoft.com/office/drawing/2014/main" id="{896AF29D-23F0-4805-B872-A42EC67BFA1F}"/>
+                <a16:creationId xmlns:a16="http://schemas.microsoft.com/office/drawing/2014/main" id="{F0801319-1E05-4B0E-8D1F-4F5B7FAA317C}"/>
               </a:ext>
             </a:extLst>
           </p:cNvPr>
@@ -17155,7 +17155,7 @@
           <p:cNvPr id="2" name="text">
             <a:extLst xmlns:a="http://schemas.openxmlformats.org/drawingml/2006/main">
               <a:ext uri="{FF2B5EF4-FFF2-40B4-BE49-F238E27FC236}">
-                <a16:creationId xmlns:a16="http://schemas.microsoft.com/office/drawing/2014/main" id="{D210EB56-5548-4896-8417-EF2F63319E1F}"/>
+                <a16:creationId xmlns:a16="http://schemas.microsoft.com/office/drawing/2014/main" id="{204ED6C8-EF8B-4A93-A8CA-A2A9623380C5}"/>
               </a:ext>
             </a:extLst>
           </p:cNvPr>
@@ -17212,7 +17212,7 @@
           <p:cNvPr id="3" name="Slide number">
             <a:extLst xmlns:a="http://schemas.openxmlformats.org/drawingml/2006/main">
               <a:ext uri="{FF2B5EF4-FFF2-40B4-BE49-F238E27FC236}">
-                <a16:creationId xmlns:a16="http://schemas.microsoft.com/office/drawing/2014/main" id="{0595DC53-257E-4FC1-900B-E7128E9F3771}"/>
+                <a16:creationId xmlns:a16="http://schemas.microsoft.com/office/drawing/2014/main" id="{DB26295D-395C-49F2-9945-E3AAAF159B81}"/>
               </a:ext>
             </a:extLst>
           </p:cNvPr>
@@ -17267,7 +17267,7 @@
     </p:spTree>
     <p:extLst>
       <p:ext uri="{BB962C8B-B14F-4D97-AF65-F5344CB8AC3E}">
-        <p14:creationId xmlns:p14="http://schemas.microsoft.com/office/powerpoint/2010/main" val="1529289577"/>
+        <p14:creationId xmlns:p14="http://schemas.microsoft.com/office/powerpoint/2010/main" val="586699806"/>
       </p:ext>
     </p:extLst>
   </p:cSld>
@@ -17298,7 +17298,7 @@
           <p:cNvPr id="16" name="Title">
             <a:extLst xmlns:a="http://schemas.openxmlformats.org/drawingml/2006/main">
               <a:ext uri="{FF2B5EF4-FFF2-40B4-BE49-F238E27FC236}">
-                <a16:creationId xmlns:a16="http://schemas.microsoft.com/office/drawing/2014/main" id="{FB789147-4D02-4566-BA23-E890B929CE03}"/>
+                <a16:creationId xmlns:a16="http://schemas.microsoft.com/office/drawing/2014/main" id="{55E25652-58CA-41B9-A064-E91D944E99BE}"/>
               </a:ext>
             </a:extLst>
           </p:cNvPr>
@@ -17355,7 +17355,7 @@
           <p:cNvPr id="2" name="text">
             <a:extLst xmlns:a="http://schemas.openxmlformats.org/drawingml/2006/main">
               <a:ext uri="{FF2B5EF4-FFF2-40B4-BE49-F238E27FC236}">
-                <a16:creationId xmlns:a16="http://schemas.microsoft.com/office/drawing/2014/main" id="{E2D0DB57-64F9-4E4C-9E3E-D6B48E2BC17C}"/>
+                <a16:creationId xmlns:a16="http://schemas.microsoft.com/office/drawing/2014/main" id="{DD359984-0866-4543-8C72-EDBBF6327288}"/>
               </a:ext>
             </a:extLst>
           </p:cNvPr>
@@ -17412,7 +17412,7 @@
           <p:cNvPr id="3" name="text">
             <a:extLst xmlns:a="http://schemas.openxmlformats.org/drawingml/2006/main">
               <a:ext uri="{FF2B5EF4-FFF2-40B4-BE49-F238E27FC236}">
-                <a16:creationId xmlns:a16="http://schemas.microsoft.com/office/drawing/2014/main" id="{49FF55BE-1553-4B75-B99D-04ED34C6BE57}"/>
+                <a16:creationId xmlns:a16="http://schemas.microsoft.com/office/drawing/2014/main" id="{1FEE05ED-5D4B-4FA4-91C0-1A5C1581A51E}"/>
               </a:ext>
             </a:extLst>
           </p:cNvPr>
@@ -17469,7 +17469,7 @@
           <p:cNvPr id="4" name="text">
             <a:extLst xmlns:a="http://schemas.openxmlformats.org/drawingml/2006/main">
               <a:ext uri="{FF2B5EF4-FFF2-40B4-BE49-F238E27FC236}">
-                <a16:creationId xmlns:a16="http://schemas.microsoft.com/office/drawing/2014/main" id="{8F3481FD-D6A4-485F-B464-BD2748724B6C}"/>
+                <a16:creationId xmlns:a16="http://schemas.microsoft.com/office/drawing/2014/main" id="{C405F7A8-F5A3-4B08-9ABF-1D621D81360E}"/>
               </a:ext>
             </a:extLst>
           </p:cNvPr>
@@ -17526,7 +17526,7 @@
           <p:cNvPr id="5" name="text">
             <a:extLst xmlns:a="http://schemas.openxmlformats.org/drawingml/2006/main">
               <a:ext uri="{FF2B5EF4-FFF2-40B4-BE49-F238E27FC236}">
-                <a16:creationId xmlns:a16="http://schemas.microsoft.com/office/drawing/2014/main" id="{58E17C3F-A5F1-4DF1-BDF1-D1E041615A38}"/>
+                <a16:creationId xmlns:a16="http://schemas.microsoft.com/office/drawing/2014/main" id="{B564A504-2C46-44C9-8106-7E1D77FAC232}"/>
               </a:ext>
             </a:extLst>
           </p:cNvPr>
@@ -17583,7 +17583,7 @@
           <p:cNvPr id="6" name="text">
             <a:extLst xmlns:a="http://schemas.openxmlformats.org/drawingml/2006/main">
               <a:ext uri="{FF2B5EF4-FFF2-40B4-BE49-F238E27FC236}">
-                <a16:creationId xmlns:a16="http://schemas.microsoft.com/office/drawing/2014/main" id="{B7E14999-895A-4CE1-A9B1-3EB320C471E0}"/>
+                <a16:creationId xmlns:a16="http://schemas.microsoft.com/office/drawing/2014/main" id="{8F1B3EE4-53D1-405A-A12C-787A31798C95}"/>
               </a:ext>
             </a:extLst>
           </p:cNvPr>
@@ -17640,7 +17640,7 @@
           <p:cNvPr id="7" name="text">
             <a:extLst xmlns:a="http://schemas.openxmlformats.org/drawingml/2006/main">
               <a:ext uri="{FF2B5EF4-FFF2-40B4-BE49-F238E27FC236}">
-                <a16:creationId xmlns:a16="http://schemas.microsoft.com/office/drawing/2014/main" id="{D8286A08-31C6-49DC-BB33-3ECF4450256F}"/>
+                <a16:creationId xmlns:a16="http://schemas.microsoft.com/office/drawing/2014/main" id="{AA4E8D8A-EF4C-484D-A1F8-D0229792188D}"/>
               </a:ext>
             </a:extLst>
           </p:cNvPr>
@@ -17697,7 +17697,7 @@
           <p:cNvPr id="8" name="text">
             <a:extLst xmlns:a="http://schemas.openxmlformats.org/drawingml/2006/main">
               <a:ext uri="{FF2B5EF4-FFF2-40B4-BE49-F238E27FC236}">
-                <a16:creationId xmlns:a16="http://schemas.microsoft.com/office/drawing/2014/main" id="{A2B373C1-7EBC-4D59-AD20-4980E4C52F00}"/>
+                <a16:creationId xmlns:a16="http://schemas.microsoft.com/office/drawing/2014/main" id="{67132C39-9C00-4D4F-8158-6D0574910620}"/>
               </a:ext>
             </a:extLst>
           </p:cNvPr>
@@ -17754,7 +17754,7 @@
           <p:cNvPr id="9" name="text">
             <a:extLst xmlns:a="http://schemas.openxmlformats.org/drawingml/2006/main">
               <a:ext uri="{FF2B5EF4-FFF2-40B4-BE49-F238E27FC236}">
-                <a16:creationId xmlns:a16="http://schemas.microsoft.com/office/drawing/2014/main" id="{325B73B3-94DB-4F21-980E-31151A716A3F}"/>
+                <a16:creationId xmlns:a16="http://schemas.microsoft.com/office/drawing/2014/main" id="{40C8895A-992A-4BF9-9CFC-6A29E5589F14}"/>
               </a:ext>
             </a:extLst>
           </p:cNvPr>
@@ -17811,7 +17811,7 @@
           <p:cNvPr id="10" name="text">
             <a:extLst xmlns:a="http://schemas.openxmlformats.org/drawingml/2006/main">
               <a:ext uri="{FF2B5EF4-FFF2-40B4-BE49-F238E27FC236}">
-                <a16:creationId xmlns:a16="http://schemas.microsoft.com/office/drawing/2014/main" id="{067441B4-8574-4B76-9936-232B4331E8F7}"/>
+                <a16:creationId xmlns:a16="http://schemas.microsoft.com/office/drawing/2014/main" id="{A75F18F2-D4B9-449D-9FEC-7CD3242ACCE1}"/>
               </a:ext>
             </a:extLst>
           </p:cNvPr>
@@ -17868,7 +17868,7 @@
           <p:cNvPr id="11" name="text">
             <a:extLst xmlns:a="http://schemas.openxmlformats.org/drawingml/2006/main">
               <a:ext uri="{FF2B5EF4-FFF2-40B4-BE49-F238E27FC236}">
-                <a16:creationId xmlns:a16="http://schemas.microsoft.com/office/drawing/2014/main" id="{82949252-8B8D-4E8B-AFBA-90DCCCE7FB57}"/>
+                <a16:creationId xmlns:a16="http://schemas.microsoft.com/office/drawing/2014/main" id="{F01C5F5F-6B81-4406-9D57-733201604B69}"/>
               </a:ext>
             </a:extLst>
           </p:cNvPr>
@@ -17925,7 +17925,7 @@
           <p:cNvPr id="12" name="text">
             <a:extLst xmlns:a="http://schemas.openxmlformats.org/drawingml/2006/main">
               <a:ext uri="{FF2B5EF4-FFF2-40B4-BE49-F238E27FC236}">
-                <a16:creationId xmlns:a16="http://schemas.microsoft.com/office/drawing/2014/main" id="{C09F2B95-C8D8-4B49-A49C-2E6CA5CDA7E1}"/>
+                <a16:creationId xmlns:a16="http://schemas.microsoft.com/office/drawing/2014/main" id="{C8C0D828-0F85-4E67-8E2B-1EEACF7FDBE2}"/>
               </a:ext>
             </a:extLst>
           </p:cNvPr>
@@ -17982,7 +17982,7 @@
           <p:cNvPr id="13" name="text">
             <a:extLst xmlns:a="http://schemas.openxmlformats.org/drawingml/2006/main">
               <a:ext uri="{FF2B5EF4-FFF2-40B4-BE49-F238E27FC236}">
-                <a16:creationId xmlns:a16="http://schemas.microsoft.com/office/drawing/2014/main" id="{9BAF6DE4-F31F-4ED9-9D19-F7DFA0DA9F93}"/>
+                <a16:creationId xmlns:a16="http://schemas.microsoft.com/office/drawing/2014/main" id="{C1BF476A-ADD9-4E9B-9F88-474541C97633}"/>
               </a:ext>
             </a:extLst>
           </p:cNvPr>
@@ -18039,7 +18039,7 @@
           <p:cNvPr id="14" name="text">
             <a:extLst xmlns:a="http://schemas.openxmlformats.org/drawingml/2006/main">
               <a:ext uri="{FF2B5EF4-FFF2-40B4-BE49-F238E27FC236}">
-                <a16:creationId xmlns:a16="http://schemas.microsoft.com/office/drawing/2014/main" id="{1986B903-56D0-4D48-8236-0A6263075F56}"/>
+                <a16:creationId xmlns:a16="http://schemas.microsoft.com/office/drawing/2014/main" id="{AC0EE493-49D8-4EB5-9D86-024AE6FA576E}"/>
               </a:ext>
             </a:extLst>
           </p:cNvPr>
@@ -18096,7 +18096,7 @@
           <p:cNvPr id="15" name="Slide number">
             <a:extLst xmlns:a="http://schemas.openxmlformats.org/drawingml/2006/main">
               <a:ext uri="{FF2B5EF4-FFF2-40B4-BE49-F238E27FC236}">
-                <a16:creationId xmlns:a16="http://schemas.microsoft.com/office/drawing/2014/main" id="{7192178C-9B1D-4298-83DF-1811999B0533}"/>
+                <a16:creationId xmlns:a16="http://schemas.microsoft.com/office/drawing/2014/main" id="{0D00B43F-5DE6-4EEC-A677-1B0867EA8038}"/>
               </a:ext>
             </a:extLst>
           </p:cNvPr>
@@ -18151,7 +18151,7 @@
     </p:spTree>
     <p:extLst>
       <p:ext uri="{BB962C8B-B14F-4D97-AF65-F5344CB8AC3E}">
-        <p14:creationId xmlns:p14="http://schemas.microsoft.com/office/powerpoint/2010/main" val="1559923155"/>
+        <p14:creationId xmlns:p14="http://schemas.microsoft.com/office/powerpoint/2010/main" val="362159288"/>
       </p:ext>
     </p:extLst>
   </p:cSld>
@@ -18182,7 +18182,7 @@
           <p:cNvPr id="12" name="Title">
             <a:extLst xmlns:a="http://schemas.openxmlformats.org/drawingml/2006/main">
               <a:ext uri="{FF2B5EF4-FFF2-40B4-BE49-F238E27FC236}">
-                <a16:creationId xmlns:a16="http://schemas.microsoft.com/office/drawing/2014/main" id="{1B7EEC79-1B04-44B5-B3B4-F7970C757065}"/>
+                <a16:creationId xmlns:a16="http://schemas.microsoft.com/office/drawing/2014/main" id="{956CF527-E5B1-4DF9-8597-ACCDF1C679D3}"/>
               </a:ext>
             </a:extLst>
           </p:cNvPr>
@@ -18239,7 +18239,7 @@
           <p:cNvPr id="2" name="text">
             <a:extLst xmlns:a="http://schemas.openxmlformats.org/drawingml/2006/main">
               <a:ext uri="{FF2B5EF4-FFF2-40B4-BE49-F238E27FC236}">
-                <a16:creationId xmlns:a16="http://schemas.microsoft.com/office/drawing/2014/main" id="{3CB9A3B4-FC34-4BF8-86A6-C8AC6B4266AD}"/>
+                <a16:creationId xmlns:a16="http://schemas.microsoft.com/office/drawing/2014/main" id="{36AB2AD8-7FB7-4442-B961-3C292DECF666}"/>
               </a:ext>
             </a:extLst>
           </p:cNvPr>
@@ -18296,7 +18296,7 @@
           <p:cNvPr id="3" name="text">
             <a:extLst xmlns:a="http://schemas.openxmlformats.org/drawingml/2006/main">
               <a:ext uri="{FF2B5EF4-FFF2-40B4-BE49-F238E27FC236}">
-                <a16:creationId xmlns:a16="http://schemas.microsoft.com/office/drawing/2014/main" id="{E1D47B81-B831-423C-AC31-ABD47443A7B9}"/>
+                <a16:creationId xmlns:a16="http://schemas.microsoft.com/office/drawing/2014/main" id="{0A267835-0EA6-47F1-BE22-C99A8CA8F992}"/>
               </a:ext>
             </a:extLst>
           </p:cNvPr>
@@ -18353,7 +18353,7 @@
           <p:cNvPr id="4" name="text">
             <a:extLst xmlns:a="http://schemas.openxmlformats.org/drawingml/2006/main">
               <a:ext uri="{FF2B5EF4-FFF2-40B4-BE49-F238E27FC236}">
-                <a16:creationId xmlns:a16="http://schemas.microsoft.com/office/drawing/2014/main" id="{16919918-C2BF-4E59-BDFA-C9AC2091EFF1}"/>
+                <a16:creationId xmlns:a16="http://schemas.microsoft.com/office/drawing/2014/main" id="{D0D98065-753D-4E78-AEDC-66A1858E8FD0}"/>
               </a:ext>
             </a:extLst>
           </p:cNvPr>
@@ -18410,7 +18410,7 @@
           <p:cNvPr id="5" name="text">
             <a:extLst xmlns:a="http://schemas.openxmlformats.org/drawingml/2006/main">
               <a:ext uri="{FF2B5EF4-FFF2-40B4-BE49-F238E27FC236}">
-                <a16:creationId xmlns:a16="http://schemas.microsoft.com/office/drawing/2014/main" id="{0CD6E3EF-BB09-4F59-8E10-2F297BA036BB}"/>
+                <a16:creationId xmlns:a16="http://schemas.microsoft.com/office/drawing/2014/main" id="{0F68BD7A-CCF9-4961-8DC0-7DFBC13FF241}"/>
               </a:ext>
             </a:extLst>
           </p:cNvPr>
@@ -18467,7 +18467,7 @@
           <p:cNvPr id="6" name="text">
             <a:extLst xmlns:a="http://schemas.openxmlformats.org/drawingml/2006/main">
               <a:ext uri="{FF2B5EF4-FFF2-40B4-BE49-F238E27FC236}">
-                <a16:creationId xmlns:a16="http://schemas.microsoft.com/office/drawing/2014/main" id="{1AAEA730-AE4F-426E-96DA-AEB3DE96B39B}"/>
+                <a16:creationId xmlns:a16="http://schemas.microsoft.com/office/drawing/2014/main" id="{60866CBF-847A-48A7-A92A-B367037338BA}"/>
               </a:ext>
             </a:extLst>
           </p:cNvPr>
@@ -18524,7 +18524,7 @@
           <p:cNvPr id="7" name="text">
             <a:extLst xmlns:a="http://schemas.openxmlformats.org/drawingml/2006/main">
               <a:ext uri="{FF2B5EF4-FFF2-40B4-BE49-F238E27FC236}">
-                <a16:creationId xmlns:a16="http://schemas.microsoft.com/office/drawing/2014/main" id="{76470C99-07C5-4F24-B279-9CD9D11936E9}"/>
+                <a16:creationId xmlns:a16="http://schemas.microsoft.com/office/drawing/2014/main" id="{38C8A38F-1B49-420E-A630-A0076EBAE3A1}"/>
               </a:ext>
             </a:extLst>
           </p:cNvPr>
@@ -18581,7 +18581,7 @@
           <p:cNvPr id="8" name="text">
             <a:extLst xmlns:a="http://schemas.openxmlformats.org/drawingml/2006/main">
               <a:ext uri="{FF2B5EF4-FFF2-40B4-BE49-F238E27FC236}">
-                <a16:creationId xmlns:a16="http://schemas.microsoft.com/office/drawing/2014/main" id="{D6EAEB86-123C-4175-84ED-9A1B93264F8B}"/>
+                <a16:creationId xmlns:a16="http://schemas.microsoft.com/office/drawing/2014/main" id="{03B43B2A-08E0-4ADB-BF72-205749ABAB02}"/>
               </a:ext>
             </a:extLst>
           </p:cNvPr>
@@ -18638,7 +18638,7 @@
           <p:cNvPr id="9" name="text">
             <a:extLst xmlns:a="http://schemas.openxmlformats.org/drawingml/2006/main">
               <a:ext uri="{FF2B5EF4-FFF2-40B4-BE49-F238E27FC236}">
-                <a16:creationId xmlns:a16="http://schemas.microsoft.com/office/drawing/2014/main" id="{541AE98A-1765-43DF-8CF8-A52BF1207C8A}"/>
+                <a16:creationId xmlns:a16="http://schemas.microsoft.com/office/drawing/2014/main" id="{E0DC5A25-ADF0-4855-B85E-8B5AC628BD47}"/>
               </a:ext>
             </a:extLst>
           </p:cNvPr>
@@ -18695,7 +18695,7 @@
           <p:cNvPr id="10" name="text">
             <a:extLst xmlns:a="http://schemas.openxmlformats.org/drawingml/2006/main">
               <a:ext uri="{FF2B5EF4-FFF2-40B4-BE49-F238E27FC236}">
-                <a16:creationId xmlns:a16="http://schemas.microsoft.com/office/drawing/2014/main" id="{DBAEFD38-8A44-4CAF-A08B-5FC3E9ADAAF2}"/>
+                <a16:creationId xmlns:a16="http://schemas.microsoft.com/office/drawing/2014/main" id="{D32748A8-94C5-4630-AB81-D51CAF068287}"/>
               </a:ext>
             </a:extLst>
           </p:cNvPr>
@@ -18752,7 +18752,7 @@
           <p:cNvPr id="11" name="Slide number">
             <a:extLst xmlns:a="http://schemas.openxmlformats.org/drawingml/2006/main">
               <a:ext uri="{FF2B5EF4-FFF2-40B4-BE49-F238E27FC236}">
-                <a16:creationId xmlns:a16="http://schemas.microsoft.com/office/drawing/2014/main" id="{53D8A744-3A04-4A88-A05E-140EAD41CAD1}"/>
+                <a16:creationId xmlns:a16="http://schemas.microsoft.com/office/drawing/2014/main" id="{63DE109E-E704-4EF0-9352-A2B61F2D02B0}"/>
               </a:ext>
             </a:extLst>
           </p:cNvPr>
@@ -18807,7 +18807,7 @@
     </p:spTree>
     <p:extLst>
       <p:ext uri="{BB962C8B-B14F-4D97-AF65-F5344CB8AC3E}">
-        <p14:creationId xmlns:p14="http://schemas.microsoft.com/office/powerpoint/2010/main" val="796727475"/>
+        <p14:creationId xmlns:p14="http://schemas.microsoft.com/office/powerpoint/2010/main" val="1493639318"/>
       </p:ext>
     </p:extLst>
   </p:cSld>
@@ -18838,7 +18838,7 @@
           <p:cNvPr id="21" name="Title">
             <a:extLst xmlns:a="http://schemas.openxmlformats.org/drawingml/2006/main">
               <a:ext uri="{FF2B5EF4-FFF2-40B4-BE49-F238E27FC236}">
-                <a16:creationId xmlns:a16="http://schemas.microsoft.com/office/drawing/2014/main" id="{4779100D-2685-4726-8C7D-6DA2DE1560F5}"/>
+                <a16:creationId xmlns:a16="http://schemas.microsoft.com/office/drawing/2014/main" id="{E7A29054-D104-4E91-94AE-B90935D23DF2}"/>
               </a:ext>
             </a:extLst>
           </p:cNvPr>
@@ -18895,7 +18895,7 @@
           <p:cNvPr id="2" name="text">
             <a:extLst xmlns:a="http://schemas.openxmlformats.org/drawingml/2006/main">
               <a:ext uri="{FF2B5EF4-FFF2-40B4-BE49-F238E27FC236}">
-                <a16:creationId xmlns:a16="http://schemas.microsoft.com/office/drawing/2014/main" id="{39912999-3F04-4A23-896A-5A31211DC755}"/>
+                <a16:creationId xmlns:a16="http://schemas.microsoft.com/office/drawing/2014/main" id="{7000BDFE-1617-4C3B-A778-48561ECDEB16}"/>
               </a:ext>
             </a:extLst>
           </p:cNvPr>
@@ -18952,7 +18952,7 @@
           <p:cNvPr id="3" name="text">
             <a:extLst xmlns:a="http://schemas.openxmlformats.org/drawingml/2006/main">
               <a:ext uri="{FF2B5EF4-FFF2-40B4-BE49-F238E27FC236}">
-                <a16:creationId xmlns:a16="http://schemas.microsoft.com/office/drawing/2014/main" id="{79B34954-1E6B-4FE9-9930-A3F6CDF52AA5}"/>
+                <a16:creationId xmlns:a16="http://schemas.microsoft.com/office/drawing/2014/main" id="{D34F3374-6970-429D-A4D0-404125A1405C}"/>
               </a:ext>
             </a:extLst>
           </p:cNvPr>
@@ -19009,7 +19009,7 @@
           <p:cNvPr id="4" name="text">
             <a:extLst xmlns:a="http://schemas.openxmlformats.org/drawingml/2006/main">
               <a:ext uri="{FF2B5EF4-FFF2-40B4-BE49-F238E27FC236}">
-                <a16:creationId xmlns:a16="http://schemas.microsoft.com/office/drawing/2014/main" id="{45E3FFA6-4867-4BC9-B59E-29CAEAF5B4FE}"/>
+                <a16:creationId xmlns:a16="http://schemas.microsoft.com/office/drawing/2014/main" id="{C1905D41-BE9D-4E92-8192-6406EC964150}"/>
               </a:ext>
             </a:extLst>
           </p:cNvPr>
@@ -19066,7 +19066,7 @@
           <p:cNvPr id="5" name="text">
             <a:extLst xmlns:a="http://schemas.openxmlformats.org/drawingml/2006/main">
               <a:ext uri="{FF2B5EF4-FFF2-40B4-BE49-F238E27FC236}">
-                <a16:creationId xmlns:a16="http://schemas.microsoft.com/office/drawing/2014/main" id="{293E3A4A-C006-434C-A49A-D95E3709F031}"/>
+                <a16:creationId xmlns:a16="http://schemas.microsoft.com/office/drawing/2014/main" id="{4325EC75-ED9B-4A2B-922B-7A7E12EF749B}"/>
               </a:ext>
             </a:extLst>
           </p:cNvPr>
@@ -19123,7 +19123,7 @@
           <p:cNvPr id="6" name="text">
             <a:extLst xmlns:a="http://schemas.openxmlformats.org/drawingml/2006/main">
               <a:ext uri="{FF2B5EF4-FFF2-40B4-BE49-F238E27FC236}">
-                <a16:creationId xmlns:a16="http://schemas.microsoft.com/office/drawing/2014/main" id="{C018DB14-DA92-458C-ACBA-0C04DC73CE04}"/>
+                <a16:creationId xmlns:a16="http://schemas.microsoft.com/office/drawing/2014/main" id="{A4A47415-BAA9-475E-813C-9EB745843869}"/>
               </a:ext>
             </a:extLst>
           </p:cNvPr>
@@ -19180,7 +19180,7 @@
           <p:cNvPr id="7" name="text">
             <a:extLst xmlns:a="http://schemas.openxmlformats.org/drawingml/2006/main">
               <a:ext uri="{FF2B5EF4-FFF2-40B4-BE49-F238E27FC236}">
-                <a16:creationId xmlns:a16="http://schemas.microsoft.com/office/drawing/2014/main" id="{611296C2-7852-4DBC-BE58-9970E9F6C936}"/>
+                <a16:creationId xmlns:a16="http://schemas.microsoft.com/office/drawing/2014/main" id="{B600D95B-B3B1-4233-B8F2-400609C53B6F}"/>
               </a:ext>
             </a:extLst>
           </p:cNvPr>
@@ -19237,7 +19237,7 @@
           <p:cNvPr id="8" name="text">
             <a:extLst xmlns:a="http://schemas.openxmlformats.org/drawingml/2006/main">
               <a:ext uri="{FF2B5EF4-FFF2-40B4-BE49-F238E27FC236}">
-                <a16:creationId xmlns:a16="http://schemas.microsoft.com/office/drawing/2014/main" id="{1011631E-7A18-4E73-AAA4-FCD754466085}"/>
+                <a16:creationId xmlns:a16="http://schemas.microsoft.com/office/drawing/2014/main" id="{C9ADF5BF-E126-4ACD-9B6A-AA4FDCA5A727}"/>
               </a:ext>
             </a:extLst>
           </p:cNvPr>
@@ -19294,7 +19294,7 @@
           <p:cNvPr id="9" name="text">
             <a:extLst xmlns:a="http://schemas.openxmlformats.org/drawingml/2006/main">
               <a:ext uri="{FF2B5EF4-FFF2-40B4-BE49-F238E27FC236}">
-                <a16:creationId xmlns:a16="http://schemas.microsoft.com/office/drawing/2014/main" id="{2EAD6CE7-C350-4C07-9830-4C1448116549}"/>
+                <a16:creationId xmlns:a16="http://schemas.microsoft.com/office/drawing/2014/main" id="{0D75DF88-2480-4DCA-9D0A-FD3AA6EC3033}"/>
               </a:ext>
             </a:extLst>
           </p:cNvPr>
@@ -19351,7 +19351,7 @@
           <p:cNvPr id="10" name="text">
             <a:extLst xmlns:a="http://schemas.openxmlformats.org/drawingml/2006/main">
               <a:ext uri="{FF2B5EF4-FFF2-40B4-BE49-F238E27FC236}">
-                <a16:creationId xmlns:a16="http://schemas.microsoft.com/office/drawing/2014/main" id="{3C8D82D0-C27C-42BD-9545-A34CB46B6B22}"/>
+                <a16:creationId xmlns:a16="http://schemas.microsoft.com/office/drawing/2014/main" id="{AEA93699-E4F8-43F6-998C-8896D7FFB4D7}"/>
               </a:ext>
             </a:extLst>
           </p:cNvPr>
@@ -19408,7 +19408,7 @@
           <p:cNvPr id="11" name="text">
             <a:extLst xmlns:a="http://schemas.openxmlformats.org/drawingml/2006/main">
               <a:ext uri="{FF2B5EF4-FFF2-40B4-BE49-F238E27FC236}">
-                <a16:creationId xmlns:a16="http://schemas.microsoft.com/office/drawing/2014/main" id="{6EF5F8DD-F0A0-4F5F-ADDC-12553CEFA27B}"/>
+                <a16:creationId xmlns:a16="http://schemas.microsoft.com/office/drawing/2014/main" id="{FB8A9371-DB6D-4AD4-8AFB-E5F134F86671}"/>
               </a:ext>
             </a:extLst>
           </p:cNvPr>
@@ -19465,7 +19465,7 @@
           <p:cNvPr id="12" name="text">
             <a:extLst xmlns:a="http://schemas.openxmlformats.org/drawingml/2006/main">
               <a:ext uri="{FF2B5EF4-FFF2-40B4-BE49-F238E27FC236}">
-                <a16:creationId xmlns:a16="http://schemas.microsoft.com/office/drawing/2014/main" id="{679C133F-5D74-4C11-B7B9-A417772DE33C}"/>
+                <a16:creationId xmlns:a16="http://schemas.microsoft.com/office/drawing/2014/main" id="{C9B0D063-47D4-4B65-B82A-2C87F9064456}"/>
               </a:ext>
             </a:extLst>
           </p:cNvPr>
@@ -19522,7 +19522,7 @@
           <p:cNvPr id="13" name="text">
             <a:extLst xmlns:a="http://schemas.openxmlformats.org/drawingml/2006/main">
               <a:ext uri="{FF2B5EF4-FFF2-40B4-BE49-F238E27FC236}">
-                <a16:creationId xmlns:a16="http://schemas.microsoft.com/office/drawing/2014/main" id="{18D5CEF8-880E-4D87-BB0A-9211C3588635}"/>
+                <a16:creationId xmlns:a16="http://schemas.microsoft.com/office/drawing/2014/main" id="{594C75BC-FE11-4C05-995B-618CFEAE1E0A}"/>
               </a:ext>
             </a:extLst>
           </p:cNvPr>
@@ -19579,7 +19579,7 @@
           <p:cNvPr id="14" name="text">
             <a:extLst xmlns:a="http://schemas.openxmlformats.org/drawingml/2006/main">
               <a:ext uri="{FF2B5EF4-FFF2-40B4-BE49-F238E27FC236}">
-                <a16:creationId xmlns:a16="http://schemas.microsoft.com/office/drawing/2014/main" id="{54E0DBDB-7F13-4250-96D4-191510ADC662}"/>
+                <a16:creationId xmlns:a16="http://schemas.microsoft.com/office/drawing/2014/main" id="{8DF5A8C6-3C4E-461B-9867-EC308CC5DD4F}"/>
               </a:ext>
             </a:extLst>
           </p:cNvPr>
@@ -19636,7 +19636,7 @@
           <p:cNvPr id="15" name="text">
             <a:extLst xmlns:a="http://schemas.openxmlformats.org/drawingml/2006/main">
               <a:ext uri="{FF2B5EF4-FFF2-40B4-BE49-F238E27FC236}">
-                <a16:creationId xmlns:a16="http://schemas.microsoft.com/office/drawing/2014/main" id="{75979A3D-A2F6-4746-9ED8-E5120CCAAC71}"/>
+                <a16:creationId xmlns:a16="http://schemas.microsoft.com/office/drawing/2014/main" id="{170F7A9B-85BD-44A6-944A-34B053BC6936}"/>
               </a:ext>
             </a:extLst>
           </p:cNvPr>
@@ -19693,7 +19693,7 @@
           <p:cNvPr id="16" name="text">
             <a:extLst xmlns:a="http://schemas.openxmlformats.org/drawingml/2006/main">
               <a:ext uri="{FF2B5EF4-FFF2-40B4-BE49-F238E27FC236}">
-                <a16:creationId xmlns:a16="http://schemas.microsoft.com/office/drawing/2014/main" id="{241F00E9-DF63-4012-B6F6-9E4DF369F30E}"/>
+                <a16:creationId xmlns:a16="http://schemas.microsoft.com/office/drawing/2014/main" id="{DDCF827A-2B3B-4361-94E4-7752B40034F9}"/>
               </a:ext>
             </a:extLst>
           </p:cNvPr>
@@ -19754,7 +19754,7 @@
           <p:nvPr/>
         </p:nvPicPr>
         <p:blipFill>
-          <a:blip xmlns:r="http://schemas.openxmlformats.org/officeDocument/2006/relationships" xmlns:a="http://schemas.openxmlformats.org/drawingml/2006/main" r:embed="R9b7b5b1bad224adb"/>
+          <a:blip xmlns:r="http://schemas.openxmlformats.org/officeDocument/2006/relationships" xmlns:a="http://schemas.openxmlformats.org/drawingml/2006/main" r:embed="Re67d8290df7c41b3"/>
           <a:stretch xmlns:a="http://schemas.openxmlformats.org/drawingml/2006/main"/>
         </p:blipFill>
         <p:spPr>
@@ -19772,7 +19772,7 @@
           <p:cNvPr id="18" name="Share page">
             <a:extLst xmlns:a="http://schemas.openxmlformats.org/drawingml/2006/main">
               <a:ext uri="{FF2B5EF4-FFF2-40B4-BE49-F238E27FC236}">
-                <a16:creationId xmlns:a16="http://schemas.microsoft.com/office/drawing/2014/main" id="{28F36433-379A-4930-B84F-0CE68B750C36}"/>
+                <a16:creationId xmlns:a16="http://schemas.microsoft.com/office/drawing/2014/main" id="{D2E8CFAE-BDC7-4FC8-A09E-D9F96B8513FA}"/>
               </a:ext>
             </a:extLst>
           </p:cNvPr>
@@ -19819,7 +19819,7 @@
                 <a:ea typeface="Satoshi Variable"/>
                 <a:cs typeface="Satoshi Variable"/>
               </a:rPr>
-              <a:t>MrAdib.com/share</a:t>
+              <a:t>MrAdib.com/@</a:t>
             </a:r>
           </a:p>
         </p:txBody>
@@ -19829,7 +19829,7 @@
           <p:cNvPr id="19" name="text">
             <a:extLst xmlns:a="http://schemas.openxmlformats.org/drawingml/2006/main">
               <a:ext uri="{FF2B5EF4-FFF2-40B4-BE49-F238E27FC236}">
-                <a16:creationId xmlns:a16="http://schemas.microsoft.com/office/drawing/2014/main" id="{E0A48791-CF80-4211-B651-2AA21D7E2670}"/>
+                <a16:creationId xmlns:a16="http://schemas.microsoft.com/office/drawing/2014/main" id="{8DC234E6-2DE7-4B6A-A3E0-A721404EC976}"/>
               </a:ext>
             </a:extLst>
           </p:cNvPr>
@@ -19909,7 +19909,7 @@
           <p:cNvPr id="20" name="Slide number">
             <a:extLst xmlns:a="http://schemas.openxmlformats.org/drawingml/2006/main">
               <a:ext uri="{FF2B5EF4-FFF2-40B4-BE49-F238E27FC236}">
-                <a16:creationId xmlns:a16="http://schemas.microsoft.com/office/drawing/2014/main" id="{EF298D97-570F-42B3-BDBC-C4C9801A874B}"/>
+                <a16:creationId xmlns:a16="http://schemas.microsoft.com/office/drawing/2014/main" id="{415A4D83-44FA-46E1-8DE5-9A81AE84D57E}"/>
               </a:ext>
             </a:extLst>
           </p:cNvPr>
@@ -19964,7 +19964,7 @@
     </p:spTree>
     <p:extLst>
       <p:ext uri="{BB962C8B-B14F-4D97-AF65-F5344CB8AC3E}">
-        <p14:creationId xmlns:p14="http://schemas.microsoft.com/office/powerpoint/2010/main" val="1703217195"/>
+        <p14:creationId xmlns:p14="http://schemas.microsoft.com/office/powerpoint/2010/main" val="1120881948"/>
       </p:ext>
     </p:extLst>
   </p:cSld>
@@ -19995,7 +19995,7 @@
           <p:cNvPr id="4" name="Title">
             <a:extLst xmlns:a="http://schemas.openxmlformats.org/drawingml/2006/main">
               <a:ext uri="{FF2B5EF4-FFF2-40B4-BE49-F238E27FC236}">
-                <a16:creationId xmlns:a16="http://schemas.microsoft.com/office/drawing/2014/main" id="{2E00852A-E984-490B-8992-8B108FA1FB3C}"/>
+                <a16:creationId xmlns:a16="http://schemas.microsoft.com/office/drawing/2014/main" id="{2B7E3D55-AC36-4CDF-B66D-A527692286A4}"/>
               </a:ext>
             </a:extLst>
           </p:cNvPr>
@@ -20075,7 +20075,7 @@
           <p:cNvPr id="2" name="text">
             <a:extLst xmlns:a="http://schemas.openxmlformats.org/drawingml/2006/main">
               <a:ext uri="{FF2B5EF4-FFF2-40B4-BE49-F238E27FC236}">
-                <a16:creationId xmlns:a16="http://schemas.microsoft.com/office/drawing/2014/main" id="{92A81B22-5F38-44B2-BB2F-246832DA4008}"/>
+                <a16:creationId xmlns:a16="http://schemas.microsoft.com/office/drawing/2014/main" id="{002EC314-A33F-441F-81C9-1F20567E0080}"/>
               </a:ext>
             </a:extLst>
           </p:cNvPr>
@@ -20155,7 +20155,7 @@
           <p:cNvPr id="3" name="Slide number">
             <a:extLst xmlns:a="http://schemas.openxmlformats.org/drawingml/2006/main">
               <a:ext uri="{FF2B5EF4-FFF2-40B4-BE49-F238E27FC236}">
-                <a16:creationId xmlns:a16="http://schemas.microsoft.com/office/drawing/2014/main" id="{5CE2C04C-BE14-459E-9707-D6596CD032B4}"/>
+                <a16:creationId xmlns:a16="http://schemas.microsoft.com/office/drawing/2014/main" id="{5DCB276C-7F0C-402F-B4C3-9F60756F99E7}"/>
               </a:ext>
             </a:extLst>
           </p:cNvPr>
@@ -20210,7 +20210,7 @@
     </p:spTree>
     <p:extLst>
       <p:ext uri="{BB962C8B-B14F-4D97-AF65-F5344CB8AC3E}">
-        <p14:creationId xmlns:p14="http://schemas.microsoft.com/office/powerpoint/2010/main" val="1777394008"/>
+        <p14:creationId xmlns:p14="http://schemas.microsoft.com/office/powerpoint/2010/main" val="452992450"/>
       </p:ext>
     </p:extLst>
   </p:cSld>
@@ -20241,7 +20241,7 @@
           <p:cNvPr id="4" name="Title">
             <a:extLst xmlns:a="http://schemas.openxmlformats.org/drawingml/2006/main">
               <a:ext uri="{FF2B5EF4-FFF2-40B4-BE49-F238E27FC236}">
-                <a16:creationId xmlns:a16="http://schemas.microsoft.com/office/drawing/2014/main" id="{FDC07A54-3E1F-40AB-9007-69EB5B6B2BF6}"/>
+                <a16:creationId xmlns:a16="http://schemas.microsoft.com/office/drawing/2014/main" id="{E15C4C2A-AF34-46BE-9101-2E17DDBB0FCB}"/>
               </a:ext>
             </a:extLst>
           </p:cNvPr>
@@ -20321,7 +20321,7 @@
           <p:cNvPr id="2" name="text">
             <a:extLst xmlns:a="http://schemas.openxmlformats.org/drawingml/2006/main">
               <a:ext uri="{FF2B5EF4-FFF2-40B4-BE49-F238E27FC236}">
-                <a16:creationId xmlns:a16="http://schemas.microsoft.com/office/drawing/2014/main" id="{599539F0-61EF-40A0-9F1F-3078CFC38F43}"/>
+                <a16:creationId xmlns:a16="http://schemas.microsoft.com/office/drawing/2014/main" id="{28119815-D817-45FD-ABF7-8813517BA598}"/>
               </a:ext>
             </a:extLst>
           </p:cNvPr>
@@ -20378,7 +20378,7 @@
           <p:cNvPr id="3" name="Slide number">
             <a:extLst xmlns:a="http://schemas.openxmlformats.org/drawingml/2006/main">
               <a:ext uri="{FF2B5EF4-FFF2-40B4-BE49-F238E27FC236}">
-                <a16:creationId xmlns:a16="http://schemas.microsoft.com/office/drawing/2014/main" id="{E19A6955-FC80-4CA7-BFAA-D9E0F3113710}"/>
+                <a16:creationId xmlns:a16="http://schemas.microsoft.com/office/drawing/2014/main" id="{6B2F0387-E57B-4970-A86B-F44FBAC339E4}"/>
               </a:ext>
             </a:extLst>
           </p:cNvPr>
@@ -20433,7 +20433,7 @@
     </p:spTree>
     <p:extLst>
       <p:ext uri="{BB962C8B-B14F-4D97-AF65-F5344CB8AC3E}">
-        <p14:creationId xmlns:p14="http://schemas.microsoft.com/office/powerpoint/2010/main" val="1491725523"/>
+        <p14:creationId xmlns:p14="http://schemas.microsoft.com/office/powerpoint/2010/main" val="130115964"/>
       </p:ext>
     </p:extLst>
   </p:cSld>
@@ -20464,7 +20464,7 @@
           <p:cNvPr id="4" name="Title">
             <a:extLst xmlns:a="http://schemas.openxmlformats.org/drawingml/2006/main">
               <a:ext uri="{FF2B5EF4-FFF2-40B4-BE49-F238E27FC236}">
-                <a16:creationId xmlns:a16="http://schemas.microsoft.com/office/drawing/2014/main" id="{50487B2D-2C7F-4BE8-8BE9-04665B0A9156}"/>
+                <a16:creationId xmlns:a16="http://schemas.microsoft.com/office/drawing/2014/main" id="{DBA8E88A-7D4E-4587-B94D-BE0859CFB284}"/>
               </a:ext>
             </a:extLst>
           </p:cNvPr>
@@ -20544,7 +20544,7 @@
           <p:cNvPr id="2" name="text">
             <a:extLst xmlns:a="http://schemas.openxmlformats.org/drawingml/2006/main">
               <a:ext uri="{FF2B5EF4-FFF2-40B4-BE49-F238E27FC236}">
-                <a16:creationId xmlns:a16="http://schemas.microsoft.com/office/drawing/2014/main" id="{A9FA32C0-9A4D-451E-9FA7-D22CC978A30C}"/>
+                <a16:creationId xmlns:a16="http://schemas.microsoft.com/office/drawing/2014/main" id="{36A83B3D-4AC8-42B5-9169-44FBBA7B7AF5}"/>
               </a:ext>
             </a:extLst>
           </p:cNvPr>
@@ -20601,7 +20601,7 @@
           <p:cNvPr id="3" name="Slide number">
             <a:extLst xmlns:a="http://schemas.openxmlformats.org/drawingml/2006/main">
               <a:ext uri="{FF2B5EF4-FFF2-40B4-BE49-F238E27FC236}">
-                <a16:creationId xmlns:a16="http://schemas.microsoft.com/office/drawing/2014/main" id="{A80C96B0-A105-4398-8E87-B10C22CBB237}"/>
+                <a16:creationId xmlns:a16="http://schemas.microsoft.com/office/drawing/2014/main" id="{DE74AB56-59B0-42E9-81D5-8FB20D6E431E}"/>
               </a:ext>
             </a:extLst>
           </p:cNvPr>
@@ -20656,7 +20656,7 @@
     </p:spTree>
     <p:extLst>
       <p:ext uri="{BB962C8B-B14F-4D97-AF65-F5344CB8AC3E}">
-        <p14:creationId xmlns:p14="http://schemas.microsoft.com/office/powerpoint/2010/main" val="86274152"/>
+        <p14:creationId xmlns:p14="http://schemas.microsoft.com/office/powerpoint/2010/main" val="317687836"/>
       </p:ext>
     </p:extLst>
   </p:cSld>
@@ -20691,7 +20691,7 @@
           <p:nvPr/>
         </p:nvPicPr>
         <p:blipFill>
-          <a:blip xmlns:r="http://schemas.openxmlformats.org/officeDocument/2006/relationships" xmlns:a="http://schemas.openxmlformats.org/drawingml/2006/main" r:embed="R2ae33bec15eb48c1"/>
+          <a:blip xmlns:r="http://schemas.openxmlformats.org/officeDocument/2006/relationships" xmlns:a="http://schemas.openxmlformats.org/drawingml/2006/main" r:embed="R52f19aa3bfa345ee"/>
           <a:srcRect xmlns:a="http://schemas.openxmlformats.org/drawingml/2006/main" l="0" t="0" r="0" b="0"/>
           <a:stretch xmlns:a="http://schemas.openxmlformats.org/drawingml/2006/main">
             <a:fillRect l="0" t="0" r="0" b="0"/>
@@ -20712,7 +20712,7 @@
           <p:cNvPr id="2" name="Title">
             <a:extLst xmlns:a="http://schemas.openxmlformats.org/drawingml/2006/main">
               <a:ext uri="{FF2B5EF4-FFF2-40B4-BE49-F238E27FC236}">
-                <a16:creationId xmlns:a16="http://schemas.microsoft.com/office/drawing/2014/main" id="{3250F189-1E2E-4FEA-B2DD-682B307E81DE}"/>
+                <a16:creationId xmlns:a16="http://schemas.microsoft.com/office/drawing/2014/main" id="{3652EF7F-C7EB-4CBA-8058-F0A4FB4BBBBB}"/>
               </a:ext>
             </a:extLst>
           </p:cNvPr>
@@ -20769,7 +20769,7 @@
           <p:cNvPr id="3" name="Title">
             <a:extLst xmlns:a="http://schemas.openxmlformats.org/drawingml/2006/main">
               <a:ext uri="{FF2B5EF4-FFF2-40B4-BE49-F238E27FC236}">
-                <a16:creationId xmlns:a16="http://schemas.microsoft.com/office/drawing/2014/main" id="{AA1C88BB-7AA0-4146-A28E-D8F548C084C6}"/>
+                <a16:creationId xmlns:a16="http://schemas.microsoft.com/office/drawing/2014/main" id="{6131D6EE-D8DF-4A4E-BA00-AC1DD33218C7}"/>
               </a:ext>
             </a:extLst>
           </p:cNvPr>
@@ -20826,7 +20826,7 @@
           <p:cNvPr id="4" name="Credentials">
             <a:extLst xmlns:a="http://schemas.openxmlformats.org/drawingml/2006/main">
               <a:ext uri="{FF2B5EF4-FFF2-40B4-BE49-F238E27FC236}">
-                <a16:creationId xmlns:a16="http://schemas.microsoft.com/office/drawing/2014/main" id="{41B753CE-F93D-408A-93EF-070BA12472DD}"/>
+                <a16:creationId xmlns:a16="http://schemas.microsoft.com/office/drawing/2014/main" id="{98D10E60-ACCE-48B4-B04C-8AD171C3BCC7}"/>
               </a:ext>
             </a:extLst>
           </p:cNvPr>
@@ -20883,7 +20883,7 @@
           <p:cNvPr id="5" name="Experience">
             <a:extLst xmlns:a="http://schemas.openxmlformats.org/drawingml/2006/main">
               <a:ext uri="{FF2B5EF4-FFF2-40B4-BE49-F238E27FC236}">
-                <a16:creationId xmlns:a16="http://schemas.microsoft.com/office/drawing/2014/main" id="{33BDDF89-0CCF-405F-90CD-52A58F11888F}"/>
+                <a16:creationId xmlns:a16="http://schemas.microsoft.com/office/drawing/2014/main" id="{FA916C11-D498-4784-B6DA-2658B5BC8B87}"/>
               </a:ext>
             </a:extLst>
           </p:cNvPr>
@@ -20940,7 +20940,7 @@
           <p:cNvPr id="6" name="Website">
             <a:extLst xmlns:a="http://schemas.openxmlformats.org/drawingml/2006/main">
               <a:ext uri="{FF2B5EF4-FFF2-40B4-BE49-F238E27FC236}">
-                <a16:creationId xmlns:a16="http://schemas.microsoft.com/office/drawing/2014/main" id="{B7F5DE0F-A0B5-43D4-9D11-7C6C025E969C}"/>
+                <a16:creationId xmlns:a16="http://schemas.microsoft.com/office/drawing/2014/main" id="{8C1B79D9-897D-4068-97B0-A4F6A23860B3}"/>
               </a:ext>
             </a:extLst>
           </p:cNvPr>
@@ -20997,7 +20997,7 @@
           <p:cNvPr id="7" name="Slide number">
             <a:extLst xmlns:a="http://schemas.openxmlformats.org/drawingml/2006/main">
               <a:ext uri="{FF2B5EF4-FFF2-40B4-BE49-F238E27FC236}">
-                <a16:creationId xmlns:a16="http://schemas.microsoft.com/office/drawing/2014/main" id="{44948736-23AD-4DA8-9302-45C0996AFE52}"/>
+                <a16:creationId xmlns:a16="http://schemas.microsoft.com/office/drawing/2014/main" id="{69CA8771-3D4F-4B46-AE6B-3AC0A80B1C40}"/>
               </a:ext>
             </a:extLst>
           </p:cNvPr>
@@ -21052,7 +21052,7 @@
     </p:spTree>
     <p:extLst>
       <p:ext uri="{BB962C8B-B14F-4D97-AF65-F5344CB8AC3E}">
-        <p14:creationId xmlns:p14="http://schemas.microsoft.com/office/powerpoint/2010/main" val="1890271321"/>
+        <p14:creationId xmlns:p14="http://schemas.microsoft.com/office/powerpoint/2010/main" val="1566091408"/>
       </p:ext>
     </p:extLst>
   </p:cSld>
@@ -21083,7 +21083,7 @@
           <p:cNvPr id="10" name="Active section">
             <a:extLst xmlns:a="http://schemas.openxmlformats.org/drawingml/2006/main">
               <a:ext uri="{FF2B5EF4-FFF2-40B4-BE49-F238E27FC236}">
-                <a16:creationId xmlns:a16="http://schemas.microsoft.com/office/drawing/2014/main" id="{F9810F8A-8EE4-44E0-8DBD-0348E8AE0842}"/>
+                <a16:creationId xmlns:a16="http://schemas.microsoft.com/office/drawing/2014/main" id="{5A30DC73-DAE9-4ABB-A768-B7E09C4C820C}"/>
               </a:ext>
             </a:extLst>
           </p:cNvPr>
@@ -21140,7 +21140,7 @@
           <p:cNvPr id="2" name="Section description 0">
             <a:extLst xmlns:a="http://schemas.openxmlformats.org/drawingml/2006/main">
               <a:ext uri="{FF2B5EF4-FFF2-40B4-BE49-F238E27FC236}">
-                <a16:creationId xmlns:a16="http://schemas.microsoft.com/office/drawing/2014/main" id="{77364B72-484D-4EEE-B7AF-F94FEFA2C6BF}"/>
+                <a16:creationId xmlns:a16="http://schemas.microsoft.com/office/drawing/2014/main" id="{B46AEECA-C4BC-44A1-A171-8244CA9AEDAF}"/>
               </a:ext>
             </a:extLst>
           </p:cNvPr>
@@ -21201,7 +21201,7 @@
           <p:nvPr/>
         </p:nvPicPr>
         <p:blipFill>
-          <a:blip xmlns:r="http://schemas.openxmlformats.org/officeDocument/2006/relationships" xmlns:a="http://schemas.openxmlformats.org/drawingml/2006/main" r:embed="R855bafc60bae4fd9"/>
+          <a:blip xmlns:r="http://schemas.openxmlformats.org/officeDocument/2006/relationships" xmlns:a="http://schemas.openxmlformats.org/drawingml/2006/main" r:embed="R93c05adbac4e42e0"/>
           <a:stretch xmlns:a="http://schemas.openxmlformats.org/drawingml/2006/main"/>
         </p:blipFill>
         <p:spPr>
@@ -21223,7 +21223,7 @@
           <p:nvPr/>
         </p:nvPicPr>
         <p:blipFill>
-          <a:blip xmlns:r="http://schemas.openxmlformats.org/officeDocument/2006/relationships" xmlns:a="http://schemas.openxmlformats.org/drawingml/2006/main" r:embed="Re3ed74c0a5624935"/>
+          <a:blip xmlns:r="http://schemas.openxmlformats.org/officeDocument/2006/relationships" xmlns:a="http://schemas.openxmlformats.org/drawingml/2006/main" r:embed="R934d94d259824344"/>
           <a:stretch xmlns:a="http://schemas.openxmlformats.org/drawingml/2006/main"/>
         </p:blipFill>
         <p:spPr>
@@ -21245,7 +21245,7 @@
           <p:nvPr/>
         </p:nvPicPr>
         <p:blipFill>
-          <a:blip xmlns:r="http://schemas.openxmlformats.org/officeDocument/2006/relationships" xmlns:a="http://schemas.openxmlformats.org/drawingml/2006/main" r:embed="R937d62573b0843a3"/>
+          <a:blip xmlns:r="http://schemas.openxmlformats.org/officeDocument/2006/relationships" xmlns:a="http://schemas.openxmlformats.org/drawingml/2006/main" r:embed="R9cd3abc13de44b50"/>
           <a:stretch xmlns:a="http://schemas.openxmlformats.org/drawingml/2006/main"/>
         </p:blipFill>
         <p:spPr>
@@ -21267,7 +21267,7 @@
           <p:nvPr/>
         </p:nvPicPr>
         <p:blipFill>
-          <a:blip xmlns:r="http://schemas.openxmlformats.org/officeDocument/2006/relationships" xmlns:a="http://schemas.openxmlformats.org/drawingml/2006/main" r:embed="R058095599fc84fe9"/>
+          <a:blip xmlns:r="http://schemas.openxmlformats.org/officeDocument/2006/relationships" xmlns:a="http://schemas.openxmlformats.org/drawingml/2006/main" r:embed="R23270bc18af24b38"/>
           <a:stretch xmlns:a="http://schemas.openxmlformats.org/drawingml/2006/main"/>
         </p:blipFill>
         <p:spPr>
@@ -21289,7 +21289,7 @@
           <p:nvPr/>
         </p:nvPicPr>
         <p:blipFill>
-          <a:blip xmlns:r="http://schemas.openxmlformats.org/officeDocument/2006/relationships" xmlns:a="http://schemas.openxmlformats.org/drawingml/2006/main" r:embed="R5bb584804b894f15"/>
+          <a:blip xmlns:r="http://schemas.openxmlformats.org/officeDocument/2006/relationships" xmlns:a="http://schemas.openxmlformats.org/drawingml/2006/main" r:embed="Rb4829226962549ea"/>
           <a:stretch xmlns:a="http://schemas.openxmlformats.org/drawingml/2006/main"/>
         </p:blipFill>
         <p:spPr>
@@ -21311,7 +21311,7 @@
           <p:nvPr/>
         </p:nvPicPr>
         <p:blipFill>
-          <a:blip xmlns:r="http://schemas.openxmlformats.org/officeDocument/2006/relationships" xmlns:a="http://schemas.openxmlformats.org/drawingml/2006/main" r:embed="R29be8132589a4001"/>
+          <a:blip xmlns:r="http://schemas.openxmlformats.org/officeDocument/2006/relationships" xmlns:a="http://schemas.openxmlformats.org/drawingml/2006/main" r:embed="R60dc9553ad5c4fcd"/>
           <a:stretch xmlns:a="http://schemas.openxmlformats.org/drawingml/2006/main"/>
         </p:blipFill>
         <p:spPr>
@@ -21329,7 +21329,7 @@
           <p:cNvPr id="9" name="Slide number">
             <a:extLst xmlns:a="http://schemas.openxmlformats.org/drawingml/2006/main">
               <a:ext uri="{FF2B5EF4-FFF2-40B4-BE49-F238E27FC236}">
-                <a16:creationId xmlns:a16="http://schemas.microsoft.com/office/drawing/2014/main" id="{C911B0A7-B1DD-4A4D-98FD-0E6BB170426E}"/>
+                <a16:creationId xmlns:a16="http://schemas.microsoft.com/office/drawing/2014/main" id="{F30B69BD-A467-421C-BA3C-4C3B8F5D057A}"/>
               </a:ext>
             </a:extLst>
           </p:cNvPr>
@@ -21384,7 +21384,7 @@
     </p:spTree>
     <p:extLst>
       <p:ext uri="{BB962C8B-B14F-4D97-AF65-F5344CB8AC3E}">
-        <p14:creationId xmlns:p14="http://schemas.microsoft.com/office/powerpoint/2010/main" val="417239002"/>
+        <p14:creationId xmlns:p14="http://schemas.microsoft.com/office/powerpoint/2010/main" val="974402538"/>
       </p:ext>
     </p:extLst>
   </p:cSld>
@@ -21415,7 +21415,7 @@
           <p:cNvPr id="20" name="Title">
             <a:extLst xmlns:a="http://schemas.openxmlformats.org/drawingml/2006/main">
               <a:ext uri="{FF2B5EF4-FFF2-40B4-BE49-F238E27FC236}">
-                <a16:creationId xmlns:a16="http://schemas.microsoft.com/office/drawing/2014/main" id="{7FEB187A-11D5-417D-A976-90853A8C0362}"/>
+                <a16:creationId xmlns:a16="http://schemas.microsoft.com/office/drawing/2014/main" id="{756D8BDD-D30D-4230-B60A-35AB333B8C17}"/>
               </a:ext>
             </a:extLst>
           </p:cNvPr>
@@ -21472,7 +21472,7 @@
           <p:cNvPr id="2" name="text">
             <a:extLst xmlns:a="http://schemas.openxmlformats.org/drawingml/2006/main">
               <a:ext uri="{FF2B5EF4-FFF2-40B4-BE49-F238E27FC236}">
-                <a16:creationId xmlns:a16="http://schemas.microsoft.com/office/drawing/2014/main" id="{E94798F0-6227-4459-BF9E-716974A57154}"/>
+                <a16:creationId xmlns:a16="http://schemas.microsoft.com/office/drawing/2014/main" id="{A0068060-C0FC-43E6-B1AC-C5F275890E95}"/>
               </a:ext>
             </a:extLst>
           </p:cNvPr>
@@ -21529,7 +21529,7 @@
           <p:cNvPr id="3" name="text">
             <a:extLst xmlns:a="http://schemas.openxmlformats.org/drawingml/2006/main">
               <a:ext uri="{FF2B5EF4-FFF2-40B4-BE49-F238E27FC236}">
-                <a16:creationId xmlns:a16="http://schemas.microsoft.com/office/drawing/2014/main" id="{D31049BD-1433-4DC6-8065-DD94B9B27977}"/>
+                <a16:creationId xmlns:a16="http://schemas.microsoft.com/office/drawing/2014/main" id="{0B5A7489-641D-40E7-95D7-CBA96882354D}"/>
               </a:ext>
             </a:extLst>
           </p:cNvPr>
@@ -21586,7 +21586,7 @@
           <p:cNvPr id="4" name="text">
             <a:extLst xmlns:a="http://schemas.openxmlformats.org/drawingml/2006/main">
               <a:ext uri="{FF2B5EF4-FFF2-40B4-BE49-F238E27FC236}">
-                <a16:creationId xmlns:a16="http://schemas.microsoft.com/office/drawing/2014/main" id="{8323FB13-EE71-48B0-A42B-4E9C59DE9FDC}"/>
+                <a16:creationId xmlns:a16="http://schemas.microsoft.com/office/drawing/2014/main" id="{53C840BF-1279-4AFD-8B44-7615BC64FB03}"/>
               </a:ext>
             </a:extLst>
           </p:cNvPr>
@@ -21643,7 +21643,7 @@
           <p:cNvPr id="5" name="text">
             <a:extLst xmlns:a="http://schemas.openxmlformats.org/drawingml/2006/main">
               <a:ext uri="{FF2B5EF4-FFF2-40B4-BE49-F238E27FC236}">
-                <a16:creationId xmlns:a16="http://schemas.microsoft.com/office/drawing/2014/main" id="{CACB3F03-341A-40DF-93A9-FFF6CCF3BA5D}"/>
+                <a16:creationId xmlns:a16="http://schemas.microsoft.com/office/drawing/2014/main" id="{E0F95F8E-E39C-489D-B360-DA73025A7655}"/>
               </a:ext>
             </a:extLst>
           </p:cNvPr>
@@ -21700,7 +21700,7 @@
           <p:cNvPr id="6" name="text">
             <a:extLst xmlns:a="http://schemas.openxmlformats.org/drawingml/2006/main">
               <a:ext uri="{FF2B5EF4-FFF2-40B4-BE49-F238E27FC236}">
-                <a16:creationId xmlns:a16="http://schemas.microsoft.com/office/drawing/2014/main" id="{67AADB3E-F273-424B-B829-002A0EADA563}"/>
+                <a16:creationId xmlns:a16="http://schemas.microsoft.com/office/drawing/2014/main" id="{25F06EF7-47D5-4902-9480-6D287FA3F36B}"/>
               </a:ext>
             </a:extLst>
           </p:cNvPr>
@@ -21757,7 +21757,7 @@
           <p:cNvPr id="7" name="text">
             <a:extLst xmlns:a="http://schemas.openxmlformats.org/drawingml/2006/main">
               <a:ext uri="{FF2B5EF4-FFF2-40B4-BE49-F238E27FC236}">
-                <a16:creationId xmlns:a16="http://schemas.microsoft.com/office/drawing/2014/main" id="{B7B61609-AE76-49C3-A77B-6AF4C36D5F59}"/>
+                <a16:creationId xmlns:a16="http://schemas.microsoft.com/office/drawing/2014/main" id="{B9A7FB57-3A7E-47B0-AE88-9485A6DC937A}"/>
               </a:ext>
             </a:extLst>
           </p:cNvPr>
@@ -21814,7 +21814,7 @@
           <p:cNvPr id="8" name="text">
             <a:extLst xmlns:a="http://schemas.openxmlformats.org/drawingml/2006/main">
               <a:ext uri="{FF2B5EF4-FFF2-40B4-BE49-F238E27FC236}">
-                <a16:creationId xmlns:a16="http://schemas.microsoft.com/office/drawing/2014/main" id="{87655647-ECBC-458A-AB08-AFCCB73AF147}"/>
+                <a16:creationId xmlns:a16="http://schemas.microsoft.com/office/drawing/2014/main" id="{0449832F-CE38-4649-A607-CE91DCB48BB6}"/>
               </a:ext>
             </a:extLst>
           </p:cNvPr>
@@ -21871,7 +21871,7 @@
           <p:cNvPr id="9" name="text">
             <a:extLst xmlns:a="http://schemas.openxmlformats.org/drawingml/2006/main">
               <a:ext uri="{FF2B5EF4-FFF2-40B4-BE49-F238E27FC236}">
-                <a16:creationId xmlns:a16="http://schemas.microsoft.com/office/drawing/2014/main" id="{20CAA20E-27C8-4F0A-8940-1262EB1EE628}"/>
+                <a16:creationId xmlns:a16="http://schemas.microsoft.com/office/drawing/2014/main" id="{C535DFBE-BB60-464D-8F0E-7A1DD0A6A56C}"/>
               </a:ext>
             </a:extLst>
           </p:cNvPr>
@@ -21928,7 +21928,7 @@
           <p:cNvPr id="10" name="text">
             <a:extLst xmlns:a="http://schemas.openxmlformats.org/drawingml/2006/main">
               <a:ext uri="{FF2B5EF4-FFF2-40B4-BE49-F238E27FC236}">
-                <a16:creationId xmlns:a16="http://schemas.microsoft.com/office/drawing/2014/main" id="{4D83F05C-E49F-4CB2-8B68-05BA8E8426DE}"/>
+                <a16:creationId xmlns:a16="http://schemas.microsoft.com/office/drawing/2014/main" id="{506573FF-C1B2-4D9A-BACF-E831CD9B2468}"/>
               </a:ext>
             </a:extLst>
           </p:cNvPr>
@@ -21985,7 +21985,7 @@
           <p:cNvPr id="11" name="text">
             <a:extLst xmlns:a="http://schemas.openxmlformats.org/drawingml/2006/main">
               <a:ext uri="{FF2B5EF4-FFF2-40B4-BE49-F238E27FC236}">
-                <a16:creationId xmlns:a16="http://schemas.microsoft.com/office/drawing/2014/main" id="{55205D37-BC6B-4A1D-8693-8F44B3C94207}"/>
+                <a16:creationId xmlns:a16="http://schemas.microsoft.com/office/drawing/2014/main" id="{3BC32811-839A-4C25-9DF6-EFB058CDD47A}"/>
               </a:ext>
             </a:extLst>
           </p:cNvPr>
@@ -22042,7 +22042,7 @@
           <p:cNvPr id="12" name="text">
             <a:extLst xmlns:a="http://schemas.openxmlformats.org/drawingml/2006/main">
               <a:ext uri="{FF2B5EF4-FFF2-40B4-BE49-F238E27FC236}">
-                <a16:creationId xmlns:a16="http://schemas.microsoft.com/office/drawing/2014/main" id="{231192E1-6E08-4696-BEF6-055E57AEF97C}"/>
+                <a16:creationId xmlns:a16="http://schemas.microsoft.com/office/drawing/2014/main" id="{F06E066D-055E-4EC3-B25A-D11F2FCE0094}"/>
               </a:ext>
             </a:extLst>
           </p:cNvPr>
@@ -22099,7 +22099,7 @@
           <p:cNvPr id="13" name="text">
             <a:extLst xmlns:a="http://schemas.openxmlformats.org/drawingml/2006/main">
               <a:ext uri="{FF2B5EF4-FFF2-40B4-BE49-F238E27FC236}">
-                <a16:creationId xmlns:a16="http://schemas.microsoft.com/office/drawing/2014/main" id="{54209DAE-1652-41A1-ACFD-D758F38AC1CC}"/>
+                <a16:creationId xmlns:a16="http://schemas.microsoft.com/office/drawing/2014/main" id="{B1D902FD-024C-40F6-A85F-435B644F4A0C}"/>
               </a:ext>
             </a:extLst>
           </p:cNvPr>
@@ -22156,7 +22156,7 @@
           <p:cNvPr id="14" name="text">
             <a:extLst xmlns:a="http://schemas.openxmlformats.org/drawingml/2006/main">
               <a:ext uri="{FF2B5EF4-FFF2-40B4-BE49-F238E27FC236}">
-                <a16:creationId xmlns:a16="http://schemas.microsoft.com/office/drawing/2014/main" id="{F2ED57E9-E822-46DC-AC56-9E421ADFBA1E}"/>
+                <a16:creationId xmlns:a16="http://schemas.microsoft.com/office/drawing/2014/main" id="{18D6D38B-6A4D-4FEA-957F-0847F16F2EDE}"/>
               </a:ext>
             </a:extLst>
           </p:cNvPr>
@@ -22213,7 +22213,7 @@
           <p:cNvPr id="15" name="text">
             <a:extLst xmlns:a="http://schemas.openxmlformats.org/drawingml/2006/main">
               <a:ext uri="{FF2B5EF4-FFF2-40B4-BE49-F238E27FC236}">
-                <a16:creationId xmlns:a16="http://schemas.microsoft.com/office/drawing/2014/main" id="{9700C2F6-D237-4D0A-BDF7-9CD1092B03CB}"/>
+                <a16:creationId xmlns:a16="http://schemas.microsoft.com/office/drawing/2014/main" id="{2137997B-11AB-463B-939A-DDAFBAE902B3}"/>
               </a:ext>
             </a:extLst>
           </p:cNvPr>
@@ -22270,7 +22270,7 @@
           <p:cNvPr id="16" name="text">
             <a:extLst xmlns:a="http://schemas.openxmlformats.org/drawingml/2006/main">
               <a:ext uri="{FF2B5EF4-FFF2-40B4-BE49-F238E27FC236}">
-                <a16:creationId xmlns:a16="http://schemas.microsoft.com/office/drawing/2014/main" id="{4A4E38EE-4060-4D32-9B10-489EE7C1AEC5}"/>
+                <a16:creationId xmlns:a16="http://schemas.microsoft.com/office/drawing/2014/main" id="{619EFCD8-6ABA-41CF-80EA-514DF1A32606}"/>
               </a:ext>
             </a:extLst>
           </p:cNvPr>
@@ -22327,7 +22327,7 @@
           <p:cNvPr id="17" name="text">
             <a:extLst xmlns:a="http://schemas.openxmlformats.org/drawingml/2006/main">
               <a:ext uri="{FF2B5EF4-FFF2-40B4-BE49-F238E27FC236}">
-                <a16:creationId xmlns:a16="http://schemas.microsoft.com/office/drawing/2014/main" id="{1BE58C5B-4901-4A6C-AB8E-A5D4B9751AAA}"/>
+                <a16:creationId xmlns:a16="http://schemas.microsoft.com/office/drawing/2014/main" id="{38C272EE-38E4-40A5-8663-CDAC5A448141}"/>
               </a:ext>
             </a:extLst>
           </p:cNvPr>
@@ -22384,7 +22384,7 @@
           <p:cNvPr id="18" name="text">
             <a:extLst xmlns:a="http://schemas.openxmlformats.org/drawingml/2006/main">
               <a:ext uri="{FF2B5EF4-FFF2-40B4-BE49-F238E27FC236}">
-                <a16:creationId xmlns:a16="http://schemas.microsoft.com/office/drawing/2014/main" id="{2EE52165-94BD-4EEC-A97E-0B22CFF2B76F}"/>
+                <a16:creationId xmlns:a16="http://schemas.microsoft.com/office/drawing/2014/main" id="{3914DEE3-E347-42C3-BE58-C5AE3E7ED1B9}"/>
               </a:ext>
             </a:extLst>
           </p:cNvPr>
@@ -22441,7 +22441,7 @@
           <p:cNvPr id="19" name="Slide number">
             <a:extLst xmlns:a="http://schemas.openxmlformats.org/drawingml/2006/main">
               <a:ext uri="{FF2B5EF4-FFF2-40B4-BE49-F238E27FC236}">
-                <a16:creationId xmlns:a16="http://schemas.microsoft.com/office/drawing/2014/main" id="{4AC19AA1-2407-4B27-8FB5-754E4CF97087}"/>
+                <a16:creationId xmlns:a16="http://schemas.microsoft.com/office/drawing/2014/main" id="{B3B8114F-F594-4713-848C-7182874E6FD2}"/>
               </a:ext>
             </a:extLst>
           </p:cNvPr>
@@ -22496,7 +22496,7 @@
     </p:spTree>
     <p:extLst>
       <p:ext uri="{BB962C8B-B14F-4D97-AF65-F5344CB8AC3E}">
-        <p14:creationId xmlns:p14="http://schemas.microsoft.com/office/powerpoint/2010/main" val="1181725275"/>
+        <p14:creationId xmlns:p14="http://schemas.microsoft.com/office/powerpoint/2010/main" val="992185784"/>
       </p:ext>
     </p:extLst>
   </p:cSld>

</xml_diff>